<commit_message>
Document Codex effort and clarify measured CRC32 baseline in slides
</commit_message>
<xml_diff>
--- a/submissions/midterm-2026-10-28/isaforge-midterm-progress-slides-final.pptx
+++ b/submissions/midterm-2026-10-28/isaforge-midterm-progress-slides-final.pptx
@@ -2,23 +2,23 @@
 <file path=ppt/presentation.xml><?xml version="1.0" encoding="utf-8"?>
 <p:presentation xmlns:p="http://schemas.openxmlformats.org/presentationml/2006/main">
   <p:sldMasterIdLst>
-    <p:sldMasterId xmlns:r="http://schemas.openxmlformats.org/officeDocument/2006/relationships" id="2147483648" r:id="R94c3470e070d4c0a"/>
+    <p:sldMasterId xmlns:r="http://schemas.openxmlformats.org/officeDocument/2006/relationships" id="2147483648" r:id="R38dd3f5c3ab040d4"/>
   </p:sldMasterIdLst>
   <p:notesMasterIdLst>
-    <p:notesMasterId xmlns:r="http://schemas.openxmlformats.org/officeDocument/2006/relationships" r:id="Rec1ed8f1d8ed407f"/>
+    <p:notesMasterId xmlns:r="http://schemas.openxmlformats.org/officeDocument/2006/relationships" r:id="R7555403a672d4f73"/>
   </p:notesMasterIdLst>
   <p:sldIdLst>
-    <p:sldId xmlns:r="http://schemas.openxmlformats.org/officeDocument/2006/relationships" id="256" r:id="Rabba107ed59f43b4"/>
-    <p:sldId xmlns:r="http://schemas.openxmlformats.org/officeDocument/2006/relationships" id="257" r:id="R17647785fe9b4b2b"/>
-    <p:sldId xmlns:r="http://schemas.openxmlformats.org/officeDocument/2006/relationships" id="258" r:id="R7fd9ff7ceb93410e"/>
-    <p:sldId xmlns:r="http://schemas.openxmlformats.org/officeDocument/2006/relationships" id="259" r:id="R52e9b86268c343ba"/>
-    <p:sldId xmlns:r="http://schemas.openxmlformats.org/officeDocument/2006/relationships" id="260" r:id="R108814550b684fcd"/>
-    <p:sldId xmlns:r="http://schemas.openxmlformats.org/officeDocument/2006/relationships" id="261" r:id="R9aacc27e022f4ad4"/>
-    <p:sldId xmlns:r="http://schemas.openxmlformats.org/officeDocument/2006/relationships" id="262" r:id="Rd4c7302563574e88"/>
-    <p:sldId xmlns:r="http://schemas.openxmlformats.org/officeDocument/2006/relationships" id="263" r:id="R0a27b3889a2e4c95"/>
-    <p:sldId xmlns:r="http://schemas.openxmlformats.org/officeDocument/2006/relationships" id="264" r:id="Re56ccc7deed34fe5"/>
-    <p:sldId xmlns:r="http://schemas.openxmlformats.org/officeDocument/2006/relationships" id="265" r:id="R8c9fe294d9a542de"/>
-    <p:sldId xmlns:r="http://schemas.openxmlformats.org/officeDocument/2006/relationships" id="266" r:id="Rb56cd10e5b614c8e"/>
+    <p:sldId xmlns:r="http://schemas.openxmlformats.org/officeDocument/2006/relationships" id="256" r:id="Rbc0bbdd8f9d946b0"/>
+    <p:sldId xmlns:r="http://schemas.openxmlformats.org/officeDocument/2006/relationships" id="257" r:id="R62c1673c12d34c81"/>
+    <p:sldId xmlns:r="http://schemas.openxmlformats.org/officeDocument/2006/relationships" id="258" r:id="Raea80d82a69843fd"/>
+    <p:sldId xmlns:r="http://schemas.openxmlformats.org/officeDocument/2006/relationships" id="259" r:id="R08657a87ed5e44af"/>
+    <p:sldId xmlns:r="http://schemas.openxmlformats.org/officeDocument/2006/relationships" id="260" r:id="Re05a4e59b8244aa6"/>
+    <p:sldId xmlns:r="http://schemas.openxmlformats.org/officeDocument/2006/relationships" id="261" r:id="R823efb18b3d84fcf"/>
+    <p:sldId xmlns:r="http://schemas.openxmlformats.org/officeDocument/2006/relationships" id="262" r:id="Rca9b40f3d0fc47b7"/>
+    <p:sldId xmlns:r="http://schemas.openxmlformats.org/officeDocument/2006/relationships" id="263" r:id="R1147d4ae1c074c5d"/>
+    <p:sldId xmlns:r="http://schemas.openxmlformats.org/officeDocument/2006/relationships" id="264" r:id="R7240a0ac195845ad"/>
+    <p:sldId xmlns:r="http://schemas.openxmlformats.org/officeDocument/2006/relationships" id="265" r:id="Re5ba94e541ca4ca2"/>
+    <p:sldId xmlns:r="http://schemas.openxmlformats.org/officeDocument/2006/relationships" id="266" r:id="R0d05e68c9ac7460f"/>
   </p:sldIdLst>
   <p:sldSz cx="12192000" cy="6858000"/>
   <p:notesSz cx="6858000" cy="9144000"/>
@@ -887,7 +887,7 @@
           </a:p>
           <a:p xmlns:a="http://schemas.openxmlformats.org/drawingml/2006/main">
             <a:r>
-              <a:t>We progressed from CRC32 and aha-mont64 to a multi-workload measured corpus, then added budgeted comparisons, explanations, and bounded LLM tools. Software, hardware, and machine learning connect through one measurement contract. The contribution mapping shown is provisional: Git evidence supports the named author areas, while the software role comes from the team report and needs team confirmation.</a:t>
+              <a:t>We progressed from CRC32 and aha-mont64 to a multi-workload corpus, followed by budgeted comparisons, explanations, and LLM tools. Codex records approximately thirty hours of turn duration in this chat; that includes tool waits and failures and is not model training time. The team contribution mapping is provisional and needs confirmation.</a:t>
             </a:r>
           </a:p>
           <a:p xmlns:a="http://schemas.openxmlformats.org/drawingml/2006/main">
@@ -902,7 +902,7 @@
           </a:p>
           <a:p xmlns:a="http://schemas.openxmlformats.org/drawingml/2006/main">
             <a:r>
-              <a:t>Dated results directories October19–27; git history; docs/original-project-proposal.txt; supplied AgenticRiscPredictor.pdf. Contribution names, author aliases and actual work must be confirmed by the team before submission. Git alone does not measure contribution shares.</a:t>
+              <a:t>Dated results directories October19–27; git history; docs/original-project-proposal.txt; supplied AgenticRiscPredictor.pdf. Codex thread history snapshot through October 27: 90 turns with duration total 29.94 hours, including 84 completed, 4 failed and 2 interrupted; tool waiting is included. 48 directly spawned subagent threads; counts are activity, not research outcomes. See codex-history-and-baseline.md. Team must confirm roles and aliases; Git alone cannot measure contribution shares.</a:t>
             </a:r>
           </a:p>
         </p:txBody>
@@ -987,7 +987,7 @@
           </a:p>
           <a:p xmlns:a="http://schemas.openxmlformats.org/drawingml/2006/main">
             <a:r>
-              <a:t>A supported RV32 integer workload is compiled and traced. We extract repeated dataflow patterns and reject illegal operations, unsafe dependencies, or excess inputs and outputs. The selected expression is lowered to a custom opcode connected through PicoRV32’s PCPI interface. We then execute the modified program, verify its output, and measure cycles plus integrated area and routed timing. Only a correct design within the constraints becomes an improvement. Cycle speedup assumes a common clock; these are simulation and synthesis measurements, not physical-chip timings.</a:t>
+              <a:t>First we compile and run the unmodified benchmark on the unmodified PicoRV32 and check its output. In the original CRC32 experiment, that reference took 32.39 million simulated cycles. The best candidate took 30.82 million: a 1.051 times common-clock speedup. We extract legal dataflow, lower the candidate to a custom opcode, and rerun the same benchmark. Integrated synthesis and routing measure area and timing. These are simulation and FPGA tool results, not physical-chip stopwatch measurements.</a:t>
             </a:r>
           </a:p>
           <a:p xmlns:a="http://schemas.openxmlformats.org/drawingml/2006/main">
@@ -1002,7 +1002,7 @@
           </a:p>
           <a:p xmlns:a="http://schemas.openxmlformats.org/drawingml/2006/main">
             <a:r>
-              <a:t>Existing extractor, lowering and PicoRV32 PCPI evaluation; README.md and docs/HANDOFF.md. Restricted integer patterns, two register inputs/one output. Reject unsafe/unsupported rewrites. Integrated hardware metrics must stay separate from standalone LUT predictors.</a:t>
+              <a:t>docs/codesign-loop.md; results/2026-10-19-codesign/independent-audit.json. Embench CRC32,170 benchmark repetitions; startup, independent checksum, warm-up and serial reporting excluded from counter window. Same RV32I PicoRV32, 8KiB RAM and 12MHz target. Baseline 32,387,382 cycles,1653 LUT4; index_offset 30,820,662 cycles,1684 LUT4 (+31), 1.050833x. Both correctness checked; same-clock speedup, not measured board runtime. Baseline synth/routing Fmax 68.49–77.16 MHz. Distinguish this unmodified reference from heuristic selection baselines.</a:t>
             </a:r>
           </a:p>
         </p:txBody>
@@ -1087,7 +1087,7 @@
           </a:p>
           <a:p xmlns:a="http://schemas.openxmlformats.org/drawingml/2006/main">
             <a:r>
-              <a:t>Our frozen corpus contains 122 successful candidate-program measurements from fourteen workload groups, with four failed attempts retained and charged. The chart shows coverage from three benchmark suites. Each row contains premeasurement candidate features and separately recorded whole-program speedup, area, timing, and correctness. Candidates from one program are related, so we hold out entire workloads and exclude related expression families. The three later Ascon measurements remain separate. Thousands of policy replays reuse these labels; they are not thousands of new hardware experiments.</a:t>
+              <a:t>Our frozen corpus contains 122 successful candidate-program measurements from fourteen workload groups, plus four charged failures. These come from three benchmark suites. We tested thirteen selection policies in the final screen: eight learned policies and five heuristics or random controls. Their 2,925 replay results reuse the same hardware measurements; they are not new hardware runs. We evaluate by holding out entire workloads. Three later Ascon measurements remain separate.</a:t>
             </a:r>
           </a:p>
           <a:p xmlns:a="http://schemas.openxmlformats.org/drawingml/2006/main">
@@ -1187,7 +1187,7 @@
           </a:p>
           <a:p xmlns:a="http://schemas.openxmlformats.org/drawingml/2006/main">
             <a:r>
-              <a:t>Our main learned challenger is XGBoost pairwise ranking, not a neural network. Thirty-five premeasurement features describe the expression, constants, operations, and trace opportunity. Training pairs are ordered using actual measured speedup within the same workload context. Eighty shallow trees produce a relative ranking score. That score is neither a predicted speedup nor a confidence probability. We also tried regression, feasibility models, and active learning; those are comparisons, not evidence that every new model helped. The goal is better selection, not simply lower prediction error.</a:t>
+              <a:t>Our main challenger is XGBoost pairwise ranking, not a neural network. Thirty-five premeasurement features describe each candidate. Pairs are ordered using measured speedup within a workload context. Eighty shallow trees produce a relative ranking score, not a predicted speedup or confidence probability. We also tested XGBoost regression and feasibility models, logistic regression, random forests, Extra Trees, and Gaussian-process active learning. We assess them on selection, not just prediction error.</a:t>
             </a:r>
           </a:p>
           <a:p xmlns:a="http://schemas.openxmlformats.org/drawingml/2006/main">
@@ -1487,7 +1487,7 @@
           </a:p>
           <a:p xmlns:a="http://schemas.openxmlformats.org/drawingml/2006/main">
             <a:r>
-              <a:t>We compare against frequency, simple merit, architecture-aware heuristics, random search, and non-agent active learning. Merit prioritizes repeated instruction savings; it is already a strong baseline. Every policy should see the same pool and information, with one, two, or three charged attempts. Outcomes stay hidden until a permitted query. A result counts only if correct and feasible. The measured oracle is a retrospective reference, not a deployable policy. Historical training cost must be reported separately; this current development cohort is not untouched confirmation.</a:t>
+              <a:t>The unmodified program gives the performance reference. A different kind of baseline is a selection policy: frequency counts occurrences, while merit estimates operations eliminated times executions. We compare these with latency-aware heuristics, random search, and learned policies. Every method gets the same pool and one, two, or three charged attempts; unqueried results remain hidden. The measured oracle knows all outcomes and gives a retrospective ceiling, not a deployable policy. Historical training cost is tracked separately.</a:t>
             </a:r>
           </a:p>
           <a:p xmlns:a="http://schemas.openxmlformats.org/drawingml/2006/main">
@@ -1549,7 +1549,7 @@
           <p:cNvPr id="3" name="Title">
             <a:extLst xmlns:a="http://schemas.openxmlformats.org/drawingml/2006/main">
               <a:ext uri="{FF2B5EF4-FFF2-40B4-BE49-F238E27FC236}">
-                <a16:creationId xmlns:a16="http://schemas.microsoft.com/office/drawing/2014/main" id="{40B84F9A-9E13-4147-A9E6-5B1EDF9CA550}"/>
+                <a16:creationId xmlns:a16="http://schemas.microsoft.com/office/drawing/2014/main" id="{A65EC7E8-ADAF-4D11-BBDC-8E61876AE5A9}"/>
               </a:ext>
             </a:extLst>
           </p:cNvPr>
@@ -1778,7 +1778,7 @@
           <p:cNvPr id="2" name="Subtitle">
             <a:extLst xmlns:a="http://schemas.openxmlformats.org/drawingml/2006/main">
               <a:ext uri="{FF2B5EF4-FFF2-40B4-BE49-F238E27FC236}">
-                <a16:creationId xmlns:a16="http://schemas.microsoft.com/office/drawing/2014/main" id="{924AC92A-1969-4775-A057-8561237AA311}"/>
+                <a16:creationId xmlns:a16="http://schemas.microsoft.com/office/drawing/2014/main" id="{E93F7796-6D51-43E3-8969-DD650C5CD3F5}"/>
               </a:ext>
             </a:extLst>
           </p:cNvPr>
@@ -2024,7 +2024,7 @@
           <p:cNvPr id="2" name="Section title">
             <a:extLst xmlns:a="http://schemas.openxmlformats.org/drawingml/2006/main">
               <a:ext uri="{FF2B5EF4-FFF2-40B4-BE49-F238E27FC236}">
-                <a16:creationId xmlns:a16="http://schemas.microsoft.com/office/drawing/2014/main" id="{093E75CC-70F4-495C-B9BE-185A292F6B14}"/>
+                <a16:creationId xmlns:a16="http://schemas.microsoft.com/office/drawing/2014/main" id="{F219E63E-8C45-43FF-9AF0-74B7BB1D891F}"/>
               </a:ext>
             </a:extLst>
           </p:cNvPr>
@@ -2270,7 +2270,7 @@
           <p:cNvPr id="3" name="Title">
             <a:extLst xmlns:a="http://schemas.openxmlformats.org/drawingml/2006/main">
               <a:ext uri="{FF2B5EF4-FFF2-40B4-BE49-F238E27FC236}">
-                <a16:creationId xmlns:a16="http://schemas.microsoft.com/office/drawing/2014/main" id="{37EBA635-7986-4DB6-B143-693BDA1C2E1B}"/>
+                <a16:creationId xmlns:a16="http://schemas.microsoft.com/office/drawing/2014/main" id="{6CE227A1-60E2-46A0-8C03-B73DA4BCD9AA}"/>
               </a:ext>
             </a:extLst>
           </p:cNvPr>
@@ -2499,7 +2499,7 @@
           <p:cNvPr id="2" name="Body">
             <a:extLst xmlns:a="http://schemas.openxmlformats.org/drawingml/2006/main">
               <a:ext uri="{FF2B5EF4-FFF2-40B4-BE49-F238E27FC236}">
-                <a16:creationId xmlns:a16="http://schemas.microsoft.com/office/drawing/2014/main" id="{D49B55B6-E259-41B9-97F4-0C30EC7CFDD2}"/>
+                <a16:creationId xmlns:a16="http://schemas.microsoft.com/office/drawing/2014/main" id="{D75DDF14-3CB4-4888-89FA-54099A413F42}"/>
               </a:ext>
             </a:extLst>
           </p:cNvPr>
@@ -2745,7 +2745,7 @@
           <p:cNvPr id="4" name="Title">
             <a:extLst xmlns:a="http://schemas.openxmlformats.org/drawingml/2006/main">
               <a:ext uri="{FF2B5EF4-FFF2-40B4-BE49-F238E27FC236}">
-                <a16:creationId xmlns:a16="http://schemas.microsoft.com/office/drawing/2014/main" id="{CECE6596-D660-4A8C-B18B-2FECCB717133}"/>
+                <a16:creationId xmlns:a16="http://schemas.microsoft.com/office/drawing/2014/main" id="{829EEE72-9434-4C42-8964-B277CA6E8CF4}"/>
               </a:ext>
             </a:extLst>
           </p:cNvPr>
@@ -2974,7 +2974,7 @@
           <p:cNvPr id="2" name="Left column">
             <a:extLst xmlns:a="http://schemas.openxmlformats.org/drawingml/2006/main">
               <a:ext uri="{FF2B5EF4-FFF2-40B4-BE49-F238E27FC236}">
-                <a16:creationId xmlns:a16="http://schemas.microsoft.com/office/drawing/2014/main" id="{008254E2-F10D-4286-9370-3FE366620FEF}"/>
+                <a16:creationId xmlns:a16="http://schemas.microsoft.com/office/drawing/2014/main" id="{6A8E6E2C-8DFC-4CCF-B9DD-8714B8804525}"/>
               </a:ext>
             </a:extLst>
           </p:cNvPr>
@@ -3203,7 +3203,7 @@
           <p:cNvPr id="3" name="Right column">
             <a:extLst xmlns:a="http://schemas.openxmlformats.org/drawingml/2006/main">
               <a:ext uri="{FF2B5EF4-FFF2-40B4-BE49-F238E27FC236}">
-                <a16:creationId xmlns:a16="http://schemas.microsoft.com/office/drawing/2014/main" id="{F07A29F2-6800-4876-BB18-EFB0A45B2E86}"/>
+                <a16:creationId xmlns:a16="http://schemas.microsoft.com/office/drawing/2014/main" id="{4278DE56-84E9-4202-B9B2-9D89D2C925BC}"/>
               </a:ext>
             </a:extLst>
           </p:cNvPr>
@@ -3449,7 +3449,7 @@
           <p:cNvPr id="3" name="Title">
             <a:extLst xmlns:a="http://schemas.openxmlformats.org/drawingml/2006/main">
               <a:ext uri="{FF2B5EF4-FFF2-40B4-BE49-F238E27FC236}">
-                <a16:creationId xmlns:a16="http://schemas.microsoft.com/office/drawing/2014/main" id="{5A029A9F-9664-414B-962E-70BABAE63FD3}"/>
+                <a16:creationId xmlns:a16="http://schemas.microsoft.com/office/drawing/2014/main" id="{D1F11089-519F-4F8F-B185-67488B720512}"/>
               </a:ext>
             </a:extLst>
           </p:cNvPr>
@@ -3678,7 +3678,7 @@
           <p:cNvPr id="2" name="Left column">
             <a:extLst xmlns:a="http://schemas.openxmlformats.org/drawingml/2006/main">
               <a:ext uri="{FF2B5EF4-FFF2-40B4-BE49-F238E27FC236}">
-                <a16:creationId xmlns:a16="http://schemas.microsoft.com/office/drawing/2014/main" id="{9B068343-F65C-408D-B4FB-817366130859}"/>
+                <a16:creationId xmlns:a16="http://schemas.microsoft.com/office/drawing/2014/main" id="{4163FC55-18EA-413C-A5C1-0F072D323CCA}"/>
               </a:ext>
             </a:extLst>
           </p:cNvPr>
@@ -3945,12 +3945,12 @@
   </p:cSld>
   <p:clrMap bg1="lt1" tx1="dk1" bg2="lt2" tx2="dk2" accent1="accent1" accent2="accent2" accent3="accent3" accent4="accent4" accent5="accent5" accent6="accent6" hlink="hlink" folHlink="folHlink"/>
   <p:sldLayoutIdLst>
-    <p:sldLayoutId xmlns:r="http://schemas.openxmlformats.org/officeDocument/2006/relationships" id="2147483649" r:id="Ra5e768cb7eac41c6"/>
-    <p:sldLayoutId xmlns:r="http://schemas.openxmlformats.org/officeDocument/2006/relationships" id="2147483650" r:id="Rfedb1d7b4d7e47c1"/>
-    <p:sldLayoutId xmlns:r="http://schemas.openxmlformats.org/officeDocument/2006/relationships" id="2147483651" r:id="Rd54cf6fee76a4246"/>
-    <p:sldLayoutId xmlns:r="http://schemas.openxmlformats.org/officeDocument/2006/relationships" id="2147483652" r:id="Rcd6a76a6f1f94042"/>
-    <p:sldLayoutId xmlns:r="http://schemas.openxmlformats.org/officeDocument/2006/relationships" id="2147483653" r:id="Rbe5b34969f0b408e"/>
-    <p:sldLayoutId xmlns:r="http://schemas.openxmlformats.org/officeDocument/2006/relationships" id="2147483654" r:id="R324d72bfea7942e1"/>
+    <p:sldLayoutId xmlns:r="http://schemas.openxmlformats.org/officeDocument/2006/relationships" id="2147483649" r:id="Rd49d7f49a1724110"/>
+    <p:sldLayoutId xmlns:r="http://schemas.openxmlformats.org/officeDocument/2006/relationships" id="2147483650" r:id="Rcab3d241e4724e97"/>
+    <p:sldLayoutId xmlns:r="http://schemas.openxmlformats.org/officeDocument/2006/relationships" id="2147483651" r:id="Re74be2f472a443d9"/>
+    <p:sldLayoutId xmlns:r="http://schemas.openxmlformats.org/officeDocument/2006/relationships" id="2147483652" r:id="Ra3ea5aea37f449a0"/>
+    <p:sldLayoutId xmlns:r="http://schemas.openxmlformats.org/officeDocument/2006/relationships" id="2147483653" r:id="R3c527b364c8a4864"/>
+    <p:sldLayoutId xmlns:r="http://schemas.openxmlformats.org/officeDocument/2006/relationships" id="2147483654" r:id="R1ecb9041d932437b"/>
   </p:sldLayoutIdLst>
   <p:txStyles>
     <p:titleStyle>
@@ -5273,7 +5273,7 @@
           <p:cNvPr id="8" name="">
             <a:extLst xmlns:a="http://schemas.openxmlformats.org/drawingml/2006/main">
               <a:ext uri="{FF2B5EF4-FFF2-40B4-BE49-F238E27FC236}">
-                <a16:creationId xmlns:a16="http://schemas.microsoft.com/office/drawing/2014/main" id="{085861A8-AB3C-4EB1-ACAC-591C5875771B}"/>
+                <a16:creationId xmlns:a16="http://schemas.microsoft.com/office/drawing/2014/main" id="{2931C739-C2B7-49E5-B3CD-899CDA50F3AA}"/>
               </a:ext>
             </a:extLst>
           </p:cNvPr>
@@ -5430,7 +5430,7 @@
           <p:cNvPr id="2" name="">
             <a:extLst xmlns:a="http://schemas.openxmlformats.org/drawingml/2006/main">
               <a:ext uri="{FF2B5EF4-FFF2-40B4-BE49-F238E27FC236}">
-                <a16:creationId xmlns:a16="http://schemas.microsoft.com/office/drawing/2014/main" id="{62356425-34D7-4847-B9AB-53D7A481830C}"/>
+                <a16:creationId xmlns:a16="http://schemas.microsoft.com/office/drawing/2014/main" id="{3221FB87-B28F-4710-9DE5-7553F59775B1}"/>
               </a:ext>
             </a:extLst>
           </p:cNvPr>
@@ -5461,7 +5461,7 @@
           <p:cNvPr id="3" name="">
             <a:extLst xmlns:a="http://schemas.openxmlformats.org/drawingml/2006/main">
               <a:ext uri="{FF2B5EF4-FFF2-40B4-BE49-F238E27FC236}">
-                <a16:creationId xmlns:a16="http://schemas.microsoft.com/office/drawing/2014/main" id="{16F72F8B-323B-4058-A2C6-E120D49B3956}"/>
+                <a16:creationId xmlns:a16="http://schemas.microsoft.com/office/drawing/2014/main" id="{1FE26197-898D-40E8-9296-7982D0160539}"/>
               </a:ext>
             </a:extLst>
           </p:cNvPr>
@@ -5618,7 +5618,7 @@
           <p:cNvPr id="4" name="">
             <a:extLst xmlns:a="http://schemas.openxmlformats.org/drawingml/2006/main">
               <a:ext uri="{FF2B5EF4-FFF2-40B4-BE49-F238E27FC236}">
-                <a16:creationId xmlns:a16="http://schemas.microsoft.com/office/drawing/2014/main" id="{64A35DBB-8FFF-4DFA-A32E-E338CC76781E}"/>
+                <a16:creationId xmlns:a16="http://schemas.microsoft.com/office/drawing/2014/main" id="{207F3C4B-84F9-4C4E-9CB6-955249D69589}"/>
               </a:ext>
             </a:extLst>
           </p:cNvPr>
@@ -5775,7 +5775,7 @@
           <p:cNvPr id="5" name="">
             <a:extLst xmlns:a="http://schemas.openxmlformats.org/drawingml/2006/main">
               <a:ext uri="{FF2B5EF4-FFF2-40B4-BE49-F238E27FC236}">
-                <a16:creationId xmlns:a16="http://schemas.microsoft.com/office/drawing/2014/main" id="{52A22048-6D03-4606-B7CD-4B5B00665369}"/>
+                <a16:creationId xmlns:a16="http://schemas.microsoft.com/office/drawing/2014/main" id="{FAF571CA-0CE3-4D98-8139-958A257F3AD8}"/>
               </a:ext>
             </a:extLst>
           </p:cNvPr>
@@ -5955,7 +5955,7 @@
           <p:cNvPr id="6" name="">
             <a:extLst xmlns:a="http://schemas.openxmlformats.org/drawingml/2006/main">
               <a:ext uri="{FF2B5EF4-FFF2-40B4-BE49-F238E27FC236}">
-                <a16:creationId xmlns:a16="http://schemas.microsoft.com/office/drawing/2014/main" id="{94BAF315-2A8A-40F7-BB88-E7E4392E3076}"/>
+                <a16:creationId xmlns:a16="http://schemas.microsoft.com/office/drawing/2014/main" id="{32FD49FE-90AC-45AB-B405-D55ECDE8E289}"/>
               </a:ext>
             </a:extLst>
           </p:cNvPr>
@@ -6112,7 +6112,7 @@
           <p:cNvPr id="7" name="">
             <a:extLst xmlns:a="http://schemas.openxmlformats.org/drawingml/2006/main">
               <a:ext uri="{FF2B5EF4-FFF2-40B4-BE49-F238E27FC236}">
-                <a16:creationId xmlns:a16="http://schemas.microsoft.com/office/drawing/2014/main" id="{FCD731BA-F819-48FA-8AFC-59718937548D}"/>
+                <a16:creationId xmlns:a16="http://schemas.microsoft.com/office/drawing/2014/main" id="{A551D15F-58CA-49A8-9624-CF8342026496}"/>
               </a:ext>
             </a:extLst>
           </p:cNvPr>
@@ -6267,7 +6267,7 @@
     </p:spTree>
     <p:extLst>
       <p:ext uri="{BB962C8B-B14F-4D97-AF65-F5344CB8AC3E}">
-        <p14:creationId xmlns:p14="http://schemas.microsoft.com/office/powerpoint/2010/main" val="628148482"/>
+        <p14:creationId xmlns:p14="http://schemas.microsoft.com/office/powerpoint/2010/main" val="76454812"/>
       </p:ext>
     </p:extLst>
   </p:cSld>
@@ -6298,7 +6298,7 @@
           <p:cNvPr id="9" name="">
             <a:extLst xmlns:a="http://schemas.openxmlformats.org/drawingml/2006/main">
               <a:ext uri="{FF2B5EF4-FFF2-40B4-BE49-F238E27FC236}">
-                <a16:creationId xmlns:a16="http://schemas.microsoft.com/office/drawing/2014/main" id="{85990A5F-26B3-4787-8F99-E343216258B4}"/>
+                <a16:creationId xmlns:a16="http://schemas.microsoft.com/office/drawing/2014/main" id="{F65F2614-3411-4836-9D5F-01720F1AAFD6}"/>
               </a:ext>
             </a:extLst>
           </p:cNvPr>
@@ -6455,7 +6455,7 @@
           <p:cNvPr id="2" name="">
             <a:extLst xmlns:a="http://schemas.openxmlformats.org/drawingml/2006/main">
               <a:ext uri="{FF2B5EF4-FFF2-40B4-BE49-F238E27FC236}">
-                <a16:creationId xmlns:a16="http://schemas.microsoft.com/office/drawing/2014/main" id="{70D8B62F-89FC-4E4C-872C-F609BC19F8C5}"/>
+                <a16:creationId xmlns:a16="http://schemas.microsoft.com/office/drawing/2014/main" id="{82C598B6-3E05-4218-ACF4-00BBE5F7CBB8}"/>
               </a:ext>
             </a:extLst>
           </p:cNvPr>
@@ -6486,7 +6486,7 @@
           <p:cNvPr id="3" name="">
             <a:extLst xmlns:a="http://schemas.openxmlformats.org/drawingml/2006/main">
               <a:ext uri="{FF2B5EF4-FFF2-40B4-BE49-F238E27FC236}">
-                <a16:creationId xmlns:a16="http://schemas.microsoft.com/office/drawing/2014/main" id="{2BBFED0B-8BB3-4A51-BD4E-5D10D4743ABB}"/>
+                <a16:creationId xmlns:a16="http://schemas.microsoft.com/office/drawing/2014/main" id="{3C3ECF62-E3D2-42A0-98BB-8FEBED43909F}"/>
               </a:ext>
             </a:extLst>
           </p:cNvPr>
@@ -6643,7 +6643,7 @@
           <p:cNvPr id="4" name="Chart">
             <a:extLst xmlns:a="http://schemas.openxmlformats.org/drawingml/2006/main">
               <a:ext uri="{FF2B5EF4-FFF2-40B4-BE49-F238E27FC236}">
-                <a16:creationId xmlns:a16="http://schemas.microsoft.com/office/drawing/2014/main" id="{86696CAB-BF73-4338-89D1-6BE33E5028F5}"/>
+                <a16:creationId xmlns:a16="http://schemas.microsoft.com/office/drawing/2014/main" id="{97E87B18-1996-407D-83EE-D67A6CE25578}"/>
               </a:ext>
             </a:extLst>
           </p:cNvPr>
@@ -6656,7 +6656,7 @@
         </p:xfrm>
         <a:graphic xmlns:a="http://schemas.openxmlformats.org/drawingml/2006/main">
           <a:graphicData uri="http://schemas.openxmlformats.org/drawingml/2006/chart">
-            <c:chart xmlns:r="http://schemas.openxmlformats.org/officeDocument/2006/relationships" xmlns:c="http://schemas.openxmlformats.org/drawingml/2006/chart" r:id="R012cfe27640f49c3"/>
+            <c:chart xmlns:r="http://schemas.openxmlformats.org/officeDocument/2006/relationships" xmlns:c="http://schemas.openxmlformats.org/drawingml/2006/chart" r:id="R2ef3791c139d4645"/>
           </a:graphicData>
         </a:graphic>
       </p:graphicFrame>
@@ -6665,7 +6665,7 @@
           <p:cNvPr id="5" name="">
             <a:extLst xmlns:a="http://schemas.openxmlformats.org/drawingml/2006/main">
               <a:ext uri="{FF2B5EF4-FFF2-40B4-BE49-F238E27FC236}">
-                <a16:creationId xmlns:a16="http://schemas.microsoft.com/office/drawing/2014/main" id="{1D4662CA-7516-4B35-966E-03FEA2845D88}"/>
+                <a16:creationId xmlns:a16="http://schemas.microsoft.com/office/drawing/2014/main" id="{8EE470E3-3192-4A9C-966C-893F3F75A701}"/>
               </a:ext>
             </a:extLst>
           </p:cNvPr>
@@ -6822,7 +6822,7 @@
           <p:cNvPr id="6" name="">
             <a:extLst xmlns:a="http://schemas.openxmlformats.org/drawingml/2006/main">
               <a:ext uri="{FF2B5EF4-FFF2-40B4-BE49-F238E27FC236}">
-                <a16:creationId xmlns:a16="http://schemas.microsoft.com/office/drawing/2014/main" id="{1AA7D12C-0466-4C88-ADBD-EBB1FE0A5A31}"/>
+                <a16:creationId xmlns:a16="http://schemas.microsoft.com/office/drawing/2014/main" id="{8B8C4C42-4C19-4E5C-8874-6AB1908B12E7}"/>
               </a:ext>
             </a:extLst>
           </p:cNvPr>
@@ -7053,7 +7053,7 @@
           <p:cNvPr id="7" name="">
             <a:extLst xmlns:a="http://schemas.openxmlformats.org/drawingml/2006/main">
               <a:ext uri="{FF2B5EF4-FFF2-40B4-BE49-F238E27FC236}">
-                <a16:creationId xmlns:a16="http://schemas.microsoft.com/office/drawing/2014/main" id="{E1A0A09F-A812-4D65-9C1A-688594200D94}"/>
+                <a16:creationId xmlns:a16="http://schemas.microsoft.com/office/drawing/2014/main" id="{E9993840-146A-4C43-94E9-E25BD05A5E4F}"/>
               </a:ext>
             </a:extLst>
           </p:cNvPr>
@@ -7233,7 +7233,7 @@
           <p:cNvPr id="8" name="">
             <a:extLst xmlns:a="http://schemas.openxmlformats.org/drawingml/2006/main">
               <a:ext uri="{FF2B5EF4-FFF2-40B4-BE49-F238E27FC236}">
-                <a16:creationId xmlns:a16="http://schemas.microsoft.com/office/drawing/2014/main" id="{1626330D-A873-4B36-9271-4E9D95F00B7C}"/>
+                <a16:creationId xmlns:a16="http://schemas.microsoft.com/office/drawing/2014/main" id="{EB9B561B-2A06-44B6-8B82-171386CDDBBB}"/>
               </a:ext>
             </a:extLst>
           </p:cNvPr>
@@ -7388,7 +7388,7 @@
     </p:spTree>
     <p:extLst>
       <p:ext uri="{BB962C8B-B14F-4D97-AF65-F5344CB8AC3E}">
-        <p14:creationId xmlns:p14="http://schemas.microsoft.com/office/powerpoint/2010/main" val="1496047022"/>
+        <p14:creationId xmlns:p14="http://schemas.microsoft.com/office/powerpoint/2010/main" val="185808069"/>
       </p:ext>
     </p:extLst>
   </p:cSld>
@@ -7419,7 +7419,7 @@
           <p:cNvPr id="9" name="">
             <a:extLst xmlns:a="http://schemas.openxmlformats.org/drawingml/2006/main">
               <a:ext uri="{FF2B5EF4-FFF2-40B4-BE49-F238E27FC236}">
-                <a16:creationId xmlns:a16="http://schemas.microsoft.com/office/drawing/2014/main" id="{2CFF114F-92B2-41AE-97E9-9F3F45CDA182}"/>
+                <a16:creationId xmlns:a16="http://schemas.microsoft.com/office/drawing/2014/main" id="{EF3F067F-6045-4DFA-B723-D133CC9D6369}"/>
               </a:ext>
             </a:extLst>
           </p:cNvPr>
@@ -7576,7 +7576,7 @@
           <p:cNvPr id="2" name="">
             <a:extLst xmlns:a="http://schemas.openxmlformats.org/drawingml/2006/main">
               <a:ext uri="{FF2B5EF4-FFF2-40B4-BE49-F238E27FC236}">
-                <a16:creationId xmlns:a16="http://schemas.microsoft.com/office/drawing/2014/main" id="{196E85A7-8EE8-4FDB-BD48-1C1B8AB9B443}"/>
+                <a16:creationId xmlns:a16="http://schemas.microsoft.com/office/drawing/2014/main" id="{F7049228-3306-439B-BFD1-E1CDF6B722FE}"/>
               </a:ext>
             </a:extLst>
           </p:cNvPr>
@@ -7607,7 +7607,7 @@
           <p:cNvPr id="3" name="">
             <a:extLst xmlns:a="http://schemas.openxmlformats.org/drawingml/2006/main">
               <a:ext uri="{FF2B5EF4-FFF2-40B4-BE49-F238E27FC236}">
-                <a16:creationId xmlns:a16="http://schemas.microsoft.com/office/drawing/2014/main" id="{0955EC8D-EC93-433B-9DEB-58B20BEC27FC}"/>
+                <a16:creationId xmlns:a16="http://schemas.microsoft.com/office/drawing/2014/main" id="{7B0F8D21-8F36-44CC-935B-B33937FBA78C}"/>
               </a:ext>
             </a:extLst>
           </p:cNvPr>
@@ -7764,7 +7764,7 @@
           <p:cNvPr id="4" name="">
             <a:extLst xmlns:a="http://schemas.openxmlformats.org/drawingml/2006/main">
               <a:ext uri="{FF2B5EF4-FFF2-40B4-BE49-F238E27FC236}">
-                <a16:creationId xmlns:a16="http://schemas.microsoft.com/office/drawing/2014/main" id="{9A5FDD7F-0A2A-4F96-BE3A-1F0928C8F7D1}"/>
+                <a16:creationId xmlns:a16="http://schemas.microsoft.com/office/drawing/2014/main" id="{7F1874AC-F606-4A9C-81E5-0AE60D783C44}"/>
               </a:ext>
             </a:extLst>
           </p:cNvPr>
@@ -7921,7 +7921,7 @@
           <p:cNvPr id="5" name="">
             <a:extLst xmlns:a="http://schemas.openxmlformats.org/drawingml/2006/main">
               <a:ext uri="{FF2B5EF4-FFF2-40B4-BE49-F238E27FC236}">
-                <a16:creationId xmlns:a16="http://schemas.microsoft.com/office/drawing/2014/main" id="{FB9EDB60-C485-4B75-B55A-1D9F13B566AC}"/>
+                <a16:creationId xmlns:a16="http://schemas.microsoft.com/office/drawing/2014/main" id="{C0A4A5C3-1B36-48C4-89D2-59953917B14F}"/>
               </a:ext>
             </a:extLst>
           </p:cNvPr>
@@ -8147,7 +8147,7 @@
           <p:cNvPr id="6" name="">
             <a:extLst xmlns:a="http://schemas.openxmlformats.org/drawingml/2006/main">
               <a:ext uri="{FF2B5EF4-FFF2-40B4-BE49-F238E27FC236}">
-                <a16:creationId xmlns:a16="http://schemas.microsoft.com/office/drawing/2014/main" id="{73DCF4EB-85CD-4D28-9903-B62F3A949FA5}"/>
+                <a16:creationId xmlns:a16="http://schemas.microsoft.com/office/drawing/2014/main" id="{C94233A3-8AD3-4A90-B505-CC313360159F}"/>
               </a:ext>
             </a:extLst>
           </p:cNvPr>
@@ -8304,7 +8304,7 @@
           <p:cNvPr id="7" name="">
             <a:extLst xmlns:a="http://schemas.openxmlformats.org/drawingml/2006/main">
               <a:ext uri="{FF2B5EF4-FFF2-40B4-BE49-F238E27FC236}">
-                <a16:creationId xmlns:a16="http://schemas.microsoft.com/office/drawing/2014/main" id="{E89DEB6D-C265-4753-B321-851FB4318660}"/>
+                <a16:creationId xmlns:a16="http://schemas.microsoft.com/office/drawing/2014/main" id="{3F440BE6-EE5C-4DED-9F73-65A9980572D7}"/>
               </a:ext>
             </a:extLst>
           </p:cNvPr>
@@ -8530,7 +8530,7 @@
           <p:cNvPr id="8" name="">
             <a:extLst xmlns:a="http://schemas.openxmlformats.org/drawingml/2006/main">
               <a:ext uri="{FF2B5EF4-FFF2-40B4-BE49-F238E27FC236}">
-                <a16:creationId xmlns:a16="http://schemas.microsoft.com/office/drawing/2014/main" id="{3FCBC74A-5B65-4616-9D48-F7D97E1F01E8}"/>
+                <a16:creationId xmlns:a16="http://schemas.microsoft.com/office/drawing/2014/main" id="{F39B4CF7-2700-469B-836A-11DB528A71DF}"/>
               </a:ext>
             </a:extLst>
           </p:cNvPr>
@@ -8685,7 +8685,7 @@
     </p:spTree>
     <p:extLst>
       <p:ext uri="{BB962C8B-B14F-4D97-AF65-F5344CB8AC3E}">
-        <p14:creationId xmlns:p14="http://schemas.microsoft.com/office/powerpoint/2010/main" val="1385435034"/>
+        <p14:creationId xmlns:p14="http://schemas.microsoft.com/office/powerpoint/2010/main" val="250166249"/>
       </p:ext>
     </p:extLst>
   </p:cSld>
@@ -8716,7 +8716,7 @@
           <p:cNvPr id="20" name="">
             <a:extLst xmlns:a="http://schemas.openxmlformats.org/drawingml/2006/main">
               <a:ext uri="{FF2B5EF4-FFF2-40B4-BE49-F238E27FC236}">
-                <a16:creationId xmlns:a16="http://schemas.microsoft.com/office/drawing/2014/main" id="{A4DA2664-4950-403A-B577-733EC9F81ED9}"/>
+                <a16:creationId xmlns:a16="http://schemas.microsoft.com/office/drawing/2014/main" id="{F771DE65-3C3D-4D45-8F55-43BFB1811946}"/>
               </a:ext>
             </a:extLst>
           </p:cNvPr>
@@ -8873,7 +8873,7 @@
           <p:cNvPr id="2" name="">
             <a:extLst xmlns:a="http://schemas.openxmlformats.org/drawingml/2006/main">
               <a:ext uri="{FF2B5EF4-FFF2-40B4-BE49-F238E27FC236}">
-                <a16:creationId xmlns:a16="http://schemas.microsoft.com/office/drawing/2014/main" id="{910FEAD2-8279-441A-B5E5-6EF80DB2DD11}"/>
+                <a16:creationId xmlns:a16="http://schemas.microsoft.com/office/drawing/2014/main" id="{3430B949-20C8-4A49-8CE5-FACF6447B538}"/>
               </a:ext>
             </a:extLst>
           </p:cNvPr>
@@ -8904,7 +8904,7 @@
           <p:cNvPr id="3" name="">
             <a:extLst xmlns:a="http://schemas.openxmlformats.org/drawingml/2006/main">
               <a:ext uri="{FF2B5EF4-FFF2-40B4-BE49-F238E27FC236}">
-                <a16:creationId xmlns:a16="http://schemas.microsoft.com/office/drawing/2014/main" id="{D4D2292E-309C-49F5-820D-9847CF107334}"/>
+                <a16:creationId xmlns:a16="http://schemas.microsoft.com/office/drawing/2014/main" id="{696E88C2-E0E7-490B-B5EC-B29DC39226A1}"/>
               </a:ext>
             </a:extLst>
           </p:cNvPr>
@@ -9061,7 +9061,7 @@
           <p:cNvPr id="4" name="">
             <a:extLst xmlns:a="http://schemas.openxmlformats.org/drawingml/2006/main">
               <a:ext uri="{FF2B5EF4-FFF2-40B4-BE49-F238E27FC236}">
-                <a16:creationId xmlns:a16="http://schemas.microsoft.com/office/drawing/2014/main" id="{86701FDB-018E-4E95-A686-18A013AC6A5E}"/>
+                <a16:creationId xmlns:a16="http://schemas.microsoft.com/office/drawing/2014/main" id="{1010AC2A-E606-4A9C-BBF2-A7073C6F1C6F}"/>
               </a:ext>
             </a:extLst>
           </p:cNvPr>
@@ -9218,7 +9218,7 @@
           <p:cNvPr id="5" name="">
             <a:extLst xmlns:a="http://schemas.openxmlformats.org/drawingml/2006/main">
               <a:ext uri="{FF2B5EF4-FFF2-40B4-BE49-F238E27FC236}">
-                <a16:creationId xmlns:a16="http://schemas.microsoft.com/office/drawing/2014/main" id="{9F6A2F6D-864D-433E-ABE3-2056C0456EE3}"/>
+                <a16:creationId xmlns:a16="http://schemas.microsoft.com/office/drawing/2014/main" id="{3486F0F7-D043-49F2-9644-030EFE352F82}"/>
               </a:ext>
             </a:extLst>
           </p:cNvPr>
@@ -9375,7 +9375,7 @@
           <p:cNvPr id="6" name="">
             <a:extLst xmlns:a="http://schemas.openxmlformats.org/drawingml/2006/main">
               <a:ext uri="{FF2B5EF4-FFF2-40B4-BE49-F238E27FC236}">
-                <a16:creationId xmlns:a16="http://schemas.microsoft.com/office/drawing/2014/main" id="{38BD5912-0F60-4E96-AB6E-34444F2A493E}"/>
+                <a16:creationId xmlns:a16="http://schemas.microsoft.com/office/drawing/2014/main" id="{C1B4F601-6289-4FF3-9E11-0EBB7EA9E3AE}"/>
               </a:ext>
             </a:extLst>
           </p:cNvPr>
@@ -9532,7 +9532,7 @@
           <p:cNvPr id="7" name="">
             <a:extLst xmlns:a="http://schemas.openxmlformats.org/drawingml/2006/main">
               <a:ext uri="{FF2B5EF4-FFF2-40B4-BE49-F238E27FC236}">
-                <a16:creationId xmlns:a16="http://schemas.microsoft.com/office/drawing/2014/main" id="{B7541DFB-211F-422D-B619-EC4680CEC75E}"/>
+                <a16:creationId xmlns:a16="http://schemas.microsoft.com/office/drawing/2014/main" id="{55F52CAD-CEE4-4E5E-9E63-CE4B7ACE9587}"/>
               </a:ext>
             </a:extLst>
           </p:cNvPr>
@@ -9563,7 +9563,7 @@
           <p:cNvPr id="8" name="">
             <a:extLst xmlns:a="http://schemas.openxmlformats.org/drawingml/2006/main">
               <a:ext uri="{FF2B5EF4-FFF2-40B4-BE49-F238E27FC236}">
-                <a16:creationId xmlns:a16="http://schemas.microsoft.com/office/drawing/2014/main" id="{0C31C49E-0D51-4992-A965-91740E1E77DA}"/>
+                <a16:creationId xmlns:a16="http://schemas.microsoft.com/office/drawing/2014/main" id="{4C30EA8B-73DD-463B-BC2E-6A3C3072EFA5}"/>
               </a:ext>
             </a:extLst>
           </p:cNvPr>
@@ -9720,7 +9720,7 @@
           <p:cNvPr id="9" name="">
             <a:extLst xmlns:a="http://schemas.openxmlformats.org/drawingml/2006/main">
               <a:ext uri="{FF2B5EF4-FFF2-40B4-BE49-F238E27FC236}">
-                <a16:creationId xmlns:a16="http://schemas.microsoft.com/office/drawing/2014/main" id="{327FECFC-E4AA-4B02-AF95-D5DA0AA14F32}"/>
+                <a16:creationId xmlns:a16="http://schemas.microsoft.com/office/drawing/2014/main" id="{2C787E27-072A-41E3-94DA-1960405A61DE}"/>
               </a:ext>
             </a:extLst>
           </p:cNvPr>
@@ -9877,7 +9877,7 @@
           <p:cNvPr id="10" name="">
             <a:extLst xmlns:a="http://schemas.openxmlformats.org/drawingml/2006/main">
               <a:ext uri="{FF2B5EF4-FFF2-40B4-BE49-F238E27FC236}">
-                <a16:creationId xmlns:a16="http://schemas.microsoft.com/office/drawing/2014/main" id="{F18336CC-944B-440C-9ECF-241AE2E64FC2}"/>
+                <a16:creationId xmlns:a16="http://schemas.microsoft.com/office/drawing/2014/main" id="{1F14217A-BCE9-46C0-B1AF-5F689652D8FF}"/>
               </a:ext>
             </a:extLst>
           </p:cNvPr>
@@ -10034,7 +10034,7 @@
           <p:cNvPr id="11" name="">
             <a:extLst xmlns:a="http://schemas.openxmlformats.org/drawingml/2006/main">
               <a:ext uri="{FF2B5EF4-FFF2-40B4-BE49-F238E27FC236}">
-                <a16:creationId xmlns:a16="http://schemas.microsoft.com/office/drawing/2014/main" id="{4C5CC8B7-8EAF-4A79-BC7D-E6CF8196BDB2}"/>
+                <a16:creationId xmlns:a16="http://schemas.microsoft.com/office/drawing/2014/main" id="{DF83E6DA-205E-4E47-B884-E99530ACCD18}"/>
               </a:ext>
             </a:extLst>
           </p:cNvPr>
@@ -10065,7 +10065,7 @@
           <p:cNvPr id="12" name="">
             <a:extLst xmlns:a="http://schemas.openxmlformats.org/drawingml/2006/main">
               <a:ext uri="{FF2B5EF4-FFF2-40B4-BE49-F238E27FC236}">
-                <a16:creationId xmlns:a16="http://schemas.microsoft.com/office/drawing/2014/main" id="{E6914BAB-DF2A-45C1-A8F4-793CC55D32F4}"/>
+                <a16:creationId xmlns:a16="http://schemas.microsoft.com/office/drawing/2014/main" id="{65A63E89-B5CD-4697-B7FD-459388F5EC6F}"/>
               </a:ext>
             </a:extLst>
           </p:cNvPr>
@@ -10222,7 +10222,7 @@
           <p:cNvPr id="13" name="">
             <a:extLst xmlns:a="http://schemas.openxmlformats.org/drawingml/2006/main">
               <a:ext uri="{FF2B5EF4-FFF2-40B4-BE49-F238E27FC236}">
-                <a16:creationId xmlns:a16="http://schemas.microsoft.com/office/drawing/2014/main" id="{570F0341-A77F-4118-B1C1-03F319C40D29}"/>
+                <a16:creationId xmlns:a16="http://schemas.microsoft.com/office/drawing/2014/main" id="{955E6554-4D37-4E8D-9EC3-BDD24B4E31C6}"/>
               </a:ext>
             </a:extLst>
           </p:cNvPr>
@@ -10379,7 +10379,7 @@
           <p:cNvPr id="14" name="">
             <a:extLst xmlns:a="http://schemas.openxmlformats.org/drawingml/2006/main">
               <a:ext uri="{FF2B5EF4-FFF2-40B4-BE49-F238E27FC236}">
-                <a16:creationId xmlns:a16="http://schemas.microsoft.com/office/drawing/2014/main" id="{AB22EC6C-8DF7-4012-A38A-7288964F8DB5}"/>
+                <a16:creationId xmlns:a16="http://schemas.microsoft.com/office/drawing/2014/main" id="{D45C8726-680D-411F-A759-0972EFAEDFD0}"/>
               </a:ext>
             </a:extLst>
           </p:cNvPr>
@@ -10536,7 +10536,7 @@
           <p:cNvPr id="15" name="">
             <a:extLst xmlns:a="http://schemas.openxmlformats.org/drawingml/2006/main">
               <a:ext uri="{FF2B5EF4-FFF2-40B4-BE49-F238E27FC236}">
-                <a16:creationId xmlns:a16="http://schemas.microsoft.com/office/drawing/2014/main" id="{F7C29D7C-F666-42FF-AB42-4198D196FFA6}"/>
+                <a16:creationId xmlns:a16="http://schemas.microsoft.com/office/drawing/2014/main" id="{0E34FAF6-AB18-4B81-A702-4B093207B495}"/>
               </a:ext>
             </a:extLst>
           </p:cNvPr>
@@ -10567,7 +10567,7 @@
           <p:cNvPr id="16" name="">
             <a:extLst xmlns:a="http://schemas.openxmlformats.org/drawingml/2006/main">
               <a:ext uri="{FF2B5EF4-FFF2-40B4-BE49-F238E27FC236}">
-                <a16:creationId xmlns:a16="http://schemas.microsoft.com/office/drawing/2014/main" id="{7E50E9F3-C7E4-4D2F-A792-5E07B7A58CC3}"/>
+                <a16:creationId xmlns:a16="http://schemas.microsoft.com/office/drawing/2014/main" id="{8BE6C259-B9A6-4E77-9B93-1422F870D4E3}"/>
               </a:ext>
             </a:extLst>
           </p:cNvPr>
@@ -10724,7 +10724,7 @@
           <p:cNvPr id="17" name="">
             <a:extLst xmlns:a="http://schemas.openxmlformats.org/drawingml/2006/main">
               <a:ext uri="{FF2B5EF4-FFF2-40B4-BE49-F238E27FC236}">
-                <a16:creationId xmlns:a16="http://schemas.microsoft.com/office/drawing/2014/main" id="{A4F32598-7A65-4263-8F69-C81749AE171C}"/>
+                <a16:creationId xmlns:a16="http://schemas.microsoft.com/office/drawing/2014/main" id="{99F49FC5-2BFA-4551-9AB0-308B6AA7E71C}"/>
               </a:ext>
             </a:extLst>
           </p:cNvPr>
@@ -10881,7 +10881,7 @@
           <p:cNvPr id="18" name="">
             <a:extLst xmlns:a="http://schemas.openxmlformats.org/drawingml/2006/main">
               <a:ext uri="{FF2B5EF4-FFF2-40B4-BE49-F238E27FC236}">
-                <a16:creationId xmlns:a16="http://schemas.microsoft.com/office/drawing/2014/main" id="{E001C4EC-7814-4599-86C2-6DDA9E166B2E}"/>
+                <a16:creationId xmlns:a16="http://schemas.microsoft.com/office/drawing/2014/main" id="{6A84CC69-0CF0-49E4-BA8C-670330DEDAFC}"/>
               </a:ext>
             </a:extLst>
           </p:cNvPr>
@@ -11038,7 +11038,7 @@
           <p:cNvPr id="19" name="">
             <a:extLst xmlns:a="http://schemas.openxmlformats.org/drawingml/2006/main">
               <a:ext uri="{FF2B5EF4-FFF2-40B4-BE49-F238E27FC236}">
-                <a16:creationId xmlns:a16="http://schemas.microsoft.com/office/drawing/2014/main" id="{E2720C83-AD78-4D1F-AF4B-AF8B7D2EAB97}"/>
+                <a16:creationId xmlns:a16="http://schemas.microsoft.com/office/drawing/2014/main" id="{2CC7DAA2-3819-4DD0-9EC6-C1DE866762F9}"/>
               </a:ext>
             </a:extLst>
           </p:cNvPr>
@@ -11193,7 +11193,7 @@
     </p:spTree>
     <p:extLst>
       <p:ext uri="{BB962C8B-B14F-4D97-AF65-F5344CB8AC3E}">
-        <p14:creationId xmlns:p14="http://schemas.microsoft.com/office/powerpoint/2010/main" val="970490988"/>
+        <p14:creationId xmlns:p14="http://schemas.microsoft.com/office/powerpoint/2010/main" val="1360634100"/>
       </p:ext>
     </p:extLst>
   </p:cSld>
@@ -11224,7 +11224,7 @@
           <p:cNvPr id="19" name="">
             <a:extLst xmlns:a="http://schemas.openxmlformats.org/drawingml/2006/main">
               <a:ext uri="{FF2B5EF4-FFF2-40B4-BE49-F238E27FC236}">
-                <a16:creationId xmlns:a16="http://schemas.microsoft.com/office/drawing/2014/main" id="{FCDB52B6-3402-427E-8A8E-4ED4BD7487BE}"/>
+                <a16:creationId xmlns:a16="http://schemas.microsoft.com/office/drawing/2014/main" id="{1F484A4F-36C6-41C9-AA55-586C2813CE61}"/>
               </a:ext>
             </a:extLst>
           </p:cNvPr>
@@ -11381,7 +11381,7 @@
           <p:cNvPr id="2" name="">
             <a:extLst xmlns:a="http://schemas.openxmlformats.org/drawingml/2006/main">
               <a:ext uri="{FF2B5EF4-FFF2-40B4-BE49-F238E27FC236}">
-                <a16:creationId xmlns:a16="http://schemas.microsoft.com/office/drawing/2014/main" id="{6EDC6004-5BDA-4CEC-B511-D899B29F948B}"/>
+                <a16:creationId xmlns:a16="http://schemas.microsoft.com/office/drawing/2014/main" id="{B7D421F5-6E3E-4DA0-94B2-F24651ED889C}"/>
               </a:ext>
             </a:extLst>
           </p:cNvPr>
@@ -11412,7 +11412,7 @@
           <p:cNvPr id="3" name="">
             <a:extLst xmlns:a="http://schemas.openxmlformats.org/drawingml/2006/main">
               <a:ext uri="{FF2B5EF4-FFF2-40B4-BE49-F238E27FC236}">
-                <a16:creationId xmlns:a16="http://schemas.microsoft.com/office/drawing/2014/main" id="{64097EC6-23EC-4001-BE67-E61A271EBC28}"/>
+                <a16:creationId xmlns:a16="http://schemas.microsoft.com/office/drawing/2014/main" id="{31AF07CC-8F84-4E2D-93A1-D46D15AB85E3}"/>
               </a:ext>
             </a:extLst>
           </p:cNvPr>
@@ -11569,7 +11569,7 @@
           <p:cNvPr id="4" name="">
             <a:extLst xmlns:a="http://schemas.openxmlformats.org/drawingml/2006/main">
               <a:ext uri="{FF2B5EF4-FFF2-40B4-BE49-F238E27FC236}">
-                <a16:creationId xmlns:a16="http://schemas.microsoft.com/office/drawing/2014/main" id="{64D9185E-75A5-4109-A7CB-9EC4246AAADA}"/>
+                <a16:creationId xmlns:a16="http://schemas.microsoft.com/office/drawing/2014/main" id="{4F5D05E3-74D2-4972-9E7C-7FE1621BEDFB}"/>
               </a:ext>
             </a:extLst>
           </p:cNvPr>
@@ -11600,7 +11600,7 @@
           <p:cNvPr id="5" name="">
             <a:extLst xmlns:a="http://schemas.openxmlformats.org/drawingml/2006/main">
               <a:ext uri="{FF2B5EF4-FFF2-40B4-BE49-F238E27FC236}">
-                <a16:creationId xmlns:a16="http://schemas.microsoft.com/office/drawing/2014/main" id="{87FB87E3-D24F-4182-A3CD-7525496951E6}"/>
+                <a16:creationId xmlns:a16="http://schemas.microsoft.com/office/drawing/2014/main" id="{C483E6D5-318C-4730-AACF-9E265A16502E}"/>
               </a:ext>
             </a:extLst>
           </p:cNvPr>
@@ -11757,7 +11757,7 @@
           <p:cNvPr id="6" name="">
             <a:extLst xmlns:a="http://schemas.openxmlformats.org/drawingml/2006/main">
               <a:ext uri="{FF2B5EF4-FFF2-40B4-BE49-F238E27FC236}">
-                <a16:creationId xmlns:a16="http://schemas.microsoft.com/office/drawing/2014/main" id="{EBD56FFA-0925-45BA-AC8E-63F458CB2CD0}"/>
+                <a16:creationId xmlns:a16="http://schemas.microsoft.com/office/drawing/2014/main" id="{DA427C46-2567-4279-9302-4ECDD2E40ECF}"/>
               </a:ext>
             </a:extLst>
           </p:cNvPr>
@@ -11788,7 +11788,7 @@
           <p:cNvPr id="7" name="">
             <a:extLst xmlns:a="http://schemas.openxmlformats.org/drawingml/2006/main">
               <a:ext uri="{FF2B5EF4-FFF2-40B4-BE49-F238E27FC236}">
-                <a16:creationId xmlns:a16="http://schemas.microsoft.com/office/drawing/2014/main" id="{7B4F7CCE-0BDF-4F88-9429-56811B2EFDD3}"/>
+                <a16:creationId xmlns:a16="http://schemas.microsoft.com/office/drawing/2014/main" id="{80B8158A-AD99-49E1-B358-9E69AF3E76C5}"/>
               </a:ext>
             </a:extLst>
           </p:cNvPr>
@@ -11968,7 +11968,7 @@
           <p:cNvPr id="8" name="">
             <a:extLst xmlns:a="http://schemas.openxmlformats.org/drawingml/2006/main">
               <a:ext uri="{FF2B5EF4-FFF2-40B4-BE49-F238E27FC236}">
-                <a16:creationId xmlns:a16="http://schemas.microsoft.com/office/drawing/2014/main" id="{2E0F0E32-F138-47D7-AC24-92448B90A950}"/>
+                <a16:creationId xmlns:a16="http://schemas.microsoft.com/office/drawing/2014/main" id="{32BC02A1-4054-484E-B265-9F2DDF81C3EF}"/>
               </a:ext>
             </a:extLst>
           </p:cNvPr>
@@ -12125,7 +12125,7 @@
           <p:cNvPr id="9" name="">
             <a:extLst xmlns:a="http://schemas.openxmlformats.org/drawingml/2006/main">
               <a:ext uri="{FF2B5EF4-FFF2-40B4-BE49-F238E27FC236}">
-                <a16:creationId xmlns:a16="http://schemas.microsoft.com/office/drawing/2014/main" id="{B9C5F17C-103E-455F-9545-4A9DC920C556}"/>
+                <a16:creationId xmlns:a16="http://schemas.microsoft.com/office/drawing/2014/main" id="{4CCDF8CC-58D6-4CF9-AF20-C9D5B8BE8551}"/>
               </a:ext>
             </a:extLst>
           </p:cNvPr>
@@ -12156,7 +12156,7 @@
           <p:cNvPr id="10" name="">
             <a:extLst xmlns:a="http://schemas.openxmlformats.org/drawingml/2006/main">
               <a:ext uri="{FF2B5EF4-FFF2-40B4-BE49-F238E27FC236}">
-                <a16:creationId xmlns:a16="http://schemas.microsoft.com/office/drawing/2014/main" id="{D1441F91-C252-4C54-932A-F179C540B300}"/>
+                <a16:creationId xmlns:a16="http://schemas.microsoft.com/office/drawing/2014/main" id="{CF3AC0FD-9BD8-4E35-BDF4-8B0F79D34794}"/>
               </a:ext>
             </a:extLst>
           </p:cNvPr>
@@ -12336,7 +12336,7 @@
           <p:cNvPr id="11" name="">
             <a:extLst xmlns:a="http://schemas.openxmlformats.org/drawingml/2006/main">
               <a:ext uri="{FF2B5EF4-FFF2-40B4-BE49-F238E27FC236}">
-                <a16:creationId xmlns:a16="http://schemas.microsoft.com/office/drawing/2014/main" id="{CE5B30D0-A015-4000-9961-2E21833629E4}"/>
+                <a16:creationId xmlns:a16="http://schemas.microsoft.com/office/drawing/2014/main" id="{619CBE95-99E1-4874-9CDC-59D8E9D29166}"/>
               </a:ext>
             </a:extLst>
           </p:cNvPr>
@@ -12493,7 +12493,7 @@
           <p:cNvPr id="12" name="">
             <a:extLst xmlns:a="http://schemas.openxmlformats.org/drawingml/2006/main">
               <a:ext uri="{FF2B5EF4-FFF2-40B4-BE49-F238E27FC236}">
-                <a16:creationId xmlns:a16="http://schemas.microsoft.com/office/drawing/2014/main" id="{96D6939C-B087-442A-9198-39BB803646F3}"/>
+                <a16:creationId xmlns:a16="http://schemas.microsoft.com/office/drawing/2014/main" id="{AA9AF423-E9DD-4CB2-8762-05793A9475B8}"/>
               </a:ext>
             </a:extLst>
           </p:cNvPr>
@@ -12524,7 +12524,7 @@
           <p:cNvPr id="13" name="">
             <a:extLst xmlns:a="http://schemas.openxmlformats.org/drawingml/2006/main">
               <a:ext uri="{FF2B5EF4-FFF2-40B4-BE49-F238E27FC236}">
-                <a16:creationId xmlns:a16="http://schemas.microsoft.com/office/drawing/2014/main" id="{95E75C5F-2068-48D5-847C-84DEE00E5E6C}"/>
+                <a16:creationId xmlns:a16="http://schemas.microsoft.com/office/drawing/2014/main" id="{BD4332C4-ECCE-4FC8-8FA5-9AD2AAE0EB32}"/>
               </a:ext>
             </a:extLst>
           </p:cNvPr>
@@ -12704,7 +12704,7 @@
           <p:cNvPr id="14" name="">
             <a:extLst xmlns:a="http://schemas.openxmlformats.org/drawingml/2006/main">
               <a:ext uri="{FF2B5EF4-FFF2-40B4-BE49-F238E27FC236}">
-                <a16:creationId xmlns:a16="http://schemas.microsoft.com/office/drawing/2014/main" id="{40C286B4-AE4A-4D98-BDB1-57FB1CE63C66}"/>
+                <a16:creationId xmlns:a16="http://schemas.microsoft.com/office/drawing/2014/main" id="{4AA6C7CA-15D8-4CE9-A5E9-E7BDE53FAD31}"/>
               </a:ext>
             </a:extLst>
           </p:cNvPr>
@@ -12861,7 +12861,7 @@
           <p:cNvPr id="15" name="">
             <a:extLst xmlns:a="http://schemas.openxmlformats.org/drawingml/2006/main">
               <a:ext uri="{FF2B5EF4-FFF2-40B4-BE49-F238E27FC236}">
-                <a16:creationId xmlns:a16="http://schemas.microsoft.com/office/drawing/2014/main" id="{756ED5F2-61BB-4601-A80B-167D11D939BF}"/>
+                <a16:creationId xmlns:a16="http://schemas.microsoft.com/office/drawing/2014/main" id="{E542199A-CCEA-44AD-B926-9A64B6E041E0}"/>
               </a:ext>
             </a:extLst>
           </p:cNvPr>
@@ -12892,7 +12892,7 @@
           <p:cNvPr id="16" name="">
             <a:extLst xmlns:a="http://schemas.openxmlformats.org/drawingml/2006/main">
               <a:ext uri="{FF2B5EF4-FFF2-40B4-BE49-F238E27FC236}">
-                <a16:creationId xmlns:a16="http://schemas.microsoft.com/office/drawing/2014/main" id="{CF710DBD-CBB7-41A0-8C13-211BAAD4D58C}"/>
+                <a16:creationId xmlns:a16="http://schemas.microsoft.com/office/drawing/2014/main" id="{58F35E30-72FE-4610-B672-74C999BA3316}"/>
               </a:ext>
             </a:extLst>
           </p:cNvPr>
@@ -13072,7 +13072,7 @@
           <p:cNvPr id="17" name="">
             <a:extLst xmlns:a="http://schemas.openxmlformats.org/drawingml/2006/main">
               <a:ext uri="{FF2B5EF4-FFF2-40B4-BE49-F238E27FC236}">
-                <a16:creationId xmlns:a16="http://schemas.microsoft.com/office/drawing/2014/main" id="{B1F0F45E-E159-448F-A0FD-C1D0C5F2F3CA}"/>
+                <a16:creationId xmlns:a16="http://schemas.microsoft.com/office/drawing/2014/main" id="{F8C7B588-DE9A-4C0C-866A-04A2700A7689}"/>
               </a:ext>
             </a:extLst>
           </p:cNvPr>
@@ -13432,7 +13432,7 @@
           <p:cNvPr id="18" name="">
             <a:extLst xmlns:a="http://schemas.openxmlformats.org/drawingml/2006/main">
               <a:ext uri="{FF2B5EF4-FFF2-40B4-BE49-F238E27FC236}">
-                <a16:creationId xmlns:a16="http://schemas.microsoft.com/office/drawing/2014/main" id="{34F7B77F-9092-4417-8BCE-4639C23670FB}"/>
+                <a16:creationId xmlns:a16="http://schemas.microsoft.com/office/drawing/2014/main" id="{67E323D1-4426-438E-B0C8-2DE9D9A65E89}"/>
               </a:ext>
             </a:extLst>
           </p:cNvPr>
@@ -13579,7 +13579,7 @@
                 <a:ea typeface="Arial"/>
                 <a:cs typeface="Arial"/>
               </a:rPr>
-              <a:t>Provisional mapping: confirm names, aliases and actual roles with the team.</a:t>
+              <a:t>Codex log: ~30 h recorded turn time • team roles require confirmation</a:t>
             </a:r>
           </a:p>
         </p:txBody>
@@ -13587,7 +13587,7 @@
     </p:spTree>
     <p:extLst>
       <p:ext uri="{BB962C8B-B14F-4D97-AF65-F5344CB8AC3E}">
-        <p14:creationId xmlns:p14="http://schemas.microsoft.com/office/powerpoint/2010/main" val="1662313214"/>
+        <p14:creationId xmlns:p14="http://schemas.microsoft.com/office/powerpoint/2010/main" val="2092980561"/>
       </p:ext>
     </p:extLst>
   </p:cSld>
@@ -13618,7 +13618,7 @@
           <p:cNvPr id="22" name="">
             <a:extLst xmlns:a="http://schemas.openxmlformats.org/drawingml/2006/main">
               <a:ext uri="{FF2B5EF4-FFF2-40B4-BE49-F238E27FC236}">
-                <a16:creationId xmlns:a16="http://schemas.microsoft.com/office/drawing/2014/main" id="{B5EE24FA-6EA6-4B5C-A439-77276D112C9F}"/>
+                <a16:creationId xmlns:a16="http://schemas.microsoft.com/office/drawing/2014/main" id="{A0F4AC98-B181-4644-9985-418FBE25F861}"/>
               </a:ext>
             </a:extLst>
           </p:cNvPr>
@@ -13775,7 +13775,7 @@
           <p:cNvPr id="2" name="">
             <a:extLst xmlns:a="http://schemas.openxmlformats.org/drawingml/2006/main">
               <a:ext uri="{FF2B5EF4-FFF2-40B4-BE49-F238E27FC236}">
-                <a16:creationId xmlns:a16="http://schemas.microsoft.com/office/drawing/2014/main" id="{F84BB9FF-2691-4699-87A6-7BD5E941DC58}"/>
+                <a16:creationId xmlns:a16="http://schemas.microsoft.com/office/drawing/2014/main" id="{BD79EB18-688B-40BD-A45B-5DA07D387555}"/>
               </a:ext>
             </a:extLst>
           </p:cNvPr>
@@ -13806,7 +13806,7 @@
           <p:cNvPr id="3" name="">
             <a:extLst xmlns:a="http://schemas.openxmlformats.org/drawingml/2006/main">
               <a:ext uri="{FF2B5EF4-FFF2-40B4-BE49-F238E27FC236}">
-                <a16:creationId xmlns:a16="http://schemas.microsoft.com/office/drawing/2014/main" id="{4B987145-342D-416F-B7CD-4074014CE308}"/>
+                <a16:creationId xmlns:a16="http://schemas.microsoft.com/office/drawing/2014/main" id="{A836D5DF-D454-4E29-87AF-3E8912D37AE9}"/>
               </a:ext>
             </a:extLst>
           </p:cNvPr>
@@ -13963,7 +13963,7 @@
           <p:cNvPr id="4" name="">
             <a:extLst xmlns:a="http://schemas.openxmlformats.org/drawingml/2006/main">
               <a:ext uri="{FF2B5EF4-FFF2-40B4-BE49-F238E27FC236}">
-                <a16:creationId xmlns:a16="http://schemas.microsoft.com/office/drawing/2014/main" id="{D7545377-BDDF-4FE1-93E0-09BCA99970C6}"/>
+                <a16:creationId xmlns:a16="http://schemas.microsoft.com/office/drawing/2014/main" id="{F8766D3D-D1EA-4CE0-8FFC-657C9E3AFFF5}"/>
               </a:ext>
             </a:extLst>
           </p:cNvPr>
@@ -13996,7 +13996,7 @@
           <p:cNvPr id="5" name="">
             <a:extLst xmlns:a="http://schemas.openxmlformats.org/drawingml/2006/main">
               <a:ext uri="{FF2B5EF4-FFF2-40B4-BE49-F238E27FC236}">
-                <a16:creationId xmlns:a16="http://schemas.microsoft.com/office/drawing/2014/main" id="{5B160502-C778-4C31-A60A-2658008A30B4}"/>
+                <a16:creationId xmlns:a16="http://schemas.microsoft.com/office/drawing/2014/main" id="{FF22F2DC-CE8B-4A71-8488-9BA0C881C9A6}"/>
               </a:ext>
             </a:extLst>
           </p:cNvPr>
@@ -14153,7 +14153,7 @@
           <p:cNvPr id="6" name="">
             <a:extLst xmlns:a="http://schemas.openxmlformats.org/drawingml/2006/main">
               <a:ext uri="{FF2B5EF4-FFF2-40B4-BE49-F238E27FC236}">
-                <a16:creationId xmlns:a16="http://schemas.microsoft.com/office/drawing/2014/main" id="{539540B7-BB19-46B6-9A55-5972EDC2AFBF}"/>
+                <a16:creationId xmlns:a16="http://schemas.microsoft.com/office/drawing/2014/main" id="{60862B03-DF5E-4B88-BD78-072DDA3CB3F7}"/>
               </a:ext>
             </a:extLst>
           </p:cNvPr>
@@ -14333,7 +14333,7 @@
           <p:cNvPr id="7" name="">
             <a:extLst xmlns:a="http://schemas.openxmlformats.org/drawingml/2006/main">
               <a:ext uri="{FF2B5EF4-FFF2-40B4-BE49-F238E27FC236}">
-                <a16:creationId xmlns:a16="http://schemas.microsoft.com/office/drawing/2014/main" id="{3909002E-47C1-4E62-B969-DB3EBDF7D467}"/>
+                <a16:creationId xmlns:a16="http://schemas.microsoft.com/office/drawing/2014/main" id="{7A784247-8B31-4228-AEF2-73994DF6EEC5}"/>
               </a:ext>
             </a:extLst>
           </p:cNvPr>
@@ -14364,7 +14364,7 @@
           <p:cNvPr id="8" name="">
             <a:extLst xmlns:a="http://schemas.openxmlformats.org/drawingml/2006/main">
               <a:ext uri="{FF2B5EF4-FFF2-40B4-BE49-F238E27FC236}">
-                <a16:creationId xmlns:a16="http://schemas.microsoft.com/office/drawing/2014/main" id="{04AC0C21-DEE5-4ABA-8216-40B7770366ED}"/>
+                <a16:creationId xmlns:a16="http://schemas.microsoft.com/office/drawing/2014/main" id="{C5D5322A-856B-4819-A6F4-EF33B11E3D4D}"/>
               </a:ext>
             </a:extLst>
           </p:cNvPr>
@@ -14397,7 +14397,7 @@
           <p:cNvPr id="9" name="">
             <a:extLst xmlns:a="http://schemas.openxmlformats.org/drawingml/2006/main">
               <a:ext uri="{FF2B5EF4-FFF2-40B4-BE49-F238E27FC236}">
-                <a16:creationId xmlns:a16="http://schemas.microsoft.com/office/drawing/2014/main" id="{498C1D4F-7241-4F9B-A6B2-3004620C741F}"/>
+                <a16:creationId xmlns:a16="http://schemas.microsoft.com/office/drawing/2014/main" id="{41184450-331D-4EBB-B00E-48F30F4E19BF}"/>
               </a:ext>
             </a:extLst>
           </p:cNvPr>
@@ -14554,7 +14554,7 @@
           <p:cNvPr id="10" name="">
             <a:extLst xmlns:a="http://schemas.openxmlformats.org/drawingml/2006/main">
               <a:ext uri="{FF2B5EF4-FFF2-40B4-BE49-F238E27FC236}">
-                <a16:creationId xmlns:a16="http://schemas.microsoft.com/office/drawing/2014/main" id="{0CA7BCF6-BB8B-4B80-850E-C58600A79F75}"/>
+                <a16:creationId xmlns:a16="http://schemas.microsoft.com/office/drawing/2014/main" id="{4240EF93-D41E-4217-B010-39B15BD871F9}"/>
               </a:ext>
             </a:extLst>
           </p:cNvPr>
@@ -14734,7 +14734,7 @@
           <p:cNvPr id="11" name="">
             <a:extLst xmlns:a="http://schemas.openxmlformats.org/drawingml/2006/main">
               <a:ext uri="{FF2B5EF4-FFF2-40B4-BE49-F238E27FC236}">
-                <a16:creationId xmlns:a16="http://schemas.microsoft.com/office/drawing/2014/main" id="{B96DA4C7-FAA5-4149-9396-4E7D73D88639}"/>
+                <a16:creationId xmlns:a16="http://schemas.microsoft.com/office/drawing/2014/main" id="{4A1EDC14-D4FA-4F23-8D20-DD1A38005D94}"/>
               </a:ext>
             </a:extLst>
           </p:cNvPr>
@@ -14765,7 +14765,7 @@
           <p:cNvPr id="12" name="">
             <a:extLst xmlns:a="http://schemas.openxmlformats.org/drawingml/2006/main">
               <a:ext uri="{FF2B5EF4-FFF2-40B4-BE49-F238E27FC236}">
-                <a16:creationId xmlns:a16="http://schemas.microsoft.com/office/drawing/2014/main" id="{90BCEEDA-D8AF-4255-A0B3-05979C4D92F8}"/>
+                <a16:creationId xmlns:a16="http://schemas.microsoft.com/office/drawing/2014/main" id="{01A96238-9C62-498A-BDB1-E7F4D9793806}"/>
               </a:ext>
             </a:extLst>
           </p:cNvPr>
@@ -14798,7 +14798,7 @@
           <p:cNvPr id="13" name="">
             <a:extLst xmlns:a="http://schemas.openxmlformats.org/drawingml/2006/main">
               <a:ext uri="{FF2B5EF4-FFF2-40B4-BE49-F238E27FC236}">
-                <a16:creationId xmlns:a16="http://schemas.microsoft.com/office/drawing/2014/main" id="{6955F987-C78C-497D-94BB-0EC504AE621B}"/>
+                <a16:creationId xmlns:a16="http://schemas.microsoft.com/office/drawing/2014/main" id="{A69D478A-1DD9-4F3F-AD16-F13E35FDA344}"/>
               </a:ext>
             </a:extLst>
           </p:cNvPr>
@@ -14955,7 +14955,7 @@
           <p:cNvPr id="14" name="">
             <a:extLst xmlns:a="http://schemas.openxmlformats.org/drawingml/2006/main">
               <a:ext uri="{FF2B5EF4-FFF2-40B4-BE49-F238E27FC236}">
-                <a16:creationId xmlns:a16="http://schemas.microsoft.com/office/drawing/2014/main" id="{DDF0CEC0-EDA1-4AEC-B44E-22E4C3596E40}"/>
+                <a16:creationId xmlns:a16="http://schemas.microsoft.com/office/drawing/2014/main" id="{5A7C852C-F5C1-40E6-B199-F13945DE264A}"/>
               </a:ext>
             </a:extLst>
           </p:cNvPr>
@@ -15135,7 +15135,7 @@
           <p:cNvPr id="15" name="">
             <a:extLst xmlns:a="http://schemas.openxmlformats.org/drawingml/2006/main">
               <a:ext uri="{FF2B5EF4-FFF2-40B4-BE49-F238E27FC236}">
-                <a16:creationId xmlns:a16="http://schemas.microsoft.com/office/drawing/2014/main" id="{D2266843-9F5B-4144-A45F-4ADFC57A8BB0}"/>
+                <a16:creationId xmlns:a16="http://schemas.microsoft.com/office/drawing/2014/main" id="{C8B6CBCB-3E84-4192-B500-989F9008ECB5}"/>
               </a:ext>
             </a:extLst>
           </p:cNvPr>
@@ -15166,7 +15166,7 @@
           <p:cNvPr id="16" name="">
             <a:extLst xmlns:a="http://schemas.openxmlformats.org/drawingml/2006/main">
               <a:ext uri="{FF2B5EF4-FFF2-40B4-BE49-F238E27FC236}">
-                <a16:creationId xmlns:a16="http://schemas.microsoft.com/office/drawing/2014/main" id="{D6EF9C6B-F9BA-4179-B450-2A5E39FC4096}"/>
+                <a16:creationId xmlns:a16="http://schemas.microsoft.com/office/drawing/2014/main" id="{57146C53-ADE4-48F5-82E7-090F75DDC51C}"/>
               </a:ext>
             </a:extLst>
           </p:cNvPr>
@@ -15199,7 +15199,7 @@
           <p:cNvPr id="17" name="">
             <a:extLst xmlns:a="http://schemas.openxmlformats.org/drawingml/2006/main">
               <a:ext uri="{FF2B5EF4-FFF2-40B4-BE49-F238E27FC236}">
-                <a16:creationId xmlns:a16="http://schemas.microsoft.com/office/drawing/2014/main" id="{9708D311-1397-4018-9790-1C1B95B42BA4}"/>
+                <a16:creationId xmlns:a16="http://schemas.microsoft.com/office/drawing/2014/main" id="{F5B4E776-E533-430C-A8AA-F7A650DCD209}"/>
               </a:ext>
             </a:extLst>
           </p:cNvPr>
@@ -15356,7 +15356,7 @@
           <p:cNvPr id="18" name="">
             <a:extLst xmlns:a="http://schemas.openxmlformats.org/drawingml/2006/main">
               <a:ext uri="{FF2B5EF4-FFF2-40B4-BE49-F238E27FC236}">
-                <a16:creationId xmlns:a16="http://schemas.microsoft.com/office/drawing/2014/main" id="{DAD1F3ED-7251-4B05-825E-3122A500B8A0}"/>
+                <a16:creationId xmlns:a16="http://schemas.microsoft.com/office/drawing/2014/main" id="{929476D8-8B68-4585-B5F5-00CEA26FD167}"/>
               </a:ext>
             </a:extLst>
           </p:cNvPr>
@@ -15536,7 +15536,7 @@
           <p:cNvPr id="19" name="">
             <a:extLst xmlns:a="http://schemas.openxmlformats.org/drawingml/2006/main">
               <a:ext uri="{FF2B5EF4-FFF2-40B4-BE49-F238E27FC236}">
-                <a16:creationId xmlns:a16="http://schemas.microsoft.com/office/drawing/2014/main" id="{D1EF1FC4-2519-45D4-BEAC-CA25A91F8915}"/>
+                <a16:creationId xmlns:a16="http://schemas.microsoft.com/office/drawing/2014/main" id="{EB4DFEA1-C5B7-429E-BAD2-50194A41B4F1}"/>
               </a:ext>
             </a:extLst>
           </p:cNvPr>
@@ -15683,7 +15683,7 @@
                 <a:ea typeface="Arial"/>
                 <a:cs typeface="Arial"/>
               </a:rPr>
-              <a:t>Baseline cycles ÷ modified-program cycles = measured cycle speedup</a:t>
+              <a:t>CRC32 reference: 32.39M cycles → 30.82M cycles = 1.051×</a:t>
             </a:r>
           </a:p>
         </p:txBody>
@@ -15693,7 +15693,7 @@
           <p:cNvPr id="20" name="">
             <a:extLst xmlns:a="http://schemas.openxmlformats.org/drawingml/2006/main">
               <a:ext uri="{FF2B5EF4-FFF2-40B4-BE49-F238E27FC236}">
-                <a16:creationId xmlns:a16="http://schemas.microsoft.com/office/drawing/2014/main" id="{B7791546-019F-4B26-81E5-F3DCA53FC28B}"/>
+                <a16:creationId xmlns:a16="http://schemas.microsoft.com/office/drawing/2014/main" id="{662E959C-8B70-4B23-81DB-0B1F5AD1DEC8}"/>
               </a:ext>
             </a:extLst>
           </p:cNvPr>
@@ -15840,7 +15840,7 @@
                 <a:ea typeface="Arial"/>
                 <a:cs typeface="Arial"/>
               </a:rPr>
-              <a:t>Correctness gate  +  area budget  +  timing floor</a:t>
+              <a:t>Unmodified program/core → compare cycles → verify area and timing</a:t>
             </a:r>
           </a:p>
         </p:txBody>
@@ -15850,7 +15850,7 @@
           <p:cNvPr id="21" name="">
             <a:extLst xmlns:a="http://schemas.openxmlformats.org/drawingml/2006/main">
               <a:ext uri="{FF2B5EF4-FFF2-40B4-BE49-F238E27FC236}">
-                <a16:creationId xmlns:a16="http://schemas.microsoft.com/office/drawing/2014/main" id="{755F0AEC-A0B7-4431-BAB1-9E4BE1BEDA2A}"/>
+                <a16:creationId xmlns:a16="http://schemas.microsoft.com/office/drawing/2014/main" id="{11763B63-889F-4075-81EE-D698589D1475}"/>
               </a:ext>
             </a:extLst>
           </p:cNvPr>
@@ -16005,7 +16005,7 @@
     </p:spTree>
     <p:extLst>
       <p:ext uri="{BB962C8B-B14F-4D97-AF65-F5344CB8AC3E}">
-        <p14:creationId xmlns:p14="http://schemas.microsoft.com/office/powerpoint/2010/main" val="1784125536"/>
+        <p14:creationId xmlns:p14="http://schemas.microsoft.com/office/powerpoint/2010/main" val="1324647877"/>
       </p:ext>
     </p:extLst>
   </p:cSld>
@@ -16036,7 +16036,7 @@
           <p:cNvPr id="10" name="">
             <a:extLst xmlns:a="http://schemas.openxmlformats.org/drawingml/2006/main">
               <a:ext uri="{FF2B5EF4-FFF2-40B4-BE49-F238E27FC236}">
-                <a16:creationId xmlns:a16="http://schemas.microsoft.com/office/drawing/2014/main" id="{81A326DA-1516-4408-9BA5-5BD3A9F28355}"/>
+                <a16:creationId xmlns:a16="http://schemas.microsoft.com/office/drawing/2014/main" id="{112D0CE9-2F77-4A63-BBF2-FB4E983DC6D7}"/>
               </a:ext>
             </a:extLst>
           </p:cNvPr>
@@ -16193,7 +16193,7 @@
           <p:cNvPr id="2" name="">
             <a:extLst xmlns:a="http://schemas.openxmlformats.org/drawingml/2006/main">
               <a:ext uri="{FF2B5EF4-FFF2-40B4-BE49-F238E27FC236}">
-                <a16:creationId xmlns:a16="http://schemas.microsoft.com/office/drawing/2014/main" id="{36A77FF4-7B39-4F39-9D30-9DA9AC5A83A1}"/>
+                <a16:creationId xmlns:a16="http://schemas.microsoft.com/office/drawing/2014/main" id="{FB597A00-3AEF-4E91-967D-A448489D5A40}"/>
               </a:ext>
             </a:extLst>
           </p:cNvPr>
@@ -16224,7 +16224,7 @@
           <p:cNvPr id="3" name="">
             <a:extLst xmlns:a="http://schemas.openxmlformats.org/drawingml/2006/main">
               <a:ext uri="{FF2B5EF4-FFF2-40B4-BE49-F238E27FC236}">
-                <a16:creationId xmlns:a16="http://schemas.microsoft.com/office/drawing/2014/main" id="{651CEC9E-60DF-4363-860E-1D0E0CF81DD2}"/>
+                <a16:creationId xmlns:a16="http://schemas.microsoft.com/office/drawing/2014/main" id="{60E8029B-F82C-4F79-B772-9BFF718E06E7}"/>
               </a:ext>
             </a:extLst>
           </p:cNvPr>
@@ -16381,7 +16381,7 @@
           <p:cNvPr id="4" name="Chart">
             <a:extLst xmlns:a="http://schemas.openxmlformats.org/drawingml/2006/main">
               <a:ext uri="{FF2B5EF4-FFF2-40B4-BE49-F238E27FC236}">
-                <a16:creationId xmlns:a16="http://schemas.microsoft.com/office/drawing/2014/main" id="{FCE94BD7-2237-4571-87DA-A269A86DFEB1}"/>
+                <a16:creationId xmlns:a16="http://schemas.microsoft.com/office/drawing/2014/main" id="{17AE3EC1-4761-4D3C-AD6F-CE9522F1E067}"/>
               </a:ext>
             </a:extLst>
           </p:cNvPr>
@@ -16394,7 +16394,7 @@
         </p:xfrm>
         <a:graphic xmlns:a="http://schemas.openxmlformats.org/drawingml/2006/main">
           <a:graphicData uri="http://schemas.openxmlformats.org/drawingml/2006/chart">
-            <c:chart xmlns:r="http://schemas.openxmlformats.org/officeDocument/2006/relationships" xmlns:c="http://schemas.openxmlformats.org/drawingml/2006/chart" r:id="R4e3966aeec614d91"/>
+            <c:chart xmlns:r="http://schemas.openxmlformats.org/officeDocument/2006/relationships" xmlns:c="http://schemas.openxmlformats.org/drawingml/2006/chart" r:id="Rb2dca3f24be5415f"/>
           </a:graphicData>
         </a:graphic>
       </p:graphicFrame>
@@ -16403,7 +16403,7 @@
           <p:cNvPr id="5" name="">
             <a:extLst xmlns:a="http://schemas.openxmlformats.org/drawingml/2006/main">
               <a:ext uri="{FF2B5EF4-FFF2-40B4-BE49-F238E27FC236}">
-                <a16:creationId xmlns:a16="http://schemas.microsoft.com/office/drawing/2014/main" id="{23DC15C1-9D26-42FC-8578-A78D77610B4B}"/>
+                <a16:creationId xmlns:a16="http://schemas.microsoft.com/office/drawing/2014/main" id="{B3129264-B0CE-4AB3-9323-4B1BC13112A3}"/>
               </a:ext>
             </a:extLst>
           </p:cNvPr>
@@ -16560,7 +16560,7 @@
           <p:cNvPr id="6" name="">
             <a:extLst xmlns:a="http://schemas.openxmlformats.org/drawingml/2006/main">
               <a:ext uri="{FF2B5EF4-FFF2-40B4-BE49-F238E27FC236}">
-                <a16:creationId xmlns:a16="http://schemas.microsoft.com/office/drawing/2014/main" id="{7C406252-9106-4DF1-A02E-9D693FD5A316}"/>
+                <a16:creationId xmlns:a16="http://schemas.microsoft.com/office/drawing/2014/main" id="{BF2C48E2-C19B-483E-B1D7-BB9E1883E4FC}"/>
               </a:ext>
             </a:extLst>
           </p:cNvPr>
@@ -16740,7 +16740,7 @@
           <p:cNvPr id="7" name="">
             <a:extLst xmlns:a="http://schemas.openxmlformats.org/drawingml/2006/main">
               <a:ext uri="{FF2B5EF4-FFF2-40B4-BE49-F238E27FC236}">
-                <a16:creationId xmlns:a16="http://schemas.microsoft.com/office/drawing/2014/main" id="{C886DE2B-366A-4302-BB5A-69C350EA3220}"/>
+                <a16:creationId xmlns:a16="http://schemas.microsoft.com/office/drawing/2014/main" id="{33B5E46F-8EE6-489B-857A-397FF71E54DE}"/>
               </a:ext>
             </a:extLst>
           </p:cNvPr>
@@ -16897,7 +16897,7 @@
           <p:cNvPr id="8" name="">
             <a:extLst xmlns:a="http://schemas.openxmlformats.org/drawingml/2006/main">
               <a:ext uri="{FF2B5EF4-FFF2-40B4-BE49-F238E27FC236}">
-                <a16:creationId xmlns:a16="http://schemas.microsoft.com/office/drawing/2014/main" id="{A2D9A15E-969A-4F50-8B77-925FB6280C47}"/>
+                <a16:creationId xmlns:a16="http://schemas.microsoft.com/office/drawing/2014/main" id="{8DF6D36F-95BF-4954-9531-1F5C26ED34CA}"/>
               </a:ext>
             </a:extLst>
           </p:cNvPr>
@@ -17044,7 +17044,7 @@
                 <a:ea typeface="Arial"/>
                 <a:cs typeface="Arial"/>
               </a:rPr>
-              <a:t>+ 3 later Ascon labels</a:t>
+              <a:t>13 policies tested: 8 learned</a:t>
             </a:r>
           </a:p>
           <a:p xmlns:a="http://schemas.openxmlformats.org/drawingml/2006/main">
@@ -17067,7 +17067,7 @@
                 <a:ea typeface="Arial"/>
                 <a:cs typeface="Arial"/>
               </a:rPr>
-              <a:t>reported separately</a:t>
+              <a:t>2,925 replays reuse labels</a:t>
             </a:r>
           </a:p>
         </p:txBody>
@@ -17077,7 +17077,7 @@
           <p:cNvPr id="9" name="">
             <a:extLst xmlns:a="http://schemas.openxmlformats.org/drawingml/2006/main">
               <a:ext uri="{FF2B5EF4-FFF2-40B4-BE49-F238E27FC236}">
-                <a16:creationId xmlns:a16="http://schemas.microsoft.com/office/drawing/2014/main" id="{94FA8C0B-E468-484C-B671-A9913E0B2B72}"/>
+                <a16:creationId xmlns:a16="http://schemas.microsoft.com/office/drawing/2014/main" id="{1D30E425-C167-4029-AD3A-56ADA1DF2D11}"/>
               </a:ext>
             </a:extLst>
           </p:cNvPr>
@@ -17232,7 +17232,7 @@
     </p:spTree>
     <p:extLst>
       <p:ext uri="{BB962C8B-B14F-4D97-AF65-F5344CB8AC3E}">
-        <p14:creationId xmlns:p14="http://schemas.microsoft.com/office/powerpoint/2010/main" val="312202807"/>
+        <p14:creationId xmlns:p14="http://schemas.microsoft.com/office/powerpoint/2010/main" val="1055109145"/>
       </p:ext>
     </p:extLst>
   </p:cSld>
@@ -17263,7 +17263,7 @@
           <p:cNvPr id="22" name="">
             <a:extLst xmlns:a="http://schemas.openxmlformats.org/drawingml/2006/main">
               <a:ext uri="{FF2B5EF4-FFF2-40B4-BE49-F238E27FC236}">
-                <a16:creationId xmlns:a16="http://schemas.microsoft.com/office/drawing/2014/main" id="{1D3A8ED8-7307-4B92-8CC2-B01F9E2475D8}"/>
+                <a16:creationId xmlns:a16="http://schemas.microsoft.com/office/drawing/2014/main" id="{B736AE88-45D9-4980-9DCC-49B2C06AA606}"/>
               </a:ext>
             </a:extLst>
           </p:cNvPr>
@@ -17420,7 +17420,7 @@
           <p:cNvPr id="2" name="">
             <a:extLst xmlns:a="http://schemas.openxmlformats.org/drawingml/2006/main">
               <a:ext uri="{FF2B5EF4-FFF2-40B4-BE49-F238E27FC236}">
-                <a16:creationId xmlns:a16="http://schemas.microsoft.com/office/drawing/2014/main" id="{993DA2BB-2E2B-453A-994B-AF057E2C8CDB}"/>
+                <a16:creationId xmlns:a16="http://schemas.microsoft.com/office/drawing/2014/main" id="{5190EAEB-D83E-467A-8DF1-712DF83FA5E2}"/>
               </a:ext>
             </a:extLst>
           </p:cNvPr>
@@ -17451,7 +17451,7 @@
           <p:cNvPr id="3" name="">
             <a:extLst xmlns:a="http://schemas.openxmlformats.org/drawingml/2006/main">
               <a:ext uri="{FF2B5EF4-FFF2-40B4-BE49-F238E27FC236}">
-                <a16:creationId xmlns:a16="http://schemas.microsoft.com/office/drawing/2014/main" id="{D098751D-D1FB-4739-9BC6-0C668DFC0EB2}"/>
+                <a16:creationId xmlns:a16="http://schemas.microsoft.com/office/drawing/2014/main" id="{DDFC7417-4DC4-4318-9212-57F4CD28EA37}"/>
               </a:ext>
             </a:extLst>
           </p:cNvPr>
@@ -17608,7 +17608,7 @@
           <p:cNvPr id="4" name="">
             <a:extLst xmlns:a="http://schemas.openxmlformats.org/drawingml/2006/main">
               <a:ext uri="{FF2B5EF4-FFF2-40B4-BE49-F238E27FC236}">
-                <a16:creationId xmlns:a16="http://schemas.microsoft.com/office/drawing/2014/main" id="{9D47F864-29B4-4A09-B61D-EFF900ED956F}"/>
+                <a16:creationId xmlns:a16="http://schemas.microsoft.com/office/drawing/2014/main" id="{9E56627B-9409-4117-A352-DE8BB95C32B3}"/>
               </a:ext>
             </a:extLst>
           </p:cNvPr>
@@ -17641,7 +17641,7 @@
           <p:cNvPr id="5" name="">
             <a:extLst xmlns:a="http://schemas.openxmlformats.org/drawingml/2006/main">
               <a:ext uri="{FF2B5EF4-FFF2-40B4-BE49-F238E27FC236}">
-                <a16:creationId xmlns:a16="http://schemas.microsoft.com/office/drawing/2014/main" id="{F7588889-0387-483A-AFC9-6BA0E5785BB9}"/>
+                <a16:creationId xmlns:a16="http://schemas.microsoft.com/office/drawing/2014/main" id="{78BDD98A-1067-4817-996E-57CBFB345539}"/>
               </a:ext>
             </a:extLst>
           </p:cNvPr>
@@ -17798,7 +17798,7 @@
           <p:cNvPr id="6" name="">
             <a:extLst xmlns:a="http://schemas.openxmlformats.org/drawingml/2006/main">
               <a:ext uri="{FF2B5EF4-FFF2-40B4-BE49-F238E27FC236}">
-                <a16:creationId xmlns:a16="http://schemas.microsoft.com/office/drawing/2014/main" id="{27EF0F19-40BC-4A8C-B33F-EF3EEDCC0377}"/>
+                <a16:creationId xmlns:a16="http://schemas.microsoft.com/office/drawing/2014/main" id="{4D0D6C7E-C166-4A1D-9FED-778140134E79}"/>
               </a:ext>
             </a:extLst>
           </p:cNvPr>
@@ -17978,7 +17978,7 @@
           <p:cNvPr id="7" name="">
             <a:extLst xmlns:a="http://schemas.openxmlformats.org/drawingml/2006/main">
               <a:ext uri="{FF2B5EF4-FFF2-40B4-BE49-F238E27FC236}">
-                <a16:creationId xmlns:a16="http://schemas.microsoft.com/office/drawing/2014/main" id="{DA76F496-8EF9-408D-905F-B8B6DAF930D0}"/>
+                <a16:creationId xmlns:a16="http://schemas.microsoft.com/office/drawing/2014/main" id="{0C744642-C05C-4C9F-9D70-25BC0526E026}"/>
               </a:ext>
             </a:extLst>
           </p:cNvPr>
@@ -18009,7 +18009,7 @@
           <p:cNvPr id="8" name="">
             <a:extLst xmlns:a="http://schemas.openxmlformats.org/drawingml/2006/main">
               <a:ext uri="{FF2B5EF4-FFF2-40B4-BE49-F238E27FC236}">
-                <a16:creationId xmlns:a16="http://schemas.microsoft.com/office/drawing/2014/main" id="{5D6DB61C-2986-4AAB-A307-5F5DA974B3AE}"/>
+                <a16:creationId xmlns:a16="http://schemas.microsoft.com/office/drawing/2014/main" id="{AFA992FA-7AF5-46B4-AFD5-7C293E0E70F8}"/>
               </a:ext>
             </a:extLst>
           </p:cNvPr>
@@ -18042,7 +18042,7 @@
           <p:cNvPr id="9" name="">
             <a:extLst xmlns:a="http://schemas.openxmlformats.org/drawingml/2006/main">
               <a:ext uri="{FF2B5EF4-FFF2-40B4-BE49-F238E27FC236}">
-                <a16:creationId xmlns:a16="http://schemas.microsoft.com/office/drawing/2014/main" id="{CB696833-B501-445D-927F-9DEE410F8227}"/>
+                <a16:creationId xmlns:a16="http://schemas.microsoft.com/office/drawing/2014/main" id="{DFA7F33F-2E66-48F1-81F0-1EE9BF01F50C}"/>
               </a:ext>
             </a:extLst>
           </p:cNvPr>
@@ -18199,7 +18199,7 @@
           <p:cNvPr id="10" name="">
             <a:extLst xmlns:a="http://schemas.openxmlformats.org/drawingml/2006/main">
               <a:ext uri="{FF2B5EF4-FFF2-40B4-BE49-F238E27FC236}">
-                <a16:creationId xmlns:a16="http://schemas.microsoft.com/office/drawing/2014/main" id="{3A9A66B2-22AA-45DE-BCDD-16227E76F31B}"/>
+                <a16:creationId xmlns:a16="http://schemas.microsoft.com/office/drawing/2014/main" id="{FDC2B308-059E-4ECB-A8D7-057194A968EF}"/>
               </a:ext>
             </a:extLst>
           </p:cNvPr>
@@ -18379,7 +18379,7 @@
           <p:cNvPr id="11" name="">
             <a:extLst xmlns:a="http://schemas.openxmlformats.org/drawingml/2006/main">
               <a:ext uri="{FF2B5EF4-FFF2-40B4-BE49-F238E27FC236}">
-                <a16:creationId xmlns:a16="http://schemas.microsoft.com/office/drawing/2014/main" id="{CE857FAB-24AA-4294-A2DF-1CF6951EC850}"/>
+                <a16:creationId xmlns:a16="http://schemas.microsoft.com/office/drawing/2014/main" id="{9978F779-A425-4060-93E8-E9027F619FCE}"/>
               </a:ext>
             </a:extLst>
           </p:cNvPr>
@@ -18410,7 +18410,7 @@
           <p:cNvPr id="12" name="">
             <a:extLst xmlns:a="http://schemas.openxmlformats.org/drawingml/2006/main">
               <a:ext uri="{FF2B5EF4-FFF2-40B4-BE49-F238E27FC236}">
-                <a16:creationId xmlns:a16="http://schemas.microsoft.com/office/drawing/2014/main" id="{399BCC75-704C-4990-9EE7-B1B5CA47A438}"/>
+                <a16:creationId xmlns:a16="http://schemas.microsoft.com/office/drawing/2014/main" id="{05651402-66B4-435E-9E99-435C5FFA36FE}"/>
               </a:ext>
             </a:extLst>
           </p:cNvPr>
@@ -18443,7 +18443,7 @@
           <p:cNvPr id="13" name="">
             <a:extLst xmlns:a="http://schemas.openxmlformats.org/drawingml/2006/main">
               <a:ext uri="{FF2B5EF4-FFF2-40B4-BE49-F238E27FC236}">
-                <a16:creationId xmlns:a16="http://schemas.microsoft.com/office/drawing/2014/main" id="{D18D3F5D-1800-4D60-A8DA-480DACBBDB12}"/>
+                <a16:creationId xmlns:a16="http://schemas.microsoft.com/office/drawing/2014/main" id="{9E83A5B3-A7BE-4ABF-A423-E6927701D035}"/>
               </a:ext>
             </a:extLst>
           </p:cNvPr>
@@ -18600,7 +18600,7 @@
           <p:cNvPr id="14" name="">
             <a:extLst xmlns:a="http://schemas.openxmlformats.org/drawingml/2006/main">
               <a:ext uri="{FF2B5EF4-FFF2-40B4-BE49-F238E27FC236}">
-                <a16:creationId xmlns:a16="http://schemas.microsoft.com/office/drawing/2014/main" id="{B1C056A1-BB3A-4A88-BB49-1F8A42A9C907}"/>
+                <a16:creationId xmlns:a16="http://schemas.microsoft.com/office/drawing/2014/main" id="{4415A495-5A8C-4083-8C23-8F3E06BA8279}"/>
               </a:ext>
             </a:extLst>
           </p:cNvPr>
@@ -18780,7 +18780,7 @@
           <p:cNvPr id="15" name="">
             <a:extLst xmlns:a="http://schemas.openxmlformats.org/drawingml/2006/main">
               <a:ext uri="{FF2B5EF4-FFF2-40B4-BE49-F238E27FC236}">
-                <a16:creationId xmlns:a16="http://schemas.microsoft.com/office/drawing/2014/main" id="{BD3F71A3-CF8C-451B-8C30-704AEDB058C6}"/>
+                <a16:creationId xmlns:a16="http://schemas.microsoft.com/office/drawing/2014/main" id="{AAB609EB-112B-47A3-ADE0-F038F9B62301}"/>
               </a:ext>
             </a:extLst>
           </p:cNvPr>
@@ -18811,7 +18811,7 @@
           <p:cNvPr id="16" name="">
             <a:extLst xmlns:a="http://schemas.openxmlformats.org/drawingml/2006/main">
               <a:ext uri="{FF2B5EF4-FFF2-40B4-BE49-F238E27FC236}">
-                <a16:creationId xmlns:a16="http://schemas.microsoft.com/office/drawing/2014/main" id="{ACBC1220-5C40-4AAA-A899-9663093344E6}"/>
+                <a16:creationId xmlns:a16="http://schemas.microsoft.com/office/drawing/2014/main" id="{73C45C3C-B3F9-4F89-957F-D3C83B1AEA1F}"/>
               </a:ext>
             </a:extLst>
           </p:cNvPr>
@@ -18844,7 +18844,7 @@
           <p:cNvPr id="17" name="">
             <a:extLst xmlns:a="http://schemas.openxmlformats.org/drawingml/2006/main">
               <a:ext uri="{FF2B5EF4-FFF2-40B4-BE49-F238E27FC236}">
-                <a16:creationId xmlns:a16="http://schemas.microsoft.com/office/drawing/2014/main" id="{7CD99551-FE06-47A3-AF9E-B52144EE5107}"/>
+                <a16:creationId xmlns:a16="http://schemas.microsoft.com/office/drawing/2014/main" id="{81E0C2F6-729C-445D-B20D-D457A60AC515}"/>
               </a:ext>
             </a:extLst>
           </p:cNvPr>
@@ -19001,7 +19001,7 @@
           <p:cNvPr id="18" name="">
             <a:extLst xmlns:a="http://schemas.openxmlformats.org/drawingml/2006/main">
               <a:ext uri="{FF2B5EF4-FFF2-40B4-BE49-F238E27FC236}">
-                <a16:creationId xmlns:a16="http://schemas.microsoft.com/office/drawing/2014/main" id="{CBC6B0C0-5963-4609-B541-1EFE1C53CB36}"/>
+                <a16:creationId xmlns:a16="http://schemas.microsoft.com/office/drawing/2014/main" id="{98AD64AC-6E5F-4CA1-8C42-AB4D7D635C90}"/>
               </a:ext>
             </a:extLst>
           </p:cNvPr>
@@ -19181,7 +19181,7 @@
           <p:cNvPr id="19" name="">
             <a:extLst xmlns:a="http://schemas.openxmlformats.org/drawingml/2006/main">
               <a:ext uri="{FF2B5EF4-FFF2-40B4-BE49-F238E27FC236}">
-                <a16:creationId xmlns:a16="http://schemas.microsoft.com/office/drawing/2014/main" id="{4AF424CE-3F70-4875-A388-AAF84519EEC5}"/>
+                <a16:creationId xmlns:a16="http://schemas.microsoft.com/office/drawing/2014/main" id="{23086F94-4D51-479D-8AAC-E631BBE72305}"/>
               </a:ext>
             </a:extLst>
           </p:cNvPr>
@@ -19338,7 +19338,7 @@
           <p:cNvPr id="20" name="">
             <a:extLst xmlns:a="http://schemas.openxmlformats.org/drawingml/2006/main">
               <a:ext uri="{FF2B5EF4-FFF2-40B4-BE49-F238E27FC236}">
-                <a16:creationId xmlns:a16="http://schemas.microsoft.com/office/drawing/2014/main" id="{2970C9AF-5B8A-4238-BC2A-DB8945FFD4A3}"/>
+                <a16:creationId xmlns:a16="http://schemas.microsoft.com/office/drawing/2014/main" id="{2FFB0B97-7A02-45DE-BC1C-1FEED96D51B3}"/>
               </a:ext>
             </a:extLst>
           </p:cNvPr>
@@ -19495,7 +19495,7 @@
           <p:cNvPr id="21" name="">
             <a:extLst xmlns:a="http://schemas.openxmlformats.org/drawingml/2006/main">
               <a:ext uri="{FF2B5EF4-FFF2-40B4-BE49-F238E27FC236}">
-                <a16:creationId xmlns:a16="http://schemas.microsoft.com/office/drawing/2014/main" id="{3E387C5A-49FC-4111-BDA9-5729B47F106B}"/>
+                <a16:creationId xmlns:a16="http://schemas.microsoft.com/office/drawing/2014/main" id="{DB4B32D3-6155-4018-9286-C3765ED92A3A}"/>
               </a:ext>
             </a:extLst>
           </p:cNvPr>
@@ -19642,7 +19642,7 @@
                 <a:ea typeface="Arial"/>
                 <a:cs typeface="Arial"/>
               </a:rPr>
-              <a:t>Whole-workload holdouts + related-expression exclusions prevent easy leakage.</a:t>
+              <a:t>Also tested: regression, feasibility models and GP active learning.</a:t>
             </a:r>
           </a:p>
         </p:txBody>
@@ -19650,7 +19650,7 @@
     </p:spTree>
     <p:extLst>
       <p:ext uri="{BB962C8B-B14F-4D97-AF65-F5344CB8AC3E}">
-        <p14:creationId xmlns:p14="http://schemas.microsoft.com/office/powerpoint/2010/main" val="1292607082"/>
+        <p14:creationId xmlns:p14="http://schemas.microsoft.com/office/powerpoint/2010/main" val="1853977148"/>
       </p:ext>
     </p:extLst>
   </p:cSld>
@@ -19681,7 +19681,7 @@
           <p:cNvPr id="9" name="">
             <a:extLst xmlns:a="http://schemas.openxmlformats.org/drawingml/2006/main">
               <a:ext uri="{FF2B5EF4-FFF2-40B4-BE49-F238E27FC236}">
-                <a16:creationId xmlns:a16="http://schemas.microsoft.com/office/drawing/2014/main" id="{C8B9A95B-4B9D-47ED-ACF2-970768C3FC7E}"/>
+                <a16:creationId xmlns:a16="http://schemas.microsoft.com/office/drawing/2014/main" id="{2FC2B5A2-B08E-48CC-A739-834649B02FC2}"/>
               </a:ext>
             </a:extLst>
           </p:cNvPr>
@@ -19838,7 +19838,7 @@
           <p:cNvPr id="2" name="">
             <a:extLst xmlns:a="http://schemas.openxmlformats.org/drawingml/2006/main">
               <a:ext uri="{FF2B5EF4-FFF2-40B4-BE49-F238E27FC236}">
-                <a16:creationId xmlns:a16="http://schemas.microsoft.com/office/drawing/2014/main" id="{8649E676-E8A0-46D4-89D7-BF94C21A7164}"/>
+                <a16:creationId xmlns:a16="http://schemas.microsoft.com/office/drawing/2014/main" id="{4655A17B-05DE-40B1-B17E-8A5C0BE5D963}"/>
               </a:ext>
             </a:extLst>
           </p:cNvPr>
@@ -19869,7 +19869,7 @@
           <p:cNvPr id="3" name="">
             <a:extLst xmlns:a="http://schemas.openxmlformats.org/drawingml/2006/main">
               <a:ext uri="{FF2B5EF4-FFF2-40B4-BE49-F238E27FC236}">
-                <a16:creationId xmlns:a16="http://schemas.microsoft.com/office/drawing/2014/main" id="{A77935F0-6123-49E1-A7F0-D4934747BED7}"/>
+                <a16:creationId xmlns:a16="http://schemas.microsoft.com/office/drawing/2014/main" id="{1AFD1C93-69F2-4C00-B779-D4FA80DF3FD3}"/>
               </a:ext>
             </a:extLst>
           </p:cNvPr>
@@ -20026,7 +20026,7 @@
           <p:cNvPr id="4" name="Chart">
             <a:extLst xmlns:a="http://schemas.openxmlformats.org/drawingml/2006/main">
               <a:ext uri="{FF2B5EF4-FFF2-40B4-BE49-F238E27FC236}">
-                <a16:creationId xmlns:a16="http://schemas.microsoft.com/office/drawing/2014/main" id="{2B1AEB0B-BAAD-4F2D-BF29-C2225BBA157E}"/>
+                <a16:creationId xmlns:a16="http://schemas.microsoft.com/office/drawing/2014/main" id="{0F0C5177-3F04-4B09-BFAD-016B70528890}"/>
               </a:ext>
             </a:extLst>
           </p:cNvPr>
@@ -20039,7 +20039,7 @@
         </p:xfrm>
         <a:graphic xmlns:a="http://schemas.openxmlformats.org/drawingml/2006/main">
           <a:graphicData uri="http://schemas.openxmlformats.org/drawingml/2006/chart">
-            <c:chart xmlns:r="http://schemas.openxmlformats.org/officeDocument/2006/relationships" xmlns:c="http://schemas.openxmlformats.org/drawingml/2006/chart" r:id="Rcfa137bc91b7434b"/>
+            <c:chart xmlns:r="http://schemas.openxmlformats.org/officeDocument/2006/relationships" xmlns:c="http://schemas.openxmlformats.org/drawingml/2006/chart" r:id="R27c93d529db64f25"/>
           </a:graphicData>
         </a:graphic>
       </p:graphicFrame>
@@ -20048,7 +20048,7 @@
           <p:cNvPr id="5" name="">
             <a:extLst xmlns:a="http://schemas.openxmlformats.org/drawingml/2006/main">
               <a:ext uri="{FF2B5EF4-FFF2-40B4-BE49-F238E27FC236}">
-                <a16:creationId xmlns:a16="http://schemas.microsoft.com/office/drawing/2014/main" id="{0BF225DF-5A3B-4994-B396-5437FC7AC069}"/>
+                <a16:creationId xmlns:a16="http://schemas.microsoft.com/office/drawing/2014/main" id="{D683152C-92FD-47E9-8BC2-30DA37836FA6}"/>
               </a:ext>
             </a:extLst>
           </p:cNvPr>
@@ -20205,7 +20205,7 @@
           <p:cNvPr id="6" name="">
             <a:extLst xmlns:a="http://schemas.openxmlformats.org/drawingml/2006/main">
               <a:ext uri="{FF2B5EF4-FFF2-40B4-BE49-F238E27FC236}">
-                <a16:creationId xmlns:a16="http://schemas.microsoft.com/office/drawing/2014/main" id="{8E8FAF30-FEC7-465D-BDEE-1F61F82490BF}"/>
+                <a16:creationId xmlns:a16="http://schemas.microsoft.com/office/drawing/2014/main" id="{80EFC796-CAE2-4B62-9297-04C25818532C}"/>
               </a:ext>
             </a:extLst>
           </p:cNvPr>
@@ -20408,7 +20408,7 @@
           <p:cNvPr id="7" name="">
             <a:extLst xmlns:a="http://schemas.openxmlformats.org/drawingml/2006/main">
               <a:ext uri="{FF2B5EF4-FFF2-40B4-BE49-F238E27FC236}">
-                <a16:creationId xmlns:a16="http://schemas.microsoft.com/office/drawing/2014/main" id="{A5611219-17C6-4BF9-B221-CB4DCEF5B68F}"/>
+                <a16:creationId xmlns:a16="http://schemas.microsoft.com/office/drawing/2014/main" id="{4E26D031-AEA6-4A91-8302-0B6E9257012E}"/>
               </a:ext>
             </a:extLst>
           </p:cNvPr>
@@ -20588,7 +20588,7 @@
           <p:cNvPr id="8" name="">
             <a:extLst xmlns:a="http://schemas.openxmlformats.org/drawingml/2006/main">
               <a:ext uri="{FF2B5EF4-FFF2-40B4-BE49-F238E27FC236}">
-                <a16:creationId xmlns:a16="http://schemas.microsoft.com/office/drawing/2014/main" id="{C8F668DB-FFC0-487E-A42F-C249101D1764}"/>
+                <a16:creationId xmlns:a16="http://schemas.microsoft.com/office/drawing/2014/main" id="{3998BAF6-92AF-4705-ABC3-B800B68D55FF}"/>
               </a:ext>
             </a:extLst>
           </p:cNvPr>
@@ -20743,7 +20743,7 @@
     </p:spTree>
     <p:extLst>
       <p:ext uri="{BB962C8B-B14F-4D97-AF65-F5344CB8AC3E}">
-        <p14:creationId xmlns:p14="http://schemas.microsoft.com/office/powerpoint/2010/main" val="903549396"/>
+        <p14:creationId xmlns:p14="http://schemas.microsoft.com/office/powerpoint/2010/main" val="256093630"/>
       </p:ext>
     </p:extLst>
   </p:cSld>
@@ -20774,7 +20774,7 @@
           <p:cNvPr id="27" name="">
             <a:extLst xmlns:a="http://schemas.openxmlformats.org/drawingml/2006/main">
               <a:ext uri="{FF2B5EF4-FFF2-40B4-BE49-F238E27FC236}">
-                <a16:creationId xmlns:a16="http://schemas.microsoft.com/office/drawing/2014/main" id="{DEE2D14B-A30E-4517-A467-8E964064B669}"/>
+                <a16:creationId xmlns:a16="http://schemas.microsoft.com/office/drawing/2014/main" id="{7882E58C-95EE-438D-85E7-BDD4CA7EFD3B}"/>
               </a:ext>
             </a:extLst>
           </p:cNvPr>
@@ -20931,7 +20931,7 @@
           <p:cNvPr id="2" name="">
             <a:extLst xmlns:a="http://schemas.openxmlformats.org/drawingml/2006/main">
               <a:ext uri="{FF2B5EF4-FFF2-40B4-BE49-F238E27FC236}">
-                <a16:creationId xmlns:a16="http://schemas.microsoft.com/office/drawing/2014/main" id="{4881BFC1-4DEE-4F1B-A0C3-54E105314D87}"/>
+                <a16:creationId xmlns:a16="http://schemas.microsoft.com/office/drawing/2014/main" id="{F08B8EFC-3443-4E97-B1B5-9608ED39DF8C}"/>
               </a:ext>
             </a:extLst>
           </p:cNvPr>
@@ -20962,7 +20962,7 @@
           <p:cNvPr id="3" name="">
             <a:extLst xmlns:a="http://schemas.openxmlformats.org/drawingml/2006/main">
               <a:ext uri="{FF2B5EF4-FFF2-40B4-BE49-F238E27FC236}">
-                <a16:creationId xmlns:a16="http://schemas.microsoft.com/office/drawing/2014/main" id="{EAFA27FB-3F26-4FAE-80BA-94B860C9920C}"/>
+                <a16:creationId xmlns:a16="http://schemas.microsoft.com/office/drawing/2014/main" id="{6BB140D1-9BB7-4868-9CF9-DAC7D94E9546}"/>
               </a:ext>
             </a:extLst>
           </p:cNvPr>
@@ -21119,7 +21119,7 @@
           <p:cNvPr id="4" name="">
             <a:extLst xmlns:a="http://schemas.openxmlformats.org/drawingml/2006/main">
               <a:ext uri="{FF2B5EF4-FFF2-40B4-BE49-F238E27FC236}">
-                <a16:creationId xmlns:a16="http://schemas.microsoft.com/office/drawing/2014/main" id="{11181A0D-487C-4227-BF17-86AEB496D6A0}"/>
+                <a16:creationId xmlns:a16="http://schemas.microsoft.com/office/drawing/2014/main" id="{B26DEBC3-025F-4235-95A6-F99382386B56}"/>
               </a:ext>
             </a:extLst>
           </p:cNvPr>
@@ -21152,7 +21152,7 @@
           <p:cNvPr id="5" name="">
             <a:extLst xmlns:a="http://schemas.openxmlformats.org/drawingml/2006/main">
               <a:ext uri="{FF2B5EF4-FFF2-40B4-BE49-F238E27FC236}">
-                <a16:creationId xmlns:a16="http://schemas.microsoft.com/office/drawing/2014/main" id="{DDC4C151-7290-4BE9-B0FE-9D8EA714EEDA}"/>
+                <a16:creationId xmlns:a16="http://schemas.microsoft.com/office/drawing/2014/main" id="{F248D006-76F1-41FE-9924-6D65469EAFAD}"/>
               </a:ext>
             </a:extLst>
           </p:cNvPr>
@@ -21309,7 +21309,7 @@
           <p:cNvPr id="6" name="">
             <a:extLst xmlns:a="http://schemas.openxmlformats.org/drawingml/2006/main">
               <a:ext uri="{FF2B5EF4-FFF2-40B4-BE49-F238E27FC236}">
-                <a16:creationId xmlns:a16="http://schemas.microsoft.com/office/drawing/2014/main" id="{97315005-08CA-470C-A298-1BDE5430B7D2}"/>
+                <a16:creationId xmlns:a16="http://schemas.microsoft.com/office/drawing/2014/main" id="{2E8AD829-E499-4B39-AB40-24A0219FBB41}"/>
               </a:ext>
             </a:extLst>
           </p:cNvPr>
@@ -21489,7 +21489,7 @@
           <p:cNvPr id="7" name="">
             <a:extLst xmlns:a="http://schemas.openxmlformats.org/drawingml/2006/main">
               <a:ext uri="{FF2B5EF4-FFF2-40B4-BE49-F238E27FC236}">
-                <a16:creationId xmlns:a16="http://schemas.microsoft.com/office/drawing/2014/main" id="{3D6F6647-5571-4181-B0DB-34EFDFD807CE}"/>
+                <a16:creationId xmlns:a16="http://schemas.microsoft.com/office/drawing/2014/main" id="{4CFF477D-4756-4108-B925-305E8628473B}"/>
               </a:ext>
             </a:extLst>
           </p:cNvPr>
@@ -21520,7 +21520,7 @@
           <p:cNvPr id="8" name="">
             <a:extLst xmlns:a="http://schemas.openxmlformats.org/drawingml/2006/main">
               <a:ext uri="{FF2B5EF4-FFF2-40B4-BE49-F238E27FC236}">
-                <a16:creationId xmlns:a16="http://schemas.microsoft.com/office/drawing/2014/main" id="{7FBCFD52-321E-4042-BC4C-2F8FAE69CC14}"/>
+                <a16:creationId xmlns:a16="http://schemas.microsoft.com/office/drawing/2014/main" id="{9C196762-B94C-4376-ABA1-0200A94A6EA7}"/>
               </a:ext>
             </a:extLst>
           </p:cNvPr>
@@ -21553,7 +21553,7 @@
           <p:cNvPr id="9" name="">
             <a:extLst xmlns:a="http://schemas.openxmlformats.org/drawingml/2006/main">
               <a:ext uri="{FF2B5EF4-FFF2-40B4-BE49-F238E27FC236}">
-                <a16:creationId xmlns:a16="http://schemas.microsoft.com/office/drawing/2014/main" id="{90DD4A2A-DF9F-472A-8C32-0E110BB41960}"/>
+                <a16:creationId xmlns:a16="http://schemas.microsoft.com/office/drawing/2014/main" id="{7351CCD3-D789-4247-8812-7DBEBB0862BE}"/>
               </a:ext>
             </a:extLst>
           </p:cNvPr>
@@ -21710,7 +21710,7 @@
           <p:cNvPr id="10" name="">
             <a:extLst xmlns:a="http://schemas.openxmlformats.org/drawingml/2006/main">
               <a:ext uri="{FF2B5EF4-FFF2-40B4-BE49-F238E27FC236}">
-                <a16:creationId xmlns:a16="http://schemas.microsoft.com/office/drawing/2014/main" id="{7B6B398B-9B29-45C9-A39B-B56EEEEE9D17}"/>
+                <a16:creationId xmlns:a16="http://schemas.microsoft.com/office/drawing/2014/main" id="{66142669-FC3F-4E65-8DB1-270C95DDCC6F}"/>
               </a:ext>
             </a:extLst>
           </p:cNvPr>
@@ -21890,7 +21890,7 @@
           <p:cNvPr id="11" name="">
             <a:extLst xmlns:a="http://schemas.openxmlformats.org/drawingml/2006/main">
               <a:ext uri="{FF2B5EF4-FFF2-40B4-BE49-F238E27FC236}">
-                <a16:creationId xmlns:a16="http://schemas.microsoft.com/office/drawing/2014/main" id="{00AB7D75-B821-4542-8EA6-DDEF90A24936}"/>
+                <a16:creationId xmlns:a16="http://schemas.microsoft.com/office/drawing/2014/main" id="{1D725198-BC13-4D94-8DC3-46E8718572F2}"/>
               </a:ext>
             </a:extLst>
           </p:cNvPr>
@@ -21921,7 +21921,7 @@
           <p:cNvPr id="12" name="">
             <a:extLst xmlns:a="http://schemas.openxmlformats.org/drawingml/2006/main">
               <a:ext uri="{FF2B5EF4-FFF2-40B4-BE49-F238E27FC236}">
-                <a16:creationId xmlns:a16="http://schemas.microsoft.com/office/drawing/2014/main" id="{71D9D55A-BC81-461A-B1EB-3EEB130E5948}"/>
+                <a16:creationId xmlns:a16="http://schemas.microsoft.com/office/drawing/2014/main" id="{9548B3B1-EF45-4E33-8ABE-BCE311EFBC82}"/>
               </a:ext>
             </a:extLst>
           </p:cNvPr>
@@ -21954,7 +21954,7 @@
           <p:cNvPr id="13" name="">
             <a:extLst xmlns:a="http://schemas.openxmlformats.org/drawingml/2006/main">
               <a:ext uri="{FF2B5EF4-FFF2-40B4-BE49-F238E27FC236}">
-                <a16:creationId xmlns:a16="http://schemas.microsoft.com/office/drawing/2014/main" id="{BF845822-E0D4-4F3F-8369-2B8ED07AF001}"/>
+                <a16:creationId xmlns:a16="http://schemas.microsoft.com/office/drawing/2014/main" id="{BD9FFE70-9F3D-4E57-8FF1-88FFDD5AE163}"/>
               </a:ext>
             </a:extLst>
           </p:cNvPr>
@@ -22111,7 +22111,7 @@
           <p:cNvPr id="14" name="">
             <a:extLst xmlns:a="http://schemas.openxmlformats.org/drawingml/2006/main">
               <a:ext uri="{FF2B5EF4-FFF2-40B4-BE49-F238E27FC236}">
-                <a16:creationId xmlns:a16="http://schemas.microsoft.com/office/drawing/2014/main" id="{5983FE2E-94D7-4E95-A2B3-F03F0EC0B25A}"/>
+                <a16:creationId xmlns:a16="http://schemas.microsoft.com/office/drawing/2014/main" id="{D9B4D3CE-1200-4E8B-9D03-1CDD9DAAD4FA}"/>
               </a:ext>
             </a:extLst>
           </p:cNvPr>
@@ -22291,7 +22291,7 @@
           <p:cNvPr id="15" name="">
             <a:extLst xmlns:a="http://schemas.openxmlformats.org/drawingml/2006/main">
               <a:ext uri="{FF2B5EF4-FFF2-40B4-BE49-F238E27FC236}">
-                <a16:creationId xmlns:a16="http://schemas.microsoft.com/office/drawing/2014/main" id="{BBC389C2-774C-4882-BCFB-0963E3FFE6FE}"/>
+                <a16:creationId xmlns:a16="http://schemas.microsoft.com/office/drawing/2014/main" id="{E944CB38-6D08-4772-B629-F32A9C6964A6}"/>
               </a:ext>
             </a:extLst>
           </p:cNvPr>
@@ -22322,7 +22322,7 @@
           <p:cNvPr id="16" name="">
             <a:extLst xmlns:a="http://schemas.openxmlformats.org/drawingml/2006/main">
               <a:ext uri="{FF2B5EF4-FFF2-40B4-BE49-F238E27FC236}">
-                <a16:creationId xmlns:a16="http://schemas.microsoft.com/office/drawing/2014/main" id="{C3B8BEBF-BFE7-4737-B120-ADABEB25F2AC}"/>
+                <a16:creationId xmlns:a16="http://schemas.microsoft.com/office/drawing/2014/main" id="{D12F222C-C641-489A-97B0-D8BDD9C55232}"/>
               </a:ext>
             </a:extLst>
           </p:cNvPr>
@@ -22355,7 +22355,7 @@
           <p:cNvPr id="17" name="">
             <a:extLst xmlns:a="http://schemas.openxmlformats.org/drawingml/2006/main">
               <a:ext uri="{FF2B5EF4-FFF2-40B4-BE49-F238E27FC236}">
-                <a16:creationId xmlns:a16="http://schemas.microsoft.com/office/drawing/2014/main" id="{ABC54636-CCE1-4154-A182-2052EB580D4D}"/>
+                <a16:creationId xmlns:a16="http://schemas.microsoft.com/office/drawing/2014/main" id="{2520519D-FF69-427B-8205-FE65C448A6DC}"/>
               </a:ext>
             </a:extLst>
           </p:cNvPr>
@@ -22512,7 +22512,7 @@
           <p:cNvPr id="18" name="">
             <a:extLst xmlns:a="http://schemas.openxmlformats.org/drawingml/2006/main">
               <a:ext uri="{FF2B5EF4-FFF2-40B4-BE49-F238E27FC236}">
-                <a16:creationId xmlns:a16="http://schemas.microsoft.com/office/drawing/2014/main" id="{23A68053-69F7-4E68-9AE6-C25DB3A0F06E}"/>
+                <a16:creationId xmlns:a16="http://schemas.microsoft.com/office/drawing/2014/main" id="{73B8E21B-13E1-4E8D-BF60-973A09F1FA1F}"/>
               </a:ext>
             </a:extLst>
           </p:cNvPr>
@@ -22692,7 +22692,7 @@
           <p:cNvPr id="19" name="">
             <a:extLst xmlns:a="http://schemas.openxmlformats.org/drawingml/2006/main">
               <a:ext uri="{FF2B5EF4-FFF2-40B4-BE49-F238E27FC236}">
-                <a16:creationId xmlns:a16="http://schemas.microsoft.com/office/drawing/2014/main" id="{DEE48C86-2A17-4A09-BB74-81F9FBB4EB96}"/>
+                <a16:creationId xmlns:a16="http://schemas.microsoft.com/office/drawing/2014/main" id="{5621466C-5382-4DF2-8ECC-7FADEA57FA30}"/>
               </a:ext>
             </a:extLst>
           </p:cNvPr>
@@ -22723,7 +22723,7 @@
           <p:cNvPr id="20" name="">
             <a:extLst xmlns:a="http://schemas.openxmlformats.org/drawingml/2006/main">
               <a:ext uri="{FF2B5EF4-FFF2-40B4-BE49-F238E27FC236}">
-                <a16:creationId xmlns:a16="http://schemas.microsoft.com/office/drawing/2014/main" id="{7BA5A5F5-22CA-4877-A752-83E03FC0D9BB}"/>
+                <a16:creationId xmlns:a16="http://schemas.microsoft.com/office/drawing/2014/main" id="{66BBABBD-3836-470D-A155-11FEEC931560}"/>
               </a:ext>
             </a:extLst>
           </p:cNvPr>
@@ -22754,7 +22754,7 @@
           <p:cNvPr id="21" name="">
             <a:extLst xmlns:a="http://schemas.openxmlformats.org/drawingml/2006/main">
               <a:ext uri="{FF2B5EF4-FFF2-40B4-BE49-F238E27FC236}">
-                <a16:creationId xmlns:a16="http://schemas.microsoft.com/office/drawing/2014/main" id="{EB3A2680-1878-4465-9A60-23800F393B85}"/>
+                <a16:creationId xmlns:a16="http://schemas.microsoft.com/office/drawing/2014/main" id="{76F45BAE-47FE-42C4-B8E0-31535610DD7D}"/>
               </a:ext>
             </a:extLst>
           </p:cNvPr>
@@ -22911,7 +22911,7 @@
           <p:cNvPr id="22" name="">
             <a:extLst xmlns:a="http://schemas.openxmlformats.org/drawingml/2006/main">
               <a:ext uri="{FF2B5EF4-FFF2-40B4-BE49-F238E27FC236}">
-                <a16:creationId xmlns:a16="http://schemas.microsoft.com/office/drawing/2014/main" id="{61DDC208-F59A-4484-A4D6-4786382AC7B9}"/>
+                <a16:creationId xmlns:a16="http://schemas.microsoft.com/office/drawing/2014/main" id="{6D494EC1-1158-4E78-8E1A-B63ADE21A5B5}"/>
               </a:ext>
             </a:extLst>
           </p:cNvPr>
@@ -23068,7 +23068,7 @@
           <p:cNvPr id="23" name="">
             <a:extLst xmlns:a="http://schemas.openxmlformats.org/drawingml/2006/main">
               <a:ext uri="{FF2B5EF4-FFF2-40B4-BE49-F238E27FC236}">
-                <a16:creationId xmlns:a16="http://schemas.microsoft.com/office/drawing/2014/main" id="{1027F248-3225-4FEE-ABAC-6BEDD900435C}"/>
+                <a16:creationId xmlns:a16="http://schemas.microsoft.com/office/drawing/2014/main" id="{AB8DF49E-2D8A-4015-B2B0-E2D19F14E010}"/>
               </a:ext>
             </a:extLst>
           </p:cNvPr>
@@ -23248,7 +23248,7 @@
           <p:cNvPr id="24" name="">
             <a:extLst xmlns:a="http://schemas.openxmlformats.org/drawingml/2006/main">
               <a:ext uri="{FF2B5EF4-FFF2-40B4-BE49-F238E27FC236}">
-                <a16:creationId xmlns:a16="http://schemas.microsoft.com/office/drawing/2014/main" id="{F83E707E-3FB8-4465-86DA-AFB7AAF71D6B}"/>
+                <a16:creationId xmlns:a16="http://schemas.microsoft.com/office/drawing/2014/main" id="{74C782B0-4978-41D2-8F64-155AAD200CAD}"/>
               </a:ext>
             </a:extLst>
           </p:cNvPr>
@@ -23405,7 +23405,7 @@
           <p:cNvPr id="25" name="">
             <a:extLst xmlns:a="http://schemas.openxmlformats.org/drawingml/2006/main">
               <a:ext uri="{FF2B5EF4-FFF2-40B4-BE49-F238E27FC236}">
-                <a16:creationId xmlns:a16="http://schemas.microsoft.com/office/drawing/2014/main" id="{864DFE44-2C83-427A-BEF4-00C47A8CEE22}"/>
+                <a16:creationId xmlns:a16="http://schemas.microsoft.com/office/drawing/2014/main" id="{94070491-F65B-4519-9E30-46EF6BE0D0A2}"/>
               </a:ext>
             </a:extLst>
           </p:cNvPr>
@@ -23585,7 +23585,7 @@
           <p:cNvPr id="26" name="">
             <a:extLst xmlns:a="http://schemas.openxmlformats.org/drawingml/2006/main">
               <a:ext uri="{FF2B5EF4-FFF2-40B4-BE49-F238E27FC236}">
-                <a16:creationId xmlns:a16="http://schemas.microsoft.com/office/drawing/2014/main" id="{224A1E10-E1B3-4D00-AECF-212FB2076568}"/>
+                <a16:creationId xmlns:a16="http://schemas.microsoft.com/office/drawing/2014/main" id="{B5F5F227-0E96-4770-B438-9CD21BCCC3D2}"/>
               </a:ext>
             </a:extLst>
           </p:cNvPr>
@@ -23740,7 +23740,7 @@
     </p:spTree>
     <p:extLst>
       <p:ext uri="{BB962C8B-B14F-4D97-AF65-F5344CB8AC3E}">
-        <p14:creationId xmlns:p14="http://schemas.microsoft.com/office/powerpoint/2010/main" val="1214692704"/>
+        <p14:creationId xmlns:p14="http://schemas.microsoft.com/office/powerpoint/2010/main" val="413055730"/>
       </p:ext>
     </p:extLst>
   </p:cSld>
@@ -23771,7 +23771,7 @@
           <p:cNvPr id="9" name="">
             <a:extLst xmlns:a="http://schemas.openxmlformats.org/drawingml/2006/main">
               <a:ext uri="{FF2B5EF4-FFF2-40B4-BE49-F238E27FC236}">
-                <a16:creationId xmlns:a16="http://schemas.microsoft.com/office/drawing/2014/main" id="{AE65E605-E85F-4BF8-8EBE-E913D4417232}"/>
+                <a16:creationId xmlns:a16="http://schemas.microsoft.com/office/drawing/2014/main" id="{75DB6AC2-DCC3-4973-BB66-E7A273CECB39}"/>
               </a:ext>
             </a:extLst>
           </p:cNvPr>
@@ -23928,7 +23928,7 @@
           <p:cNvPr id="2" name="">
             <a:extLst xmlns:a="http://schemas.openxmlformats.org/drawingml/2006/main">
               <a:ext uri="{FF2B5EF4-FFF2-40B4-BE49-F238E27FC236}">
-                <a16:creationId xmlns:a16="http://schemas.microsoft.com/office/drawing/2014/main" id="{F561EBC4-A0DA-4CEB-A041-0132856E3CEB}"/>
+                <a16:creationId xmlns:a16="http://schemas.microsoft.com/office/drawing/2014/main" id="{81CB349F-3430-4CA5-A6DB-6E3257E4F3EC}"/>
               </a:ext>
             </a:extLst>
           </p:cNvPr>
@@ -23959,7 +23959,7 @@
           <p:cNvPr id="3" name="">
             <a:extLst xmlns:a="http://schemas.openxmlformats.org/drawingml/2006/main">
               <a:ext uri="{FF2B5EF4-FFF2-40B4-BE49-F238E27FC236}">
-                <a16:creationId xmlns:a16="http://schemas.microsoft.com/office/drawing/2014/main" id="{4C708572-52E7-4AEC-88BA-53765FE49594}"/>
+                <a16:creationId xmlns:a16="http://schemas.microsoft.com/office/drawing/2014/main" id="{8AFDF8D2-29CF-46AA-A2A1-C36E0F685E87}"/>
               </a:ext>
             </a:extLst>
           </p:cNvPr>
@@ -24116,7 +24116,7 @@
           <p:cNvPr id="4" name="">
             <a:extLst xmlns:a="http://schemas.openxmlformats.org/drawingml/2006/main">
               <a:ext uri="{FF2B5EF4-FFF2-40B4-BE49-F238E27FC236}">
-                <a16:creationId xmlns:a16="http://schemas.microsoft.com/office/drawing/2014/main" id="{6C121610-02A6-4414-AC54-58DDA6C0214D}"/>
+                <a16:creationId xmlns:a16="http://schemas.microsoft.com/office/drawing/2014/main" id="{21A86B7F-5A7D-4B55-BDF5-46DFDB0B0B5A}"/>
               </a:ext>
             </a:extLst>
           </p:cNvPr>
@@ -24273,7 +24273,7 @@
           <p:cNvPr id="5" name="">
             <a:extLst xmlns:a="http://schemas.openxmlformats.org/drawingml/2006/main">
               <a:ext uri="{FF2B5EF4-FFF2-40B4-BE49-F238E27FC236}">
-                <a16:creationId xmlns:a16="http://schemas.microsoft.com/office/drawing/2014/main" id="{FE7873B5-8441-4926-B7B1-EC7B449E3DF5}"/>
+                <a16:creationId xmlns:a16="http://schemas.microsoft.com/office/drawing/2014/main" id="{58540B2A-0056-4485-AE76-AE50BF1C8FA6}"/>
               </a:ext>
             </a:extLst>
           </p:cNvPr>
@@ -24443,7 +24443,7 @@
                 <a:ea typeface="Arial"/>
                 <a:cs typeface="Arial"/>
               </a:rPr>
-              <a:t>Merit: repeated instruction savings</a:t>
+              <a:t>Merit: operations saved × executions</a:t>
             </a:r>
           </a:p>
           <a:p xmlns:a="http://schemas.openxmlformats.org/drawingml/2006/main">
@@ -24522,7 +24522,7 @@
           <p:cNvPr id="6" name="">
             <a:extLst xmlns:a="http://schemas.openxmlformats.org/drawingml/2006/main">
               <a:ext uri="{FF2B5EF4-FFF2-40B4-BE49-F238E27FC236}">
-                <a16:creationId xmlns:a16="http://schemas.microsoft.com/office/drawing/2014/main" id="{E89752FD-F971-41E7-8733-1A8810CB13EA}"/>
+                <a16:creationId xmlns:a16="http://schemas.microsoft.com/office/drawing/2014/main" id="{DF20E616-CB49-4CE6-83B4-E747D946EFE7}"/>
               </a:ext>
             </a:extLst>
           </p:cNvPr>
@@ -24679,7 +24679,7 @@
           <p:cNvPr id="7" name="">
             <a:extLst xmlns:a="http://schemas.openxmlformats.org/drawingml/2006/main">
               <a:ext uri="{FF2B5EF4-FFF2-40B4-BE49-F238E27FC236}">
-                <a16:creationId xmlns:a16="http://schemas.microsoft.com/office/drawing/2014/main" id="{B057FDF3-4640-4F70-B645-58C82CCFB3DC}"/>
+                <a16:creationId xmlns:a16="http://schemas.microsoft.com/office/drawing/2014/main" id="{7468DB1D-C912-4AD0-BD97-EEE5E5543078}"/>
               </a:ext>
             </a:extLst>
           </p:cNvPr>
@@ -24928,7 +24928,7 @@
           <p:cNvPr id="8" name="">
             <a:extLst xmlns:a="http://schemas.openxmlformats.org/drawingml/2006/main">
               <a:ext uri="{FF2B5EF4-FFF2-40B4-BE49-F238E27FC236}">
-                <a16:creationId xmlns:a16="http://schemas.microsoft.com/office/drawing/2014/main" id="{C1573C74-713A-4518-9DA5-46259D7137C5}"/>
+                <a16:creationId xmlns:a16="http://schemas.microsoft.com/office/drawing/2014/main" id="{4BA7B392-7FEB-4DF6-953B-03E7CFA9736B}"/>
               </a:ext>
             </a:extLst>
           </p:cNvPr>
@@ -25083,7 +25083,7 @@
     </p:spTree>
     <p:extLst>
       <p:ext uri="{BB962C8B-B14F-4D97-AF65-F5344CB8AC3E}">
-        <p14:creationId xmlns:p14="http://schemas.microsoft.com/office/powerpoint/2010/main" val="1177781110"/>
+        <p14:creationId xmlns:p14="http://schemas.microsoft.com/office/powerpoint/2010/main" val="1897287884"/>
       </p:ext>
     </p:extLst>
   </p:cSld>

</xml_diff>

<commit_message>
Show project build history and measurement workflow
</commit_message>
<xml_diff>
--- a/submissions/midterm-2026-10-28/isaforge-midterm-progress-slides-final.pptx
+++ b/submissions/midterm-2026-10-28/isaforge-midterm-progress-slides-final.pptx
@@ -2,23 +2,23 @@
 <file path=ppt/presentation.xml><?xml version="1.0" encoding="utf-8"?>
 <p:presentation xmlns:p="http://schemas.openxmlformats.org/presentationml/2006/main">
   <p:sldMasterIdLst>
-    <p:sldMasterId xmlns:r="http://schemas.openxmlformats.org/officeDocument/2006/relationships" id="2147483648" r:id="R38dd3f5c3ab040d4"/>
+    <p:sldMasterId xmlns:r="http://schemas.openxmlformats.org/officeDocument/2006/relationships" id="2147483648" r:id="R0623956cba924f6a"/>
   </p:sldMasterIdLst>
   <p:notesMasterIdLst>
-    <p:notesMasterId xmlns:r="http://schemas.openxmlformats.org/officeDocument/2006/relationships" r:id="R7555403a672d4f73"/>
+    <p:notesMasterId xmlns:r="http://schemas.openxmlformats.org/officeDocument/2006/relationships" r:id="R478eb663ac444115"/>
   </p:notesMasterIdLst>
   <p:sldIdLst>
-    <p:sldId xmlns:r="http://schemas.openxmlformats.org/officeDocument/2006/relationships" id="256" r:id="Rbc0bbdd8f9d946b0"/>
-    <p:sldId xmlns:r="http://schemas.openxmlformats.org/officeDocument/2006/relationships" id="257" r:id="R62c1673c12d34c81"/>
-    <p:sldId xmlns:r="http://schemas.openxmlformats.org/officeDocument/2006/relationships" id="258" r:id="Raea80d82a69843fd"/>
-    <p:sldId xmlns:r="http://schemas.openxmlformats.org/officeDocument/2006/relationships" id="259" r:id="R08657a87ed5e44af"/>
-    <p:sldId xmlns:r="http://schemas.openxmlformats.org/officeDocument/2006/relationships" id="260" r:id="Re05a4e59b8244aa6"/>
-    <p:sldId xmlns:r="http://schemas.openxmlformats.org/officeDocument/2006/relationships" id="261" r:id="R823efb18b3d84fcf"/>
-    <p:sldId xmlns:r="http://schemas.openxmlformats.org/officeDocument/2006/relationships" id="262" r:id="Rca9b40f3d0fc47b7"/>
-    <p:sldId xmlns:r="http://schemas.openxmlformats.org/officeDocument/2006/relationships" id="263" r:id="R1147d4ae1c074c5d"/>
-    <p:sldId xmlns:r="http://schemas.openxmlformats.org/officeDocument/2006/relationships" id="264" r:id="R7240a0ac195845ad"/>
-    <p:sldId xmlns:r="http://schemas.openxmlformats.org/officeDocument/2006/relationships" id="265" r:id="Re5ba94e541ca4ca2"/>
-    <p:sldId xmlns:r="http://schemas.openxmlformats.org/officeDocument/2006/relationships" id="266" r:id="R0d05e68c9ac7460f"/>
+    <p:sldId xmlns:r="http://schemas.openxmlformats.org/officeDocument/2006/relationships" id="256" r:id="R18c80ad563cc4e9d"/>
+    <p:sldId xmlns:r="http://schemas.openxmlformats.org/officeDocument/2006/relationships" id="257" r:id="Rd47b3ce9ce9b4183"/>
+    <p:sldId xmlns:r="http://schemas.openxmlformats.org/officeDocument/2006/relationships" id="258" r:id="R55aed49ad1f14496"/>
+    <p:sldId xmlns:r="http://schemas.openxmlformats.org/officeDocument/2006/relationships" id="259" r:id="R715b2bdfcdb8421d"/>
+    <p:sldId xmlns:r="http://schemas.openxmlformats.org/officeDocument/2006/relationships" id="260" r:id="R0836f81688c14d9e"/>
+    <p:sldId xmlns:r="http://schemas.openxmlformats.org/officeDocument/2006/relationships" id="261" r:id="R7f2b1b0af4254625"/>
+    <p:sldId xmlns:r="http://schemas.openxmlformats.org/officeDocument/2006/relationships" id="262" r:id="Red77a0d0b6714133"/>
+    <p:sldId xmlns:r="http://schemas.openxmlformats.org/officeDocument/2006/relationships" id="263" r:id="R8cf89c8779b14c04"/>
+    <p:sldId xmlns:r="http://schemas.openxmlformats.org/officeDocument/2006/relationships" id="264" r:id="R13c4a78f60014a4a"/>
+    <p:sldId xmlns:r="http://schemas.openxmlformats.org/officeDocument/2006/relationships" id="265" r:id="R9f44b38896434a42"/>
+    <p:sldId xmlns:r="http://schemas.openxmlformats.org/officeDocument/2006/relationships" id="266" r:id="R74f8aefdcc85453d"/>
   </p:sldIdLst>
   <p:sldSz cx="12192000" cy="6858000"/>
   <p:notesSz cx="6858000" cy="9144000"/>
@@ -887,7 +887,7 @@
           </a:p>
           <a:p xmlns:a="http://schemas.openxmlformats.org/drawingml/2006/main">
             <a:r>
-              <a:t>We progressed from CRC32 and aha-mont64 to a multi-workload corpus, followed by budgeted comparisons, explanations, and LLM tools. Codex records approximately thirty hours of turn duration in this chat; that includes tool waits and failures and is not model training time. The team contribution mapping is provisional and needs confirmation.</a:t>
+              <a:t>We started by collecting real benchmark traces and synthesizing isolated circuits for a hardware-cost model. Next we connected candidates to whole-program execution on PicoRV32, expanded the dataset, and tested selection policies. Two project chats record about forty-six hours of turn duration, including waits and interruptions, not training time. Team roles are provisional and need confirmation.</a:t>
             </a:r>
           </a:p>
           <a:p xmlns:a="http://schemas.openxmlformats.org/drawingml/2006/main">
@@ -902,7 +902,7 @@
           </a:p>
           <a:p xmlns:a="http://schemas.openxmlformats.org/drawingml/2006/main">
             <a:r>
-              <a:t>Dated results directories October19–27; git history; docs/original-project-proposal.txt; supplied AgenticRiscPredictor.pdf. Codex thread history snapshot through October 27: 90 turns with duration total 29.94 hours, including 84 completed, 4 failed and 2 interrupted; tool waiting is included. 48 directly spawned subagent threads; counts are activity, not research outcomes. See codex-history-and-baseline.md. Team must confirm roles and aliases; Git alone cannot measure contribution shares.</a:t>
+              <a:t>Dated results directories October19–27; git history; docs/original-project-proposal.txt; supplied AgenticRiscPredictor.pdf. Codex history snapshot: two project chats record 15.82 and 29.97 hours of ended turn duration, approximately 45.8 hours combined, including tool waits and interruptions. The earlier 15.82 hours includes 4.51 hours across two interrupted turns. 72 distinct directly spawned subagent threads; activity is not training time or a research outcome. See codex-history-and-baseline.md. Team must confirm roles and aliases; Git alone cannot measure contribution shares.</a:t>
             </a:r>
           </a:p>
         </p:txBody>
@@ -987,7 +987,7 @@
           </a:p>
           <a:p xmlns:a="http://schemas.openxmlformats.org/drawingml/2006/main">
             <a:r>
-              <a:t>First we compile and run the unmodified benchmark on the unmodified PicoRV32 and check its output. In the original CRC32 experiment, that reference took 32.39 million simulated cycles. The best candidate took 30.82 million: a 1.051 times common-clock speedup. We extract legal dataflow, lower the candidate to a custom opcode, and rerun the same benchmark. Integrated synthesis and routing measure area and timing. These are simulation and FPGA tool results, not physical-chip stopwatch measurements.</a:t>
+              <a:t>We wrote scripts that compile and profile workloads, extract legal candidates, and lower them to custom instructions. The evaluator executes each modified program with Verilator and checks correctness; Yosys and nextpnr measure integrated area and timing. The unmodified CRC32 reference took 32.39 million simulated cycles. The best candidate took 30.82 million, a 1.051 times common-clock speedup. These are simulation and FPGA tool results, not physical-chip stopwatch measurements.</a:t>
             </a:r>
           </a:p>
           <a:p xmlns:a="http://schemas.openxmlformats.org/drawingml/2006/main">
@@ -1002,7 +1002,7 @@
           </a:p>
           <a:p xmlns:a="http://schemas.openxmlformats.org/drawingml/2006/main">
             <a:r>
-              <a:t>docs/codesign-loop.md; results/2026-10-19-codesign/independent-audit.json. Embench CRC32,170 benchmark repetitions; startup, independent checksum, warm-up and serial reporting excluded from counter window. Same RV32I PicoRV32, 8KiB RAM and 12MHz target. Baseline 32,387,382 cycles,1653 LUT4; index_offset 30,820,662 cycles,1684 LUT4 (+31), 1.050833x. Both correctness checked; same-clock speedup, not measured board runtime. Baseline synth/routing Fmax 68.49–77.16 MHz. Distinguish this unmodified reference from heuristic selection baselines.</a:t>
+              <a:t>src/candidates.py extracts legal candidates; isaforge/workload_experiment.py orchestrates workload preparation and collection; isaforge/codesign.py implements ProcessorEvaluator; Verilator simulates, Yosys synthesizes, nextpnr routes. docs/codesign-loop.md; results/2026-10-19-codesign/independent-audit.json. Embench CRC32,170 benchmark repetitions; startup, independent checksum, warm-up and serial reporting excluded from counter window. Same RV32I PicoRV32, 8KiB RAM and 12MHz target. Baseline 32,387,382 cycles,1653 LUT4; index_offset 30,820,662 cycles,1684 LUT4 (+31), 1.050833x. Both correctness checked; same-clock speedup, not measured board runtime. Baseline synth/routing Fmax 68.49–77.16 MHz. Distinguish this unmodified reference from heuristic selection baselines.</a:t>
             </a:r>
           </a:p>
         </p:txBody>
@@ -1087,7 +1087,7 @@
           </a:p>
           <a:p xmlns:a="http://schemas.openxmlformats.org/drawingml/2006/main">
             <a:r>
-              <a:t>Our frozen corpus contains 122 successful candidate-program measurements from fourteen workload groups, plus four charged failures. These come from three benchmark suites. We tested thirteen selection policies in the final screen: eight learned policies and five heuristics or random controls. Their 2,925 replay results reuse the same hardware measurements; they are not new hardware runs. We evaluate by holding out entire workloads. Three later Ascon measurements remain separate.</a:t>
+              <a:t>Our first dataset used eight Embench programs and 301 synthesized isolated circuits to train a LUT-cost model. That is separate from the current whole-program dataset of 122 measured candidate-program results across fourteen workload groups, plus four charged failures. The chart shows the three suites in that current corpus. We hold out entire workloads. Our thirteen-policy screen includes 2,925 replays of existing measurements, not new hardware runs.</a:t>
             </a:r>
           </a:p>
           <a:p xmlns:a="http://schemas.openxmlformats.org/drawingml/2006/main">
@@ -1102,7 +1102,7 @@
           </a:p>
           <a:p xmlns:a="http://schemas.openxmlformats.org/drawingml/2006/main">
             <a:r>
-              <a:t>Dataset: submissions/midterm-2026-10-28/dataset/; results/2026-10-27-final-selection-scorecard/scorecard.json. 15 build/input contexts;12 complete measured-pool oracles,2 censored. Embench39 labels/6 groups; BEEBS48/5; TACLeBench35/3. Original teammate hardware-branch data uses a distinct context and is not silently merged.</a:t>
+              <a:t>Earlier area dataset: results/2026-10-13/README.md: 339 candidate examples, 301 distinct synthesized formulas from eight Embench programs; isolated LUT4 labels, not processor cycles; grouped held-out XGBoost MAE 33.08 versus 77.32 LUT4 mean baseline. Current dataset: submissions/midterm-2026-10-28/dataset/; results/2026-10-27-final-selection-scorecard/scorecard.json. 15 build/input contexts;12 complete measured-pool oracles,2 censored. Embench39 labels/6 groups; BEEBS48/5; TACLeBench35/3. Original teammate hardware-branch data uses a distinct context and is not silently merged.</a:t>
             </a:r>
           </a:p>
         </p:txBody>
@@ -1187,7 +1187,7 @@
           </a:p>
           <a:p xmlns:a="http://schemas.openxmlformats.org/drawingml/2006/main">
             <a:r>
-              <a:t>Our main challenger is XGBoost pairwise ranking, not a neural network. Thirty-five premeasurement features describe each candidate. Pairs are ordered using measured speedup within a workload context. Eighty shallow trees produce a relative ranking score, not a predicted speedup or confidence probability. We also tested XGBoost regression and feasibility models, logistic regression, random forests, Extra Trees, and Gaussian-process active learning. We assess them on selection, not just prediction error.</a:t>
+              <a:t>Our main challenger is XGBoost pairwise ranking, not a neural network. Thirty-five premeasurement features describe each candidate. We use measured speedup to order pairs within a workload, then fit eighty shallow trees. The output is a relative ranking, not a speedup or confidence probability. We tried eight learned policies in the final screen and five controls. Separate experiments tested Gaussian-process active learning. We assess selection quality, not just prediction error.</a:t>
             </a:r>
           </a:p>
           <a:p xmlns:a="http://schemas.openxmlformats.org/drawingml/2006/main">
@@ -1549,7 +1549,7 @@
           <p:cNvPr id="3" name="Title">
             <a:extLst xmlns:a="http://schemas.openxmlformats.org/drawingml/2006/main">
               <a:ext uri="{FF2B5EF4-FFF2-40B4-BE49-F238E27FC236}">
-                <a16:creationId xmlns:a16="http://schemas.microsoft.com/office/drawing/2014/main" id="{A65EC7E8-ADAF-4D11-BBDC-8E61876AE5A9}"/>
+                <a16:creationId xmlns:a16="http://schemas.microsoft.com/office/drawing/2014/main" id="{FA7E7869-FB95-4337-8546-8707339279DA}"/>
               </a:ext>
             </a:extLst>
           </p:cNvPr>
@@ -1778,7 +1778,7 @@
           <p:cNvPr id="2" name="Subtitle">
             <a:extLst xmlns:a="http://schemas.openxmlformats.org/drawingml/2006/main">
               <a:ext uri="{FF2B5EF4-FFF2-40B4-BE49-F238E27FC236}">
-                <a16:creationId xmlns:a16="http://schemas.microsoft.com/office/drawing/2014/main" id="{E93F7796-6D51-43E3-8969-DD650C5CD3F5}"/>
+                <a16:creationId xmlns:a16="http://schemas.microsoft.com/office/drawing/2014/main" id="{AD5BF009-84C8-4DEC-97A3-50D4AB170160}"/>
               </a:ext>
             </a:extLst>
           </p:cNvPr>
@@ -2024,7 +2024,7 @@
           <p:cNvPr id="2" name="Section title">
             <a:extLst xmlns:a="http://schemas.openxmlformats.org/drawingml/2006/main">
               <a:ext uri="{FF2B5EF4-FFF2-40B4-BE49-F238E27FC236}">
-                <a16:creationId xmlns:a16="http://schemas.microsoft.com/office/drawing/2014/main" id="{F219E63E-8C45-43FF-9AF0-74B7BB1D891F}"/>
+                <a16:creationId xmlns:a16="http://schemas.microsoft.com/office/drawing/2014/main" id="{E5C8598C-FAAD-4C8E-9310-256ACD6AAD0B}"/>
               </a:ext>
             </a:extLst>
           </p:cNvPr>
@@ -2270,7 +2270,7 @@
           <p:cNvPr id="3" name="Title">
             <a:extLst xmlns:a="http://schemas.openxmlformats.org/drawingml/2006/main">
               <a:ext uri="{FF2B5EF4-FFF2-40B4-BE49-F238E27FC236}">
-                <a16:creationId xmlns:a16="http://schemas.microsoft.com/office/drawing/2014/main" id="{6CE227A1-60E2-46A0-8C03-B73DA4BCD9AA}"/>
+                <a16:creationId xmlns:a16="http://schemas.microsoft.com/office/drawing/2014/main" id="{4B9DF5A9-54D7-4A3B-9A55-15D420065F94}"/>
               </a:ext>
             </a:extLst>
           </p:cNvPr>
@@ -2499,7 +2499,7 @@
           <p:cNvPr id="2" name="Body">
             <a:extLst xmlns:a="http://schemas.openxmlformats.org/drawingml/2006/main">
               <a:ext uri="{FF2B5EF4-FFF2-40B4-BE49-F238E27FC236}">
-                <a16:creationId xmlns:a16="http://schemas.microsoft.com/office/drawing/2014/main" id="{D75DDF14-3CB4-4888-89FA-54099A413F42}"/>
+                <a16:creationId xmlns:a16="http://schemas.microsoft.com/office/drawing/2014/main" id="{7160F0B8-2161-4057-85BC-C937818E6686}"/>
               </a:ext>
             </a:extLst>
           </p:cNvPr>
@@ -2745,7 +2745,7 @@
           <p:cNvPr id="4" name="Title">
             <a:extLst xmlns:a="http://schemas.openxmlformats.org/drawingml/2006/main">
               <a:ext uri="{FF2B5EF4-FFF2-40B4-BE49-F238E27FC236}">
-                <a16:creationId xmlns:a16="http://schemas.microsoft.com/office/drawing/2014/main" id="{829EEE72-9434-4C42-8964-B277CA6E8CF4}"/>
+                <a16:creationId xmlns:a16="http://schemas.microsoft.com/office/drawing/2014/main" id="{3045B9A8-5734-4D86-B2D9-D7761ECA4102}"/>
               </a:ext>
             </a:extLst>
           </p:cNvPr>
@@ -2974,7 +2974,7 @@
           <p:cNvPr id="2" name="Left column">
             <a:extLst xmlns:a="http://schemas.openxmlformats.org/drawingml/2006/main">
               <a:ext uri="{FF2B5EF4-FFF2-40B4-BE49-F238E27FC236}">
-                <a16:creationId xmlns:a16="http://schemas.microsoft.com/office/drawing/2014/main" id="{6A8E6E2C-8DFC-4CCF-B9DD-8714B8804525}"/>
+                <a16:creationId xmlns:a16="http://schemas.microsoft.com/office/drawing/2014/main" id="{477D2F0D-684E-4D09-95CB-8833D5753831}"/>
               </a:ext>
             </a:extLst>
           </p:cNvPr>
@@ -3203,7 +3203,7 @@
           <p:cNvPr id="3" name="Right column">
             <a:extLst xmlns:a="http://schemas.openxmlformats.org/drawingml/2006/main">
               <a:ext uri="{FF2B5EF4-FFF2-40B4-BE49-F238E27FC236}">
-                <a16:creationId xmlns:a16="http://schemas.microsoft.com/office/drawing/2014/main" id="{4278DE56-84E9-4202-B9B2-9D89D2C925BC}"/>
+                <a16:creationId xmlns:a16="http://schemas.microsoft.com/office/drawing/2014/main" id="{185AF445-C131-48F0-84C3-F8A5807E9624}"/>
               </a:ext>
             </a:extLst>
           </p:cNvPr>
@@ -3449,7 +3449,7 @@
           <p:cNvPr id="3" name="Title">
             <a:extLst xmlns:a="http://schemas.openxmlformats.org/drawingml/2006/main">
               <a:ext uri="{FF2B5EF4-FFF2-40B4-BE49-F238E27FC236}">
-                <a16:creationId xmlns:a16="http://schemas.microsoft.com/office/drawing/2014/main" id="{D1F11089-519F-4F8F-B185-67488B720512}"/>
+                <a16:creationId xmlns:a16="http://schemas.microsoft.com/office/drawing/2014/main" id="{206E28C4-DE41-47C5-AD13-C17F7AAFB393}"/>
               </a:ext>
             </a:extLst>
           </p:cNvPr>
@@ -3678,7 +3678,7 @@
           <p:cNvPr id="2" name="Left column">
             <a:extLst xmlns:a="http://schemas.openxmlformats.org/drawingml/2006/main">
               <a:ext uri="{FF2B5EF4-FFF2-40B4-BE49-F238E27FC236}">
-                <a16:creationId xmlns:a16="http://schemas.microsoft.com/office/drawing/2014/main" id="{4163FC55-18EA-413C-A5C1-0F072D323CCA}"/>
+                <a16:creationId xmlns:a16="http://schemas.microsoft.com/office/drawing/2014/main" id="{6716925A-8C92-467B-AF92-33C242633675}"/>
               </a:ext>
             </a:extLst>
           </p:cNvPr>
@@ -3945,12 +3945,12 @@
   </p:cSld>
   <p:clrMap bg1="lt1" tx1="dk1" bg2="lt2" tx2="dk2" accent1="accent1" accent2="accent2" accent3="accent3" accent4="accent4" accent5="accent5" accent6="accent6" hlink="hlink" folHlink="folHlink"/>
   <p:sldLayoutIdLst>
-    <p:sldLayoutId xmlns:r="http://schemas.openxmlformats.org/officeDocument/2006/relationships" id="2147483649" r:id="Rd49d7f49a1724110"/>
-    <p:sldLayoutId xmlns:r="http://schemas.openxmlformats.org/officeDocument/2006/relationships" id="2147483650" r:id="Rcab3d241e4724e97"/>
-    <p:sldLayoutId xmlns:r="http://schemas.openxmlformats.org/officeDocument/2006/relationships" id="2147483651" r:id="Re74be2f472a443d9"/>
-    <p:sldLayoutId xmlns:r="http://schemas.openxmlformats.org/officeDocument/2006/relationships" id="2147483652" r:id="Ra3ea5aea37f449a0"/>
-    <p:sldLayoutId xmlns:r="http://schemas.openxmlformats.org/officeDocument/2006/relationships" id="2147483653" r:id="R3c527b364c8a4864"/>
-    <p:sldLayoutId xmlns:r="http://schemas.openxmlformats.org/officeDocument/2006/relationships" id="2147483654" r:id="R1ecb9041d932437b"/>
+    <p:sldLayoutId xmlns:r="http://schemas.openxmlformats.org/officeDocument/2006/relationships" id="2147483649" r:id="Rebeeaeaf1dd04382"/>
+    <p:sldLayoutId xmlns:r="http://schemas.openxmlformats.org/officeDocument/2006/relationships" id="2147483650" r:id="R08c7c02e24af4c7c"/>
+    <p:sldLayoutId xmlns:r="http://schemas.openxmlformats.org/officeDocument/2006/relationships" id="2147483651" r:id="R455dfc98caf849f3"/>
+    <p:sldLayoutId xmlns:r="http://schemas.openxmlformats.org/officeDocument/2006/relationships" id="2147483652" r:id="Ra4470d83d5fc49f3"/>
+    <p:sldLayoutId xmlns:r="http://schemas.openxmlformats.org/officeDocument/2006/relationships" id="2147483653" r:id="Rc967ae79e226438c"/>
+    <p:sldLayoutId xmlns:r="http://schemas.openxmlformats.org/officeDocument/2006/relationships" id="2147483654" r:id="R6e912c3354604b04"/>
   </p:sldLayoutIdLst>
   <p:txStyles>
     <p:titleStyle>
@@ -5273,7 +5273,7 @@
           <p:cNvPr id="8" name="">
             <a:extLst xmlns:a="http://schemas.openxmlformats.org/drawingml/2006/main">
               <a:ext uri="{FF2B5EF4-FFF2-40B4-BE49-F238E27FC236}">
-                <a16:creationId xmlns:a16="http://schemas.microsoft.com/office/drawing/2014/main" id="{2931C739-C2B7-49E5-B3CD-899CDA50F3AA}"/>
+                <a16:creationId xmlns:a16="http://schemas.microsoft.com/office/drawing/2014/main" id="{61DE2131-48A5-4E47-B050-97CD3EC14902}"/>
               </a:ext>
             </a:extLst>
           </p:cNvPr>
@@ -5430,7 +5430,7 @@
           <p:cNvPr id="2" name="">
             <a:extLst xmlns:a="http://schemas.openxmlformats.org/drawingml/2006/main">
               <a:ext uri="{FF2B5EF4-FFF2-40B4-BE49-F238E27FC236}">
-                <a16:creationId xmlns:a16="http://schemas.microsoft.com/office/drawing/2014/main" id="{3221FB87-B28F-4710-9DE5-7553F59775B1}"/>
+                <a16:creationId xmlns:a16="http://schemas.microsoft.com/office/drawing/2014/main" id="{51739359-DE02-4D74-B803-100B8C2820A7}"/>
               </a:ext>
             </a:extLst>
           </p:cNvPr>
@@ -5461,7 +5461,7 @@
           <p:cNvPr id="3" name="">
             <a:extLst xmlns:a="http://schemas.openxmlformats.org/drawingml/2006/main">
               <a:ext uri="{FF2B5EF4-FFF2-40B4-BE49-F238E27FC236}">
-                <a16:creationId xmlns:a16="http://schemas.microsoft.com/office/drawing/2014/main" id="{1FE26197-898D-40E8-9296-7982D0160539}"/>
+                <a16:creationId xmlns:a16="http://schemas.microsoft.com/office/drawing/2014/main" id="{0ABEC04D-DAB8-430E-A6AD-BDBBE75057BC}"/>
               </a:ext>
             </a:extLst>
           </p:cNvPr>
@@ -5618,7 +5618,7 @@
           <p:cNvPr id="4" name="">
             <a:extLst xmlns:a="http://schemas.openxmlformats.org/drawingml/2006/main">
               <a:ext uri="{FF2B5EF4-FFF2-40B4-BE49-F238E27FC236}">
-                <a16:creationId xmlns:a16="http://schemas.microsoft.com/office/drawing/2014/main" id="{207F3C4B-84F9-4C4E-9CB6-955249D69589}"/>
+                <a16:creationId xmlns:a16="http://schemas.microsoft.com/office/drawing/2014/main" id="{71A35658-B7B1-450B-B8F5-3D138D807265}"/>
               </a:ext>
             </a:extLst>
           </p:cNvPr>
@@ -5775,7 +5775,7 @@
           <p:cNvPr id="5" name="">
             <a:extLst xmlns:a="http://schemas.openxmlformats.org/drawingml/2006/main">
               <a:ext uri="{FF2B5EF4-FFF2-40B4-BE49-F238E27FC236}">
-                <a16:creationId xmlns:a16="http://schemas.microsoft.com/office/drawing/2014/main" id="{FAF571CA-0CE3-4D98-8139-958A257F3AD8}"/>
+                <a16:creationId xmlns:a16="http://schemas.microsoft.com/office/drawing/2014/main" id="{59C98795-4483-43A8-B07B-CEDCC0CD2D2B}"/>
               </a:ext>
             </a:extLst>
           </p:cNvPr>
@@ -5955,7 +5955,7 @@
           <p:cNvPr id="6" name="">
             <a:extLst xmlns:a="http://schemas.openxmlformats.org/drawingml/2006/main">
               <a:ext uri="{FF2B5EF4-FFF2-40B4-BE49-F238E27FC236}">
-                <a16:creationId xmlns:a16="http://schemas.microsoft.com/office/drawing/2014/main" id="{32FD49FE-90AC-45AB-B405-D55ECDE8E289}"/>
+                <a16:creationId xmlns:a16="http://schemas.microsoft.com/office/drawing/2014/main" id="{A76882A7-0856-4069-9716-CCC7FDDA99C8}"/>
               </a:ext>
             </a:extLst>
           </p:cNvPr>
@@ -6112,7 +6112,7 @@
           <p:cNvPr id="7" name="">
             <a:extLst xmlns:a="http://schemas.openxmlformats.org/drawingml/2006/main">
               <a:ext uri="{FF2B5EF4-FFF2-40B4-BE49-F238E27FC236}">
-                <a16:creationId xmlns:a16="http://schemas.microsoft.com/office/drawing/2014/main" id="{A551D15F-58CA-49A8-9624-CF8342026496}"/>
+                <a16:creationId xmlns:a16="http://schemas.microsoft.com/office/drawing/2014/main" id="{3CC734E7-4672-4968-889B-08A25F7BB9C6}"/>
               </a:ext>
             </a:extLst>
           </p:cNvPr>
@@ -6267,7 +6267,7 @@
     </p:spTree>
     <p:extLst>
       <p:ext uri="{BB962C8B-B14F-4D97-AF65-F5344CB8AC3E}">
-        <p14:creationId xmlns:p14="http://schemas.microsoft.com/office/powerpoint/2010/main" val="76454812"/>
+        <p14:creationId xmlns:p14="http://schemas.microsoft.com/office/powerpoint/2010/main" val="1675780396"/>
       </p:ext>
     </p:extLst>
   </p:cSld>
@@ -6298,7 +6298,7 @@
           <p:cNvPr id="9" name="">
             <a:extLst xmlns:a="http://schemas.openxmlformats.org/drawingml/2006/main">
               <a:ext uri="{FF2B5EF4-FFF2-40B4-BE49-F238E27FC236}">
-                <a16:creationId xmlns:a16="http://schemas.microsoft.com/office/drawing/2014/main" id="{F65F2614-3411-4836-9D5F-01720F1AAFD6}"/>
+                <a16:creationId xmlns:a16="http://schemas.microsoft.com/office/drawing/2014/main" id="{F8581C0D-9D54-406E-A5BC-9A7136BF4F3C}"/>
               </a:ext>
             </a:extLst>
           </p:cNvPr>
@@ -6455,7 +6455,7 @@
           <p:cNvPr id="2" name="">
             <a:extLst xmlns:a="http://schemas.openxmlformats.org/drawingml/2006/main">
               <a:ext uri="{FF2B5EF4-FFF2-40B4-BE49-F238E27FC236}">
-                <a16:creationId xmlns:a16="http://schemas.microsoft.com/office/drawing/2014/main" id="{82C598B6-3E05-4218-ACF4-00BBE5F7CBB8}"/>
+                <a16:creationId xmlns:a16="http://schemas.microsoft.com/office/drawing/2014/main" id="{9A8792D2-62F5-4658-ADC0-1F1AA787C46C}"/>
               </a:ext>
             </a:extLst>
           </p:cNvPr>
@@ -6486,7 +6486,7 @@
           <p:cNvPr id="3" name="">
             <a:extLst xmlns:a="http://schemas.openxmlformats.org/drawingml/2006/main">
               <a:ext uri="{FF2B5EF4-FFF2-40B4-BE49-F238E27FC236}">
-                <a16:creationId xmlns:a16="http://schemas.microsoft.com/office/drawing/2014/main" id="{3C3ECF62-E3D2-42A0-98BB-8FEBED43909F}"/>
+                <a16:creationId xmlns:a16="http://schemas.microsoft.com/office/drawing/2014/main" id="{B51BDA9C-70B9-407F-BA1A-5CCF4162BD7C}"/>
               </a:ext>
             </a:extLst>
           </p:cNvPr>
@@ -6643,7 +6643,7 @@
           <p:cNvPr id="4" name="Chart">
             <a:extLst xmlns:a="http://schemas.openxmlformats.org/drawingml/2006/main">
               <a:ext uri="{FF2B5EF4-FFF2-40B4-BE49-F238E27FC236}">
-                <a16:creationId xmlns:a16="http://schemas.microsoft.com/office/drawing/2014/main" id="{97E87B18-1996-407D-83EE-D67A6CE25578}"/>
+                <a16:creationId xmlns:a16="http://schemas.microsoft.com/office/drawing/2014/main" id="{E7BB5A51-C31F-4E2A-864D-B8A22DAA26A4}"/>
               </a:ext>
             </a:extLst>
           </p:cNvPr>
@@ -6656,7 +6656,7 @@
         </p:xfrm>
         <a:graphic xmlns:a="http://schemas.openxmlformats.org/drawingml/2006/main">
           <a:graphicData uri="http://schemas.openxmlformats.org/drawingml/2006/chart">
-            <c:chart xmlns:r="http://schemas.openxmlformats.org/officeDocument/2006/relationships" xmlns:c="http://schemas.openxmlformats.org/drawingml/2006/chart" r:id="R2ef3791c139d4645"/>
+            <c:chart xmlns:r="http://schemas.openxmlformats.org/officeDocument/2006/relationships" xmlns:c="http://schemas.openxmlformats.org/drawingml/2006/chart" r:id="Rd718d523413242cd"/>
           </a:graphicData>
         </a:graphic>
       </p:graphicFrame>
@@ -6665,7 +6665,7 @@
           <p:cNvPr id="5" name="">
             <a:extLst xmlns:a="http://schemas.openxmlformats.org/drawingml/2006/main">
               <a:ext uri="{FF2B5EF4-FFF2-40B4-BE49-F238E27FC236}">
-                <a16:creationId xmlns:a16="http://schemas.microsoft.com/office/drawing/2014/main" id="{8EE470E3-3192-4A9C-966C-893F3F75A701}"/>
+                <a16:creationId xmlns:a16="http://schemas.microsoft.com/office/drawing/2014/main" id="{9E65921B-B821-481E-8394-67B371A86205}"/>
               </a:ext>
             </a:extLst>
           </p:cNvPr>
@@ -6822,7 +6822,7 @@
           <p:cNvPr id="6" name="">
             <a:extLst xmlns:a="http://schemas.openxmlformats.org/drawingml/2006/main">
               <a:ext uri="{FF2B5EF4-FFF2-40B4-BE49-F238E27FC236}">
-                <a16:creationId xmlns:a16="http://schemas.microsoft.com/office/drawing/2014/main" id="{8B8C4C42-4C19-4E5C-8874-6AB1908B12E7}"/>
+                <a16:creationId xmlns:a16="http://schemas.microsoft.com/office/drawing/2014/main" id="{8172B635-7605-4FFC-BDE3-2DF6967A85FE}"/>
               </a:ext>
             </a:extLst>
           </p:cNvPr>
@@ -7053,7 +7053,7 @@
           <p:cNvPr id="7" name="">
             <a:extLst xmlns:a="http://schemas.openxmlformats.org/drawingml/2006/main">
               <a:ext uri="{FF2B5EF4-FFF2-40B4-BE49-F238E27FC236}">
-                <a16:creationId xmlns:a16="http://schemas.microsoft.com/office/drawing/2014/main" id="{E9993840-146A-4C43-94E9-E25BD05A5E4F}"/>
+                <a16:creationId xmlns:a16="http://schemas.microsoft.com/office/drawing/2014/main" id="{E0AF0C83-5CFE-4459-87F0-E8ADCE0C1AAF}"/>
               </a:ext>
             </a:extLst>
           </p:cNvPr>
@@ -7233,7 +7233,7 @@
           <p:cNvPr id="8" name="">
             <a:extLst xmlns:a="http://schemas.openxmlformats.org/drawingml/2006/main">
               <a:ext uri="{FF2B5EF4-FFF2-40B4-BE49-F238E27FC236}">
-                <a16:creationId xmlns:a16="http://schemas.microsoft.com/office/drawing/2014/main" id="{EB9B561B-2A06-44B6-8B82-171386CDDBBB}"/>
+                <a16:creationId xmlns:a16="http://schemas.microsoft.com/office/drawing/2014/main" id="{860BDED1-9C5F-47D6-B963-B7A1CF79488E}"/>
               </a:ext>
             </a:extLst>
           </p:cNvPr>
@@ -7388,7 +7388,7 @@
     </p:spTree>
     <p:extLst>
       <p:ext uri="{BB962C8B-B14F-4D97-AF65-F5344CB8AC3E}">
-        <p14:creationId xmlns:p14="http://schemas.microsoft.com/office/powerpoint/2010/main" val="185808069"/>
+        <p14:creationId xmlns:p14="http://schemas.microsoft.com/office/powerpoint/2010/main" val="1978658533"/>
       </p:ext>
     </p:extLst>
   </p:cSld>
@@ -7419,7 +7419,7 @@
           <p:cNvPr id="9" name="">
             <a:extLst xmlns:a="http://schemas.openxmlformats.org/drawingml/2006/main">
               <a:ext uri="{FF2B5EF4-FFF2-40B4-BE49-F238E27FC236}">
-                <a16:creationId xmlns:a16="http://schemas.microsoft.com/office/drawing/2014/main" id="{EF3F067F-6045-4DFA-B723-D133CC9D6369}"/>
+                <a16:creationId xmlns:a16="http://schemas.microsoft.com/office/drawing/2014/main" id="{EFEE2C31-3030-47B0-84D2-FC30DCA3BDE1}"/>
               </a:ext>
             </a:extLst>
           </p:cNvPr>
@@ -7576,7 +7576,7 @@
           <p:cNvPr id="2" name="">
             <a:extLst xmlns:a="http://schemas.openxmlformats.org/drawingml/2006/main">
               <a:ext uri="{FF2B5EF4-FFF2-40B4-BE49-F238E27FC236}">
-                <a16:creationId xmlns:a16="http://schemas.microsoft.com/office/drawing/2014/main" id="{F7049228-3306-439B-BFD1-E1CDF6B722FE}"/>
+                <a16:creationId xmlns:a16="http://schemas.microsoft.com/office/drawing/2014/main" id="{B7EC99B5-D270-4EB5-BC92-EBE242089CB0}"/>
               </a:ext>
             </a:extLst>
           </p:cNvPr>
@@ -7607,7 +7607,7 @@
           <p:cNvPr id="3" name="">
             <a:extLst xmlns:a="http://schemas.openxmlformats.org/drawingml/2006/main">
               <a:ext uri="{FF2B5EF4-FFF2-40B4-BE49-F238E27FC236}">
-                <a16:creationId xmlns:a16="http://schemas.microsoft.com/office/drawing/2014/main" id="{7B0F8D21-8F36-44CC-935B-B33937FBA78C}"/>
+                <a16:creationId xmlns:a16="http://schemas.microsoft.com/office/drawing/2014/main" id="{EBC7367A-4A27-4D1F-AE63-8A02DD29884F}"/>
               </a:ext>
             </a:extLst>
           </p:cNvPr>
@@ -7764,7 +7764,7 @@
           <p:cNvPr id="4" name="">
             <a:extLst xmlns:a="http://schemas.openxmlformats.org/drawingml/2006/main">
               <a:ext uri="{FF2B5EF4-FFF2-40B4-BE49-F238E27FC236}">
-                <a16:creationId xmlns:a16="http://schemas.microsoft.com/office/drawing/2014/main" id="{7F1874AC-F606-4A9C-81E5-0AE60D783C44}"/>
+                <a16:creationId xmlns:a16="http://schemas.microsoft.com/office/drawing/2014/main" id="{E4AD5BA2-0080-44E9-B179-62D72B8CF9CE}"/>
               </a:ext>
             </a:extLst>
           </p:cNvPr>
@@ -7921,7 +7921,7 @@
           <p:cNvPr id="5" name="">
             <a:extLst xmlns:a="http://schemas.openxmlformats.org/drawingml/2006/main">
               <a:ext uri="{FF2B5EF4-FFF2-40B4-BE49-F238E27FC236}">
-                <a16:creationId xmlns:a16="http://schemas.microsoft.com/office/drawing/2014/main" id="{C0A4A5C3-1B36-48C4-89D2-59953917B14F}"/>
+                <a16:creationId xmlns:a16="http://schemas.microsoft.com/office/drawing/2014/main" id="{A99CF495-418B-4B01-A459-C2E1291B2D84}"/>
               </a:ext>
             </a:extLst>
           </p:cNvPr>
@@ -8147,7 +8147,7 @@
           <p:cNvPr id="6" name="">
             <a:extLst xmlns:a="http://schemas.openxmlformats.org/drawingml/2006/main">
               <a:ext uri="{FF2B5EF4-FFF2-40B4-BE49-F238E27FC236}">
-                <a16:creationId xmlns:a16="http://schemas.microsoft.com/office/drawing/2014/main" id="{C94233A3-8AD3-4A90-B505-CC313360159F}"/>
+                <a16:creationId xmlns:a16="http://schemas.microsoft.com/office/drawing/2014/main" id="{15354239-8553-4ACB-BED4-ADDF58BA92BA}"/>
               </a:ext>
             </a:extLst>
           </p:cNvPr>
@@ -8304,7 +8304,7 @@
           <p:cNvPr id="7" name="">
             <a:extLst xmlns:a="http://schemas.openxmlformats.org/drawingml/2006/main">
               <a:ext uri="{FF2B5EF4-FFF2-40B4-BE49-F238E27FC236}">
-                <a16:creationId xmlns:a16="http://schemas.microsoft.com/office/drawing/2014/main" id="{3F440BE6-EE5C-4DED-9F73-65A9980572D7}"/>
+                <a16:creationId xmlns:a16="http://schemas.microsoft.com/office/drawing/2014/main" id="{807B9610-149C-4A5E-8C1E-3CB04F3811CD}"/>
               </a:ext>
             </a:extLst>
           </p:cNvPr>
@@ -8530,7 +8530,7 @@
           <p:cNvPr id="8" name="">
             <a:extLst xmlns:a="http://schemas.openxmlformats.org/drawingml/2006/main">
               <a:ext uri="{FF2B5EF4-FFF2-40B4-BE49-F238E27FC236}">
-                <a16:creationId xmlns:a16="http://schemas.microsoft.com/office/drawing/2014/main" id="{F39B4CF7-2700-469B-836A-11DB528A71DF}"/>
+                <a16:creationId xmlns:a16="http://schemas.microsoft.com/office/drawing/2014/main" id="{C85883D3-5395-4547-A511-8821A14E3F4B}"/>
               </a:ext>
             </a:extLst>
           </p:cNvPr>
@@ -8685,7 +8685,7 @@
     </p:spTree>
     <p:extLst>
       <p:ext uri="{BB962C8B-B14F-4D97-AF65-F5344CB8AC3E}">
-        <p14:creationId xmlns:p14="http://schemas.microsoft.com/office/powerpoint/2010/main" val="250166249"/>
+        <p14:creationId xmlns:p14="http://schemas.microsoft.com/office/powerpoint/2010/main" val="385360529"/>
       </p:ext>
     </p:extLst>
   </p:cSld>
@@ -8716,7 +8716,7 @@
           <p:cNvPr id="20" name="">
             <a:extLst xmlns:a="http://schemas.openxmlformats.org/drawingml/2006/main">
               <a:ext uri="{FF2B5EF4-FFF2-40B4-BE49-F238E27FC236}">
-                <a16:creationId xmlns:a16="http://schemas.microsoft.com/office/drawing/2014/main" id="{F771DE65-3C3D-4D45-8F55-43BFB1811946}"/>
+                <a16:creationId xmlns:a16="http://schemas.microsoft.com/office/drawing/2014/main" id="{6777DFFD-B63C-4E45-A272-49123FD8B41B}"/>
               </a:ext>
             </a:extLst>
           </p:cNvPr>
@@ -8873,7 +8873,7 @@
           <p:cNvPr id="2" name="">
             <a:extLst xmlns:a="http://schemas.openxmlformats.org/drawingml/2006/main">
               <a:ext uri="{FF2B5EF4-FFF2-40B4-BE49-F238E27FC236}">
-                <a16:creationId xmlns:a16="http://schemas.microsoft.com/office/drawing/2014/main" id="{3430B949-20C8-4A49-8CE5-FACF6447B538}"/>
+                <a16:creationId xmlns:a16="http://schemas.microsoft.com/office/drawing/2014/main" id="{01C31A0B-D5D6-4D49-A7C9-E9152C6D6E73}"/>
               </a:ext>
             </a:extLst>
           </p:cNvPr>
@@ -8904,7 +8904,7 @@
           <p:cNvPr id="3" name="">
             <a:extLst xmlns:a="http://schemas.openxmlformats.org/drawingml/2006/main">
               <a:ext uri="{FF2B5EF4-FFF2-40B4-BE49-F238E27FC236}">
-                <a16:creationId xmlns:a16="http://schemas.microsoft.com/office/drawing/2014/main" id="{696E88C2-E0E7-490B-B5EC-B29DC39226A1}"/>
+                <a16:creationId xmlns:a16="http://schemas.microsoft.com/office/drawing/2014/main" id="{B1EF5656-A7AD-4B43-9ECC-027B3543A45B}"/>
               </a:ext>
             </a:extLst>
           </p:cNvPr>
@@ -9061,7 +9061,7 @@
           <p:cNvPr id="4" name="">
             <a:extLst xmlns:a="http://schemas.openxmlformats.org/drawingml/2006/main">
               <a:ext uri="{FF2B5EF4-FFF2-40B4-BE49-F238E27FC236}">
-                <a16:creationId xmlns:a16="http://schemas.microsoft.com/office/drawing/2014/main" id="{1010AC2A-E606-4A9C-BBF2-A7073C6F1C6F}"/>
+                <a16:creationId xmlns:a16="http://schemas.microsoft.com/office/drawing/2014/main" id="{FCC6D045-0CD3-44A5-933D-8BC28645FB1F}"/>
               </a:ext>
             </a:extLst>
           </p:cNvPr>
@@ -9218,7 +9218,7 @@
           <p:cNvPr id="5" name="">
             <a:extLst xmlns:a="http://schemas.openxmlformats.org/drawingml/2006/main">
               <a:ext uri="{FF2B5EF4-FFF2-40B4-BE49-F238E27FC236}">
-                <a16:creationId xmlns:a16="http://schemas.microsoft.com/office/drawing/2014/main" id="{3486F0F7-D043-49F2-9644-030EFE352F82}"/>
+                <a16:creationId xmlns:a16="http://schemas.microsoft.com/office/drawing/2014/main" id="{64B9D309-56DF-47E9-ADFE-F3866A282927}"/>
               </a:ext>
             </a:extLst>
           </p:cNvPr>
@@ -9375,7 +9375,7 @@
           <p:cNvPr id="6" name="">
             <a:extLst xmlns:a="http://schemas.openxmlformats.org/drawingml/2006/main">
               <a:ext uri="{FF2B5EF4-FFF2-40B4-BE49-F238E27FC236}">
-                <a16:creationId xmlns:a16="http://schemas.microsoft.com/office/drawing/2014/main" id="{C1B4F601-6289-4FF3-9E11-0EBB7EA9E3AE}"/>
+                <a16:creationId xmlns:a16="http://schemas.microsoft.com/office/drawing/2014/main" id="{46FC94BF-D1F4-4DEA-9827-ED58837EBD04}"/>
               </a:ext>
             </a:extLst>
           </p:cNvPr>
@@ -9532,7 +9532,7 @@
           <p:cNvPr id="7" name="">
             <a:extLst xmlns:a="http://schemas.openxmlformats.org/drawingml/2006/main">
               <a:ext uri="{FF2B5EF4-FFF2-40B4-BE49-F238E27FC236}">
-                <a16:creationId xmlns:a16="http://schemas.microsoft.com/office/drawing/2014/main" id="{55F52CAD-CEE4-4E5E-9E63-CE4B7ACE9587}"/>
+                <a16:creationId xmlns:a16="http://schemas.microsoft.com/office/drawing/2014/main" id="{25B7B12C-723D-49A9-9CEB-D450D1AF429B}"/>
               </a:ext>
             </a:extLst>
           </p:cNvPr>
@@ -9563,7 +9563,7 @@
           <p:cNvPr id="8" name="">
             <a:extLst xmlns:a="http://schemas.openxmlformats.org/drawingml/2006/main">
               <a:ext uri="{FF2B5EF4-FFF2-40B4-BE49-F238E27FC236}">
-                <a16:creationId xmlns:a16="http://schemas.microsoft.com/office/drawing/2014/main" id="{4C30EA8B-73DD-463B-BC2E-6A3C3072EFA5}"/>
+                <a16:creationId xmlns:a16="http://schemas.microsoft.com/office/drawing/2014/main" id="{53060440-9B6C-4840-9FBB-CB982E51EF30}"/>
               </a:ext>
             </a:extLst>
           </p:cNvPr>
@@ -9720,7 +9720,7 @@
           <p:cNvPr id="9" name="">
             <a:extLst xmlns:a="http://schemas.openxmlformats.org/drawingml/2006/main">
               <a:ext uri="{FF2B5EF4-FFF2-40B4-BE49-F238E27FC236}">
-                <a16:creationId xmlns:a16="http://schemas.microsoft.com/office/drawing/2014/main" id="{2C787E27-072A-41E3-94DA-1960405A61DE}"/>
+                <a16:creationId xmlns:a16="http://schemas.microsoft.com/office/drawing/2014/main" id="{075FC094-FB8B-4A4F-AECB-E01D0C1AC510}"/>
               </a:ext>
             </a:extLst>
           </p:cNvPr>
@@ -9877,7 +9877,7 @@
           <p:cNvPr id="10" name="">
             <a:extLst xmlns:a="http://schemas.openxmlformats.org/drawingml/2006/main">
               <a:ext uri="{FF2B5EF4-FFF2-40B4-BE49-F238E27FC236}">
-                <a16:creationId xmlns:a16="http://schemas.microsoft.com/office/drawing/2014/main" id="{1F14217A-BCE9-46C0-B1AF-5F689652D8FF}"/>
+                <a16:creationId xmlns:a16="http://schemas.microsoft.com/office/drawing/2014/main" id="{1A7D89E3-57F6-4267-AA5F-D3219628A0A7}"/>
               </a:ext>
             </a:extLst>
           </p:cNvPr>
@@ -10034,7 +10034,7 @@
           <p:cNvPr id="11" name="">
             <a:extLst xmlns:a="http://schemas.openxmlformats.org/drawingml/2006/main">
               <a:ext uri="{FF2B5EF4-FFF2-40B4-BE49-F238E27FC236}">
-                <a16:creationId xmlns:a16="http://schemas.microsoft.com/office/drawing/2014/main" id="{DF83E6DA-205E-4E47-B884-E99530ACCD18}"/>
+                <a16:creationId xmlns:a16="http://schemas.microsoft.com/office/drawing/2014/main" id="{F00F49B4-C877-422D-8F40-1868F192FF93}"/>
               </a:ext>
             </a:extLst>
           </p:cNvPr>
@@ -10065,7 +10065,7 @@
           <p:cNvPr id="12" name="">
             <a:extLst xmlns:a="http://schemas.openxmlformats.org/drawingml/2006/main">
               <a:ext uri="{FF2B5EF4-FFF2-40B4-BE49-F238E27FC236}">
-                <a16:creationId xmlns:a16="http://schemas.microsoft.com/office/drawing/2014/main" id="{65A63E89-B5CD-4697-B7FD-459388F5EC6F}"/>
+                <a16:creationId xmlns:a16="http://schemas.microsoft.com/office/drawing/2014/main" id="{7AC3B62D-A5C9-4DCC-AD6E-12FFDE922919}"/>
               </a:ext>
             </a:extLst>
           </p:cNvPr>
@@ -10222,7 +10222,7 @@
           <p:cNvPr id="13" name="">
             <a:extLst xmlns:a="http://schemas.openxmlformats.org/drawingml/2006/main">
               <a:ext uri="{FF2B5EF4-FFF2-40B4-BE49-F238E27FC236}">
-                <a16:creationId xmlns:a16="http://schemas.microsoft.com/office/drawing/2014/main" id="{955E6554-4D37-4E8D-9EC3-BDD24B4E31C6}"/>
+                <a16:creationId xmlns:a16="http://schemas.microsoft.com/office/drawing/2014/main" id="{3B4D0DE5-3E0C-4BD0-AAE7-F3136B41F785}"/>
               </a:ext>
             </a:extLst>
           </p:cNvPr>
@@ -10379,7 +10379,7 @@
           <p:cNvPr id="14" name="">
             <a:extLst xmlns:a="http://schemas.openxmlformats.org/drawingml/2006/main">
               <a:ext uri="{FF2B5EF4-FFF2-40B4-BE49-F238E27FC236}">
-                <a16:creationId xmlns:a16="http://schemas.microsoft.com/office/drawing/2014/main" id="{D45C8726-680D-411F-A759-0972EFAEDFD0}"/>
+                <a16:creationId xmlns:a16="http://schemas.microsoft.com/office/drawing/2014/main" id="{FB6F202F-31FB-4739-A76D-A831F08301C6}"/>
               </a:ext>
             </a:extLst>
           </p:cNvPr>
@@ -10536,7 +10536,7 @@
           <p:cNvPr id="15" name="">
             <a:extLst xmlns:a="http://schemas.openxmlformats.org/drawingml/2006/main">
               <a:ext uri="{FF2B5EF4-FFF2-40B4-BE49-F238E27FC236}">
-                <a16:creationId xmlns:a16="http://schemas.microsoft.com/office/drawing/2014/main" id="{0E34FAF6-AB18-4B81-A702-4B093207B495}"/>
+                <a16:creationId xmlns:a16="http://schemas.microsoft.com/office/drawing/2014/main" id="{ED732178-BE91-47F0-BBBB-0CC206FB82B6}"/>
               </a:ext>
             </a:extLst>
           </p:cNvPr>
@@ -10567,7 +10567,7 @@
           <p:cNvPr id="16" name="">
             <a:extLst xmlns:a="http://schemas.openxmlformats.org/drawingml/2006/main">
               <a:ext uri="{FF2B5EF4-FFF2-40B4-BE49-F238E27FC236}">
-                <a16:creationId xmlns:a16="http://schemas.microsoft.com/office/drawing/2014/main" id="{8BE6C259-B9A6-4E77-9B93-1422F870D4E3}"/>
+                <a16:creationId xmlns:a16="http://schemas.microsoft.com/office/drawing/2014/main" id="{4B25404B-8394-4B79-B5F5-28A2B16DE6AD}"/>
               </a:ext>
             </a:extLst>
           </p:cNvPr>
@@ -10724,7 +10724,7 @@
           <p:cNvPr id="17" name="">
             <a:extLst xmlns:a="http://schemas.openxmlformats.org/drawingml/2006/main">
               <a:ext uri="{FF2B5EF4-FFF2-40B4-BE49-F238E27FC236}">
-                <a16:creationId xmlns:a16="http://schemas.microsoft.com/office/drawing/2014/main" id="{99F49FC5-2BFA-4551-9AB0-308B6AA7E71C}"/>
+                <a16:creationId xmlns:a16="http://schemas.microsoft.com/office/drawing/2014/main" id="{83024BD9-96C9-4324-A7F2-95417FE340DC}"/>
               </a:ext>
             </a:extLst>
           </p:cNvPr>
@@ -10881,7 +10881,7 @@
           <p:cNvPr id="18" name="">
             <a:extLst xmlns:a="http://schemas.openxmlformats.org/drawingml/2006/main">
               <a:ext uri="{FF2B5EF4-FFF2-40B4-BE49-F238E27FC236}">
-                <a16:creationId xmlns:a16="http://schemas.microsoft.com/office/drawing/2014/main" id="{6A84CC69-0CF0-49E4-BA8C-670330DEDAFC}"/>
+                <a16:creationId xmlns:a16="http://schemas.microsoft.com/office/drawing/2014/main" id="{8D467B52-50F3-46EB-A1BD-0E408FB31629}"/>
               </a:ext>
             </a:extLst>
           </p:cNvPr>
@@ -11038,7 +11038,7 @@
           <p:cNvPr id="19" name="">
             <a:extLst xmlns:a="http://schemas.openxmlformats.org/drawingml/2006/main">
               <a:ext uri="{FF2B5EF4-FFF2-40B4-BE49-F238E27FC236}">
-                <a16:creationId xmlns:a16="http://schemas.microsoft.com/office/drawing/2014/main" id="{2CC7DAA2-3819-4DD0-9EC6-C1DE866762F9}"/>
+                <a16:creationId xmlns:a16="http://schemas.microsoft.com/office/drawing/2014/main" id="{31D3B1C6-E12F-432A-B56B-812D54070A6C}"/>
               </a:ext>
             </a:extLst>
           </p:cNvPr>
@@ -11193,7 +11193,7 @@
     </p:spTree>
     <p:extLst>
       <p:ext uri="{BB962C8B-B14F-4D97-AF65-F5344CB8AC3E}">
-        <p14:creationId xmlns:p14="http://schemas.microsoft.com/office/powerpoint/2010/main" val="1360634100"/>
+        <p14:creationId xmlns:p14="http://schemas.microsoft.com/office/powerpoint/2010/main" val="1830254580"/>
       </p:ext>
     </p:extLst>
   </p:cSld>
@@ -11224,7 +11224,7 @@
           <p:cNvPr id="19" name="">
             <a:extLst xmlns:a="http://schemas.openxmlformats.org/drawingml/2006/main">
               <a:ext uri="{FF2B5EF4-FFF2-40B4-BE49-F238E27FC236}">
-                <a16:creationId xmlns:a16="http://schemas.microsoft.com/office/drawing/2014/main" id="{1F484A4F-36C6-41C9-AA55-586C2813CE61}"/>
+                <a16:creationId xmlns:a16="http://schemas.microsoft.com/office/drawing/2014/main" id="{C152C74A-171E-466F-A272-A22D37B092AA}"/>
               </a:ext>
             </a:extLst>
           </p:cNvPr>
@@ -11381,7 +11381,7 @@
           <p:cNvPr id="2" name="">
             <a:extLst xmlns:a="http://schemas.openxmlformats.org/drawingml/2006/main">
               <a:ext uri="{FF2B5EF4-FFF2-40B4-BE49-F238E27FC236}">
-                <a16:creationId xmlns:a16="http://schemas.microsoft.com/office/drawing/2014/main" id="{B7D421F5-6E3E-4DA0-94B2-F24651ED889C}"/>
+                <a16:creationId xmlns:a16="http://schemas.microsoft.com/office/drawing/2014/main" id="{6492210F-4D37-4BED-9C13-8C10E0556249}"/>
               </a:ext>
             </a:extLst>
           </p:cNvPr>
@@ -11412,7 +11412,7 @@
           <p:cNvPr id="3" name="">
             <a:extLst xmlns:a="http://schemas.openxmlformats.org/drawingml/2006/main">
               <a:ext uri="{FF2B5EF4-FFF2-40B4-BE49-F238E27FC236}">
-                <a16:creationId xmlns:a16="http://schemas.microsoft.com/office/drawing/2014/main" id="{31AF07CC-8F84-4E2D-93A1-D46D15AB85E3}"/>
+                <a16:creationId xmlns:a16="http://schemas.microsoft.com/office/drawing/2014/main" id="{0407901C-F576-4302-98C5-10FA6CB306B6}"/>
               </a:ext>
             </a:extLst>
           </p:cNvPr>
@@ -11569,7 +11569,7 @@
           <p:cNvPr id="4" name="">
             <a:extLst xmlns:a="http://schemas.openxmlformats.org/drawingml/2006/main">
               <a:ext uri="{FF2B5EF4-FFF2-40B4-BE49-F238E27FC236}">
-                <a16:creationId xmlns:a16="http://schemas.microsoft.com/office/drawing/2014/main" id="{4F5D05E3-74D2-4972-9E7C-7FE1621BEDFB}"/>
+                <a16:creationId xmlns:a16="http://schemas.microsoft.com/office/drawing/2014/main" id="{E83798EC-A922-481A-8507-F81FA2D997AC}"/>
               </a:ext>
             </a:extLst>
           </p:cNvPr>
@@ -11600,7 +11600,7 @@
           <p:cNvPr id="5" name="">
             <a:extLst xmlns:a="http://schemas.openxmlformats.org/drawingml/2006/main">
               <a:ext uri="{FF2B5EF4-FFF2-40B4-BE49-F238E27FC236}">
-                <a16:creationId xmlns:a16="http://schemas.microsoft.com/office/drawing/2014/main" id="{C483E6D5-318C-4730-AACF-9E265A16502E}"/>
+                <a16:creationId xmlns:a16="http://schemas.microsoft.com/office/drawing/2014/main" id="{E91AD153-4BC7-4B63-9116-EA673932740A}"/>
               </a:ext>
             </a:extLst>
           </p:cNvPr>
@@ -11747,7 +11747,7 @@
                 <a:ea typeface="Arial"/>
                 <a:cs typeface="Arial"/>
               </a:rPr>
-              <a:t>OCT 19–21</a:t>
+              <a:t>OCT 13–18</a:t>
             </a:r>
           </a:p>
         </p:txBody>
@@ -11757,7 +11757,7 @@
           <p:cNvPr id="6" name="">
             <a:extLst xmlns:a="http://schemas.openxmlformats.org/drawingml/2006/main">
               <a:ext uri="{FF2B5EF4-FFF2-40B4-BE49-F238E27FC236}">
-                <a16:creationId xmlns:a16="http://schemas.microsoft.com/office/drawing/2014/main" id="{DA427C46-2567-4279-9302-4ECDD2E40ECF}"/>
+                <a16:creationId xmlns:a16="http://schemas.microsoft.com/office/drawing/2014/main" id="{A26A4BA3-320D-4262-828C-65DCC32CB0EC}"/>
               </a:ext>
             </a:extLst>
           </p:cNvPr>
@@ -11788,7 +11788,7 @@
           <p:cNvPr id="7" name="">
             <a:extLst xmlns:a="http://schemas.openxmlformats.org/drawingml/2006/main">
               <a:ext uri="{FF2B5EF4-FFF2-40B4-BE49-F238E27FC236}">
-                <a16:creationId xmlns:a16="http://schemas.microsoft.com/office/drawing/2014/main" id="{80B8158A-AD99-49E1-B358-9E69AF3E76C5}"/>
+                <a16:creationId xmlns:a16="http://schemas.microsoft.com/office/drawing/2014/main" id="{A90A01F2-D42B-4C08-B0B7-64B6C6FB20DB}"/>
               </a:ext>
             </a:extLst>
           </p:cNvPr>
@@ -11935,7 +11935,7 @@
                 <a:ea typeface="Arial"/>
                 <a:cs typeface="Arial"/>
               </a:rPr>
-              <a:t>CRC32 + aha</a:t>
+              <a:t>Traces + synthesis</a:t>
             </a:r>
           </a:p>
           <a:p xmlns:a="http://schemas.openxmlformats.org/drawingml/2006/main">
@@ -11958,7 +11958,7 @@
                 <a:ea typeface="Arial"/>
                 <a:cs typeface="Arial"/>
               </a:rPr>
-              <a:t>working pipeline</a:t>
+              <a:t>early cost models</a:t>
             </a:r>
           </a:p>
         </p:txBody>
@@ -11968,7 +11968,7 @@
           <p:cNvPr id="8" name="">
             <a:extLst xmlns:a="http://schemas.openxmlformats.org/drawingml/2006/main">
               <a:ext uri="{FF2B5EF4-FFF2-40B4-BE49-F238E27FC236}">
-                <a16:creationId xmlns:a16="http://schemas.microsoft.com/office/drawing/2014/main" id="{32BC02A1-4054-484E-B265-9F2DDF81C3EF}"/>
+                <a16:creationId xmlns:a16="http://schemas.microsoft.com/office/drawing/2014/main" id="{F82CCD71-A779-4F7D-96B8-BB8E58772BC4}"/>
               </a:ext>
             </a:extLst>
           </p:cNvPr>
@@ -12115,7 +12115,7 @@
                 <a:ea typeface="Arial"/>
                 <a:cs typeface="Arial"/>
               </a:rPr>
-              <a:t>OCT 22</a:t>
+              <a:t>OCT 19</a:t>
             </a:r>
           </a:p>
         </p:txBody>
@@ -12125,7 +12125,7 @@
           <p:cNvPr id="9" name="">
             <a:extLst xmlns:a="http://schemas.openxmlformats.org/drawingml/2006/main">
               <a:ext uri="{FF2B5EF4-FFF2-40B4-BE49-F238E27FC236}">
-                <a16:creationId xmlns:a16="http://schemas.microsoft.com/office/drawing/2014/main" id="{4CCDF8CC-58D6-4CF9-AF20-C9D5B8BE8551}"/>
+                <a16:creationId xmlns:a16="http://schemas.microsoft.com/office/drawing/2014/main" id="{6C2106CA-1D57-48D9-B66B-6D1AEF3CFF15}"/>
               </a:ext>
             </a:extLst>
           </p:cNvPr>
@@ -12156,7 +12156,7 @@
           <p:cNvPr id="10" name="">
             <a:extLst xmlns:a="http://schemas.openxmlformats.org/drawingml/2006/main">
               <a:ext uri="{FF2B5EF4-FFF2-40B4-BE49-F238E27FC236}">
-                <a16:creationId xmlns:a16="http://schemas.microsoft.com/office/drawing/2014/main" id="{CF3AC0FD-9BD8-4E35-BDF4-8B0F79D34794}"/>
+                <a16:creationId xmlns:a16="http://schemas.microsoft.com/office/drawing/2014/main" id="{D5384057-8533-4AB5-A7AE-D18AE542F772}"/>
               </a:ext>
             </a:extLst>
           </p:cNvPr>
@@ -12303,7 +12303,7 @@
                 <a:ea typeface="Arial"/>
                 <a:cs typeface="Arial"/>
               </a:rPr>
-              <a:t>Cross-workload</a:t>
+              <a:t>CRC32 + aha</a:t>
             </a:r>
           </a:p>
           <a:p xmlns:a="http://schemas.openxmlformats.org/drawingml/2006/main">
@@ -12326,7 +12326,7 @@
                 <a:ea typeface="Arial"/>
                 <a:cs typeface="Arial"/>
               </a:rPr>
-              <a:t>selection tests</a:t>
+              <a:t>processor pipeline</a:t>
             </a:r>
           </a:p>
         </p:txBody>
@@ -12336,7 +12336,7 @@
           <p:cNvPr id="11" name="">
             <a:extLst xmlns:a="http://schemas.openxmlformats.org/drawingml/2006/main">
               <a:ext uri="{FF2B5EF4-FFF2-40B4-BE49-F238E27FC236}">
-                <a16:creationId xmlns:a16="http://schemas.microsoft.com/office/drawing/2014/main" id="{619CBE95-99E1-4874-9CDC-59D8E9D29166}"/>
+                <a16:creationId xmlns:a16="http://schemas.microsoft.com/office/drawing/2014/main" id="{5DE8CEB0-B3F9-40D1-BD18-7417F55F408C}"/>
               </a:ext>
             </a:extLst>
           </p:cNvPr>
@@ -12483,7 +12483,7 @@
                 <a:ea typeface="Arial"/>
                 <a:cs typeface="Arial"/>
               </a:rPr>
-              <a:t>OCT 25–26</a:t>
+              <a:t>OCT 20–26</a:t>
             </a:r>
           </a:p>
         </p:txBody>
@@ -12493,7 +12493,7 @@
           <p:cNvPr id="12" name="">
             <a:extLst xmlns:a="http://schemas.openxmlformats.org/drawingml/2006/main">
               <a:ext uri="{FF2B5EF4-FFF2-40B4-BE49-F238E27FC236}">
-                <a16:creationId xmlns:a16="http://schemas.microsoft.com/office/drawing/2014/main" id="{AA9AF423-E9DD-4CB2-8762-05793A9475B8}"/>
+                <a16:creationId xmlns:a16="http://schemas.microsoft.com/office/drawing/2014/main" id="{419DE4D4-2C84-40D8-AA05-EFF483F7D5EB}"/>
               </a:ext>
             </a:extLst>
           </p:cNvPr>
@@ -12524,7 +12524,7 @@
           <p:cNvPr id="13" name="">
             <a:extLst xmlns:a="http://schemas.openxmlformats.org/drawingml/2006/main">
               <a:ext uri="{FF2B5EF4-FFF2-40B4-BE49-F238E27FC236}">
-                <a16:creationId xmlns:a16="http://schemas.microsoft.com/office/drawing/2014/main" id="{BD4332C4-ECCE-4FC8-8FA5-9AD2AAE0EB32}"/>
+                <a16:creationId xmlns:a16="http://schemas.microsoft.com/office/drawing/2014/main" id="{1F83EFD4-B573-42C5-A0BD-D43C0D8A55E8}"/>
               </a:ext>
             </a:extLst>
           </p:cNvPr>
@@ -12671,7 +12671,7 @@
                 <a:ea typeface="Arial"/>
                 <a:cs typeface="Arial"/>
               </a:rPr>
-              <a:t>Broader corpus</a:t>
+              <a:t>More workloads</a:t>
             </a:r>
           </a:p>
           <a:p xmlns:a="http://schemas.openxmlformats.org/drawingml/2006/main">
@@ -12694,7 +12694,7 @@
                 <a:ea typeface="Arial"/>
                 <a:cs typeface="Arial"/>
               </a:rPr>
-              <a:t>+ agent tools</a:t>
+              <a:t>+ selection tests</a:t>
             </a:r>
           </a:p>
         </p:txBody>
@@ -12704,7 +12704,7 @@
           <p:cNvPr id="14" name="">
             <a:extLst xmlns:a="http://schemas.openxmlformats.org/drawingml/2006/main">
               <a:ext uri="{FF2B5EF4-FFF2-40B4-BE49-F238E27FC236}">
-                <a16:creationId xmlns:a16="http://schemas.microsoft.com/office/drawing/2014/main" id="{4AA6C7CA-15D8-4CE9-A5E9-E7BDE53FAD31}"/>
+                <a16:creationId xmlns:a16="http://schemas.microsoft.com/office/drawing/2014/main" id="{9961CF59-17D9-4C1D-BEB3-C5FE6DBBA8BE}"/>
               </a:ext>
             </a:extLst>
           </p:cNvPr>
@@ -12861,7 +12861,7 @@
           <p:cNvPr id="15" name="">
             <a:extLst xmlns:a="http://schemas.openxmlformats.org/drawingml/2006/main">
               <a:ext uri="{FF2B5EF4-FFF2-40B4-BE49-F238E27FC236}">
-                <a16:creationId xmlns:a16="http://schemas.microsoft.com/office/drawing/2014/main" id="{E542199A-CCEA-44AD-B926-9A64B6E041E0}"/>
+                <a16:creationId xmlns:a16="http://schemas.microsoft.com/office/drawing/2014/main" id="{99860F05-B71C-4532-B2B1-3E1054F8224C}"/>
               </a:ext>
             </a:extLst>
           </p:cNvPr>
@@ -12892,7 +12892,7 @@
           <p:cNvPr id="16" name="">
             <a:extLst xmlns:a="http://schemas.openxmlformats.org/drawingml/2006/main">
               <a:ext uri="{FF2B5EF4-FFF2-40B4-BE49-F238E27FC236}">
-                <a16:creationId xmlns:a16="http://schemas.microsoft.com/office/drawing/2014/main" id="{58F35E30-72FE-4610-B672-74C999BA3316}"/>
+                <a16:creationId xmlns:a16="http://schemas.microsoft.com/office/drawing/2014/main" id="{C3D7A684-43B2-4A53-A6AE-6BA752CEA371}"/>
               </a:ext>
             </a:extLst>
           </p:cNvPr>
@@ -13062,7 +13062,7 @@
                 <a:ea typeface="Arial"/>
                 <a:cs typeface="Arial"/>
               </a:rPr>
-              <a:t>+ Ascon pilot</a:t>
+              <a:t>+ agent pilot</a:t>
             </a:r>
           </a:p>
         </p:txBody>
@@ -13072,7 +13072,7 @@
           <p:cNvPr id="17" name="">
             <a:extLst xmlns:a="http://schemas.openxmlformats.org/drawingml/2006/main">
               <a:ext uri="{FF2B5EF4-FFF2-40B4-BE49-F238E27FC236}">
-                <a16:creationId xmlns:a16="http://schemas.microsoft.com/office/drawing/2014/main" id="{F8C7B588-DE9A-4C0C-866A-04A2700A7689}"/>
+                <a16:creationId xmlns:a16="http://schemas.microsoft.com/office/drawing/2014/main" id="{2DDD3040-8059-412C-8017-C7D2E22BA56C}"/>
               </a:ext>
             </a:extLst>
           </p:cNvPr>
@@ -13432,7 +13432,7 @@
           <p:cNvPr id="18" name="">
             <a:extLst xmlns:a="http://schemas.openxmlformats.org/drawingml/2006/main">
               <a:ext uri="{FF2B5EF4-FFF2-40B4-BE49-F238E27FC236}">
-                <a16:creationId xmlns:a16="http://schemas.microsoft.com/office/drawing/2014/main" id="{67E323D1-4426-438E-B0C8-2DE9D9A65E89}"/>
+                <a16:creationId xmlns:a16="http://schemas.microsoft.com/office/drawing/2014/main" id="{8AD9AA35-5E1C-474C-9C38-75EB70A3FB85}"/>
               </a:ext>
             </a:extLst>
           </p:cNvPr>
@@ -13579,7 +13579,7 @@
                 <a:ea typeface="Arial"/>
                 <a:cs typeface="Arial"/>
               </a:rPr>
-              <a:t>Codex log: ~30 h recorded turn time • team roles require confirmation</a:t>
+              <a:t>Two project chats: ~46 h recorded turn time • roles need confirmation</a:t>
             </a:r>
           </a:p>
         </p:txBody>
@@ -13587,7 +13587,7 @@
     </p:spTree>
     <p:extLst>
       <p:ext uri="{BB962C8B-B14F-4D97-AF65-F5344CB8AC3E}">
-        <p14:creationId xmlns:p14="http://schemas.microsoft.com/office/powerpoint/2010/main" val="2092980561"/>
+        <p14:creationId xmlns:p14="http://schemas.microsoft.com/office/powerpoint/2010/main" val="2058392039"/>
       </p:ext>
     </p:extLst>
   </p:cSld>
@@ -13615,10 +13615,10 @@
       </p:grpSpPr>
       <p:sp>
         <p:nvSpPr>
-          <p:cNvPr id="22" name="">
+          <p:cNvPr id="26" name="">
             <a:extLst xmlns:a="http://schemas.openxmlformats.org/drawingml/2006/main">
               <a:ext uri="{FF2B5EF4-FFF2-40B4-BE49-F238E27FC236}">
-                <a16:creationId xmlns:a16="http://schemas.microsoft.com/office/drawing/2014/main" id="{A0F4AC98-B181-4644-9985-418FBE25F861}"/>
+                <a16:creationId xmlns:a16="http://schemas.microsoft.com/office/drawing/2014/main" id="{9FB38A30-A65A-4A52-B648-2E7D1D19EA53}"/>
               </a:ext>
             </a:extLst>
           </p:cNvPr>
@@ -13775,7 +13775,7 @@
           <p:cNvPr id="2" name="">
             <a:extLst xmlns:a="http://schemas.openxmlformats.org/drawingml/2006/main">
               <a:ext uri="{FF2B5EF4-FFF2-40B4-BE49-F238E27FC236}">
-                <a16:creationId xmlns:a16="http://schemas.microsoft.com/office/drawing/2014/main" id="{BD79EB18-688B-40BD-A45B-5DA07D387555}"/>
+                <a16:creationId xmlns:a16="http://schemas.microsoft.com/office/drawing/2014/main" id="{AB2FEB17-B50C-422E-89BB-7929D12A43F9}"/>
               </a:ext>
             </a:extLst>
           </p:cNvPr>
@@ -13806,7 +13806,7 @@
           <p:cNvPr id="3" name="">
             <a:extLst xmlns:a="http://schemas.openxmlformats.org/drawingml/2006/main">
               <a:ext uri="{FF2B5EF4-FFF2-40B4-BE49-F238E27FC236}">
-                <a16:creationId xmlns:a16="http://schemas.microsoft.com/office/drawing/2014/main" id="{A836D5DF-D454-4E29-87AF-3E8912D37AE9}"/>
+                <a16:creationId xmlns:a16="http://schemas.microsoft.com/office/drawing/2014/main" id="{37C5734D-1D98-46D6-B742-54D17C5E02E9}"/>
               </a:ext>
             </a:extLst>
           </p:cNvPr>
@@ -13963,7 +13963,7 @@
           <p:cNvPr id="4" name="">
             <a:extLst xmlns:a="http://schemas.openxmlformats.org/drawingml/2006/main">
               <a:ext uri="{FF2B5EF4-FFF2-40B4-BE49-F238E27FC236}">
-                <a16:creationId xmlns:a16="http://schemas.microsoft.com/office/drawing/2014/main" id="{F8766D3D-D1EA-4CE0-8FFC-657C9E3AFFF5}"/>
+                <a16:creationId xmlns:a16="http://schemas.microsoft.com/office/drawing/2014/main" id="{C4216A7C-ECC8-49D9-93B7-1D1CEE6AC785}"/>
               </a:ext>
             </a:extLst>
           </p:cNvPr>
@@ -13996,7 +13996,7 @@
           <p:cNvPr id="5" name="">
             <a:extLst xmlns:a="http://schemas.openxmlformats.org/drawingml/2006/main">
               <a:ext uri="{FF2B5EF4-FFF2-40B4-BE49-F238E27FC236}">
-                <a16:creationId xmlns:a16="http://schemas.microsoft.com/office/drawing/2014/main" id="{FF22F2DC-CE8B-4A71-8488-9BA0C881C9A6}"/>
+                <a16:creationId xmlns:a16="http://schemas.microsoft.com/office/drawing/2014/main" id="{9D9D245C-4302-46D6-823D-20C37E15940A}"/>
               </a:ext>
             </a:extLst>
           </p:cNvPr>
@@ -14153,7 +14153,7 @@
           <p:cNvPr id="6" name="">
             <a:extLst xmlns:a="http://schemas.openxmlformats.org/drawingml/2006/main">
               <a:ext uri="{FF2B5EF4-FFF2-40B4-BE49-F238E27FC236}">
-                <a16:creationId xmlns:a16="http://schemas.microsoft.com/office/drawing/2014/main" id="{60862B03-DF5E-4B88-BD78-072DDA3CB3F7}"/>
+                <a16:creationId xmlns:a16="http://schemas.microsoft.com/office/drawing/2014/main" id="{76F960F7-778D-40ED-BD77-D0C81A0EC0B6}"/>
               </a:ext>
             </a:extLst>
           </p:cNvPr>
@@ -14333,7 +14333,7 @@
           <p:cNvPr id="7" name="">
             <a:extLst xmlns:a="http://schemas.openxmlformats.org/drawingml/2006/main">
               <a:ext uri="{FF2B5EF4-FFF2-40B4-BE49-F238E27FC236}">
-                <a16:creationId xmlns:a16="http://schemas.microsoft.com/office/drawing/2014/main" id="{7A784247-8B31-4228-AEF2-73994DF6EEC5}"/>
+                <a16:creationId xmlns:a16="http://schemas.microsoft.com/office/drawing/2014/main" id="{5DF8110E-B894-4202-82F5-17E68BCBE136}"/>
               </a:ext>
             </a:extLst>
           </p:cNvPr>
@@ -14364,7 +14364,7 @@
           <p:cNvPr id="8" name="">
             <a:extLst xmlns:a="http://schemas.openxmlformats.org/drawingml/2006/main">
               <a:ext uri="{FF2B5EF4-FFF2-40B4-BE49-F238E27FC236}">
-                <a16:creationId xmlns:a16="http://schemas.microsoft.com/office/drawing/2014/main" id="{C5D5322A-856B-4819-A6F4-EF33B11E3D4D}"/>
+                <a16:creationId xmlns:a16="http://schemas.microsoft.com/office/drawing/2014/main" id="{261D709A-D70B-43AA-BF1F-4DA01359998E}"/>
               </a:ext>
             </a:extLst>
           </p:cNvPr>
@@ -14397,7 +14397,7 @@
           <p:cNvPr id="9" name="">
             <a:extLst xmlns:a="http://schemas.openxmlformats.org/drawingml/2006/main">
               <a:ext uri="{FF2B5EF4-FFF2-40B4-BE49-F238E27FC236}">
-                <a16:creationId xmlns:a16="http://schemas.microsoft.com/office/drawing/2014/main" id="{41184450-331D-4EBB-B00E-48F30F4E19BF}"/>
+                <a16:creationId xmlns:a16="http://schemas.microsoft.com/office/drawing/2014/main" id="{E2B18B3F-BF0D-438B-8310-EE7A90195696}"/>
               </a:ext>
             </a:extLst>
           </p:cNvPr>
@@ -14554,7 +14554,7 @@
           <p:cNvPr id="10" name="">
             <a:extLst xmlns:a="http://schemas.openxmlformats.org/drawingml/2006/main">
               <a:ext uri="{FF2B5EF4-FFF2-40B4-BE49-F238E27FC236}">
-                <a16:creationId xmlns:a16="http://schemas.microsoft.com/office/drawing/2014/main" id="{4240EF93-D41E-4217-B010-39B15BD871F9}"/>
+                <a16:creationId xmlns:a16="http://schemas.microsoft.com/office/drawing/2014/main" id="{5187E50D-D4D2-4576-A10D-93819F94E31E}"/>
               </a:ext>
             </a:extLst>
           </p:cNvPr>
@@ -14734,7 +14734,7 @@
           <p:cNvPr id="11" name="">
             <a:extLst xmlns:a="http://schemas.openxmlformats.org/drawingml/2006/main">
               <a:ext uri="{FF2B5EF4-FFF2-40B4-BE49-F238E27FC236}">
-                <a16:creationId xmlns:a16="http://schemas.microsoft.com/office/drawing/2014/main" id="{4A1EDC14-D4FA-4F23-8D20-DD1A38005D94}"/>
+                <a16:creationId xmlns:a16="http://schemas.microsoft.com/office/drawing/2014/main" id="{BC41EF9B-251B-4EB0-8581-3C4072F78FEC}"/>
               </a:ext>
             </a:extLst>
           </p:cNvPr>
@@ -14765,7 +14765,7 @@
           <p:cNvPr id="12" name="">
             <a:extLst xmlns:a="http://schemas.openxmlformats.org/drawingml/2006/main">
               <a:ext uri="{FF2B5EF4-FFF2-40B4-BE49-F238E27FC236}">
-                <a16:creationId xmlns:a16="http://schemas.microsoft.com/office/drawing/2014/main" id="{01A96238-9C62-498A-BDB1-E7F4D9793806}"/>
+                <a16:creationId xmlns:a16="http://schemas.microsoft.com/office/drawing/2014/main" id="{5B9E9794-7A40-4407-825F-6DE8C57AE025}"/>
               </a:ext>
             </a:extLst>
           </p:cNvPr>
@@ -14798,7 +14798,7 @@
           <p:cNvPr id="13" name="">
             <a:extLst xmlns:a="http://schemas.openxmlformats.org/drawingml/2006/main">
               <a:ext uri="{FF2B5EF4-FFF2-40B4-BE49-F238E27FC236}">
-                <a16:creationId xmlns:a16="http://schemas.microsoft.com/office/drawing/2014/main" id="{A69D478A-1DD9-4F3F-AD16-F13E35FDA344}"/>
+                <a16:creationId xmlns:a16="http://schemas.microsoft.com/office/drawing/2014/main" id="{D31AA480-756D-4645-A248-1F65B1D51261}"/>
               </a:ext>
             </a:extLst>
           </p:cNvPr>
@@ -14955,7 +14955,7 @@
           <p:cNvPr id="14" name="">
             <a:extLst xmlns:a="http://schemas.openxmlformats.org/drawingml/2006/main">
               <a:ext uri="{FF2B5EF4-FFF2-40B4-BE49-F238E27FC236}">
-                <a16:creationId xmlns:a16="http://schemas.microsoft.com/office/drawing/2014/main" id="{5A7C852C-F5C1-40E6-B199-F13945DE264A}"/>
+                <a16:creationId xmlns:a16="http://schemas.microsoft.com/office/drawing/2014/main" id="{1442FF51-428E-4E0D-96F4-761558363701}"/>
               </a:ext>
             </a:extLst>
           </p:cNvPr>
@@ -15135,7 +15135,7 @@
           <p:cNvPr id="15" name="">
             <a:extLst xmlns:a="http://schemas.openxmlformats.org/drawingml/2006/main">
               <a:ext uri="{FF2B5EF4-FFF2-40B4-BE49-F238E27FC236}">
-                <a16:creationId xmlns:a16="http://schemas.microsoft.com/office/drawing/2014/main" id="{C8B6CBCB-3E84-4192-B500-989F9008ECB5}"/>
+                <a16:creationId xmlns:a16="http://schemas.microsoft.com/office/drawing/2014/main" id="{E95847C6-66D0-4630-B91F-5B1D9E0AA259}"/>
               </a:ext>
             </a:extLst>
           </p:cNvPr>
@@ -15166,7 +15166,7 @@
           <p:cNvPr id="16" name="">
             <a:extLst xmlns:a="http://schemas.openxmlformats.org/drawingml/2006/main">
               <a:ext uri="{FF2B5EF4-FFF2-40B4-BE49-F238E27FC236}">
-                <a16:creationId xmlns:a16="http://schemas.microsoft.com/office/drawing/2014/main" id="{57146C53-ADE4-48F5-82E7-090F75DDC51C}"/>
+                <a16:creationId xmlns:a16="http://schemas.microsoft.com/office/drawing/2014/main" id="{E1162B7A-2E20-458B-B4AD-9D7BF49F9298}"/>
               </a:ext>
             </a:extLst>
           </p:cNvPr>
@@ -15199,7 +15199,7 @@
           <p:cNvPr id="17" name="">
             <a:extLst xmlns:a="http://schemas.openxmlformats.org/drawingml/2006/main">
               <a:ext uri="{FF2B5EF4-FFF2-40B4-BE49-F238E27FC236}">
-                <a16:creationId xmlns:a16="http://schemas.microsoft.com/office/drawing/2014/main" id="{F5B4E776-E533-430C-A8AA-F7A650DCD209}"/>
+                <a16:creationId xmlns:a16="http://schemas.microsoft.com/office/drawing/2014/main" id="{903AE87D-B5A3-4385-91AB-6D7E85EF79EA}"/>
               </a:ext>
             </a:extLst>
           </p:cNvPr>
@@ -15356,7 +15356,7 @@
           <p:cNvPr id="18" name="">
             <a:extLst xmlns:a="http://schemas.openxmlformats.org/drawingml/2006/main">
               <a:ext uri="{FF2B5EF4-FFF2-40B4-BE49-F238E27FC236}">
-                <a16:creationId xmlns:a16="http://schemas.microsoft.com/office/drawing/2014/main" id="{929476D8-8B68-4585-B5F5-00CEA26FD167}"/>
+                <a16:creationId xmlns:a16="http://schemas.microsoft.com/office/drawing/2014/main" id="{B4ACE975-F234-4FFC-B52E-BFAAC6FADB8D}"/>
               </a:ext>
             </a:extLst>
           </p:cNvPr>
@@ -15536,7 +15536,635 @@
           <p:cNvPr id="19" name="">
             <a:extLst xmlns:a="http://schemas.openxmlformats.org/drawingml/2006/main">
               <a:ext uri="{FF2B5EF4-FFF2-40B4-BE49-F238E27FC236}">
-                <a16:creationId xmlns:a16="http://schemas.microsoft.com/office/drawing/2014/main" id="{EB4DFEA1-C5B7-429E-BAD2-50194A41B4F1}"/>
+                <a16:creationId xmlns:a16="http://schemas.microsoft.com/office/drawing/2014/main" id="{035A4682-1203-42E9-A725-D0B3B26EB8FD}"/>
+              </a:ext>
+            </a:extLst>
+          </p:cNvPr>
+          <p:cNvSpPr>
+            <a:spLocks xmlns:a="http://schemas.openxmlformats.org/drawingml/2006/main" noGrp="1"/>
+          </p:cNvSpPr>
+          <p:nvPr/>
+        </p:nvSpPr>
+        <p:spPr>
+          <a:xfrm xmlns:a="http://schemas.openxmlformats.org/drawingml/2006/main">
+            <a:off x="685800" y="3381375"/>
+            <a:ext cx="2333625" cy="285750"/>
+          </a:xfrm>
+          <a:prstGeom xmlns:a="http://schemas.openxmlformats.org/drawingml/2006/main" prst="rect">
+            <a:avLst/>
+          </a:prstGeom>
+          <a:noFill xmlns:a="http://schemas.openxmlformats.org/drawingml/2006/main"/>
+          <a:ln xmlns:a="http://schemas.openxmlformats.org/drawingml/2006/main" w="0">
+            <a:noFill/>
+            <a:prstDash val="solid"/>
+          </a:ln>
+        </p:spPr>
+        <p:txBody>
+          <a:bodyPr xmlns:a="http://schemas.openxmlformats.org/drawingml/2006/main" lIns="0" tIns="0" rIns="0" bIns="0"/>
+          <a:lstStyle xmlns:a="http://schemas.openxmlformats.org/drawingml/2006/main">
+            <a:defPPr algn="ctr">
+              <a:defRPr sz="1350">
+                <a:solidFill>
+                  <a:srgbClr val="607286"/>
+                </a:solidFill>
+                <a:latin typeface="Arial"/>
+                <a:ea typeface="Arial"/>
+                <a:cs typeface="Arial"/>
+              </a:defRPr>
+            </a:defPPr>
+            <a:lvl1pPr algn="ctr">
+              <a:defRPr sz="1350">
+                <a:solidFill>
+                  <a:srgbClr val="607286"/>
+                </a:solidFill>
+                <a:latin typeface="Arial"/>
+                <a:ea typeface="Arial"/>
+                <a:cs typeface="Arial"/>
+              </a:defRPr>
+            </a:lvl1pPr>
+            <a:lvl2pPr algn="ctr">
+              <a:defRPr sz="1350">
+                <a:solidFill>
+                  <a:srgbClr val="607286"/>
+                </a:solidFill>
+                <a:latin typeface="Arial"/>
+                <a:ea typeface="Arial"/>
+                <a:cs typeface="Arial"/>
+              </a:defRPr>
+            </a:lvl2pPr>
+            <a:lvl3pPr algn="ctr">
+              <a:defRPr sz="1350">
+                <a:solidFill>
+                  <a:srgbClr val="607286"/>
+                </a:solidFill>
+                <a:latin typeface="Arial"/>
+                <a:ea typeface="Arial"/>
+                <a:cs typeface="Arial"/>
+              </a:defRPr>
+            </a:lvl3pPr>
+            <a:lvl4pPr algn="ctr">
+              <a:defRPr sz="1350">
+                <a:solidFill>
+                  <a:srgbClr val="607286"/>
+                </a:solidFill>
+                <a:latin typeface="Arial"/>
+                <a:ea typeface="Arial"/>
+                <a:cs typeface="Arial"/>
+              </a:defRPr>
+            </a:lvl4pPr>
+            <a:lvl5pPr algn="ctr">
+              <a:defRPr sz="1350">
+                <a:solidFill>
+                  <a:srgbClr val="607286"/>
+                </a:solidFill>
+                <a:latin typeface="Arial"/>
+                <a:ea typeface="Arial"/>
+                <a:cs typeface="Arial"/>
+              </a:defRPr>
+            </a:lvl5pPr>
+            <a:lvl6pPr algn="ctr">
+              <a:defRPr sz="1350">
+                <a:solidFill>
+                  <a:srgbClr val="607286"/>
+                </a:solidFill>
+                <a:latin typeface="Arial"/>
+                <a:ea typeface="Arial"/>
+                <a:cs typeface="Arial"/>
+              </a:defRPr>
+            </a:lvl6pPr>
+            <a:lvl7pPr algn="ctr">
+              <a:defRPr sz="1350">
+                <a:solidFill>
+                  <a:srgbClr val="607286"/>
+                </a:solidFill>
+                <a:latin typeface="Arial"/>
+                <a:ea typeface="Arial"/>
+                <a:cs typeface="Arial"/>
+              </a:defRPr>
+            </a:lvl7pPr>
+            <a:lvl8pPr algn="ctr">
+              <a:defRPr sz="1350">
+                <a:solidFill>
+                  <a:srgbClr val="607286"/>
+                </a:solidFill>
+                <a:latin typeface="Arial"/>
+                <a:ea typeface="Arial"/>
+                <a:cs typeface="Arial"/>
+              </a:defRPr>
+            </a:lvl8pPr>
+            <a:lvl9pPr algn="ctr">
+              <a:defRPr sz="1350">
+                <a:solidFill>
+                  <a:srgbClr val="607286"/>
+                </a:solidFill>
+                <a:latin typeface="Arial"/>
+                <a:ea typeface="Arial"/>
+                <a:cs typeface="Arial"/>
+              </a:defRPr>
+            </a:lvl9pPr>
+          </a:lstStyle>
+          <a:p xmlns:a="http://schemas.openxmlformats.org/drawingml/2006/main">
+            <a:pPr algn="ctr">
+              <a:defRPr sz="1350">
+                <a:solidFill>
+                  <a:srgbClr val="607286"/>
+                </a:solidFill>
+                <a:latin typeface="Arial"/>
+                <a:ea typeface="Arial"/>
+                <a:cs typeface="Arial"/>
+              </a:defRPr>
+            </a:pPr>
+            <a:r>
+              <a:rPr sz="1350">
+                <a:solidFill>
+                  <a:srgbClr val="607286"/>
+                </a:solidFill>
+                <a:latin typeface="Arial"/>
+                <a:ea typeface="Arial"/>
+                <a:cs typeface="Arial"/>
+              </a:rPr>
+              <a:t>candidates.py</a:t>
+            </a:r>
+          </a:p>
+        </p:txBody>
+      </p:sp>
+      <p:sp>
+        <p:nvSpPr>
+          <p:cNvPr id="20" name="">
+            <a:extLst xmlns:a="http://schemas.openxmlformats.org/drawingml/2006/main">
+              <a:ext uri="{FF2B5EF4-FFF2-40B4-BE49-F238E27FC236}">
+                <a16:creationId xmlns:a16="http://schemas.microsoft.com/office/drawing/2014/main" id="{F39FB035-F41D-48D8-8FD5-25F016B8C33E}"/>
+              </a:ext>
+            </a:extLst>
+          </p:cNvPr>
+          <p:cNvSpPr>
+            <a:spLocks xmlns:a="http://schemas.openxmlformats.org/drawingml/2006/main" noGrp="1"/>
+          </p:cNvSpPr>
+          <p:nvPr/>
+        </p:nvSpPr>
+        <p:spPr>
+          <a:xfrm xmlns:a="http://schemas.openxmlformats.org/drawingml/2006/main">
+            <a:off x="3476625" y="3381375"/>
+            <a:ext cx="2333625" cy="285750"/>
+          </a:xfrm>
+          <a:prstGeom xmlns:a="http://schemas.openxmlformats.org/drawingml/2006/main" prst="rect">
+            <a:avLst/>
+          </a:prstGeom>
+          <a:noFill xmlns:a="http://schemas.openxmlformats.org/drawingml/2006/main"/>
+          <a:ln xmlns:a="http://schemas.openxmlformats.org/drawingml/2006/main" w="0">
+            <a:noFill/>
+            <a:prstDash val="solid"/>
+          </a:ln>
+        </p:spPr>
+        <p:txBody>
+          <a:bodyPr xmlns:a="http://schemas.openxmlformats.org/drawingml/2006/main" lIns="0" tIns="0" rIns="0" bIns="0"/>
+          <a:lstStyle xmlns:a="http://schemas.openxmlformats.org/drawingml/2006/main">
+            <a:defPPr algn="ctr">
+              <a:defRPr sz="1350">
+                <a:solidFill>
+                  <a:srgbClr val="607286"/>
+                </a:solidFill>
+                <a:latin typeface="Arial"/>
+                <a:ea typeface="Arial"/>
+                <a:cs typeface="Arial"/>
+              </a:defRPr>
+            </a:defPPr>
+            <a:lvl1pPr algn="ctr">
+              <a:defRPr sz="1350">
+                <a:solidFill>
+                  <a:srgbClr val="607286"/>
+                </a:solidFill>
+                <a:latin typeface="Arial"/>
+                <a:ea typeface="Arial"/>
+                <a:cs typeface="Arial"/>
+              </a:defRPr>
+            </a:lvl1pPr>
+            <a:lvl2pPr algn="ctr">
+              <a:defRPr sz="1350">
+                <a:solidFill>
+                  <a:srgbClr val="607286"/>
+                </a:solidFill>
+                <a:latin typeface="Arial"/>
+                <a:ea typeface="Arial"/>
+                <a:cs typeface="Arial"/>
+              </a:defRPr>
+            </a:lvl2pPr>
+            <a:lvl3pPr algn="ctr">
+              <a:defRPr sz="1350">
+                <a:solidFill>
+                  <a:srgbClr val="607286"/>
+                </a:solidFill>
+                <a:latin typeface="Arial"/>
+                <a:ea typeface="Arial"/>
+                <a:cs typeface="Arial"/>
+              </a:defRPr>
+            </a:lvl3pPr>
+            <a:lvl4pPr algn="ctr">
+              <a:defRPr sz="1350">
+                <a:solidFill>
+                  <a:srgbClr val="607286"/>
+                </a:solidFill>
+                <a:latin typeface="Arial"/>
+                <a:ea typeface="Arial"/>
+                <a:cs typeface="Arial"/>
+              </a:defRPr>
+            </a:lvl4pPr>
+            <a:lvl5pPr algn="ctr">
+              <a:defRPr sz="1350">
+                <a:solidFill>
+                  <a:srgbClr val="607286"/>
+                </a:solidFill>
+                <a:latin typeface="Arial"/>
+                <a:ea typeface="Arial"/>
+                <a:cs typeface="Arial"/>
+              </a:defRPr>
+            </a:lvl5pPr>
+            <a:lvl6pPr algn="ctr">
+              <a:defRPr sz="1350">
+                <a:solidFill>
+                  <a:srgbClr val="607286"/>
+                </a:solidFill>
+                <a:latin typeface="Arial"/>
+                <a:ea typeface="Arial"/>
+                <a:cs typeface="Arial"/>
+              </a:defRPr>
+            </a:lvl6pPr>
+            <a:lvl7pPr algn="ctr">
+              <a:defRPr sz="1350">
+                <a:solidFill>
+                  <a:srgbClr val="607286"/>
+                </a:solidFill>
+                <a:latin typeface="Arial"/>
+                <a:ea typeface="Arial"/>
+                <a:cs typeface="Arial"/>
+              </a:defRPr>
+            </a:lvl7pPr>
+            <a:lvl8pPr algn="ctr">
+              <a:defRPr sz="1350">
+                <a:solidFill>
+                  <a:srgbClr val="607286"/>
+                </a:solidFill>
+                <a:latin typeface="Arial"/>
+                <a:ea typeface="Arial"/>
+                <a:cs typeface="Arial"/>
+              </a:defRPr>
+            </a:lvl8pPr>
+            <a:lvl9pPr algn="ctr">
+              <a:defRPr sz="1350">
+                <a:solidFill>
+                  <a:srgbClr val="607286"/>
+                </a:solidFill>
+                <a:latin typeface="Arial"/>
+                <a:ea typeface="Arial"/>
+                <a:cs typeface="Arial"/>
+              </a:defRPr>
+            </a:lvl9pPr>
+          </a:lstStyle>
+          <a:p xmlns:a="http://schemas.openxmlformats.org/drawingml/2006/main">
+            <a:pPr algn="ctr">
+              <a:defRPr sz="1350">
+                <a:solidFill>
+                  <a:srgbClr val="607286"/>
+                </a:solidFill>
+                <a:latin typeface="Arial"/>
+                <a:ea typeface="Arial"/>
+                <a:cs typeface="Arial"/>
+              </a:defRPr>
+            </a:pPr>
+            <a:r>
+              <a:rPr sz="1350">
+                <a:solidFill>
+                  <a:srgbClr val="607286"/>
+                </a:solidFill>
+                <a:latin typeface="Arial"/>
+                <a:ea typeface="Arial"/>
+                <a:cs typeface="Arial"/>
+              </a:rPr>
+              <a:t>workload_experiment.py</a:t>
+            </a:r>
+          </a:p>
+        </p:txBody>
+      </p:sp>
+      <p:sp>
+        <p:nvSpPr>
+          <p:cNvPr id="21" name="">
+            <a:extLst xmlns:a="http://schemas.openxmlformats.org/drawingml/2006/main">
+              <a:ext uri="{FF2B5EF4-FFF2-40B4-BE49-F238E27FC236}">
+                <a16:creationId xmlns:a16="http://schemas.microsoft.com/office/drawing/2014/main" id="{D6E8728A-450D-4A80-A745-12E1C4BF0CBA}"/>
+              </a:ext>
+            </a:extLst>
+          </p:cNvPr>
+          <p:cNvSpPr>
+            <a:spLocks xmlns:a="http://schemas.openxmlformats.org/drawingml/2006/main" noGrp="1"/>
+          </p:cNvSpPr>
+          <p:nvPr/>
+        </p:nvSpPr>
+        <p:spPr>
+          <a:xfrm xmlns:a="http://schemas.openxmlformats.org/drawingml/2006/main">
+            <a:off x="6267450" y="3381375"/>
+            <a:ext cx="2333625" cy="285750"/>
+          </a:xfrm>
+          <a:prstGeom xmlns:a="http://schemas.openxmlformats.org/drawingml/2006/main" prst="rect">
+            <a:avLst/>
+          </a:prstGeom>
+          <a:noFill xmlns:a="http://schemas.openxmlformats.org/drawingml/2006/main"/>
+          <a:ln xmlns:a="http://schemas.openxmlformats.org/drawingml/2006/main" w="0">
+            <a:noFill/>
+            <a:prstDash val="solid"/>
+          </a:ln>
+        </p:spPr>
+        <p:txBody>
+          <a:bodyPr xmlns:a="http://schemas.openxmlformats.org/drawingml/2006/main" lIns="0" tIns="0" rIns="0" bIns="0"/>
+          <a:lstStyle xmlns:a="http://schemas.openxmlformats.org/drawingml/2006/main">
+            <a:defPPr algn="ctr">
+              <a:defRPr sz="1350">
+                <a:solidFill>
+                  <a:srgbClr val="607286"/>
+                </a:solidFill>
+                <a:latin typeface="Arial"/>
+                <a:ea typeface="Arial"/>
+                <a:cs typeface="Arial"/>
+              </a:defRPr>
+            </a:defPPr>
+            <a:lvl1pPr algn="ctr">
+              <a:defRPr sz="1350">
+                <a:solidFill>
+                  <a:srgbClr val="607286"/>
+                </a:solidFill>
+                <a:latin typeface="Arial"/>
+                <a:ea typeface="Arial"/>
+                <a:cs typeface="Arial"/>
+              </a:defRPr>
+            </a:lvl1pPr>
+            <a:lvl2pPr algn="ctr">
+              <a:defRPr sz="1350">
+                <a:solidFill>
+                  <a:srgbClr val="607286"/>
+                </a:solidFill>
+                <a:latin typeface="Arial"/>
+                <a:ea typeface="Arial"/>
+                <a:cs typeface="Arial"/>
+              </a:defRPr>
+            </a:lvl2pPr>
+            <a:lvl3pPr algn="ctr">
+              <a:defRPr sz="1350">
+                <a:solidFill>
+                  <a:srgbClr val="607286"/>
+                </a:solidFill>
+                <a:latin typeface="Arial"/>
+                <a:ea typeface="Arial"/>
+                <a:cs typeface="Arial"/>
+              </a:defRPr>
+            </a:lvl3pPr>
+            <a:lvl4pPr algn="ctr">
+              <a:defRPr sz="1350">
+                <a:solidFill>
+                  <a:srgbClr val="607286"/>
+                </a:solidFill>
+                <a:latin typeface="Arial"/>
+                <a:ea typeface="Arial"/>
+                <a:cs typeface="Arial"/>
+              </a:defRPr>
+            </a:lvl4pPr>
+            <a:lvl5pPr algn="ctr">
+              <a:defRPr sz="1350">
+                <a:solidFill>
+                  <a:srgbClr val="607286"/>
+                </a:solidFill>
+                <a:latin typeface="Arial"/>
+                <a:ea typeface="Arial"/>
+                <a:cs typeface="Arial"/>
+              </a:defRPr>
+            </a:lvl5pPr>
+            <a:lvl6pPr algn="ctr">
+              <a:defRPr sz="1350">
+                <a:solidFill>
+                  <a:srgbClr val="607286"/>
+                </a:solidFill>
+                <a:latin typeface="Arial"/>
+                <a:ea typeface="Arial"/>
+                <a:cs typeface="Arial"/>
+              </a:defRPr>
+            </a:lvl6pPr>
+            <a:lvl7pPr algn="ctr">
+              <a:defRPr sz="1350">
+                <a:solidFill>
+                  <a:srgbClr val="607286"/>
+                </a:solidFill>
+                <a:latin typeface="Arial"/>
+                <a:ea typeface="Arial"/>
+                <a:cs typeface="Arial"/>
+              </a:defRPr>
+            </a:lvl7pPr>
+            <a:lvl8pPr algn="ctr">
+              <a:defRPr sz="1350">
+                <a:solidFill>
+                  <a:srgbClr val="607286"/>
+                </a:solidFill>
+                <a:latin typeface="Arial"/>
+                <a:ea typeface="Arial"/>
+                <a:cs typeface="Arial"/>
+              </a:defRPr>
+            </a:lvl8pPr>
+            <a:lvl9pPr algn="ctr">
+              <a:defRPr sz="1350">
+                <a:solidFill>
+                  <a:srgbClr val="607286"/>
+                </a:solidFill>
+                <a:latin typeface="Arial"/>
+                <a:ea typeface="Arial"/>
+                <a:cs typeface="Arial"/>
+              </a:defRPr>
+            </a:lvl9pPr>
+          </a:lstStyle>
+          <a:p xmlns:a="http://schemas.openxmlformats.org/drawingml/2006/main">
+            <a:pPr algn="ctr">
+              <a:defRPr sz="1350">
+                <a:solidFill>
+                  <a:srgbClr val="607286"/>
+                </a:solidFill>
+                <a:latin typeface="Arial"/>
+                <a:ea typeface="Arial"/>
+                <a:cs typeface="Arial"/>
+              </a:defRPr>
+            </a:pPr>
+            <a:r>
+              <a:rPr sz="1350">
+                <a:solidFill>
+                  <a:srgbClr val="607286"/>
+                </a:solidFill>
+                <a:latin typeface="Arial"/>
+                <a:ea typeface="Arial"/>
+                <a:cs typeface="Arial"/>
+              </a:rPr>
+              <a:t>Verilator</a:t>
+            </a:r>
+          </a:p>
+        </p:txBody>
+      </p:sp>
+      <p:sp>
+        <p:nvSpPr>
+          <p:cNvPr id="22" name="">
+            <a:extLst xmlns:a="http://schemas.openxmlformats.org/drawingml/2006/main">
+              <a:ext uri="{FF2B5EF4-FFF2-40B4-BE49-F238E27FC236}">
+                <a16:creationId xmlns:a16="http://schemas.microsoft.com/office/drawing/2014/main" id="{44893E58-FDF6-417E-B7B8-585E7E136202}"/>
+              </a:ext>
+            </a:extLst>
+          </p:cNvPr>
+          <p:cNvSpPr>
+            <a:spLocks xmlns:a="http://schemas.openxmlformats.org/drawingml/2006/main" noGrp="1"/>
+          </p:cNvSpPr>
+          <p:nvPr/>
+        </p:nvSpPr>
+        <p:spPr>
+          <a:xfrm xmlns:a="http://schemas.openxmlformats.org/drawingml/2006/main">
+            <a:off x="9058275" y="3381375"/>
+            <a:ext cx="2333625" cy="285750"/>
+          </a:xfrm>
+          <a:prstGeom xmlns:a="http://schemas.openxmlformats.org/drawingml/2006/main" prst="rect">
+            <a:avLst/>
+          </a:prstGeom>
+          <a:noFill xmlns:a="http://schemas.openxmlformats.org/drawingml/2006/main"/>
+          <a:ln xmlns:a="http://schemas.openxmlformats.org/drawingml/2006/main" w="0">
+            <a:noFill/>
+            <a:prstDash val="solid"/>
+          </a:ln>
+        </p:spPr>
+        <p:txBody>
+          <a:bodyPr xmlns:a="http://schemas.openxmlformats.org/drawingml/2006/main" lIns="0" tIns="0" rIns="0" bIns="0"/>
+          <a:lstStyle xmlns:a="http://schemas.openxmlformats.org/drawingml/2006/main">
+            <a:defPPr algn="ctr">
+              <a:defRPr sz="1350">
+                <a:solidFill>
+                  <a:srgbClr val="607286"/>
+                </a:solidFill>
+                <a:latin typeface="Arial"/>
+                <a:ea typeface="Arial"/>
+                <a:cs typeface="Arial"/>
+              </a:defRPr>
+            </a:defPPr>
+            <a:lvl1pPr algn="ctr">
+              <a:defRPr sz="1350">
+                <a:solidFill>
+                  <a:srgbClr val="607286"/>
+                </a:solidFill>
+                <a:latin typeface="Arial"/>
+                <a:ea typeface="Arial"/>
+                <a:cs typeface="Arial"/>
+              </a:defRPr>
+            </a:lvl1pPr>
+            <a:lvl2pPr algn="ctr">
+              <a:defRPr sz="1350">
+                <a:solidFill>
+                  <a:srgbClr val="607286"/>
+                </a:solidFill>
+                <a:latin typeface="Arial"/>
+                <a:ea typeface="Arial"/>
+                <a:cs typeface="Arial"/>
+              </a:defRPr>
+            </a:lvl2pPr>
+            <a:lvl3pPr algn="ctr">
+              <a:defRPr sz="1350">
+                <a:solidFill>
+                  <a:srgbClr val="607286"/>
+                </a:solidFill>
+                <a:latin typeface="Arial"/>
+                <a:ea typeface="Arial"/>
+                <a:cs typeface="Arial"/>
+              </a:defRPr>
+            </a:lvl3pPr>
+            <a:lvl4pPr algn="ctr">
+              <a:defRPr sz="1350">
+                <a:solidFill>
+                  <a:srgbClr val="607286"/>
+                </a:solidFill>
+                <a:latin typeface="Arial"/>
+                <a:ea typeface="Arial"/>
+                <a:cs typeface="Arial"/>
+              </a:defRPr>
+            </a:lvl4pPr>
+            <a:lvl5pPr algn="ctr">
+              <a:defRPr sz="1350">
+                <a:solidFill>
+                  <a:srgbClr val="607286"/>
+                </a:solidFill>
+                <a:latin typeface="Arial"/>
+                <a:ea typeface="Arial"/>
+                <a:cs typeface="Arial"/>
+              </a:defRPr>
+            </a:lvl5pPr>
+            <a:lvl6pPr algn="ctr">
+              <a:defRPr sz="1350">
+                <a:solidFill>
+                  <a:srgbClr val="607286"/>
+                </a:solidFill>
+                <a:latin typeface="Arial"/>
+                <a:ea typeface="Arial"/>
+                <a:cs typeface="Arial"/>
+              </a:defRPr>
+            </a:lvl6pPr>
+            <a:lvl7pPr algn="ctr">
+              <a:defRPr sz="1350">
+                <a:solidFill>
+                  <a:srgbClr val="607286"/>
+                </a:solidFill>
+                <a:latin typeface="Arial"/>
+                <a:ea typeface="Arial"/>
+                <a:cs typeface="Arial"/>
+              </a:defRPr>
+            </a:lvl7pPr>
+            <a:lvl8pPr algn="ctr">
+              <a:defRPr sz="1350">
+                <a:solidFill>
+                  <a:srgbClr val="607286"/>
+                </a:solidFill>
+                <a:latin typeface="Arial"/>
+                <a:ea typeface="Arial"/>
+                <a:cs typeface="Arial"/>
+              </a:defRPr>
+            </a:lvl8pPr>
+            <a:lvl9pPr algn="ctr">
+              <a:defRPr sz="1350">
+                <a:solidFill>
+                  <a:srgbClr val="607286"/>
+                </a:solidFill>
+                <a:latin typeface="Arial"/>
+                <a:ea typeface="Arial"/>
+                <a:cs typeface="Arial"/>
+              </a:defRPr>
+            </a:lvl9pPr>
+          </a:lstStyle>
+          <a:p xmlns:a="http://schemas.openxmlformats.org/drawingml/2006/main">
+            <a:pPr algn="ctr">
+              <a:defRPr sz="1350">
+                <a:solidFill>
+                  <a:srgbClr val="607286"/>
+                </a:solidFill>
+                <a:latin typeface="Arial"/>
+                <a:ea typeface="Arial"/>
+                <a:cs typeface="Arial"/>
+              </a:defRPr>
+            </a:pPr>
+            <a:r>
+              <a:rPr sz="1350">
+                <a:solidFill>
+                  <a:srgbClr val="607286"/>
+                </a:solidFill>
+                <a:latin typeface="Arial"/>
+                <a:ea typeface="Arial"/>
+                <a:cs typeface="Arial"/>
+              </a:rPr>
+              <a:t>Yosys + nextpnr</a:t>
+            </a:r>
+          </a:p>
+        </p:txBody>
+      </p:sp>
+      <p:sp>
+        <p:nvSpPr>
+          <p:cNvPr id="23" name="">
+            <a:extLst xmlns:a="http://schemas.openxmlformats.org/drawingml/2006/main">
+              <a:ext uri="{FF2B5EF4-FFF2-40B4-BE49-F238E27FC236}">
+                <a16:creationId xmlns:a16="http://schemas.microsoft.com/office/drawing/2014/main" id="{49334D1E-E545-4516-AA7F-88E7E1F35DDF}"/>
               </a:ext>
             </a:extLst>
           </p:cNvPr>
@@ -15690,10 +16318,10 @@
       </p:sp>
       <p:sp>
         <p:nvSpPr>
-          <p:cNvPr id="20" name="">
+          <p:cNvPr id="24" name="">
             <a:extLst xmlns:a="http://schemas.openxmlformats.org/drawingml/2006/main">
               <a:ext uri="{FF2B5EF4-FFF2-40B4-BE49-F238E27FC236}">
-                <a16:creationId xmlns:a16="http://schemas.microsoft.com/office/drawing/2014/main" id="{662E959C-8B70-4B23-81DB-0B1F5AD1DEC8}"/>
+                <a16:creationId xmlns:a16="http://schemas.microsoft.com/office/drawing/2014/main" id="{9C005B56-3A1C-4943-973D-D8D30FEBA9A0}"/>
               </a:ext>
             </a:extLst>
           </p:cNvPr>
@@ -15847,10 +16475,10 @@
       </p:sp>
       <p:sp>
         <p:nvSpPr>
-          <p:cNvPr id="21" name="">
+          <p:cNvPr id="25" name="">
             <a:extLst xmlns:a="http://schemas.openxmlformats.org/drawingml/2006/main">
               <a:ext uri="{FF2B5EF4-FFF2-40B4-BE49-F238E27FC236}">
-                <a16:creationId xmlns:a16="http://schemas.microsoft.com/office/drawing/2014/main" id="{11763B63-889F-4075-81EE-D698589D1475}"/>
+                <a16:creationId xmlns:a16="http://schemas.microsoft.com/office/drawing/2014/main" id="{5B283125-5E9A-40B3-8BF1-55970EAFC7C4}"/>
               </a:ext>
             </a:extLst>
           </p:cNvPr>
@@ -16005,7 +16633,7 @@
     </p:spTree>
     <p:extLst>
       <p:ext uri="{BB962C8B-B14F-4D97-AF65-F5344CB8AC3E}">
-        <p14:creationId xmlns:p14="http://schemas.microsoft.com/office/powerpoint/2010/main" val="1324647877"/>
+        <p14:creationId xmlns:p14="http://schemas.microsoft.com/office/powerpoint/2010/main" val="1634176236"/>
       </p:ext>
     </p:extLst>
   </p:cSld>
@@ -16036,7 +16664,7 @@
           <p:cNvPr id="10" name="">
             <a:extLst xmlns:a="http://schemas.openxmlformats.org/drawingml/2006/main">
               <a:ext uri="{FF2B5EF4-FFF2-40B4-BE49-F238E27FC236}">
-                <a16:creationId xmlns:a16="http://schemas.microsoft.com/office/drawing/2014/main" id="{112D0CE9-2F77-4A63-BBF2-FB4E983DC6D7}"/>
+                <a16:creationId xmlns:a16="http://schemas.microsoft.com/office/drawing/2014/main" id="{D428BCC3-0F3F-4199-8299-45A886B568E0}"/>
               </a:ext>
             </a:extLst>
           </p:cNvPr>
@@ -16193,7 +16821,7 @@
           <p:cNvPr id="2" name="">
             <a:extLst xmlns:a="http://schemas.openxmlformats.org/drawingml/2006/main">
               <a:ext uri="{FF2B5EF4-FFF2-40B4-BE49-F238E27FC236}">
-                <a16:creationId xmlns:a16="http://schemas.microsoft.com/office/drawing/2014/main" id="{FB597A00-3AEF-4E91-967D-A448489D5A40}"/>
+                <a16:creationId xmlns:a16="http://schemas.microsoft.com/office/drawing/2014/main" id="{0E3B9989-E2B4-44BC-A532-5B2A3C4E6C1E}"/>
               </a:ext>
             </a:extLst>
           </p:cNvPr>
@@ -16224,7 +16852,7 @@
           <p:cNvPr id="3" name="">
             <a:extLst xmlns:a="http://schemas.openxmlformats.org/drawingml/2006/main">
               <a:ext uri="{FF2B5EF4-FFF2-40B4-BE49-F238E27FC236}">
-                <a16:creationId xmlns:a16="http://schemas.microsoft.com/office/drawing/2014/main" id="{60E8029B-F82C-4F79-B772-9BFF718E06E7}"/>
+                <a16:creationId xmlns:a16="http://schemas.microsoft.com/office/drawing/2014/main" id="{03794836-F9D3-4ACF-A1CB-6D22B3F8094C}"/>
               </a:ext>
             </a:extLst>
           </p:cNvPr>
@@ -16381,7 +17009,7 @@
           <p:cNvPr id="4" name="Chart">
             <a:extLst xmlns:a="http://schemas.openxmlformats.org/drawingml/2006/main">
               <a:ext uri="{FF2B5EF4-FFF2-40B4-BE49-F238E27FC236}">
-                <a16:creationId xmlns:a16="http://schemas.microsoft.com/office/drawing/2014/main" id="{17AE3EC1-4761-4D3C-AD6F-CE9522F1E067}"/>
+                <a16:creationId xmlns:a16="http://schemas.microsoft.com/office/drawing/2014/main" id="{1A41D405-3AF5-4603-AD37-36FDCE8110EF}"/>
               </a:ext>
             </a:extLst>
           </p:cNvPr>
@@ -16394,7 +17022,7 @@
         </p:xfrm>
         <a:graphic xmlns:a="http://schemas.openxmlformats.org/drawingml/2006/main">
           <a:graphicData uri="http://schemas.openxmlformats.org/drawingml/2006/chart">
-            <c:chart xmlns:r="http://schemas.openxmlformats.org/officeDocument/2006/relationships" xmlns:c="http://schemas.openxmlformats.org/drawingml/2006/chart" r:id="Rb2dca3f24be5415f"/>
+            <c:chart xmlns:r="http://schemas.openxmlformats.org/officeDocument/2006/relationships" xmlns:c="http://schemas.openxmlformats.org/drawingml/2006/chart" r:id="R39c2380e42e94e7f"/>
           </a:graphicData>
         </a:graphic>
       </p:graphicFrame>
@@ -16403,7 +17031,7 @@
           <p:cNvPr id="5" name="">
             <a:extLst xmlns:a="http://schemas.openxmlformats.org/drawingml/2006/main">
               <a:ext uri="{FF2B5EF4-FFF2-40B4-BE49-F238E27FC236}">
-                <a16:creationId xmlns:a16="http://schemas.microsoft.com/office/drawing/2014/main" id="{B3129264-B0CE-4AB3-9323-4B1BC13112A3}"/>
+                <a16:creationId xmlns:a16="http://schemas.microsoft.com/office/drawing/2014/main" id="{A0AC2698-3FFD-4271-A377-A3AF31E263A0}"/>
               </a:ext>
             </a:extLst>
           </p:cNvPr>
@@ -16560,7 +17188,7 @@
           <p:cNvPr id="6" name="">
             <a:extLst xmlns:a="http://schemas.openxmlformats.org/drawingml/2006/main">
               <a:ext uri="{FF2B5EF4-FFF2-40B4-BE49-F238E27FC236}">
-                <a16:creationId xmlns:a16="http://schemas.microsoft.com/office/drawing/2014/main" id="{BF2C48E2-C19B-483E-B1D7-BB9E1883E4FC}"/>
+                <a16:creationId xmlns:a16="http://schemas.microsoft.com/office/drawing/2014/main" id="{1B43EF2D-DD81-4CF6-A40F-799E1943030D}"/>
               </a:ext>
             </a:extLst>
           </p:cNvPr>
@@ -16740,7 +17368,7 @@
           <p:cNvPr id="7" name="">
             <a:extLst xmlns:a="http://schemas.openxmlformats.org/drawingml/2006/main">
               <a:ext uri="{FF2B5EF4-FFF2-40B4-BE49-F238E27FC236}">
-                <a16:creationId xmlns:a16="http://schemas.microsoft.com/office/drawing/2014/main" id="{33B5E46F-8EE6-489B-857A-397FF71E54DE}"/>
+                <a16:creationId xmlns:a16="http://schemas.microsoft.com/office/drawing/2014/main" id="{FA6AC5E3-8712-43B0-A46D-369838F9AC9C}"/>
               </a:ext>
             </a:extLst>
           </p:cNvPr>
@@ -16897,7 +17525,7 @@
           <p:cNvPr id="8" name="">
             <a:extLst xmlns:a="http://schemas.openxmlformats.org/drawingml/2006/main">
               <a:ext uri="{FF2B5EF4-FFF2-40B4-BE49-F238E27FC236}">
-                <a16:creationId xmlns:a16="http://schemas.microsoft.com/office/drawing/2014/main" id="{8DF6D36F-95BF-4954-9531-1F5C26ED34CA}"/>
+                <a16:creationId xmlns:a16="http://schemas.microsoft.com/office/drawing/2014/main" id="{67753CBE-D314-4336-AADB-E2337215C504}"/>
               </a:ext>
             </a:extLst>
           </p:cNvPr>
@@ -17044,7 +17672,7 @@
                 <a:ea typeface="Arial"/>
                 <a:cs typeface="Arial"/>
               </a:rPr>
-              <a:t>13 policies tested: 8 learned</a:t>
+              <a:t>Earlier cost study: 301 circuits</a:t>
             </a:r>
           </a:p>
           <a:p xmlns:a="http://schemas.openxmlformats.org/drawingml/2006/main">
@@ -17067,7 +17695,7 @@
                 <a:ea typeface="Arial"/>
                 <a:cs typeface="Arial"/>
               </a:rPr>
-              <a:t>2,925 replays reuse labels</a:t>
+              <a:t>Separate isolated-LUT labels</a:t>
             </a:r>
           </a:p>
         </p:txBody>
@@ -17077,7 +17705,7 @@
           <p:cNvPr id="9" name="">
             <a:extLst xmlns:a="http://schemas.openxmlformats.org/drawingml/2006/main">
               <a:ext uri="{FF2B5EF4-FFF2-40B4-BE49-F238E27FC236}">
-                <a16:creationId xmlns:a16="http://schemas.microsoft.com/office/drawing/2014/main" id="{1D30E425-C167-4029-AD3A-56ADA1DF2D11}"/>
+                <a16:creationId xmlns:a16="http://schemas.microsoft.com/office/drawing/2014/main" id="{D15FFFCF-CE42-4646-81B6-D31519C5B349}"/>
               </a:ext>
             </a:extLst>
           </p:cNvPr>
@@ -17232,7 +17860,7 @@
     </p:spTree>
     <p:extLst>
       <p:ext uri="{BB962C8B-B14F-4D97-AF65-F5344CB8AC3E}">
-        <p14:creationId xmlns:p14="http://schemas.microsoft.com/office/powerpoint/2010/main" val="1055109145"/>
+        <p14:creationId xmlns:p14="http://schemas.microsoft.com/office/powerpoint/2010/main" val="1131978160"/>
       </p:ext>
     </p:extLst>
   </p:cSld>
@@ -17263,7 +17891,7 @@
           <p:cNvPr id="22" name="">
             <a:extLst xmlns:a="http://schemas.openxmlformats.org/drawingml/2006/main">
               <a:ext uri="{FF2B5EF4-FFF2-40B4-BE49-F238E27FC236}">
-                <a16:creationId xmlns:a16="http://schemas.microsoft.com/office/drawing/2014/main" id="{B736AE88-45D9-4980-9DCC-49B2C06AA606}"/>
+                <a16:creationId xmlns:a16="http://schemas.microsoft.com/office/drawing/2014/main" id="{71D3DC8A-95DA-4897-A423-E7842A96DE96}"/>
               </a:ext>
             </a:extLst>
           </p:cNvPr>
@@ -17420,7 +18048,7 @@
           <p:cNvPr id="2" name="">
             <a:extLst xmlns:a="http://schemas.openxmlformats.org/drawingml/2006/main">
               <a:ext uri="{FF2B5EF4-FFF2-40B4-BE49-F238E27FC236}">
-                <a16:creationId xmlns:a16="http://schemas.microsoft.com/office/drawing/2014/main" id="{5190EAEB-D83E-467A-8DF1-712DF83FA5E2}"/>
+                <a16:creationId xmlns:a16="http://schemas.microsoft.com/office/drawing/2014/main" id="{9763D6C4-0869-47D2-A77D-5159BE798F6F}"/>
               </a:ext>
             </a:extLst>
           </p:cNvPr>
@@ -17451,7 +18079,7 @@
           <p:cNvPr id="3" name="">
             <a:extLst xmlns:a="http://schemas.openxmlformats.org/drawingml/2006/main">
               <a:ext uri="{FF2B5EF4-FFF2-40B4-BE49-F238E27FC236}">
-                <a16:creationId xmlns:a16="http://schemas.microsoft.com/office/drawing/2014/main" id="{DDFC7417-4DC4-4318-9212-57F4CD28EA37}"/>
+                <a16:creationId xmlns:a16="http://schemas.microsoft.com/office/drawing/2014/main" id="{0385A132-1C4A-4B38-A10F-128B359F5A5C}"/>
               </a:ext>
             </a:extLst>
           </p:cNvPr>
@@ -17608,7 +18236,7 @@
           <p:cNvPr id="4" name="">
             <a:extLst xmlns:a="http://schemas.openxmlformats.org/drawingml/2006/main">
               <a:ext uri="{FF2B5EF4-FFF2-40B4-BE49-F238E27FC236}">
-                <a16:creationId xmlns:a16="http://schemas.microsoft.com/office/drawing/2014/main" id="{9E56627B-9409-4117-A352-DE8BB95C32B3}"/>
+                <a16:creationId xmlns:a16="http://schemas.microsoft.com/office/drawing/2014/main" id="{042074EB-817D-4D17-BAAA-16189DEFEBC3}"/>
               </a:ext>
             </a:extLst>
           </p:cNvPr>
@@ -17641,7 +18269,7 @@
           <p:cNvPr id="5" name="">
             <a:extLst xmlns:a="http://schemas.openxmlformats.org/drawingml/2006/main">
               <a:ext uri="{FF2B5EF4-FFF2-40B4-BE49-F238E27FC236}">
-                <a16:creationId xmlns:a16="http://schemas.microsoft.com/office/drawing/2014/main" id="{78BDD98A-1067-4817-996E-57CBFB345539}"/>
+                <a16:creationId xmlns:a16="http://schemas.microsoft.com/office/drawing/2014/main" id="{5A08C834-DE20-4278-8416-781D303E481C}"/>
               </a:ext>
             </a:extLst>
           </p:cNvPr>
@@ -17798,7 +18426,7 @@
           <p:cNvPr id="6" name="">
             <a:extLst xmlns:a="http://schemas.openxmlformats.org/drawingml/2006/main">
               <a:ext uri="{FF2B5EF4-FFF2-40B4-BE49-F238E27FC236}">
-                <a16:creationId xmlns:a16="http://schemas.microsoft.com/office/drawing/2014/main" id="{4D0D6C7E-C166-4A1D-9FED-778140134E79}"/>
+                <a16:creationId xmlns:a16="http://schemas.microsoft.com/office/drawing/2014/main" id="{76CE54D2-B06F-445E-85F1-DA62504B8FF4}"/>
               </a:ext>
             </a:extLst>
           </p:cNvPr>
@@ -17978,7 +18606,7 @@
           <p:cNvPr id="7" name="">
             <a:extLst xmlns:a="http://schemas.openxmlformats.org/drawingml/2006/main">
               <a:ext uri="{FF2B5EF4-FFF2-40B4-BE49-F238E27FC236}">
-                <a16:creationId xmlns:a16="http://schemas.microsoft.com/office/drawing/2014/main" id="{0C744642-C05C-4C9F-9D70-25BC0526E026}"/>
+                <a16:creationId xmlns:a16="http://schemas.microsoft.com/office/drawing/2014/main" id="{8EB7F449-577E-4190-8B59-986BD62B5285}"/>
               </a:ext>
             </a:extLst>
           </p:cNvPr>
@@ -18009,7 +18637,7 @@
           <p:cNvPr id="8" name="">
             <a:extLst xmlns:a="http://schemas.openxmlformats.org/drawingml/2006/main">
               <a:ext uri="{FF2B5EF4-FFF2-40B4-BE49-F238E27FC236}">
-                <a16:creationId xmlns:a16="http://schemas.microsoft.com/office/drawing/2014/main" id="{AFA992FA-7AF5-46B4-AFD5-7C293E0E70F8}"/>
+                <a16:creationId xmlns:a16="http://schemas.microsoft.com/office/drawing/2014/main" id="{CA9861A9-2DFE-42CD-9A65-CFC9249B9F52}"/>
               </a:ext>
             </a:extLst>
           </p:cNvPr>
@@ -18042,7 +18670,7 @@
           <p:cNvPr id="9" name="">
             <a:extLst xmlns:a="http://schemas.openxmlformats.org/drawingml/2006/main">
               <a:ext uri="{FF2B5EF4-FFF2-40B4-BE49-F238E27FC236}">
-                <a16:creationId xmlns:a16="http://schemas.microsoft.com/office/drawing/2014/main" id="{DFA7F33F-2E66-48F1-81F0-1EE9BF01F50C}"/>
+                <a16:creationId xmlns:a16="http://schemas.microsoft.com/office/drawing/2014/main" id="{27444114-7D18-4EAE-882F-5CE3F4581764}"/>
               </a:ext>
             </a:extLst>
           </p:cNvPr>
@@ -18199,7 +18827,7 @@
           <p:cNvPr id="10" name="">
             <a:extLst xmlns:a="http://schemas.openxmlformats.org/drawingml/2006/main">
               <a:ext uri="{FF2B5EF4-FFF2-40B4-BE49-F238E27FC236}">
-                <a16:creationId xmlns:a16="http://schemas.microsoft.com/office/drawing/2014/main" id="{FDC2B308-059E-4ECB-A8D7-057194A968EF}"/>
+                <a16:creationId xmlns:a16="http://schemas.microsoft.com/office/drawing/2014/main" id="{8E4D76FC-F165-4E6B-B0CD-F9F2B31D23E5}"/>
               </a:ext>
             </a:extLst>
           </p:cNvPr>
@@ -18379,7 +19007,7 @@
           <p:cNvPr id="11" name="">
             <a:extLst xmlns:a="http://schemas.openxmlformats.org/drawingml/2006/main">
               <a:ext uri="{FF2B5EF4-FFF2-40B4-BE49-F238E27FC236}">
-                <a16:creationId xmlns:a16="http://schemas.microsoft.com/office/drawing/2014/main" id="{9978F779-A425-4060-93E8-E9027F619FCE}"/>
+                <a16:creationId xmlns:a16="http://schemas.microsoft.com/office/drawing/2014/main" id="{9A1ACE3E-7FA8-44F7-B1D9-6FCC995A8AED}"/>
               </a:ext>
             </a:extLst>
           </p:cNvPr>
@@ -18410,7 +19038,7 @@
           <p:cNvPr id="12" name="">
             <a:extLst xmlns:a="http://schemas.openxmlformats.org/drawingml/2006/main">
               <a:ext uri="{FF2B5EF4-FFF2-40B4-BE49-F238E27FC236}">
-                <a16:creationId xmlns:a16="http://schemas.microsoft.com/office/drawing/2014/main" id="{05651402-66B4-435E-9E99-435C5FFA36FE}"/>
+                <a16:creationId xmlns:a16="http://schemas.microsoft.com/office/drawing/2014/main" id="{0EF6B0D5-DACE-4B87-A911-129F84A9C7A1}"/>
               </a:ext>
             </a:extLst>
           </p:cNvPr>
@@ -18443,7 +19071,7 @@
           <p:cNvPr id="13" name="">
             <a:extLst xmlns:a="http://schemas.openxmlformats.org/drawingml/2006/main">
               <a:ext uri="{FF2B5EF4-FFF2-40B4-BE49-F238E27FC236}">
-                <a16:creationId xmlns:a16="http://schemas.microsoft.com/office/drawing/2014/main" id="{9E83A5B3-A7BE-4ABF-A423-E6927701D035}"/>
+                <a16:creationId xmlns:a16="http://schemas.microsoft.com/office/drawing/2014/main" id="{819A3C7C-ACD6-4D3F-ADBF-333463B63573}"/>
               </a:ext>
             </a:extLst>
           </p:cNvPr>
@@ -18600,7 +19228,7 @@
           <p:cNvPr id="14" name="">
             <a:extLst xmlns:a="http://schemas.openxmlformats.org/drawingml/2006/main">
               <a:ext uri="{FF2B5EF4-FFF2-40B4-BE49-F238E27FC236}">
-                <a16:creationId xmlns:a16="http://schemas.microsoft.com/office/drawing/2014/main" id="{4415A495-5A8C-4083-8C23-8F3E06BA8279}"/>
+                <a16:creationId xmlns:a16="http://schemas.microsoft.com/office/drawing/2014/main" id="{05261CFD-56E0-49F1-B9FC-D9C34C67AC06}"/>
               </a:ext>
             </a:extLst>
           </p:cNvPr>
@@ -18780,7 +19408,7 @@
           <p:cNvPr id="15" name="">
             <a:extLst xmlns:a="http://schemas.openxmlformats.org/drawingml/2006/main">
               <a:ext uri="{FF2B5EF4-FFF2-40B4-BE49-F238E27FC236}">
-                <a16:creationId xmlns:a16="http://schemas.microsoft.com/office/drawing/2014/main" id="{AAB609EB-112B-47A3-ADE0-F038F9B62301}"/>
+                <a16:creationId xmlns:a16="http://schemas.microsoft.com/office/drawing/2014/main" id="{3F293E27-3B30-465B-A85E-3B4BBE0501B4}"/>
               </a:ext>
             </a:extLst>
           </p:cNvPr>
@@ -18811,7 +19439,7 @@
           <p:cNvPr id="16" name="">
             <a:extLst xmlns:a="http://schemas.openxmlformats.org/drawingml/2006/main">
               <a:ext uri="{FF2B5EF4-FFF2-40B4-BE49-F238E27FC236}">
-                <a16:creationId xmlns:a16="http://schemas.microsoft.com/office/drawing/2014/main" id="{73C45C3C-B3F9-4F89-957F-D3C83B1AEA1F}"/>
+                <a16:creationId xmlns:a16="http://schemas.microsoft.com/office/drawing/2014/main" id="{C47DFA25-F541-469A-846C-63A24D39E422}"/>
               </a:ext>
             </a:extLst>
           </p:cNvPr>
@@ -18844,7 +19472,7 @@
           <p:cNvPr id="17" name="">
             <a:extLst xmlns:a="http://schemas.openxmlformats.org/drawingml/2006/main">
               <a:ext uri="{FF2B5EF4-FFF2-40B4-BE49-F238E27FC236}">
-                <a16:creationId xmlns:a16="http://schemas.microsoft.com/office/drawing/2014/main" id="{81E0C2F6-729C-445D-B20D-D457A60AC515}"/>
+                <a16:creationId xmlns:a16="http://schemas.microsoft.com/office/drawing/2014/main" id="{476AE2B9-38D5-4DF4-87A5-6EF2DBF75FDC}"/>
               </a:ext>
             </a:extLst>
           </p:cNvPr>
@@ -19001,7 +19629,7 @@
           <p:cNvPr id="18" name="">
             <a:extLst xmlns:a="http://schemas.openxmlformats.org/drawingml/2006/main">
               <a:ext uri="{FF2B5EF4-FFF2-40B4-BE49-F238E27FC236}">
-                <a16:creationId xmlns:a16="http://schemas.microsoft.com/office/drawing/2014/main" id="{98AD64AC-6E5F-4CA1-8C42-AB4D7D635C90}"/>
+                <a16:creationId xmlns:a16="http://schemas.microsoft.com/office/drawing/2014/main" id="{CFC8E463-C2D5-4EDD-9D92-1E5C5ECDF4D1}"/>
               </a:ext>
             </a:extLst>
           </p:cNvPr>
@@ -19181,7 +19809,7 @@
           <p:cNvPr id="19" name="">
             <a:extLst xmlns:a="http://schemas.openxmlformats.org/drawingml/2006/main">
               <a:ext uri="{FF2B5EF4-FFF2-40B4-BE49-F238E27FC236}">
-                <a16:creationId xmlns:a16="http://schemas.microsoft.com/office/drawing/2014/main" id="{23086F94-4D51-479D-8AAC-E631BBE72305}"/>
+                <a16:creationId xmlns:a16="http://schemas.microsoft.com/office/drawing/2014/main" id="{5779660B-893D-45F5-97FB-9FE1DA6BD4A4}"/>
               </a:ext>
             </a:extLst>
           </p:cNvPr>
@@ -19338,7 +19966,7 @@
           <p:cNvPr id="20" name="">
             <a:extLst xmlns:a="http://schemas.openxmlformats.org/drawingml/2006/main">
               <a:ext uri="{FF2B5EF4-FFF2-40B4-BE49-F238E27FC236}">
-                <a16:creationId xmlns:a16="http://schemas.microsoft.com/office/drawing/2014/main" id="{2FFB0B97-7A02-45DE-BC1C-1FEED96D51B3}"/>
+                <a16:creationId xmlns:a16="http://schemas.microsoft.com/office/drawing/2014/main" id="{2374FBDA-D2A9-45EF-830D-C85F0A748647}"/>
               </a:ext>
             </a:extLst>
           </p:cNvPr>
@@ -19495,7 +20123,7 @@
           <p:cNvPr id="21" name="">
             <a:extLst xmlns:a="http://schemas.openxmlformats.org/drawingml/2006/main">
               <a:ext uri="{FF2B5EF4-FFF2-40B4-BE49-F238E27FC236}">
-                <a16:creationId xmlns:a16="http://schemas.microsoft.com/office/drawing/2014/main" id="{DB4B32D3-6155-4018-9286-C3765ED92A3A}"/>
+                <a16:creationId xmlns:a16="http://schemas.microsoft.com/office/drawing/2014/main" id="{69184C6B-7665-4EF1-8D60-4883BD0600AE}"/>
               </a:ext>
             </a:extLst>
           </p:cNvPr>
@@ -19642,7 +20270,7 @@
                 <a:ea typeface="Arial"/>
                 <a:cs typeface="Arial"/>
               </a:rPr>
-              <a:t>Also tested: regression, feasibility models and GP active learning.</a:t>
+              <a:t>13 policies tested • 8 learned • 2,925 retrospective replays</a:t>
             </a:r>
           </a:p>
         </p:txBody>
@@ -19650,7 +20278,7 @@
     </p:spTree>
     <p:extLst>
       <p:ext uri="{BB962C8B-B14F-4D97-AF65-F5344CB8AC3E}">
-        <p14:creationId xmlns:p14="http://schemas.microsoft.com/office/powerpoint/2010/main" val="1853977148"/>
+        <p14:creationId xmlns:p14="http://schemas.microsoft.com/office/powerpoint/2010/main" val="359337838"/>
       </p:ext>
     </p:extLst>
   </p:cSld>
@@ -19681,7 +20309,7 @@
           <p:cNvPr id="9" name="">
             <a:extLst xmlns:a="http://schemas.openxmlformats.org/drawingml/2006/main">
               <a:ext uri="{FF2B5EF4-FFF2-40B4-BE49-F238E27FC236}">
-                <a16:creationId xmlns:a16="http://schemas.microsoft.com/office/drawing/2014/main" id="{2FC2B5A2-B08E-48CC-A739-834649B02FC2}"/>
+                <a16:creationId xmlns:a16="http://schemas.microsoft.com/office/drawing/2014/main" id="{34FDB08E-BD0D-4074-A28F-1D37F886DE4A}"/>
               </a:ext>
             </a:extLst>
           </p:cNvPr>
@@ -19838,7 +20466,7 @@
           <p:cNvPr id="2" name="">
             <a:extLst xmlns:a="http://schemas.openxmlformats.org/drawingml/2006/main">
               <a:ext uri="{FF2B5EF4-FFF2-40B4-BE49-F238E27FC236}">
-                <a16:creationId xmlns:a16="http://schemas.microsoft.com/office/drawing/2014/main" id="{4655A17B-05DE-40B1-B17E-8A5C0BE5D963}"/>
+                <a16:creationId xmlns:a16="http://schemas.microsoft.com/office/drawing/2014/main" id="{CC9B74CB-A249-40BD-92BE-B234267F268A}"/>
               </a:ext>
             </a:extLst>
           </p:cNvPr>
@@ -19869,7 +20497,7 @@
           <p:cNvPr id="3" name="">
             <a:extLst xmlns:a="http://schemas.openxmlformats.org/drawingml/2006/main">
               <a:ext uri="{FF2B5EF4-FFF2-40B4-BE49-F238E27FC236}">
-                <a16:creationId xmlns:a16="http://schemas.microsoft.com/office/drawing/2014/main" id="{1AFD1C93-69F2-4C00-B779-D4FA80DF3FD3}"/>
+                <a16:creationId xmlns:a16="http://schemas.microsoft.com/office/drawing/2014/main" id="{78C9AC53-088E-40C8-86F4-84A37DB5709E}"/>
               </a:ext>
             </a:extLst>
           </p:cNvPr>
@@ -20026,7 +20654,7 @@
           <p:cNvPr id="4" name="Chart">
             <a:extLst xmlns:a="http://schemas.openxmlformats.org/drawingml/2006/main">
               <a:ext uri="{FF2B5EF4-FFF2-40B4-BE49-F238E27FC236}">
-                <a16:creationId xmlns:a16="http://schemas.microsoft.com/office/drawing/2014/main" id="{0F0C5177-3F04-4B09-BFAD-016B70528890}"/>
+                <a16:creationId xmlns:a16="http://schemas.microsoft.com/office/drawing/2014/main" id="{02324DD7-68AC-499D-A28A-7D7D78E2BC9C}"/>
               </a:ext>
             </a:extLst>
           </p:cNvPr>
@@ -20039,7 +20667,7 @@
         </p:xfrm>
         <a:graphic xmlns:a="http://schemas.openxmlformats.org/drawingml/2006/main">
           <a:graphicData uri="http://schemas.openxmlformats.org/drawingml/2006/chart">
-            <c:chart xmlns:r="http://schemas.openxmlformats.org/officeDocument/2006/relationships" xmlns:c="http://schemas.openxmlformats.org/drawingml/2006/chart" r:id="R27c93d529db64f25"/>
+            <c:chart xmlns:r="http://schemas.openxmlformats.org/officeDocument/2006/relationships" xmlns:c="http://schemas.openxmlformats.org/drawingml/2006/chart" r:id="R8bbaf23ee2ab44d8"/>
           </a:graphicData>
         </a:graphic>
       </p:graphicFrame>
@@ -20048,7 +20676,7 @@
           <p:cNvPr id="5" name="">
             <a:extLst xmlns:a="http://schemas.openxmlformats.org/drawingml/2006/main">
               <a:ext uri="{FF2B5EF4-FFF2-40B4-BE49-F238E27FC236}">
-                <a16:creationId xmlns:a16="http://schemas.microsoft.com/office/drawing/2014/main" id="{D683152C-92FD-47E9-8BC2-30DA37836FA6}"/>
+                <a16:creationId xmlns:a16="http://schemas.microsoft.com/office/drawing/2014/main" id="{CE5BF85E-A7A1-44D7-9D07-204A15D50158}"/>
               </a:ext>
             </a:extLst>
           </p:cNvPr>
@@ -20205,7 +20833,7 @@
           <p:cNvPr id="6" name="">
             <a:extLst xmlns:a="http://schemas.openxmlformats.org/drawingml/2006/main">
               <a:ext uri="{FF2B5EF4-FFF2-40B4-BE49-F238E27FC236}">
-                <a16:creationId xmlns:a16="http://schemas.microsoft.com/office/drawing/2014/main" id="{80EFC796-CAE2-4B62-9297-04C25818532C}"/>
+                <a16:creationId xmlns:a16="http://schemas.microsoft.com/office/drawing/2014/main" id="{0AF4E014-1D15-4049-BD1F-627131DFBF92}"/>
               </a:ext>
             </a:extLst>
           </p:cNvPr>
@@ -20408,7 +21036,7 @@
           <p:cNvPr id="7" name="">
             <a:extLst xmlns:a="http://schemas.openxmlformats.org/drawingml/2006/main">
               <a:ext uri="{FF2B5EF4-FFF2-40B4-BE49-F238E27FC236}">
-                <a16:creationId xmlns:a16="http://schemas.microsoft.com/office/drawing/2014/main" id="{4E26D031-AEA6-4A91-8302-0B6E9257012E}"/>
+                <a16:creationId xmlns:a16="http://schemas.microsoft.com/office/drawing/2014/main" id="{3C8FA38F-7C90-4FE1-9242-C3576FAC3924}"/>
               </a:ext>
             </a:extLst>
           </p:cNvPr>
@@ -20588,7 +21216,7 @@
           <p:cNvPr id="8" name="">
             <a:extLst xmlns:a="http://schemas.openxmlformats.org/drawingml/2006/main">
               <a:ext uri="{FF2B5EF4-FFF2-40B4-BE49-F238E27FC236}">
-                <a16:creationId xmlns:a16="http://schemas.microsoft.com/office/drawing/2014/main" id="{3998BAF6-92AF-4705-ABC3-B800B68D55FF}"/>
+                <a16:creationId xmlns:a16="http://schemas.microsoft.com/office/drawing/2014/main" id="{F0BCFB13-CDFD-4156-89BF-76FDE5658664}"/>
               </a:ext>
             </a:extLst>
           </p:cNvPr>
@@ -20743,7 +21371,7 @@
     </p:spTree>
     <p:extLst>
       <p:ext uri="{BB962C8B-B14F-4D97-AF65-F5344CB8AC3E}">
-        <p14:creationId xmlns:p14="http://schemas.microsoft.com/office/powerpoint/2010/main" val="256093630"/>
+        <p14:creationId xmlns:p14="http://schemas.microsoft.com/office/powerpoint/2010/main" val="439758488"/>
       </p:ext>
     </p:extLst>
   </p:cSld>
@@ -20774,7 +21402,7 @@
           <p:cNvPr id="27" name="">
             <a:extLst xmlns:a="http://schemas.openxmlformats.org/drawingml/2006/main">
               <a:ext uri="{FF2B5EF4-FFF2-40B4-BE49-F238E27FC236}">
-                <a16:creationId xmlns:a16="http://schemas.microsoft.com/office/drawing/2014/main" id="{7882E58C-95EE-438D-85E7-BDD4CA7EFD3B}"/>
+                <a16:creationId xmlns:a16="http://schemas.microsoft.com/office/drawing/2014/main" id="{6EFB3799-8D76-470C-B8FC-29B74D07171F}"/>
               </a:ext>
             </a:extLst>
           </p:cNvPr>
@@ -20931,7 +21559,7 @@
           <p:cNvPr id="2" name="">
             <a:extLst xmlns:a="http://schemas.openxmlformats.org/drawingml/2006/main">
               <a:ext uri="{FF2B5EF4-FFF2-40B4-BE49-F238E27FC236}">
-                <a16:creationId xmlns:a16="http://schemas.microsoft.com/office/drawing/2014/main" id="{F08B8EFC-3443-4E97-B1B5-9608ED39DF8C}"/>
+                <a16:creationId xmlns:a16="http://schemas.microsoft.com/office/drawing/2014/main" id="{881F4926-093B-40E3-80C3-AD59FA5B69A6}"/>
               </a:ext>
             </a:extLst>
           </p:cNvPr>
@@ -20962,7 +21590,7 @@
           <p:cNvPr id="3" name="">
             <a:extLst xmlns:a="http://schemas.openxmlformats.org/drawingml/2006/main">
               <a:ext uri="{FF2B5EF4-FFF2-40B4-BE49-F238E27FC236}">
-                <a16:creationId xmlns:a16="http://schemas.microsoft.com/office/drawing/2014/main" id="{6BB140D1-9BB7-4868-9CF9-DAC7D94E9546}"/>
+                <a16:creationId xmlns:a16="http://schemas.microsoft.com/office/drawing/2014/main" id="{9B11AA80-320A-4556-BE0E-DCDE68AEBB7E}"/>
               </a:ext>
             </a:extLst>
           </p:cNvPr>
@@ -21119,7 +21747,7 @@
           <p:cNvPr id="4" name="">
             <a:extLst xmlns:a="http://schemas.openxmlformats.org/drawingml/2006/main">
               <a:ext uri="{FF2B5EF4-FFF2-40B4-BE49-F238E27FC236}">
-                <a16:creationId xmlns:a16="http://schemas.microsoft.com/office/drawing/2014/main" id="{B26DEBC3-025F-4235-95A6-F99382386B56}"/>
+                <a16:creationId xmlns:a16="http://schemas.microsoft.com/office/drawing/2014/main" id="{F55B0203-F0F2-46A0-A290-A03E0BD0FB99}"/>
               </a:ext>
             </a:extLst>
           </p:cNvPr>
@@ -21152,7 +21780,7 @@
           <p:cNvPr id="5" name="">
             <a:extLst xmlns:a="http://schemas.openxmlformats.org/drawingml/2006/main">
               <a:ext uri="{FF2B5EF4-FFF2-40B4-BE49-F238E27FC236}">
-                <a16:creationId xmlns:a16="http://schemas.microsoft.com/office/drawing/2014/main" id="{F248D006-76F1-41FE-9924-6D65469EAFAD}"/>
+                <a16:creationId xmlns:a16="http://schemas.microsoft.com/office/drawing/2014/main" id="{C6C7B386-BCB6-4696-B491-31C6E047C6EE}"/>
               </a:ext>
             </a:extLst>
           </p:cNvPr>
@@ -21309,7 +21937,7 @@
           <p:cNvPr id="6" name="">
             <a:extLst xmlns:a="http://schemas.openxmlformats.org/drawingml/2006/main">
               <a:ext uri="{FF2B5EF4-FFF2-40B4-BE49-F238E27FC236}">
-                <a16:creationId xmlns:a16="http://schemas.microsoft.com/office/drawing/2014/main" id="{2E8AD829-E499-4B39-AB40-24A0219FBB41}"/>
+                <a16:creationId xmlns:a16="http://schemas.microsoft.com/office/drawing/2014/main" id="{10B77955-FA12-4CCE-A571-F9E2E514ADB9}"/>
               </a:ext>
             </a:extLst>
           </p:cNvPr>
@@ -21489,7 +22117,7 @@
           <p:cNvPr id="7" name="">
             <a:extLst xmlns:a="http://schemas.openxmlformats.org/drawingml/2006/main">
               <a:ext uri="{FF2B5EF4-FFF2-40B4-BE49-F238E27FC236}">
-                <a16:creationId xmlns:a16="http://schemas.microsoft.com/office/drawing/2014/main" id="{4CFF477D-4756-4108-B925-305E8628473B}"/>
+                <a16:creationId xmlns:a16="http://schemas.microsoft.com/office/drawing/2014/main" id="{B01E42B7-0CB4-4840-99C0-16D9B5C3ABDA}"/>
               </a:ext>
             </a:extLst>
           </p:cNvPr>
@@ -21520,7 +22148,7 @@
           <p:cNvPr id="8" name="">
             <a:extLst xmlns:a="http://schemas.openxmlformats.org/drawingml/2006/main">
               <a:ext uri="{FF2B5EF4-FFF2-40B4-BE49-F238E27FC236}">
-                <a16:creationId xmlns:a16="http://schemas.microsoft.com/office/drawing/2014/main" id="{9C196762-B94C-4376-ABA1-0200A94A6EA7}"/>
+                <a16:creationId xmlns:a16="http://schemas.microsoft.com/office/drawing/2014/main" id="{D14D97F5-CE14-4792-8318-EB90F2EFB294}"/>
               </a:ext>
             </a:extLst>
           </p:cNvPr>
@@ -21553,7 +22181,7 @@
           <p:cNvPr id="9" name="">
             <a:extLst xmlns:a="http://schemas.openxmlformats.org/drawingml/2006/main">
               <a:ext uri="{FF2B5EF4-FFF2-40B4-BE49-F238E27FC236}">
-                <a16:creationId xmlns:a16="http://schemas.microsoft.com/office/drawing/2014/main" id="{7351CCD3-D789-4247-8812-7DBEBB0862BE}"/>
+                <a16:creationId xmlns:a16="http://schemas.microsoft.com/office/drawing/2014/main" id="{ED8A6D45-D17A-4808-AFAE-019DBD72F7E8}"/>
               </a:ext>
             </a:extLst>
           </p:cNvPr>
@@ -21710,7 +22338,7 @@
           <p:cNvPr id="10" name="">
             <a:extLst xmlns:a="http://schemas.openxmlformats.org/drawingml/2006/main">
               <a:ext uri="{FF2B5EF4-FFF2-40B4-BE49-F238E27FC236}">
-                <a16:creationId xmlns:a16="http://schemas.microsoft.com/office/drawing/2014/main" id="{66142669-FC3F-4E65-8DB1-270C95DDCC6F}"/>
+                <a16:creationId xmlns:a16="http://schemas.microsoft.com/office/drawing/2014/main" id="{EECEBB33-2B04-454C-B764-A295CA304D40}"/>
               </a:ext>
             </a:extLst>
           </p:cNvPr>
@@ -21890,7 +22518,7 @@
           <p:cNvPr id="11" name="">
             <a:extLst xmlns:a="http://schemas.openxmlformats.org/drawingml/2006/main">
               <a:ext uri="{FF2B5EF4-FFF2-40B4-BE49-F238E27FC236}">
-                <a16:creationId xmlns:a16="http://schemas.microsoft.com/office/drawing/2014/main" id="{1D725198-BC13-4D94-8DC3-46E8718572F2}"/>
+                <a16:creationId xmlns:a16="http://schemas.microsoft.com/office/drawing/2014/main" id="{15688CC8-D5D0-4BB2-AC5D-7D48DC5F45FA}"/>
               </a:ext>
             </a:extLst>
           </p:cNvPr>
@@ -21921,7 +22549,7 @@
           <p:cNvPr id="12" name="">
             <a:extLst xmlns:a="http://schemas.openxmlformats.org/drawingml/2006/main">
               <a:ext uri="{FF2B5EF4-FFF2-40B4-BE49-F238E27FC236}">
-                <a16:creationId xmlns:a16="http://schemas.microsoft.com/office/drawing/2014/main" id="{9548B3B1-EF45-4E33-8ABE-BCE311EFBC82}"/>
+                <a16:creationId xmlns:a16="http://schemas.microsoft.com/office/drawing/2014/main" id="{E7B6675E-CF46-4BCD-8E92-CB1CD6AB6AD6}"/>
               </a:ext>
             </a:extLst>
           </p:cNvPr>
@@ -21954,7 +22582,7 @@
           <p:cNvPr id="13" name="">
             <a:extLst xmlns:a="http://schemas.openxmlformats.org/drawingml/2006/main">
               <a:ext uri="{FF2B5EF4-FFF2-40B4-BE49-F238E27FC236}">
-                <a16:creationId xmlns:a16="http://schemas.microsoft.com/office/drawing/2014/main" id="{BD9FFE70-9F3D-4E57-8FF1-88FFDD5AE163}"/>
+                <a16:creationId xmlns:a16="http://schemas.microsoft.com/office/drawing/2014/main" id="{34BF9A74-1936-4BD8-990F-3C9EDF3ACD09}"/>
               </a:ext>
             </a:extLst>
           </p:cNvPr>
@@ -22111,7 +22739,7 @@
           <p:cNvPr id="14" name="">
             <a:extLst xmlns:a="http://schemas.openxmlformats.org/drawingml/2006/main">
               <a:ext uri="{FF2B5EF4-FFF2-40B4-BE49-F238E27FC236}">
-                <a16:creationId xmlns:a16="http://schemas.microsoft.com/office/drawing/2014/main" id="{D9B4D3CE-1200-4E8B-9D03-1CDD9DAAD4FA}"/>
+                <a16:creationId xmlns:a16="http://schemas.microsoft.com/office/drawing/2014/main" id="{998FA2CD-222E-47BC-BDC7-BFC3BCCE5259}"/>
               </a:ext>
             </a:extLst>
           </p:cNvPr>
@@ -22291,7 +22919,7 @@
           <p:cNvPr id="15" name="">
             <a:extLst xmlns:a="http://schemas.openxmlformats.org/drawingml/2006/main">
               <a:ext uri="{FF2B5EF4-FFF2-40B4-BE49-F238E27FC236}">
-                <a16:creationId xmlns:a16="http://schemas.microsoft.com/office/drawing/2014/main" id="{E944CB38-6D08-4772-B629-F32A9C6964A6}"/>
+                <a16:creationId xmlns:a16="http://schemas.microsoft.com/office/drawing/2014/main" id="{CD491605-0DDB-43AF-BEC9-2BD1E1BC4F4C}"/>
               </a:ext>
             </a:extLst>
           </p:cNvPr>
@@ -22322,7 +22950,7 @@
           <p:cNvPr id="16" name="">
             <a:extLst xmlns:a="http://schemas.openxmlformats.org/drawingml/2006/main">
               <a:ext uri="{FF2B5EF4-FFF2-40B4-BE49-F238E27FC236}">
-                <a16:creationId xmlns:a16="http://schemas.microsoft.com/office/drawing/2014/main" id="{D12F222C-C641-489A-97B0-D8BDD9C55232}"/>
+                <a16:creationId xmlns:a16="http://schemas.microsoft.com/office/drawing/2014/main" id="{44D5D06D-1CB8-47FD-9826-8951FE102BED}"/>
               </a:ext>
             </a:extLst>
           </p:cNvPr>
@@ -22355,7 +22983,7 @@
           <p:cNvPr id="17" name="">
             <a:extLst xmlns:a="http://schemas.openxmlformats.org/drawingml/2006/main">
               <a:ext uri="{FF2B5EF4-FFF2-40B4-BE49-F238E27FC236}">
-                <a16:creationId xmlns:a16="http://schemas.microsoft.com/office/drawing/2014/main" id="{2520519D-FF69-427B-8205-FE65C448A6DC}"/>
+                <a16:creationId xmlns:a16="http://schemas.microsoft.com/office/drawing/2014/main" id="{29CD2DCA-6E31-400B-BE88-0F706A347D56}"/>
               </a:ext>
             </a:extLst>
           </p:cNvPr>
@@ -22512,7 +23140,7 @@
           <p:cNvPr id="18" name="">
             <a:extLst xmlns:a="http://schemas.openxmlformats.org/drawingml/2006/main">
               <a:ext uri="{FF2B5EF4-FFF2-40B4-BE49-F238E27FC236}">
-                <a16:creationId xmlns:a16="http://schemas.microsoft.com/office/drawing/2014/main" id="{73B8E21B-13E1-4E8D-BF60-973A09F1FA1F}"/>
+                <a16:creationId xmlns:a16="http://schemas.microsoft.com/office/drawing/2014/main" id="{EFA92BCD-130F-46C6-AC65-32EB62EC8AF9}"/>
               </a:ext>
             </a:extLst>
           </p:cNvPr>
@@ -22692,7 +23320,7 @@
           <p:cNvPr id="19" name="">
             <a:extLst xmlns:a="http://schemas.openxmlformats.org/drawingml/2006/main">
               <a:ext uri="{FF2B5EF4-FFF2-40B4-BE49-F238E27FC236}">
-                <a16:creationId xmlns:a16="http://schemas.microsoft.com/office/drawing/2014/main" id="{5621466C-5382-4DF2-8ECC-7FADEA57FA30}"/>
+                <a16:creationId xmlns:a16="http://schemas.microsoft.com/office/drawing/2014/main" id="{CC1BEE46-DD5E-4C13-B400-565EA8BCFB3A}"/>
               </a:ext>
             </a:extLst>
           </p:cNvPr>
@@ -22723,7 +23351,7 @@
           <p:cNvPr id="20" name="">
             <a:extLst xmlns:a="http://schemas.openxmlformats.org/drawingml/2006/main">
               <a:ext uri="{FF2B5EF4-FFF2-40B4-BE49-F238E27FC236}">
-                <a16:creationId xmlns:a16="http://schemas.microsoft.com/office/drawing/2014/main" id="{66BBABBD-3836-470D-A155-11FEEC931560}"/>
+                <a16:creationId xmlns:a16="http://schemas.microsoft.com/office/drawing/2014/main" id="{D5B2CB22-DCAC-4C19-97CC-39F10FBB32F1}"/>
               </a:ext>
             </a:extLst>
           </p:cNvPr>
@@ -22754,7 +23382,7 @@
           <p:cNvPr id="21" name="">
             <a:extLst xmlns:a="http://schemas.openxmlformats.org/drawingml/2006/main">
               <a:ext uri="{FF2B5EF4-FFF2-40B4-BE49-F238E27FC236}">
-                <a16:creationId xmlns:a16="http://schemas.microsoft.com/office/drawing/2014/main" id="{76F45BAE-47FE-42C4-B8E0-31535610DD7D}"/>
+                <a16:creationId xmlns:a16="http://schemas.microsoft.com/office/drawing/2014/main" id="{A9FB1893-1E61-40C1-BA3D-3AB482539B1E}"/>
               </a:ext>
             </a:extLst>
           </p:cNvPr>
@@ -22911,7 +23539,7 @@
           <p:cNvPr id="22" name="">
             <a:extLst xmlns:a="http://schemas.openxmlformats.org/drawingml/2006/main">
               <a:ext uri="{FF2B5EF4-FFF2-40B4-BE49-F238E27FC236}">
-                <a16:creationId xmlns:a16="http://schemas.microsoft.com/office/drawing/2014/main" id="{6D494EC1-1158-4E78-8E1A-B63ADE21A5B5}"/>
+                <a16:creationId xmlns:a16="http://schemas.microsoft.com/office/drawing/2014/main" id="{700FE1F2-317B-488D-B4F9-E50CA4BF8616}"/>
               </a:ext>
             </a:extLst>
           </p:cNvPr>
@@ -23068,7 +23696,7 @@
           <p:cNvPr id="23" name="">
             <a:extLst xmlns:a="http://schemas.openxmlformats.org/drawingml/2006/main">
               <a:ext uri="{FF2B5EF4-FFF2-40B4-BE49-F238E27FC236}">
-                <a16:creationId xmlns:a16="http://schemas.microsoft.com/office/drawing/2014/main" id="{AB8DF49E-2D8A-4015-B2B0-E2D19F14E010}"/>
+                <a16:creationId xmlns:a16="http://schemas.microsoft.com/office/drawing/2014/main" id="{CD89B04E-53FB-45DE-8A9B-2796C6533C76}"/>
               </a:ext>
             </a:extLst>
           </p:cNvPr>
@@ -23248,7 +23876,7 @@
           <p:cNvPr id="24" name="">
             <a:extLst xmlns:a="http://schemas.openxmlformats.org/drawingml/2006/main">
               <a:ext uri="{FF2B5EF4-FFF2-40B4-BE49-F238E27FC236}">
-                <a16:creationId xmlns:a16="http://schemas.microsoft.com/office/drawing/2014/main" id="{74C782B0-4978-41D2-8F64-155AAD200CAD}"/>
+                <a16:creationId xmlns:a16="http://schemas.microsoft.com/office/drawing/2014/main" id="{118E826C-8932-435B-BD34-E6EAD1F50141}"/>
               </a:ext>
             </a:extLst>
           </p:cNvPr>
@@ -23405,7 +24033,7 @@
           <p:cNvPr id="25" name="">
             <a:extLst xmlns:a="http://schemas.openxmlformats.org/drawingml/2006/main">
               <a:ext uri="{FF2B5EF4-FFF2-40B4-BE49-F238E27FC236}">
-                <a16:creationId xmlns:a16="http://schemas.microsoft.com/office/drawing/2014/main" id="{94070491-F65B-4519-9E30-46EF6BE0D0A2}"/>
+                <a16:creationId xmlns:a16="http://schemas.microsoft.com/office/drawing/2014/main" id="{C437C77C-16B1-4442-A44D-05626998F7B2}"/>
               </a:ext>
             </a:extLst>
           </p:cNvPr>
@@ -23552,7 +24180,7 @@
                 <a:ea typeface="Arial"/>
                 <a:cs typeface="Arial"/>
               </a:rPr>
-              <a:t>Coding, debugging, literature and analysis</a:t>
+              <a:t>AI-assisted scripts, testing and analysis</a:t>
             </a:r>
           </a:p>
           <a:p xmlns:a="http://schemas.openxmlformats.org/drawingml/2006/main">
@@ -23585,7 +24213,7 @@
           <p:cNvPr id="26" name="">
             <a:extLst xmlns:a="http://schemas.openxmlformats.org/drawingml/2006/main">
               <a:ext uri="{FF2B5EF4-FFF2-40B4-BE49-F238E27FC236}">
-                <a16:creationId xmlns:a16="http://schemas.microsoft.com/office/drawing/2014/main" id="{B5F5F227-0E96-4770-B438-9CD21BCCC3D2}"/>
+                <a16:creationId xmlns:a16="http://schemas.microsoft.com/office/drawing/2014/main" id="{93402058-22AC-43F7-88AB-25DA43B5FEC5}"/>
               </a:ext>
             </a:extLst>
           </p:cNvPr>
@@ -23740,7 +24368,7 @@
     </p:spTree>
     <p:extLst>
       <p:ext uri="{BB962C8B-B14F-4D97-AF65-F5344CB8AC3E}">
-        <p14:creationId xmlns:p14="http://schemas.microsoft.com/office/powerpoint/2010/main" val="413055730"/>
+        <p14:creationId xmlns:p14="http://schemas.microsoft.com/office/powerpoint/2010/main" val="758918212"/>
       </p:ext>
     </p:extLst>
   </p:cSld>
@@ -23771,7 +24399,7 @@
           <p:cNvPr id="9" name="">
             <a:extLst xmlns:a="http://schemas.openxmlformats.org/drawingml/2006/main">
               <a:ext uri="{FF2B5EF4-FFF2-40B4-BE49-F238E27FC236}">
-                <a16:creationId xmlns:a16="http://schemas.microsoft.com/office/drawing/2014/main" id="{75DB6AC2-DCC3-4973-BB66-E7A273CECB39}"/>
+                <a16:creationId xmlns:a16="http://schemas.microsoft.com/office/drawing/2014/main" id="{46CB975C-A6F9-4CA2-B308-3E1714D39562}"/>
               </a:ext>
             </a:extLst>
           </p:cNvPr>
@@ -23928,7 +24556,7 @@
           <p:cNvPr id="2" name="">
             <a:extLst xmlns:a="http://schemas.openxmlformats.org/drawingml/2006/main">
               <a:ext uri="{FF2B5EF4-FFF2-40B4-BE49-F238E27FC236}">
-                <a16:creationId xmlns:a16="http://schemas.microsoft.com/office/drawing/2014/main" id="{81CB349F-3430-4CA5-A6DB-6E3257E4F3EC}"/>
+                <a16:creationId xmlns:a16="http://schemas.microsoft.com/office/drawing/2014/main" id="{F1D632CC-F886-4CD8-8936-0F7A3738DAE1}"/>
               </a:ext>
             </a:extLst>
           </p:cNvPr>
@@ -23959,7 +24587,7 @@
           <p:cNvPr id="3" name="">
             <a:extLst xmlns:a="http://schemas.openxmlformats.org/drawingml/2006/main">
               <a:ext uri="{FF2B5EF4-FFF2-40B4-BE49-F238E27FC236}">
-                <a16:creationId xmlns:a16="http://schemas.microsoft.com/office/drawing/2014/main" id="{8AFDF8D2-29CF-46AA-A2A1-C36E0F685E87}"/>
+                <a16:creationId xmlns:a16="http://schemas.microsoft.com/office/drawing/2014/main" id="{28CA4A4F-5822-4FA6-8FCC-D91CC283FD53}"/>
               </a:ext>
             </a:extLst>
           </p:cNvPr>
@@ -24116,7 +24744,7 @@
           <p:cNvPr id="4" name="">
             <a:extLst xmlns:a="http://schemas.openxmlformats.org/drawingml/2006/main">
               <a:ext uri="{FF2B5EF4-FFF2-40B4-BE49-F238E27FC236}">
-                <a16:creationId xmlns:a16="http://schemas.microsoft.com/office/drawing/2014/main" id="{21A86B7F-5A7D-4B55-BDF5-46DFDB0B0B5A}"/>
+                <a16:creationId xmlns:a16="http://schemas.microsoft.com/office/drawing/2014/main" id="{562CE069-054D-4D5A-88F6-1C603ED94A12}"/>
               </a:ext>
             </a:extLst>
           </p:cNvPr>
@@ -24273,7 +24901,7 @@
           <p:cNvPr id="5" name="">
             <a:extLst xmlns:a="http://schemas.openxmlformats.org/drawingml/2006/main">
               <a:ext uri="{FF2B5EF4-FFF2-40B4-BE49-F238E27FC236}">
-                <a16:creationId xmlns:a16="http://schemas.microsoft.com/office/drawing/2014/main" id="{58540B2A-0056-4485-AE76-AE50BF1C8FA6}"/>
+                <a16:creationId xmlns:a16="http://schemas.microsoft.com/office/drawing/2014/main" id="{D2548CA0-66FE-4D72-8285-4E3A79C1D61A}"/>
               </a:ext>
             </a:extLst>
           </p:cNvPr>
@@ -24522,7 +25150,7 @@
           <p:cNvPr id="6" name="">
             <a:extLst xmlns:a="http://schemas.openxmlformats.org/drawingml/2006/main">
               <a:ext uri="{FF2B5EF4-FFF2-40B4-BE49-F238E27FC236}">
-                <a16:creationId xmlns:a16="http://schemas.microsoft.com/office/drawing/2014/main" id="{DF20E616-CB49-4CE6-83B4-E747D946EFE7}"/>
+                <a16:creationId xmlns:a16="http://schemas.microsoft.com/office/drawing/2014/main" id="{A46FA2ED-2903-4CDD-BB21-BBD55BB9942F}"/>
               </a:ext>
             </a:extLst>
           </p:cNvPr>
@@ -24679,7 +25307,7 @@
           <p:cNvPr id="7" name="">
             <a:extLst xmlns:a="http://schemas.openxmlformats.org/drawingml/2006/main">
               <a:ext uri="{FF2B5EF4-FFF2-40B4-BE49-F238E27FC236}">
-                <a16:creationId xmlns:a16="http://schemas.microsoft.com/office/drawing/2014/main" id="{7468DB1D-C912-4AD0-BD97-EEE5E5543078}"/>
+                <a16:creationId xmlns:a16="http://schemas.microsoft.com/office/drawing/2014/main" id="{6BFE7AC8-90A5-4F08-8B81-F31D3B26C624}"/>
               </a:ext>
             </a:extLst>
           </p:cNvPr>
@@ -24928,7 +25556,7 @@
           <p:cNvPr id="8" name="">
             <a:extLst xmlns:a="http://schemas.openxmlformats.org/drawingml/2006/main">
               <a:ext uri="{FF2B5EF4-FFF2-40B4-BE49-F238E27FC236}">
-                <a16:creationId xmlns:a16="http://schemas.microsoft.com/office/drawing/2014/main" id="{4BA7B392-7FEB-4DF6-953B-03E7CFA9736B}"/>
+                <a16:creationId xmlns:a16="http://schemas.microsoft.com/office/drawing/2014/main" id="{2FABA984-F7B4-476B-A205-264B56581B22}"/>
               </a:ext>
             </a:extLst>
           </p:cNvPr>
@@ -25083,7 +25711,7 @@
     </p:spTree>
     <p:extLst>
       <p:ext uri="{BB962C8B-B14F-4D97-AF65-F5344CB8AC3E}">
-        <p14:creationId xmlns:p14="http://schemas.microsoft.com/office/powerpoint/2010/main" val="1897287884"/>
+        <p14:creationId xmlns:p14="http://schemas.microsoft.com/office/powerpoint/2010/main" val="737326393"/>
       </p:ext>
     </p:extLst>
   </p:cSld>

</xml_diff>

<commit_message>
Add verified findings from earlier ISAForge chat history
</commit_message>
<xml_diff>
--- a/submissions/midterm-2026-10-28/isaforge-midterm-progress-slides-final.pptx
+++ b/submissions/midterm-2026-10-28/isaforge-midterm-progress-slides-final.pptx
@@ -2,23 +2,23 @@
 <file path=ppt/presentation.xml><?xml version="1.0" encoding="utf-8"?>
 <p:presentation xmlns:p="http://schemas.openxmlformats.org/presentationml/2006/main">
   <p:sldMasterIdLst>
-    <p:sldMasterId xmlns:r="http://schemas.openxmlformats.org/officeDocument/2006/relationships" id="2147483648" r:id="R0623956cba924f6a"/>
+    <p:sldMasterId xmlns:r="http://schemas.openxmlformats.org/officeDocument/2006/relationships" id="2147483648" r:id="R8566ba1cccaf4f96"/>
   </p:sldMasterIdLst>
   <p:notesMasterIdLst>
-    <p:notesMasterId xmlns:r="http://schemas.openxmlformats.org/officeDocument/2006/relationships" r:id="R478eb663ac444115"/>
+    <p:notesMasterId xmlns:r="http://schemas.openxmlformats.org/officeDocument/2006/relationships" r:id="Rf4f1ecc471ed45f5"/>
   </p:notesMasterIdLst>
   <p:sldIdLst>
-    <p:sldId xmlns:r="http://schemas.openxmlformats.org/officeDocument/2006/relationships" id="256" r:id="R18c80ad563cc4e9d"/>
-    <p:sldId xmlns:r="http://schemas.openxmlformats.org/officeDocument/2006/relationships" id="257" r:id="Rd47b3ce9ce9b4183"/>
-    <p:sldId xmlns:r="http://schemas.openxmlformats.org/officeDocument/2006/relationships" id="258" r:id="R55aed49ad1f14496"/>
-    <p:sldId xmlns:r="http://schemas.openxmlformats.org/officeDocument/2006/relationships" id="259" r:id="R715b2bdfcdb8421d"/>
-    <p:sldId xmlns:r="http://schemas.openxmlformats.org/officeDocument/2006/relationships" id="260" r:id="R0836f81688c14d9e"/>
-    <p:sldId xmlns:r="http://schemas.openxmlformats.org/officeDocument/2006/relationships" id="261" r:id="R7f2b1b0af4254625"/>
-    <p:sldId xmlns:r="http://schemas.openxmlformats.org/officeDocument/2006/relationships" id="262" r:id="Red77a0d0b6714133"/>
-    <p:sldId xmlns:r="http://schemas.openxmlformats.org/officeDocument/2006/relationships" id="263" r:id="R8cf89c8779b14c04"/>
-    <p:sldId xmlns:r="http://schemas.openxmlformats.org/officeDocument/2006/relationships" id="264" r:id="R13c4a78f60014a4a"/>
-    <p:sldId xmlns:r="http://schemas.openxmlformats.org/officeDocument/2006/relationships" id="265" r:id="R9f44b38896434a42"/>
-    <p:sldId xmlns:r="http://schemas.openxmlformats.org/officeDocument/2006/relationships" id="266" r:id="R74f8aefdcc85453d"/>
+    <p:sldId xmlns:r="http://schemas.openxmlformats.org/officeDocument/2006/relationships" id="256" r:id="Ra9829389fc574085"/>
+    <p:sldId xmlns:r="http://schemas.openxmlformats.org/officeDocument/2006/relationships" id="257" r:id="R802e39ff4c1742ab"/>
+    <p:sldId xmlns:r="http://schemas.openxmlformats.org/officeDocument/2006/relationships" id="258" r:id="Rd3742b487df448ef"/>
+    <p:sldId xmlns:r="http://schemas.openxmlformats.org/officeDocument/2006/relationships" id="259" r:id="R14c977e1277b46e8"/>
+    <p:sldId xmlns:r="http://schemas.openxmlformats.org/officeDocument/2006/relationships" id="260" r:id="R41a8945c3b3d45f8"/>
+    <p:sldId xmlns:r="http://schemas.openxmlformats.org/officeDocument/2006/relationships" id="261" r:id="R0ce0e45aa4b94a53"/>
+    <p:sldId xmlns:r="http://schemas.openxmlformats.org/officeDocument/2006/relationships" id="262" r:id="R4180ca8d15ab41bf"/>
+    <p:sldId xmlns:r="http://schemas.openxmlformats.org/officeDocument/2006/relationships" id="263" r:id="R22e0ab48a77043d8"/>
+    <p:sldId xmlns:r="http://schemas.openxmlformats.org/officeDocument/2006/relationships" id="264" r:id="R71a0f0ca0e244518"/>
+    <p:sldId xmlns:r="http://schemas.openxmlformats.org/officeDocument/2006/relationships" id="265" r:id="Rf306c1110d7449c9"/>
+    <p:sldId xmlns:r="http://schemas.openxmlformats.org/officeDocument/2006/relationships" id="266" r:id="R913bd8f539514003"/>
   </p:sldIdLst>
   <p:sldSz cx="12192000" cy="6858000"/>
   <p:notesSz cx="6858000" cy="9144000"/>
@@ -567,7 +567,7 @@
           </a:p>
           <a:p xmlns:a="http://schemas.openxmlformats.org/drawingml/2006/main">
             <a:r>
-              <a:t>Here is the main selection result. The vertical axis is mean cycle-reduction regret relative to the best measured feasible candidate in each complete pool; lower is better. At one attempt, merit has 1.132 percent regret and the ranker has 0.842 percent. At two attempts they are almost tied. At three attempts, merit is better. The paired workload confidence intervals include zero for the early-budget advantages, so we cannot claim consistent superiority. Twelve workload groups have complete pool oracles; two incomplete groups are excluded from this regret calculation. The 2,925 policy-budget replays are dependent analyses of the existing measurements, not new hardware experiments. There is also an important diagnosis: all 122 historical cycle-speedup labels match the independently calibrated processor-latency calculation. This dataset therefore does not demonstrate a residual speedup relationship requiring machine learning. Our remaining challenge is learning which useful designs will be hardware-feasible and worth measuring. The Ascon pilot proves the selection-to-measurement connection, but its incomplete pool and missing controls prevent an agent-performance claim.</a:t>
+              <a:t>Here is the main selection result. The vertical axis is mean cycle-reduction regret relative to the best measured feasible candidate in each complete pool; lower is better. At one attempt, merit has 1.132 percent regret and the ranker has 0.842 percent. At two attempts they are almost tied. At three attempts, merit is better. The paired workload confidence intervals include zero for the early-budget advantages, so we cannot claim consistent superiority. Twelve workload groups have complete pool oracles; two incomplete groups are excluded from this regret calculation. The 2,925 policy-budget replays are dependent analyses of the existing measurements, not new hardware experiments. There is also an important diagnosis: all 122 historical cycle-speedup labels match the independently calibrated processor-latency calculation. This dataset therefore does not demonstrate a residual speedup relationship requiring machine learning. Our remaining challenge is learning which useful designs will be hardware-feasible and worth measuring. A previous three-source blind campaign favored both GP policies over merit at three attempts, but a later bitcount test favored the latency-cost heuristic. Those mixed results do not establish a general advantage. The Ascon pilot has no matched controls.</a:t>
             </a:r>
           </a:p>
           <a:p xmlns:a="http://schemas.openxmlformats.org/drawingml/2006/main">
@@ -582,7 +582,7 @@
           </a:p>
           <a:p xmlns:a="http://schemas.openxmlformats.org/drawingml/2006/main">
             <a:r>
-              <a:t>results/2026-10-27-final-selection-scorecard/scorecard.json. Paired difference = merit regret minus ranker regret (percentage points): B1 +0.290 [−0.065,+0.849]; B2 +0.027 [−0.097,+0.177]; B3 −0.056 [−0.167,0.000]. Workload bootstrap;12 complete pools.14-group cycle-reduction means merit1.086/1.657/2.043%;ranker1.334/1.680/1.996%. Timing floor weakly tested:minimum selected feasible Fmax59.13MHz vs12MHz. Target mean eval time merit55.67/114.24/169.76s;ranker56.29/115.69/171.46s. No total-cost advantage established.</a:t>
+              <a:t>results/2026-10-27-final-selection-scorecard/scorecard.json. Paired difference = merit regret minus ranker regret (percentage points): B1 +0.290 [−0.065,+0.849]; B2 +0.027 [−0.097,+0.177]; B3 −0.056 [−0.167,0.000]. Workload bootstrap;12 complete pools.14-group cycle-reduction means merit1.086/1.657/2.043%;ranker1.334/1.680/1.996%. Earlier frozen three-source campaign: GP 1.602185% mean cycle reduction vs merit 1.144539% at B3; only three sources and cooperative replay, no total-cost win established. Later bitcount B3 latency-cost heuristic found 0.174118% improvement while both GP policies returned baseline. docs/blind-source-campaign.md; results/2026-10-22-bitcount-report/results.md. Timing floor weakly tested:minimum selected feasible Fmax59.13MHz vs12MHz. Target mean eval time merit55.67/114.24/169.76s;ranker56.29/115.69/171.46s. No total-cost advantage established.</a:t>
             </a:r>
           </a:p>
         </p:txBody>
@@ -1087,7 +1087,7 @@
           </a:p>
           <a:p xmlns:a="http://schemas.openxmlformats.org/drawingml/2006/main">
             <a:r>
-              <a:t>Our first dataset used eight Embench programs and 301 synthesized isolated circuits to train a LUT-cost model. That is separate from the current whole-program dataset of 122 measured candidate-program results across fourteen workload groups, plus four charged failures. The chart shows the three suites in that current corpus. We hold out entire workloads. Our thirteen-policy screen includes 2,925 replays of existing measurements, not new hardware runs.</a:t>
+              <a:t>Our first hardware-cost study grew from 301 to 713 distinct synthesized formulas across benchmark collections. Those isolated LUT labels are separate from the current whole-program dataset: 122 candidate-program measurements across fourteen workload groups, plus four charged failures. The chart shows its three benchmark suites. We hold out entire workloads. Our thirteen-policy screen includes 2,925 replays of existing measurements, not new hardware runs.</a:t>
             </a:r>
           </a:p>
           <a:p xmlns:a="http://schemas.openxmlformats.org/drawingml/2006/main">
@@ -1102,7 +1102,7 @@
           </a:p>
           <a:p xmlns:a="http://schemas.openxmlformats.org/drawingml/2006/main">
             <a:r>
-              <a:t>Earlier area dataset: results/2026-10-13/README.md: 339 candidate examples, 301 distinct synthesized formulas from eight Embench programs; isolated LUT4 labels, not processor cycles; grouped held-out XGBoost MAE 33.08 versus 77.32 LUT4 mean baseline. Current dataset: submissions/midterm-2026-10-28/dataset/; results/2026-10-27-final-selection-scorecard/scorecard.json. 15 build/input contexts;12 complete measured-pool oracles,2 censored. Embench39 labels/6 groups; BEEBS48/5; TACLeBench35/3. Original teammate hardware-branch data uses a distinct context and is not silently merged.</a:t>
+              <a:t>Earlier area study: initial 301 formulas, later three collections 1,098 program/formula rows and 713 distinct formulas from 17 candidate-bearing programs; isolated LUT4 labels, not processor cycles. The frozen original-301 model evaluated 331 novel final formulas: structural linear 23.154 LUT4 MAE versus original XGBoost 87.595. Later all-713 deployment refit lacks a fresh independent test. See results/2026-10-13-prospective/README.md and docs/methodology-history.md. Current dataset: submissions/midterm-2026-10-28/dataset/; results/2026-10-27-final-selection-scorecard/scorecard.json. 15 build/input contexts;12 complete measured-pool oracles,2 censored. Embench39 labels/6 groups; BEEBS48/5; TACLeBench35/3. Original teammate hardware-branch data uses a distinct context and is not silently merged.</a:t>
             </a:r>
           </a:p>
         </p:txBody>
@@ -1549,7 +1549,7 @@
           <p:cNvPr id="3" name="Title">
             <a:extLst xmlns:a="http://schemas.openxmlformats.org/drawingml/2006/main">
               <a:ext uri="{FF2B5EF4-FFF2-40B4-BE49-F238E27FC236}">
-                <a16:creationId xmlns:a16="http://schemas.microsoft.com/office/drawing/2014/main" id="{FA7E7869-FB95-4337-8546-8707339279DA}"/>
+                <a16:creationId xmlns:a16="http://schemas.microsoft.com/office/drawing/2014/main" id="{F5C602D6-95BC-4A98-94ED-A9EAC5681E35}"/>
               </a:ext>
             </a:extLst>
           </p:cNvPr>
@@ -1778,7 +1778,7 @@
           <p:cNvPr id="2" name="Subtitle">
             <a:extLst xmlns:a="http://schemas.openxmlformats.org/drawingml/2006/main">
               <a:ext uri="{FF2B5EF4-FFF2-40B4-BE49-F238E27FC236}">
-                <a16:creationId xmlns:a16="http://schemas.microsoft.com/office/drawing/2014/main" id="{AD5BF009-84C8-4DEC-97A3-50D4AB170160}"/>
+                <a16:creationId xmlns:a16="http://schemas.microsoft.com/office/drawing/2014/main" id="{DF52B176-63C0-4A97-97E7-BDB5392B340C}"/>
               </a:ext>
             </a:extLst>
           </p:cNvPr>
@@ -2024,7 +2024,7 @@
           <p:cNvPr id="2" name="Section title">
             <a:extLst xmlns:a="http://schemas.openxmlformats.org/drawingml/2006/main">
               <a:ext uri="{FF2B5EF4-FFF2-40B4-BE49-F238E27FC236}">
-                <a16:creationId xmlns:a16="http://schemas.microsoft.com/office/drawing/2014/main" id="{E5C8598C-FAAD-4C8E-9310-256ACD6AAD0B}"/>
+                <a16:creationId xmlns:a16="http://schemas.microsoft.com/office/drawing/2014/main" id="{435A7BD1-4DDF-4B22-9518-9136BFED9049}"/>
               </a:ext>
             </a:extLst>
           </p:cNvPr>
@@ -2270,7 +2270,7 @@
           <p:cNvPr id="3" name="Title">
             <a:extLst xmlns:a="http://schemas.openxmlformats.org/drawingml/2006/main">
               <a:ext uri="{FF2B5EF4-FFF2-40B4-BE49-F238E27FC236}">
-                <a16:creationId xmlns:a16="http://schemas.microsoft.com/office/drawing/2014/main" id="{4B9DF5A9-54D7-4A3B-9A55-15D420065F94}"/>
+                <a16:creationId xmlns:a16="http://schemas.microsoft.com/office/drawing/2014/main" id="{FB817CE6-DC83-41C0-A96C-6BDB889CABC2}"/>
               </a:ext>
             </a:extLst>
           </p:cNvPr>
@@ -2499,7 +2499,7 @@
           <p:cNvPr id="2" name="Body">
             <a:extLst xmlns:a="http://schemas.openxmlformats.org/drawingml/2006/main">
               <a:ext uri="{FF2B5EF4-FFF2-40B4-BE49-F238E27FC236}">
-                <a16:creationId xmlns:a16="http://schemas.microsoft.com/office/drawing/2014/main" id="{7160F0B8-2161-4057-85BC-C937818E6686}"/>
+                <a16:creationId xmlns:a16="http://schemas.microsoft.com/office/drawing/2014/main" id="{C0AFC915-E7C8-48EB-A3B8-C586B170268F}"/>
               </a:ext>
             </a:extLst>
           </p:cNvPr>
@@ -2745,7 +2745,7 @@
           <p:cNvPr id="4" name="Title">
             <a:extLst xmlns:a="http://schemas.openxmlformats.org/drawingml/2006/main">
               <a:ext uri="{FF2B5EF4-FFF2-40B4-BE49-F238E27FC236}">
-                <a16:creationId xmlns:a16="http://schemas.microsoft.com/office/drawing/2014/main" id="{3045B9A8-5734-4D86-B2D9-D7761ECA4102}"/>
+                <a16:creationId xmlns:a16="http://schemas.microsoft.com/office/drawing/2014/main" id="{6115151F-AA64-4B32-BF5F-EF0306EB9690}"/>
               </a:ext>
             </a:extLst>
           </p:cNvPr>
@@ -2974,7 +2974,7 @@
           <p:cNvPr id="2" name="Left column">
             <a:extLst xmlns:a="http://schemas.openxmlformats.org/drawingml/2006/main">
               <a:ext uri="{FF2B5EF4-FFF2-40B4-BE49-F238E27FC236}">
-                <a16:creationId xmlns:a16="http://schemas.microsoft.com/office/drawing/2014/main" id="{477D2F0D-684E-4D09-95CB-8833D5753831}"/>
+                <a16:creationId xmlns:a16="http://schemas.microsoft.com/office/drawing/2014/main" id="{2C1D0A56-CD3B-482F-8823-7C45FB523C3F}"/>
               </a:ext>
             </a:extLst>
           </p:cNvPr>
@@ -3203,7 +3203,7 @@
           <p:cNvPr id="3" name="Right column">
             <a:extLst xmlns:a="http://schemas.openxmlformats.org/drawingml/2006/main">
               <a:ext uri="{FF2B5EF4-FFF2-40B4-BE49-F238E27FC236}">
-                <a16:creationId xmlns:a16="http://schemas.microsoft.com/office/drawing/2014/main" id="{185AF445-C131-48F0-84C3-F8A5807E9624}"/>
+                <a16:creationId xmlns:a16="http://schemas.microsoft.com/office/drawing/2014/main" id="{86D873EA-AD99-49D3-A595-EC83CB3976CB}"/>
               </a:ext>
             </a:extLst>
           </p:cNvPr>
@@ -3449,7 +3449,7 @@
           <p:cNvPr id="3" name="Title">
             <a:extLst xmlns:a="http://schemas.openxmlformats.org/drawingml/2006/main">
               <a:ext uri="{FF2B5EF4-FFF2-40B4-BE49-F238E27FC236}">
-                <a16:creationId xmlns:a16="http://schemas.microsoft.com/office/drawing/2014/main" id="{206E28C4-DE41-47C5-AD13-C17F7AAFB393}"/>
+                <a16:creationId xmlns:a16="http://schemas.microsoft.com/office/drawing/2014/main" id="{FC2FE6C2-5C93-408F-A84B-91528F7D72A2}"/>
               </a:ext>
             </a:extLst>
           </p:cNvPr>
@@ -3678,7 +3678,7 @@
           <p:cNvPr id="2" name="Left column">
             <a:extLst xmlns:a="http://schemas.openxmlformats.org/drawingml/2006/main">
               <a:ext uri="{FF2B5EF4-FFF2-40B4-BE49-F238E27FC236}">
-                <a16:creationId xmlns:a16="http://schemas.microsoft.com/office/drawing/2014/main" id="{6716925A-8C92-467B-AF92-33C242633675}"/>
+                <a16:creationId xmlns:a16="http://schemas.microsoft.com/office/drawing/2014/main" id="{1ABDC9AE-BC1C-495F-A3D7-98C98F73514E}"/>
               </a:ext>
             </a:extLst>
           </p:cNvPr>
@@ -3945,12 +3945,12 @@
   </p:cSld>
   <p:clrMap bg1="lt1" tx1="dk1" bg2="lt2" tx2="dk2" accent1="accent1" accent2="accent2" accent3="accent3" accent4="accent4" accent5="accent5" accent6="accent6" hlink="hlink" folHlink="folHlink"/>
   <p:sldLayoutIdLst>
-    <p:sldLayoutId xmlns:r="http://schemas.openxmlformats.org/officeDocument/2006/relationships" id="2147483649" r:id="Rebeeaeaf1dd04382"/>
-    <p:sldLayoutId xmlns:r="http://schemas.openxmlformats.org/officeDocument/2006/relationships" id="2147483650" r:id="R08c7c02e24af4c7c"/>
-    <p:sldLayoutId xmlns:r="http://schemas.openxmlformats.org/officeDocument/2006/relationships" id="2147483651" r:id="R455dfc98caf849f3"/>
-    <p:sldLayoutId xmlns:r="http://schemas.openxmlformats.org/officeDocument/2006/relationships" id="2147483652" r:id="Ra4470d83d5fc49f3"/>
-    <p:sldLayoutId xmlns:r="http://schemas.openxmlformats.org/officeDocument/2006/relationships" id="2147483653" r:id="Rc967ae79e226438c"/>
-    <p:sldLayoutId xmlns:r="http://schemas.openxmlformats.org/officeDocument/2006/relationships" id="2147483654" r:id="R6e912c3354604b04"/>
+    <p:sldLayoutId xmlns:r="http://schemas.openxmlformats.org/officeDocument/2006/relationships" id="2147483649" r:id="Rf5853933bc2649fa"/>
+    <p:sldLayoutId xmlns:r="http://schemas.openxmlformats.org/officeDocument/2006/relationships" id="2147483650" r:id="R0d368ef1b8cf4ba0"/>
+    <p:sldLayoutId xmlns:r="http://schemas.openxmlformats.org/officeDocument/2006/relationships" id="2147483651" r:id="R5d6da2ee8a40451a"/>
+    <p:sldLayoutId xmlns:r="http://schemas.openxmlformats.org/officeDocument/2006/relationships" id="2147483652" r:id="R3d1a8b92c97244e6"/>
+    <p:sldLayoutId xmlns:r="http://schemas.openxmlformats.org/officeDocument/2006/relationships" id="2147483653" r:id="R459fafd97d084ec3"/>
+    <p:sldLayoutId xmlns:r="http://schemas.openxmlformats.org/officeDocument/2006/relationships" id="2147483654" r:id="Rdd42467abec64f3d"/>
   </p:sldLayoutIdLst>
   <p:txStyles>
     <p:titleStyle>
@@ -5273,7 +5273,7 @@
           <p:cNvPr id="8" name="">
             <a:extLst xmlns:a="http://schemas.openxmlformats.org/drawingml/2006/main">
               <a:ext uri="{FF2B5EF4-FFF2-40B4-BE49-F238E27FC236}">
-                <a16:creationId xmlns:a16="http://schemas.microsoft.com/office/drawing/2014/main" id="{61DE2131-48A5-4E47-B050-97CD3EC14902}"/>
+                <a16:creationId xmlns:a16="http://schemas.microsoft.com/office/drawing/2014/main" id="{7FDC0041-AF61-4062-A814-78B43041C73C}"/>
               </a:ext>
             </a:extLst>
           </p:cNvPr>
@@ -5430,7 +5430,7 @@
           <p:cNvPr id="2" name="">
             <a:extLst xmlns:a="http://schemas.openxmlformats.org/drawingml/2006/main">
               <a:ext uri="{FF2B5EF4-FFF2-40B4-BE49-F238E27FC236}">
-                <a16:creationId xmlns:a16="http://schemas.microsoft.com/office/drawing/2014/main" id="{51739359-DE02-4D74-B803-100B8C2820A7}"/>
+                <a16:creationId xmlns:a16="http://schemas.microsoft.com/office/drawing/2014/main" id="{67C7500F-0820-4E8F-B324-E39572F3D189}"/>
               </a:ext>
             </a:extLst>
           </p:cNvPr>
@@ -5461,7 +5461,7 @@
           <p:cNvPr id="3" name="">
             <a:extLst xmlns:a="http://schemas.openxmlformats.org/drawingml/2006/main">
               <a:ext uri="{FF2B5EF4-FFF2-40B4-BE49-F238E27FC236}">
-                <a16:creationId xmlns:a16="http://schemas.microsoft.com/office/drawing/2014/main" id="{0ABEC04D-DAB8-430E-A6AD-BDBBE75057BC}"/>
+                <a16:creationId xmlns:a16="http://schemas.microsoft.com/office/drawing/2014/main" id="{03FE7972-DBA2-4B8A-88E0-964C8AA4EA27}"/>
               </a:ext>
             </a:extLst>
           </p:cNvPr>
@@ -5618,7 +5618,7 @@
           <p:cNvPr id="4" name="">
             <a:extLst xmlns:a="http://schemas.openxmlformats.org/drawingml/2006/main">
               <a:ext uri="{FF2B5EF4-FFF2-40B4-BE49-F238E27FC236}">
-                <a16:creationId xmlns:a16="http://schemas.microsoft.com/office/drawing/2014/main" id="{71A35658-B7B1-450B-B8F5-3D138D807265}"/>
+                <a16:creationId xmlns:a16="http://schemas.microsoft.com/office/drawing/2014/main" id="{3BBCD238-59F3-4C90-B0B8-56B5CCC5A5B8}"/>
               </a:ext>
             </a:extLst>
           </p:cNvPr>
@@ -5775,7 +5775,7 @@
           <p:cNvPr id="5" name="">
             <a:extLst xmlns:a="http://schemas.openxmlformats.org/drawingml/2006/main">
               <a:ext uri="{FF2B5EF4-FFF2-40B4-BE49-F238E27FC236}">
-                <a16:creationId xmlns:a16="http://schemas.microsoft.com/office/drawing/2014/main" id="{59C98795-4483-43A8-B07B-CEDCC0CD2D2B}"/>
+                <a16:creationId xmlns:a16="http://schemas.microsoft.com/office/drawing/2014/main" id="{84BCB66F-A669-474C-A9A4-282E9FA36E91}"/>
               </a:ext>
             </a:extLst>
           </p:cNvPr>
@@ -5955,7 +5955,7 @@
           <p:cNvPr id="6" name="">
             <a:extLst xmlns:a="http://schemas.openxmlformats.org/drawingml/2006/main">
               <a:ext uri="{FF2B5EF4-FFF2-40B4-BE49-F238E27FC236}">
-                <a16:creationId xmlns:a16="http://schemas.microsoft.com/office/drawing/2014/main" id="{A76882A7-0856-4069-9716-CCC7FDDA99C8}"/>
+                <a16:creationId xmlns:a16="http://schemas.microsoft.com/office/drawing/2014/main" id="{A7532DE6-3127-4345-A20E-0EFEDC0E3465}"/>
               </a:ext>
             </a:extLst>
           </p:cNvPr>
@@ -6112,7 +6112,7 @@
           <p:cNvPr id="7" name="">
             <a:extLst xmlns:a="http://schemas.openxmlformats.org/drawingml/2006/main">
               <a:ext uri="{FF2B5EF4-FFF2-40B4-BE49-F238E27FC236}">
-                <a16:creationId xmlns:a16="http://schemas.microsoft.com/office/drawing/2014/main" id="{3CC734E7-4672-4968-889B-08A25F7BB9C6}"/>
+                <a16:creationId xmlns:a16="http://schemas.microsoft.com/office/drawing/2014/main" id="{47B7FC0E-DE47-4DB4-8ADD-069551C00AC1}"/>
               </a:ext>
             </a:extLst>
           </p:cNvPr>
@@ -6267,7 +6267,7 @@
     </p:spTree>
     <p:extLst>
       <p:ext uri="{BB962C8B-B14F-4D97-AF65-F5344CB8AC3E}">
-        <p14:creationId xmlns:p14="http://schemas.microsoft.com/office/powerpoint/2010/main" val="1675780396"/>
+        <p14:creationId xmlns:p14="http://schemas.microsoft.com/office/powerpoint/2010/main" val="259353831"/>
       </p:ext>
     </p:extLst>
   </p:cSld>
@@ -6298,7 +6298,7 @@
           <p:cNvPr id="9" name="">
             <a:extLst xmlns:a="http://schemas.openxmlformats.org/drawingml/2006/main">
               <a:ext uri="{FF2B5EF4-FFF2-40B4-BE49-F238E27FC236}">
-                <a16:creationId xmlns:a16="http://schemas.microsoft.com/office/drawing/2014/main" id="{F8581C0D-9D54-406E-A5BC-9A7136BF4F3C}"/>
+                <a16:creationId xmlns:a16="http://schemas.microsoft.com/office/drawing/2014/main" id="{7A7B25A1-1D6A-4B26-A880-BBD1ABB8370C}"/>
               </a:ext>
             </a:extLst>
           </p:cNvPr>
@@ -6455,7 +6455,7 @@
           <p:cNvPr id="2" name="">
             <a:extLst xmlns:a="http://schemas.openxmlformats.org/drawingml/2006/main">
               <a:ext uri="{FF2B5EF4-FFF2-40B4-BE49-F238E27FC236}">
-                <a16:creationId xmlns:a16="http://schemas.microsoft.com/office/drawing/2014/main" id="{9A8792D2-62F5-4658-ADC0-1F1AA787C46C}"/>
+                <a16:creationId xmlns:a16="http://schemas.microsoft.com/office/drawing/2014/main" id="{F6FD2889-580A-4FE9-917F-940843B0FE41}"/>
               </a:ext>
             </a:extLst>
           </p:cNvPr>
@@ -6486,7 +6486,7 @@
           <p:cNvPr id="3" name="">
             <a:extLst xmlns:a="http://schemas.openxmlformats.org/drawingml/2006/main">
               <a:ext uri="{FF2B5EF4-FFF2-40B4-BE49-F238E27FC236}">
-                <a16:creationId xmlns:a16="http://schemas.microsoft.com/office/drawing/2014/main" id="{B51BDA9C-70B9-407F-BA1A-5CCF4162BD7C}"/>
+                <a16:creationId xmlns:a16="http://schemas.microsoft.com/office/drawing/2014/main" id="{93390E27-473C-40DA-87C4-49AD09C7FBBF}"/>
               </a:ext>
             </a:extLst>
           </p:cNvPr>
@@ -6643,7 +6643,7 @@
           <p:cNvPr id="4" name="Chart">
             <a:extLst xmlns:a="http://schemas.openxmlformats.org/drawingml/2006/main">
               <a:ext uri="{FF2B5EF4-FFF2-40B4-BE49-F238E27FC236}">
-                <a16:creationId xmlns:a16="http://schemas.microsoft.com/office/drawing/2014/main" id="{E7BB5A51-C31F-4E2A-864D-B8A22DAA26A4}"/>
+                <a16:creationId xmlns:a16="http://schemas.microsoft.com/office/drawing/2014/main" id="{452768A5-5CE6-4EA3-ABCC-7102C24743ED}"/>
               </a:ext>
             </a:extLst>
           </p:cNvPr>
@@ -6656,7 +6656,7 @@
         </p:xfrm>
         <a:graphic xmlns:a="http://schemas.openxmlformats.org/drawingml/2006/main">
           <a:graphicData uri="http://schemas.openxmlformats.org/drawingml/2006/chart">
-            <c:chart xmlns:r="http://schemas.openxmlformats.org/officeDocument/2006/relationships" xmlns:c="http://schemas.openxmlformats.org/drawingml/2006/chart" r:id="Rd718d523413242cd"/>
+            <c:chart xmlns:r="http://schemas.openxmlformats.org/officeDocument/2006/relationships" xmlns:c="http://schemas.openxmlformats.org/drawingml/2006/chart" r:id="R0d8f5e27d98344a9"/>
           </a:graphicData>
         </a:graphic>
       </p:graphicFrame>
@@ -6665,7 +6665,7 @@
           <p:cNvPr id="5" name="">
             <a:extLst xmlns:a="http://schemas.openxmlformats.org/drawingml/2006/main">
               <a:ext uri="{FF2B5EF4-FFF2-40B4-BE49-F238E27FC236}">
-                <a16:creationId xmlns:a16="http://schemas.microsoft.com/office/drawing/2014/main" id="{9E65921B-B821-481E-8394-67B371A86205}"/>
+                <a16:creationId xmlns:a16="http://schemas.microsoft.com/office/drawing/2014/main" id="{7CA1AC87-7199-4D47-8645-3DA2F60055A2}"/>
               </a:ext>
             </a:extLst>
           </p:cNvPr>
@@ -6822,7 +6822,7 @@
           <p:cNvPr id="6" name="">
             <a:extLst xmlns:a="http://schemas.openxmlformats.org/drawingml/2006/main">
               <a:ext uri="{FF2B5EF4-FFF2-40B4-BE49-F238E27FC236}">
-                <a16:creationId xmlns:a16="http://schemas.microsoft.com/office/drawing/2014/main" id="{8172B635-7605-4FFC-BDE3-2DF6967A85FE}"/>
+                <a16:creationId xmlns:a16="http://schemas.microsoft.com/office/drawing/2014/main" id="{7A8212DE-4A89-43F2-870D-6269A01E1850}"/>
               </a:ext>
             </a:extLst>
           </p:cNvPr>
@@ -7053,7 +7053,7 @@
           <p:cNvPr id="7" name="">
             <a:extLst xmlns:a="http://schemas.openxmlformats.org/drawingml/2006/main">
               <a:ext uri="{FF2B5EF4-FFF2-40B4-BE49-F238E27FC236}">
-                <a16:creationId xmlns:a16="http://schemas.microsoft.com/office/drawing/2014/main" id="{E0AF0C83-5CFE-4459-87F0-E8ADCE0C1AAF}"/>
+                <a16:creationId xmlns:a16="http://schemas.microsoft.com/office/drawing/2014/main" id="{4F6D068B-4D76-4551-9C3B-B0ABE435B6A2}"/>
               </a:ext>
             </a:extLst>
           </p:cNvPr>
@@ -7233,7 +7233,7 @@
           <p:cNvPr id="8" name="">
             <a:extLst xmlns:a="http://schemas.openxmlformats.org/drawingml/2006/main">
               <a:ext uri="{FF2B5EF4-FFF2-40B4-BE49-F238E27FC236}">
-                <a16:creationId xmlns:a16="http://schemas.microsoft.com/office/drawing/2014/main" id="{860BDED1-9C5F-47D6-B963-B7A1CF79488E}"/>
+                <a16:creationId xmlns:a16="http://schemas.microsoft.com/office/drawing/2014/main" id="{85E5DDA7-5173-4D29-A576-5C2F5A2CF025}"/>
               </a:ext>
             </a:extLst>
           </p:cNvPr>
@@ -7388,7 +7388,7 @@
     </p:spTree>
     <p:extLst>
       <p:ext uri="{BB962C8B-B14F-4D97-AF65-F5344CB8AC3E}">
-        <p14:creationId xmlns:p14="http://schemas.microsoft.com/office/powerpoint/2010/main" val="1978658533"/>
+        <p14:creationId xmlns:p14="http://schemas.microsoft.com/office/powerpoint/2010/main" val="1539456164"/>
       </p:ext>
     </p:extLst>
   </p:cSld>
@@ -7419,7 +7419,7 @@
           <p:cNvPr id="9" name="">
             <a:extLst xmlns:a="http://schemas.openxmlformats.org/drawingml/2006/main">
               <a:ext uri="{FF2B5EF4-FFF2-40B4-BE49-F238E27FC236}">
-                <a16:creationId xmlns:a16="http://schemas.microsoft.com/office/drawing/2014/main" id="{EFEE2C31-3030-47B0-84D2-FC30DCA3BDE1}"/>
+                <a16:creationId xmlns:a16="http://schemas.microsoft.com/office/drawing/2014/main" id="{28B2FB8C-8D4E-400A-B3FB-EFCFF1C2ABDF}"/>
               </a:ext>
             </a:extLst>
           </p:cNvPr>
@@ -7576,7 +7576,7 @@
           <p:cNvPr id="2" name="">
             <a:extLst xmlns:a="http://schemas.openxmlformats.org/drawingml/2006/main">
               <a:ext uri="{FF2B5EF4-FFF2-40B4-BE49-F238E27FC236}">
-                <a16:creationId xmlns:a16="http://schemas.microsoft.com/office/drawing/2014/main" id="{B7EC99B5-D270-4EB5-BC92-EBE242089CB0}"/>
+                <a16:creationId xmlns:a16="http://schemas.microsoft.com/office/drawing/2014/main" id="{7A00AFCA-90BE-453F-88B6-F22136E5B702}"/>
               </a:ext>
             </a:extLst>
           </p:cNvPr>
@@ -7607,7 +7607,7 @@
           <p:cNvPr id="3" name="">
             <a:extLst xmlns:a="http://schemas.openxmlformats.org/drawingml/2006/main">
               <a:ext uri="{FF2B5EF4-FFF2-40B4-BE49-F238E27FC236}">
-                <a16:creationId xmlns:a16="http://schemas.microsoft.com/office/drawing/2014/main" id="{EBC7367A-4A27-4D1F-AE63-8A02DD29884F}"/>
+                <a16:creationId xmlns:a16="http://schemas.microsoft.com/office/drawing/2014/main" id="{7836A346-5043-4F52-98A5-B26BD006FFF0}"/>
               </a:ext>
             </a:extLst>
           </p:cNvPr>
@@ -7764,7 +7764,7 @@
           <p:cNvPr id="4" name="">
             <a:extLst xmlns:a="http://schemas.openxmlformats.org/drawingml/2006/main">
               <a:ext uri="{FF2B5EF4-FFF2-40B4-BE49-F238E27FC236}">
-                <a16:creationId xmlns:a16="http://schemas.microsoft.com/office/drawing/2014/main" id="{E4AD5BA2-0080-44E9-B179-62D72B8CF9CE}"/>
+                <a16:creationId xmlns:a16="http://schemas.microsoft.com/office/drawing/2014/main" id="{62418BA4-BDFE-4E09-8E28-52570E534A9D}"/>
               </a:ext>
             </a:extLst>
           </p:cNvPr>
@@ -7921,7 +7921,7 @@
           <p:cNvPr id="5" name="">
             <a:extLst xmlns:a="http://schemas.openxmlformats.org/drawingml/2006/main">
               <a:ext uri="{FF2B5EF4-FFF2-40B4-BE49-F238E27FC236}">
-                <a16:creationId xmlns:a16="http://schemas.microsoft.com/office/drawing/2014/main" id="{A99CF495-418B-4B01-A459-C2E1291B2D84}"/>
+                <a16:creationId xmlns:a16="http://schemas.microsoft.com/office/drawing/2014/main" id="{30CA01C1-6A22-41EB-94CB-D7A3CB0D26D8}"/>
               </a:ext>
             </a:extLst>
           </p:cNvPr>
@@ -8147,7 +8147,7 @@
           <p:cNvPr id="6" name="">
             <a:extLst xmlns:a="http://schemas.openxmlformats.org/drawingml/2006/main">
               <a:ext uri="{FF2B5EF4-FFF2-40B4-BE49-F238E27FC236}">
-                <a16:creationId xmlns:a16="http://schemas.microsoft.com/office/drawing/2014/main" id="{15354239-8553-4ACB-BED4-ADDF58BA92BA}"/>
+                <a16:creationId xmlns:a16="http://schemas.microsoft.com/office/drawing/2014/main" id="{FF668C37-42C0-4E2E-BFA0-B0B81CFC12CA}"/>
               </a:ext>
             </a:extLst>
           </p:cNvPr>
@@ -8304,7 +8304,7 @@
           <p:cNvPr id="7" name="">
             <a:extLst xmlns:a="http://schemas.openxmlformats.org/drawingml/2006/main">
               <a:ext uri="{FF2B5EF4-FFF2-40B4-BE49-F238E27FC236}">
-                <a16:creationId xmlns:a16="http://schemas.microsoft.com/office/drawing/2014/main" id="{807B9610-149C-4A5E-8C1E-3CB04F3811CD}"/>
+                <a16:creationId xmlns:a16="http://schemas.microsoft.com/office/drawing/2014/main" id="{59CB0E14-BAFF-4D74-8024-797C6B3B94EA}"/>
               </a:ext>
             </a:extLst>
           </p:cNvPr>
@@ -8530,7 +8530,7 @@
           <p:cNvPr id="8" name="">
             <a:extLst xmlns:a="http://schemas.openxmlformats.org/drawingml/2006/main">
               <a:ext uri="{FF2B5EF4-FFF2-40B4-BE49-F238E27FC236}">
-                <a16:creationId xmlns:a16="http://schemas.microsoft.com/office/drawing/2014/main" id="{C85883D3-5395-4547-A511-8821A14E3F4B}"/>
+                <a16:creationId xmlns:a16="http://schemas.microsoft.com/office/drawing/2014/main" id="{0057D2BA-7741-423B-916F-8B0A98872CC7}"/>
               </a:ext>
             </a:extLst>
           </p:cNvPr>
@@ -8685,7 +8685,7 @@
     </p:spTree>
     <p:extLst>
       <p:ext uri="{BB962C8B-B14F-4D97-AF65-F5344CB8AC3E}">
-        <p14:creationId xmlns:p14="http://schemas.microsoft.com/office/powerpoint/2010/main" val="385360529"/>
+        <p14:creationId xmlns:p14="http://schemas.microsoft.com/office/powerpoint/2010/main" val="1855195373"/>
       </p:ext>
     </p:extLst>
   </p:cSld>
@@ -8716,7 +8716,7 @@
           <p:cNvPr id="20" name="">
             <a:extLst xmlns:a="http://schemas.openxmlformats.org/drawingml/2006/main">
               <a:ext uri="{FF2B5EF4-FFF2-40B4-BE49-F238E27FC236}">
-                <a16:creationId xmlns:a16="http://schemas.microsoft.com/office/drawing/2014/main" id="{6777DFFD-B63C-4E45-A272-49123FD8B41B}"/>
+                <a16:creationId xmlns:a16="http://schemas.microsoft.com/office/drawing/2014/main" id="{5B0D65BC-17C5-444C-BAA4-F4C7D1266674}"/>
               </a:ext>
             </a:extLst>
           </p:cNvPr>
@@ -8873,7 +8873,7 @@
           <p:cNvPr id="2" name="">
             <a:extLst xmlns:a="http://schemas.openxmlformats.org/drawingml/2006/main">
               <a:ext uri="{FF2B5EF4-FFF2-40B4-BE49-F238E27FC236}">
-                <a16:creationId xmlns:a16="http://schemas.microsoft.com/office/drawing/2014/main" id="{01C31A0B-D5D6-4D49-A7C9-E9152C6D6E73}"/>
+                <a16:creationId xmlns:a16="http://schemas.microsoft.com/office/drawing/2014/main" id="{87DE2890-0F8C-49FA-BA63-47966E00E52B}"/>
               </a:ext>
             </a:extLst>
           </p:cNvPr>
@@ -8904,7 +8904,7 @@
           <p:cNvPr id="3" name="">
             <a:extLst xmlns:a="http://schemas.openxmlformats.org/drawingml/2006/main">
               <a:ext uri="{FF2B5EF4-FFF2-40B4-BE49-F238E27FC236}">
-                <a16:creationId xmlns:a16="http://schemas.microsoft.com/office/drawing/2014/main" id="{B1EF5656-A7AD-4B43-9ECC-027B3543A45B}"/>
+                <a16:creationId xmlns:a16="http://schemas.microsoft.com/office/drawing/2014/main" id="{28612F1C-5E52-4B48-B634-C7EBB03A0279}"/>
               </a:ext>
             </a:extLst>
           </p:cNvPr>
@@ -9061,7 +9061,7 @@
           <p:cNvPr id="4" name="">
             <a:extLst xmlns:a="http://schemas.openxmlformats.org/drawingml/2006/main">
               <a:ext uri="{FF2B5EF4-FFF2-40B4-BE49-F238E27FC236}">
-                <a16:creationId xmlns:a16="http://schemas.microsoft.com/office/drawing/2014/main" id="{FCC6D045-0CD3-44A5-933D-8BC28645FB1F}"/>
+                <a16:creationId xmlns:a16="http://schemas.microsoft.com/office/drawing/2014/main" id="{53382C57-4F62-4CB0-B218-EF8B6AD4AAA1}"/>
               </a:ext>
             </a:extLst>
           </p:cNvPr>
@@ -9218,7 +9218,7 @@
           <p:cNvPr id="5" name="">
             <a:extLst xmlns:a="http://schemas.openxmlformats.org/drawingml/2006/main">
               <a:ext uri="{FF2B5EF4-FFF2-40B4-BE49-F238E27FC236}">
-                <a16:creationId xmlns:a16="http://schemas.microsoft.com/office/drawing/2014/main" id="{64B9D309-56DF-47E9-ADFE-F3866A282927}"/>
+                <a16:creationId xmlns:a16="http://schemas.microsoft.com/office/drawing/2014/main" id="{BA8FC150-E22B-4263-BF56-846B9394675E}"/>
               </a:ext>
             </a:extLst>
           </p:cNvPr>
@@ -9375,7 +9375,7 @@
           <p:cNvPr id="6" name="">
             <a:extLst xmlns:a="http://schemas.openxmlformats.org/drawingml/2006/main">
               <a:ext uri="{FF2B5EF4-FFF2-40B4-BE49-F238E27FC236}">
-                <a16:creationId xmlns:a16="http://schemas.microsoft.com/office/drawing/2014/main" id="{46FC94BF-D1F4-4DEA-9827-ED58837EBD04}"/>
+                <a16:creationId xmlns:a16="http://schemas.microsoft.com/office/drawing/2014/main" id="{1A813AB1-E7A3-4AF5-89B7-8361658243D1}"/>
               </a:ext>
             </a:extLst>
           </p:cNvPr>
@@ -9532,7 +9532,7 @@
           <p:cNvPr id="7" name="">
             <a:extLst xmlns:a="http://schemas.openxmlformats.org/drawingml/2006/main">
               <a:ext uri="{FF2B5EF4-FFF2-40B4-BE49-F238E27FC236}">
-                <a16:creationId xmlns:a16="http://schemas.microsoft.com/office/drawing/2014/main" id="{25B7B12C-723D-49A9-9CEB-D450D1AF429B}"/>
+                <a16:creationId xmlns:a16="http://schemas.microsoft.com/office/drawing/2014/main" id="{E4D7BC91-8165-4D0B-B864-EB885B3CEBDF}"/>
               </a:ext>
             </a:extLst>
           </p:cNvPr>
@@ -9563,7 +9563,7 @@
           <p:cNvPr id="8" name="">
             <a:extLst xmlns:a="http://schemas.openxmlformats.org/drawingml/2006/main">
               <a:ext uri="{FF2B5EF4-FFF2-40B4-BE49-F238E27FC236}">
-                <a16:creationId xmlns:a16="http://schemas.microsoft.com/office/drawing/2014/main" id="{53060440-9B6C-4840-9FBB-CB982E51EF30}"/>
+                <a16:creationId xmlns:a16="http://schemas.microsoft.com/office/drawing/2014/main" id="{6202A92A-78B7-476D-A302-3906581C75FC}"/>
               </a:ext>
             </a:extLst>
           </p:cNvPr>
@@ -9720,7 +9720,7 @@
           <p:cNvPr id="9" name="">
             <a:extLst xmlns:a="http://schemas.openxmlformats.org/drawingml/2006/main">
               <a:ext uri="{FF2B5EF4-FFF2-40B4-BE49-F238E27FC236}">
-                <a16:creationId xmlns:a16="http://schemas.microsoft.com/office/drawing/2014/main" id="{075FC094-FB8B-4A4F-AECB-E01D0C1AC510}"/>
+                <a16:creationId xmlns:a16="http://schemas.microsoft.com/office/drawing/2014/main" id="{B8036EF4-656D-4FFC-805C-5C86B2A42749}"/>
               </a:ext>
             </a:extLst>
           </p:cNvPr>
@@ -9877,7 +9877,7 @@
           <p:cNvPr id="10" name="">
             <a:extLst xmlns:a="http://schemas.openxmlformats.org/drawingml/2006/main">
               <a:ext uri="{FF2B5EF4-FFF2-40B4-BE49-F238E27FC236}">
-                <a16:creationId xmlns:a16="http://schemas.microsoft.com/office/drawing/2014/main" id="{1A7D89E3-57F6-4267-AA5F-D3219628A0A7}"/>
+                <a16:creationId xmlns:a16="http://schemas.microsoft.com/office/drawing/2014/main" id="{BF379C6F-5119-4A35-BF03-F413CAA2A155}"/>
               </a:ext>
             </a:extLst>
           </p:cNvPr>
@@ -10034,7 +10034,7 @@
           <p:cNvPr id="11" name="">
             <a:extLst xmlns:a="http://schemas.openxmlformats.org/drawingml/2006/main">
               <a:ext uri="{FF2B5EF4-FFF2-40B4-BE49-F238E27FC236}">
-                <a16:creationId xmlns:a16="http://schemas.microsoft.com/office/drawing/2014/main" id="{F00F49B4-C877-422D-8F40-1868F192FF93}"/>
+                <a16:creationId xmlns:a16="http://schemas.microsoft.com/office/drawing/2014/main" id="{48DA7E31-6640-43C5-A801-2A6A49C6CE0A}"/>
               </a:ext>
             </a:extLst>
           </p:cNvPr>
@@ -10065,7 +10065,7 @@
           <p:cNvPr id="12" name="">
             <a:extLst xmlns:a="http://schemas.openxmlformats.org/drawingml/2006/main">
               <a:ext uri="{FF2B5EF4-FFF2-40B4-BE49-F238E27FC236}">
-                <a16:creationId xmlns:a16="http://schemas.microsoft.com/office/drawing/2014/main" id="{7AC3B62D-A5C9-4DCC-AD6E-12FFDE922919}"/>
+                <a16:creationId xmlns:a16="http://schemas.microsoft.com/office/drawing/2014/main" id="{D3D64880-D6E5-4EA6-BBC6-5BE83485E9B6}"/>
               </a:ext>
             </a:extLst>
           </p:cNvPr>
@@ -10222,7 +10222,7 @@
           <p:cNvPr id="13" name="">
             <a:extLst xmlns:a="http://schemas.openxmlformats.org/drawingml/2006/main">
               <a:ext uri="{FF2B5EF4-FFF2-40B4-BE49-F238E27FC236}">
-                <a16:creationId xmlns:a16="http://schemas.microsoft.com/office/drawing/2014/main" id="{3B4D0DE5-3E0C-4BD0-AAE7-F3136B41F785}"/>
+                <a16:creationId xmlns:a16="http://schemas.microsoft.com/office/drawing/2014/main" id="{BC03E20C-0525-47E6-A47D-53C035808892}"/>
               </a:ext>
             </a:extLst>
           </p:cNvPr>
@@ -10379,7 +10379,7 @@
           <p:cNvPr id="14" name="">
             <a:extLst xmlns:a="http://schemas.openxmlformats.org/drawingml/2006/main">
               <a:ext uri="{FF2B5EF4-FFF2-40B4-BE49-F238E27FC236}">
-                <a16:creationId xmlns:a16="http://schemas.microsoft.com/office/drawing/2014/main" id="{FB6F202F-31FB-4739-A76D-A831F08301C6}"/>
+                <a16:creationId xmlns:a16="http://schemas.microsoft.com/office/drawing/2014/main" id="{689793E6-B062-439B-9B02-83EE481219FB}"/>
               </a:ext>
             </a:extLst>
           </p:cNvPr>
@@ -10536,7 +10536,7 @@
           <p:cNvPr id="15" name="">
             <a:extLst xmlns:a="http://schemas.openxmlformats.org/drawingml/2006/main">
               <a:ext uri="{FF2B5EF4-FFF2-40B4-BE49-F238E27FC236}">
-                <a16:creationId xmlns:a16="http://schemas.microsoft.com/office/drawing/2014/main" id="{ED732178-BE91-47F0-BBBB-0CC206FB82B6}"/>
+                <a16:creationId xmlns:a16="http://schemas.microsoft.com/office/drawing/2014/main" id="{80293A98-3743-43CD-B6B5-44935157C3DC}"/>
               </a:ext>
             </a:extLst>
           </p:cNvPr>
@@ -10567,7 +10567,7 @@
           <p:cNvPr id="16" name="">
             <a:extLst xmlns:a="http://schemas.openxmlformats.org/drawingml/2006/main">
               <a:ext uri="{FF2B5EF4-FFF2-40B4-BE49-F238E27FC236}">
-                <a16:creationId xmlns:a16="http://schemas.microsoft.com/office/drawing/2014/main" id="{4B25404B-8394-4B79-B5F5-28A2B16DE6AD}"/>
+                <a16:creationId xmlns:a16="http://schemas.microsoft.com/office/drawing/2014/main" id="{FA343E6E-9E48-47F5-85DC-545996A1CA67}"/>
               </a:ext>
             </a:extLst>
           </p:cNvPr>
@@ -10724,7 +10724,7 @@
           <p:cNvPr id="17" name="">
             <a:extLst xmlns:a="http://schemas.openxmlformats.org/drawingml/2006/main">
               <a:ext uri="{FF2B5EF4-FFF2-40B4-BE49-F238E27FC236}">
-                <a16:creationId xmlns:a16="http://schemas.microsoft.com/office/drawing/2014/main" id="{83024BD9-96C9-4324-A7F2-95417FE340DC}"/>
+                <a16:creationId xmlns:a16="http://schemas.microsoft.com/office/drawing/2014/main" id="{419CE40A-B661-49CB-B3C5-B5E94B22556D}"/>
               </a:ext>
             </a:extLst>
           </p:cNvPr>
@@ -10881,7 +10881,7 @@
           <p:cNvPr id="18" name="">
             <a:extLst xmlns:a="http://schemas.openxmlformats.org/drawingml/2006/main">
               <a:ext uri="{FF2B5EF4-FFF2-40B4-BE49-F238E27FC236}">
-                <a16:creationId xmlns:a16="http://schemas.microsoft.com/office/drawing/2014/main" id="{8D467B52-50F3-46EB-A1BD-0E408FB31629}"/>
+                <a16:creationId xmlns:a16="http://schemas.microsoft.com/office/drawing/2014/main" id="{9C459C9D-0868-4B20-BC0E-1B1550451C63}"/>
               </a:ext>
             </a:extLst>
           </p:cNvPr>
@@ -11038,7 +11038,7 @@
           <p:cNvPr id="19" name="">
             <a:extLst xmlns:a="http://schemas.openxmlformats.org/drawingml/2006/main">
               <a:ext uri="{FF2B5EF4-FFF2-40B4-BE49-F238E27FC236}">
-                <a16:creationId xmlns:a16="http://schemas.microsoft.com/office/drawing/2014/main" id="{31D3B1C6-E12F-432A-B56B-812D54070A6C}"/>
+                <a16:creationId xmlns:a16="http://schemas.microsoft.com/office/drawing/2014/main" id="{CDA071F8-743B-4040-A93A-A3FF2418BF57}"/>
               </a:ext>
             </a:extLst>
           </p:cNvPr>
@@ -11193,7 +11193,7 @@
     </p:spTree>
     <p:extLst>
       <p:ext uri="{BB962C8B-B14F-4D97-AF65-F5344CB8AC3E}">
-        <p14:creationId xmlns:p14="http://schemas.microsoft.com/office/powerpoint/2010/main" val="1830254580"/>
+        <p14:creationId xmlns:p14="http://schemas.microsoft.com/office/powerpoint/2010/main" val="1210164465"/>
       </p:ext>
     </p:extLst>
   </p:cSld>
@@ -11224,7 +11224,7 @@
           <p:cNvPr id="19" name="">
             <a:extLst xmlns:a="http://schemas.openxmlformats.org/drawingml/2006/main">
               <a:ext uri="{FF2B5EF4-FFF2-40B4-BE49-F238E27FC236}">
-                <a16:creationId xmlns:a16="http://schemas.microsoft.com/office/drawing/2014/main" id="{C152C74A-171E-466F-A272-A22D37B092AA}"/>
+                <a16:creationId xmlns:a16="http://schemas.microsoft.com/office/drawing/2014/main" id="{DC277C7A-B849-44A2-BE63-7D38F2704374}"/>
               </a:ext>
             </a:extLst>
           </p:cNvPr>
@@ -11381,7 +11381,7 @@
           <p:cNvPr id="2" name="">
             <a:extLst xmlns:a="http://schemas.openxmlformats.org/drawingml/2006/main">
               <a:ext uri="{FF2B5EF4-FFF2-40B4-BE49-F238E27FC236}">
-                <a16:creationId xmlns:a16="http://schemas.microsoft.com/office/drawing/2014/main" id="{6492210F-4D37-4BED-9C13-8C10E0556249}"/>
+                <a16:creationId xmlns:a16="http://schemas.microsoft.com/office/drawing/2014/main" id="{9CF9B8CF-383F-4879-9AFE-F95897AFFF3B}"/>
               </a:ext>
             </a:extLst>
           </p:cNvPr>
@@ -11412,7 +11412,7 @@
           <p:cNvPr id="3" name="">
             <a:extLst xmlns:a="http://schemas.openxmlformats.org/drawingml/2006/main">
               <a:ext uri="{FF2B5EF4-FFF2-40B4-BE49-F238E27FC236}">
-                <a16:creationId xmlns:a16="http://schemas.microsoft.com/office/drawing/2014/main" id="{0407901C-F576-4302-98C5-10FA6CB306B6}"/>
+                <a16:creationId xmlns:a16="http://schemas.microsoft.com/office/drawing/2014/main" id="{D67A4163-E809-4290-814E-4304360AB3F9}"/>
               </a:ext>
             </a:extLst>
           </p:cNvPr>
@@ -11569,7 +11569,7 @@
           <p:cNvPr id="4" name="">
             <a:extLst xmlns:a="http://schemas.openxmlformats.org/drawingml/2006/main">
               <a:ext uri="{FF2B5EF4-FFF2-40B4-BE49-F238E27FC236}">
-                <a16:creationId xmlns:a16="http://schemas.microsoft.com/office/drawing/2014/main" id="{E83798EC-A922-481A-8507-F81FA2D997AC}"/>
+                <a16:creationId xmlns:a16="http://schemas.microsoft.com/office/drawing/2014/main" id="{2813AB08-FC64-4E2C-8E97-23998233341C}"/>
               </a:ext>
             </a:extLst>
           </p:cNvPr>
@@ -11600,7 +11600,7 @@
           <p:cNvPr id="5" name="">
             <a:extLst xmlns:a="http://schemas.openxmlformats.org/drawingml/2006/main">
               <a:ext uri="{FF2B5EF4-FFF2-40B4-BE49-F238E27FC236}">
-                <a16:creationId xmlns:a16="http://schemas.microsoft.com/office/drawing/2014/main" id="{E91AD153-4BC7-4B63-9116-EA673932740A}"/>
+                <a16:creationId xmlns:a16="http://schemas.microsoft.com/office/drawing/2014/main" id="{7CD3B583-50AE-47EC-A38F-50001DB32C5D}"/>
               </a:ext>
             </a:extLst>
           </p:cNvPr>
@@ -11757,7 +11757,7 @@
           <p:cNvPr id="6" name="">
             <a:extLst xmlns:a="http://schemas.openxmlformats.org/drawingml/2006/main">
               <a:ext uri="{FF2B5EF4-FFF2-40B4-BE49-F238E27FC236}">
-                <a16:creationId xmlns:a16="http://schemas.microsoft.com/office/drawing/2014/main" id="{A26A4BA3-320D-4262-828C-65DCC32CB0EC}"/>
+                <a16:creationId xmlns:a16="http://schemas.microsoft.com/office/drawing/2014/main" id="{7CA86B94-082D-4FB0-8038-8A4C5F327A7E}"/>
               </a:ext>
             </a:extLst>
           </p:cNvPr>
@@ -11788,7 +11788,7 @@
           <p:cNvPr id="7" name="">
             <a:extLst xmlns:a="http://schemas.openxmlformats.org/drawingml/2006/main">
               <a:ext uri="{FF2B5EF4-FFF2-40B4-BE49-F238E27FC236}">
-                <a16:creationId xmlns:a16="http://schemas.microsoft.com/office/drawing/2014/main" id="{A90A01F2-D42B-4C08-B0B7-64B6C6FB20DB}"/>
+                <a16:creationId xmlns:a16="http://schemas.microsoft.com/office/drawing/2014/main" id="{507BC876-FB6E-4993-9713-20B287FFF683}"/>
               </a:ext>
             </a:extLst>
           </p:cNvPr>
@@ -11968,7 +11968,7 @@
           <p:cNvPr id="8" name="">
             <a:extLst xmlns:a="http://schemas.openxmlformats.org/drawingml/2006/main">
               <a:ext uri="{FF2B5EF4-FFF2-40B4-BE49-F238E27FC236}">
-                <a16:creationId xmlns:a16="http://schemas.microsoft.com/office/drawing/2014/main" id="{F82CCD71-A779-4F7D-96B8-BB8E58772BC4}"/>
+                <a16:creationId xmlns:a16="http://schemas.microsoft.com/office/drawing/2014/main" id="{C49AEA2F-1BD3-4491-A82C-0ED9D63AE213}"/>
               </a:ext>
             </a:extLst>
           </p:cNvPr>
@@ -12125,7 +12125,7 @@
           <p:cNvPr id="9" name="">
             <a:extLst xmlns:a="http://schemas.openxmlformats.org/drawingml/2006/main">
               <a:ext uri="{FF2B5EF4-FFF2-40B4-BE49-F238E27FC236}">
-                <a16:creationId xmlns:a16="http://schemas.microsoft.com/office/drawing/2014/main" id="{6C2106CA-1D57-48D9-B66B-6D1AEF3CFF15}"/>
+                <a16:creationId xmlns:a16="http://schemas.microsoft.com/office/drawing/2014/main" id="{2457D2C4-7B14-4E7D-AF55-70EDB2E21272}"/>
               </a:ext>
             </a:extLst>
           </p:cNvPr>
@@ -12156,7 +12156,7 @@
           <p:cNvPr id="10" name="">
             <a:extLst xmlns:a="http://schemas.openxmlformats.org/drawingml/2006/main">
               <a:ext uri="{FF2B5EF4-FFF2-40B4-BE49-F238E27FC236}">
-                <a16:creationId xmlns:a16="http://schemas.microsoft.com/office/drawing/2014/main" id="{D5384057-8533-4AB5-A7AE-D18AE542F772}"/>
+                <a16:creationId xmlns:a16="http://schemas.microsoft.com/office/drawing/2014/main" id="{68B0842B-F6C9-4086-97AB-36FEF7D0B44F}"/>
               </a:ext>
             </a:extLst>
           </p:cNvPr>
@@ -12336,7 +12336,7 @@
           <p:cNvPr id="11" name="">
             <a:extLst xmlns:a="http://schemas.openxmlformats.org/drawingml/2006/main">
               <a:ext uri="{FF2B5EF4-FFF2-40B4-BE49-F238E27FC236}">
-                <a16:creationId xmlns:a16="http://schemas.microsoft.com/office/drawing/2014/main" id="{5DE8CEB0-B3F9-40D1-BD18-7417F55F408C}"/>
+                <a16:creationId xmlns:a16="http://schemas.microsoft.com/office/drawing/2014/main" id="{35810490-39EE-41EF-90C0-1825372B7F0F}"/>
               </a:ext>
             </a:extLst>
           </p:cNvPr>
@@ -12493,7 +12493,7 @@
           <p:cNvPr id="12" name="">
             <a:extLst xmlns:a="http://schemas.openxmlformats.org/drawingml/2006/main">
               <a:ext uri="{FF2B5EF4-FFF2-40B4-BE49-F238E27FC236}">
-                <a16:creationId xmlns:a16="http://schemas.microsoft.com/office/drawing/2014/main" id="{419DE4D4-2C84-40D8-AA05-EFF483F7D5EB}"/>
+                <a16:creationId xmlns:a16="http://schemas.microsoft.com/office/drawing/2014/main" id="{3A5B8118-72EC-44A5-8551-F4C061153A5E}"/>
               </a:ext>
             </a:extLst>
           </p:cNvPr>
@@ -12524,7 +12524,7 @@
           <p:cNvPr id="13" name="">
             <a:extLst xmlns:a="http://schemas.openxmlformats.org/drawingml/2006/main">
               <a:ext uri="{FF2B5EF4-FFF2-40B4-BE49-F238E27FC236}">
-                <a16:creationId xmlns:a16="http://schemas.microsoft.com/office/drawing/2014/main" id="{1F83EFD4-B573-42C5-A0BD-D43C0D8A55E8}"/>
+                <a16:creationId xmlns:a16="http://schemas.microsoft.com/office/drawing/2014/main" id="{DFB211C1-BC2F-4E00-A68E-723017E81CB8}"/>
               </a:ext>
             </a:extLst>
           </p:cNvPr>
@@ -12704,7 +12704,7 @@
           <p:cNvPr id="14" name="">
             <a:extLst xmlns:a="http://schemas.openxmlformats.org/drawingml/2006/main">
               <a:ext uri="{FF2B5EF4-FFF2-40B4-BE49-F238E27FC236}">
-                <a16:creationId xmlns:a16="http://schemas.microsoft.com/office/drawing/2014/main" id="{9961CF59-17D9-4C1D-BEB3-C5FE6DBBA8BE}"/>
+                <a16:creationId xmlns:a16="http://schemas.microsoft.com/office/drawing/2014/main" id="{09E0D447-725A-40FD-BFF8-173FE7E26777}"/>
               </a:ext>
             </a:extLst>
           </p:cNvPr>
@@ -12861,7 +12861,7 @@
           <p:cNvPr id="15" name="">
             <a:extLst xmlns:a="http://schemas.openxmlformats.org/drawingml/2006/main">
               <a:ext uri="{FF2B5EF4-FFF2-40B4-BE49-F238E27FC236}">
-                <a16:creationId xmlns:a16="http://schemas.microsoft.com/office/drawing/2014/main" id="{99860F05-B71C-4532-B2B1-3E1054F8224C}"/>
+                <a16:creationId xmlns:a16="http://schemas.microsoft.com/office/drawing/2014/main" id="{F3B3FB8C-8916-4F62-806C-53579AB74AD0}"/>
               </a:ext>
             </a:extLst>
           </p:cNvPr>
@@ -12892,7 +12892,7 @@
           <p:cNvPr id="16" name="">
             <a:extLst xmlns:a="http://schemas.openxmlformats.org/drawingml/2006/main">
               <a:ext uri="{FF2B5EF4-FFF2-40B4-BE49-F238E27FC236}">
-                <a16:creationId xmlns:a16="http://schemas.microsoft.com/office/drawing/2014/main" id="{C3D7A684-43B2-4A53-A6AE-6BA752CEA371}"/>
+                <a16:creationId xmlns:a16="http://schemas.microsoft.com/office/drawing/2014/main" id="{2EDBD1E5-9691-4B06-9017-06FAF4EEA4A4}"/>
               </a:ext>
             </a:extLst>
           </p:cNvPr>
@@ -13072,7 +13072,7 @@
           <p:cNvPr id="17" name="">
             <a:extLst xmlns:a="http://schemas.openxmlformats.org/drawingml/2006/main">
               <a:ext uri="{FF2B5EF4-FFF2-40B4-BE49-F238E27FC236}">
-                <a16:creationId xmlns:a16="http://schemas.microsoft.com/office/drawing/2014/main" id="{2DDD3040-8059-412C-8017-C7D2E22BA56C}"/>
+                <a16:creationId xmlns:a16="http://schemas.microsoft.com/office/drawing/2014/main" id="{67D5DBA4-7BA6-4503-8E34-7259CCAAAE1B}"/>
               </a:ext>
             </a:extLst>
           </p:cNvPr>
@@ -13432,7 +13432,7 @@
           <p:cNvPr id="18" name="">
             <a:extLst xmlns:a="http://schemas.openxmlformats.org/drawingml/2006/main">
               <a:ext uri="{FF2B5EF4-FFF2-40B4-BE49-F238E27FC236}">
-                <a16:creationId xmlns:a16="http://schemas.microsoft.com/office/drawing/2014/main" id="{8AD9AA35-5E1C-474C-9C38-75EB70A3FB85}"/>
+                <a16:creationId xmlns:a16="http://schemas.microsoft.com/office/drawing/2014/main" id="{5FDD7383-C915-48FB-A479-21CC40F576FD}"/>
               </a:ext>
             </a:extLst>
           </p:cNvPr>
@@ -13587,7 +13587,7 @@
     </p:spTree>
     <p:extLst>
       <p:ext uri="{BB962C8B-B14F-4D97-AF65-F5344CB8AC3E}">
-        <p14:creationId xmlns:p14="http://schemas.microsoft.com/office/powerpoint/2010/main" val="2058392039"/>
+        <p14:creationId xmlns:p14="http://schemas.microsoft.com/office/powerpoint/2010/main" val="517986482"/>
       </p:ext>
     </p:extLst>
   </p:cSld>
@@ -13618,7 +13618,7 @@
           <p:cNvPr id="26" name="">
             <a:extLst xmlns:a="http://schemas.openxmlformats.org/drawingml/2006/main">
               <a:ext uri="{FF2B5EF4-FFF2-40B4-BE49-F238E27FC236}">
-                <a16:creationId xmlns:a16="http://schemas.microsoft.com/office/drawing/2014/main" id="{9FB38A30-A65A-4A52-B648-2E7D1D19EA53}"/>
+                <a16:creationId xmlns:a16="http://schemas.microsoft.com/office/drawing/2014/main" id="{E63ED0B5-D3D6-4F08-99AB-1184204A38EA}"/>
               </a:ext>
             </a:extLst>
           </p:cNvPr>
@@ -13775,7 +13775,7 @@
           <p:cNvPr id="2" name="">
             <a:extLst xmlns:a="http://schemas.openxmlformats.org/drawingml/2006/main">
               <a:ext uri="{FF2B5EF4-FFF2-40B4-BE49-F238E27FC236}">
-                <a16:creationId xmlns:a16="http://schemas.microsoft.com/office/drawing/2014/main" id="{AB2FEB17-B50C-422E-89BB-7929D12A43F9}"/>
+                <a16:creationId xmlns:a16="http://schemas.microsoft.com/office/drawing/2014/main" id="{8A4433AE-8AAC-42DE-92D3-F0CA2FB1E3D6}"/>
               </a:ext>
             </a:extLst>
           </p:cNvPr>
@@ -13806,7 +13806,7 @@
           <p:cNvPr id="3" name="">
             <a:extLst xmlns:a="http://schemas.openxmlformats.org/drawingml/2006/main">
               <a:ext uri="{FF2B5EF4-FFF2-40B4-BE49-F238E27FC236}">
-                <a16:creationId xmlns:a16="http://schemas.microsoft.com/office/drawing/2014/main" id="{37C5734D-1D98-46D6-B742-54D17C5E02E9}"/>
+                <a16:creationId xmlns:a16="http://schemas.microsoft.com/office/drawing/2014/main" id="{53C7DA5C-3382-4FEC-B4BF-57AFF0029C46}"/>
               </a:ext>
             </a:extLst>
           </p:cNvPr>
@@ -13963,7 +13963,7 @@
           <p:cNvPr id="4" name="">
             <a:extLst xmlns:a="http://schemas.openxmlformats.org/drawingml/2006/main">
               <a:ext uri="{FF2B5EF4-FFF2-40B4-BE49-F238E27FC236}">
-                <a16:creationId xmlns:a16="http://schemas.microsoft.com/office/drawing/2014/main" id="{C4216A7C-ECC8-49D9-93B7-1D1CEE6AC785}"/>
+                <a16:creationId xmlns:a16="http://schemas.microsoft.com/office/drawing/2014/main" id="{01867D94-6B39-4D59-82D4-1A0C59E5CCAD}"/>
               </a:ext>
             </a:extLst>
           </p:cNvPr>
@@ -13996,7 +13996,7 @@
           <p:cNvPr id="5" name="">
             <a:extLst xmlns:a="http://schemas.openxmlformats.org/drawingml/2006/main">
               <a:ext uri="{FF2B5EF4-FFF2-40B4-BE49-F238E27FC236}">
-                <a16:creationId xmlns:a16="http://schemas.microsoft.com/office/drawing/2014/main" id="{9D9D245C-4302-46D6-823D-20C37E15940A}"/>
+                <a16:creationId xmlns:a16="http://schemas.microsoft.com/office/drawing/2014/main" id="{EEA3883C-1764-4C4B-8605-75B233957FC3}"/>
               </a:ext>
             </a:extLst>
           </p:cNvPr>
@@ -14153,7 +14153,7 @@
           <p:cNvPr id="6" name="">
             <a:extLst xmlns:a="http://schemas.openxmlformats.org/drawingml/2006/main">
               <a:ext uri="{FF2B5EF4-FFF2-40B4-BE49-F238E27FC236}">
-                <a16:creationId xmlns:a16="http://schemas.microsoft.com/office/drawing/2014/main" id="{76F960F7-778D-40ED-BD77-D0C81A0EC0B6}"/>
+                <a16:creationId xmlns:a16="http://schemas.microsoft.com/office/drawing/2014/main" id="{E05A3553-8C91-4E44-A667-E67A55900FFF}"/>
               </a:ext>
             </a:extLst>
           </p:cNvPr>
@@ -14333,7 +14333,7 @@
           <p:cNvPr id="7" name="">
             <a:extLst xmlns:a="http://schemas.openxmlformats.org/drawingml/2006/main">
               <a:ext uri="{FF2B5EF4-FFF2-40B4-BE49-F238E27FC236}">
-                <a16:creationId xmlns:a16="http://schemas.microsoft.com/office/drawing/2014/main" id="{5DF8110E-B894-4202-82F5-17E68BCBE136}"/>
+                <a16:creationId xmlns:a16="http://schemas.microsoft.com/office/drawing/2014/main" id="{BEBAAE80-7A65-48EE-BF64-02AB777D503B}"/>
               </a:ext>
             </a:extLst>
           </p:cNvPr>
@@ -14364,7 +14364,7 @@
           <p:cNvPr id="8" name="">
             <a:extLst xmlns:a="http://schemas.openxmlformats.org/drawingml/2006/main">
               <a:ext uri="{FF2B5EF4-FFF2-40B4-BE49-F238E27FC236}">
-                <a16:creationId xmlns:a16="http://schemas.microsoft.com/office/drawing/2014/main" id="{261D709A-D70B-43AA-BF1F-4DA01359998E}"/>
+                <a16:creationId xmlns:a16="http://schemas.microsoft.com/office/drawing/2014/main" id="{51B4497B-FED6-48A6-9519-687DCA2FA660}"/>
               </a:ext>
             </a:extLst>
           </p:cNvPr>
@@ -14397,7 +14397,7 @@
           <p:cNvPr id="9" name="">
             <a:extLst xmlns:a="http://schemas.openxmlformats.org/drawingml/2006/main">
               <a:ext uri="{FF2B5EF4-FFF2-40B4-BE49-F238E27FC236}">
-                <a16:creationId xmlns:a16="http://schemas.microsoft.com/office/drawing/2014/main" id="{E2B18B3F-BF0D-438B-8310-EE7A90195696}"/>
+                <a16:creationId xmlns:a16="http://schemas.microsoft.com/office/drawing/2014/main" id="{052465E7-DE4E-4A47-B7CA-22271B1A7832}"/>
               </a:ext>
             </a:extLst>
           </p:cNvPr>
@@ -14554,7 +14554,7 @@
           <p:cNvPr id="10" name="">
             <a:extLst xmlns:a="http://schemas.openxmlformats.org/drawingml/2006/main">
               <a:ext uri="{FF2B5EF4-FFF2-40B4-BE49-F238E27FC236}">
-                <a16:creationId xmlns:a16="http://schemas.microsoft.com/office/drawing/2014/main" id="{5187E50D-D4D2-4576-A10D-93819F94E31E}"/>
+                <a16:creationId xmlns:a16="http://schemas.microsoft.com/office/drawing/2014/main" id="{658966B6-C441-4504-9480-BEF057E4983D}"/>
               </a:ext>
             </a:extLst>
           </p:cNvPr>
@@ -14734,7 +14734,7 @@
           <p:cNvPr id="11" name="">
             <a:extLst xmlns:a="http://schemas.openxmlformats.org/drawingml/2006/main">
               <a:ext uri="{FF2B5EF4-FFF2-40B4-BE49-F238E27FC236}">
-                <a16:creationId xmlns:a16="http://schemas.microsoft.com/office/drawing/2014/main" id="{BC41EF9B-251B-4EB0-8581-3C4072F78FEC}"/>
+                <a16:creationId xmlns:a16="http://schemas.microsoft.com/office/drawing/2014/main" id="{D32A9ED9-CBD4-4DE6-A08D-898A8B446FA0}"/>
               </a:ext>
             </a:extLst>
           </p:cNvPr>
@@ -14765,7 +14765,7 @@
           <p:cNvPr id="12" name="">
             <a:extLst xmlns:a="http://schemas.openxmlformats.org/drawingml/2006/main">
               <a:ext uri="{FF2B5EF4-FFF2-40B4-BE49-F238E27FC236}">
-                <a16:creationId xmlns:a16="http://schemas.microsoft.com/office/drawing/2014/main" id="{5B9E9794-7A40-4407-825F-6DE8C57AE025}"/>
+                <a16:creationId xmlns:a16="http://schemas.microsoft.com/office/drawing/2014/main" id="{ACCC8899-8672-4E8C-8CD8-96410654F84E}"/>
               </a:ext>
             </a:extLst>
           </p:cNvPr>
@@ -14798,7 +14798,7 @@
           <p:cNvPr id="13" name="">
             <a:extLst xmlns:a="http://schemas.openxmlformats.org/drawingml/2006/main">
               <a:ext uri="{FF2B5EF4-FFF2-40B4-BE49-F238E27FC236}">
-                <a16:creationId xmlns:a16="http://schemas.microsoft.com/office/drawing/2014/main" id="{D31AA480-756D-4645-A248-1F65B1D51261}"/>
+                <a16:creationId xmlns:a16="http://schemas.microsoft.com/office/drawing/2014/main" id="{582E6120-7E8D-4C1C-B88F-530D1585AC46}"/>
               </a:ext>
             </a:extLst>
           </p:cNvPr>
@@ -14955,7 +14955,7 @@
           <p:cNvPr id="14" name="">
             <a:extLst xmlns:a="http://schemas.openxmlformats.org/drawingml/2006/main">
               <a:ext uri="{FF2B5EF4-FFF2-40B4-BE49-F238E27FC236}">
-                <a16:creationId xmlns:a16="http://schemas.microsoft.com/office/drawing/2014/main" id="{1442FF51-428E-4E0D-96F4-761558363701}"/>
+                <a16:creationId xmlns:a16="http://schemas.microsoft.com/office/drawing/2014/main" id="{F9CADB71-75E4-4A2D-AA8B-316BB4EFDB0F}"/>
               </a:ext>
             </a:extLst>
           </p:cNvPr>
@@ -15135,7 +15135,7 @@
           <p:cNvPr id="15" name="">
             <a:extLst xmlns:a="http://schemas.openxmlformats.org/drawingml/2006/main">
               <a:ext uri="{FF2B5EF4-FFF2-40B4-BE49-F238E27FC236}">
-                <a16:creationId xmlns:a16="http://schemas.microsoft.com/office/drawing/2014/main" id="{E95847C6-66D0-4630-B91F-5B1D9E0AA259}"/>
+                <a16:creationId xmlns:a16="http://schemas.microsoft.com/office/drawing/2014/main" id="{6DB3BCD3-1ECB-4315-AB99-6630E17C2A2F}"/>
               </a:ext>
             </a:extLst>
           </p:cNvPr>
@@ -15166,7 +15166,7 @@
           <p:cNvPr id="16" name="">
             <a:extLst xmlns:a="http://schemas.openxmlformats.org/drawingml/2006/main">
               <a:ext uri="{FF2B5EF4-FFF2-40B4-BE49-F238E27FC236}">
-                <a16:creationId xmlns:a16="http://schemas.microsoft.com/office/drawing/2014/main" id="{E1162B7A-2E20-458B-B4AD-9D7BF49F9298}"/>
+                <a16:creationId xmlns:a16="http://schemas.microsoft.com/office/drawing/2014/main" id="{82A0A540-F7A0-4F51-B8A7-75FBB8E9F23B}"/>
               </a:ext>
             </a:extLst>
           </p:cNvPr>
@@ -15199,7 +15199,7 @@
           <p:cNvPr id="17" name="">
             <a:extLst xmlns:a="http://schemas.openxmlformats.org/drawingml/2006/main">
               <a:ext uri="{FF2B5EF4-FFF2-40B4-BE49-F238E27FC236}">
-                <a16:creationId xmlns:a16="http://schemas.microsoft.com/office/drawing/2014/main" id="{903AE87D-B5A3-4385-91AB-6D7E85EF79EA}"/>
+                <a16:creationId xmlns:a16="http://schemas.microsoft.com/office/drawing/2014/main" id="{627493D2-C3D6-4A1F-9465-AD010C93238B}"/>
               </a:ext>
             </a:extLst>
           </p:cNvPr>
@@ -15356,7 +15356,7 @@
           <p:cNvPr id="18" name="">
             <a:extLst xmlns:a="http://schemas.openxmlformats.org/drawingml/2006/main">
               <a:ext uri="{FF2B5EF4-FFF2-40B4-BE49-F238E27FC236}">
-                <a16:creationId xmlns:a16="http://schemas.microsoft.com/office/drawing/2014/main" id="{B4ACE975-F234-4FFC-B52E-BFAAC6FADB8D}"/>
+                <a16:creationId xmlns:a16="http://schemas.microsoft.com/office/drawing/2014/main" id="{10828542-7609-4D5E-A296-1E484F9306FB}"/>
               </a:ext>
             </a:extLst>
           </p:cNvPr>
@@ -15536,7 +15536,7 @@
           <p:cNvPr id="19" name="">
             <a:extLst xmlns:a="http://schemas.openxmlformats.org/drawingml/2006/main">
               <a:ext uri="{FF2B5EF4-FFF2-40B4-BE49-F238E27FC236}">
-                <a16:creationId xmlns:a16="http://schemas.microsoft.com/office/drawing/2014/main" id="{035A4682-1203-42E9-A725-D0B3B26EB8FD}"/>
+                <a16:creationId xmlns:a16="http://schemas.microsoft.com/office/drawing/2014/main" id="{1F612EED-5AE5-420D-82C0-0ED02C3112C5}"/>
               </a:ext>
             </a:extLst>
           </p:cNvPr>
@@ -15693,7 +15693,7 @@
           <p:cNvPr id="20" name="">
             <a:extLst xmlns:a="http://schemas.openxmlformats.org/drawingml/2006/main">
               <a:ext uri="{FF2B5EF4-FFF2-40B4-BE49-F238E27FC236}">
-                <a16:creationId xmlns:a16="http://schemas.microsoft.com/office/drawing/2014/main" id="{F39FB035-F41D-48D8-8FD5-25F016B8C33E}"/>
+                <a16:creationId xmlns:a16="http://schemas.microsoft.com/office/drawing/2014/main" id="{C301A472-929E-4AB9-90DF-C20E2ABAD36A}"/>
               </a:ext>
             </a:extLst>
           </p:cNvPr>
@@ -15850,7 +15850,7 @@
           <p:cNvPr id="21" name="">
             <a:extLst xmlns:a="http://schemas.openxmlformats.org/drawingml/2006/main">
               <a:ext uri="{FF2B5EF4-FFF2-40B4-BE49-F238E27FC236}">
-                <a16:creationId xmlns:a16="http://schemas.microsoft.com/office/drawing/2014/main" id="{D6E8728A-450D-4A80-A745-12E1C4BF0CBA}"/>
+                <a16:creationId xmlns:a16="http://schemas.microsoft.com/office/drawing/2014/main" id="{C81EE886-E35A-4FCC-AFCA-C4B173587A6E}"/>
               </a:ext>
             </a:extLst>
           </p:cNvPr>
@@ -16007,7 +16007,7 @@
           <p:cNvPr id="22" name="">
             <a:extLst xmlns:a="http://schemas.openxmlformats.org/drawingml/2006/main">
               <a:ext uri="{FF2B5EF4-FFF2-40B4-BE49-F238E27FC236}">
-                <a16:creationId xmlns:a16="http://schemas.microsoft.com/office/drawing/2014/main" id="{44893E58-FDF6-417E-B7B8-585E7E136202}"/>
+                <a16:creationId xmlns:a16="http://schemas.microsoft.com/office/drawing/2014/main" id="{831895FD-CFE3-4DB2-B382-FD0137EEF7F4}"/>
               </a:ext>
             </a:extLst>
           </p:cNvPr>
@@ -16164,7 +16164,7 @@
           <p:cNvPr id="23" name="">
             <a:extLst xmlns:a="http://schemas.openxmlformats.org/drawingml/2006/main">
               <a:ext uri="{FF2B5EF4-FFF2-40B4-BE49-F238E27FC236}">
-                <a16:creationId xmlns:a16="http://schemas.microsoft.com/office/drawing/2014/main" id="{49334D1E-E545-4516-AA7F-88E7E1F35DDF}"/>
+                <a16:creationId xmlns:a16="http://schemas.microsoft.com/office/drawing/2014/main" id="{40471ADE-BF6E-4EA6-85D2-C9B31223683D}"/>
               </a:ext>
             </a:extLst>
           </p:cNvPr>
@@ -16321,7 +16321,7 @@
           <p:cNvPr id="24" name="">
             <a:extLst xmlns:a="http://schemas.openxmlformats.org/drawingml/2006/main">
               <a:ext uri="{FF2B5EF4-FFF2-40B4-BE49-F238E27FC236}">
-                <a16:creationId xmlns:a16="http://schemas.microsoft.com/office/drawing/2014/main" id="{9C005B56-3A1C-4943-973D-D8D30FEBA9A0}"/>
+                <a16:creationId xmlns:a16="http://schemas.microsoft.com/office/drawing/2014/main" id="{9F55A9EE-ADBE-4BCF-82C9-D97F88579D44}"/>
               </a:ext>
             </a:extLst>
           </p:cNvPr>
@@ -16478,7 +16478,7 @@
           <p:cNvPr id="25" name="">
             <a:extLst xmlns:a="http://schemas.openxmlformats.org/drawingml/2006/main">
               <a:ext uri="{FF2B5EF4-FFF2-40B4-BE49-F238E27FC236}">
-                <a16:creationId xmlns:a16="http://schemas.microsoft.com/office/drawing/2014/main" id="{5B283125-5E9A-40B3-8BF1-55970EAFC7C4}"/>
+                <a16:creationId xmlns:a16="http://schemas.microsoft.com/office/drawing/2014/main" id="{C913427F-5AF3-4248-87E9-0AB486E904C2}"/>
               </a:ext>
             </a:extLst>
           </p:cNvPr>
@@ -16633,7 +16633,7 @@
     </p:spTree>
     <p:extLst>
       <p:ext uri="{BB962C8B-B14F-4D97-AF65-F5344CB8AC3E}">
-        <p14:creationId xmlns:p14="http://schemas.microsoft.com/office/powerpoint/2010/main" val="1634176236"/>
+        <p14:creationId xmlns:p14="http://schemas.microsoft.com/office/powerpoint/2010/main" val="638663905"/>
       </p:ext>
     </p:extLst>
   </p:cSld>
@@ -16664,7 +16664,7 @@
           <p:cNvPr id="10" name="">
             <a:extLst xmlns:a="http://schemas.openxmlformats.org/drawingml/2006/main">
               <a:ext uri="{FF2B5EF4-FFF2-40B4-BE49-F238E27FC236}">
-                <a16:creationId xmlns:a16="http://schemas.microsoft.com/office/drawing/2014/main" id="{D428BCC3-0F3F-4199-8299-45A886B568E0}"/>
+                <a16:creationId xmlns:a16="http://schemas.microsoft.com/office/drawing/2014/main" id="{33B95E47-6278-4602-BD14-1F4970267C17}"/>
               </a:ext>
             </a:extLst>
           </p:cNvPr>
@@ -16821,7 +16821,7 @@
           <p:cNvPr id="2" name="">
             <a:extLst xmlns:a="http://schemas.openxmlformats.org/drawingml/2006/main">
               <a:ext uri="{FF2B5EF4-FFF2-40B4-BE49-F238E27FC236}">
-                <a16:creationId xmlns:a16="http://schemas.microsoft.com/office/drawing/2014/main" id="{0E3B9989-E2B4-44BC-A532-5B2A3C4E6C1E}"/>
+                <a16:creationId xmlns:a16="http://schemas.microsoft.com/office/drawing/2014/main" id="{6FF3BF3B-2755-4A6A-80D1-75FA850660A0}"/>
               </a:ext>
             </a:extLst>
           </p:cNvPr>
@@ -16852,7 +16852,7 @@
           <p:cNvPr id="3" name="">
             <a:extLst xmlns:a="http://schemas.openxmlformats.org/drawingml/2006/main">
               <a:ext uri="{FF2B5EF4-FFF2-40B4-BE49-F238E27FC236}">
-                <a16:creationId xmlns:a16="http://schemas.microsoft.com/office/drawing/2014/main" id="{03794836-F9D3-4ACF-A1CB-6D22B3F8094C}"/>
+                <a16:creationId xmlns:a16="http://schemas.microsoft.com/office/drawing/2014/main" id="{B7BFBDD6-99C2-4499-8E3C-F1C6E4B28B6C}"/>
               </a:ext>
             </a:extLst>
           </p:cNvPr>
@@ -17009,7 +17009,7 @@
           <p:cNvPr id="4" name="Chart">
             <a:extLst xmlns:a="http://schemas.openxmlformats.org/drawingml/2006/main">
               <a:ext uri="{FF2B5EF4-FFF2-40B4-BE49-F238E27FC236}">
-                <a16:creationId xmlns:a16="http://schemas.microsoft.com/office/drawing/2014/main" id="{1A41D405-3AF5-4603-AD37-36FDCE8110EF}"/>
+                <a16:creationId xmlns:a16="http://schemas.microsoft.com/office/drawing/2014/main" id="{336C67CF-B659-4191-B2C4-DF1674E9B811}"/>
               </a:ext>
             </a:extLst>
           </p:cNvPr>
@@ -17022,7 +17022,7 @@
         </p:xfrm>
         <a:graphic xmlns:a="http://schemas.openxmlformats.org/drawingml/2006/main">
           <a:graphicData uri="http://schemas.openxmlformats.org/drawingml/2006/chart">
-            <c:chart xmlns:r="http://schemas.openxmlformats.org/officeDocument/2006/relationships" xmlns:c="http://schemas.openxmlformats.org/drawingml/2006/chart" r:id="R39c2380e42e94e7f"/>
+            <c:chart xmlns:r="http://schemas.openxmlformats.org/officeDocument/2006/relationships" xmlns:c="http://schemas.openxmlformats.org/drawingml/2006/chart" r:id="R6d23a023c01c40d3"/>
           </a:graphicData>
         </a:graphic>
       </p:graphicFrame>
@@ -17031,7 +17031,7 @@
           <p:cNvPr id="5" name="">
             <a:extLst xmlns:a="http://schemas.openxmlformats.org/drawingml/2006/main">
               <a:ext uri="{FF2B5EF4-FFF2-40B4-BE49-F238E27FC236}">
-                <a16:creationId xmlns:a16="http://schemas.microsoft.com/office/drawing/2014/main" id="{A0AC2698-3FFD-4271-A377-A3AF31E263A0}"/>
+                <a16:creationId xmlns:a16="http://schemas.microsoft.com/office/drawing/2014/main" id="{D1D14BC6-EE50-4DD7-8A6F-4D03B3B02493}"/>
               </a:ext>
             </a:extLst>
           </p:cNvPr>
@@ -17188,7 +17188,7 @@
           <p:cNvPr id="6" name="">
             <a:extLst xmlns:a="http://schemas.openxmlformats.org/drawingml/2006/main">
               <a:ext uri="{FF2B5EF4-FFF2-40B4-BE49-F238E27FC236}">
-                <a16:creationId xmlns:a16="http://schemas.microsoft.com/office/drawing/2014/main" id="{1B43EF2D-DD81-4CF6-A40F-799E1943030D}"/>
+                <a16:creationId xmlns:a16="http://schemas.microsoft.com/office/drawing/2014/main" id="{9F69D02F-F591-4643-9FA8-99640765B9C6}"/>
               </a:ext>
             </a:extLst>
           </p:cNvPr>
@@ -17368,7 +17368,7 @@
           <p:cNvPr id="7" name="">
             <a:extLst xmlns:a="http://schemas.openxmlformats.org/drawingml/2006/main">
               <a:ext uri="{FF2B5EF4-FFF2-40B4-BE49-F238E27FC236}">
-                <a16:creationId xmlns:a16="http://schemas.microsoft.com/office/drawing/2014/main" id="{FA6AC5E3-8712-43B0-A46D-369838F9AC9C}"/>
+                <a16:creationId xmlns:a16="http://schemas.microsoft.com/office/drawing/2014/main" id="{62D08954-08EA-438F-9A9C-DE52C1771643}"/>
               </a:ext>
             </a:extLst>
           </p:cNvPr>
@@ -17525,7 +17525,7 @@
           <p:cNvPr id="8" name="">
             <a:extLst xmlns:a="http://schemas.openxmlformats.org/drawingml/2006/main">
               <a:ext uri="{FF2B5EF4-FFF2-40B4-BE49-F238E27FC236}">
-                <a16:creationId xmlns:a16="http://schemas.microsoft.com/office/drawing/2014/main" id="{67753CBE-D314-4336-AADB-E2337215C504}"/>
+                <a16:creationId xmlns:a16="http://schemas.microsoft.com/office/drawing/2014/main" id="{63C59163-8920-466D-8980-57387B9FA4BD}"/>
               </a:ext>
             </a:extLst>
           </p:cNvPr>
@@ -17672,7 +17672,7 @@
                 <a:ea typeface="Arial"/>
                 <a:cs typeface="Arial"/>
               </a:rPr>
-              <a:t>Earlier cost study: 301 circuits</a:t>
+              <a:t>Earlier cost study: 713 formulas</a:t>
             </a:r>
           </a:p>
           <a:p xmlns:a="http://schemas.openxmlformats.org/drawingml/2006/main">
@@ -17705,7 +17705,7 @@
           <p:cNvPr id="9" name="">
             <a:extLst xmlns:a="http://schemas.openxmlformats.org/drawingml/2006/main">
               <a:ext uri="{FF2B5EF4-FFF2-40B4-BE49-F238E27FC236}">
-                <a16:creationId xmlns:a16="http://schemas.microsoft.com/office/drawing/2014/main" id="{D15FFFCF-CE42-4646-81B6-D31519C5B349}"/>
+                <a16:creationId xmlns:a16="http://schemas.microsoft.com/office/drawing/2014/main" id="{44ACCD1B-6B1A-4BDA-B53E-4E0A078BA035}"/>
               </a:ext>
             </a:extLst>
           </p:cNvPr>
@@ -17860,7 +17860,7 @@
     </p:spTree>
     <p:extLst>
       <p:ext uri="{BB962C8B-B14F-4D97-AF65-F5344CB8AC3E}">
-        <p14:creationId xmlns:p14="http://schemas.microsoft.com/office/powerpoint/2010/main" val="1131978160"/>
+        <p14:creationId xmlns:p14="http://schemas.microsoft.com/office/powerpoint/2010/main" val="232933482"/>
       </p:ext>
     </p:extLst>
   </p:cSld>
@@ -17891,7 +17891,7 @@
           <p:cNvPr id="22" name="">
             <a:extLst xmlns:a="http://schemas.openxmlformats.org/drawingml/2006/main">
               <a:ext uri="{FF2B5EF4-FFF2-40B4-BE49-F238E27FC236}">
-                <a16:creationId xmlns:a16="http://schemas.microsoft.com/office/drawing/2014/main" id="{71D3DC8A-95DA-4897-A423-E7842A96DE96}"/>
+                <a16:creationId xmlns:a16="http://schemas.microsoft.com/office/drawing/2014/main" id="{D4F94414-6AD7-426F-B50D-4DD2884B5EA5}"/>
               </a:ext>
             </a:extLst>
           </p:cNvPr>
@@ -18048,7 +18048,7 @@
           <p:cNvPr id="2" name="">
             <a:extLst xmlns:a="http://schemas.openxmlformats.org/drawingml/2006/main">
               <a:ext uri="{FF2B5EF4-FFF2-40B4-BE49-F238E27FC236}">
-                <a16:creationId xmlns:a16="http://schemas.microsoft.com/office/drawing/2014/main" id="{9763D6C4-0869-47D2-A77D-5159BE798F6F}"/>
+                <a16:creationId xmlns:a16="http://schemas.microsoft.com/office/drawing/2014/main" id="{5BE6A5B4-E4D5-4C41-8430-FC0A52257BF9}"/>
               </a:ext>
             </a:extLst>
           </p:cNvPr>
@@ -18079,7 +18079,7 @@
           <p:cNvPr id="3" name="">
             <a:extLst xmlns:a="http://schemas.openxmlformats.org/drawingml/2006/main">
               <a:ext uri="{FF2B5EF4-FFF2-40B4-BE49-F238E27FC236}">
-                <a16:creationId xmlns:a16="http://schemas.microsoft.com/office/drawing/2014/main" id="{0385A132-1C4A-4B38-A10F-128B359F5A5C}"/>
+                <a16:creationId xmlns:a16="http://schemas.microsoft.com/office/drawing/2014/main" id="{F74E4A65-60F2-4AF7-9E2C-2B873DE2B30C}"/>
               </a:ext>
             </a:extLst>
           </p:cNvPr>
@@ -18236,7 +18236,7 @@
           <p:cNvPr id="4" name="">
             <a:extLst xmlns:a="http://schemas.openxmlformats.org/drawingml/2006/main">
               <a:ext uri="{FF2B5EF4-FFF2-40B4-BE49-F238E27FC236}">
-                <a16:creationId xmlns:a16="http://schemas.microsoft.com/office/drawing/2014/main" id="{042074EB-817D-4D17-BAAA-16189DEFEBC3}"/>
+                <a16:creationId xmlns:a16="http://schemas.microsoft.com/office/drawing/2014/main" id="{37AE3FEA-53D8-4331-90FF-974229598009}"/>
               </a:ext>
             </a:extLst>
           </p:cNvPr>
@@ -18269,7 +18269,7 @@
           <p:cNvPr id="5" name="">
             <a:extLst xmlns:a="http://schemas.openxmlformats.org/drawingml/2006/main">
               <a:ext uri="{FF2B5EF4-FFF2-40B4-BE49-F238E27FC236}">
-                <a16:creationId xmlns:a16="http://schemas.microsoft.com/office/drawing/2014/main" id="{5A08C834-DE20-4278-8416-781D303E481C}"/>
+                <a16:creationId xmlns:a16="http://schemas.microsoft.com/office/drawing/2014/main" id="{E167C069-4ECA-4835-BE2E-2F7F816C708C}"/>
               </a:ext>
             </a:extLst>
           </p:cNvPr>
@@ -18426,7 +18426,7 @@
           <p:cNvPr id="6" name="">
             <a:extLst xmlns:a="http://schemas.openxmlformats.org/drawingml/2006/main">
               <a:ext uri="{FF2B5EF4-FFF2-40B4-BE49-F238E27FC236}">
-                <a16:creationId xmlns:a16="http://schemas.microsoft.com/office/drawing/2014/main" id="{76CE54D2-B06F-445E-85F1-DA62504B8FF4}"/>
+                <a16:creationId xmlns:a16="http://schemas.microsoft.com/office/drawing/2014/main" id="{8E69A16B-B43E-451E-8F9F-A38926454CD3}"/>
               </a:ext>
             </a:extLst>
           </p:cNvPr>
@@ -18606,7 +18606,7 @@
           <p:cNvPr id="7" name="">
             <a:extLst xmlns:a="http://schemas.openxmlformats.org/drawingml/2006/main">
               <a:ext uri="{FF2B5EF4-FFF2-40B4-BE49-F238E27FC236}">
-                <a16:creationId xmlns:a16="http://schemas.microsoft.com/office/drawing/2014/main" id="{8EB7F449-577E-4190-8B59-986BD62B5285}"/>
+                <a16:creationId xmlns:a16="http://schemas.microsoft.com/office/drawing/2014/main" id="{2C377ACB-C5CB-4BAB-8A0C-81C4FD1B8FCF}"/>
               </a:ext>
             </a:extLst>
           </p:cNvPr>
@@ -18637,7 +18637,7 @@
           <p:cNvPr id="8" name="">
             <a:extLst xmlns:a="http://schemas.openxmlformats.org/drawingml/2006/main">
               <a:ext uri="{FF2B5EF4-FFF2-40B4-BE49-F238E27FC236}">
-                <a16:creationId xmlns:a16="http://schemas.microsoft.com/office/drawing/2014/main" id="{CA9861A9-2DFE-42CD-9A65-CFC9249B9F52}"/>
+                <a16:creationId xmlns:a16="http://schemas.microsoft.com/office/drawing/2014/main" id="{3E2DA8C0-792E-48F4-87EB-CF9BA28BDE61}"/>
               </a:ext>
             </a:extLst>
           </p:cNvPr>
@@ -18670,7 +18670,7 @@
           <p:cNvPr id="9" name="">
             <a:extLst xmlns:a="http://schemas.openxmlformats.org/drawingml/2006/main">
               <a:ext uri="{FF2B5EF4-FFF2-40B4-BE49-F238E27FC236}">
-                <a16:creationId xmlns:a16="http://schemas.microsoft.com/office/drawing/2014/main" id="{27444114-7D18-4EAE-882F-5CE3F4581764}"/>
+                <a16:creationId xmlns:a16="http://schemas.microsoft.com/office/drawing/2014/main" id="{F65D5E97-C70C-4F67-B27A-3109075E75F5}"/>
               </a:ext>
             </a:extLst>
           </p:cNvPr>
@@ -18827,7 +18827,7 @@
           <p:cNvPr id="10" name="">
             <a:extLst xmlns:a="http://schemas.openxmlformats.org/drawingml/2006/main">
               <a:ext uri="{FF2B5EF4-FFF2-40B4-BE49-F238E27FC236}">
-                <a16:creationId xmlns:a16="http://schemas.microsoft.com/office/drawing/2014/main" id="{8E4D76FC-F165-4E6B-B0CD-F9F2B31D23E5}"/>
+                <a16:creationId xmlns:a16="http://schemas.microsoft.com/office/drawing/2014/main" id="{C8DC1992-02F3-40A0-A18D-E0DEDF415DDE}"/>
               </a:ext>
             </a:extLst>
           </p:cNvPr>
@@ -19007,7 +19007,7 @@
           <p:cNvPr id="11" name="">
             <a:extLst xmlns:a="http://schemas.openxmlformats.org/drawingml/2006/main">
               <a:ext uri="{FF2B5EF4-FFF2-40B4-BE49-F238E27FC236}">
-                <a16:creationId xmlns:a16="http://schemas.microsoft.com/office/drawing/2014/main" id="{9A1ACE3E-7FA8-44F7-B1D9-6FCC995A8AED}"/>
+                <a16:creationId xmlns:a16="http://schemas.microsoft.com/office/drawing/2014/main" id="{26CB718B-E88A-4BC6-B45D-F19CD375FB50}"/>
               </a:ext>
             </a:extLst>
           </p:cNvPr>
@@ -19038,7 +19038,7 @@
           <p:cNvPr id="12" name="">
             <a:extLst xmlns:a="http://schemas.openxmlformats.org/drawingml/2006/main">
               <a:ext uri="{FF2B5EF4-FFF2-40B4-BE49-F238E27FC236}">
-                <a16:creationId xmlns:a16="http://schemas.microsoft.com/office/drawing/2014/main" id="{0EF6B0D5-DACE-4B87-A911-129F84A9C7A1}"/>
+                <a16:creationId xmlns:a16="http://schemas.microsoft.com/office/drawing/2014/main" id="{6A4E34CD-816A-4DD6-9D4E-DB43ADA330E0}"/>
               </a:ext>
             </a:extLst>
           </p:cNvPr>
@@ -19071,7 +19071,7 @@
           <p:cNvPr id="13" name="">
             <a:extLst xmlns:a="http://schemas.openxmlformats.org/drawingml/2006/main">
               <a:ext uri="{FF2B5EF4-FFF2-40B4-BE49-F238E27FC236}">
-                <a16:creationId xmlns:a16="http://schemas.microsoft.com/office/drawing/2014/main" id="{819A3C7C-ACD6-4D3F-ADBF-333463B63573}"/>
+                <a16:creationId xmlns:a16="http://schemas.microsoft.com/office/drawing/2014/main" id="{0CE18A97-05A6-46B6-AD0C-CC39AE22AE10}"/>
               </a:ext>
             </a:extLst>
           </p:cNvPr>
@@ -19228,7 +19228,7 @@
           <p:cNvPr id="14" name="">
             <a:extLst xmlns:a="http://schemas.openxmlformats.org/drawingml/2006/main">
               <a:ext uri="{FF2B5EF4-FFF2-40B4-BE49-F238E27FC236}">
-                <a16:creationId xmlns:a16="http://schemas.microsoft.com/office/drawing/2014/main" id="{05261CFD-56E0-49F1-B9FC-D9C34C67AC06}"/>
+                <a16:creationId xmlns:a16="http://schemas.microsoft.com/office/drawing/2014/main" id="{93727979-4B9E-4350-BBFB-E5AF70E1867A}"/>
               </a:ext>
             </a:extLst>
           </p:cNvPr>
@@ -19408,7 +19408,7 @@
           <p:cNvPr id="15" name="">
             <a:extLst xmlns:a="http://schemas.openxmlformats.org/drawingml/2006/main">
               <a:ext uri="{FF2B5EF4-FFF2-40B4-BE49-F238E27FC236}">
-                <a16:creationId xmlns:a16="http://schemas.microsoft.com/office/drawing/2014/main" id="{3F293E27-3B30-465B-A85E-3B4BBE0501B4}"/>
+                <a16:creationId xmlns:a16="http://schemas.microsoft.com/office/drawing/2014/main" id="{81CB14EE-4382-4181-8A4B-9B013D6A34A9}"/>
               </a:ext>
             </a:extLst>
           </p:cNvPr>
@@ -19439,7 +19439,7 @@
           <p:cNvPr id="16" name="">
             <a:extLst xmlns:a="http://schemas.openxmlformats.org/drawingml/2006/main">
               <a:ext uri="{FF2B5EF4-FFF2-40B4-BE49-F238E27FC236}">
-                <a16:creationId xmlns:a16="http://schemas.microsoft.com/office/drawing/2014/main" id="{C47DFA25-F541-469A-846C-63A24D39E422}"/>
+                <a16:creationId xmlns:a16="http://schemas.microsoft.com/office/drawing/2014/main" id="{5DC021BC-C012-48D9-A1E0-CB55DDF1A997}"/>
               </a:ext>
             </a:extLst>
           </p:cNvPr>
@@ -19472,7 +19472,7 @@
           <p:cNvPr id="17" name="">
             <a:extLst xmlns:a="http://schemas.openxmlformats.org/drawingml/2006/main">
               <a:ext uri="{FF2B5EF4-FFF2-40B4-BE49-F238E27FC236}">
-                <a16:creationId xmlns:a16="http://schemas.microsoft.com/office/drawing/2014/main" id="{476AE2B9-38D5-4DF4-87A5-6EF2DBF75FDC}"/>
+                <a16:creationId xmlns:a16="http://schemas.microsoft.com/office/drawing/2014/main" id="{6335456C-CD9C-4B6D-ABC3-5D89A7A8A321}"/>
               </a:ext>
             </a:extLst>
           </p:cNvPr>
@@ -19629,7 +19629,7 @@
           <p:cNvPr id="18" name="">
             <a:extLst xmlns:a="http://schemas.openxmlformats.org/drawingml/2006/main">
               <a:ext uri="{FF2B5EF4-FFF2-40B4-BE49-F238E27FC236}">
-                <a16:creationId xmlns:a16="http://schemas.microsoft.com/office/drawing/2014/main" id="{CFC8E463-C2D5-4EDD-9D92-1E5C5ECDF4D1}"/>
+                <a16:creationId xmlns:a16="http://schemas.microsoft.com/office/drawing/2014/main" id="{46601018-A1CB-4E42-AAEA-A5DA02668E12}"/>
               </a:ext>
             </a:extLst>
           </p:cNvPr>
@@ -19809,7 +19809,7 @@
           <p:cNvPr id="19" name="">
             <a:extLst xmlns:a="http://schemas.openxmlformats.org/drawingml/2006/main">
               <a:ext uri="{FF2B5EF4-FFF2-40B4-BE49-F238E27FC236}">
-                <a16:creationId xmlns:a16="http://schemas.microsoft.com/office/drawing/2014/main" id="{5779660B-893D-45F5-97FB-9FE1DA6BD4A4}"/>
+                <a16:creationId xmlns:a16="http://schemas.microsoft.com/office/drawing/2014/main" id="{F6ECA249-AD84-41FB-ABD4-4CFBC36F2976}"/>
               </a:ext>
             </a:extLst>
           </p:cNvPr>
@@ -19966,7 +19966,7 @@
           <p:cNvPr id="20" name="">
             <a:extLst xmlns:a="http://schemas.openxmlformats.org/drawingml/2006/main">
               <a:ext uri="{FF2B5EF4-FFF2-40B4-BE49-F238E27FC236}">
-                <a16:creationId xmlns:a16="http://schemas.microsoft.com/office/drawing/2014/main" id="{2374FBDA-D2A9-45EF-830D-C85F0A748647}"/>
+                <a16:creationId xmlns:a16="http://schemas.microsoft.com/office/drawing/2014/main" id="{A776EAFA-669D-4683-A846-0B6C78F78990}"/>
               </a:ext>
             </a:extLst>
           </p:cNvPr>
@@ -20123,7 +20123,7 @@
           <p:cNvPr id="21" name="">
             <a:extLst xmlns:a="http://schemas.openxmlformats.org/drawingml/2006/main">
               <a:ext uri="{FF2B5EF4-FFF2-40B4-BE49-F238E27FC236}">
-                <a16:creationId xmlns:a16="http://schemas.microsoft.com/office/drawing/2014/main" id="{69184C6B-7665-4EF1-8D60-4883BD0600AE}"/>
+                <a16:creationId xmlns:a16="http://schemas.microsoft.com/office/drawing/2014/main" id="{4A8E322E-770D-476D-B67A-AC7E557FBEC8}"/>
               </a:ext>
             </a:extLst>
           </p:cNvPr>
@@ -20278,7 +20278,7 @@
     </p:spTree>
     <p:extLst>
       <p:ext uri="{BB962C8B-B14F-4D97-AF65-F5344CB8AC3E}">
-        <p14:creationId xmlns:p14="http://schemas.microsoft.com/office/powerpoint/2010/main" val="359337838"/>
+        <p14:creationId xmlns:p14="http://schemas.microsoft.com/office/powerpoint/2010/main" val="2060873633"/>
       </p:ext>
     </p:extLst>
   </p:cSld>
@@ -20309,7 +20309,7 @@
           <p:cNvPr id="9" name="">
             <a:extLst xmlns:a="http://schemas.openxmlformats.org/drawingml/2006/main">
               <a:ext uri="{FF2B5EF4-FFF2-40B4-BE49-F238E27FC236}">
-                <a16:creationId xmlns:a16="http://schemas.microsoft.com/office/drawing/2014/main" id="{34FDB08E-BD0D-4074-A28F-1D37F886DE4A}"/>
+                <a16:creationId xmlns:a16="http://schemas.microsoft.com/office/drawing/2014/main" id="{99A2C3C1-09B1-4DAE-BFFF-4AC8C1F52C49}"/>
               </a:ext>
             </a:extLst>
           </p:cNvPr>
@@ -20466,7 +20466,7 @@
           <p:cNvPr id="2" name="">
             <a:extLst xmlns:a="http://schemas.openxmlformats.org/drawingml/2006/main">
               <a:ext uri="{FF2B5EF4-FFF2-40B4-BE49-F238E27FC236}">
-                <a16:creationId xmlns:a16="http://schemas.microsoft.com/office/drawing/2014/main" id="{CC9B74CB-A249-40BD-92BE-B234267F268A}"/>
+                <a16:creationId xmlns:a16="http://schemas.microsoft.com/office/drawing/2014/main" id="{F5B4FA86-9103-4702-8452-4A7FC716B3DA}"/>
               </a:ext>
             </a:extLst>
           </p:cNvPr>
@@ -20497,7 +20497,7 @@
           <p:cNvPr id="3" name="">
             <a:extLst xmlns:a="http://schemas.openxmlformats.org/drawingml/2006/main">
               <a:ext uri="{FF2B5EF4-FFF2-40B4-BE49-F238E27FC236}">
-                <a16:creationId xmlns:a16="http://schemas.microsoft.com/office/drawing/2014/main" id="{78C9AC53-088E-40C8-86F4-84A37DB5709E}"/>
+                <a16:creationId xmlns:a16="http://schemas.microsoft.com/office/drawing/2014/main" id="{F117FDF5-2730-4637-A74B-77F6CC3AABF8}"/>
               </a:ext>
             </a:extLst>
           </p:cNvPr>
@@ -20654,7 +20654,7 @@
           <p:cNvPr id="4" name="Chart">
             <a:extLst xmlns:a="http://schemas.openxmlformats.org/drawingml/2006/main">
               <a:ext uri="{FF2B5EF4-FFF2-40B4-BE49-F238E27FC236}">
-                <a16:creationId xmlns:a16="http://schemas.microsoft.com/office/drawing/2014/main" id="{02324DD7-68AC-499D-A28A-7D7D78E2BC9C}"/>
+                <a16:creationId xmlns:a16="http://schemas.microsoft.com/office/drawing/2014/main" id="{3F03A1D2-6113-40AB-A694-5FB55765AFC1}"/>
               </a:ext>
             </a:extLst>
           </p:cNvPr>
@@ -20667,7 +20667,7 @@
         </p:xfrm>
         <a:graphic xmlns:a="http://schemas.openxmlformats.org/drawingml/2006/main">
           <a:graphicData uri="http://schemas.openxmlformats.org/drawingml/2006/chart">
-            <c:chart xmlns:r="http://schemas.openxmlformats.org/officeDocument/2006/relationships" xmlns:c="http://schemas.openxmlformats.org/drawingml/2006/chart" r:id="R8bbaf23ee2ab44d8"/>
+            <c:chart xmlns:r="http://schemas.openxmlformats.org/officeDocument/2006/relationships" xmlns:c="http://schemas.openxmlformats.org/drawingml/2006/chart" r:id="R78d422211b864cb1"/>
           </a:graphicData>
         </a:graphic>
       </p:graphicFrame>
@@ -20676,7 +20676,7 @@
           <p:cNvPr id="5" name="">
             <a:extLst xmlns:a="http://schemas.openxmlformats.org/drawingml/2006/main">
               <a:ext uri="{FF2B5EF4-FFF2-40B4-BE49-F238E27FC236}">
-                <a16:creationId xmlns:a16="http://schemas.microsoft.com/office/drawing/2014/main" id="{CE5BF85E-A7A1-44D7-9D07-204A15D50158}"/>
+                <a16:creationId xmlns:a16="http://schemas.microsoft.com/office/drawing/2014/main" id="{19B0A222-6D83-4C11-BA3C-D3F7E996CB8E}"/>
               </a:ext>
             </a:extLst>
           </p:cNvPr>
@@ -20833,7 +20833,7 @@
           <p:cNvPr id="6" name="">
             <a:extLst xmlns:a="http://schemas.openxmlformats.org/drawingml/2006/main">
               <a:ext uri="{FF2B5EF4-FFF2-40B4-BE49-F238E27FC236}">
-                <a16:creationId xmlns:a16="http://schemas.microsoft.com/office/drawing/2014/main" id="{0AF4E014-1D15-4049-BD1F-627131DFBF92}"/>
+                <a16:creationId xmlns:a16="http://schemas.microsoft.com/office/drawing/2014/main" id="{9861E300-102C-484A-B85D-7F3DF09B6AE3}"/>
               </a:ext>
             </a:extLst>
           </p:cNvPr>
@@ -21036,7 +21036,7 @@
           <p:cNvPr id="7" name="">
             <a:extLst xmlns:a="http://schemas.openxmlformats.org/drawingml/2006/main">
               <a:ext uri="{FF2B5EF4-FFF2-40B4-BE49-F238E27FC236}">
-                <a16:creationId xmlns:a16="http://schemas.microsoft.com/office/drawing/2014/main" id="{3C8FA38F-7C90-4FE1-9242-C3576FAC3924}"/>
+                <a16:creationId xmlns:a16="http://schemas.microsoft.com/office/drawing/2014/main" id="{C8F0DE83-02B7-4F40-BB51-B44DB9F3DD27}"/>
               </a:ext>
             </a:extLst>
           </p:cNvPr>
@@ -21216,7 +21216,7 @@
           <p:cNvPr id="8" name="">
             <a:extLst xmlns:a="http://schemas.openxmlformats.org/drawingml/2006/main">
               <a:ext uri="{FF2B5EF4-FFF2-40B4-BE49-F238E27FC236}">
-                <a16:creationId xmlns:a16="http://schemas.microsoft.com/office/drawing/2014/main" id="{F0BCFB13-CDFD-4156-89BF-76FDE5658664}"/>
+                <a16:creationId xmlns:a16="http://schemas.microsoft.com/office/drawing/2014/main" id="{92B98284-2C4C-449C-87A5-A6C93D88B7FC}"/>
               </a:ext>
             </a:extLst>
           </p:cNvPr>
@@ -21371,7 +21371,7 @@
     </p:spTree>
     <p:extLst>
       <p:ext uri="{BB962C8B-B14F-4D97-AF65-F5344CB8AC3E}">
-        <p14:creationId xmlns:p14="http://schemas.microsoft.com/office/powerpoint/2010/main" val="439758488"/>
+        <p14:creationId xmlns:p14="http://schemas.microsoft.com/office/powerpoint/2010/main" val="2095766550"/>
       </p:ext>
     </p:extLst>
   </p:cSld>
@@ -21402,7 +21402,7 @@
           <p:cNvPr id="27" name="">
             <a:extLst xmlns:a="http://schemas.openxmlformats.org/drawingml/2006/main">
               <a:ext uri="{FF2B5EF4-FFF2-40B4-BE49-F238E27FC236}">
-                <a16:creationId xmlns:a16="http://schemas.microsoft.com/office/drawing/2014/main" id="{6EFB3799-8D76-470C-B8FC-29B74D07171F}"/>
+                <a16:creationId xmlns:a16="http://schemas.microsoft.com/office/drawing/2014/main" id="{1C070339-FDD5-4DD5-AEE3-A9158CB72ED0}"/>
               </a:ext>
             </a:extLst>
           </p:cNvPr>
@@ -21559,7 +21559,7 @@
           <p:cNvPr id="2" name="">
             <a:extLst xmlns:a="http://schemas.openxmlformats.org/drawingml/2006/main">
               <a:ext uri="{FF2B5EF4-FFF2-40B4-BE49-F238E27FC236}">
-                <a16:creationId xmlns:a16="http://schemas.microsoft.com/office/drawing/2014/main" id="{881F4926-093B-40E3-80C3-AD59FA5B69A6}"/>
+                <a16:creationId xmlns:a16="http://schemas.microsoft.com/office/drawing/2014/main" id="{20FBDD98-D8A9-49C0-AEE3-3ADA350BDE71}"/>
               </a:ext>
             </a:extLst>
           </p:cNvPr>
@@ -21590,7 +21590,7 @@
           <p:cNvPr id="3" name="">
             <a:extLst xmlns:a="http://schemas.openxmlformats.org/drawingml/2006/main">
               <a:ext uri="{FF2B5EF4-FFF2-40B4-BE49-F238E27FC236}">
-                <a16:creationId xmlns:a16="http://schemas.microsoft.com/office/drawing/2014/main" id="{9B11AA80-320A-4556-BE0E-DCDE68AEBB7E}"/>
+                <a16:creationId xmlns:a16="http://schemas.microsoft.com/office/drawing/2014/main" id="{E2F027E2-B71F-4080-9B93-0F57EC079DF5}"/>
               </a:ext>
             </a:extLst>
           </p:cNvPr>
@@ -21747,7 +21747,7 @@
           <p:cNvPr id="4" name="">
             <a:extLst xmlns:a="http://schemas.openxmlformats.org/drawingml/2006/main">
               <a:ext uri="{FF2B5EF4-FFF2-40B4-BE49-F238E27FC236}">
-                <a16:creationId xmlns:a16="http://schemas.microsoft.com/office/drawing/2014/main" id="{F55B0203-F0F2-46A0-A290-A03E0BD0FB99}"/>
+                <a16:creationId xmlns:a16="http://schemas.microsoft.com/office/drawing/2014/main" id="{92FCCF86-2EAF-45F8-A489-69374CBC1F05}"/>
               </a:ext>
             </a:extLst>
           </p:cNvPr>
@@ -21780,7 +21780,7 @@
           <p:cNvPr id="5" name="">
             <a:extLst xmlns:a="http://schemas.openxmlformats.org/drawingml/2006/main">
               <a:ext uri="{FF2B5EF4-FFF2-40B4-BE49-F238E27FC236}">
-                <a16:creationId xmlns:a16="http://schemas.microsoft.com/office/drawing/2014/main" id="{C6C7B386-BCB6-4696-B491-31C6E047C6EE}"/>
+                <a16:creationId xmlns:a16="http://schemas.microsoft.com/office/drawing/2014/main" id="{3DFDC9A3-CA39-46C2-9420-317799A4E73A}"/>
               </a:ext>
             </a:extLst>
           </p:cNvPr>
@@ -21937,7 +21937,7 @@
           <p:cNvPr id="6" name="">
             <a:extLst xmlns:a="http://schemas.openxmlformats.org/drawingml/2006/main">
               <a:ext uri="{FF2B5EF4-FFF2-40B4-BE49-F238E27FC236}">
-                <a16:creationId xmlns:a16="http://schemas.microsoft.com/office/drawing/2014/main" id="{10B77955-FA12-4CCE-A571-F9E2E514ADB9}"/>
+                <a16:creationId xmlns:a16="http://schemas.microsoft.com/office/drawing/2014/main" id="{6910CD06-DF64-4F81-A7F5-07C611801B55}"/>
               </a:ext>
             </a:extLst>
           </p:cNvPr>
@@ -22117,7 +22117,7 @@
           <p:cNvPr id="7" name="">
             <a:extLst xmlns:a="http://schemas.openxmlformats.org/drawingml/2006/main">
               <a:ext uri="{FF2B5EF4-FFF2-40B4-BE49-F238E27FC236}">
-                <a16:creationId xmlns:a16="http://schemas.microsoft.com/office/drawing/2014/main" id="{B01E42B7-0CB4-4840-99C0-16D9B5C3ABDA}"/>
+                <a16:creationId xmlns:a16="http://schemas.microsoft.com/office/drawing/2014/main" id="{DBED5E7C-201D-4724-8113-040B69FE2008}"/>
               </a:ext>
             </a:extLst>
           </p:cNvPr>
@@ -22148,7 +22148,7 @@
           <p:cNvPr id="8" name="">
             <a:extLst xmlns:a="http://schemas.openxmlformats.org/drawingml/2006/main">
               <a:ext uri="{FF2B5EF4-FFF2-40B4-BE49-F238E27FC236}">
-                <a16:creationId xmlns:a16="http://schemas.microsoft.com/office/drawing/2014/main" id="{D14D97F5-CE14-4792-8318-EB90F2EFB294}"/>
+                <a16:creationId xmlns:a16="http://schemas.microsoft.com/office/drawing/2014/main" id="{888568F5-D854-44CC-AF66-877E740EA3C1}"/>
               </a:ext>
             </a:extLst>
           </p:cNvPr>
@@ -22181,7 +22181,7 @@
           <p:cNvPr id="9" name="">
             <a:extLst xmlns:a="http://schemas.openxmlformats.org/drawingml/2006/main">
               <a:ext uri="{FF2B5EF4-FFF2-40B4-BE49-F238E27FC236}">
-                <a16:creationId xmlns:a16="http://schemas.microsoft.com/office/drawing/2014/main" id="{ED8A6D45-D17A-4808-AFAE-019DBD72F7E8}"/>
+                <a16:creationId xmlns:a16="http://schemas.microsoft.com/office/drawing/2014/main" id="{0A85EEEE-912E-444B-A11E-351B9CC66C95}"/>
               </a:ext>
             </a:extLst>
           </p:cNvPr>
@@ -22338,7 +22338,7 @@
           <p:cNvPr id="10" name="">
             <a:extLst xmlns:a="http://schemas.openxmlformats.org/drawingml/2006/main">
               <a:ext uri="{FF2B5EF4-FFF2-40B4-BE49-F238E27FC236}">
-                <a16:creationId xmlns:a16="http://schemas.microsoft.com/office/drawing/2014/main" id="{EECEBB33-2B04-454C-B764-A295CA304D40}"/>
+                <a16:creationId xmlns:a16="http://schemas.microsoft.com/office/drawing/2014/main" id="{080754D2-AFAA-4D5F-A127-39EC35772DE2}"/>
               </a:ext>
             </a:extLst>
           </p:cNvPr>
@@ -22518,7 +22518,7 @@
           <p:cNvPr id="11" name="">
             <a:extLst xmlns:a="http://schemas.openxmlformats.org/drawingml/2006/main">
               <a:ext uri="{FF2B5EF4-FFF2-40B4-BE49-F238E27FC236}">
-                <a16:creationId xmlns:a16="http://schemas.microsoft.com/office/drawing/2014/main" id="{15688CC8-D5D0-4BB2-AC5D-7D48DC5F45FA}"/>
+                <a16:creationId xmlns:a16="http://schemas.microsoft.com/office/drawing/2014/main" id="{32088BF2-C3C5-4CB4-BBC3-3EBD59308A32}"/>
               </a:ext>
             </a:extLst>
           </p:cNvPr>
@@ -22549,7 +22549,7 @@
           <p:cNvPr id="12" name="">
             <a:extLst xmlns:a="http://schemas.openxmlformats.org/drawingml/2006/main">
               <a:ext uri="{FF2B5EF4-FFF2-40B4-BE49-F238E27FC236}">
-                <a16:creationId xmlns:a16="http://schemas.microsoft.com/office/drawing/2014/main" id="{E7B6675E-CF46-4BCD-8E92-CB1CD6AB6AD6}"/>
+                <a16:creationId xmlns:a16="http://schemas.microsoft.com/office/drawing/2014/main" id="{D18F98F1-33E1-497C-BE2E-7C9E1D4B0252}"/>
               </a:ext>
             </a:extLst>
           </p:cNvPr>
@@ -22582,7 +22582,7 @@
           <p:cNvPr id="13" name="">
             <a:extLst xmlns:a="http://schemas.openxmlformats.org/drawingml/2006/main">
               <a:ext uri="{FF2B5EF4-FFF2-40B4-BE49-F238E27FC236}">
-                <a16:creationId xmlns:a16="http://schemas.microsoft.com/office/drawing/2014/main" id="{34BF9A74-1936-4BD8-990F-3C9EDF3ACD09}"/>
+                <a16:creationId xmlns:a16="http://schemas.microsoft.com/office/drawing/2014/main" id="{E238FC24-195C-4CAA-878F-CE8AC6367B8F}"/>
               </a:ext>
             </a:extLst>
           </p:cNvPr>
@@ -22739,7 +22739,7 @@
           <p:cNvPr id="14" name="">
             <a:extLst xmlns:a="http://schemas.openxmlformats.org/drawingml/2006/main">
               <a:ext uri="{FF2B5EF4-FFF2-40B4-BE49-F238E27FC236}">
-                <a16:creationId xmlns:a16="http://schemas.microsoft.com/office/drawing/2014/main" id="{998FA2CD-222E-47BC-BDC7-BFC3BCCE5259}"/>
+                <a16:creationId xmlns:a16="http://schemas.microsoft.com/office/drawing/2014/main" id="{B4A02D1B-E67B-47E9-B28A-DD0BDE6E900D}"/>
               </a:ext>
             </a:extLst>
           </p:cNvPr>
@@ -22919,7 +22919,7 @@
           <p:cNvPr id="15" name="">
             <a:extLst xmlns:a="http://schemas.openxmlformats.org/drawingml/2006/main">
               <a:ext uri="{FF2B5EF4-FFF2-40B4-BE49-F238E27FC236}">
-                <a16:creationId xmlns:a16="http://schemas.microsoft.com/office/drawing/2014/main" id="{CD491605-0DDB-43AF-BEC9-2BD1E1BC4F4C}"/>
+                <a16:creationId xmlns:a16="http://schemas.microsoft.com/office/drawing/2014/main" id="{07CC5D44-B2EA-49BB-B41F-CC81E7844A76}"/>
               </a:ext>
             </a:extLst>
           </p:cNvPr>
@@ -22950,7 +22950,7 @@
           <p:cNvPr id="16" name="">
             <a:extLst xmlns:a="http://schemas.openxmlformats.org/drawingml/2006/main">
               <a:ext uri="{FF2B5EF4-FFF2-40B4-BE49-F238E27FC236}">
-                <a16:creationId xmlns:a16="http://schemas.microsoft.com/office/drawing/2014/main" id="{44D5D06D-1CB8-47FD-9826-8951FE102BED}"/>
+                <a16:creationId xmlns:a16="http://schemas.microsoft.com/office/drawing/2014/main" id="{29C4E65C-9F1A-41EE-9CD3-FE6D2CD70C94}"/>
               </a:ext>
             </a:extLst>
           </p:cNvPr>
@@ -22983,7 +22983,7 @@
           <p:cNvPr id="17" name="">
             <a:extLst xmlns:a="http://schemas.openxmlformats.org/drawingml/2006/main">
               <a:ext uri="{FF2B5EF4-FFF2-40B4-BE49-F238E27FC236}">
-                <a16:creationId xmlns:a16="http://schemas.microsoft.com/office/drawing/2014/main" id="{29CD2DCA-6E31-400B-BE88-0F706A347D56}"/>
+                <a16:creationId xmlns:a16="http://schemas.microsoft.com/office/drawing/2014/main" id="{3F51BE7F-3A47-493C-BB6D-B328EE149B04}"/>
               </a:ext>
             </a:extLst>
           </p:cNvPr>
@@ -23140,7 +23140,7 @@
           <p:cNvPr id="18" name="">
             <a:extLst xmlns:a="http://schemas.openxmlformats.org/drawingml/2006/main">
               <a:ext uri="{FF2B5EF4-FFF2-40B4-BE49-F238E27FC236}">
-                <a16:creationId xmlns:a16="http://schemas.microsoft.com/office/drawing/2014/main" id="{EFA92BCD-130F-46C6-AC65-32EB62EC8AF9}"/>
+                <a16:creationId xmlns:a16="http://schemas.microsoft.com/office/drawing/2014/main" id="{270BD70F-C4F6-42B9-A7C2-316AC595F627}"/>
               </a:ext>
             </a:extLst>
           </p:cNvPr>
@@ -23320,7 +23320,7 @@
           <p:cNvPr id="19" name="">
             <a:extLst xmlns:a="http://schemas.openxmlformats.org/drawingml/2006/main">
               <a:ext uri="{FF2B5EF4-FFF2-40B4-BE49-F238E27FC236}">
-                <a16:creationId xmlns:a16="http://schemas.microsoft.com/office/drawing/2014/main" id="{CC1BEE46-DD5E-4C13-B400-565EA8BCFB3A}"/>
+                <a16:creationId xmlns:a16="http://schemas.microsoft.com/office/drawing/2014/main" id="{E7301ED8-4696-49D9-9330-FCE5A8A258E3}"/>
               </a:ext>
             </a:extLst>
           </p:cNvPr>
@@ -23351,7 +23351,7 @@
           <p:cNvPr id="20" name="">
             <a:extLst xmlns:a="http://schemas.openxmlformats.org/drawingml/2006/main">
               <a:ext uri="{FF2B5EF4-FFF2-40B4-BE49-F238E27FC236}">
-                <a16:creationId xmlns:a16="http://schemas.microsoft.com/office/drawing/2014/main" id="{D5B2CB22-DCAC-4C19-97CC-39F10FBB32F1}"/>
+                <a16:creationId xmlns:a16="http://schemas.microsoft.com/office/drawing/2014/main" id="{5DEF512F-FB08-4C2D-A25A-E10F4D325406}"/>
               </a:ext>
             </a:extLst>
           </p:cNvPr>
@@ -23382,7 +23382,7 @@
           <p:cNvPr id="21" name="">
             <a:extLst xmlns:a="http://schemas.openxmlformats.org/drawingml/2006/main">
               <a:ext uri="{FF2B5EF4-FFF2-40B4-BE49-F238E27FC236}">
-                <a16:creationId xmlns:a16="http://schemas.microsoft.com/office/drawing/2014/main" id="{A9FB1893-1E61-40C1-BA3D-3AB482539B1E}"/>
+                <a16:creationId xmlns:a16="http://schemas.microsoft.com/office/drawing/2014/main" id="{2BBAE3C2-0B57-4C28-891D-2F69856C04E4}"/>
               </a:ext>
             </a:extLst>
           </p:cNvPr>
@@ -23539,7 +23539,7 @@
           <p:cNvPr id="22" name="">
             <a:extLst xmlns:a="http://schemas.openxmlformats.org/drawingml/2006/main">
               <a:ext uri="{FF2B5EF4-FFF2-40B4-BE49-F238E27FC236}">
-                <a16:creationId xmlns:a16="http://schemas.microsoft.com/office/drawing/2014/main" id="{700FE1F2-317B-488D-B4F9-E50CA4BF8616}"/>
+                <a16:creationId xmlns:a16="http://schemas.microsoft.com/office/drawing/2014/main" id="{F8BB49E1-6D19-45A3-94E8-88C4B35F6B09}"/>
               </a:ext>
             </a:extLst>
           </p:cNvPr>
@@ -23696,7 +23696,7 @@
           <p:cNvPr id="23" name="">
             <a:extLst xmlns:a="http://schemas.openxmlformats.org/drawingml/2006/main">
               <a:ext uri="{FF2B5EF4-FFF2-40B4-BE49-F238E27FC236}">
-                <a16:creationId xmlns:a16="http://schemas.microsoft.com/office/drawing/2014/main" id="{CD89B04E-53FB-45DE-8A9B-2796C6533C76}"/>
+                <a16:creationId xmlns:a16="http://schemas.microsoft.com/office/drawing/2014/main" id="{1118A931-037C-47D7-8150-81ED4EFAD942}"/>
               </a:ext>
             </a:extLst>
           </p:cNvPr>
@@ -23876,7 +23876,7 @@
           <p:cNvPr id="24" name="">
             <a:extLst xmlns:a="http://schemas.openxmlformats.org/drawingml/2006/main">
               <a:ext uri="{FF2B5EF4-FFF2-40B4-BE49-F238E27FC236}">
-                <a16:creationId xmlns:a16="http://schemas.microsoft.com/office/drawing/2014/main" id="{118E826C-8932-435B-BD34-E6EAD1F50141}"/>
+                <a16:creationId xmlns:a16="http://schemas.microsoft.com/office/drawing/2014/main" id="{C192BB81-FEF5-4ABC-8894-C448635051E4}"/>
               </a:ext>
             </a:extLst>
           </p:cNvPr>
@@ -24033,7 +24033,7 @@
           <p:cNvPr id="25" name="">
             <a:extLst xmlns:a="http://schemas.openxmlformats.org/drawingml/2006/main">
               <a:ext uri="{FF2B5EF4-FFF2-40B4-BE49-F238E27FC236}">
-                <a16:creationId xmlns:a16="http://schemas.microsoft.com/office/drawing/2014/main" id="{C437C77C-16B1-4442-A44D-05626998F7B2}"/>
+                <a16:creationId xmlns:a16="http://schemas.microsoft.com/office/drawing/2014/main" id="{ACE39012-102E-4DB5-B31A-9D0661728009}"/>
               </a:ext>
             </a:extLst>
           </p:cNvPr>
@@ -24213,7 +24213,7 @@
           <p:cNvPr id="26" name="">
             <a:extLst xmlns:a="http://schemas.openxmlformats.org/drawingml/2006/main">
               <a:ext uri="{FF2B5EF4-FFF2-40B4-BE49-F238E27FC236}">
-                <a16:creationId xmlns:a16="http://schemas.microsoft.com/office/drawing/2014/main" id="{93402058-22AC-43F7-88AB-25DA43B5FEC5}"/>
+                <a16:creationId xmlns:a16="http://schemas.microsoft.com/office/drawing/2014/main" id="{3007C0A5-90AC-48FA-8957-E6C44FC45A12}"/>
               </a:ext>
             </a:extLst>
           </p:cNvPr>
@@ -24368,7 +24368,7 @@
     </p:spTree>
     <p:extLst>
       <p:ext uri="{BB962C8B-B14F-4D97-AF65-F5344CB8AC3E}">
-        <p14:creationId xmlns:p14="http://schemas.microsoft.com/office/powerpoint/2010/main" val="758918212"/>
+        <p14:creationId xmlns:p14="http://schemas.microsoft.com/office/powerpoint/2010/main" val="1269541018"/>
       </p:ext>
     </p:extLst>
   </p:cSld>
@@ -24399,7 +24399,7 @@
           <p:cNvPr id="9" name="">
             <a:extLst xmlns:a="http://schemas.openxmlformats.org/drawingml/2006/main">
               <a:ext uri="{FF2B5EF4-FFF2-40B4-BE49-F238E27FC236}">
-                <a16:creationId xmlns:a16="http://schemas.microsoft.com/office/drawing/2014/main" id="{46CB975C-A6F9-4CA2-B308-3E1714D39562}"/>
+                <a16:creationId xmlns:a16="http://schemas.microsoft.com/office/drawing/2014/main" id="{754BD249-5816-4353-ADC2-C8C608424A15}"/>
               </a:ext>
             </a:extLst>
           </p:cNvPr>
@@ -24556,7 +24556,7 @@
           <p:cNvPr id="2" name="">
             <a:extLst xmlns:a="http://schemas.openxmlformats.org/drawingml/2006/main">
               <a:ext uri="{FF2B5EF4-FFF2-40B4-BE49-F238E27FC236}">
-                <a16:creationId xmlns:a16="http://schemas.microsoft.com/office/drawing/2014/main" id="{F1D632CC-F886-4CD8-8936-0F7A3738DAE1}"/>
+                <a16:creationId xmlns:a16="http://schemas.microsoft.com/office/drawing/2014/main" id="{AE9CA0F2-38B4-4B65-A402-5F38CC20D49D}"/>
               </a:ext>
             </a:extLst>
           </p:cNvPr>
@@ -24587,7 +24587,7 @@
           <p:cNvPr id="3" name="">
             <a:extLst xmlns:a="http://schemas.openxmlformats.org/drawingml/2006/main">
               <a:ext uri="{FF2B5EF4-FFF2-40B4-BE49-F238E27FC236}">
-                <a16:creationId xmlns:a16="http://schemas.microsoft.com/office/drawing/2014/main" id="{28CA4A4F-5822-4FA6-8FCC-D91CC283FD53}"/>
+                <a16:creationId xmlns:a16="http://schemas.microsoft.com/office/drawing/2014/main" id="{29AF9265-C4D7-4D37-B99B-0253BF0C23B5}"/>
               </a:ext>
             </a:extLst>
           </p:cNvPr>
@@ -24744,7 +24744,7 @@
           <p:cNvPr id="4" name="">
             <a:extLst xmlns:a="http://schemas.openxmlformats.org/drawingml/2006/main">
               <a:ext uri="{FF2B5EF4-FFF2-40B4-BE49-F238E27FC236}">
-                <a16:creationId xmlns:a16="http://schemas.microsoft.com/office/drawing/2014/main" id="{562CE069-054D-4D5A-88F6-1C603ED94A12}"/>
+                <a16:creationId xmlns:a16="http://schemas.microsoft.com/office/drawing/2014/main" id="{C44D38F3-771B-46BD-A597-FB32F4BC13D7}"/>
               </a:ext>
             </a:extLst>
           </p:cNvPr>
@@ -24901,7 +24901,7 @@
           <p:cNvPr id="5" name="">
             <a:extLst xmlns:a="http://schemas.openxmlformats.org/drawingml/2006/main">
               <a:ext uri="{FF2B5EF4-FFF2-40B4-BE49-F238E27FC236}">
-                <a16:creationId xmlns:a16="http://schemas.microsoft.com/office/drawing/2014/main" id="{D2548CA0-66FE-4D72-8285-4E3A79C1D61A}"/>
+                <a16:creationId xmlns:a16="http://schemas.microsoft.com/office/drawing/2014/main" id="{BAD4950C-40FB-4B10-A9B0-E325BA09F99C}"/>
               </a:ext>
             </a:extLst>
           </p:cNvPr>
@@ -25150,7 +25150,7 @@
           <p:cNvPr id="6" name="">
             <a:extLst xmlns:a="http://schemas.openxmlformats.org/drawingml/2006/main">
               <a:ext uri="{FF2B5EF4-FFF2-40B4-BE49-F238E27FC236}">
-                <a16:creationId xmlns:a16="http://schemas.microsoft.com/office/drawing/2014/main" id="{A46FA2ED-2903-4CDD-BB21-BBD55BB9942F}"/>
+                <a16:creationId xmlns:a16="http://schemas.microsoft.com/office/drawing/2014/main" id="{0CD9D912-D271-4EE8-80C2-8D1C6B858C47}"/>
               </a:ext>
             </a:extLst>
           </p:cNvPr>
@@ -25307,7 +25307,7 @@
           <p:cNvPr id="7" name="">
             <a:extLst xmlns:a="http://schemas.openxmlformats.org/drawingml/2006/main">
               <a:ext uri="{FF2B5EF4-FFF2-40B4-BE49-F238E27FC236}">
-                <a16:creationId xmlns:a16="http://schemas.microsoft.com/office/drawing/2014/main" id="{6BFE7AC8-90A5-4F08-8B81-F31D3B26C624}"/>
+                <a16:creationId xmlns:a16="http://schemas.microsoft.com/office/drawing/2014/main" id="{DEF85F63-7B74-4FD9-9C6A-735CC73C6A0B}"/>
               </a:ext>
             </a:extLst>
           </p:cNvPr>
@@ -25556,7 +25556,7 @@
           <p:cNvPr id="8" name="">
             <a:extLst xmlns:a="http://schemas.openxmlformats.org/drawingml/2006/main">
               <a:ext uri="{FF2B5EF4-FFF2-40B4-BE49-F238E27FC236}">
-                <a16:creationId xmlns:a16="http://schemas.microsoft.com/office/drawing/2014/main" id="{2FABA984-F7B4-476B-A205-264B56581B22}"/>
+                <a16:creationId xmlns:a16="http://schemas.microsoft.com/office/drawing/2014/main" id="{1D1463D0-BAF9-4C2B-9B5F-1BCA7E198821}"/>
               </a:ext>
             </a:extLst>
           </p:cNvPr>
@@ -25711,7 +25711,7 @@
     </p:spTree>
     <p:extLst>
       <p:ext uri="{BB962C8B-B14F-4D97-AF65-F5344CB8AC3E}">
-        <p14:creationId xmlns:p14="http://schemas.microsoft.com/office/powerpoint/2010/main" val="737326393"/>
+        <p14:creationId xmlns:p14="http://schemas.microsoft.com/office/powerpoint/2010/main" val="1109085674"/>
       </p:ext>
     </p:extLst>
   </p:cSld>

</xml_diff>

<commit_message>
Present bounded agent and planned dynamic LLM routing
</commit_message>
<xml_diff>
--- a/submissions/midterm-2026-10-28/isaforge-midterm-progress-slides-final.pptx
+++ b/submissions/midterm-2026-10-28/isaforge-midterm-progress-slides-final.pptx
@@ -2,23 +2,23 @@
 <file path=ppt/presentation.xml><?xml version="1.0" encoding="utf-8"?>
 <p:presentation xmlns:p="http://schemas.openxmlformats.org/presentationml/2006/main">
   <p:sldMasterIdLst>
-    <p:sldMasterId xmlns:r="http://schemas.openxmlformats.org/officeDocument/2006/relationships" id="2147483648" r:id="R8566ba1cccaf4f96"/>
+    <p:sldMasterId xmlns:r="http://schemas.openxmlformats.org/officeDocument/2006/relationships" id="2147483648" r:id="R25c1c1be500c48ab"/>
   </p:sldMasterIdLst>
   <p:notesMasterIdLst>
-    <p:notesMasterId xmlns:r="http://schemas.openxmlformats.org/officeDocument/2006/relationships" r:id="Rf4f1ecc471ed45f5"/>
+    <p:notesMasterId xmlns:r="http://schemas.openxmlformats.org/officeDocument/2006/relationships" r:id="R77b3bfccceb244bd"/>
   </p:notesMasterIdLst>
   <p:sldIdLst>
-    <p:sldId xmlns:r="http://schemas.openxmlformats.org/officeDocument/2006/relationships" id="256" r:id="Ra9829389fc574085"/>
-    <p:sldId xmlns:r="http://schemas.openxmlformats.org/officeDocument/2006/relationships" id="257" r:id="R802e39ff4c1742ab"/>
-    <p:sldId xmlns:r="http://schemas.openxmlformats.org/officeDocument/2006/relationships" id="258" r:id="Rd3742b487df448ef"/>
-    <p:sldId xmlns:r="http://schemas.openxmlformats.org/officeDocument/2006/relationships" id="259" r:id="R14c977e1277b46e8"/>
-    <p:sldId xmlns:r="http://schemas.openxmlformats.org/officeDocument/2006/relationships" id="260" r:id="R41a8945c3b3d45f8"/>
-    <p:sldId xmlns:r="http://schemas.openxmlformats.org/officeDocument/2006/relationships" id="261" r:id="R0ce0e45aa4b94a53"/>
-    <p:sldId xmlns:r="http://schemas.openxmlformats.org/officeDocument/2006/relationships" id="262" r:id="R4180ca8d15ab41bf"/>
-    <p:sldId xmlns:r="http://schemas.openxmlformats.org/officeDocument/2006/relationships" id="263" r:id="R22e0ab48a77043d8"/>
-    <p:sldId xmlns:r="http://schemas.openxmlformats.org/officeDocument/2006/relationships" id="264" r:id="R71a0f0ca0e244518"/>
-    <p:sldId xmlns:r="http://schemas.openxmlformats.org/officeDocument/2006/relationships" id="265" r:id="Rf306c1110d7449c9"/>
-    <p:sldId xmlns:r="http://schemas.openxmlformats.org/officeDocument/2006/relationships" id="266" r:id="R913bd8f539514003"/>
+    <p:sldId xmlns:r="http://schemas.openxmlformats.org/officeDocument/2006/relationships" id="256" r:id="R46cfd58efbef4ddd"/>
+    <p:sldId xmlns:r="http://schemas.openxmlformats.org/officeDocument/2006/relationships" id="257" r:id="R77d72b9455734861"/>
+    <p:sldId xmlns:r="http://schemas.openxmlformats.org/officeDocument/2006/relationships" id="258" r:id="Rfad6cb04cabc4e57"/>
+    <p:sldId xmlns:r="http://schemas.openxmlformats.org/officeDocument/2006/relationships" id="259" r:id="Rb7eeff40eace4358"/>
+    <p:sldId xmlns:r="http://schemas.openxmlformats.org/officeDocument/2006/relationships" id="260" r:id="Rd8644832c6c3444c"/>
+    <p:sldId xmlns:r="http://schemas.openxmlformats.org/officeDocument/2006/relationships" id="261" r:id="Ra5ec2d4bb3c64fce"/>
+    <p:sldId xmlns:r="http://schemas.openxmlformats.org/officeDocument/2006/relationships" id="262" r:id="R392f8b2719f64984"/>
+    <p:sldId xmlns:r="http://schemas.openxmlformats.org/officeDocument/2006/relationships" id="263" r:id="R39cb69d3497b4256"/>
+    <p:sldId xmlns:r="http://schemas.openxmlformats.org/officeDocument/2006/relationships" id="264" r:id="R580e83400c834306"/>
+    <p:sldId xmlns:r="http://schemas.openxmlformats.org/officeDocument/2006/relationships" id="265" r:id="R427685a577ac4bee"/>
+    <p:sldId xmlns:r="http://schemas.openxmlformats.org/officeDocument/2006/relationships" id="266" r:id="R47398582bd094387"/>
   </p:sldIdLst>
   <p:sldSz cx="12192000" cy="6858000"/>
   <p:notesSz cx="6858000" cy="9144000"/>
@@ -1387,7 +1387,7 @@
           </a:p>
           <a:p xmlns:a="http://schemas.openxmlformats.org/drawingml/2006/main">
             <a:r>
-              <a:t>The LLM selector uses controlled tools to inspect candidates, query predictions, request a bounded measurement, and return a validated selection. Paid outcomes feed its next decision, and failed requests consume budget. This is an actual agentic loop, separate from the coding assistants used for implementation, debugging, and analysis. The Ascon pilot measured three correct candidates; the best feasible one achieved about 1.024 times cycle speedup. But nine candidates remain unmeasured and there are no matched controls. A status-handling bug prevented live GP updates; the fix was verified afterward. We also have not implemented dynamic routing between language models.</a:t>
+              <a:t>Our current agent uses structured actions to inspect candidates, query predictions, request a bounded measurement, and finalize a verified result. Guardrails enforce the hardware budget and keep unmeasured outcomes hidden. We plan dynamic language model routing: start with a smaller model, escalate ambiguous cases to a stronger model, and record token usage and latency. This router is not implemented yet. Agent memory would contain only public information and paid results. We will compare routing against fixed-model and non-agent controls under the same hardware budget. In the Ascon pilot, three candidates were measured; the best feasible one reached 1.024 times cycle speedup, but there is no matched agent win.</a:t>
             </a:r>
           </a:p>
           <a:p xmlns:a="http://schemas.openxmlformats.org/drawingml/2006/main">
@@ -1402,7 +1402,7 @@
           </a:p>
           <a:p xmlns:a="http://schemas.openxmlformats.org/drawingml/2006/main">
             <a:r>
-              <a:t>Agent protocol and logs: results/2026-10-27-codex-chat-agent-edn-b64-s0/; Ascon results and docs/HANDOFF.md. EDN consumed replay:2 charged attempts including1 invalid ID, matched oracle and ordinary policies. Ascon C01:1.019698x,+73LUT4,62.992MHz; C06:1.017027x,+41LUT4,67.069MHz; C02:1.023731x,+42LUT4,64.620MHz.3/12 measured; correctness passed for all3. No claim of agent superiority or successful live GP refitting.</a:t>
+              <a:t>Implemented: isaforge/bounded_selector.py, isaforge/selection_provider.py, scripts/run_codex_chat_selector.py; four tools list_candidates, predict, measure, finalize. Remote provider records model, tool calls, usage and latency where returned; active chat does not expose exact deployment ID or model-only usage. EDN consumed replay; Ascon three native measurements and live GP update defect fixed afterward. Proposed: smaller/stronger model routing, context/token budgets, retrieval, and complete cost/quality evaluation. No dynamic LLM routing, RAG/vector database, MCP integration, LangGraph, Ragas or production observability is claimed. See agent-architecture-plan.md.</a:t>
             </a:r>
           </a:p>
         </p:txBody>
@@ -1549,7 +1549,7 @@
           <p:cNvPr id="3" name="Title">
             <a:extLst xmlns:a="http://schemas.openxmlformats.org/drawingml/2006/main">
               <a:ext uri="{FF2B5EF4-FFF2-40B4-BE49-F238E27FC236}">
-                <a16:creationId xmlns:a16="http://schemas.microsoft.com/office/drawing/2014/main" id="{F5C602D6-95BC-4A98-94ED-A9EAC5681E35}"/>
+                <a16:creationId xmlns:a16="http://schemas.microsoft.com/office/drawing/2014/main" id="{A7CF5774-85D5-49B0-A39B-F362BD547FFB}"/>
               </a:ext>
             </a:extLst>
           </p:cNvPr>
@@ -1778,7 +1778,7 @@
           <p:cNvPr id="2" name="Subtitle">
             <a:extLst xmlns:a="http://schemas.openxmlformats.org/drawingml/2006/main">
               <a:ext uri="{FF2B5EF4-FFF2-40B4-BE49-F238E27FC236}">
-                <a16:creationId xmlns:a16="http://schemas.microsoft.com/office/drawing/2014/main" id="{DF52B176-63C0-4A97-97E7-BDB5392B340C}"/>
+                <a16:creationId xmlns:a16="http://schemas.microsoft.com/office/drawing/2014/main" id="{D6563462-E586-434C-992E-9EAC25C1B0E6}"/>
               </a:ext>
             </a:extLst>
           </p:cNvPr>
@@ -2024,7 +2024,7 @@
           <p:cNvPr id="2" name="Section title">
             <a:extLst xmlns:a="http://schemas.openxmlformats.org/drawingml/2006/main">
               <a:ext uri="{FF2B5EF4-FFF2-40B4-BE49-F238E27FC236}">
-                <a16:creationId xmlns:a16="http://schemas.microsoft.com/office/drawing/2014/main" id="{435A7BD1-4DDF-4B22-9518-9136BFED9049}"/>
+                <a16:creationId xmlns:a16="http://schemas.microsoft.com/office/drawing/2014/main" id="{F8A94DE7-2A04-4300-89EB-324A719B29D6}"/>
               </a:ext>
             </a:extLst>
           </p:cNvPr>
@@ -2270,7 +2270,7 @@
           <p:cNvPr id="3" name="Title">
             <a:extLst xmlns:a="http://schemas.openxmlformats.org/drawingml/2006/main">
               <a:ext uri="{FF2B5EF4-FFF2-40B4-BE49-F238E27FC236}">
-                <a16:creationId xmlns:a16="http://schemas.microsoft.com/office/drawing/2014/main" id="{FB817CE6-DC83-41C0-A96C-6BDB889CABC2}"/>
+                <a16:creationId xmlns:a16="http://schemas.microsoft.com/office/drawing/2014/main" id="{74FA5202-4268-4B10-8CE5-B38E8B9F807B}"/>
               </a:ext>
             </a:extLst>
           </p:cNvPr>
@@ -2499,7 +2499,7 @@
           <p:cNvPr id="2" name="Body">
             <a:extLst xmlns:a="http://schemas.openxmlformats.org/drawingml/2006/main">
               <a:ext uri="{FF2B5EF4-FFF2-40B4-BE49-F238E27FC236}">
-                <a16:creationId xmlns:a16="http://schemas.microsoft.com/office/drawing/2014/main" id="{C0AFC915-E7C8-48EB-A3B8-C586B170268F}"/>
+                <a16:creationId xmlns:a16="http://schemas.microsoft.com/office/drawing/2014/main" id="{FC1C111D-E068-46F9-BB29-AF0AC1970932}"/>
               </a:ext>
             </a:extLst>
           </p:cNvPr>
@@ -2745,7 +2745,7 @@
           <p:cNvPr id="4" name="Title">
             <a:extLst xmlns:a="http://schemas.openxmlformats.org/drawingml/2006/main">
               <a:ext uri="{FF2B5EF4-FFF2-40B4-BE49-F238E27FC236}">
-                <a16:creationId xmlns:a16="http://schemas.microsoft.com/office/drawing/2014/main" id="{6115151F-AA64-4B32-BF5F-EF0306EB9690}"/>
+                <a16:creationId xmlns:a16="http://schemas.microsoft.com/office/drawing/2014/main" id="{D738F043-5EE7-46BE-B8D0-91F7C25A4A5A}"/>
               </a:ext>
             </a:extLst>
           </p:cNvPr>
@@ -2974,7 +2974,7 @@
           <p:cNvPr id="2" name="Left column">
             <a:extLst xmlns:a="http://schemas.openxmlformats.org/drawingml/2006/main">
               <a:ext uri="{FF2B5EF4-FFF2-40B4-BE49-F238E27FC236}">
-                <a16:creationId xmlns:a16="http://schemas.microsoft.com/office/drawing/2014/main" id="{2C1D0A56-CD3B-482F-8823-7C45FB523C3F}"/>
+                <a16:creationId xmlns:a16="http://schemas.microsoft.com/office/drawing/2014/main" id="{F5E02D36-C115-459D-9D86-9FB9DEB57205}"/>
               </a:ext>
             </a:extLst>
           </p:cNvPr>
@@ -3203,7 +3203,7 @@
           <p:cNvPr id="3" name="Right column">
             <a:extLst xmlns:a="http://schemas.openxmlformats.org/drawingml/2006/main">
               <a:ext uri="{FF2B5EF4-FFF2-40B4-BE49-F238E27FC236}">
-                <a16:creationId xmlns:a16="http://schemas.microsoft.com/office/drawing/2014/main" id="{86D873EA-AD99-49D3-A595-EC83CB3976CB}"/>
+                <a16:creationId xmlns:a16="http://schemas.microsoft.com/office/drawing/2014/main" id="{0A6B7628-DD52-49B4-901F-3BE924E99AA3}"/>
               </a:ext>
             </a:extLst>
           </p:cNvPr>
@@ -3449,7 +3449,7 @@
           <p:cNvPr id="3" name="Title">
             <a:extLst xmlns:a="http://schemas.openxmlformats.org/drawingml/2006/main">
               <a:ext uri="{FF2B5EF4-FFF2-40B4-BE49-F238E27FC236}">
-                <a16:creationId xmlns:a16="http://schemas.microsoft.com/office/drawing/2014/main" id="{FC2FE6C2-5C93-408F-A84B-91528F7D72A2}"/>
+                <a16:creationId xmlns:a16="http://schemas.microsoft.com/office/drawing/2014/main" id="{7ECC5F99-E82E-4164-88A7-6545600D1CAF}"/>
               </a:ext>
             </a:extLst>
           </p:cNvPr>
@@ -3678,7 +3678,7 @@
           <p:cNvPr id="2" name="Left column">
             <a:extLst xmlns:a="http://schemas.openxmlformats.org/drawingml/2006/main">
               <a:ext uri="{FF2B5EF4-FFF2-40B4-BE49-F238E27FC236}">
-                <a16:creationId xmlns:a16="http://schemas.microsoft.com/office/drawing/2014/main" id="{1ABDC9AE-BC1C-495F-A3D7-98C98F73514E}"/>
+                <a16:creationId xmlns:a16="http://schemas.microsoft.com/office/drawing/2014/main" id="{1F954650-D264-4D84-8C4B-701FB3BDA912}"/>
               </a:ext>
             </a:extLst>
           </p:cNvPr>
@@ -3945,12 +3945,12 @@
   </p:cSld>
   <p:clrMap bg1="lt1" tx1="dk1" bg2="lt2" tx2="dk2" accent1="accent1" accent2="accent2" accent3="accent3" accent4="accent4" accent5="accent5" accent6="accent6" hlink="hlink" folHlink="folHlink"/>
   <p:sldLayoutIdLst>
-    <p:sldLayoutId xmlns:r="http://schemas.openxmlformats.org/officeDocument/2006/relationships" id="2147483649" r:id="Rf5853933bc2649fa"/>
-    <p:sldLayoutId xmlns:r="http://schemas.openxmlformats.org/officeDocument/2006/relationships" id="2147483650" r:id="R0d368ef1b8cf4ba0"/>
-    <p:sldLayoutId xmlns:r="http://schemas.openxmlformats.org/officeDocument/2006/relationships" id="2147483651" r:id="R5d6da2ee8a40451a"/>
-    <p:sldLayoutId xmlns:r="http://schemas.openxmlformats.org/officeDocument/2006/relationships" id="2147483652" r:id="R3d1a8b92c97244e6"/>
-    <p:sldLayoutId xmlns:r="http://schemas.openxmlformats.org/officeDocument/2006/relationships" id="2147483653" r:id="R459fafd97d084ec3"/>
-    <p:sldLayoutId xmlns:r="http://schemas.openxmlformats.org/officeDocument/2006/relationships" id="2147483654" r:id="Rdd42467abec64f3d"/>
+    <p:sldLayoutId xmlns:r="http://schemas.openxmlformats.org/officeDocument/2006/relationships" id="2147483649" r:id="R8189423e2ee54dd6"/>
+    <p:sldLayoutId xmlns:r="http://schemas.openxmlformats.org/officeDocument/2006/relationships" id="2147483650" r:id="Re4ed48b33a6c46b2"/>
+    <p:sldLayoutId xmlns:r="http://schemas.openxmlformats.org/officeDocument/2006/relationships" id="2147483651" r:id="R8bf72088f3de4a8e"/>
+    <p:sldLayoutId xmlns:r="http://schemas.openxmlformats.org/officeDocument/2006/relationships" id="2147483652" r:id="Rf0edc883bb1340bb"/>
+    <p:sldLayoutId xmlns:r="http://schemas.openxmlformats.org/officeDocument/2006/relationships" id="2147483653" r:id="R00f6e6cde2fc4b25"/>
+    <p:sldLayoutId xmlns:r="http://schemas.openxmlformats.org/officeDocument/2006/relationships" id="2147483654" r:id="R7e74056c15194c5c"/>
   </p:sldLayoutIdLst>
   <p:txStyles>
     <p:titleStyle>
@@ -5273,7 +5273,7 @@
           <p:cNvPr id="8" name="">
             <a:extLst xmlns:a="http://schemas.openxmlformats.org/drawingml/2006/main">
               <a:ext uri="{FF2B5EF4-FFF2-40B4-BE49-F238E27FC236}">
-                <a16:creationId xmlns:a16="http://schemas.microsoft.com/office/drawing/2014/main" id="{7FDC0041-AF61-4062-A814-78B43041C73C}"/>
+                <a16:creationId xmlns:a16="http://schemas.microsoft.com/office/drawing/2014/main" id="{5A5A131D-658C-413F-AD3B-D731A3C853CA}"/>
               </a:ext>
             </a:extLst>
           </p:cNvPr>
@@ -5430,7 +5430,7 @@
           <p:cNvPr id="2" name="">
             <a:extLst xmlns:a="http://schemas.openxmlformats.org/drawingml/2006/main">
               <a:ext uri="{FF2B5EF4-FFF2-40B4-BE49-F238E27FC236}">
-                <a16:creationId xmlns:a16="http://schemas.microsoft.com/office/drawing/2014/main" id="{67C7500F-0820-4E8F-B324-E39572F3D189}"/>
+                <a16:creationId xmlns:a16="http://schemas.microsoft.com/office/drawing/2014/main" id="{81140563-2BCE-418F-865A-78952EDEB923}"/>
               </a:ext>
             </a:extLst>
           </p:cNvPr>
@@ -5461,7 +5461,7 @@
           <p:cNvPr id="3" name="">
             <a:extLst xmlns:a="http://schemas.openxmlformats.org/drawingml/2006/main">
               <a:ext uri="{FF2B5EF4-FFF2-40B4-BE49-F238E27FC236}">
-                <a16:creationId xmlns:a16="http://schemas.microsoft.com/office/drawing/2014/main" id="{03FE7972-DBA2-4B8A-88E0-964C8AA4EA27}"/>
+                <a16:creationId xmlns:a16="http://schemas.microsoft.com/office/drawing/2014/main" id="{53A5F272-DF9F-4869-89B5-21A972E2A4F9}"/>
               </a:ext>
             </a:extLst>
           </p:cNvPr>
@@ -5618,7 +5618,7 @@
           <p:cNvPr id="4" name="">
             <a:extLst xmlns:a="http://schemas.openxmlformats.org/drawingml/2006/main">
               <a:ext uri="{FF2B5EF4-FFF2-40B4-BE49-F238E27FC236}">
-                <a16:creationId xmlns:a16="http://schemas.microsoft.com/office/drawing/2014/main" id="{3BBCD238-59F3-4C90-B0B8-56B5CCC5A5B8}"/>
+                <a16:creationId xmlns:a16="http://schemas.microsoft.com/office/drawing/2014/main" id="{2583D8F1-BB88-4AF2-8A52-123271C8A2D9}"/>
               </a:ext>
             </a:extLst>
           </p:cNvPr>
@@ -5775,7 +5775,7 @@
           <p:cNvPr id="5" name="">
             <a:extLst xmlns:a="http://schemas.openxmlformats.org/drawingml/2006/main">
               <a:ext uri="{FF2B5EF4-FFF2-40B4-BE49-F238E27FC236}">
-                <a16:creationId xmlns:a16="http://schemas.microsoft.com/office/drawing/2014/main" id="{84BCB66F-A669-474C-A9A4-282E9FA36E91}"/>
+                <a16:creationId xmlns:a16="http://schemas.microsoft.com/office/drawing/2014/main" id="{D6DD027D-7563-4230-B8D6-87E16D358BC0}"/>
               </a:ext>
             </a:extLst>
           </p:cNvPr>
@@ -5955,7 +5955,7 @@
           <p:cNvPr id="6" name="">
             <a:extLst xmlns:a="http://schemas.openxmlformats.org/drawingml/2006/main">
               <a:ext uri="{FF2B5EF4-FFF2-40B4-BE49-F238E27FC236}">
-                <a16:creationId xmlns:a16="http://schemas.microsoft.com/office/drawing/2014/main" id="{A7532DE6-3127-4345-A20E-0EFEDC0E3465}"/>
+                <a16:creationId xmlns:a16="http://schemas.microsoft.com/office/drawing/2014/main" id="{29AD9D2D-BF75-4CF0-ADCD-DA6EEB0F6605}"/>
               </a:ext>
             </a:extLst>
           </p:cNvPr>
@@ -6112,7 +6112,7 @@
           <p:cNvPr id="7" name="">
             <a:extLst xmlns:a="http://schemas.openxmlformats.org/drawingml/2006/main">
               <a:ext uri="{FF2B5EF4-FFF2-40B4-BE49-F238E27FC236}">
-                <a16:creationId xmlns:a16="http://schemas.microsoft.com/office/drawing/2014/main" id="{47B7FC0E-DE47-4DB4-8ADD-069551C00AC1}"/>
+                <a16:creationId xmlns:a16="http://schemas.microsoft.com/office/drawing/2014/main" id="{02AC9E8C-6251-43E7-AB04-5C56B1EA56BD}"/>
               </a:ext>
             </a:extLst>
           </p:cNvPr>
@@ -6267,7 +6267,7 @@
     </p:spTree>
     <p:extLst>
       <p:ext uri="{BB962C8B-B14F-4D97-AF65-F5344CB8AC3E}">
-        <p14:creationId xmlns:p14="http://schemas.microsoft.com/office/powerpoint/2010/main" val="259353831"/>
+        <p14:creationId xmlns:p14="http://schemas.microsoft.com/office/powerpoint/2010/main" val="1409095491"/>
       </p:ext>
     </p:extLst>
   </p:cSld>
@@ -6298,7 +6298,7 @@
           <p:cNvPr id="9" name="">
             <a:extLst xmlns:a="http://schemas.openxmlformats.org/drawingml/2006/main">
               <a:ext uri="{FF2B5EF4-FFF2-40B4-BE49-F238E27FC236}">
-                <a16:creationId xmlns:a16="http://schemas.microsoft.com/office/drawing/2014/main" id="{7A7B25A1-1D6A-4B26-A880-BBD1ABB8370C}"/>
+                <a16:creationId xmlns:a16="http://schemas.microsoft.com/office/drawing/2014/main" id="{E6ABAFA8-CB05-4874-B9D9-CE2AC43EFF67}"/>
               </a:ext>
             </a:extLst>
           </p:cNvPr>
@@ -6455,7 +6455,7 @@
           <p:cNvPr id="2" name="">
             <a:extLst xmlns:a="http://schemas.openxmlformats.org/drawingml/2006/main">
               <a:ext uri="{FF2B5EF4-FFF2-40B4-BE49-F238E27FC236}">
-                <a16:creationId xmlns:a16="http://schemas.microsoft.com/office/drawing/2014/main" id="{F6FD2889-580A-4FE9-917F-940843B0FE41}"/>
+                <a16:creationId xmlns:a16="http://schemas.microsoft.com/office/drawing/2014/main" id="{0A01B493-87FE-40D4-990D-BB53FEC325E8}"/>
               </a:ext>
             </a:extLst>
           </p:cNvPr>
@@ -6486,7 +6486,7 @@
           <p:cNvPr id="3" name="">
             <a:extLst xmlns:a="http://schemas.openxmlformats.org/drawingml/2006/main">
               <a:ext uri="{FF2B5EF4-FFF2-40B4-BE49-F238E27FC236}">
-                <a16:creationId xmlns:a16="http://schemas.microsoft.com/office/drawing/2014/main" id="{93390E27-473C-40DA-87C4-49AD09C7FBBF}"/>
+                <a16:creationId xmlns:a16="http://schemas.microsoft.com/office/drawing/2014/main" id="{1A6F68F1-4ACB-4D8F-B393-CB3B59690A35}"/>
               </a:ext>
             </a:extLst>
           </p:cNvPr>
@@ -6643,7 +6643,7 @@
           <p:cNvPr id="4" name="Chart">
             <a:extLst xmlns:a="http://schemas.openxmlformats.org/drawingml/2006/main">
               <a:ext uri="{FF2B5EF4-FFF2-40B4-BE49-F238E27FC236}">
-                <a16:creationId xmlns:a16="http://schemas.microsoft.com/office/drawing/2014/main" id="{452768A5-5CE6-4EA3-ABCC-7102C24743ED}"/>
+                <a16:creationId xmlns:a16="http://schemas.microsoft.com/office/drawing/2014/main" id="{39F1AA93-F963-4CEC-BD1B-444B985B6B16}"/>
               </a:ext>
             </a:extLst>
           </p:cNvPr>
@@ -6656,7 +6656,7 @@
         </p:xfrm>
         <a:graphic xmlns:a="http://schemas.openxmlformats.org/drawingml/2006/main">
           <a:graphicData uri="http://schemas.openxmlformats.org/drawingml/2006/chart">
-            <c:chart xmlns:r="http://schemas.openxmlformats.org/officeDocument/2006/relationships" xmlns:c="http://schemas.openxmlformats.org/drawingml/2006/chart" r:id="R0d8f5e27d98344a9"/>
+            <c:chart xmlns:r="http://schemas.openxmlformats.org/officeDocument/2006/relationships" xmlns:c="http://schemas.openxmlformats.org/drawingml/2006/chart" r:id="R635008741df5403a"/>
           </a:graphicData>
         </a:graphic>
       </p:graphicFrame>
@@ -6665,7 +6665,7 @@
           <p:cNvPr id="5" name="">
             <a:extLst xmlns:a="http://schemas.openxmlformats.org/drawingml/2006/main">
               <a:ext uri="{FF2B5EF4-FFF2-40B4-BE49-F238E27FC236}">
-                <a16:creationId xmlns:a16="http://schemas.microsoft.com/office/drawing/2014/main" id="{7CA1AC87-7199-4D47-8645-3DA2F60055A2}"/>
+                <a16:creationId xmlns:a16="http://schemas.microsoft.com/office/drawing/2014/main" id="{A792F69E-5E42-4A65-A9BB-E04DA6D1898C}"/>
               </a:ext>
             </a:extLst>
           </p:cNvPr>
@@ -6822,7 +6822,7 @@
           <p:cNvPr id="6" name="">
             <a:extLst xmlns:a="http://schemas.openxmlformats.org/drawingml/2006/main">
               <a:ext uri="{FF2B5EF4-FFF2-40B4-BE49-F238E27FC236}">
-                <a16:creationId xmlns:a16="http://schemas.microsoft.com/office/drawing/2014/main" id="{7A8212DE-4A89-43F2-870D-6269A01E1850}"/>
+                <a16:creationId xmlns:a16="http://schemas.microsoft.com/office/drawing/2014/main" id="{40901852-CDEC-4BFE-B502-F6C392B1B321}"/>
               </a:ext>
             </a:extLst>
           </p:cNvPr>
@@ -7053,7 +7053,7 @@
           <p:cNvPr id="7" name="">
             <a:extLst xmlns:a="http://schemas.openxmlformats.org/drawingml/2006/main">
               <a:ext uri="{FF2B5EF4-FFF2-40B4-BE49-F238E27FC236}">
-                <a16:creationId xmlns:a16="http://schemas.microsoft.com/office/drawing/2014/main" id="{4F6D068B-4D76-4551-9C3B-B0ABE435B6A2}"/>
+                <a16:creationId xmlns:a16="http://schemas.microsoft.com/office/drawing/2014/main" id="{19041167-9200-4D21-BBB8-AD60055EFDC9}"/>
               </a:ext>
             </a:extLst>
           </p:cNvPr>
@@ -7233,7 +7233,7 @@
           <p:cNvPr id="8" name="">
             <a:extLst xmlns:a="http://schemas.openxmlformats.org/drawingml/2006/main">
               <a:ext uri="{FF2B5EF4-FFF2-40B4-BE49-F238E27FC236}">
-                <a16:creationId xmlns:a16="http://schemas.microsoft.com/office/drawing/2014/main" id="{85E5DDA7-5173-4D29-A576-5C2F5A2CF025}"/>
+                <a16:creationId xmlns:a16="http://schemas.microsoft.com/office/drawing/2014/main" id="{EA295DBD-747D-4FBA-91DC-2EAD36F04621}"/>
               </a:ext>
             </a:extLst>
           </p:cNvPr>
@@ -7388,7 +7388,7 @@
     </p:spTree>
     <p:extLst>
       <p:ext uri="{BB962C8B-B14F-4D97-AF65-F5344CB8AC3E}">
-        <p14:creationId xmlns:p14="http://schemas.microsoft.com/office/powerpoint/2010/main" val="1539456164"/>
+        <p14:creationId xmlns:p14="http://schemas.microsoft.com/office/powerpoint/2010/main" val="830729655"/>
       </p:ext>
     </p:extLst>
   </p:cSld>
@@ -7419,7 +7419,7 @@
           <p:cNvPr id="9" name="">
             <a:extLst xmlns:a="http://schemas.openxmlformats.org/drawingml/2006/main">
               <a:ext uri="{FF2B5EF4-FFF2-40B4-BE49-F238E27FC236}">
-                <a16:creationId xmlns:a16="http://schemas.microsoft.com/office/drawing/2014/main" id="{28B2FB8C-8D4E-400A-B3FB-EFCFF1C2ABDF}"/>
+                <a16:creationId xmlns:a16="http://schemas.microsoft.com/office/drawing/2014/main" id="{A0E20086-5EE9-4B11-BE15-DF110A951D71}"/>
               </a:ext>
             </a:extLst>
           </p:cNvPr>
@@ -7576,7 +7576,7 @@
           <p:cNvPr id="2" name="">
             <a:extLst xmlns:a="http://schemas.openxmlformats.org/drawingml/2006/main">
               <a:ext uri="{FF2B5EF4-FFF2-40B4-BE49-F238E27FC236}">
-                <a16:creationId xmlns:a16="http://schemas.microsoft.com/office/drawing/2014/main" id="{7A00AFCA-90BE-453F-88B6-F22136E5B702}"/>
+                <a16:creationId xmlns:a16="http://schemas.microsoft.com/office/drawing/2014/main" id="{C71E2750-BB3F-429E-9197-060A7FD8EBFC}"/>
               </a:ext>
             </a:extLst>
           </p:cNvPr>
@@ -7607,7 +7607,7 @@
           <p:cNvPr id="3" name="">
             <a:extLst xmlns:a="http://schemas.openxmlformats.org/drawingml/2006/main">
               <a:ext uri="{FF2B5EF4-FFF2-40B4-BE49-F238E27FC236}">
-                <a16:creationId xmlns:a16="http://schemas.microsoft.com/office/drawing/2014/main" id="{7836A346-5043-4F52-98A5-B26BD006FFF0}"/>
+                <a16:creationId xmlns:a16="http://schemas.microsoft.com/office/drawing/2014/main" id="{84F9CE70-1094-47E9-96CA-3980B9439530}"/>
               </a:ext>
             </a:extLst>
           </p:cNvPr>
@@ -7764,7 +7764,7 @@
           <p:cNvPr id="4" name="">
             <a:extLst xmlns:a="http://schemas.openxmlformats.org/drawingml/2006/main">
               <a:ext uri="{FF2B5EF4-FFF2-40B4-BE49-F238E27FC236}">
-                <a16:creationId xmlns:a16="http://schemas.microsoft.com/office/drawing/2014/main" id="{62418BA4-BDFE-4E09-8E28-52570E534A9D}"/>
+                <a16:creationId xmlns:a16="http://schemas.microsoft.com/office/drawing/2014/main" id="{E2396486-CE2D-4385-A62A-6364E819BC20}"/>
               </a:ext>
             </a:extLst>
           </p:cNvPr>
@@ -7921,7 +7921,7 @@
           <p:cNvPr id="5" name="">
             <a:extLst xmlns:a="http://schemas.openxmlformats.org/drawingml/2006/main">
               <a:ext uri="{FF2B5EF4-FFF2-40B4-BE49-F238E27FC236}">
-                <a16:creationId xmlns:a16="http://schemas.microsoft.com/office/drawing/2014/main" id="{30CA01C1-6A22-41EB-94CB-D7A3CB0D26D8}"/>
+                <a16:creationId xmlns:a16="http://schemas.microsoft.com/office/drawing/2014/main" id="{C407C0AA-B89E-4242-9379-C01CFF972007}"/>
               </a:ext>
             </a:extLst>
           </p:cNvPr>
@@ -8147,7 +8147,7 @@
           <p:cNvPr id="6" name="">
             <a:extLst xmlns:a="http://schemas.openxmlformats.org/drawingml/2006/main">
               <a:ext uri="{FF2B5EF4-FFF2-40B4-BE49-F238E27FC236}">
-                <a16:creationId xmlns:a16="http://schemas.microsoft.com/office/drawing/2014/main" id="{FF668C37-42C0-4E2E-BFA0-B0B81CFC12CA}"/>
+                <a16:creationId xmlns:a16="http://schemas.microsoft.com/office/drawing/2014/main" id="{390A7691-4CE9-43EE-9C70-F2ACB9CD94D8}"/>
               </a:ext>
             </a:extLst>
           </p:cNvPr>
@@ -8304,7 +8304,7 @@
           <p:cNvPr id="7" name="">
             <a:extLst xmlns:a="http://schemas.openxmlformats.org/drawingml/2006/main">
               <a:ext uri="{FF2B5EF4-FFF2-40B4-BE49-F238E27FC236}">
-                <a16:creationId xmlns:a16="http://schemas.microsoft.com/office/drawing/2014/main" id="{59CB0E14-BAFF-4D74-8024-797C6B3B94EA}"/>
+                <a16:creationId xmlns:a16="http://schemas.microsoft.com/office/drawing/2014/main" id="{D5BD1BE4-213D-4295-93C3-BA43F5ECB0CA}"/>
               </a:ext>
             </a:extLst>
           </p:cNvPr>
@@ -8530,7 +8530,7 @@
           <p:cNvPr id="8" name="">
             <a:extLst xmlns:a="http://schemas.openxmlformats.org/drawingml/2006/main">
               <a:ext uri="{FF2B5EF4-FFF2-40B4-BE49-F238E27FC236}">
-                <a16:creationId xmlns:a16="http://schemas.microsoft.com/office/drawing/2014/main" id="{0057D2BA-7741-423B-916F-8B0A98872CC7}"/>
+                <a16:creationId xmlns:a16="http://schemas.microsoft.com/office/drawing/2014/main" id="{031565E8-2890-4E8C-A16C-203AA563147F}"/>
               </a:ext>
             </a:extLst>
           </p:cNvPr>
@@ -8685,7 +8685,7 @@
     </p:spTree>
     <p:extLst>
       <p:ext uri="{BB962C8B-B14F-4D97-AF65-F5344CB8AC3E}">
-        <p14:creationId xmlns:p14="http://schemas.microsoft.com/office/powerpoint/2010/main" val="1855195373"/>
+        <p14:creationId xmlns:p14="http://schemas.microsoft.com/office/powerpoint/2010/main" val="1015538832"/>
       </p:ext>
     </p:extLst>
   </p:cSld>
@@ -8716,7 +8716,7 @@
           <p:cNvPr id="20" name="">
             <a:extLst xmlns:a="http://schemas.openxmlformats.org/drawingml/2006/main">
               <a:ext uri="{FF2B5EF4-FFF2-40B4-BE49-F238E27FC236}">
-                <a16:creationId xmlns:a16="http://schemas.microsoft.com/office/drawing/2014/main" id="{5B0D65BC-17C5-444C-BAA4-F4C7D1266674}"/>
+                <a16:creationId xmlns:a16="http://schemas.microsoft.com/office/drawing/2014/main" id="{1A3C4500-35CD-4EED-A88F-8540BCB1C78A}"/>
               </a:ext>
             </a:extLst>
           </p:cNvPr>
@@ -8873,7 +8873,7 @@
           <p:cNvPr id="2" name="">
             <a:extLst xmlns:a="http://schemas.openxmlformats.org/drawingml/2006/main">
               <a:ext uri="{FF2B5EF4-FFF2-40B4-BE49-F238E27FC236}">
-                <a16:creationId xmlns:a16="http://schemas.microsoft.com/office/drawing/2014/main" id="{87DE2890-0F8C-49FA-BA63-47966E00E52B}"/>
+                <a16:creationId xmlns:a16="http://schemas.microsoft.com/office/drawing/2014/main" id="{6840AF90-EB3E-45D7-AAF4-978B4207161E}"/>
               </a:ext>
             </a:extLst>
           </p:cNvPr>
@@ -8904,7 +8904,7 @@
           <p:cNvPr id="3" name="">
             <a:extLst xmlns:a="http://schemas.openxmlformats.org/drawingml/2006/main">
               <a:ext uri="{FF2B5EF4-FFF2-40B4-BE49-F238E27FC236}">
-                <a16:creationId xmlns:a16="http://schemas.microsoft.com/office/drawing/2014/main" id="{28612F1C-5E52-4B48-B634-C7EBB03A0279}"/>
+                <a16:creationId xmlns:a16="http://schemas.microsoft.com/office/drawing/2014/main" id="{A2E94FF1-F98F-4AA8-9A86-B2BB029B8BB0}"/>
               </a:ext>
             </a:extLst>
           </p:cNvPr>
@@ -9061,7 +9061,7 @@
           <p:cNvPr id="4" name="">
             <a:extLst xmlns:a="http://schemas.openxmlformats.org/drawingml/2006/main">
               <a:ext uri="{FF2B5EF4-FFF2-40B4-BE49-F238E27FC236}">
-                <a16:creationId xmlns:a16="http://schemas.microsoft.com/office/drawing/2014/main" id="{53382C57-4F62-4CB0-B218-EF8B6AD4AAA1}"/>
+                <a16:creationId xmlns:a16="http://schemas.microsoft.com/office/drawing/2014/main" id="{72EAF1FD-9691-4408-A6EC-3514429F362C}"/>
               </a:ext>
             </a:extLst>
           </p:cNvPr>
@@ -9218,7 +9218,7 @@
           <p:cNvPr id="5" name="">
             <a:extLst xmlns:a="http://schemas.openxmlformats.org/drawingml/2006/main">
               <a:ext uri="{FF2B5EF4-FFF2-40B4-BE49-F238E27FC236}">
-                <a16:creationId xmlns:a16="http://schemas.microsoft.com/office/drawing/2014/main" id="{BA8FC150-E22B-4263-BF56-846B9394675E}"/>
+                <a16:creationId xmlns:a16="http://schemas.microsoft.com/office/drawing/2014/main" id="{A3627388-CF36-4BE6-8F2B-D143DE3253D7}"/>
               </a:ext>
             </a:extLst>
           </p:cNvPr>
@@ -9375,7 +9375,7 @@
           <p:cNvPr id="6" name="">
             <a:extLst xmlns:a="http://schemas.openxmlformats.org/drawingml/2006/main">
               <a:ext uri="{FF2B5EF4-FFF2-40B4-BE49-F238E27FC236}">
-                <a16:creationId xmlns:a16="http://schemas.microsoft.com/office/drawing/2014/main" id="{1A813AB1-E7A3-4AF5-89B7-8361658243D1}"/>
+                <a16:creationId xmlns:a16="http://schemas.microsoft.com/office/drawing/2014/main" id="{76081F2A-B444-4AF2-A2CB-647ADBF628E7}"/>
               </a:ext>
             </a:extLst>
           </p:cNvPr>
@@ -9532,7 +9532,7 @@
           <p:cNvPr id="7" name="">
             <a:extLst xmlns:a="http://schemas.openxmlformats.org/drawingml/2006/main">
               <a:ext uri="{FF2B5EF4-FFF2-40B4-BE49-F238E27FC236}">
-                <a16:creationId xmlns:a16="http://schemas.microsoft.com/office/drawing/2014/main" id="{E4D7BC91-8165-4D0B-B864-EB885B3CEBDF}"/>
+                <a16:creationId xmlns:a16="http://schemas.microsoft.com/office/drawing/2014/main" id="{7FF97A00-655A-4A73-8B50-8DE4591E85B1}"/>
               </a:ext>
             </a:extLst>
           </p:cNvPr>
@@ -9563,7 +9563,7 @@
           <p:cNvPr id="8" name="">
             <a:extLst xmlns:a="http://schemas.openxmlformats.org/drawingml/2006/main">
               <a:ext uri="{FF2B5EF4-FFF2-40B4-BE49-F238E27FC236}">
-                <a16:creationId xmlns:a16="http://schemas.microsoft.com/office/drawing/2014/main" id="{6202A92A-78B7-476D-A302-3906581C75FC}"/>
+                <a16:creationId xmlns:a16="http://schemas.microsoft.com/office/drawing/2014/main" id="{3A1B53A2-57E3-4177-96FB-D8057F4B053F}"/>
               </a:ext>
             </a:extLst>
           </p:cNvPr>
@@ -9720,7 +9720,7 @@
           <p:cNvPr id="9" name="">
             <a:extLst xmlns:a="http://schemas.openxmlformats.org/drawingml/2006/main">
               <a:ext uri="{FF2B5EF4-FFF2-40B4-BE49-F238E27FC236}">
-                <a16:creationId xmlns:a16="http://schemas.microsoft.com/office/drawing/2014/main" id="{B8036EF4-656D-4FFC-805C-5C86B2A42749}"/>
+                <a16:creationId xmlns:a16="http://schemas.microsoft.com/office/drawing/2014/main" id="{93A2F03F-F2DC-4D59-8C0A-7B61DBAE23B5}"/>
               </a:ext>
             </a:extLst>
           </p:cNvPr>
@@ -9877,7 +9877,7 @@
           <p:cNvPr id="10" name="">
             <a:extLst xmlns:a="http://schemas.openxmlformats.org/drawingml/2006/main">
               <a:ext uri="{FF2B5EF4-FFF2-40B4-BE49-F238E27FC236}">
-                <a16:creationId xmlns:a16="http://schemas.microsoft.com/office/drawing/2014/main" id="{BF379C6F-5119-4A35-BF03-F413CAA2A155}"/>
+                <a16:creationId xmlns:a16="http://schemas.microsoft.com/office/drawing/2014/main" id="{AF2B3D92-0220-4244-AEFB-456855573330}"/>
               </a:ext>
             </a:extLst>
           </p:cNvPr>
@@ -10034,7 +10034,7 @@
           <p:cNvPr id="11" name="">
             <a:extLst xmlns:a="http://schemas.openxmlformats.org/drawingml/2006/main">
               <a:ext uri="{FF2B5EF4-FFF2-40B4-BE49-F238E27FC236}">
-                <a16:creationId xmlns:a16="http://schemas.microsoft.com/office/drawing/2014/main" id="{48DA7E31-6640-43C5-A801-2A6A49C6CE0A}"/>
+                <a16:creationId xmlns:a16="http://schemas.microsoft.com/office/drawing/2014/main" id="{1FD648DC-F968-4BF5-AFDB-58F4C0FF3BE9}"/>
               </a:ext>
             </a:extLst>
           </p:cNvPr>
@@ -10065,7 +10065,7 @@
           <p:cNvPr id="12" name="">
             <a:extLst xmlns:a="http://schemas.openxmlformats.org/drawingml/2006/main">
               <a:ext uri="{FF2B5EF4-FFF2-40B4-BE49-F238E27FC236}">
-                <a16:creationId xmlns:a16="http://schemas.microsoft.com/office/drawing/2014/main" id="{D3D64880-D6E5-4EA6-BBC6-5BE83485E9B6}"/>
+                <a16:creationId xmlns:a16="http://schemas.microsoft.com/office/drawing/2014/main" id="{32AD3120-BF89-48BE-97FC-F2601E56E548}"/>
               </a:ext>
             </a:extLst>
           </p:cNvPr>
@@ -10222,7 +10222,7 @@
           <p:cNvPr id="13" name="">
             <a:extLst xmlns:a="http://schemas.openxmlformats.org/drawingml/2006/main">
               <a:ext uri="{FF2B5EF4-FFF2-40B4-BE49-F238E27FC236}">
-                <a16:creationId xmlns:a16="http://schemas.microsoft.com/office/drawing/2014/main" id="{BC03E20C-0525-47E6-A47D-53C035808892}"/>
+                <a16:creationId xmlns:a16="http://schemas.microsoft.com/office/drawing/2014/main" id="{CA24CA56-9F7C-4098-8773-AFE2CD5796F8}"/>
               </a:ext>
             </a:extLst>
           </p:cNvPr>
@@ -10379,7 +10379,7 @@
           <p:cNvPr id="14" name="">
             <a:extLst xmlns:a="http://schemas.openxmlformats.org/drawingml/2006/main">
               <a:ext uri="{FF2B5EF4-FFF2-40B4-BE49-F238E27FC236}">
-                <a16:creationId xmlns:a16="http://schemas.microsoft.com/office/drawing/2014/main" id="{689793E6-B062-439B-9B02-83EE481219FB}"/>
+                <a16:creationId xmlns:a16="http://schemas.microsoft.com/office/drawing/2014/main" id="{061482D1-3017-4D6D-A855-3ECBFE944B4C}"/>
               </a:ext>
             </a:extLst>
           </p:cNvPr>
@@ -10536,7 +10536,7 @@
           <p:cNvPr id="15" name="">
             <a:extLst xmlns:a="http://schemas.openxmlformats.org/drawingml/2006/main">
               <a:ext uri="{FF2B5EF4-FFF2-40B4-BE49-F238E27FC236}">
-                <a16:creationId xmlns:a16="http://schemas.microsoft.com/office/drawing/2014/main" id="{80293A98-3743-43CD-B6B5-44935157C3DC}"/>
+                <a16:creationId xmlns:a16="http://schemas.microsoft.com/office/drawing/2014/main" id="{D13DFF04-DDAE-4207-AE77-24978500AE11}"/>
               </a:ext>
             </a:extLst>
           </p:cNvPr>
@@ -10567,7 +10567,7 @@
           <p:cNvPr id="16" name="">
             <a:extLst xmlns:a="http://schemas.openxmlformats.org/drawingml/2006/main">
               <a:ext uri="{FF2B5EF4-FFF2-40B4-BE49-F238E27FC236}">
-                <a16:creationId xmlns:a16="http://schemas.microsoft.com/office/drawing/2014/main" id="{FA343E6E-9E48-47F5-85DC-545996A1CA67}"/>
+                <a16:creationId xmlns:a16="http://schemas.microsoft.com/office/drawing/2014/main" id="{6E7FB08C-9998-46BF-8C80-27EF6D2F2C17}"/>
               </a:ext>
             </a:extLst>
           </p:cNvPr>
@@ -10724,7 +10724,7 @@
           <p:cNvPr id="17" name="">
             <a:extLst xmlns:a="http://schemas.openxmlformats.org/drawingml/2006/main">
               <a:ext uri="{FF2B5EF4-FFF2-40B4-BE49-F238E27FC236}">
-                <a16:creationId xmlns:a16="http://schemas.microsoft.com/office/drawing/2014/main" id="{419CE40A-B661-49CB-B3C5-B5E94B22556D}"/>
+                <a16:creationId xmlns:a16="http://schemas.microsoft.com/office/drawing/2014/main" id="{A98ECBBD-0671-415B-871A-566A9DA021A6}"/>
               </a:ext>
             </a:extLst>
           </p:cNvPr>
@@ -10881,7 +10881,7 @@
           <p:cNvPr id="18" name="">
             <a:extLst xmlns:a="http://schemas.openxmlformats.org/drawingml/2006/main">
               <a:ext uri="{FF2B5EF4-FFF2-40B4-BE49-F238E27FC236}">
-                <a16:creationId xmlns:a16="http://schemas.microsoft.com/office/drawing/2014/main" id="{9C459C9D-0868-4B20-BC0E-1B1550451C63}"/>
+                <a16:creationId xmlns:a16="http://schemas.microsoft.com/office/drawing/2014/main" id="{F7BCBB15-9647-4AFB-AE83-AF2BF7E1A525}"/>
               </a:ext>
             </a:extLst>
           </p:cNvPr>
@@ -11038,7 +11038,7 @@
           <p:cNvPr id="19" name="">
             <a:extLst xmlns:a="http://schemas.openxmlformats.org/drawingml/2006/main">
               <a:ext uri="{FF2B5EF4-FFF2-40B4-BE49-F238E27FC236}">
-                <a16:creationId xmlns:a16="http://schemas.microsoft.com/office/drawing/2014/main" id="{CDA071F8-743B-4040-A93A-A3FF2418BF57}"/>
+                <a16:creationId xmlns:a16="http://schemas.microsoft.com/office/drawing/2014/main" id="{EA53CD8F-5D21-4071-9A92-DFA1A67F86C5}"/>
               </a:ext>
             </a:extLst>
           </p:cNvPr>
@@ -11193,7 +11193,7 @@
     </p:spTree>
     <p:extLst>
       <p:ext uri="{BB962C8B-B14F-4D97-AF65-F5344CB8AC3E}">
-        <p14:creationId xmlns:p14="http://schemas.microsoft.com/office/powerpoint/2010/main" val="1210164465"/>
+        <p14:creationId xmlns:p14="http://schemas.microsoft.com/office/powerpoint/2010/main" val="1520546986"/>
       </p:ext>
     </p:extLst>
   </p:cSld>
@@ -11224,7 +11224,7 @@
           <p:cNvPr id="19" name="">
             <a:extLst xmlns:a="http://schemas.openxmlformats.org/drawingml/2006/main">
               <a:ext uri="{FF2B5EF4-FFF2-40B4-BE49-F238E27FC236}">
-                <a16:creationId xmlns:a16="http://schemas.microsoft.com/office/drawing/2014/main" id="{DC277C7A-B849-44A2-BE63-7D38F2704374}"/>
+                <a16:creationId xmlns:a16="http://schemas.microsoft.com/office/drawing/2014/main" id="{2955B972-C2B5-409D-866A-BE5E5E67526A}"/>
               </a:ext>
             </a:extLst>
           </p:cNvPr>
@@ -11381,7 +11381,7 @@
           <p:cNvPr id="2" name="">
             <a:extLst xmlns:a="http://schemas.openxmlformats.org/drawingml/2006/main">
               <a:ext uri="{FF2B5EF4-FFF2-40B4-BE49-F238E27FC236}">
-                <a16:creationId xmlns:a16="http://schemas.microsoft.com/office/drawing/2014/main" id="{9CF9B8CF-383F-4879-9AFE-F95897AFFF3B}"/>
+                <a16:creationId xmlns:a16="http://schemas.microsoft.com/office/drawing/2014/main" id="{E808F087-911E-4CBF-B2DB-F7050BFDA0FB}"/>
               </a:ext>
             </a:extLst>
           </p:cNvPr>
@@ -11412,7 +11412,7 @@
           <p:cNvPr id="3" name="">
             <a:extLst xmlns:a="http://schemas.openxmlformats.org/drawingml/2006/main">
               <a:ext uri="{FF2B5EF4-FFF2-40B4-BE49-F238E27FC236}">
-                <a16:creationId xmlns:a16="http://schemas.microsoft.com/office/drawing/2014/main" id="{D67A4163-E809-4290-814E-4304360AB3F9}"/>
+                <a16:creationId xmlns:a16="http://schemas.microsoft.com/office/drawing/2014/main" id="{E5E00619-BABE-4EF1-A702-A91CA02776F9}"/>
               </a:ext>
             </a:extLst>
           </p:cNvPr>
@@ -11569,7 +11569,7 @@
           <p:cNvPr id="4" name="">
             <a:extLst xmlns:a="http://schemas.openxmlformats.org/drawingml/2006/main">
               <a:ext uri="{FF2B5EF4-FFF2-40B4-BE49-F238E27FC236}">
-                <a16:creationId xmlns:a16="http://schemas.microsoft.com/office/drawing/2014/main" id="{2813AB08-FC64-4E2C-8E97-23998233341C}"/>
+                <a16:creationId xmlns:a16="http://schemas.microsoft.com/office/drawing/2014/main" id="{1A68FB13-9546-40A6-BC39-6A42DE35B019}"/>
               </a:ext>
             </a:extLst>
           </p:cNvPr>
@@ -11600,7 +11600,7 @@
           <p:cNvPr id="5" name="">
             <a:extLst xmlns:a="http://schemas.openxmlformats.org/drawingml/2006/main">
               <a:ext uri="{FF2B5EF4-FFF2-40B4-BE49-F238E27FC236}">
-                <a16:creationId xmlns:a16="http://schemas.microsoft.com/office/drawing/2014/main" id="{7CD3B583-50AE-47EC-A38F-50001DB32C5D}"/>
+                <a16:creationId xmlns:a16="http://schemas.microsoft.com/office/drawing/2014/main" id="{C995B73F-4E1D-462D-A709-B29AE88138F3}"/>
               </a:ext>
             </a:extLst>
           </p:cNvPr>
@@ -11757,7 +11757,7 @@
           <p:cNvPr id="6" name="">
             <a:extLst xmlns:a="http://schemas.openxmlformats.org/drawingml/2006/main">
               <a:ext uri="{FF2B5EF4-FFF2-40B4-BE49-F238E27FC236}">
-                <a16:creationId xmlns:a16="http://schemas.microsoft.com/office/drawing/2014/main" id="{7CA86B94-082D-4FB0-8038-8A4C5F327A7E}"/>
+                <a16:creationId xmlns:a16="http://schemas.microsoft.com/office/drawing/2014/main" id="{EA8476E6-BEF3-4BB3-8401-9BD5215B239F}"/>
               </a:ext>
             </a:extLst>
           </p:cNvPr>
@@ -11788,7 +11788,7 @@
           <p:cNvPr id="7" name="">
             <a:extLst xmlns:a="http://schemas.openxmlformats.org/drawingml/2006/main">
               <a:ext uri="{FF2B5EF4-FFF2-40B4-BE49-F238E27FC236}">
-                <a16:creationId xmlns:a16="http://schemas.microsoft.com/office/drawing/2014/main" id="{507BC876-FB6E-4993-9713-20B287FFF683}"/>
+                <a16:creationId xmlns:a16="http://schemas.microsoft.com/office/drawing/2014/main" id="{7D100D58-4453-4F29-B1A3-FB03FD7DDAB1}"/>
               </a:ext>
             </a:extLst>
           </p:cNvPr>
@@ -11968,7 +11968,7 @@
           <p:cNvPr id="8" name="">
             <a:extLst xmlns:a="http://schemas.openxmlformats.org/drawingml/2006/main">
               <a:ext uri="{FF2B5EF4-FFF2-40B4-BE49-F238E27FC236}">
-                <a16:creationId xmlns:a16="http://schemas.microsoft.com/office/drawing/2014/main" id="{C49AEA2F-1BD3-4491-A82C-0ED9D63AE213}"/>
+                <a16:creationId xmlns:a16="http://schemas.microsoft.com/office/drawing/2014/main" id="{B1CF50BA-A4AA-41F6-A566-31BC20E381B6}"/>
               </a:ext>
             </a:extLst>
           </p:cNvPr>
@@ -12125,7 +12125,7 @@
           <p:cNvPr id="9" name="">
             <a:extLst xmlns:a="http://schemas.openxmlformats.org/drawingml/2006/main">
               <a:ext uri="{FF2B5EF4-FFF2-40B4-BE49-F238E27FC236}">
-                <a16:creationId xmlns:a16="http://schemas.microsoft.com/office/drawing/2014/main" id="{2457D2C4-7B14-4E7D-AF55-70EDB2E21272}"/>
+                <a16:creationId xmlns:a16="http://schemas.microsoft.com/office/drawing/2014/main" id="{3B0F2248-C577-45B0-A92D-F8EF00D10BE8}"/>
               </a:ext>
             </a:extLst>
           </p:cNvPr>
@@ -12156,7 +12156,7 @@
           <p:cNvPr id="10" name="">
             <a:extLst xmlns:a="http://schemas.openxmlformats.org/drawingml/2006/main">
               <a:ext uri="{FF2B5EF4-FFF2-40B4-BE49-F238E27FC236}">
-                <a16:creationId xmlns:a16="http://schemas.microsoft.com/office/drawing/2014/main" id="{68B0842B-F6C9-4086-97AB-36FEF7D0B44F}"/>
+                <a16:creationId xmlns:a16="http://schemas.microsoft.com/office/drawing/2014/main" id="{B1CA5847-0243-48BC-BEBC-1C574A351D13}"/>
               </a:ext>
             </a:extLst>
           </p:cNvPr>
@@ -12336,7 +12336,7 @@
           <p:cNvPr id="11" name="">
             <a:extLst xmlns:a="http://schemas.openxmlformats.org/drawingml/2006/main">
               <a:ext uri="{FF2B5EF4-FFF2-40B4-BE49-F238E27FC236}">
-                <a16:creationId xmlns:a16="http://schemas.microsoft.com/office/drawing/2014/main" id="{35810490-39EE-41EF-90C0-1825372B7F0F}"/>
+                <a16:creationId xmlns:a16="http://schemas.microsoft.com/office/drawing/2014/main" id="{2CC124C6-E515-4CED-AAE1-3E3DF77A7211}"/>
               </a:ext>
             </a:extLst>
           </p:cNvPr>
@@ -12493,7 +12493,7 @@
           <p:cNvPr id="12" name="">
             <a:extLst xmlns:a="http://schemas.openxmlformats.org/drawingml/2006/main">
               <a:ext uri="{FF2B5EF4-FFF2-40B4-BE49-F238E27FC236}">
-                <a16:creationId xmlns:a16="http://schemas.microsoft.com/office/drawing/2014/main" id="{3A5B8118-72EC-44A5-8551-F4C061153A5E}"/>
+                <a16:creationId xmlns:a16="http://schemas.microsoft.com/office/drawing/2014/main" id="{0A7CAA4A-B01C-4DA6-BFC8-48E58A18ECAE}"/>
               </a:ext>
             </a:extLst>
           </p:cNvPr>
@@ -12524,7 +12524,7 @@
           <p:cNvPr id="13" name="">
             <a:extLst xmlns:a="http://schemas.openxmlformats.org/drawingml/2006/main">
               <a:ext uri="{FF2B5EF4-FFF2-40B4-BE49-F238E27FC236}">
-                <a16:creationId xmlns:a16="http://schemas.microsoft.com/office/drawing/2014/main" id="{DFB211C1-BC2F-4E00-A68E-723017E81CB8}"/>
+                <a16:creationId xmlns:a16="http://schemas.microsoft.com/office/drawing/2014/main" id="{880FE39D-D801-4815-87FC-652B9B660571}"/>
               </a:ext>
             </a:extLst>
           </p:cNvPr>
@@ -12704,7 +12704,7 @@
           <p:cNvPr id="14" name="">
             <a:extLst xmlns:a="http://schemas.openxmlformats.org/drawingml/2006/main">
               <a:ext uri="{FF2B5EF4-FFF2-40B4-BE49-F238E27FC236}">
-                <a16:creationId xmlns:a16="http://schemas.microsoft.com/office/drawing/2014/main" id="{09E0D447-725A-40FD-BFF8-173FE7E26777}"/>
+                <a16:creationId xmlns:a16="http://schemas.microsoft.com/office/drawing/2014/main" id="{67C3D0B5-4353-4F98-86F6-A6A29F7E0379}"/>
               </a:ext>
             </a:extLst>
           </p:cNvPr>
@@ -12861,7 +12861,7 @@
           <p:cNvPr id="15" name="">
             <a:extLst xmlns:a="http://schemas.openxmlformats.org/drawingml/2006/main">
               <a:ext uri="{FF2B5EF4-FFF2-40B4-BE49-F238E27FC236}">
-                <a16:creationId xmlns:a16="http://schemas.microsoft.com/office/drawing/2014/main" id="{F3B3FB8C-8916-4F62-806C-53579AB74AD0}"/>
+                <a16:creationId xmlns:a16="http://schemas.microsoft.com/office/drawing/2014/main" id="{021A4F33-6776-4BD1-BE70-92323DBC1B5D}"/>
               </a:ext>
             </a:extLst>
           </p:cNvPr>
@@ -12892,7 +12892,7 @@
           <p:cNvPr id="16" name="">
             <a:extLst xmlns:a="http://schemas.openxmlformats.org/drawingml/2006/main">
               <a:ext uri="{FF2B5EF4-FFF2-40B4-BE49-F238E27FC236}">
-                <a16:creationId xmlns:a16="http://schemas.microsoft.com/office/drawing/2014/main" id="{2EDBD1E5-9691-4B06-9017-06FAF4EEA4A4}"/>
+                <a16:creationId xmlns:a16="http://schemas.microsoft.com/office/drawing/2014/main" id="{BD33FC41-8FCE-422E-8100-BECAA41DBB34}"/>
               </a:ext>
             </a:extLst>
           </p:cNvPr>
@@ -13072,7 +13072,7 @@
           <p:cNvPr id="17" name="">
             <a:extLst xmlns:a="http://schemas.openxmlformats.org/drawingml/2006/main">
               <a:ext uri="{FF2B5EF4-FFF2-40B4-BE49-F238E27FC236}">
-                <a16:creationId xmlns:a16="http://schemas.microsoft.com/office/drawing/2014/main" id="{67D5DBA4-7BA6-4503-8E34-7259CCAAAE1B}"/>
+                <a16:creationId xmlns:a16="http://schemas.microsoft.com/office/drawing/2014/main" id="{75A3DC89-7AE5-4F1C-8D35-EA8528A7DC51}"/>
               </a:ext>
             </a:extLst>
           </p:cNvPr>
@@ -13432,7 +13432,7 @@
           <p:cNvPr id="18" name="">
             <a:extLst xmlns:a="http://schemas.openxmlformats.org/drawingml/2006/main">
               <a:ext uri="{FF2B5EF4-FFF2-40B4-BE49-F238E27FC236}">
-                <a16:creationId xmlns:a16="http://schemas.microsoft.com/office/drawing/2014/main" id="{5FDD7383-C915-48FB-A479-21CC40F576FD}"/>
+                <a16:creationId xmlns:a16="http://schemas.microsoft.com/office/drawing/2014/main" id="{EB8A9277-C76A-44B4-82D3-481B61CAE105}"/>
               </a:ext>
             </a:extLst>
           </p:cNvPr>
@@ -13587,7 +13587,7 @@
     </p:spTree>
     <p:extLst>
       <p:ext uri="{BB962C8B-B14F-4D97-AF65-F5344CB8AC3E}">
-        <p14:creationId xmlns:p14="http://schemas.microsoft.com/office/powerpoint/2010/main" val="517986482"/>
+        <p14:creationId xmlns:p14="http://schemas.microsoft.com/office/powerpoint/2010/main" val="287037744"/>
       </p:ext>
     </p:extLst>
   </p:cSld>
@@ -13618,7 +13618,7 @@
           <p:cNvPr id="26" name="">
             <a:extLst xmlns:a="http://schemas.openxmlformats.org/drawingml/2006/main">
               <a:ext uri="{FF2B5EF4-FFF2-40B4-BE49-F238E27FC236}">
-                <a16:creationId xmlns:a16="http://schemas.microsoft.com/office/drawing/2014/main" id="{E63ED0B5-D3D6-4F08-99AB-1184204A38EA}"/>
+                <a16:creationId xmlns:a16="http://schemas.microsoft.com/office/drawing/2014/main" id="{7C54A32A-3815-4072-8486-DA61AAA7CEFA}"/>
               </a:ext>
             </a:extLst>
           </p:cNvPr>
@@ -13775,7 +13775,7 @@
           <p:cNvPr id="2" name="">
             <a:extLst xmlns:a="http://schemas.openxmlformats.org/drawingml/2006/main">
               <a:ext uri="{FF2B5EF4-FFF2-40B4-BE49-F238E27FC236}">
-                <a16:creationId xmlns:a16="http://schemas.microsoft.com/office/drawing/2014/main" id="{8A4433AE-8AAC-42DE-92D3-F0CA2FB1E3D6}"/>
+                <a16:creationId xmlns:a16="http://schemas.microsoft.com/office/drawing/2014/main" id="{EEF84E9F-F821-4D0F-ACB2-2691702161EB}"/>
               </a:ext>
             </a:extLst>
           </p:cNvPr>
@@ -13806,7 +13806,7 @@
           <p:cNvPr id="3" name="">
             <a:extLst xmlns:a="http://schemas.openxmlformats.org/drawingml/2006/main">
               <a:ext uri="{FF2B5EF4-FFF2-40B4-BE49-F238E27FC236}">
-                <a16:creationId xmlns:a16="http://schemas.microsoft.com/office/drawing/2014/main" id="{53C7DA5C-3382-4FEC-B4BF-57AFF0029C46}"/>
+                <a16:creationId xmlns:a16="http://schemas.microsoft.com/office/drawing/2014/main" id="{DF7D03EA-7A13-4015-AEE4-FC506B6FFDEE}"/>
               </a:ext>
             </a:extLst>
           </p:cNvPr>
@@ -13963,7 +13963,7 @@
           <p:cNvPr id="4" name="">
             <a:extLst xmlns:a="http://schemas.openxmlformats.org/drawingml/2006/main">
               <a:ext uri="{FF2B5EF4-FFF2-40B4-BE49-F238E27FC236}">
-                <a16:creationId xmlns:a16="http://schemas.microsoft.com/office/drawing/2014/main" id="{01867D94-6B39-4D59-82D4-1A0C59E5CCAD}"/>
+                <a16:creationId xmlns:a16="http://schemas.microsoft.com/office/drawing/2014/main" id="{8799C24C-7741-4DE9-BA30-050DFBD9CD3E}"/>
               </a:ext>
             </a:extLst>
           </p:cNvPr>
@@ -13996,7 +13996,7 @@
           <p:cNvPr id="5" name="">
             <a:extLst xmlns:a="http://schemas.openxmlformats.org/drawingml/2006/main">
               <a:ext uri="{FF2B5EF4-FFF2-40B4-BE49-F238E27FC236}">
-                <a16:creationId xmlns:a16="http://schemas.microsoft.com/office/drawing/2014/main" id="{EEA3883C-1764-4C4B-8605-75B233957FC3}"/>
+                <a16:creationId xmlns:a16="http://schemas.microsoft.com/office/drawing/2014/main" id="{DD2475DB-F152-48B4-8504-591CC1B4FECF}"/>
               </a:ext>
             </a:extLst>
           </p:cNvPr>
@@ -14153,7 +14153,7 @@
           <p:cNvPr id="6" name="">
             <a:extLst xmlns:a="http://schemas.openxmlformats.org/drawingml/2006/main">
               <a:ext uri="{FF2B5EF4-FFF2-40B4-BE49-F238E27FC236}">
-                <a16:creationId xmlns:a16="http://schemas.microsoft.com/office/drawing/2014/main" id="{E05A3553-8C91-4E44-A667-E67A55900FFF}"/>
+                <a16:creationId xmlns:a16="http://schemas.microsoft.com/office/drawing/2014/main" id="{DC6A51D9-2DC9-44F4-B5F0-0D70868856B3}"/>
               </a:ext>
             </a:extLst>
           </p:cNvPr>
@@ -14333,7 +14333,7 @@
           <p:cNvPr id="7" name="">
             <a:extLst xmlns:a="http://schemas.openxmlformats.org/drawingml/2006/main">
               <a:ext uri="{FF2B5EF4-FFF2-40B4-BE49-F238E27FC236}">
-                <a16:creationId xmlns:a16="http://schemas.microsoft.com/office/drawing/2014/main" id="{BEBAAE80-7A65-48EE-BF64-02AB777D503B}"/>
+                <a16:creationId xmlns:a16="http://schemas.microsoft.com/office/drawing/2014/main" id="{34C51783-D148-48A6-B5C7-F1B7C4A5574C}"/>
               </a:ext>
             </a:extLst>
           </p:cNvPr>
@@ -14364,7 +14364,7 @@
           <p:cNvPr id="8" name="">
             <a:extLst xmlns:a="http://schemas.openxmlformats.org/drawingml/2006/main">
               <a:ext uri="{FF2B5EF4-FFF2-40B4-BE49-F238E27FC236}">
-                <a16:creationId xmlns:a16="http://schemas.microsoft.com/office/drawing/2014/main" id="{51B4497B-FED6-48A6-9519-687DCA2FA660}"/>
+                <a16:creationId xmlns:a16="http://schemas.microsoft.com/office/drawing/2014/main" id="{61B41862-A24B-48E0-B6A5-D1C27CDD7CF0}"/>
               </a:ext>
             </a:extLst>
           </p:cNvPr>
@@ -14397,7 +14397,7 @@
           <p:cNvPr id="9" name="">
             <a:extLst xmlns:a="http://schemas.openxmlformats.org/drawingml/2006/main">
               <a:ext uri="{FF2B5EF4-FFF2-40B4-BE49-F238E27FC236}">
-                <a16:creationId xmlns:a16="http://schemas.microsoft.com/office/drawing/2014/main" id="{052465E7-DE4E-4A47-B7CA-22271B1A7832}"/>
+                <a16:creationId xmlns:a16="http://schemas.microsoft.com/office/drawing/2014/main" id="{5B484FC7-01D9-462E-B4CB-6895ECF6BB64}"/>
               </a:ext>
             </a:extLst>
           </p:cNvPr>
@@ -14554,7 +14554,7 @@
           <p:cNvPr id="10" name="">
             <a:extLst xmlns:a="http://schemas.openxmlformats.org/drawingml/2006/main">
               <a:ext uri="{FF2B5EF4-FFF2-40B4-BE49-F238E27FC236}">
-                <a16:creationId xmlns:a16="http://schemas.microsoft.com/office/drawing/2014/main" id="{658966B6-C441-4504-9480-BEF057E4983D}"/>
+                <a16:creationId xmlns:a16="http://schemas.microsoft.com/office/drawing/2014/main" id="{71302469-6CC9-4F7C-9B97-8FAE74FC215A}"/>
               </a:ext>
             </a:extLst>
           </p:cNvPr>
@@ -14734,7 +14734,7 @@
           <p:cNvPr id="11" name="">
             <a:extLst xmlns:a="http://schemas.openxmlformats.org/drawingml/2006/main">
               <a:ext uri="{FF2B5EF4-FFF2-40B4-BE49-F238E27FC236}">
-                <a16:creationId xmlns:a16="http://schemas.microsoft.com/office/drawing/2014/main" id="{D32A9ED9-CBD4-4DE6-A08D-898A8B446FA0}"/>
+                <a16:creationId xmlns:a16="http://schemas.microsoft.com/office/drawing/2014/main" id="{D3EFF310-008B-47FA-BD80-847EB8A68CEE}"/>
               </a:ext>
             </a:extLst>
           </p:cNvPr>
@@ -14765,7 +14765,7 @@
           <p:cNvPr id="12" name="">
             <a:extLst xmlns:a="http://schemas.openxmlformats.org/drawingml/2006/main">
               <a:ext uri="{FF2B5EF4-FFF2-40B4-BE49-F238E27FC236}">
-                <a16:creationId xmlns:a16="http://schemas.microsoft.com/office/drawing/2014/main" id="{ACCC8899-8672-4E8C-8CD8-96410654F84E}"/>
+                <a16:creationId xmlns:a16="http://schemas.microsoft.com/office/drawing/2014/main" id="{8BAF8364-FAFF-4773-A78A-36A09628980F}"/>
               </a:ext>
             </a:extLst>
           </p:cNvPr>
@@ -14798,7 +14798,7 @@
           <p:cNvPr id="13" name="">
             <a:extLst xmlns:a="http://schemas.openxmlformats.org/drawingml/2006/main">
               <a:ext uri="{FF2B5EF4-FFF2-40B4-BE49-F238E27FC236}">
-                <a16:creationId xmlns:a16="http://schemas.microsoft.com/office/drawing/2014/main" id="{582E6120-7E8D-4C1C-B88F-530D1585AC46}"/>
+                <a16:creationId xmlns:a16="http://schemas.microsoft.com/office/drawing/2014/main" id="{92E658B0-509A-45CD-AB37-501FB5A5F7F3}"/>
               </a:ext>
             </a:extLst>
           </p:cNvPr>
@@ -14955,7 +14955,7 @@
           <p:cNvPr id="14" name="">
             <a:extLst xmlns:a="http://schemas.openxmlformats.org/drawingml/2006/main">
               <a:ext uri="{FF2B5EF4-FFF2-40B4-BE49-F238E27FC236}">
-                <a16:creationId xmlns:a16="http://schemas.microsoft.com/office/drawing/2014/main" id="{F9CADB71-75E4-4A2D-AA8B-316BB4EFDB0F}"/>
+                <a16:creationId xmlns:a16="http://schemas.microsoft.com/office/drawing/2014/main" id="{F838A9EE-8511-4B48-9D54-C53DFFC79CA9}"/>
               </a:ext>
             </a:extLst>
           </p:cNvPr>
@@ -15135,7 +15135,7 @@
           <p:cNvPr id="15" name="">
             <a:extLst xmlns:a="http://schemas.openxmlformats.org/drawingml/2006/main">
               <a:ext uri="{FF2B5EF4-FFF2-40B4-BE49-F238E27FC236}">
-                <a16:creationId xmlns:a16="http://schemas.microsoft.com/office/drawing/2014/main" id="{6DB3BCD3-1ECB-4315-AB99-6630E17C2A2F}"/>
+                <a16:creationId xmlns:a16="http://schemas.microsoft.com/office/drawing/2014/main" id="{E02E4491-AA08-4887-9931-8307BDB4F129}"/>
               </a:ext>
             </a:extLst>
           </p:cNvPr>
@@ -15166,7 +15166,7 @@
           <p:cNvPr id="16" name="">
             <a:extLst xmlns:a="http://schemas.openxmlformats.org/drawingml/2006/main">
               <a:ext uri="{FF2B5EF4-FFF2-40B4-BE49-F238E27FC236}">
-                <a16:creationId xmlns:a16="http://schemas.microsoft.com/office/drawing/2014/main" id="{82A0A540-F7A0-4F51-B8A7-75FBB8E9F23B}"/>
+                <a16:creationId xmlns:a16="http://schemas.microsoft.com/office/drawing/2014/main" id="{A205E000-F341-40D8-81C0-7244F806C4AF}"/>
               </a:ext>
             </a:extLst>
           </p:cNvPr>
@@ -15199,7 +15199,7 @@
           <p:cNvPr id="17" name="">
             <a:extLst xmlns:a="http://schemas.openxmlformats.org/drawingml/2006/main">
               <a:ext uri="{FF2B5EF4-FFF2-40B4-BE49-F238E27FC236}">
-                <a16:creationId xmlns:a16="http://schemas.microsoft.com/office/drawing/2014/main" id="{627493D2-C3D6-4A1F-9465-AD010C93238B}"/>
+                <a16:creationId xmlns:a16="http://schemas.microsoft.com/office/drawing/2014/main" id="{DFE85D7B-491C-4A42-AD59-1E1E85B14ED6}"/>
               </a:ext>
             </a:extLst>
           </p:cNvPr>
@@ -15356,7 +15356,7 @@
           <p:cNvPr id="18" name="">
             <a:extLst xmlns:a="http://schemas.openxmlformats.org/drawingml/2006/main">
               <a:ext uri="{FF2B5EF4-FFF2-40B4-BE49-F238E27FC236}">
-                <a16:creationId xmlns:a16="http://schemas.microsoft.com/office/drawing/2014/main" id="{10828542-7609-4D5E-A296-1E484F9306FB}"/>
+                <a16:creationId xmlns:a16="http://schemas.microsoft.com/office/drawing/2014/main" id="{9B2C2A19-1A26-400F-89F8-A9337B455F2D}"/>
               </a:ext>
             </a:extLst>
           </p:cNvPr>
@@ -15536,7 +15536,7 @@
           <p:cNvPr id="19" name="">
             <a:extLst xmlns:a="http://schemas.openxmlformats.org/drawingml/2006/main">
               <a:ext uri="{FF2B5EF4-FFF2-40B4-BE49-F238E27FC236}">
-                <a16:creationId xmlns:a16="http://schemas.microsoft.com/office/drawing/2014/main" id="{1F612EED-5AE5-420D-82C0-0ED02C3112C5}"/>
+                <a16:creationId xmlns:a16="http://schemas.microsoft.com/office/drawing/2014/main" id="{55F3A9AA-F8AF-4753-AE1F-D63D04AA61F0}"/>
               </a:ext>
             </a:extLst>
           </p:cNvPr>
@@ -15693,7 +15693,7 @@
           <p:cNvPr id="20" name="">
             <a:extLst xmlns:a="http://schemas.openxmlformats.org/drawingml/2006/main">
               <a:ext uri="{FF2B5EF4-FFF2-40B4-BE49-F238E27FC236}">
-                <a16:creationId xmlns:a16="http://schemas.microsoft.com/office/drawing/2014/main" id="{C301A472-929E-4AB9-90DF-C20E2ABAD36A}"/>
+                <a16:creationId xmlns:a16="http://schemas.microsoft.com/office/drawing/2014/main" id="{8CABED76-DB69-4D7C-B5A4-EEDEC4927743}"/>
               </a:ext>
             </a:extLst>
           </p:cNvPr>
@@ -15850,7 +15850,7 @@
           <p:cNvPr id="21" name="">
             <a:extLst xmlns:a="http://schemas.openxmlformats.org/drawingml/2006/main">
               <a:ext uri="{FF2B5EF4-FFF2-40B4-BE49-F238E27FC236}">
-                <a16:creationId xmlns:a16="http://schemas.microsoft.com/office/drawing/2014/main" id="{C81EE886-E35A-4FCC-AFCA-C4B173587A6E}"/>
+                <a16:creationId xmlns:a16="http://schemas.microsoft.com/office/drawing/2014/main" id="{4893A5DE-E21F-45EC-A9FA-07104CC1D90E}"/>
               </a:ext>
             </a:extLst>
           </p:cNvPr>
@@ -16007,7 +16007,7 @@
           <p:cNvPr id="22" name="">
             <a:extLst xmlns:a="http://schemas.openxmlformats.org/drawingml/2006/main">
               <a:ext uri="{FF2B5EF4-FFF2-40B4-BE49-F238E27FC236}">
-                <a16:creationId xmlns:a16="http://schemas.microsoft.com/office/drawing/2014/main" id="{831895FD-CFE3-4DB2-B382-FD0137EEF7F4}"/>
+                <a16:creationId xmlns:a16="http://schemas.microsoft.com/office/drawing/2014/main" id="{D06D525F-C610-4B79-899A-C25AD4F8E432}"/>
               </a:ext>
             </a:extLst>
           </p:cNvPr>
@@ -16164,7 +16164,7 @@
           <p:cNvPr id="23" name="">
             <a:extLst xmlns:a="http://schemas.openxmlformats.org/drawingml/2006/main">
               <a:ext uri="{FF2B5EF4-FFF2-40B4-BE49-F238E27FC236}">
-                <a16:creationId xmlns:a16="http://schemas.microsoft.com/office/drawing/2014/main" id="{40471ADE-BF6E-4EA6-85D2-C9B31223683D}"/>
+                <a16:creationId xmlns:a16="http://schemas.microsoft.com/office/drawing/2014/main" id="{AB50BCBA-9868-4DC3-8A60-26F64F2328B2}"/>
               </a:ext>
             </a:extLst>
           </p:cNvPr>
@@ -16321,7 +16321,7 @@
           <p:cNvPr id="24" name="">
             <a:extLst xmlns:a="http://schemas.openxmlformats.org/drawingml/2006/main">
               <a:ext uri="{FF2B5EF4-FFF2-40B4-BE49-F238E27FC236}">
-                <a16:creationId xmlns:a16="http://schemas.microsoft.com/office/drawing/2014/main" id="{9F55A9EE-ADBE-4BCF-82C9-D97F88579D44}"/>
+                <a16:creationId xmlns:a16="http://schemas.microsoft.com/office/drawing/2014/main" id="{BD4A4B69-103C-4BB1-8BDC-D5D0D6E1079D}"/>
               </a:ext>
             </a:extLst>
           </p:cNvPr>
@@ -16478,7 +16478,7 @@
           <p:cNvPr id="25" name="">
             <a:extLst xmlns:a="http://schemas.openxmlformats.org/drawingml/2006/main">
               <a:ext uri="{FF2B5EF4-FFF2-40B4-BE49-F238E27FC236}">
-                <a16:creationId xmlns:a16="http://schemas.microsoft.com/office/drawing/2014/main" id="{C913427F-5AF3-4248-87E9-0AB486E904C2}"/>
+                <a16:creationId xmlns:a16="http://schemas.microsoft.com/office/drawing/2014/main" id="{843731BD-EB19-4E39-9E28-D993F8188C19}"/>
               </a:ext>
             </a:extLst>
           </p:cNvPr>
@@ -16633,7 +16633,7 @@
     </p:spTree>
     <p:extLst>
       <p:ext uri="{BB962C8B-B14F-4D97-AF65-F5344CB8AC3E}">
-        <p14:creationId xmlns:p14="http://schemas.microsoft.com/office/powerpoint/2010/main" val="638663905"/>
+        <p14:creationId xmlns:p14="http://schemas.microsoft.com/office/powerpoint/2010/main" val="2031457124"/>
       </p:ext>
     </p:extLst>
   </p:cSld>
@@ -16664,7 +16664,7 @@
           <p:cNvPr id="10" name="">
             <a:extLst xmlns:a="http://schemas.openxmlformats.org/drawingml/2006/main">
               <a:ext uri="{FF2B5EF4-FFF2-40B4-BE49-F238E27FC236}">
-                <a16:creationId xmlns:a16="http://schemas.microsoft.com/office/drawing/2014/main" id="{33B95E47-6278-4602-BD14-1F4970267C17}"/>
+                <a16:creationId xmlns:a16="http://schemas.microsoft.com/office/drawing/2014/main" id="{39824401-A2FF-4923-850C-32A21930D602}"/>
               </a:ext>
             </a:extLst>
           </p:cNvPr>
@@ -16821,7 +16821,7 @@
           <p:cNvPr id="2" name="">
             <a:extLst xmlns:a="http://schemas.openxmlformats.org/drawingml/2006/main">
               <a:ext uri="{FF2B5EF4-FFF2-40B4-BE49-F238E27FC236}">
-                <a16:creationId xmlns:a16="http://schemas.microsoft.com/office/drawing/2014/main" id="{6FF3BF3B-2755-4A6A-80D1-75FA850660A0}"/>
+                <a16:creationId xmlns:a16="http://schemas.microsoft.com/office/drawing/2014/main" id="{7AB70AD3-96B8-4569-82ED-2EA1FF2B7AF0}"/>
               </a:ext>
             </a:extLst>
           </p:cNvPr>
@@ -16852,7 +16852,7 @@
           <p:cNvPr id="3" name="">
             <a:extLst xmlns:a="http://schemas.openxmlformats.org/drawingml/2006/main">
               <a:ext uri="{FF2B5EF4-FFF2-40B4-BE49-F238E27FC236}">
-                <a16:creationId xmlns:a16="http://schemas.microsoft.com/office/drawing/2014/main" id="{B7BFBDD6-99C2-4499-8E3C-F1C6E4B28B6C}"/>
+                <a16:creationId xmlns:a16="http://schemas.microsoft.com/office/drawing/2014/main" id="{C239289C-1576-476C-9E77-B90166812299}"/>
               </a:ext>
             </a:extLst>
           </p:cNvPr>
@@ -17009,7 +17009,7 @@
           <p:cNvPr id="4" name="Chart">
             <a:extLst xmlns:a="http://schemas.openxmlformats.org/drawingml/2006/main">
               <a:ext uri="{FF2B5EF4-FFF2-40B4-BE49-F238E27FC236}">
-                <a16:creationId xmlns:a16="http://schemas.microsoft.com/office/drawing/2014/main" id="{336C67CF-B659-4191-B2C4-DF1674E9B811}"/>
+                <a16:creationId xmlns:a16="http://schemas.microsoft.com/office/drawing/2014/main" id="{F71DAC06-0777-4BF8-A0EE-8E2D0C09123C}"/>
               </a:ext>
             </a:extLst>
           </p:cNvPr>
@@ -17022,7 +17022,7 @@
         </p:xfrm>
         <a:graphic xmlns:a="http://schemas.openxmlformats.org/drawingml/2006/main">
           <a:graphicData uri="http://schemas.openxmlformats.org/drawingml/2006/chart">
-            <c:chart xmlns:r="http://schemas.openxmlformats.org/officeDocument/2006/relationships" xmlns:c="http://schemas.openxmlformats.org/drawingml/2006/chart" r:id="R6d23a023c01c40d3"/>
+            <c:chart xmlns:r="http://schemas.openxmlformats.org/officeDocument/2006/relationships" xmlns:c="http://schemas.openxmlformats.org/drawingml/2006/chart" r:id="R3692c6145d6849ab"/>
           </a:graphicData>
         </a:graphic>
       </p:graphicFrame>
@@ -17031,7 +17031,7 @@
           <p:cNvPr id="5" name="">
             <a:extLst xmlns:a="http://schemas.openxmlformats.org/drawingml/2006/main">
               <a:ext uri="{FF2B5EF4-FFF2-40B4-BE49-F238E27FC236}">
-                <a16:creationId xmlns:a16="http://schemas.microsoft.com/office/drawing/2014/main" id="{D1D14BC6-EE50-4DD7-8A6F-4D03B3B02493}"/>
+                <a16:creationId xmlns:a16="http://schemas.microsoft.com/office/drawing/2014/main" id="{5D26C32D-B5F5-4D40-9C4E-E9B02252B8FC}"/>
               </a:ext>
             </a:extLst>
           </p:cNvPr>
@@ -17188,7 +17188,7 @@
           <p:cNvPr id="6" name="">
             <a:extLst xmlns:a="http://schemas.openxmlformats.org/drawingml/2006/main">
               <a:ext uri="{FF2B5EF4-FFF2-40B4-BE49-F238E27FC236}">
-                <a16:creationId xmlns:a16="http://schemas.microsoft.com/office/drawing/2014/main" id="{9F69D02F-F591-4643-9FA8-99640765B9C6}"/>
+                <a16:creationId xmlns:a16="http://schemas.microsoft.com/office/drawing/2014/main" id="{535D4636-7F0A-4897-9BC2-4ED949BD4D3E}"/>
               </a:ext>
             </a:extLst>
           </p:cNvPr>
@@ -17368,7 +17368,7 @@
           <p:cNvPr id="7" name="">
             <a:extLst xmlns:a="http://schemas.openxmlformats.org/drawingml/2006/main">
               <a:ext uri="{FF2B5EF4-FFF2-40B4-BE49-F238E27FC236}">
-                <a16:creationId xmlns:a16="http://schemas.microsoft.com/office/drawing/2014/main" id="{62D08954-08EA-438F-9A9C-DE52C1771643}"/>
+                <a16:creationId xmlns:a16="http://schemas.microsoft.com/office/drawing/2014/main" id="{0F441457-465D-4496-BBA3-F46305840B2C}"/>
               </a:ext>
             </a:extLst>
           </p:cNvPr>
@@ -17525,7 +17525,7 @@
           <p:cNvPr id="8" name="">
             <a:extLst xmlns:a="http://schemas.openxmlformats.org/drawingml/2006/main">
               <a:ext uri="{FF2B5EF4-FFF2-40B4-BE49-F238E27FC236}">
-                <a16:creationId xmlns:a16="http://schemas.microsoft.com/office/drawing/2014/main" id="{63C59163-8920-466D-8980-57387B9FA4BD}"/>
+                <a16:creationId xmlns:a16="http://schemas.microsoft.com/office/drawing/2014/main" id="{62982E7C-3436-4F8E-BAB3-E7A4EFEADC53}"/>
               </a:ext>
             </a:extLst>
           </p:cNvPr>
@@ -17705,7 +17705,7 @@
           <p:cNvPr id="9" name="">
             <a:extLst xmlns:a="http://schemas.openxmlformats.org/drawingml/2006/main">
               <a:ext uri="{FF2B5EF4-FFF2-40B4-BE49-F238E27FC236}">
-                <a16:creationId xmlns:a16="http://schemas.microsoft.com/office/drawing/2014/main" id="{44ACCD1B-6B1A-4BDA-B53E-4E0A078BA035}"/>
+                <a16:creationId xmlns:a16="http://schemas.microsoft.com/office/drawing/2014/main" id="{33021AE7-55E6-4B31-B8B3-72F0ACF46B7A}"/>
               </a:ext>
             </a:extLst>
           </p:cNvPr>
@@ -17860,7 +17860,7 @@
     </p:spTree>
     <p:extLst>
       <p:ext uri="{BB962C8B-B14F-4D97-AF65-F5344CB8AC3E}">
-        <p14:creationId xmlns:p14="http://schemas.microsoft.com/office/powerpoint/2010/main" val="232933482"/>
+        <p14:creationId xmlns:p14="http://schemas.microsoft.com/office/powerpoint/2010/main" val="1296423497"/>
       </p:ext>
     </p:extLst>
   </p:cSld>
@@ -17891,7 +17891,7 @@
           <p:cNvPr id="22" name="">
             <a:extLst xmlns:a="http://schemas.openxmlformats.org/drawingml/2006/main">
               <a:ext uri="{FF2B5EF4-FFF2-40B4-BE49-F238E27FC236}">
-                <a16:creationId xmlns:a16="http://schemas.microsoft.com/office/drawing/2014/main" id="{D4F94414-6AD7-426F-B50D-4DD2884B5EA5}"/>
+                <a16:creationId xmlns:a16="http://schemas.microsoft.com/office/drawing/2014/main" id="{8BB83147-70FF-4C5D-8A9B-E19679610433}"/>
               </a:ext>
             </a:extLst>
           </p:cNvPr>
@@ -18048,7 +18048,7 @@
           <p:cNvPr id="2" name="">
             <a:extLst xmlns:a="http://schemas.openxmlformats.org/drawingml/2006/main">
               <a:ext uri="{FF2B5EF4-FFF2-40B4-BE49-F238E27FC236}">
-                <a16:creationId xmlns:a16="http://schemas.microsoft.com/office/drawing/2014/main" id="{5BE6A5B4-E4D5-4C41-8430-FC0A52257BF9}"/>
+                <a16:creationId xmlns:a16="http://schemas.microsoft.com/office/drawing/2014/main" id="{F2341EFA-81E8-4E97-BA59-56C9699FC6EF}"/>
               </a:ext>
             </a:extLst>
           </p:cNvPr>
@@ -18079,7 +18079,7 @@
           <p:cNvPr id="3" name="">
             <a:extLst xmlns:a="http://schemas.openxmlformats.org/drawingml/2006/main">
               <a:ext uri="{FF2B5EF4-FFF2-40B4-BE49-F238E27FC236}">
-                <a16:creationId xmlns:a16="http://schemas.microsoft.com/office/drawing/2014/main" id="{F74E4A65-60F2-4AF7-9E2C-2B873DE2B30C}"/>
+                <a16:creationId xmlns:a16="http://schemas.microsoft.com/office/drawing/2014/main" id="{97E90A8B-B01F-40B8-8278-2C810D1881E1}"/>
               </a:ext>
             </a:extLst>
           </p:cNvPr>
@@ -18236,7 +18236,7 @@
           <p:cNvPr id="4" name="">
             <a:extLst xmlns:a="http://schemas.openxmlformats.org/drawingml/2006/main">
               <a:ext uri="{FF2B5EF4-FFF2-40B4-BE49-F238E27FC236}">
-                <a16:creationId xmlns:a16="http://schemas.microsoft.com/office/drawing/2014/main" id="{37AE3FEA-53D8-4331-90FF-974229598009}"/>
+                <a16:creationId xmlns:a16="http://schemas.microsoft.com/office/drawing/2014/main" id="{5FCAA8BD-F85D-4850-AFFD-22AED759E74A}"/>
               </a:ext>
             </a:extLst>
           </p:cNvPr>
@@ -18269,7 +18269,7 @@
           <p:cNvPr id="5" name="">
             <a:extLst xmlns:a="http://schemas.openxmlformats.org/drawingml/2006/main">
               <a:ext uri="{FF2B5EF4-FFF2-40B4-BE49-F238E27FC236}">
-                <a16:creationId xmlns:a16="http://schemas.microsoft.com/office/drawing/2014/main" id="{E167C069-4ECA-4835-BE2E-2F7F816C708C}"/>
+                <a16:creationId xmlns:a16="http://schemas.microsoft.com/office/drawing/2014/main" id="{6130BC16-A951-4C84-990E-165BD534CA6B}"/>
               </a:ext>
             </a:extLst>
           </p:cNvPr>
@@ -18426,7 +18426,7 @@
           <p:cNvPr id="6" name="">
             <a:extLst xmlns:a="http://schemas.openxmlformats.org/drawingml/2006/main">
               <a:ext uri="{FF2B5EF4-FFF2-40B4-BE49-F238E27FC236}">
-                <a16:creationId xmlns:a16="http://schemas.microsoft.com/office/drawing/2014/main" id="{8E69A16B-B43E-451E-8F9F-A38926454CD3}"/>
+                <a16:creationId xmlns:a16="http://schemas.microsoft.com/office/drawing/2014/main" id="{7AB90C10-1792-4EFC-B7C9-237D5832F8CB}"/>
               </a:ext>
             </a:extLst>
           </p:cNvPr>
@@ -18606,7 +18606,7 @@
           <p:cNvPr id="7" name="">
             <a:extLst xmlns:a="http://schemas.openxmlformats.org/drawingml/2006/main">
               <a:ext uri="{FF2B5EF4-FFF2-40B4-BE49-F238E27FC236}">
-                <a16:creationId xmlns:a16="http://schemas.microsoft.com/office/drawing/2014/main" id="{2C377ACB-C5CB-4BAB-8A0C-81C4FD1B8FCF}"/>
+                <a16:creationId xmlns:a16="http://schemas.microsoft.com/office/drawing/2014/main" id="{16A05DA6-E003-40CD-90F4-DF83213B0FCF}"/>
               </a:ext>
             </a:extLst>
           </p:cNvPr>
@@ -18637,7 +18637,7 @@
           <p:cNvPr id="8" name="">
             <a:extLst xmlns:a="http://schemas.openxmlformats.org/drawingml/2006/main">
               <a:ext uri="{FF2B5EF4-FFF2-40B4-BE49-F238E27FC236}">
-                <a16:creationId xmlns:a16="http://schemas.microsoft.com/office/drawing/2014/main" id="{3E2DA8C0-792E-48F4-87EB-CF9BA28BDE61}"/>
+                <a16:creationId xmlns:a16="http://schemas.microsoft.com/office/drawing/2014/main" id="{2C8FC47E-D920-46CE-B84B-2C9FBD126AED}"/>
               </a:ext>
             </a:extLst>
           </p:cNvPr>
@@ -18670,7 +18670,7 @@
           <p:cNvPr id="9" name="">
             <a:extLst xmlns:a="http://schemas.openxmlformats.org/drawingml/2006/main">
               <a:ext uri="{FF2B5EF4-FFF2-40B4-BE49-F238E27FC236}">
-                <a16:creationId xmlns:a16="http://schemas.microsoft.com/office/drawing/2014/main" id="{F65D5E97-C70C-4F67-B27A-3109075E75F5}"/>
+                <a16:creationId xmlns:a16="http://schemas.microsoft.com/office/drawing/2014/main" id="{07F420B3-5ACB-4A2F-9ECE-75DD56566C24}"/>
               </a:ext>
             </a:extLst>
           </p:cNvPr>
@@ -18827,7 +18827,7 @@
           <p:cNvPr id="10" name="">
             <a:extLst xmlns:a="http://schemas.openxmlformats.org/drawingml/2006/main">
               <a:ext uri="{FF2B5EF4-FFF2-40B4-BE49-F238E27FC236}">
-                <a16:creationId xmlns:a16="http://schemas.microsoft.com/office/drawing/2014/main" id="{C8DC1992-02F3-40A0-A18D-E0DEDF415DDE}"/>
+                <a16:creationId xmlns:a16="http://schemas.microsoft.com/office/drawing/2014/main" id="{56EDDB5B-2DFF-4F49-9FEF-99C671700051}"/>
               </a:ext>
             </a:extLst>
           </p:cNvPr>
@@ -19007,7 +19007,7 @@
           <p:cNvPr id="11" name="">
             <a:extLst xmlns:a="http://schemas.openxmlformats.org/drawingml/2006/main">
               <a:ext uri="{FF2B5EF4-FFF2-40B4-BE49-F238E27FC236}">
-                <a16:creationId xmlns:a16="http://schemas.microsoft.com/office/drawing/2014/main" id="{26CB718B-E88A-4BC6-B45D-F19CD375FB50}"/>
+                <a16:creationId xmlns:a16="http://schemas.microsoft.com/office/drawing/2014/main" id="{FFF45D9B-07DE-4DD2-9AC5-CE3E3AE105B9}"/>
               </a:ext>
             </a:extLst>
           </p:cNvPr>
@@ -19038,7 +19038,7 @@
           <p:cNvPr id="12" name="">
             <a:extLst xmlns:a="http://schemas.openxmlformats.org/drawingml/2006/main">
               <a:ext uri="{FF2B5EF4-FFF2-40B4-BE49-F238E27FC236}">
-                <a16:creationId xmlns:a16="http://schemas.microsoft.com/office/drawing/2014/main" id="{6A4E34CD-816A-4DD6-9D4E-DB43ADA330E0}"/>
+                <a16:creationId xmlns:a16="http://schemas.microsoft.com/office/drawing/2014/main" id="{4FE0872E-458C-4520-AC58-8E9D0306F372}"/>
               </a:ext>
             </a:extLst>
           </p:cNvPr>
@@ -19071,7 +19071,7 @@
           <p:cNvPr id="13" name="">
             <a:extLst xmlns:a="http://schemas.openxmlformats.org/drawingml/2006/main">
               <a:ext uri="{FF2B5EF4-FFF2-40B4-BE49-F238E27FC236}">
-                <a16:creationId xmlns:a16="http://schemas.microsoft.com/office/drawing/2014/main" id="{0CE18A97-05A6-46B6-AD0C-CC39AE22AE10}"/>
+                <a16:creationId xmlns:a16="http://schemas.microsoft.com/office/drawing/2014/main" id="{C11D8DD7-2613-4CEE-B2C7-9CC4E4C2A5AC}"/>
               </a:ext>
             </a:extLst>
           </p:cNvPr>
@@ -19228,7 +19228,7 @@
           <p:cNvPr id="14" name="">
             <a:extLst xmlns:a="http://schemas.openxmlformats.org/drawingml/2006/main">
               <a:ext uri="{FF2B5EF4-FFF2-40B4-BE49-F238E27FC236}">
-                <a16:creationId xmlns:a16="http://schemas.microsoft.com/office/drawing/2014/main" id="{93727979-4B9E-4350-BBFB-E5AF70E1867A}"/>
+                <a16:creationId xmlns:a16="http://schemas.microsoft.com/office/drawing/2014/main" id="{57C662A7-08FA-4185-8F5D-E2F276BCF434}"/>
               </a:ext>
             </a:extLst>
           </p:cNvPr>
@@ -19408,7 +19408,7 @@
           <p:cNvPr id="15" name="">
             <a:extLst xmlns:a="http://schemas.openxmlformats.org/drawingml/2006/main">
               <a:ext uri="{FF2B5EF4-FFF2-40B4-BE49-F238E27FC236}">
-                <a16:creationId xmlns:a16="http://schemas.microsoft.com/office/drawing/2014/main" id="{81CB14EE-4382-4181-8A4B-9B013D6A34A9}"/>
+                <a16:creationId xmlns:a16="http://schemas.microsoft.com/office/drawing/2014/main" id="{3765E0F4-5593-40EA-812A-2ABA82084DEC}"/>
               </a:ext>
             </a:extLst>
           </p:cNvPr>
@@ -19439,7 +19439,7 @@
           <p:cNvPr id="16" name="">
             <a:extLst xmlns:a="http://schemas.openxmlformats.org/drawingml/2006/main">
               <a:ext uri="{FF2B5EF4-FFF2-40B4-BE49-F238E27FC236}">
-                <a16:creationId xmlns:a16="http://schemas.microsoft.com/office/drawing/2014/main" id="{5DC021BC-C012-48D9-A1E0-CB55DDF1A997}"/>
+                <a16:creationId xmlns:a16="http://schemas.microsoft.com/office/drawing/2014/main" id="{A569B14A-0369-4A6E-9A1A-20109F7521FD}"/>
               </a:ext>
             </a:extLst>
           </p:cNvPr>
@@ -19472,7 +19472,7 @@
           <p:cNvPr id="17" name="">
             <a:extLst xmlns:a="http://schemas.openxmlformats.org/drawingml/2006/main">
               <a:ext uri="{FF2B5EF4-FFF2-40B4-BE49-F238E27FC236}">
-                <a16:creationId xmlns:a16="http://schemas.microsoft.com/office/drawing/2014/main" id="{6335456C-CD9C-4B6D-ABC3-5D89A7A8A321}"/>
+                <a16:creationId xmlns:a16="http://schemas.microsoft.com/office/drawing/2014/main" id="{3F563FBB-23D0-4E41-AB90-A72C7E2E5FA9}"/>
               </a:ext>
             </a:extLst>
           </p:cNvPr>
@@ -19629,7 +19629,7 @@
           <p:cNvPr id="18" name="">
             <a:extLst xmlns:a="http://schemas.openxmlformats.org/drawingml/2006/main">
               <a:ext uri="{FF2B5EF4-FFF2-40B4-BE49-F238E27FC236}">
-                <a16:creationId xmlns:a16="http://schemas.microsoft.com/office/drawing/2014/main" id="{46601018-A1CB-4E42-AAEA-A5DA02668E12}"/>
+                <a16:creationId xmlns:a16="http://schemas.microsoft.com/office/drawing/2014/main" id="{1FB4908D-AFC9-4FA4-B124-BAAB37E7BB0D}"/>
               </a:ext>
             </a:extLst>
           </p:cNvPr>
@@ -19809,7 +19809,7 @@
           <p:cNvPr id="19" name="">
             <a:extLst xmlns:a="http://schemas.openxmlformats.org/drawingml/2006/main">
               <a:ext uri="{FF2B5EF4-FFF2-40B4-BE49-F238E27FC236}">
-                <a16:creationId xmlns:a16="http://schemas.microsoft.com/office/drawing/2014/main" id="{F6ECA249-AD84-41FB-ABD4-4CFBC36F2976}"/>
+                <a16:creationId xmlns:a16="http://schemas.microsoft.com/office/drawing/2014/main" id="{A57F2E6E-5167-471E-9F01-14B11B4F4353}"/>
               </a:ext>
             </a:extLst>
           </p:cNvPr>
@@ -19966,7 +19966,7 @@
           <p:cNvPr id="20" name="">
             <a:extLst xmlns:a="http://schemas.openxmlformats.org/drawingml/2006/main">
               <a:ext uri="{FF2B5EF4-FFF2-40B4-BE49-F238E27FC236}">
-                <a16:creationId xmlns:a16="http://schemas.microsoft.com/office/drawing/2014/main" id="{A776EAFA-669D-4683-A846-0B6C78F78990}"/>
+                <a16:creationId xmlns:a16="http://schemas.microsoft.com/office/drawing/2014/main" id="{9FB8E4FC-111D-46C7-996E-EBC01870D415}"/>
               </a:ext>
             </a:extLst>
           </p:cNvPr>
@@ -20123,7 +20123,7 @@
           <p:cNvPr id="21" name="">
             <a:extLst xmlns:a="http://schemas.openxmlformats.org/drawingml/2006/main">
               <a:ext uri="{FF2B5EF4-FFF2-40B4-BE49-F238E27FC236}">
-                <a16:creationId xmlns:a16="http://schemas.microsoft.com/office/drawing/2014/main" id="{4A8E322E-770D-476D-B67A-AC7E557FBEC8}"/>
+                <a16:creationId xmlns:a16="http://schemas.microsoft.com/office/drawing/2014/main" id="{028760A6-4088-4C89-BE30-6F54C86F40EA}"/>
               </a:ext>
             </a:extLst>
           </p:cNvPr>
@@ -20278,7 +20278,7 @@
     </p:spTree>
     <p:extLst>
       <p:ext uri="{BB962C8B-B14F-4D97-AF65-F5344CB8AC3E}">
-        <p14:creationId xmlns:p14="http://schemas.microsoft.com/office/powerpoint/2010/main" val="2060873633"/>
+        <p14:creationId xmlns:p14="http://schemas.microsoft.com/office/powerpoint/2010/main" val="477139536"/>
       </p:ext>
     </p:extLst>
   </p:cSld>
@@ -20309,7 +20309,7 @@
           <p:cNvPr id="9" name="">
             <a:extLst xmlns:a="http://schemas.openxmlformats.org/drawingml/2006/main">
               <a:ext uri="{FF2B5EF4-FFF2-40B4-BE49-F238E27FC236}">
-                <a16:creationId xmlns:a16="http://schemas.microsoft.com/office/drawing/2014/main" id="{99A2C3C1-09B1-4DAE-BFFF-4AC8C1F52C49}"/>
+                <a16:creationId xmlns:a16="http://schemas.microsoft.com/office/drawing/2014/main" id="{7F5514F3-8FC6-4CE1-BEF9-609D044E059E}"/>
               </a:ext>
             </a:extLst>
           </p:cNvPr>
@@ -20466,7 +20466,7 @@
           <p:cNvPr id="2" name="">
             <a:extLst xmlns:a="http://schemas.openxmlformats.org/drawingml/2006/main">
               <a:ext uri="{FF2B5EF4-FFF2-40B4-BE49-F238E27FC236}">
-                <a16:creationId xmlns:a16="http://schemas.microsoft.com/office/drawing/2014/main" id="{F5B4FA86-9103-4702-8452-4A7FC716B3DA}"/>
+                <a16:creationId xmlns:a16="http://schemas.microsoft.com/office/drawing/2014/main" id="{F9ADA627-4962-43BB-98E4-7374B9EAAC27}"/>
               </a:ext>
             </a:extLst>
           </p:cNvPr>
@@ -20497,7 +20497,7 @@
           <p:cNvPr id="3" name="">
             <a:extLst xmlns:a="http://schemas.openxmlformats.org/drawingml/2006/main">
               <a:ext uri="{FF2B5EF4-FFF2-40B4-BE49-F238E27FC236}">
-                <a16:creationId xmlns:a16="http://schemas.microsoft.com/office/drawing/2014/main" id="{F117FDF5-2730-4637-A74B-77F6CC3AABF8}"/>
+                <a16:creationId xmlns:a16="http://schemas.microsoft.com/office/drawing/2014/main" id="{1AD2A69A-6D2A-4AB9-9C18-0556BAE46724}"/>
               </a:ext>
             </a:extLst>
           </p:cNvPr>
@@ -20654,7 +20654,7 @@
           <p:cNvPr id="4" name="Chart">
             <a:extLst xmlns:a="http://schemas.openxmlformats.org/drawingml/2006/main">
               <a:ext uri="{FF2B5EF4-FFF2-40B4-BE49-F238E27FC236}">
-                <a16:creationId xmlns:a16="http://schemas.microsoft.com/office/drawing/2014/main" id="{3F03A1D2-6113-40AB-A694-5FB55765AFC1}"/>
+                <a16:creationId xmlns:a16="http://schemas.microsoft.com/office/drawing/2014/main" id="{50041597-BCD4-400F-BD2C-A1FF41C2B8C9}"/>
               </a:ext>
             </a:extLst>
           </p:cNvPr>
@@ -20667,7 +20667,7 @@
         </p:xfrm>
         <a:graphic xmlns:a="http://schemas.openxmlformats.org/drawingml/2006/main">
           <a:graphicData uri="http://schemas.openxmlformats.org/drawingml/2006/chart">
-            <c:chart xmlns:r="http://schemas.openxmlformats.org/officeDocument/2006/relationships" xmlns:c="http://schemas.openxmlformats.org/drawingml/2006/chart" r:id="R78d422211b864cb1"/>
+            <c:chart xmlns:r="http://schemas.openxmlformats.org/officeDocument/2006/relationships" xmlns:c="http://schemas.openxmlformats.org/drawingml/2006/chart" r:id="R4f8a1eeb9bf84bdc"/>
           </a:graphicData>
         </a:graphic>
       </p:graphicFrame>
@@ -20676,7 +20676,7 @@
           <p:cNvPr id="5" name="">
             <a:extLst xmlns:a="http://schemas.openxmlformats.org/drawingml/2006/main">
               <a:ext uri="{FF2B5EF4-FFF2-40B4-BE49-F238E27FC236}">
-                <a16:creationId xmlns:a16="http://schemas.microsoft.com/office/drawing/2014/main" id="{19B0A222-6D83-4C11-BA3C-D3F7E996CB8E}"/>
+                <a16:creationId xmlns:a16="http://schemas.microsoft.com/office/drawing/2014/main" id="{16664D95-A9AA-4E5F-A06F-9186ABED66B2}"/>
               </a:ext>
             </a:extLst>
           </p:cNvPr>
@@ -20833,7 +20833,7 @@
           <p:cNvPr id="6" name="">
             <a:extLst xmlns:a="http://schemas.openxmlformats.org/drawingml/2006/main">
               <a:ext uri="{FF2B5EF4-FFF2-40B4-BE49-F238E27FC236}">
-                <a16:creationId xmlns:a16="http://schemas.microsoft.com/office/drawing/2014/main" id="{9861E300-102C-484A-B85D-7F3DF09B6AE3}"/>
+                <a16:creationId xmlns:a16="http://schemas.microsoft.com/office/drawing/2014/main" id="{B5589F02-8D02-4C82-9F14-AF00C279DF65}"/>
               </a:ext>
             </a:extLst>
           </p:cNvPr>
@@ -21036,7 +21036,7 @@
           <p:cNvPr id="7" name="">
             <a:extLst xmlns:a="http://schemas.openxmlformats.org/drawingml/2006/main">
               <a:ext uri="{FF2B5EF4-FFF2-40B4-BE49-F238E27FC236}">
-                <a16:creationId xmlns:a16="http://schemas.microsoft.com/office/drawing/2014/main" id="{C8F0DE83-02B7-4F40-BB51-B44DB9F3DD27}"/>
+                <a16:creationId xmlns:a16="http://schemas.microsoft.com/office/drawing/2014/main" id="{AAD7C755-7C71-4C1C-865F-EEC46ADD2CB8}"/>
               </a:ext>
             </a:extLst>
           </p:cNvPr>
@@ -21216,7 +21216,7 @@
           <p:cNvPr id="8" name="">
             <a:extLst xmlns:a="http://schemas.openxmlformats.org/drawingml/2006/main">
               <a:ext uri="{FF2B5EF4-FFF2-40B4-BE49-F238E27FC236}">
-                <a16:creationId xmlns:a16="http://schemas.microsoft.com/office/drawing/2014/main" id="{92B98284-2C4C-449C-87A5-A6C93D88B7FC}"/>
+                <a16:creationId xmlns:a16="http://schemas.microsoft.com/office/drawing/2014/main" id="{82D4A88C-3A1C-4BBC-B59F-A92081C9E975}"/>
               </a:ext>
             </a:extLst>
           </p:cNvPr>
@@ -21371,7 +21371,7 @@
     </p:spTree>
     <p:extLst>
       <p:ext uri="{BB962C8B-B14F-4D97-AF65-F5344CB8AC3E}">
-        <p14:creationId xmlns:p14="http://schemas.microsoft.com/office/powerpoint/2010/main" val="2095766550"/>
+        <p14:creationId xmlns:p14="http://schemas.microsoft.com/office/powerpoint/2010/main" val="2042590800"/>
       </p:ext>
     </p:extLst>
   </p:cSld>
@@ -21399,10 +21399,10 @@
       </p:grpSpPr>
       <p:sp>
         <p:nvSpPr>
-          <p:cNvPr id="27" name="">
+          <p:cNvPr id="28" name="">
             <a:extLst xmlns:a="http://schemas.openxmlformats.org/drawingml/2006/main">
               <a:ext uri="{FF2B5EF4-FFF2-40B4-BE49-F238E27FC236}">
-                <a16:creationId xmlns:a16="http://schemas.microsoft.com/office/drawing/2014/main" id="{1C070339-FDD5-4DD5-AEE3-A9158CB72ED0}"/>
+                <a16:creationId xmlns:a16="http://schemas.microsoft.com/office/drawing/2014/main" id="{1F6F87D8-5156-4B00-B3EF-1CF3A2F2D734}"/>
               </a:ext>
             </a:extLst>
           </p:cNvPr>
@@ -21549,7 +21549,7 @@
                 <a:ea typeface="Arial"/>
                 <a:cs typeface="Arial"/>
               </a:rPr>
-              <a:t>The LLM agent: choose, measure, respond</a:t>
+              <a:t>Agentic selection: working loop + planned routing</a:t>
             </a:r>
           </a:p>
         </p:txBody>
@@ -21559,7 +21559,7 @@
           <p:cNvPr id="2" name="">
             <a:extLst xmlns:a="http://schemas.openxmlformats.org/drawingml/2006/main">
               <a:ext uri="{FF2B5EF4-FFF2-40B4-BE49-F238E27FC236}">
-                <a16:creationId xmlns:a16="http://schemas.microsoft.com/office/drawing/2014/main" id="{20FBDD98-D8A9-49C0-AEE3-3ADA350BDE71}"/>
+                <a16:creationId xmlns:a16="http://schemas.microsoft.com/office/drawing/2014/main" id="{645F72AC-F092-4246-BCB8-A733BD199CA6}"/>
               </a:ext>
             </a:extLst>
           </p:cNvPr>
@@ -21590,7 +21590,7 @@
           <p:cNvPr id="3" name="">
             <a:extLst xmlns:a="http://schemas.openxmlformats.org/drawingml/2006/main">
               <a:ext uri="{FF2B5EF4-FFF2-40B4-BE49-F238E27FC236}">
-                <a16:creationId xmlns:a16="http://schemas.microsoft.com/office/drawing/2014/main" id="{E2F027E2-B71F-4080-9B93-0F57EC079DF5}"/>
+                <a16:creationId xmlns:a16="http://schemas.microsoft.com/office/drawing/2014/main" id="{90D461DC-4710-424A-B01F-6B63E1B19B95}"/>
               </a:ext>
             </a:extLst>
           </p:cNvPr>
@@ -21747,7 +21747,7 @@
           <p:cNvPr id="4" name="">
             <a:extLst xmlns:a="http://schemas.openxmlformats.org/drawingml/2006/main">
               <a:ext uri="{FF2B5EF4-FFF2-40B4-BE49-F238E27FC236}">
-                <a16:creationId xmlns:a16="http://schemas.microsoft.com/office/drawing/2014/main" id="{92FCCF86-2EAF-45F8-A489-69374CBC1F05}"/>
+                <a16:creationId xmlns:a16="http://schemas.microsoft.com/office/drawing/2014/main" id="{8CD81C88-1557-4C74-AD12-5FC6EB0ADD53}"/>
               </a:ext>
             </a:extLst>
           </p:cNvPr>
@@ -21758,7 +21758,164 @@
         </p:nvSpPr>
         <p:spPr>
           <a:xfrm xmlns:a="http://schemas.openxmlformats.org/drawingml/2006/main">
-            <a:off x="685800" y="1771650"/>
+            <a:off x="685800" y="1362075"/>
+            <a:ext cx="8096250" cy="333375"/>
+          </a:xfrm>
+          <a:prstGeom xmlns:a="http://schemas.openxmlformats.org/drawingml/2006/main" prst="rect">
+            <a:avLst/>
+          </a:prstGeom>
+          <a:noFill xmlns:a="http://schemas.openxmlformats.org/drawingml/2006/main"/>
+          <a:ln xmlns:a="http://schemas.openxmlformats.org/drawingml/2006/main" w="0">
+            <a:noFill/>
+            <a:prstDash val="solid"/>
+          </a:ln>
+        </p:spPr>
+        <p:txBody>
+          <a:bodyPr xmlns:a="http://schemas.openxmlformats.org/drawingml/2006/main" lIns="0" tIns="0" rIns="0" bIns="0"/>
+          <a:lstStyle xmlns:a="http://schemas.openxmlformats.org/drawingml/2006/main">
+            <a:defPPr>
+              <a:defRPr sz="1950" b="1">
+                <a:solidFill>
+                  <a:srgbClr val="18856B"/>
+                </a:solidFill>
+                <a:latin typeface="Arial"/>
+                <a:ea typeface="Arial"/>
+                <a:cs typeface="Arial"/>
+              </a:defRPr>
+            </a:defPPr>
+            <a:lvl1pPr>
+              <a:defRPr sz="1950" b="1">
+                <a:solidFill>
+                  <a:srgbClr val="18856B"/>
+                </a:solidFill>
+                <a:latin typeface="Arial"/>
+                <a:ea typeface="Arial"/>
+                <a:cs typeface="Arial"/>
+              </a:defRPr>
+            </a:lvl1pPr>
+            <a:lvl2pPr>
+              <a:defRPr sz="1950" b="1">
+                <a:solidFill>
+                  <a:srgbClr val="18856B"/>
+                </a:solidFill>
+                <a:latin typeface="Arial"/>
+                <a:ea typeface="Arial"/>
+                <a:cs typeface="Arial"/>
+              </a:defRPr>
+            </a:lvl2pPr>
+            <a:lvl3pPr>
+              <a:defRPr sz="1950" b="1">
+                <a:solidFill>
+                  <a:srgbClr val="18856B"/>
+                </a:solidFill>
+                <a:latin typeface="Arial"/>
+                <a:ea typeface="Arial"/>
+                <a:cs typeface="Arial"/>
+              </a:defRPr>
+            </a:lvl3pPr>
+            <a:lvl4pPr>
+              <a:defRPr sz="1950" b="1">
+                <a:solidFill>
+                  <a:srgbClr val="18856B"/>
+                </a:solidFill>
+                <a:latin typeface="Arial"/>
+                <a:ea typeface="Arial"/>
+                <a:cs typeface="Arial"/>
+              </a:defRPr>
+            </a:lvl4pPr>
+            <a:lvl5pPr>
+              <a:defRPr sz="1950" b="1">
+                <a:solidFill>
+                  <a:srgbClr val="18856B"/>
+                </a:solidFill>
+                <a:latin typeface="Arial"/>
+                <a:ea typeface="Arial"/>
+                <a:cs typeface="Arial"/>
+              </a:defRPr>
+            </a:lvl5pPr>
+            <a:lvl6pPr>
+              <a:defRPr sz="1950" b="1">
+                <a:solidFill>
+                  <a:srgbClr val="18856B"/>
+                </a:solidFill>
+                <a:latin typeface="Arial"/>
+                <a:ea typeface="Arial"/>
+                <a:cs typeface="Arial"/>
+              </a:defRPr>
+            </a:lvl6pPr>
+            <a:lvl7pPr>
+              <a:defRPr sz="1950" b="1">
+                <a:solidFill>
+                  <a:srgbClr val="18856B"/>
+                </a:solidFill>
+                <a:latin typeface="Arial"/>
+                <a:ea typeface="Arial"/>
+                <a:cs typeface="Arial"/>
+              </a:defRPr>
+            </a:lvl7pPr>
+            <a:lvl8pPr>
+              <a:defRPr sz="1950" b="1">
+                <a:solidFill>
+                  <a:srgbClr val="18856B"/>
+                </a:solidFill>
+                <a:latin typeface="Arial"/>
+                <a:ea typeface="Arial"/>
+                <a:cs typeface="Arial"/>
+              </a:defRPr>
+            </a:lvl8pPr>
+            <a:lvl9pPr>
+              <a:defRPr sz="1950" b="1">
+                <a:solidFill>
+                  <a:srgbClr val="18856B"/>
+                </a:solidFill>
+                <a:latin typeface="Arial"/>
+                <a:ea typeface="Arial"/>
+                <a:cs typeface="Arial"/>
+              </a:defRPr>
+            </a:lvl9pPr>
+          </a:lstStyle>
+          <a:p xmlns:a="http://schemas.openxmlformats.org/drawingml/2006/main">
+            <a:pPr>
+              <a:defRPr sz="1950" b="1">
+                <a:solidFill>
+                  <a:srgbClr val="18856B"/>
+                </a:solidFill>
+                <a:latin typeface="Arial"/>
+                <a:ea typeface="Arial"/>
+                <a:cs typeface="Arial"/>
+              </a:defRPr>
+            </a:pPr>
+            <a:r>
+              <a:rPr sz="1950" b="1">
+                <a:solidFill>
+                  <a:srgbClr val="18856B"/>
+                </a:solidFill>
+                <a:latin typeface="Arial"/>
+                <a:ea typeface="Arial"/>
+                <a:cs typeface="Arial"/>
+              </a:rPr>
+              <a:t>WORKING  |  Bounded agentic loop</a:t>
+            </a:r>
+          </a:p>
+        </p:txBody>
+      </p:sp>
+      <p:sp>
+        <p:nvSpPr>
+          <p:cNvPr id="5" name="">
+            <a:extLst xmlns:a="http://schemas.openxmlformats.org/drawingml/2006/main">
+              <a:ext uri="{FF2B5EF4-FFF2-40B4-BE49-F238E27FC236}">
+                <a16:creationId xmlns:a16="http://schemas.microsoft.com/office/drawing/2014/main" id="{3AA55555-A058-4EA7-8593-D3CCF11454D8}"/>
+              </a:ext>
+            </a:extLst>
+          </p:cNvPr>
+          <p:cNvSpPr>
+            <a:spLocks xmlns:a="http://schemas.openxmlformats.org/drawingml/2006/main" noGrp="1"/>
+          </p:cNvSpPr>
+          <p:nvPr/>
+        </p:nvSpPr>
+        <p:spPr>
+          <a:xfrm xmlns:a="http://schemas.openxmlformats.org/drawingml/2006/main">
+            <a:off x="685800" y="1809750"/>
             <a:ext cx="2333625" cy="1238250"/>
           </a:xfrm>
           <a:prstGeom xmlns:a="http://schemas.openxmlformats.org/drawingml/2006/main" prst="rect">
@@ -21777,10 +21934,10 @@
       </p:sp>
       <p:sp>
         <p:nvSpPr>
-          <p:cNvPr id="5" name="">
+          <p:cNvPr id="6" name="">
             <a:extLst xmlns:a="http://schemas.openxmlformats.org/drawingml/2006/main">
               <a:ext uri="{FF2B5EF4-FFF2-40B4-BE49-F238E27FC236}">
-                <a16:creationId xmlns:a16="http://schemas.microsoft.com/office/drawing/2014/main" id="{3DFDC9A3-CA39-46C2-9420-317799A4E73A}"/>
+                <a16:creationId xmlns:a16="http://schemas.microsoft.com/office/drawing/2014/main" id="{5144366A-615E-4FD0-A220-F89A9578651A}"/>
               </a:ext>
             </a:extLst>
           </p:cNvPr>
@@ -21791,7 +21948,7 @@
         </p:nvSpPr>
         <p:spPr>
           <a:xfrm xmlns:a="http://schemas.openxmlformats.org/drawingml/2006/main">
-            <a:off x="819150" y="1905000"/>
+            <a:off x="819150" y="1943100"/>
             <a:ext cx="2066925" cy="361950"/>
           </a:xfrm>
           <a:prstGeom xmlns:a="http://schemas.openxmlformats.org/drawingml/2006/main" prst="rect">
@@ -21934,10 +22091,10 @@
       </p:sp>
       <p:sp>
         <p:nvSpPr>
-          <p:cNvPr id="6" name="">
+          <p:cNvPr id="7" name="">
             <a:extLst xmlns:a="http://schemas.openxmlformats.org/drawingml/2006/main">
               <a:ext uri="{FF2B5EF4-FFF2-40B4-BE49-F238E27FC236}">
-                <a16:creationId xmlns:a16="http://schemas.microsoft.com/office/drawing/2014/main" id="{6910CD06-DF64-4F81-A7F5-07C611801B55}"/>
+                <a16:creationId xmlns:a16="http://schemas.microsoft.com/office/drawing/2014/main" id="{E3CFB900-E239-43AF-B508-EBAA32AC901D}"/>
               </a:ext>
             </a:extLst>
           </p:cNvPr>
@@ -21948,7 +22105,7 @@
         </p:nvSpPr>
         <p:spPr>
           <a:xfrm xmlns:a="http://schemas.openxmlformats.org/drawingml/2006/main">
-            <a:off x="819150" y="2314575"/>
+            <a:off x="819150" y="2352675"/>
             <a:ext cx="2066925" cy="619125"/>
           </a:xfrm>
           <a:prstGeom xmlns:a="http://schemas.openxmlformats.org/drawingml/2006/main" prst="rect">
@@ -22084,7 +22241,7 @@
                 <a:ea typeface="Arial"/>
                 <a:cs typeface="Arial"/>
               </a:rPr>
-              <a:t>Legal candidates</a:t>
+              <a:t>Candidates +</a:t>
             </a:r>
           </a:p>
           <a:p xmlns:a="http://schemas.openxmlformats.org/drawingml/2006/main">
@@ -22107,17 +22264,17 @@
                 <a:ea typeface="Arial"/>
                 <a:cs typeface="Arial"/>
               </a:rPr>
-              <a:t>+ constraints</a:t>
+              <a:t>constraints</a:t>
             </a:r>
           </a:p>
         </p:txBody>
       </p:sp>
       <p:sp>
         <p:nvSpPr>
-          <p:cNvPr id="7" name="">
+          <p:cNvPr id="8" name="">
             <a:extLst xmlns:a="http://schemas.openxmlformats.org/drawingml/2006/main">
               <a:ext uri="{FF2B5EF4-FFF2-40B4-BE49-F238E27FC236}">
-                <a16:creationId xmlns:a16="http://schemas.microsoft.com/office/drawing/2014/main" id="{DBED5E7C-201D-4724-8113-040B69FE2008}"/>
+                <a16:creationId xmlns:a16="http://schemas.microsoft.com/office/drawing/2014/main" id="{7F8D4179-B94A-445D-8945-BBC4D8C32674}"/>
               </a:ext>
             </a:extLst>
           </p:cNvPr>
@@ -22128,7 +22285,7 @@
         </p:nvSpPr>
         <p:spPr>
           <a:xfrm xmlns:a="http://schemas.openxmlformats.org/drawingml/2006/main">
-            <a:off x="3105150" y="2276475"/>
+            <a:off x="3105150" y="2314575"/>
             <a:ext cx="285750" cy="228600"/>
           </a:xfrm>
           <a:prstGeom xmlns:a="http://schemas.openxmlformats.org/drawingml/2006/main" prst="rightArrow">
@@ -22145,10 +22302,10 @@
       </p:sp>
       <p:sp>
         <p:nvSpPr>
-          <p:cNvPr id="8" name="">
+          <p:cNvPr id="9" name="">
             <a:extLst xmlns:a="http://schemas.openxmlformats.org/drawingml/2006/main">
               <a:ext uri="{FF2B5EF4-FFF2-40B4-BE49-F238E27FC236}">
-                <a16:creationId xmlns:a16="http://schemas.microsoft.com/office/drawing/2014/main" id="{888568F5-D854-44CC-AF66-877E740EA3C1}"/>
+                <a16:creationId xmlns:a16="http://schemas.microsoft.com/office/drawing/2014/main" id="{B22B1B9C-0D19-4753-88FE-7F806BFC4155}"/>
               </a:ext>
             </a:extLst>
           </p:cNvPr>
@@ -22159,7 +22316,7 @@
         </p:nvSpPr>
         <p:spPr>
           <a:xfrm xmlns:a="http://schemas.openxmlformats.org/drawingml/2006/main">
-            <a:off x="3476625" y="1771650"/>
+            <a:off x="3476625" y="1809750"/>
             <a:ext cx="2333625" cy="1238250"/>
           </a:xfrm>
           <a:prstGeom xmlns:a="http://schemas.openxmlformats.org/drawingml/2006/main" prst="rect">
@@ -22178,10 +22335,10 @@
       </p:sp>
       <p:sp>
         <p:nvSpPr>
-          <p:cNvPr id="9" name="">
+          <p:cNvPr id="10" name="">
             <a:extLst xmlns:a="http://schemas.openxmlformats.org/drawingml/2006/main">
               <a:ext uri="{FF2B5EF4-FFF2-40B4-BE49-F238E27FC236}">
-                <a16:creationId xmlns:a16="http://schemas.microsoft.com/office/drawing/2014/main" id="{0A85EEEE-912E-444B-A11E-351B9CC66C95}"/>
+                <a16:creationId xmlns:a16="http://schemas.microsoft.com/office/drawing/2014/main" id="{3B90B13F-F785-41BA-BEC6-95EF418E8C6E}"/>
               </a:ext>
             </a:extLst>
           </p:cNvPr>
@@ -22192,7 +22349,7 @@
         </p:nvSpPr>
         <p:spPr>
           <a:xfrm xmlns:a="http://schemas.openxmlformats.org/drawingml/2006/main">
-            <a:off x="3609975" y="1905000"/>
+            <a:off x="3609975" y="1943100"/>
             <a:ext cx="2066925" cy="361950"/>
           </a:xfrm>
           <a:prstGeom xmlns:a="http://schemas.openxmlformats.org/drawingml/2006/main" prst="rect">
@@ -22335,10 +22492,10 @@
       </p:sp>
       <p:sp>
         <p:nvSpPr>
-          <p:cNvPr id="10" name="">
+          <p:cNvPr id="11" name="">
             <a:extLst xmlns:a="http://schemas.openxmlformats.org/drawingml/2006/main">
               <a:ext uri="{FF2B5EF4-FFF2-40B4-BE49-F238E27FC236}">
-                <a16:creationId xmlns:a16="http://schemas.microsoft.com/office/drawing/2014/main" id="{080754D2-AFAA-4D5F-A127-39EC35772DE2}"/>
+                <a16:creationId xmlns:a16="http://schemas.microsoft.com/office/drawing/2014/main" id="{2AE23380-326C-45B3-AC66-80BAA6D79D97}"/>
               </a:ext>
             </a:extLst>
           </p:cNvPr>
@@ -22349,7 +22506,7 @@
         </p:nvSpPr>
         <p:spPr>
           <a:xfrm xmlns:a="http://schemas.openxmlformats.org/drawingml/2006/main">
-            <a:off x="3609975" y="2314575"/>
+            <a:off x="3609975" y="2352675"/>
             <a:ext cx="2066925" cy="619125"/>
           </a:xfrm>
           <a:prstGeom xmlns:a="http://schemas.openxmlformats.org/drawingml/2006/main" prst="rect">
@@ -22485,7 +22642,7 @@
                 <a:ea typeface="Arial"/>
                 <a:cs typeface="Arial"/>
               </a:rPr>
-              <a:t>ML scores</a:t>
+              <a:t>XGBoost score</a:t>
             </a:r>
           </a:p>
           <a:p xmlns:a="http://schemas.openxmlformats.org/drawingml/2006/main">
@@ -22508,17 +22665,17 @@
                 <a:ea typeface="Arial"/>
                 <a:cs typeface="Arial"/>
               </a:rPr>
-              <a:t>+ model diagnostics</a:t>
+              <a:t>+ diagnostics</a:t>
             </a:r>
           </a:p>
         </p:txBody>
       </p:sp>
       <p:sp>
         <p:nvSpPr>
-          <p:cNvPr id="11" name="">
+          <p:cNvPr id="12" name="">
             <a:extLst xmlns:a="http://schemas.openxmlformats.org/drawingml/2006/main">
               <a:ext uri="{FF2B5EF4-FFF2-40B4-BE49-F238E27FC236}">
-                <a16:creationId xmlns:a16="http://schemas.microsoft.com/office/drawing/2014/main" id="{32088BF2-C3C5-4CB4-BBC3-3EBD59308A32}"/>
+                <a16:creationId xmlns:a16="http://schemas.microsoft.com/office/drawing/2014/main" id="{474A0469-5D53-4B2D-B6D3-B19B04E3258E}"/>
               </a:ext>
             </a:extLst>
           </p:cNvPr>
@@ -22529,7 +22686,7 @@
         </p:nvSpPr>
         <p:spPr>
           <a:xfrm xmlns:a="http://schemas.openxmlformats.org/drawingml/2006/main">
-            <a:off x="5895975" y="2276475"/>
+            <a:off x="5895975" y="2314575"/>
             <a:ext cx="285750" cy="228600"/>
           </a:xfrm>
           <a:prstGeom xmlns:a="http://schemas.openxmlformats.org/drawingml/2006/main" prst="rightArrow">
@@ -22546,10 +22703,10 @@
       </p:sp>
       <p:sp>
         <p:nvSpPr>
-          <p:cNvPr id="12" name="">
+          <p:cNvPr id="13" name="">
             <a:extLst xmlns:a="http://schemas.openxmlformats.org/drawingml/2006/main">
               <a:ext uri="{FF2B5EF4-FFF2-40B4-BE49-F238E27FC236}">
-                <a16:creationId xmlns:a16="http://schemas.microsoft.com/office/drawing/2014/main" id="{D18F98F1-33E1-497C-BE2E-7C9E1D4B0252}"/>
+                <a16:creationId xmlns:a16="http://schemas.microsoft.com/office/drawing/2014/main" id="{E0D97C5A-7EFA-44F6-9D7A-6064EE127CEF}"/>
               </a:ext>
             </a:extLst>
           </p:cNvPr>
@@ -22560,7 +22717,7 @@
         </p:nvSpPr>
         <p:spPr>
           <a:xfrm xmlns:a="http://schemas.openxmlformats.org/drawingml/2006/main">
-            <a:off x="6267450" y="1771650"/>
+            <a:off x="6267450" y="1809750"/>
             <a:ext cx="2333625" cy="1238250"/>
           </a:xfrm>
           <a:prstGeom xmlns:a="http://schemas.openxmlformats.org/drawingml/2006/main" prst="rect">
@@ -22579,10 +22736,10 @@
       </p:sp>
       <p:sp>
         <p:nvSpPr>
-          <p:cNvPr id="13" name="">
+          <p:cNvPr id="14" name="">
             <a:extLst xmlns:a="http://schemas.openxmlformats.org/drawingml/2006/main">
               <a:ext uri="{FF2B5EF4-FFF2-40B4-BE49-F238E27FC236}">
-                <a16:creationId xmlns:a16="http://schemas.microsoft.com/office/drawing/2014/main" id="{E238FC24-195C-4CAA-878F-CE8AC6367B8F}"/>
+                <a16:creationId xmlns:a16="http://schemas.microsoft.com/office/drawing/2014/main" id="{9CA856A7-ECAB-4A7C-AA99-8D039714E90D}"/>
               </a:ext>
             </a:extLst>
           </p:cNvPr>
@@ -22593,7 +22750,7 @@
         </p:nvSpPr>
         <p:spPr>
           <a:xfrm xmlns:a="http://schemas.openxmlformats.org/drawingml/2006/main">
-            <a:off x="6400800" y="1905000"/>
+            <a:off x="6400800" y="1943100"/>
             <a:ext cx="2066925" cy="361950"/>
           </a:xfrm>
           <a:prstGeom xmlns:a="http://schemas.openxmlformats.org/drawingml/2006/main" prst="rect">
@@ -22736,10 +22893,10 @@
       </p:sp>
       <p:sp>
         <p:nvSpPr>
-          <p:cNvPr id="14" name="">
+          <p:cNvPr id="15" name="">
             <a:extLst xmlns:a="http://schemas.openxmlformats.org/drawingml/2006/main">
               <a:ext uri="{FF2B5EF4-FFF2-40B4-BE49-F238E27FC236}">
-                <a16:creationId xmlns:a16="http://schemas.microsoft.com/office/drawing/2014/main" id="{B4A02D1B-E67B-47E9-B28A-DD0BDE6E900D}"/>
+                <a16:creationId xmlns:a16="http://schemas.microsoft.com/office/drawing/2014/main" id="{DFC213C7-9A50-47A3-94F3-5313D97B12AF}"/>
               </a:ext>
             </a:extLst>
           </p:cNvPr>
@@ -22750,7 +22907,7 @@
         </p:nvSpPr>
         <p:spPr>
           <a:xfrm xmlns:a="http://schemas.openxmlformats.org/drawingml/2006/main">
-            <a:off x="6400800" y="2314575"/>
+            <a:off x="6400800" y="2352675"/>
             <a:ext cx="2066925" cy="619125"/>
           </a:xfrm>
           <a:prstGeom xmlns:a="http://schemas.openxmlformats.org/drawingml/2006/main" prst="rect">
@@ -22886,7 +23043,7 @@
                 <a:ea typeface="Arial"/>
                 <a:cs typeface="Arial"/>
               </a:rPr>
-              <a:t>One charged attempt</a:t>
+              <a:t>Pay one attempt;</a:t>
             </a:r>
           </a:p>
           <a:p xmlns:a="http://schemas.openxmlformats.org/drawingml/2006/main">
@@ -22909,17 +23066,17 @@
                 <a:ea typeface="Arial"/>
                 <a:cs typeface="Arial"/>
               </a:rPr>
-              <a:t>Reveal real outcome</a:t>
+              <a:t>verify outcome</a:t>
             </a:r>
           </a:p>
         </p:txBody>
       </p:sp>
       <p:sp>
         <p:nvSpPr>
-          <p:cNvPr id="15" name="">
+          <p:cNvPr id="16" name="">
             <a:extLst xmlns:a="http://schemas.openxmlformats.org/drawingml/2006/main">
               <a:ext uri="{FF2B5EF4-FFF2-40B4-BE49-F238E27FC236}">
-                <a16:creationId xmlns:a16="http://schemas.microsoft.com/office/drawing/2014/main" id="{07CC5D44-B2EA-49BB-B41F-CC81E7844A76}"/>
+                <a16:creationId xmlns:a16="http://schemas.microsoft.com/office/drawing/2014/main" id="{84694FA6-683B-4C5F-B040-24088EC6F520}"/>
               </a:ext>
             </a:extLst>
           </p:cNvPr>
@@ -22930,7 +23087,7 @@
         </p:nvSpPr>
         <p:spPr>
           <a:xfrm xmlns:a="http://schemas.openxmlformats.org/drawingml/2006/main">
-            <a:off x="8686800" y="2276475"/>
+            <a:off x="8686800" y="2314575"/>
             <a:ext cx="285750" cy="228600"/>
           </a:xfrm>
           <a:prstGeom xmlns:a="http://schemas.openxmlformats.org/drawingml/2006/main" prst="rightArrow">
@@ -22947,10 +23104,10 @@
       </p:sp>
       <p:sp>
         <p:nvSpPr>
-          <p:cNvPr id="16" name="">
+          <p:cNvPr id="17" name="">
             <a:extLst xmlns:a="http://schemas.openxmlformats.org/drawingml/2006/main">
               <a:ext uri="{FF2B5EF4-FFF2-40B4-BE49-F238E27FC236}">
-                <a16:creationId xmlns:a16="http://schemas.microsoft.com/office/drawing/2014/main" id="{29C4E65C-9F1A-41EE-9CD3-FE6D2CD70C94}"/>
+                <a16:creationId xmlns:a16="http://schemas.microsoft.com/office/drawing/2014/main" id="{856A03AA-D39F-4A81-8FDA-FF400BA121B4}"/>
               </a:ext>
             </a:extLst>
           </p:cNvPr>
@@ -22961,7 +23118,7 @@
         </p:nvSpPr>
         <p:spPr>
           <a:xfrm xmlns:a="http://schemas.openxmlformats.org/drawingml/2006/main">
-            <a:off x="9058275" y="1771650"/>
+            <a:off x="9058275" y="1809750"/>
             <a:ext cx="2333625" cy="1238250"/>
           </a:xfrm>
           <a:prstGeom xmlns:a="http://schemas.openxmlformats.org/drawingml/2006/main" prst="rect">
@@ -22980,10 +23137,10 @@
       </p:sp>
       <p:sp>
         <p:nvSpPr>
-          <p:cNvPr id="17" name="">
+          <p:cNvPr id="18" name="">
             <a:extLst xmlns:a="http://schemas.openxmlformats.org/drawingml/2006/main">
               <a:ext uri="{FF2B5EF4-FFF2-40B4-BE49-F238E27FC236}">
-                <a16:creationId xmlns:a16="http://schemas.microsoft.com/office/drawing/2014/main" id="{3F51BE7F-3A47-493C-BB6D-B328EE149B04}"/>
+                <a16:creationId xmlns:a16="http://schemas.microsoft.com/office/drawing/2014/main" id="{EAF482B6-E189-402B-B256-78343339B92E}"/>
               </a:ext>
             </a:extLst>
           </p:cNvPr>
@@ -22994,7 +23151,7 @@
         </p:nvSpPr>
         <p:spPr>
           <a:xfrm xmlns:a="http://schemas.openxmlformats.org/drawingml/2006/main">
-            <a:off x="9191625" y="1905000"/>
+            <a:off x="9191625" y="1943100"/>
             <a:ext cx="2066925" cy="361950"/>
           </a:xfrm>
           <a:prstGeom xmlns:a="http://schemas.openxmlformats.org/drawingml/2006/main" prst="rect">
@@ -23130,17 +23287,17 @@
                 <a:ea typeface="Arial"/>
                 <a:cs typeface="Arial"/>
               </a:rPr>
-              <a:t>Select</a:t>
+              <a:t>Finalize</a:t>
             </a:r>
           </a:p>
         </p:txBody>
       </p:sp>
       <p:sp>
         <p:nvSpPr>
-          <p:cNvPr id="18" name="">
+          <p:cNvPr id="19" name="">
             <a:extLst xmlns:a="http://schemas.openxmlformats.org/drawingml/2006/main">
               <a:ext uri="{FF2B5EF4-FFF2-40B4-BE49-F238E27FC236}">
-                <a16:creationId xmlns:a16="http://schemas.microsoft.com/office/drawing/2014/main" id="{270BD70F-C4F6-42B9-A7C2-316AC595F627}"/>
+                <a16:creationId xmlns:a16="http://schemas.microsoft.com/office/drawing/2014/main" id="{24A4BF89-96BD-4FD7-BF20-E5ED2F67F325}"/>
               </a:ext>
             </a:extLst>
           </p:cNvPr>
@@ -23151,7 +23308,7 @@
         </p:nvSpPr>
         <p:spPr>
           <a:xfrm xmlns:a="http://schemas.openxmlformats.org/drawingml/2006/main">
-            <a:off x="9191625" y="2314575"/>
+            <a:off x="9191625" y="2352675"/>
             <a:ext cx="2066925" cy="619125"/>
           </a:xfrm>
           <a:prstGeom xmlns:a="http://schemas.openxmlformats.org/drawingml/2006/main" prst="rect">
@@ -23287,7 +23444,7 @@
                 <a:ea typeface="Arial"/>
                 <a:cs typeface="Arial"/>
               </a:rPr>
-              <a:t>Best verified feasible</a:t>
+              <a:t>Best verified</a:t>
             </a:r>
           </a:p>
           <a:p xmlns:a="http://schemas.openxmlformats.org/drawingml/2006/main">
@@ -23310,17 +23467,17 @@
                 <a:ea typeface="Arial"/>
                 <a:cs typeface="Arial"/>
               </a:rPr>
-              <a:t>result within budget</a:t>
+              <a:t>feasible result</a:t>
             </a:r>
           </a:p>
         </p:txBody>
       </p:sp>
       <p:sp>
         <p:nvSpPr>
-          <p:cNvPr id="19" name="">
+          <p:cNvPr id="20" name="">
             <a:extLst xmlns:a="http://schemas.openxmlformats.org/drawingml/2006/main">
               <a:ext uri="{FF2B5EF4-FFF2-40B4-BE49-F238E27FC236}">
-                <a16:creationId xmlns:a16="http://schemas.microsoft.com/office/drawing/2014/main" id="{E7301ED8-4696-49D9-9330-FCE5A8A258E3}"/>
+                <a16:creationId xmlns:a16="http://schemas.microsoft.com/office/drawing/2014/main" id="{4BACE5E2-AD62-49A3-846D-1D1D14731E58}"/>
               </a:ext>
             </a:extLst>
           </p:cNvPr>
@@ -23331,39 +23488,8 @@
         </p:nvSpPr>
         <p:spPr>
           <a:xfrm xmlns:a="http://schemas.openxmlformats.org/drawingml/2006/main">
-            <a:off x="10477500" y="3286125"/>
-            <a:ext cx="0" cy="333375"/>
-          </a:xfrm>
-          <a:prstGeom xmlns:a="http://schemas.openxmlformats.org/drawingml/2006/main" prst="line">
-            <a:avLst/>
-          </a:prstGeom>
-          <a:noFill xmlns:a="http://schemas.openxmlformats.org/drawingml/2006/main"/>
-          <a:ln xmlns:a="http://schemas.openxmlformats.org/drawingml/2006/main" w="19050">
-            <a:solidFill>
-              <a:srgbClr val="2878A8"/>
-            </a:solidFill>
-            <a:prstDash val="solid"/>
-          </a:ln>
-        </p:spPr>
-      </p:sp>
-      <p:sp>
-        <p:nvSpPr>
-          <p:cNvPr id="20" name="">
-            <a:extLst xmlns:a="http://schemas.openxmlformats.org/drawingml/2006/main">
-              <a:ext uri="{FF2B5EF4-FFF2-40B4-BE49-F238E27FC236}">
-                <a16:creationId xmlns:a16="http://schemas.microsoft.com/office/drawing/2014/main" id="{5DEF512F-FB08-4C2D-A25A-E10F4D325406}"/>
-              </a:ext>
-            </a:extLst>
-          </p:cNvPr>
-          <p:cNvSpPr>
-            <a:spLocks xmlns:a="http://schemas.openxmlformats.org/drawingml/2006/main" noGrp="1"/>
-          </p:cNvSpPr>
-          <p:nvPr/>
-        </p:nvSpPr>
-        <p:spPr>
-          <a:xfrm xmlns:a="http://schemas.openxmlformats.org/drawingml/2006/main">
-            <a:off x="4000500" y="3619500"/>
-            <a:ext cx="6477000" cy="0"/>
+            <a:off x="10363200" y="3086100"/>
+            <a:ext cx="0" cy="219075"/>
           </a:xfrm>
           <a:prstGeom xmlns:a="http://schemas.openxmlformats.org/drawingml/2006/main" prst="line">
             <a:avLst/>
@@ -23382,7 +23508,7 @@
           <p:cNvPr id="21" name="">
             <a:extLst xmlns:a="http://schemas.openxmlformats.org/drawingml/2006/main">
               <a:ext uri="{FF2B5EF4-FFF2-40B4-BE49-F238E27FC236}">
-                <a16:creationId xmlns:a16="http://schemas.microsoft.com/office/drawing/2014/main" id="{2BBAE3C2-0B57-4C28-891D-2F69856C04E4}"/>
+                <a16:creationId xmlns:a16="http://schemas.microsoft.com/office/drawing/2014/main" id="{7B20ED7B-28DA-4037-8D5A-D6E1DC20D4E6}"/>
               </a:ext>
             </a:extLst>
           </p:cNvPr>
@@ -23393,8 +23519,39 @@
         </p:nvSpPr>
         <p:spPr>
           <a:xfrm xmlns:a="http://schemas.openxmlformats.org/drawingml/2006/main">
-            <a:off x="4095750" y="3743325"/>
-            <a:ext cx="6286500" cy="361950"/>
+            <a:off x="3952875" y="3305175"/>
+            <a:ext cx="6410325" cy="0"/>
+          </a:xfrm>
+          <a:prstGeom xmlns:a="http://schemas.openxmlformats.org/drawingml/2006/main" prst="line">
+            <a:avLst/>
+          </a:prstGeom>
+          <a:noFill xmlns:a="http://schemas.openxmlformats.org/drawingml/2006/main"/>
+          <a:ln xmlns:a="http://schemas.openxmlformats.org/drawingml/2006/main" w="19050">
+            <a:solidFill>
+              <a:srgbClr val="2878A8"/>
+            </a:solidFill>
+            <a:prstDash val="solid"/>
+          </a:ln>
+        </p:spPr>
+      </p:sp>
+      <p:sp>
+        <p:nvSpPr>
+          <p:cNvPr id="22" name="">
+            <a:extLst xmlns:a="http://schemas.openxmlformats.org/drawingml/2006/main">
+              <a:ext uri="{FF2B5EF4-FFF2-40B4-BE49-F238E27FC236}">
+                <a16:creationId xmlns:a16="http://schemas.microsoft.com/office/drawing/2014/main" id="{670B2C8B-7F11-4354-80CF-3AE7BA78F915}"/>
+              </a:ext>
+            </a:extLst>
+          </p:cNvPr>
+          <p:cNvSpPr>
+            <a:spLocks xmlns:a="http://schemas.openxmlformats.org/drawingml/2006/main" noGrp="1"/>
+          </p:cNvSpPr>
+          <p:nvPr/>
+        </p:nvSpPr>
+        <p:spPr>
+          <a:xfrm xmlns:a="http://schemas.openxmlformats.org/drawingml/2006/main">
+            <a:off x="4095750" y="3400425"/>
+            <a:ext cx="6667500" cy="323850"/>
           </a:xfrm>
           <a:prstGeom xmlns:a="http://schemas.openxmlformats.org/drawingml/2006/main" prst="rect">
             <a:avLst/>
@@ -23409,7 +23566,7 @@
           <a:bodyPr xmlns:a="http://schemas.openxmlformats.org/drawingml/2006/main" lIns="0" tIns="0" rIns="0" bIns="0"/>
           <a:lstStyle xmlns:a="http://schemas.openxmlformats.org/drawingml/2006/main">
             <a:defPPr>
-              <a:defRPr sz="1800" b="1">
+              <a:defRPr sz="1725" b="1">
                 <a:solidFill>
                   <a:srgbClr val="2878A8"/>
                 </a:solidFill>
@@ -23419,7 +23576,7 @@
               </a:defRPr>
             </a:defPPr>
             <a:lvl1pPr>
-              <a:defRPr sz="1800" b="1">
+              <a:defRPr sz="1725" b="1">
                 <a:solidFill>
                   <a:srgbClr val="2878A8"/>
                 </a:solidFill>
@@ -23429,7 +23586,7 @@
               </a:defRPr>
             </a:lvl1pPr>
             <a:lvl2pPr>
-              <a:defRPr sz="1800" b="1">
+              <a:defRPr sz="1725" b="1">
                 <a:solidFill>
                   <a:srgbClr val="2878A8"/>
                 </a:solidFill>
@@ -23439,7 +23596,7 @@
               </a:defRPr>
             </a:lvl2pPr>
             <a:lvl3pPr>
-              <a:defRPr sz="1800" b="1">
+              <a:defRPr sz="1725" b="1">
                 <a:solidFill>
                   <a:srgbClr val="2878A8"/>
                 </a:solidFill>
@@ -23449,7 +23606,7 @@
               </a:defRPr>
             </a:lvl3pPr>
             <a:lvl4pPr>
-              <a:defRPr sz="1800" b="1">
+              <a:defRPr sz="1725" b="1">
                 <a:solidFill>
                   <a:srgbClr val="2878A8"/>
                 </a:solidFill>
@@ -23459,7 +23616,7 @@
               </a:defRPr>
             </a:lvl4pPr>
             <a:lvl5pPr>
-              <a:defRPr sz="1800" b="1">
+              <a:defRPr sz="1725" b="1">
                 <a:solidFill>
                   <a:srgbClr val="2878A8"/>
                 </a:solidFill>
@@ -23469,7 +23626,7 @@
               </a:defRPr>
             </a:lvl5pPr>
             <a:lvl6pPr>
-              <a:defRPr sz="1800" b="1">
+              <a:defRPr sz="1725" b="1">
                 <a:solidFill>
                   <a:srgbClr val="2878A8"/>
                 </a:solidFill>
@@ -23479,7 +23636,7 @@
               </a:defRPr>
             </a:lvl6pPr>
             <a:lvl7pPr>
-              <a:defRPr sz="1800" b="1">
+              <a:defRPr sz="1725" b="1">
                 <a:solidFill>
                   <a:srgbClr val="2878A8"/>
                 </a:solidFill>
@@ -23489,7 +23646,7 @@
               </a:defRPr>
             </a:lvl7pPr>
             <a:lvl8pPr>
-              <a:defRPr sz="1800" b="1">
+              <a:defRPr sz="1725" b="1">
                 <a:solidFill>
                   <a:srgbClr val="2878A8"/>
                 </a:solidFill>
@@ -23499,7 +23656,7 @@
               </a:defRPr>
             </a:lvl8pPr>
             <a:lvl9pPr>
-              <a:defRPr sz="1800" b="1">
+              <a:defRPr sz="1725" b="1">
                 <a:solidFill>
                   <a:srgbClr val="2878A8"/>
                 </a:solidFill>
@@ -23511,7 +23668,7 @@
           </a:lstStyle>
           <a:p xmlns:a="http://schemas.openxmlformats.org/drawingml/2006/main">
             <a:pPr>
-              <a:defRPr sz="1800" b="1">
+              <a:defRPr sz="1725" b="1">
                 <a:solidFill>
                   <a:srgbClr val="2878A8"/>
                 </a:solidFill>
@@ -23521,7 +23678,7 @@
               </a:defRPr>
             </a:pPr>
             <a:r>
-              <a:rPr sz="1800" b="1">
+              <a:rPr sz="1725" b="1">
                 <a:solidFill>
                   <a:srgbClr val="2878A8"/>
                 </a:solidFill>
@@ -23529,17 +23686,17 @@
                 <a:ea typeface="Arial"/>
                 <a:cs typeface="Arial"/>
               </a:rPr>
-              <a:t>Paid outcomes inform the next query</a:t>
+              <a:t>Paid outcomes inform the next decision</a:t>
             </a:r>
           </a:p>
         </p:txBody>
       </p:sp>
       <p:sp>
         <p:nvSpPr>
-          <p:cNvPr id="22" name="">
+          <p:cNvPr id="23" name="">
             <a:extLst xmlns:a="http://schemas.openxmlformats.org/drawingml/2006/main">
               <a:ext uri="{FF2B5EF4-FFF2-40B4-BE49-F238E27FC236}">
-                <a16:creationId xmlns:a16="http://schemas.microsoft.com/office/drawing/2014/main" id="{F8BB49E1-6D19-45A3-94E8-88C4B35F6B09}"/>
+                <a16:creationId xmlns:a16="http://schemas.microsoft.com/office/drawing/2014/main" id="{B0EE5137-1136-4853-9266-322624EF39A2}"/>
               </a:ext>
             </a:extLst>
           </p:cNvPr>
@@ -23550,8 +23707,39 @@
         </p:nvSpPr>
         <p:spPr>
           <a:xfrm xmlns:a="http://schemas.openxmlformats.org/drawingml/2006/main">
-            <a:off x="685800" y="4410075"/>
-            <a:ext cx="4667250" cy="361950"/>
+            <a:off x="685800" y="3914775"/>
+            <a:ext cx="10820400" cy="0"/>
+          </a:xfrm>
+          <a:prstGeom xmlns:a="http://schemas.openxmlformats.org/drawingml/2006/main" prst="line">
+            <a:avLst/>
+          </a:prstGeom>
+          <a:noFill xmlns:a="http://schemas.openxmlformats.org/drawingml/2006/main"/>
+          <a:ln xmlns:a="http://schemas.openxmlformats.org/drawingml/2006/main" w="9525">
+            <a:solidFill>
+              <a:srgbClr val="D9E1E8"/>
+            </a:solidFill>
+            <a:prstDash val="solid"/>
+          </a:ln>
+        </p:spPr>
+      </p:sp>
+      <p:sp>
+        <p:nvSpPr>
+          <p:cNvPr id="24" name="">
+            <a:extLst xmlns:a="http://schemas.openxmlformats.org/drawingml/2006/main">
+              <a:ext uri="{FF2B5EF4-FFF2-40B4-BE49-F238E27FC236}">
+                <a16:creationId xmlns:a16="http://schemas.microsoft.com/office/drawing/2014/main" id="{41462B26-B4FE-470C-9468-339482C2C499}"/>
+              </a:ext>
+            </a:extLst>
+          </p:cNvPr>
+          <p:cNvSpPr>
+            <a:spLocks xmlns:a="http://schemas.openxmlformats.org/drawingml/2006/main" noGrp="1"/>
+          </p:cNvSpPr>
+          <p:nvPr/>
+        </p:nvSpPr>
+        <p:spPr>
+          <a:xfrm xmlns:a="http://schemas.openxmlformats.org/drawingml/2006/main">
+            <a:off x="685800" y="4095750"/>
+            <a:ext cx="7810500" cy="342900"/>
           </a:xfrm>
           <a:prstGeom xmlns:a="http://schemas.openxmlformats.org/drawingml/2006/main" prst="rect">
             <a:avLst/>
@@ -23566,9 +23754,9 @@
           <a:bodyPr xmlns:a="http://schemas.openxmlformats.org/drawingml/2006/main" lIns="0" tIns="0" rIns="0" bIns="0"/>
           <a:lstStyle xmlns:a="http://schemas.openxmlformats.org/drawingml/2006/main">
             <a:defPPr>
-              <a:defRPr sz="2100" b="1">
-                <a:solidFill>
-                  <a:srgbClr val="17324D"/>
+              <a:defRPr sz="1950" b="1">
+                <a:solidFill>
+                  <a:srgbClr val="A65A00"/>
                 </a:solidFill>
                 <a:latin typeface="Arial"/>
                 <a:ea typeface="Arial"/>
@@ -23576,9 +23764,9 @@
               </a:defRPr>
             </a:defPPr>
             <a:lvl1pPr>
-              <a:defRPr sz="2100" b="1">
-                <a:solidFill>
-                  <a:srgbClr val="17324D"/>
+              <a:defRPr sz="1950" b="1">
+                <a:solidFill>
+                  <a:srgbClr val="A65A00"/>
                 </a:solidFill>
                 <a:latin typeface="Arial"/>
                 <a:ea typeface="Arial"/>
@@ -23586,9 +23774,9 @@
               </a:defRPr>
             </a:lvl1pPr>
             <a:lvl2pPr>
-              <a:defRPr sz="2100" b="1">
-                <a:solidFill>
-                  <a:srgbClr val="17324D"/>
+              <a:defRPr sz="1950" b="1">
+                <a:solidFill>
+                  <a:srgbClr val="A65A00"/>
                 </a:solidFill>
                 <a:latin typeface="Arial"/>
                 <a:ea typeface="Arial"/>
@@ -23596,9 +23784,9 @@
               </a:defRPr>
             </a:lvl2pPr>
             <a:lvl3pPr>
-              <a:defRPr sz="2100" b="1">
-                <a:solidFill>
-                  <a:srgbClr val="17324D"/>
+              <a:defRPr sz="1950" b="1">
+                <a:solidFill>
+                  <a:srgbClr val="A65A00"/>
                 </a:solidFill>
                 <a:latin typeface="Arial"/>
                 <a:ea typeface="Arial"/>
@@ -23606,9 +23794,9 @@
               </a:defRPr>
             </a:lvl3pPr>
             <a:lvl4pPr>
-              <a:defRPr sz="2100" b="1">
-                <a:solidFill>
-                  <a:srgbClr val="17324D"/>
+              <a:defRPr sz="1950" b="1">
+                <a:solidFill>
+                  <a:srgbClr val="A65A00"/>
                 </a:solidFill>
                 <a:latin typeface="Arial"/>
                 <a:ea typeface="Arial"/>
@@ -23616,9 +23804,9 @@
               </a:defRPr>
             </a:lvl4pPr>
             <a:lvl5pPr>
-              <a:defRPr sz="2100" b="1">
-                <a:solidFill>
-                  <a:srgbClr val="17324D"/>
+              <a:defRPr sz="1950" b="1">
+                <a:solidFill>
+                  <a:srgbClr val="A65A00"/>
                 </a:solidFill>
                 <a:latin typeface="Arial"/>
                 <a:ea typeface="Arial"/>
@@ -23626,9 +23814,9 @@
               </a:defRPr>
             </a:lvl5pPr>
             <a:lvl6pPr>
-              <a:defRPr sz="2100" b="1">
-                <a:solidFill>
-                  <a:srgbClr val="17324D"/>
+              <a:defRPr sz="1950" b="1">
+                <a:solidFill>
+                  <a:srgbClr val="A65A00"/>
                 </a:solidFill>
                 <a:latin typeface="Arial"/>
                 <a:ea typeface="Arial"/>
@@ -23636,9 +23824,9 @@
               </a:defRPr>
             </a:lvl6pPr>
             <a:lvl7pPr>
-              <a:defRPr sz="2100" b="1">
-                <a:solidFill>
-                  <a:srgbClr val="17324D"/>
+              <a:defRPr sz="1950" b="1">
+                <a:solidFill>
+                  <a:srgbClr val="A65A00"/>
                 </a:solidFill>
                 <a:latin typeface="Arial"/>
                 <a:ea typeface="Arial"/>
@@ -23646,9 +23834,9 @@
               </a:defRPr>
             </a:lvl7pPr>
             <a:lvl8pPr>
-              <a:defRPr sz="2100" b="1">
-                <a:solidFill>
-                  <a:srgbClr val="17324D"/>
+              <a:defRPr sz="1950" b="1">
+                <a:solidFill>
+                  <a:srgbClr val="A65A00"/>
                 </a:solidFill>
                 <a:latin typeface="Arial"/>
                 <a:ea typeface="Arial"/>
@@ -23656,9 +23844,9 @@
               </a:defRPr>
             </a:lvl8pPr>
             <a:lvl9pPr>
-              <a:defRPr sz="2100" b="1">
-                <a:solidFill>
-                  <a:srgbClr val="17324D"/>
+              <a:defRPr sz="1950" b="1">
+                <a:solidFill>
+                  <a:srgbClr val="A65A00"/>
                 </a:solidFill>
                 <a:latin typeface="Arial"/>
                 <a:ea typeface="Arial"/>
@@ -23668,9 +23856,9 @@
           </a:lstStyle>
           <a:p xmlns:a="http://schemas.openxmlformats.org/drawingml/2006/main">
             <a:pPr>
-              <a:defRPr sz="2100" b="1">
-                <a:solidFill>
-                  <a:srgbClr val="17324D"/>
+              <a:defRPr sz="1950" b="1">
+                <a:solidFill>
+                  <a:srgbClr val="A65A00"/>
                 </a:solidFill>
                 <a:latin typeface="Arial"/>
                 <a:ea typeface="Arial"/>
@@ -23678,25 +23866,25 @@
               </a:defRPr>
             </a:pPr>
             <a:r>
-              <a:rPr sz="2100" b="1">
-                <a:solidFill>
-                  <a:srgbClr val="17324D"/>
+              <a:rPr sz="1950" b="1">
+                <a:solidFill>
+                  <a:srgbClr val="A65A00"/>
                 </a:solidFill>
                 <a:latin typeface="Arial"/>
                 <a:ea typeface="Arial"/>
                 <a:cs typeface="Arial"/>
               </a:rPr>
-              <a:t>Selector AI</a:t>
+              <a:t>PLANNED  |  Dynamic LLM routing</a:t>
             </a:r>
           </a:p>
         </p:txBody>
       </p:sp>
       <p:sp>
         <p:nvSpPr>
-          <p:cNvPr id="23" name="">
+          <p:cNvPr id="25" name="">
             <a:extLst xmlns:a="http://schemas.openxmlformats.org/drawingml/2006/main">
               <a:ext uri="{FF2B5EF4-FFF2-40B4-BE49-F238E27FC236}">
-                <a16:creationId xmlns:a16="http://schemas.microsoft.com/office/drawing/2014/main" id="{1118A931-037C-47D7-8150-81ED4EFAD942}"/>
+                <a16:creationId xmlns:a16="http://schemas.microsoft.com/office/drawing/2014/main" id="{DEFCC824-9482-4F68-ACDC-CC7D9EF259FF}"/>
               </a:ext>
             </a:extLst>
           </p:cNvPr>
@@ -23707,8 +23895,165 @@
         </p:nvSpPr>
         <p:spPr>
           <a:xfrm xmlns:a="http://schemas.openxmlformats.org/drawingml/2006/main">
-            <a:off x="685800" y="4886325"/>
-            <a:ext cx="5143500" cy="809625"/>
+            <a:off x="685800" y="4543425"/>
+            <a:ext cx="9906000" cy="381000"/>
+          </a:xfrm>
+          <a:prstGeom xmlns:a="http://schemas.openxmlformats.org/drawingml/2006/main" prst="rect">
+            <a:avLst/>
+          </a:prstGeom>
+          <a:noFill xmlns:a="http://schemas.openxmlformats.org/drawingml/2006/main"/>
+          <a:ln xmlns:a="http://schemas.openxmlformats.org/drawingml/2006/main" w="0">
+            <a:noFill/>
+            <a:prstDash val="solid"/>
+          </a:ln>
+        </p:spPr>
+        <p:txBody>
+          <a:bodyPr xmlns:a="http://schemas.openxmlformats.org/drawingml/2006/main" lIns="0" tIns="0" rIns="0" bIns="0"/>
+          <a:lstStyle xmlns:a="http://schemas.openxmlformats.org/drawingml/2006/main">
+            <a:defPPr>
+              <a:defRPr sz="2025" b="1">
+                <a:solidFill>
+                  <a:srgbClr val="17324D"/>
+                </a:solidFill>
+                <a:latin typeface="Arial"/>
+                <a:ea typeface="Arial"/>
+                <a:cs typeface="Arial"/>
+              </a:defRPr>
+            </a:defPPr>
+            <a:lvl1pPr>
+              <a:defRPr sz="2025" b="1">
+                <a:solidFill>
+                  <a:srgbClr val="17324D"/>
+                </a:solidFill>
+                <a:latin typeface="Arial"/>
+                <a:ea typeface="Arial"/>
+                <a:cs typeface="Arial"/>
+              </a:defRPr>
+            </a:lvl1pPr>
+            <a:lvl2pPr>
+              <a:defRPr sz="2025" b="1">
+                <a:solidFill>
+                  <a:srgbClr val="17324D"/>
+                </a:solidFill>
+                <a:latin typeface="Arial"/>
+                <a:ea typeface="Arial"/>
+                <a:cs typeface="Arial"/>
+              </a:defRPr>
+            </a:lvl2pPr>
+            <a:lvl3pPr>
+              <a:defRPr sz="2025" b="1">
+                <a:solidFill>
+                  <a:srgbClr val="17324D"/>
+                </a:solidFill>
+                <a:latin typeface="Arial"/>
+                <a:ea typeface="Arial"/>
+                <a:cs typeface="Arial"/>
+              </a:defRPr>
+            </a:lvl3pPr>
+            <a:lvl4pPr>
+              <a:defRPr sz="2025" b="1">
+                <a:solidFill>
+                  <a:srgbClr val="17324D"/>
+                </a:solidFill>
+                <a:latin typeface="Arial"/>
+                <a:ea typeface="Arial"/>
+                <a:cs typeface="Arial"/>
+              </a:defRPr>
+            </a:lvl4pPr>
+            <a:lvl5pPr>
+              <a:defRPr sz="2025" b="1">
+                <a:solidFill>
+                  <a:srgbClr val="17324D"/>
+                </a:solidFill>
+                <a:latin typeface="Arial"/>
+                <a:ea typeface="Arial"/>
+                <a:cs typeface="Arial"/>
+              </a:defRPr>
+            </a:lvl5pPr>
+            <a:lvl6pPr>
+              <a:defRPr sz="2025" b="1">
+                <a:solidFill>
+                  <a:srgbClr val="17324D"/>
+                </a:solidFill>
+                <a:latin typeface="Arial"/>
+                <a:ea typeface="Arial"/>
+                <a:cs typeface="Arial"/>
+              </a:defRPr>
+            </a:lvl6pPr>
+            <a:lvl7pPr>
+              <a:defRPr sz="2025" b="1">
+                <a:solidFill>
+                  <a:srgbClr val="17324D"/>
+                </a:solidFill>
+                <a:latin typeface="Arial"/>
+                <a:ea typeface="Arial"/>
+                <a:cs typeface="Arial"/>
+              </a:defRPr>
+            </a:lvl7pPr>
+            <a:lvl8pPr>
+              <a:defRPr sz="2025" b="1">
+                <a:solidFill>
+                  <a:srgbClr val="17324D"/>
+                </a:solidFill>
+                <a:latin typeface="Arial"/>
+                <a:ea typeface="Arial"/>
+                <a:cs typeface="Arial"/>
+              </a:defRPr>
+            </a:lvl8pPr>
+            <a:lvl9pPr>
+              <a:defRPr sz="2025" b="1">
+                <a:solidFill>
+                  <a:srgbClr val="17324D"/>
+                </a:solidFill>
+                <a:latin typeface="Arial"/>
+                <a:ea typeface="Arial"/>
+                <a:cs typeface="Arial"/>
+              </a:defRPr>
+            </a:lvl9pPr>
+          </a:lstStyle>
+          <a:p xmlns:a="http://schemas.openxmlformats.org/drawingml/2006/main">
+            <a:pPr>
+              <a:defRPr sz="2025" b="1">
+                <a:solidFill>
+                  <a:srgbClr val="17324D"/>
+                </a:solidFill>
+                <a:latin typeface="Arial"/>
+                <a:ea typeface="Arial"/>
+                <a:cs typeface="Arial"/>
+              </a:defRPr>
+            </a:pPr>
+            <a:r>
+              <a:rPr sz="2025" b="1">
+                <a:solidFill>
+                  <a:srgbClr val="17324D"/>
+                </a:solidFill>
+                <a:latin typeface="Arial"/>
+                <a:ea typeface="Arial"/>
+                <a:cs typeface="Arial"/>
+              </a:rPr>
+              <a:t>Small model → escalate difficult cases → stronger model</a:t>
+            </a:r>
+          </a:p>
+        </p:txBody>
+      </p:sp>
+      <p:sp>
+        <p:nvSpPr>
+          <p:cNvPr id="26" name="">
+            <a:extLst xmlns:a="http://schemas.openxmlformats.org/drawingml/2006/main">
+              <a:ext uri="{FF2B5EF4-FFF2-40B4-BE49-F238E27FC236}">
+                <a16:creationId xmlns:a16="http://schemas.microsoft.com/office/drawing/2014/main" id="{8F5A3EC3-3C97-417A-815D-9F5BCBE9137A}"/>
+              </a:ext>
+            </a:extLst>
+          </p:cNvPr>
+          <p:cNvSpPr>
+            <a:spLocks xmlns:a="http://schemas.openxmlformats.org/drawingml/2006/main" noGrp="1"/>
+          </p:cNvSpPr>
+          <p:nvPr/>
+        </p:nvSpPr>
+        <p:spPr>
+          <a:xfrm xmlns:a="http://schemas.openxmlformats.org/drawingml/2006/main">
+            <a:off x="685800" y="5057775"/>
+            <a:ext cx="10820400" cy="342900"/>
           </a:xfrm>
           <a:prstGeom xmlns:a="http://schemas.openxmlformats.org/drawingml/2006/main" prst="rect">
             <a:avLst/>
@@ -23843,40 +24188,17 @@
                 <a:ea typeface="Arial"/>
                 <a:cs typeface="Arial"/>
               </a:rPr>
-              <a:t>Ascon pilot: 3 measured candidates</a:t>
-            </a:r>
-          </a:p>
-          <a:p xmlns:a="http://schemas.openxmlformats.org/drawingml/2006/main">
-            <a:pPr>
-              <a:defRPr sz="1875" b="0">
-                <a:solidFill>
-                  <a:srgbClr val="263648"/>
-                </a:solidFill>
-                <a:latin typeface="Arial"/>
-                <a:ea typeface="Arial"/>
-                <a:cs typeface="Arial"/>
-              </a:defRPr>
-            </a:pPr>
-            <a:r>
-              <a:rPr sz="1875" b="0">
-                <a:solidFill>
-                  <a:srgbClr val="263648"/>
-                </a:solidFill>
-                <a:latin typeface="Arial"/>
-                <a:ea typeface="Arial"/>
-                <a:cs typeface="Arial"/>
-              </a:rPr>
-              <a:t>Best feasible: 1.0237×, +42 LUT4</a:t>
+              <a:t>Structured outputs • tool guardrails • bounded context / memory</a:t>
             </a:r>
           </a:p>
         </p:txBody>
       </p:sp>
       <p:sp>
         <p:nvSpPr>
-          <p:cNvPr id="24" name="">
+          <p:cNvPr id="27" name="">
             <a:extLst xmlns:a="http://schemas.openxmlformats.org/drawingml/2006/main">
               <a:ext uri="{FF2B5EF4-FFF2-40B4-BE49-F238E27FC236}">
-                <a16:creationId xmlns:a16="http://schemas.microsoft.com/office/drawing/2014/main" id="{C192BB81-FEF5-4ABC-8894-C448635051E4}"/>
+                <a16:creationId xmlns:a16="http://schemas.microsoft.com/office/drawing/2014/main" id="{A1C0C8EC-A0A1-4C01-ADF7-6C5439EB1503}"/>
               </a:ext>
             </a:extLst>
           </p:cNvPr>
@@ -23887,8 +24209,8 @@
         </p:nvSpPr>
         <p:spPr>
           <a:xfrm xmlns:a="http://schemas.openxmlformats.org/drawingml/2006/main">
-            <a:off x="6572250" y="4410075"/>
-            <a:ext cx="4857750" cy="361950"/>
+            <a:off x="685800" y="5553075"/>
+            <a:ext cx="10820400" cy="428625"/>
           </a:xfrm>
           <a:prstGeom xmlns:a="http://schemas.openxmlformats.org/drawingml/2006/main" prst="rect">
             <a:avLst/>
@@ -23903,9 +24225,9 @@
           <a:bodyPr xmlns:a="http://schemas.openxmlformats.org/drawingml/2006/main" lIns="0" tIns="0" rIns="0" bIns="0"/>
           <a:lstStyle xmlns:a="http://schemas.openxmlformats.org/drawingml/2006/main">
             <a:defPPr>
-              <a:defRPr sz="2100" b="1">
-                <a:solidFill>
-                  <a:srgbClr val="17324D"/>
+              <a:defRPr sz="1725" b="0">
+                <a:solidFill>
+                  <a:srgbClr val="607286"/>
                 </a:solidFill>
                 <a:latin typeface="Arial"/>
                 <a:ea typeface="Arial"/>
@@ -23913,9 +24235,9 @@
               </a:defRPr>
             </a:defPPr>
             <a:lvl1pPr>
-              <a:defRPr sz="2100" b="1">
-                <a:solidFill>
-                  <a:srgbClr val="17324D"/>
+              <a:defRPr sz="1725" b="0">
+                <a:solidFill>
+                  <a:srgbClr val="607286"/>
                 </a:solidFill>
                 <a:latin typeface="Arial"/>
                 <a:ea typeface="Arial"/>
@@ -23923,9 +24245,9 @@
               </a:defRPr>
             </a:lvl1pPr>
             <a:lvl2pPr>
-              <a:defRPr sz="2100" b="1">
-                <a:solidFill>
-                  <a:srgbClr val="17324D"/>
+              <a:defRPr sz="1725" b="0">
+                <a:solidFill>
+                  <a:srgbClr val="607286"/>
                 </a:solidFill>
                 <a:latin typeface="Arial"/>
                 <a:ea typeface="Arial"/>
@@ -23933,9 +24255,9 @@
               </a:defRPr>
             </a:lvl2pPr>
             <a:lvl3pPr>
-              <a:defRPr sz="2100" b="1">
-                <a:solidFill>
-                  <a:srgbClr val="17324D"/>
+              <a:defRPr sz="1725" b="0">
+                <a:solidFill>
+                  <a:srgbClr val="607286"/>
                 </a:solidFill>
                 <a:latin typeface="Arial"/>
                 <a:ea typeface="Arial"/>
@@ -23943,9 +24265,9 @@
               </a:defRPr>
             </a:lvl3pPr>
             <a:lvl4pPr>
-              <a:defRPr sz="2100" b="1">
-                <a:solidFill>
-                  <a:srgbClr val="17324D"/>
+              <a:defRPr sz="1725" b="0">
+                <a:solidFill>
+                  <a:srgbClr val="607286"/>
                 </a:solidFill>
                 <a:latin typeface="Arial"/>
                 <a:ea typeface="Arial"/>
@@ -23953,9 +24275,9 @@
               </a:defRPr>
             </a:lvl4pPr>
             <a:lvl5pPr>
-              <a:defRPr sz="2100" b="1">
-                <a:solidFill>
-                  <a:srgbClr val="17324D"/>
+              <a:defRPr sz="1725" b="0">
+                <a:solidFill>
+                  <a:srgbClr val="607286"/>
                 </a:solidFill>
                 <a:latin typeface="Arial"/>
                 <a:ea typeface="Arial"/>
@@ -23963,9 +24285,9 @@
               </a:defRPr>
             </a:lvl5pPr>
             <a:lvl6pPr>
-              <a:defRPr sz="2100" b="1">
-                <a:solidFill>
-                  <a:srgbClr val="17324D"/>
+              <a:defRPr sz="1725" b="0">
+                <a:solidFill>
+                  <a:srgbClr val="607286"/>
                 </a:solidFill>
                 <a:latin typeface="Arial"/>
                 <a:ea typeface="Arial"/>
@@ -23973,9 +24295,9 @@
               </a:defRPr>
             </a:lvl6pPr>
             <a:lvl7pPr>
-              <a:defRPr sz="2100" b="1">
-                <a:solidFill>
-                  <a:srgbClr val="17324D"/>
+              <a:defRPr sz="1725" b="0">
+                <a:solidFill>
+                  <a:srgbClr val="607286"/>
                 </a:solidFill>
                 <a:latin typeface="Arial"/>
                 <a:ea typeface="Arial"/>
@@ -23983,9 +24305,9 @@
               </a:defRPr>
             </a:lvl7pPr>
             <a:lvl8pPr>
-              <a:defRPr sz="2100" b="1">
-                <a:solidFill>
-                  <a:srgbClr val="17324D"/>
+              <a:defRPr sz="1725" b="0">
+                <a:solidFill>
+                  <a:srgbClr val="607286"/>
                 </a:solidFill>
                 <a:latin typeface="Arial"/>
                 <a:ea typeface="Arial"/>
@@ -23993,9 +24315,9 @@
               </a:defRPr>
             </a:lvl8pPr>
             <a:lvl9pPr>
-              <a:defRPr sz="2100" b="1">
-                <a:solidFill>
-                  <a:srgbClr val="17324D"/>
+              <a:defRPr sz="1725" b="0">
+                <a:solidFill>
+                  <a:srgbClr val="607286"/>
                 </a:solidFill>
                 <a:latin typeface="Arial"/>
                 <a:ea typeface="Arial"/>
@@ -24005,9 +24327,9 @@
           </a:lstStyle>
           <a:p xmlns:a="http://schemas.openxmlformats.org/drawingml/2006/main">
             <a:pPr>
-              <a:defRPr sz="2100" b="1">
-                <a:solidFill>
-                  <a:srgbClr val="17324D"/>
+              <a:defRPr sz="1725" b="0">
+                <a:solidFill>
+                  <a:srgbClr val="607286"/>
                 </a:solidFill>
                 <a:latin typeface="Arial"/>
                 <a:ea typeface="Arial"/>
@@ -24015,352 +24337,15 @@
               </a:defRPr>
             </a:pPr>
             <a:r>
-              <a:rPr sz="2100" b="1">
-                <a:solidFill>
-                  <a:srgbClr val="17324D"/>
+              <a:rPr sz="1725" b="0">
+                <a:solidFill>
+                  <a:srgbClr val="607286"/>
                 </a:solidFill>
                 <a:latin typeface="Arial"/>
                 <a:ea typeface="Arial"/>
                 <a:cs typeface="Arial"/>
               </a:rPr>
-              <a:t>Development AI</a:t>
-            </a:r>
-          </a:p>
-        </p:txBody>
-      </p:sp>
-      <p:sp>
-        <p:nvSpPr>
-          <p:cNvPr id="25" name="">
-            <a:extLst xmlns:a="http://schemas.openxmlformats.org/drawingml/2006/main">
-              <a:ext uri="{FF2B5EF4-FFF2-40B4-BE49-F238E27FC236}">
-                <a16:creationId xmlns:a16="http://schemas.microsoft.com/office/drawing/2014/main" id="{ACE39012-102E-4DB5-B31A-9D0661728009}"/>
-              </a:ext>
-            </a:extLst>
-          </p:cNvPr>
-          <p:cNvSpPr>
-            <a:spLocks xmlns:a="http://schemas.openxmlformats.org/drawingml/2006/main" noGrp="1"/>
-          </p:cNvSpPr>
-          <p:nvPr/>
-        </p:nvSpPr>
-        <p:spPr>
-          <a:xfrm xmlns:a="http://schemas.openxmlformats.org/drawingml/2006/main">
-            <a:off x="6572250" y="4886325"/>
-            <a:ext cx="4857750" cy="809625"/>
-          </a:xfrm>
-          <a:prstGeom xmlns:a="http://schemas.openxmlformats.org/drawingml/2006/main" prst="rect">
-            <a:avLst/>
-          </a:prstGeom>
-          <a:noFill xmlns:a="http://schemas.openxmlformats.org/drawingml/2006/main"/>
-          <a:ln xmlns:a="http://schemas.openxmlformats.org/drawingml/2006/main" w="0">
-            <a:noFill/>
-            <a:prstDash val="solid"/>
-          </a:ln>
-        </p:spPr>
-        <p:txBody>
-          <a:bodyPr xmlns:a="http://schemas.openxmlformats.org/drawingml/2006/main" lIns="0" tIns="0" rIns="0" bIns="0"/>
-          <a:lstStyle xmlns:a="http://schemas.openxmlformats.org/drawingml/2006/main">
-            <a:defPPr>
-              <a:defRPr sz="1800" b="0">
-                <a:solidFill>
-                  <a:srgbClr val="263648"/>
-                </a:solidFill>
-                <a:latin typeface="Arial"/>
-                <a:ea typeface="Arial"/>
-                <a:cs typeface="Arial"/>
-              </a:defRPr>
-            </a:defPPr>
-            <a:lvl1pPr>
-              <a:defRPr sz="1800" b="0">
-                <a:solidFill>
-                  <a:srgbClr val="263648"/>
-                </a:solidFill>
-                <a:latin typeface="Arial"/>
-                <a:ea typeface="Arial"/>
-                <a:cs typeface="Arial"/>
-              </a:defRPr>
-            </a:lvl1pPr>
-            <a:lvl2pPr>
-              <a:defRPr sz="1800" b="0">
-                <a:solidFill>
-                  <a:srgbClr val="263648"/>
-                </a:solidFill>
-                <a:latin typeface="Arial"/>
-                <a:ea typeface="Arial"/>
-                <a:cs typeface="Arial"/>
-              </a:defRPr>
-            </a:lvl2pPr>
-            <a:lvl3pPr>
-              <a:defRPr sz="1800" b="0">
-                <a:solidFill>
-                  <a:srgbClr val="263648"/>
-                </a:solidFill>
-                <a:latin typeface="Arial"/>
-                <a:ea typeface="Arial"/>
-                <a:cs typeface="Arial"/>
-              </a:defRPr>
-            </a:lvl3pPr>
-            <a:lvl4pPr>
-              <a:defRPr sz="1800" b="0">
-                <a:solidFill>
-                  <a:srgbClr val="263648"/>
-                </a:solidFill>
-                <a:latin typeface="Arial"/>
-                <a:ea typeface="Arial"/>
-                <a:cs typeface="Arial"/>
-              </a:defRPr>
-            </a:lvl4pPr>
-            <a:lvl5pPr>
-              <a:defRPr sz="1800" b="0">
-                <a:solidFill>
-                  <a:srgbClr val="263648"/>
-                </a:solidFill>
-                <a:latin typeface="Arial"/>
-                <a:ea typeface="Arial"/>
-                <a:cs typeface="Arial"/>
-              </a:defRPr>
-            </a:lvl5pPr>
-            <a:lvl6pPr>
-              <a:defRPr sz="1800" b="0">
-                <a:solidFill>
-                  <a:srgbClr val="263648"/>
-                </a:solidFill>
-                <a:latin typeface="Arial"/>
-                <a:ea typeface="Arial"/>
-                <a:cs typeface="Arial"/>
-              </a:defRPr>
-            </a:lvl6pPr>
-            <a:lvl7pPr>
-              <a:defRPr sz="1800" b="0">
-                <a:solidFill>
-                  <a:srgbClr val="263648"/>
-                </a:solidFill>
-                <a:latin typeface="Arial"/>
-                <a:ea typeface="Arial"/>
-                <a:cs typeface="Arial"/>
-              </a:defRPr>
-            </a:lvl7pPr>
-            <a:lvl8pPr>
-              <a:defRPr sz="1800" b="0">
-                <a:solidFill>
-                  <a:srgbClr val="263648"/>
-                </a:solidFill>
-                <a:latin typeface="Arial"/>
-                <a:ea typeface="Arial"/>
-                <a:cs typeface="Arial"/>
-              </a:defRPr>
-            </a:lvl8pPr>
-            <a:lvl9pPr>
-              <a:defRPr sz="1800" b="0">
-                <a:solidFill>
-                  <a:srgbClr val="263648"/>
-                </a:solidFill>
-                <a:latin typeface="Arial"/>
-                <a:ea typeface="Arial"/>
-                <a:cs typeface="Arial"/>
-              </a:defRPr>
-            </a:lvl9pPr>
-          </a:lstStyle>
-          <a:p xmlns:a="http://schemas.openxmlformats.org/drawingml/2006/main">
-            <a:pPr>
-              <a:defRPr sz="1800" b="0">
-                <a:solidFill>
-                  <a:srgbClr val="263648"/>
-                </a:solidFill>
-                <a:latin typeface="Arial"/>
-                <a:ea typeface="Arial"/>
-                <a:cs typeface="Arial"/>
-              </a:defRPr>
-            </a:pPr>
-            <a:r>
-              <a:rPr sz="1800" b="0">
-                <a:solidFill>
-                  <a:srgbClr val="263648"/>
-                </a:solidFill>
-                <a:latin typeface="Arial"/>
-                <a:ea typeface="Arial"/>
-                <a:cs typeface="Arial"/>
-              </a:rPr>
-              <a:t>AI-assisted scripts, testing and analysis</a:t>
-            </a:r>
-          </a:p>
-          <a:p xmlns:a="http://schemas.openxmlformats.org/drawingml/2006/main">
-            <a:pPr>
-              <a:defRPr sz="1800" b="0">
-                <a:solidFill>
-                  <a:srgbClr val="263648"/>
-                </a:solidFill>
-                <a:latin typeface="Arial"/>
-                <a:ea typeface="Arial"/>
-                <a:cs typeface="Arial"/>
-              </a:defRPr>
-            </a:pPr>
-            <a:r>
-              <a:rPr sz="1800" b="0">
-                <a:solidFill>
-                  <a:srgbClr val="263648"/>
-                </a:solidFill>
-                <a:latin typeface="Arial"/>
-                <a:ea typeface="Arial"/>
-                <a:cs typeface="Arial"/>
-              </a:rPr>
-              <a:t>Human review owns claims and scope</a:t>
-            </a:r>
-          </a:p>
-        </p:txBody>
-      </p:sp>
-      <p:sp>
-        <p:nvSpPr>
-          <p:cNvPr id="26" name="">
-            <a:extLst xmlns:a="http://schemas.openxmlformats.org/drawingml/2006/main">
-              <a:ext uri="{FF2B5EF4-FFF2-40B4-BE49-F238E27FC236}">
-                <a16:creationId xmlns:a16="http://schemas.microsoft.com/office/drawing/2014/main" id="{3007C0A5-90AC-48FA-8957-E6C44FC45A12}"/>
-              </a:ext>
-            </a:extLst>
-          </p:cNvPr>
-          <p:cNvSpPr>
-            <a:spLocks xmlns:a="http://schemas.openxmlformats.org/drawingml/2006/main" noGrp="1"/>
-          </p:cNvSpPr>
-          <p:nvPr/>
-        </p:nvSpPr>
-        <p:spPr>
-          <a:xfrm xmlns:a="http://schemas.openxmlformats.org/drawingml/2006/main">
-            <a:off x="685800" y="5953125"/>
-            <a:ext cx="10820400" cy="304800"/>
-          </a:xfrm>
-          <a:prstGeom xmlns:a="http://schemas.openxmlformats.org/drawingml/2006/main" prst="rect">
-            <a:avLst/>
-          </a:prstGeom>
-          <a:noFill xmlns:a="http://schemas.openxmlformats.org/drawingml/2006/main"/>
-          <a:ln xmlns:a="http://schemas.openxmlformats.org/drawingml/2006/main" w="0">
-            <a:noFill/>
-            <a:prstDash val="solid"/>
-          </a:ln>
-        </p:spPr>
-        <p:txBody>
-          <a:bodyPr xmlns:a="http://schemas.openxmlformats.org/drawingml/2006/main" lIns="0" tIns="0" rIns="0" bIns="0"/>
-          <a:lstStyle xmlns:a="http://schemas.openxmlformats.org/drawingml/2006/main">
-            <a:defPPr>
-              <a:defRPr sz="1425" b="1">
-                <a:solidFill>
-                  <a:srgbClr val="A65A00"/>
-                </a:solidFill>
-                <a:latin typeface="Arial"/>
-                <a:ea typeface="Arial"/>
-                <a:cs typeface="Arial"/>
-              </a:defRPr>
-            </a:defPPr>
-            <a:lvl1pPr>
-              <a:defRPr sz="1425" b="1">
-                <a:solidFill>
-                  <a:srgbClr val="A65A00"/>
-                </a:solidFill>
-                <a:latin typeface="Arial"/>
-                <a:ea typeface="Arial"/>
-                <a:cs typeface="Arial"/>
-              </a:defRPr>
-            </a:lvl1pPr>
-            <a:lvl2pPr>
-              <a:defRPr sz="1425" b="1">
-                <a:solidFill>
-                  <a:srgbClr val="A65A00"/>
-                </a:solidFill>
-                <a:latin typeface="Arial"/>
-                <a:ea typeface="Arial"/>
-                <a:cs typeface="Arial"/>
-              </a:defRPr>
-            </a:lvl2pPr>
-            <a:lvl3pPr>
-              <a:defRPr sz="1425" b="1">
-                <a:solidFill>
-                  <a:srgbClr val="A65A00"/>
-                </a:solidFill>
-                <a:latin typeface="Arial"/>
-                <a:ea typeface="Arial"/>
-                <a:cs typeface="Arial"/>
-              </a:defRPr>
-            </a:lvl3pPr>
-            <a:lvl4pPr>
-              <a:defRPr sz="1425" b="1">
-                <a:solidFill>
-                  <a:srgbClr val="A65A00"/>
-                </a:solidFill>
-                <a:latin typeface="Arial"/>
-                <a:ea typeface="Arial"/>
-                <a:cs typeface="Arial"/>
-              </a:defRPr>
-            </a:lvl4pPr>
-            <a:lvl5pPr>
-              <a:defRPr sz="1425" b="1">
-                <a:solidFill>
-                  <a:srgbClr val="A65A00"/>
-                </a:solidFill>
-                <a:latin typeface="Arial"/>
-                <a:ea typeface="Arial"/>
-                <a:cs typeface="Arial"/>
-              </a:defRPr>
-            </a:lvl5pPr>
-            <a:lvl6pPr>
-              <a:defRPr sz="1425" b="1">
-                <a:solidFill>
-                  <a:srgbClr val="A65A00"/>
-                </a:solidFill>
-                <a:latin typeface="Arial"/>
-                <a:ea typeface="Arial"/>
-                <a:cs typeface="Arial"/>
-              </a:defRPr>
-            </a:lvl6pPr>
-            <a:lvl7pPr>
-              <a:defRPr sz="1425" b="1">
-                <a:solidFill>
-                  <a:srgbClr val="A65A00"/>
-                </a:solidFill>
-                <a:latin typeface="Arial"/>
-                <a:ea typeface="Arial"/>
-                <a:cs typeface="Arial"/>
-              </a:defRPr>
-            </a:lvl7pPr>
-            <a:lvl8pPr>
-              <a:defRPr sz="1425" b="1">
-                <a:solidFill>
-                  <a:srgbClr val="A65A00"/>
-                </a:solidFill>
-                <a:latin typeface="Arial"/>
-                <a:ea typeface="Arial"/>
-                <a:cs typeface="Arial"/>
-              </a:defRPr>
-            </a:lvl8pPr>
-            <a:lvl9pPr>
-              <a:defRPr sz="1425" b="1">
-                <a:solidFill>
-                  <a:srgbClr val="A65A00"/>
-                </a:solidFill>
-                <a:latin typeface="Arial"/>
-                <a:ea typeface="Arial"/>
-                <a:cs typeface="Arial"/>
-              </a:defRPr>
-            </a:lvl9pPr>
-          </a:lstStyle>
-          <a:p xmlns:a="http://schemas.openxmlformats.org/drawingml/2006/main">
-            <a:pPr>
-              <a:defRPr sz="1425" b="1">
-                <a:solidFill>
-                  <a:srgbClr val="A65A00"/>
-                </a:solidFill>
-                <a:latin typeface="Arial"/>
-                <a:ea typeface="Arial"/>
-                <a:cs typeface="Arial"/>
-              </a:defRPr>
-            </a:pPr>
-            <a:r>
-              <a:rPr sz="1425" b="1">
-                <a:solidFill>
-                  <a:srgbClr val="A65A00"/>
-                </a:solidFill>
-                <a:latin typeface="Arial"/>
-                <a:ea typeface="Arial"/>
-                <a:cs typeface="Arial"/>
-              </a:rPr>
-              <a:t>No matched agent win yet • live GP update defect disclosed • no dynamic LLM routing</a:t>
+              <a:t>Evaluate selection quality, token cost and latency against fixed-model controls.</a:t>
             </a:r>
           </a:p>
         </p:txBody>
@@ -24368,7 +24353,7 @@
     </p:spTree>
     <p:extLst>
       <p:ext uri="{BB962C8B-B14F-4D97-AF65-F5344CB8AC3E}">
-        <p14:creationId xmlns:p14="http://schemas.microsoft.com/office/powerpoint/2010/main" val="1269541018"/>
+        <p14:creationId xmlns:p14="http://schemas.microsoft.com/office/powerpoint/2010/main" val="802705811"/>
       </p:ext>
     </p:extLst>
   </p:cSld>
@@ -24399,7 +24384,7 @@
           <p:cNvPr id="9" name="">
             <a:extLst xmlns:a="http://schemas.openxmlformats.org/drawingml/2006/main">
               <a:ext uri="{FF2B5EF4-FFF2-40B4-BE49-F238E27FC236}">
-                <a16:creationId xmlns:a16="http://schemas.microsoft.com/office/drawing/2014/main" id="{754BD249-5816-4353-ADC2-C8C608424A15}"/>
+                <a16:creationId xmlns:a16="http://schemas.microsoft.com/office/drawing/2014/main" id="{7FFD8C33-606F-4D79-8E6B-C56214C9086D}"/>
               </a:ext>
             </a:extLst>
           </p:cNvPr>
@@ -24556,7 +24541,7 @@
           <p:cNvPr id="2" name="">
             <a:extLst xmlns:a="http://schemas.openxmlformats.org/drawingml/2006/main">
               <a:ext uri="{FF2B5EF4-FFF2-40B4-BE49-F238E27FC236}">
-                <a16:creationId xmlns:a16="http://schemas.microsoft.com/office/drawing/2014/main" id="{AE9CA0F2-38B4-4B65-A402-5F38CC20D49D}"/>
+                <a16:creationId xmlns:a16="http://schemas.microsoft.com/office/drawing/2014/main" id="{DAF19AC1-8B58-4B55-8EFA-8C44396E91A4}"/>
               </a:ext>
             </a:extLst>
           </p:cNvPr>
@@ -24587,7 +24572,7 @@
           <p:cNvPr id="3" name="">
             <a:extLst xmlns:a="http://schemas.openxmlformats.org/drawingml/2006/main">
               <a:ext uri="{FF2B5EF4-FFF2-40B4-BE49-F238E27FC236}">
-                <a16:creationId xmlns:a16="http://schemas.microsoft.com/office/drawing/2014/main" id="{29AF9265-C4D7-4D37-B99B-0253BF0C23B5}"/>
+                <a16:creationId xmlns:a16="http://schemas.microsoft.com/office/drawing/2014/main" id="{F75E4ACD-55DB-4F18-8FD2-CDA2A71E4305}"/>
               </a:ext>
             </a:extLst>
           </p:cNvPr>
@@ -24744,7 +24729,7 @@
           <p:cNvPr id="4" name="">
             <a:extLst xmlns:a="http://schemas.openxmlformats.org/drawingml/2006/main">
               <a:ext uri="{FF2B5EF4-FFF2-40B4-BE49-F238E27FC236}">
-                <a16:creationId xmlns:a16="http://schemas.microsoft.com/office/drawing/2014/main" id="{C44D38F3-771B-46BD-A597-FB32F4BC13D7}"/>
+                <a16:creationId xmlns:a16="http://schemas.microsoft.com/office/drawing/2014/main" id="{A5CB04C1-313E-4537-ABD7-2C0AFD351567}"/>
               </a:ext>
             </a:extLst>
           </p:cNvPr>
@@ -24901,7 +24886,7 @@
           <p:cNvPr id="5" name="">
             <a:extLst xmlns:a="http://schemas.openxmlformats.org/drawingml/2006/main">
               <a:ext uri="{FF2B5EF4-FFF2-40B4-BE49-F238E27FC236}">
-                <a16:creationId xmlns:a16="http://schemas.microsoft.com/office/drawing/2014/main" id="{BAD4950C-40FB-4B10-A9B0-E325BA09F99C}"/>
+                <a16:creationId xmlns:a16="http://schemas.microsoft.com/office/drawing/2014/main" id="{4042B578-8559-4C5C-9999-D61DB6AF6340}"/>
               </a:ext>
             </a:extLst>
           </p:cNvPr>
@@ -25150,7 +25135,7 @@
           <p:cNvPr id="6" name="">
             <a:extLst xmlns:a="http://schemas.openxmlformats.org/drawingml/2006/main">
               <a:ext uri="{FF2B5EF4-FFF2-40B4-BE49-F238E27FC236}">
-                <a16:creationId xmlns:a16="http://schemas.microsoft.com/office/drawing/2014/main" id="{0CD9D912-D271-4EE8-80C2-8D1C6B858C47}"/>
+                <a16:creationId xmlns:a16="http://schemas.microsoft.com/office/drawing/2014/main" id="{F493FB19-9EB1-47F7-9CFE-F99BBA2F4B5A}"/>
               </a:ext>
             </a:extLst>
           </p:cNvPr>
@@ -25307,7 +25292,7 @@
           <p:cNvPr id="7" name="">
             <a:extLst xmlns:a="http://schemas.openxmlformats.org/drawingml/2006/main">
               <a:ext uri="{FF2B5EF4-FFF2-40B4-BE49-F238E27FC236}">
-                <a16:creationId xmlns:a16="http://schemas.microsoft.com/office/drawing/2014/main" id="{DEF85F63-7B74-4FD9-9C6A-735CC73C6A0B}"/>
+                <a16:creationId xmlns:a16="http://schemas.microsoft.com/office/drawing/2014/main" id="{039F23AB-C514-47D1-8018-6DE0A4AD187C}"/>
               </a:ext>
             </a:extLst>
           </p:cNvPr>
@@ -25556,7 +25541,7 @@
           <p:cNvPr id="8" name="">
             <a:extLst xmlns:a="http://schemas.openxmlformats.org/drawingml/2006/main">
               <a:ext uri="{FF2B5EF4-FFF2-40B4-BE49-F238E27FC236}">
-                <a16:creationId xmlns:a16="http://schemas.microsoft.com/office/drawing/2014/main" id="{1D1463D0-BAF9-4C2B-9B5F-1BCA7E198821}"/>
+                <a16:creationId xmlns:a16="http://schemas.microsoft.com/office/drawing/2014/main" id="{4FB425EB-277B-444C-9675-52FDBC46929C}"/>
               </a:ext>
             </a:extLst>
           </p:cNvPr>
@@ -25711,7 +25696,7 @@
     </p:spTree>
     <p:extLst>
       <p:ext uri="{BB962C8B-B14F-4D97-AF65-F5344CB8AC3E}">
-        <p14:creationId xmlns:p14="http://schemas.microsoft.com/office/powerpoint/2010/main" val="1109085674"/>
+        <p14:creationId xmlns:p14="http://schemas.microsoft.com/office/powerpoint/2010/main" val="1168189479"/>
       </p:ext>
     </p:extLst>
   </p:cSld>

</xml_diff>

<commit_message>
Expand agent architecture slide and evaluate AI component placement
</commit_message>
<xml_diff>
--- a/submissions/midterm-2026-10-28/isaforge-midterm-progress-slides-final.pptx
+++ b/submissions/midterm-2026-10-28/isaforge-midterm-progress-slides-final.pptx
@@ -2,23 +2,23 @@
 <file path=ppt/presentation.xml><?xml version="1.0" encoding="utf-8"?>
 <p:presentation xmlns:p="http://schemas.openxmlformats.org/presentationml/2006/main">
   <p:sldMasterIdLst>
-    <p:sldMasterId xmlns:r="http://schemas.openxmlformats.org/officeDocument/2006/relationships" id="2147483648" r:id="R25c1c1be500c48ab"/>
+    <p:sldMasterId xmlns:r="http://schemas.openxmlformats.org/officeDocument/2006/relationships" id="2147483648" r:id="R8ebc841738ec473d"/>
   </p:sldMasterIdLst>
   <p:notesMasterIdLst>
-    <p:notesMasterId xmlns:r="http://schemas.openxmlformats.org/officeDocument/2006/relationships" r:id="R77b3bfccceb244bd"/>
+    <p:notesMasterId xmlns:r="http://schemas.openxmlformats.org/officeDocument/2006/relationships" r:id="R60c33dc9c5f74c8c"/>
   </p:notesMasterIdLst>
   <p:sldIdLst>
-    <p:sldId xmlns:r="http://schemas.openxmlformats.org/officeDocument/2006/relationships" id="256" r:id="R46cfd58efbef4ddd"/>
-    <p:sldId xmlns:r="http://schemas.openxmlformats.org/officeDocument/2006/relationships" id="257" r:id="R77d72b9455734861"/>
-    <p:sldId xmlns:r="http://schemas.openxmlformats.org/officeDocument/2006/relationships" id="258" r:id="Rfad6cb04cabc4e57"/>
-    <p:sldId xmlns:r="http://schemas.openxmlformats.org/officeDocument/2006/relationships" id="259" r:id="Rb7eeff40eace4358"/>
-    <p:sldId xmlns:r="http://schemas.openxmlformats.org/officeDocument/2006/relationships" id="260" r:id="Rd8644832c6c3444c"/>
-    <p:sldId xmlns:r="http://schemas.openxmlformats.org/officeDocument/2006/relationships" id="261" r:id="Ra5ec2d4bb3c64fce"/>
-    <p:sldId xmlns:r="http://schemas.openxmlformats.org/officeDocument/2006/relationships" id="262" r:id="R392f8b2719f64984"/>
-    <p:sldId xmlns:r="http://schemas.openxmlformats.org/officeDocument/2006/relationships" id="263" r:id="R39cb69d3497b4256"/>
-    <p:sldId xmlns:r="http://schemas.openxmlformats.org/officeDocument/2006/relationships" id="264" r:id="R580e83400c834306"/>
-    <p:sldId xmlns:r="http://schemas.openxmlformats.org/officeDocument/2006/relationships" id="265" r:id="R427685a577ac4bee"/>
-    <p:sldId xmlns:r="http://schemas.openxmlformats.org/officeDocument/2006/relationships" id="266" r:id="R47398582bd094387"/>
+    <p:sldId xmlns:r="http://schemas.openxmlformats.org/officeDocument/2006/relationships" id="256" r:id="R48db7e12abed41f1"/>
+    <p:sldId xmlns:r="http://schemas.openxmlformats.org/officeDocument/2006/relationships" id="257" r:id="R7fc2ccb2889d4404"/>
+    <p:sldId xmlns:r="http://schemas.openxmlformats.org/officeDocument/2006/relationships" id="258" r:id="R771d43a1639c4355"/>
+    <p:sldId xmlns:r="http://schemas.openxmlformats.org/officeDocument/2006/relationships" id="259" r:id="Rd973772c751f4ea7"/>
+    <p:sldId xmlns:r="http://schemas.openxmlformats.org/officeDocument/2006/relationships" id="260" r:id="R82e657a477224b46"/>
+    <p:sldId xmlns:r="http://schemas.openxmlformats.org/officeDocument/2006/relationships" id="261" r:id="R8eb2d17197ce475c"/>
+    <p:sldId xmlns:r="http://schemas.openxmlformats.org/officeDocument/2006/relationships" id="262" r:id="Re5e18ef191724f2a"/>
+    <p:sldId xmlns:r="http://schemas.openxmlformats.org/officeDocument/2006/relationships" id="263" r:id="Re19ff4317cec4749"/>
+    <p:sldId xmlns:r="http://schemas.openxmlformats.org/officeDocument/2006/relationships" id="264" r:id="R83c88b8e4ab64824"/>
+    <p:sldId xmlns:r="http://schemas.openxmlformats.org/officeDocument/2006/relationships" id="265" r:id="Rd05e980fe587428f"/>
+    <p:sldId xmlns:r="http://schemas.openxmlformats.org/officeDocument/2006/relationships" id="266" r:id="R2434c7f3d0a14d72"/>
   </p:sldIdLst>
   <p:sldSz cx="12192000" cy="6858000"/>
   <p:notesSz cx="6858000" cy="9144000"/>
@@ -1387,7 +1387,7 @@
           </a:p>
           <a:p xmlns:a="http://schemas.openxmlformats.org/drawingml/2006/main">
             <a:r>
-              <a:t>Our current agent uses structured actions to inspect candidates, query predictions, request a bounded measurement, and finalize a verified result. Guardrails enforce the hardware budget and keep unmeasured outcomes hidden. We plan dynamic language model routing: start with a smaller model, escalate ambiguous cases to a stronger model, and record token usage and latency. This router is not implemented yet. Agent memory would contain only public information and paid results. We will compare routing against fixed-model and non-agent controls under the same hardware budget. In the Ascon pilot, three candidates were measured; the best feasible one reached 1.024 times cycle speedup, but there is no matched agent win.</a:t>
+              <a:t>Our agent has four stages: analyze candidates and query ML predictions, choose a structured action, execute it through host guardrails, and record measured evidence. Paid observations feed the next decision. The lower half shows planned extensions. A bounded context builder would route routine decisions to a smaller language model and escalate difficult cases to a stronger one. Optional retrieval could supply approved historical evidence using chunking, embeddings, hybrid search and reranking. These components are not implemented yet. Across the system, LLMOps would version releases and track quality, tokens, latency and cost. We will judge every addition by verified feasible performance under the same measurement budget.</a:t>
             </a:r>
           </a:p>
           <a:p xmlns:a="http://schemas.openxmlformats.org/drawingml/2006/main">
@@ -1549,7 +1549,7 @@
           <p:cNvPr id="3" name="Title">
             <a:extLst xmlns:a="http://schemas.openxmlformats.org/drawingml/2006/main">
               <a:ext uri="{FF2B5EF4-FFF2-40B4-BE49-F238E27FC236}">
-                <a16:creationId xmlns:a16="http://schemas.microsoft.com/office/drawing/2014/main" id="{A7CF5774-85D5-49B0-A39B-F362BD547FFB}"/>
+                <a16:creationId xmlns:a16="http://schemas.microsoft.com/office/drawing/2014/main" id="{72307348-B6D2-473A-81E8-41787642BBA4}"/>
               </a:ext>
             </a:extLst>
           </p:cNvPr>
@@ -1778,7 +1778,7 @@
           <p:cNvPr id="2" name="Subtitle">
             <a:extLst xmlns:a="http://schemas.openxmlformats.org/drawingml/2006/main">
               <a:ext uri="{FF2B5EF4-FFF2-40B4-BE49-F238E27FC236}">
-                <a16:creationId xmlns:a16="http://schemas.microsoft.com/office/drawing/2014/main" id="{D6563462-E586-434C-992E-9EAC25C1B0E6}"/>
+                <a16:creationId xmlns:a16="http://schemas.microsoft.com/office/drawing/2014/main" id="{3E53BD86-1243-4B5B-A123-9072B05C2994}"/>
               </a:ext>
             </a:extLst>
           </p:cNvPr>
@@ -2024,7 +2024,7 @@
           <p:cNvPr id="2" name="Section title">
             <a:extLst xmlns:a="http://schemas.openxmlformats.org/drawingml/2006/main">
               <a:ext uri="{FF2B5EF4-FFF2-40B4-BE49-F238E27FC236}">
-                <a16:creationId xmlns:a16="http://schemas.microsoft.com/office/drawing/2014/main" id="{F8A94DE7-2A04-4300-89EB-324A719B29D6}"/>
+                <a16:creationId xmlns:a16="http://schemas.microsoft.com/office/drawing/2014/main" id="{DDE61444-4CAF-4F4B-B134-AD342A152D2E}"/>
               </a:ext>
             </a:extLst>
           </p:cNvPr>
@@ -2270,7 +2270,7 @@
           <p:cNvPr id="3" name="Title">
             <a:extLst xmlns:a="http://schemas.openxmlformats.org/drawingml/2006/main">
               <a:ext uri="{FF2B5EF4-FFF2-40B4-BE49-F238E27FC236}">
-                <a16:creationId xmlns:a16="http://schemas.microsoft.com/office/drawing/2014/main" id="{74FA5202-4268-4B10-8CE5-B38E8B9F807B}"/>
+                <a16:creationId xmlns:a16="http://schemas.microsoft.com/office/drawing/2014/main" id="{59DCD876-0C97-4610-888D-798BCB60C2F0}"/>
               </a:ext>
             </a:extLst>
           </p:cNvPr>
@@ -2499,7 +2499,7 @@
           <p:cNvPr id="2" name="Body">
             <a:extLst xmlns:a="http://schemas.openxmlformats.org/drawingml/2006/main">
               <a:ext uri="{FF2B5EF4-FFF2-40B4-BE49-F238E27FC236}">
-                <a16:creationId xmlns:a16="http://schemas.microsoft.com/office/drawing/2014/main" id="{FC1C111D-E068-46F9-BB29-AF0AC1970932}"/>
+                <a16:creationId xmlns:a16="http://schemas.microsoft.com/office/drawing/2014/main" id="{7D688D27-92CE-433F-8E21-07DB29A8AEAC}"/>
               </a:ext>
             </a:extLst>
           </p:cNvPr>
@@ -2745,7 +2745,7 @@
           <p:cNvPr id="4" name="Title">
             <a:extLst xmlns:a="http://schemas.openxmlformats.org/drawingml/2006/main">
               <a:ext uri="{FF2B5EF4-FFF2-40B4-BE49-F238E27FC236}">
-                <a16:creationId xmlns:a16="http://schemas.microsoft.com/office/drawing/2014/main" id="{D738F043-5EE7-46BE-B8D0-91F7C25A4A5A}"/>
+                <a16:creationId xmlns:a16="http://schemas.microsoft.com/office/drawing/2014/main" id="{89A581D9-B3A9-4D4F-8FEB-7671CC135E4B}"/>
               </a:ext>
             </a:extLst>
           </p:cNvPr>
@@ -2974,7 +2974,7 @@
           <p:cNvPr id="2" name="Left column">
             <a:extLst xmlns:a="http://schemas.openxmlformats.org/drawingml/2006/main">
               <a:ext uri="{FF2B5EF4-FFF2-40B4-BE49-F238E27FC236}">
-                <a16:creationId xmlns:a16="http://schemas.microsoft.com/office/drawing/2014/main" id="{F5E02D36-C115-459D-9D86-9FB9DEB57205}"/>
+                <a16:creationId xmlns:a16="http://schemas.microsoft.com/office/drawing/2014/main" id="{59D9C728-2618-4FD1-9A96-47A7EF27DC74}"/>
               </a:ext>
             </a:extLst>
           </p:cNvPr>
@@ -3203,7 +3203,7 @@
           <p:cNvPr id="3" name="Right column">
             <a:extLst xmlns:a="http://schemas.openxmlformats.org/drawingml/2006/main">
               <a:ext uri="{FF2B5EF4-FFF2-40B4-BE49-F238E27FC236}">
-                <a16:creationId xmlns:a16="http://schemas.microsoft.com/office/drawing/2014/main" id="{0A6B7628-DD52-49B4-901F-3BE924E99AA3}"/>
+                <a16:creationId xmlns:a16="http://schemas.microsoft.com/office/drawing/2014/main" id="{A7A23E8C-1D08-418D-A242-462F8626046D}"/>
               </a:ext>
             </a:extLst>
           </p:cNvPr>
@@ -3449,7 +3449,7 @@
           <p:cNvPr id="3" name="Title">
             <a:extLst xmlns:a="http://schemas.openxmlformats.org/drawingml/2006/main">
               <a:ext uri="{FF2B5EF4-FFF2-40B4-BE49-F238E27FC236}">
-                <a16:creationId xmlns:a16="http://schemas.microsoft.com/office/drawing/2014/main" id="{7ECC5F99-E82E-4164-88A7-6545600D1CAF}"/>
+                <a16:creationId xmlns:a16="http://schemas.microsoft.com/office/drawing/2014/main" id="{81037DA8-DFBE-44A1-BEDC-7BFA8D039E53}"/>
               </a:ext>
             </a:extLst>
           </p:cNvPr>
@@ -3678,7 +3678,7 @@
           <p:cNvPr id="2" name="Left column">
             <a:extLst xmlns:a="http://schemas.openxmlformats.org/drawingml/2006/main">
               <a:ext uri="{FF2B5EF4-FFF2-40B4-BE49-F238E27FC236}">
-                <a16:creationId xmlns:a16="http://schemas.microsoft.com/office/drawing/2014/main" id="{1F954650-D264-4D84-8C4B-701FB3BDA912}"/>
+                <a16:creationId xmlns:a16="http://schemas.microsoft.com/office/drawing/2014/main" id="{3E40825F-7AA3-45B1-B0DA-E23973CA8391}"/>
               </a:ext>
             </a:extLst>
           </p:cNvPr>
@@ -3945,12 +3945,12 @@
   </p:cSld>
   <p:clrMap bg1="lt1" tx1="dk1" bg2="lt2" tx2="dk2" accent1="accent1" accent2="accent2" accent3="accent3" accent4="accent4" accent5="accent5" accent6="accent6" hlink="hlink" folHlink="folHlink"/>
   <p:sldLayoutIdLst>
-    <p:sldLayoutId xmlns:r="http://schemas.openxmlformats.org/officeDocument/2006/relationships" id="2147483649" r:id="R8189423e2ee54dd6"/>
-    <p:sldLayoutId xmlns:r="http://schemas.openxmlformats.org/officeDocument/2006/relationships" id="2147483650" r:id="Re4ed48b33a6c46b2"/>
-    <p:sldLayoutId xmlns:r="http://schemas.openxmlformats.org/officeDocument/2006/relationships" id="2147483651" r:id="R8bf72088f3de4a8e"/>
-    <p:sldLayoutId xmlns:r="http://schemas.openxmlformats.org/officeDocument/2006/relationships" id="2147483652" r:id="Rf0edc883bb1340bb"/>
-    <p:sldLayoutId xmlns:r="http://schemas.openxmlformats.org/officeDocument/2006/relationships" id="2147483653" r:id="R00f6e6cde2fc4b25"/>
-    <p:sldLayoutId xmlns:r="http://schemas.openxmlformats.org/officeDocument/2006/relationships" id="2147483654" r:id="R7e74056c15194c5c"/>
+    <p:sldLayoutId xmlns:r="http://schemas.openxmlformats.org/officeDocument/2006/relationships" id="2147483649" r:id="Ra767641b8df945f7"/>
+    <p:sldLayoutId xmlns:r="http://schemas.openxmlformats.org/officeDocument/2006/relationships" id="2147483650" r:id="Rddaadcdc26934d02"/>
+    <p:sldLayoutId xmlns:r="http://schemas.openxmlformats.org/officeDocument/2006/relationships" id="2147483651" r:id="R5c9d73e702b9411d"/>
+    <p:sldLayoutId xmlns:r="http://schemas.openxmlformats.org/officeDocument/2006/relationships" id="2147483652" r:id="Rdf5d2dc555244f8b"/>
+    <p:sldLayoutId xmlns:r="http://schemas.openxmlformats.org/officeDocument/2006/relationships" id="2147483653" r:id="R2eb80be27cd14107"/>
+    <p:sldLayoutId xmlns:r="http://schemas.openxmlformats.org/officeDocument/2006/relationships" id="2147483654" r:id="Rb3a0ec51bb6b4d4d"/>
   </p:sldLayoutIdLst>
   <p:txStyles>
     <p:titleStyle>
@@ -5273,7 +5273,7 @@
           <p:cNvPr id="8" name="">
             <a:extLst xmlns:a="http://schemas.openxmlformats.org/drawingml/2006/main">
               <a:ext uri="{FF2B5EF4-FFF2-40B4-BE49-F238E27FC236}">
-                <a16:creationId xmlns:a16="http://schemas.microsoft.com/office/drawing/2014/main" id="{5A5A131D-658C-413F-AD3B-D731A3C853CA}"/>
+                <a16:creationId xmlns:a16="http://schemas.microsoft.com/office/drawing/2014/main" id="{C34444A3-D815-4FD0-9B24-C58F48A74036}"/>
               </a:ext>
             </a:extLst>
           </p:cNvPr>
@@ -5430,7 +5430,7 @@
           <p:cNvPr id="2" name="">
             <a:extLst xmlns:a="http://schemas.openxmlformats.org/drawingml/2006/main">
               <a:ext uri="{FF2B5EF4-FFF2-40B4-BE49-F238E27FC236}">
-                <a16:creationId xmlns:a16="http://schemas.microsoft.com/office/drawing/2014/main" id="{81140563-2BCE-418F-865A-78952EDEB923}"/>
+                <a16:creationId xmlns:a16="http://schemas.microsoft.com/office/drawing/2014/main" id="{50C4A47E-EF77-4EB7-83E0-5B44E61AE895}"/>
               </a:ext>
             </a:extLst>
           </p:cNvPr>
@@ -5461,7 +5461,7 @@
           <p:cNvPr id="3" name="">
             <a:extLst xmlns:a="http://schemas.openxmlformats.org/drawingml/2006/main">
               <a:ext uri="{FF2B5EF4-FFF2-40B4-BE49-F238E27FC236}">
-                <a16:creationId xmlns:a16="http://schemas.microsoft.com/office/drawing/2014/main" id="{53A5F272-DF9F-4869-89B5-21A972E2A4F9}"/>
+                <a16:creationId xmlns:a16="http://schemas.microsoft.com/office/drawing/2014/main" id="{B9850BB5-49B3-4D6A-A1AA-6A392EDEB68F}"/>
               </a:ext>
             </a:extLst>
           </p:cNvPr>
@@ -5618,7 +5618,7 @@
           <p:cNvPr id="4" name="">
             <a:extLst xmlns:a="http://schemas.openxmlformats.org/drawingml/2006/main">
               <a:ext uri="{FF2B5EF4-FFF2-40B4-BE49-F238E27FC236}">
-                <a16:creationId xmlns:a16="http://schemas.microsoft.com/office/drawing/2014/main" id="{2583D8F1-BB88-4AF2-8A52-123271C8A2D9}"/>
+                <a16:creationId xmlns:a16="http://schemas.microsoft.com/office/drawing/2014/main" id="{4FED64FA-7EDA-4806-B12B-64F95EF58E44}"/>
               </a:ext>
             </a:extLst>
           </p:cNvPr>
@@ -5775,7 +5775,7 @@
           <p:cNvPr id="5" name="">
             <a:extLst xmlns:a="http://schemas.openxmlformats.org/drawingml/2006/main">
               <a:ext uri="{FF2B5EF4-FFF2-40B4-BE49-F238E27FC236}">
-                <a16:creationId xmlns:a16="http://schemas.microsoft.com/office/drawing/2014/main" id="{D6DD027D-7563-4230-B8D6-87E16D358BC0}"/>
+                <a16:creationId xmlns:a16="http://schemas.microsoft.com/office/drawing/2014/main" id="{31DE9723-1CC9-4295-AA61-42900C7AB9C9}"/>
               </a:ext>
             </a:extLst>
           </p:cNvPr>
@@ -5955,7 +5955,7 @@
           <p:cNvPr id="6" name="">
             <a:extLst xmlns:a="http://schemas.openxmlformats.org/drawingml/2006/main">
               <a:ext uri="{FF2B5EF4-FFF2-40B4-BE49-F238E27FC236}">
-                <a16:creationId xmlns:a16="http://schemas.microsoft.com/office/drawing/2014/main" id="{29AD9D2D-BF75-4CF0-ADCD-DA6EEB0F6605}"/>
+                <a16:creationId xmlns:a16="http://schemas.microsoft.com/office/drawing/2014/main" id="{8FD39306-4A0A-4276-B751-51409E0FB316}"/>
               </a:ext>
             </a:extLst>
           </p:cNvPr>
@@ -6112,7 +6112,7 @@
           <p:cNvPr id="7" name="">
             <a:extLst xmlns:a="http://schemas.openxmlformats.org/drawingml/2006/main">
               <a:ext uri="{FF2B5EF4-FFF2-40B4-BE49-F238E27FC236}">
-                <a16:creationId xmlns:a16="http://schemas.microsoft.com/office/drawing/2014/main" id="{02AC9E8C-6251-43E7-AB04-5C56B1EA56BD}"/>
+                <a16:creationId xmlns:a16="http://schemas.microsoft.com/office/drawing/2014/main" id="{790F2771-130E-48AC-A457-5B08B11BF7BD}"/>
               </a:ext>
             </a:extLst>
           </p:cNvPr>
@@ -6267,7 +6267,7 @@
     </p:spTree>
     <p:extLst>
       <p:ext uri="{BB962C8B-B14F-4D97-AF65-F5344CB8AC3E}">
-        <p14:creationId xmlns:p14="http://schemas.microsoft.com/office/powerpoint/2010/main" val="1409095491"/>
+        <p14:creationId xmlns:p14="http://schemas.microsoft.com/office/powerpoint/2010/main" val="1295815358"/>
       </p:ext>
     </p:extLst>
   </p:cSld>
@@ -6298,7 +6298,7 @@
           <p:cNvPr id="9" name="">
             <a:extLst xmlns:a="http://schemas.openxmlformats.org/drawingml/2006/main">
               <a:ext uri="{FF2B5EF4-FFF2-40B4-BE49-F238E27FC236}">
-                <a16:creationId xmlns:a16="http://schemas.microsoft.com/office/drawing/2014/main" id="{E6ABAFA8-CB05-4874-B9D9-CE2AC43EFF67}"/>
+                <a16:creationId xmlns:a16="http://schemas.microsoft.com/office/drawing/2014/main" id="{EB162AE5-C97B-4A42-BD2E-37B8C1965F23}"/>
               </a:ext>
             </a:extLst>
           </p:cNvPr>
@@ -6455,7 +6455,7 @@
           <p:cNvPr id="2" name="">
             <a:extLst xmlns:a="http://schemas.openxmlformats.org/drawingml/2006/main">
               <a:ext uri="{FF2B5EF4-FFF2-40B4-BE49-F238E27FC236}">
-                <a16:creationId xmlns:a16="http://schemas.microsoft.com/office/drawing/2014/main" id="{0A01B493-87FE-40D4-990D-BB53FEC325E8}"/>
+                <a16:creationId xmlns:a16="http://schemas.microsoft.com/office/drawing/2014/main" id="{226CCE9E-2FC6-4809-97F0-41B197178896}"/>
               </a:ext>
             </a:extLst>
           </p:cNvPr>
@@ -6486,7 +6486,7 @@
           <p:cNvPr id="3" name="">
             <a:extLst xmlns:a="http://schemas.openxmlformats.org/drawingml/2006/main">
               <a:ext uri="{FF2B5EF4-FFF2-40B4-BE49-F238E27FC236}">
-                <a16:creationId xmlns:a16="http://schemas.microsoft.com/office/drawing/2014/main" id="{1A6F68F1-4ACB-4D8F-B393-CB3B59690A35}"/>
+                <a16:creationId xmlns:a16="http://schemas.microsoft.com/office/drawing/2014/main" id="{4C224B04-4CA2-48B0-A0C0-B03CFC0D7DDD}"/>
               </a:ext>
             </a:extLst>
           </p:cNvPr>
@@ -6643,7 +6643,7 @@
           <p:cNvPr id="4" name="Chart">
             <a:extLst xmlns:a="http://schemas.openxmlformats.org/drawingml/2006/main">
               <a:ext uri="{FF2B5EF4-FFF2-40B4-BE49-F238E27FC236}">
-                <a16:creationId xmlns:a16="http://schemas.microsoft.com/office/drawing/2014/main" id="{39F1AA93-F963-4CEC-BD1B-444B985B6B16}"/>
+                <a16:creationId xmlns:a16="http://schemas.microsoft.com/office/drawing/2014/main" id="{AE9BCCBC-E2D3-4B1B-A95B-EDBC70FB42BE}"/>
               </a:ext>
             </a:extLst>
           </p:cNvPr>
@@ -6656,7 +6656,7 @@
         </p:xfrm>
         <a:graphic xmlns:a="http://schemas.openxmlformats.org/drawingml/2006/main">
           <a:graphicData uri="http://schemas.openxmlformats.org/drawingml/2006/chart">
-            <c:chart xmlns:r="http://schemas.openxmlformats.org/officeDocument/2006/relationships" xmlns:c="http://schemas.openxmlformats.org/drawingml/2006/chart" r:id="R635008741df5403a"/>
+            <c:chart xmlns:r="http://schemas.openxmlformats.org/officeDocument/2006/relationships" xmlns:c="http://schemas.openxmlformats.org/drawingml/2006/chart" r:id="R52c28a42d3e9481c"/>
           </a:graphicData>
         </a:graphic>
       </p:graphicFrame>
@@ -6665,7 +6665,7 @@
           <p:cNvPr id="5" name="">
             <a:extLst xmlns:a="http://schemas.openxmlformats.org/drawingml/2006/main">
               <a:ext uri="{FF2B5EF4-FFF2-40B4-BE49-F238E27FC236}">
-                <a16:creationId xmlns:a16="http://schemas.microsoft.com/office/drawing/2014/main" id="{A792F69E-5E42-4A65-A9BB-E04DA6D1898C}"/>
+                <a16:creationId xmlns:a16="http://schemas.microsoft.com/office/drawing/2014/main" id="{32D93178-6E8E-41F8-B9C0-F6AD4F590800}"/>
               </a:ext>
             </a:extLst>
           </p:cNvPr>
@@ -6822,7 +6822,7 @@
           <p:cNvPr id="6" name="">
             <a:extLst xmlns:a="http://schemas.openxmlformats.org/drawingml/2006/main">
               <a:ext uri="{FF2B5EF4-FFF2-40B4-BE49-F238E27FC236}">
-                <a16:creationId xmlns:a16="http://schemas.microsoft.com/office/drawing/2014/main" id="{40901852-CDEC-4BFE-B502-F6C392B1B321}"/>
+                <a16:creationId xmlns:a16="http://schemas.microsoft.com/office/drawing/2014/main" id="{B91C8CB1-0E9B-4E7F-9916-CA541FC8926F}"/>
               </a:ext>
             </a:extLst>
           </p:cNvPr>
@@ -7053,7 +7053,7 @@
           <p:cNvPr id="7" name="">
             <a:extLst xmlns:a="http://schemas.openxmlformats.org/drawingml/2006/main">
               <a:ext uri="{FF2B5EF4-FFF2-40B4-BE49-F238E27FC236}">
-                <a16:creationId xmlns:a16="http://schemas.microsoft.com/office/drawing/2014/main" id="{19041167-9200-4D21-BBB8-AD60055EFDC9}"/>
+                <a16:creationId xmlns:a16="http://schemas.microsoft.com/office/drawing/2014/main" id="{97E3E5DE-06D9-46E9-8803-E4B1801CA5B0}"/>
               </a:ext>
             </a:extLst>
           </p:cNvPr>
@@ -7233,7 +7233,7 @@
           <p:cNvPr id="8" name="">
             <a:extLst xmlns:a="http://schemas.openxmlformats.org/drawingml/2006/main">
               <a:ext uri="{FF2B5EF4-FFF2-40B4-BE49-F238E27FC236}">
-                <a16:creationId xmlns:a16="http://schemas.microsoft.com/office/drawing/2014/main" id="{EA295DBD-747D-4FBA-91DC-2EAD36F04621}"/>
+                <a16:creationId xmlns:a16="http://schemas.microsoft.com/office/drawing/2014/main" id="{494310CE-C657-4595-BC0C-885D115C068A}"/>
               </a:ext>
             </a:extLst>
           </p:cNvPr>
@@ -7388,7 +7388,7 @@
     </p:spTree>
     <p:extLst>
       <p:ext uri="{BB962C8B-B14F-4D97-AF65-F5344CB8AC3E}">
-        <p14:creationId xmlns:p14="http://schemas.microsoft.com/office/powerpoint/2010/main" val="830729655"/>
+        <p14:creationId xmlns:p14="http://schemas.microsoft.com/office/powerpoint/2010/main" val="1261694005"/>
       </p:ext>
     </p:extLst>
   </p:cSld>
@@ -7419,7 +7419,7 @@
           <p:cNvPr id="9" name="">
             <a:extLst xmlns:a="http://schemas.openxmlformats.org/drawingml/2006/main">
               <a:ext uri="{FF2B5EF4-FFF2-40B4-BE49-F238E27FC236}">
-                <a16:creationId xmlns:a16="http://schemas.microsoft.com/office/drawing/2014/main" id="{A0E20086-5EE9-4B11-BE15-DF110A951D71}"/>
+                <a16:creationId xmlns:a16="http://schemas.microsoft.com/office/drawing/2014/main" id="{E9D89C25-E844-4FF2-ACE6-BD89C6122301}"/>
               </a:ext>
             </a:extLst>
           </p:cNvPr>
@@ -7576,7 +7576,7 @@
           <p:cNvPr id="2" name="">
             <a:extLst xmlns:a="http://schemas.openxmlformats.org/drawingml/2006/main">
               <a:ext uri="{FF2B5EF4-FFF2-40B4-BE49-F238E27FC236}">
-                <a16:creationId xmlns:a16="http://schemas.microsoft.com/office/drawing/2014/main" id="{C71E2750-BB3F-429E-9197-060A7FD8EBFC}"/>
+                <a16:creationId xmlns:a16="http://schemas.microsoft.com/office/drawing/2014/main" id="{26ECF756-3699-414C-8CBD-5941EB514DE9}"/>
               </a:ext>
             </a:extLst>
           </p:cNvPr>
@@ -7607,7 +7607,7 @@
           <p:cNvPr id="3" name="">
             <a:extLst xmlns:a="http://schemas.openxmlformats.org/drawingml/2006/main">
               <a:ext uri="{FF2B5EF4-FFF2-40B4-BE49-F238E27FC236}">
-                <a16:creationId xmlns:a16="http://schemas.microsoft.com/office/drawing/2014/main" id="{84F9CE70-1094-47E9-96CA-3980B9439530}"/>
+                <a16:creationId xmlns:a16="http://schemas.microsoft.com/office/drawing/2014/main" id="{F1DC2800-899D-465B-A901-2B1667361A77}"/>
               </a:ext>
             </a:extLst>
           </p:cNvPr>
@@ -7764,7 +7764,7 @@
           <p:cNvPr id="4" name="">
             <a:extLst xmlns:a="http://schemas.openxmlformats.org/drawingml/2006/main">
               <a:ext uri="{FF2B5EF4-FFF2-40B4-BE49-F238E27FC236}">
-                <a16:creationId xmlns:a16="http://schemas.microsoft.com/office/drawing/2014/main" id="{E2396486-CE2D-4385-A62A-6364E819BC20}"/>
+                <a16:creationId xmlns:a16="http://schemas.microsoft.com/office/drawing/2014/main" id="{CD93CE44-D9D2-4D47-BAF9-51111EEFA0BD}"/>
               </a:ext>
             </a:extLst>
           </p:cNvPr>
@@ -7921,7 +7921,7 @@
           <p:cNvPr id="5" name="">
             <a:extLst xmlns:a="http://schemas.openxmlformats.org/drawingml/2006/main">
               <a:ext uri="{FF2B5EF4-FFF2-40B4-BE49-F238E27FC236}">
-                <a16:creationId xmlns:a16="http://schemas.microsoft.com/office/drawing/2014/main" id="{C407C0AA-B89E-4242-9379-C01CFF972007}"/>
+                <a16:creationId xmlns:a16="http://schemas.microsoft.com/office/drawing/2014/main" id="{B04C563C-6283-4FF9-995D-36BF33E7D423}"/>
               </a:ext>
             </a:extLst>
           </p:cNvPr>
@@ -8147,7 +8147,7 @@
           <p:cNvPr id="6" name="">
             <a:extLst xmlns:a="http://schemas.openxmlformats.org/drawingml/2006/main">
               <a:ext uri="{FF2B5EF4-FFF2-40B4-BE49-F238E27FC236}">
-                <a16:creationId xmlns:a16="http://schemas.microsoft.com/office/drawing/2014/main" id="{390A7691-4CE9-43EE-9C70-F2ACB9CD94D8}"/>
+                <a16:creationId xmlns:a16="http://schemas.microsoft.com/office/drawing/2014/main" id="{ED8E2509-146F-442E-B361-165A997BCE76}"/>
               </a:ext>
             </a:extLst>
           </p:cNvPr>
@@ -8304,7 +8304,7 @@
           <p:cNvPr id="7" name="">
             <a:extLst xmlns:a="http://schemas.openxmlformats.org/drawingml/2006/main">
               <a:ext uri="{FF2B5EF4-FFF2-40B4-BE49-F238E27FC236}">
-                <a16:creationId xmlns:a16="http://schemas.microsoft.com/office/drawing/2014/main" id="{D5BD1BE4-213D-4295-93C3-BA43F5ECB0CA}"/>
+                <a16:creationId xmlns:a16="http://schemas.microsoft.com/office/drawing/2014/main" id="{66F41877-9B07-4F00-94E3-10D5500524CD}"/>
               </a:ext>
             </a:extLst>
           </p:cNvPr>
@@ -8530,7 +8530,7 @@
           <p:cNvPr id="8" name="">
             <a:extLst xmlns:a="http://schemas.openxmlformats.org/drawingml/2006/main">
               <a:ext uri="{FF2B5EF4-FFF2-40B4-BE49-F238E27FC236}">
-                <a16:creationId xmlns:a16="http://schemas.microsoft.com/office/drawing/2014/main" id="{031565E8-2890-4E8C-A16C-203AA563147F}"/>
+                <a16:creationId xmlns:a16="http://schemas.microsoft.com/office/drawing/2014/main" id="{098106AB-A410-437D-92A8-35DAB5F23B9F}"/>
               </a:ext>
             </a:extLst>
           </p:cNvPr>
@@ -8685,7 +8685,7 @@
     </p:spTree>
     <p:extLst>
       <p:ext uri="{BB962C8B-B14F-4D97-AF65-F5344CB8AC3E}">
-        <p14:creationId xmlns:p14="http://schemas.microsoft.com/office/powerpoint/2010/main" val="1015538832"/>
+        <p14:creationId xmlns:p14="http://schemas.microsoft.com/office/powerpoint/2010/main" val="1777061452"/>
       </p:ext>
     </p:extLst>
   </p:cSld>
@@ -8716,7 +8716,7 @@
           <p:cNvPr id="20" name="">
             <a:extLst xmlns:a="http://schemas.openxmlformats.org/drawingml/2006/main">
               <a:ext uri="{FF2B5EF4-FFF2-40B4-BE49-F238E27FC236}">
-                <a16:creationId xmlns:a16="http://schemas.microsoft.com/office/drawing/2014/main" id="{1A3C4500-35CD-4EED-A88F-8540BCB1C78A}"/>
+                <a16:creationId xmlns:a16="http://schemas.microsoft.com/office/drawing/2014/main" id="{CA5124AC-1D9E-4C71-9941-B5727905B126}"/>
               </a:ext>
             </a:extLst>
           </p:cNvPr>
@@ -8873,7 +8873,7 @@
           <p:cNvPr id="2" name="">
             <a:extLst xmlns:a="http://schemas.openxmlformats.org/drawingml/2006/main">
               <a:ext uri="{FF2B5EF4-FFF2-40B4-BE49-F238E27FC236}">
-                <a16:creationId xmlns:a16="http://schemas.microsoft.com/office/drawing/2014/main" id="{6840AF90-EB3E-45D7-AAF4-978B4207161E}"/>
+                <a16:creationId xmlns:a16="http://schemas.microsoft.com/office/drawing/2014/main" id="{C2744CB8-80CB-45FD-AC34-E984FCBA8906}"/>
               </a:ext>
             </a:extLst>
           </p:cNvPr>
@@ -8904,7 +8904,7 @@
           <p:cNvPr id="3" name="">
             <a:extLst xmlns:a="http://schemas.openxmlformats.org/drawingml/2006/main">
               <a:ext uri="{FF2B5EF4-FFF2-40B4-BE49-F238E27FC236}">
-                <a16:creationId xmlns:a16="http://schemas.microsoft.com/office/drawing/2014/main" id="{A2E94FF1-F98F-4AA8-9A86-B2BB029B8BB0}"/>
+                <a16:creationId xmlns:a16="http://schemas.microsoft.com/office/drawing/2014/main" id="{ADFDC56E-4523-487B-9638-6C8EC671FAF4}"/>
               </a:ext>
             </a:extLst>
           </p:cNvPr>
@@ -9061,7 +9061,7 @@
           <p:cNvPr id="4" name="">
             <a:extLst xmlns:a="http://schemas.openxmlformats.org/drawingml/2006/main">
               <a:ext uri="{FF2B5EF4-FFF2-40B4-BE49-F238E27FC236}">
-                <a16:creationId xmlns:a16="http://schemas.microsoft.com/office/drawing/2014/main" id="{72EAF1FD-9691-4408-A6EC-3514429F362C}"/>
+                <a16:creationId xmlns:a16="http://schemas.microsoft.com/office/drawing/2014/main" id="{BD6A92DA-FAC3-472F-9670-0E15CF94D5E1}"/>
               </a:ext>
             </a:extLst>
           </p:cNvPr>
@@ -9218,7 +9218,7 @@
           <p:cNvPr id="5" name="">
             <a:extLst xmlns:a="http://schemas.openxmlformats.org/drawingml/2006/main">
               <a:ext uri="{FF2B5EF4-FFF2-40B4-BE49-F238E27FC236}">
-                <a16:creationId xmlns:a16="http://schemas.microsoft.com/office/drawing/2014/main" id="{A3627388-CF36-4BE6-8F2B-D143DE3253D7}"/>
+                <a16:creationId xmlns:a16="http://schemas.microsoft.com/office/drawing/2014/main" id="{0B5AC5C5-6EB7-42DA-8688-937AA722630C}"/>
               </a:ext>
             </a:extLst>
           </p:cNvPr>
@@ -9375,7 +9375,7 @@
           <p:cNvPr id="6" name="">
             <a:extLst xmlns:a="http://schemas.openxmlformats.org/drawingml/2006/main">
               <a:ext uri="{FF2B5EF4-FFF2-40B4-BE49-F238E27FC236}">
-                <a16:creationId xmlns:a16="http://schemas.microsoft.com/office/drawing/2014/main" id="{76081F2A-B444-4AF2-A2CB-647ADBF628E7}"/>
+                <a16:creationId xmlns:a16="http://schemas.microsoft.com/office/drawing/2014/main" id="{9D3213FA-0E95-4FB0-B9ED-E52BBB061AE5}"/>
               </a:ext>
             </a:extLst>
           </p:cNvPr>
@@ -9532,7 +9532,7 @@
           <p:cNvPr id="7" name="">
             <a:extLst xmlns:a="http://schemas.openxmlformats.org/drawingml/2006/main">
               <a:ext uri="{FF2B5EF4-FFF2-40B4-BE49-F238E27FC236}">
-                <a16:creationId xmlns:a16="http://schemas.microsoft.com/office/drawing/2014/main" id="{7FF97A00-655A-4A73-8B50-8DE4591E85B1}"/>
+                <a16:creationId xmlns:a16="http://schemas.microsoft.com/office/drawing/2014/main" id="{1BF04074-6CDF-42E9-8AEA-6BA3D87850D7}"/>
               </a:ext>
             </a:extLst>
           </p:cNvPr>
@@ -9563,7 +9563,7 @@
           <p:cNvPr id="8" name="">
             <a:extLst xmlns:a="http://schemas.openxmlformats.org/drawingml/2006/main">
               <a:ext uri="{FF2B5EF4-FFF2-40B4-BE49-F238E27FC236}">
-                <a16:creationId xmlns:a16="http://schemas.microsoft.com/office/drawing/2014/main" id="{3A1B53A2-57E3-4177-96FB-D8057F4B053F}"/>
+                <a16:creationId xmlns:a16="http://schemas.microsoft.com/office/drawing/2014/main" id="{7DC99C30-0B9B-4F0B-9EC6-5FCD53761A33}"/>
               </a:ext>
             </a:extLst>
           </p:cNvPr>
@@ -9720,7 +9720,7 @@
           <p:cNvPr id="9" name="">
             <a:extLst xmlns:a="http://schemas.openxmlformats.org/drawingml/2006/main">
               <a:ext uri="{FF2B5EF4-FFF2-40B4-BE49-F238E27FC236}">
-                <a16:creationId xmlns:a16="http://schemas.microsoft.com/office/drawing/2014/main" id="{93A2F03F-F2DC-4D59-8C0A-7B61DBAE23B5}"/>
+                <a16:creationId xmlns:a16="http://schemas.microsoft.com/office/drawing/2014/main" id="{688E743D-481B-413A-8E71-F85F602D536C}"/>
               </a:ext>
             </a:extLst>
           </p:cNvPr>
@@ -9877,7 +9877,7 @@
           <p:cNvPr id="10" name="">
             <a:extLst xmlns:a="http://schemas.openxmlformats.org/drawingml/2006/main">
               <a:ext uri="{FF2B5EF4-FFF2-40B4-BE49-F238E27FC236}">
-                <a16:creationId xmlns:a16="http://schemas.microsoft.com/office/drawing/2014/main" id="{AF2B3D92-0220-4244-AEFB-456855573330}"/>
+                <a16:creationId xmlns:a16="http://schemas.microsoft.com/office/drawing/2014/main" id="{F5500841-BDAE-46DC-A7BC-9AEA43DBF2D1}"/>
               </a:ext>
             </a:extLst>
           </p:cNvPr>
@@ -10034,7 +10034,7 @@
           <p:cNvPr id="11" name="">
             <a:extLst xmlns:a="http://schemas.openxmlformats.org/drawingml/2006/main">
               <a:ext uri="{FF2B5EF4-FFF2-40B4-BE49-F238E27FC236}">
-                <a16:creationId xmlns:a16="http://schemas.microsoft.com/office/drawing/2014/main" id="{1FD648DC-F968-4BF5-AFDB-58F4C0FF3BE9}"/>
+                <a16:creationId xmlns:a16="http://schemas.microsoft.com/office/drawing/2014/main" id="{6EADE166-3170-41B9-9625-7E860196B2E6}"/>
               </a:ext>
             </a:extLst>
           </p:cNvPr>
@@ -10065,7 +10065,7 @@
           <p:cNvPr id="12" name="">
             <a:extLst xmlns:a="http://schemas.openxmlformats.org/drawingml/2006/main">
               <a:ext uri="{FF2B5EF4-FFF2-40B4-BE49-F238E27FC236}">
-                <a16:creationId xmlns:a16="http://schemas.microsoft.com/office/drawing/2014/main" id="{32AD3120-BF89-48BE-97FC-F2601E56E548}"/>
+                <a16:creationId xmlns:a16="http://schemas.microsoft.com/office/drawing/2014/main" id="{CAF29F5F-54CA-43A5-A7F1-CB727520709B}"/>
               </a:ext>
             </a:extLst>
           </p:cNvPr>
@@ -10222,7 +10222,7 @@
           <p:cNvPr id="13" name="">
             <a:extLst xmlns:a="http://schemas.openxmlformats.org/drawingml/2006/main">
               <a:ext uri="{FF2B5EF4-FFF2-40B4-BE49-F238E27FC236}">
-                <a16:creationId xmlns:a16="http://schemas.microsoft.com/office/drawing/2014/main" id="{CA24CA56-9F7C-4098-8773-AFE2CD5796F8}"/>
+                <a16:creationId xmlns:a16="http://schemas.microsoft.com/office/drawing/2014/main" id="{D9214BE0-9A4B-4738-A49D-043499C43636}"/>
               </a:ext>
             </a:extLst>
           </p:cNvPr>
@@ -10379,7 +10379,7 @@
           <p:cNvPr id="14" name="">
             <a:extLst xmlns:a="http://schemas.openxmlformats.org/drawingml/2006/main">
               <a:ext uri="{FF2B5EF4-FFF2-40B4-BE49-F238E27FC236}">
-                <a16:creationId xmlns:a16="http://schemas.microsoft.com/office/drawing/2014/main" id="{061482D1-3017-4D6D-A855-3ECBFE944B4C}"/>
+                <a16:creationId xmlns:a16="http://schemas.microsoft.com/office/drawing/2014/main" id="{5CD8EE5E-98D5-4ED5-B8CD-4BCA57C81F40}"/>
               </a:ext>
             </a:extLst>
           </p:cNvPr>
@@ -10536,7 +10536,7 @@
           <p:cNvPr id="15" name="">
             <a:extLst xmlns:a="http://schemas.openxmlformats.org/drawingml/2006/main">
               <a:ext uri="{FF2B5EF4-FFF2-40B4-BE49-F238E27FC236}">
-                <a16:creationId xmlns:a16="http://schemas.microsoft.com/office/drawing/2014/main" id="{D13DFF04-DDAE-4207-AE77-24978500AE11}"/>
+                <a16:creationId xmlns:a16="http://schemas.microsoft.com/office/drawing/2014/main" id="{8199F29C-C446-4FBC-8871-1DD5E35C30FF}"/>
               </a:ext>
             </a:extLst>
           </p:cNvPr>
@@ -10567,7 +10567,7 @@
           <p:cNvPr id="16" name="">
             <a:extLst xmlns:a="http://schemas.openxmlformats.org/drawingml/2006/main">
               <a:ext uri="{FF2B5EF4-FFF2-40B4-BE49-F238E27FC236}">
-                <a16:creationId xmlns:a16="http://schemas.microsoft.com/office/drawing/2014/main" id="{6E7FB08C-9998-46BF-8C80-27EF6D2F2C17}"/>
+                <a16:creationId xmlns:a16="http://schemas.microsoft.com/office/drawing/2014/main" id="{40BCD80A-8F23-4481-8591-8FC7F8E9CCA8}"/>
               </a:ext>
             </a:extLst>
           </p:cNvPr>
@@ -10724,7 +10724,7 @@
           <p:cNvPr id="17" name="">
             <a:extLst xmlns:a="http://schemas.openxmlformats.org/drawingml/2006/main">
               <a:ext uri="{FF2B5EF4-FFF2-40B4-BE49-F238E27FC236}">
-                <a16:creationId xmlns:a16="http://schemas.microsoft.com/office/drawing/2014/main" id="{A98ECBBD-0671-415B-871A-566A9DA021A6}"/>
+                <a16:creationId xmlns:a16="http://schemas.microsoft.com/office/drawing/2014/main" id="{DD9E2C47-7A92-4E01-824F-D8A41384DEDF}"/>
               </a:ext>
             </a:extLst>
           </p:cNvPr>
@@ -10881,7 +10881,7 @@
           <p:cNvPr id="18" name="">
             <a:extLst xmlns:a="http://schemas.openxmlformats.org/drawingml/2006/main">
               <a:ext uri="{FF2B5EF4-FFF2-40B4-BE49-F238E27FC236}">
-                <a16:creationId xmlns:a16="http://schemas.microsoft.com/office/drawing/2014/main" id="{F7BCBB15-9647-4AFB-AE83-AF2BF7E1A525}"/>
+                <a16:creationId xmlns:a16="http://schemas.microsoft.com/office/drawing/2014/main" id="{27F0BC98-2BCC-4F62-981C-37A12018D659}"/>
               </a:ext>
             </a:extLst>
           </p:cNvPr>
@@ -11038,7 +11038,7 @@
           <p:cNvPr id="19" name="">
             <a:extLst xmlns:a="http://schemas.openxmlformats.org/drawingml/2006/main">
               <a:ext uri="{FF2B5EF4-FFF2-40B4-BE49-F238E27FC236}">
-                <a16:creationId xmlns:a16="http://schemas.microsoft.com/office/drawing/2014/main" id="{EA53CD8F-5D21-4071-9A92-DFA1A67F86C5}"/>
+                <a16:creationId xmlns:a16="http://schemas.microsoft.com/office/drawing/2014/main" id="{17C56CF3-15A0-42C8-852C-3E678DFC7BCA}"/>
               </a:ext>
             </a:extLst>
           </p:cNvPr>
@@ -11193,7 +11193,7 @@
     </p:spTree>
     <p:extLst>
       <p:ext uri="{BB962C8B-B14F-4D97-AF65-F5344CB8AC3E}">
-        <p14:creationId xmlns:p14="http://schemas.microsoft.com/office/powerpoint/2010/main" val="1520546986"/>
+        <p14:creationId xmlns:p14="http://schemas.microsoft.com/office/powerpoint/2010/main" val="1975162308"/>
       </p:ext>
     </p:extLst>
   </p:cSld>
@@ -11224,7 +11224,7 @@
           <p:cNvPr id="19" name="">
             <a:extLst xmlns:a="http://schemas.openxmlformats.org/drawingml/2006/main">
               <a:ext uri="{FF2B5EF4-FFF2-40B4-BE49-F238E27FC236}">
-                <a16:creationId xmlns:a16="http://schemas.microsoft.com/office/drawing/2014/main" id="{2955B972-C2B5-409D-866A-BE5E5E67526A}"/>
+                <a16:creationId xmlns:a16="http://schemas.microsoft.com/office/drawing/2014/main" id="{D9BE1A81-483C-4207-B51E-C1959D253096}"/>
               </a:ext>
             </a:extLst>
           </p:cNvPr>
@@ -11381,7 +11381,7 @@
           <p:cNvPr id="2" name="">
             <a:extLst xmlns:a="http://schemas.openxmlformats.org/drawingml/2006/main">
               <a:ext uri="{FF2B5EF4-FFF2-40B4-BE49-F238E27FC236}">
-                <a16:creationId xmlns:a16="http://schemas.microsoft.com/office/drawing/2014/main" id="{E808F087-911E-4CBF-B2DB-F7050BFDA0FB}"/>
+                <a16:creationId xmlns:a16="http://schemas.microsoft.com/office/drawing/2014/main" id="{C2A7CB12-7ABF-4289-8FD1-C35D6225F3D6}"/>
               </a:ext>
             </a:extLst>
           </p:cNvPr>
@@ -11412,7 +11412,7 @@
           <p:cNvPr id="3" name="">
             <a:extLst xmlns:a="http://schemas.openxmlformats.org/drawingml/2006/main">
               <a:ext uri="{FF2B5EF4-FFF2-40B4-BE49-F238E27FC236}">
-                <a16:creationId xmlns:a16="http://schemas.microsoft.com/office/drawing/2014/main" id="{E5E00619-BABE-4EF1-A702-A91CA02776F9}"/>
+                <a16:creationId xmlns:a16="http://schemas.microsoft.com/office/drawing/2014/main" id="{5AFBE873-BD6A-4BE2-BC2D-58D5C01FBF88}"/>
               </a:ext>
             </a:extLst>
           </p:cNvPr>
@@ -11569,7 +11569,7 @@
           <p:cNvPr id="4" name="">
             <a:extLst xmlns:a="http://schemas.openxmlformats.org/drawingml/2006/main">
               <a:ext uri="{FF2B5EF4-FFF2-40B4-BE49-F238E27FC236}">
-                <a16:creationId xmlns:a16="http://schemas.microsoft.com/office/drawing/2014/main" id="{1A68FB13-9546-40A6-BC39-6A42DE35B019}"/>
+                <a16:creationId xmlns:a16="http://schemas.microsoft.com/office/drawing/2014/main" id="{EA8E970D-8772-4A1B-87BD-85C4E225B6EF}"/>
               </a:ext>
             </a:extLst>
           </p:cNvPr>
@@ -11600,7 +11600,7 @@
           <p:cNvPr id="5" name="">
             <a:extLst xmlns:a="http://schemas.openxmlformats.org/drawingml/2006/main">
               <a:ext uri="{FF2B5EF4-FFF2-40B4-BE49-F238E27FC236}">
-                <a16:creationId xmlns:a16="http://schemas.microsoft.com/office/drawing/2014/main" id="{C995B73F-4E1D-462D-A709-B29AE88138F3}"/>
+                <a16:creationId xmlns:a16="http://schemas.microsoft.com/office/drawing/2014/main" id="{58E62A5D-99EE-42CC-957B-B6F9FAEDEFF1}"/>
               </a:ext>
             </a:extLst>
           </p:cNvPr>
@@ -11757,7 +11757,7 @@
           <p:cNvPr id="6" name="">
             <a:extLst xmlns:a="http://schemas.openxmlformats.org/drawingml/2006/main">
               <a:ext uri="{FF2B5EF4-FFF2-40B4-BE49-F238E27FC236}">
-                <a16:creationId xmlns:a16="http://schemas.microsoft.com/office/drawing/2014/main" id="{EA8476E6-BEF3-4BB3-8401-9BD5215B239F}"/>
+                <a16:creationId xmlns:a16="http://schemas.microsoft.com/office/drawing/2014/main" id="{8C2DB62B-A619-4621-9EFC-CE8001E0D9DF}"/>
               </a:ext>
             </a:extLst>
           </p:cNvPr>
@@ -11788,7 +11788,7 @@
           <p:cNvPr id="7" name="">
             <a:extLst xmlns:a="http://schemas.openxmlformats.org/drawingml/2006/main">
               <a:ext uri="{FF2B5EF4-FFF2-40B4-BE49-F238E27FC236}">
-                <a16:creationId xmlns:a16="http://schemas.microsoft.com/office/drawing/2014/main" id="{7D100D58-4453-4F29-B1A3-FB03FD7DDAB1}"/>
+                <a16:creationId xmlns:a16="http://schemas.microsoft.com/office/drawing/2014/main" id="{42570FBF-5D40-481C-906F-416B2C1E0D67}"/>
               </a:ext>
             </a:extLst>
           </p:cNvPr>
@@ -11968,7 +11968,7 @@
           <p:cNvPr id="8" name="">
             <a:extLst xmlns:a="http://schemas.openxmlformats.org/drawingml/2006/main">
               <a:ext uri="{FF2B5EF4-FFF2-40B4-BE49-F238E27FC236}">
-                <a16:creationId xmlns:a16="http://schemas.microsoft.com/office/drawing/2014/main" id="{B1CF50BA-A4AA-41F6-A566-31BC20E381B6}"/>
+                <a16:creationId xmlns:a16="http://schemas.microsoft.com/office/drawing/2014/main" id="{FFB41E35-88E9-41F1-9B0F-1F2B90656553}"/>
               </a:ext>
             </a:extLst>
           </p:cNvPr>
@@ -12125,7 +12125,7 @@
           <p:cNvPr id="9" name="">
             <a:extLst xmlns:a="http://schemas.openxmlformats.org/drawingml/2006/main">
               <a:ext uri="{FF2B5EF4-FFF2-40B4-BE49-F238E27FC236}">
-                <a16:creationId xmlns:a16="http://schemas.microsoft.com/office/drawing/2014/main" id="{3B0F2248-C577-45B0-A92D-F8EF00D10BE8}"/>
+                <a16:creationId xmlns:a16="http://schemas.microsoft.com/office/drawing/2014/main" id="{E2FC2F1E-D091-4E15-891E-9D6B9D508515}"/>
               </a:ext>
             </a:extLst>
           </p:cNvPr>
@@ -12156,7 +12156,7 @@
           <p:cNvPr id="10" name="">
             <a:extLst xmlns:a="http://schemas.openxmlformats.org/drawingml/2006/main">
               <a:ext uri="{FF2B5EF4-FFF2-40B4-BE49-F238E27FC236}">
-                <a16:creationId xmlns:a16="http://schemas.microsoft.com/office/drawing/2014/main" id="{B1CA5847-0243-48BC-BEBC-1C574A351D13}"/>
+                <a16:creationId xmlns:a16="http://schemas.microsoft.com/office/drawing/2014/main" id="{4DC48254-C1DC-4FDC-8E05-B0553A1FD2EC}"/>
               </a:ext>
             </a:extLst>
           </p:cNvPr>
@@ -12336,7 +12336,7 @@
           <p:cNvPr id="11" name="">
             <a:extLst xmlns:a="http://schemas.openxmlformats.org/drawingml/2006/main">
               <a:ext uri="{FF2B5EF4-FFF2-40B4-BE49-F238E27FC236}">
-                <a16:creationId xmlns:a16="http://schemas.microsoft.com/office/drawing/2014/main" id="{2CC124C6-E515-4CED-AAE1-3E3DF77A7211}"/>
+                <a16:creationId xmlns:a16="http://schemas.microsoft.com/office/drawing/2014/main" id="{0CE808C4-BA93-4D12-8288-EB55F8B718AE}"/>
               </a:ext>
             </a:extLst>
           </p:cNvPr>
@@ -12493,7 +12493,7 @@
           <p:cNvPr id="12" name="">
             <a:extLst xmlns:a="http://schemas.openxmlformats.org/drawingml/2006/main">
               <a:ext uri="{FF2B5EF4-FFF2-40B4-BE49-F238E27FC236}">
-                <a16:creationId xmlns:a16="http://schemas.microsoft.com/office/drawing/2014/main" id="{0A7CAA4A-B01C-4DA6-BFC8-48E58A18ECAE}"/>
+                <a16:creationId xmlns:a16="http://schemas.microsoft.com/office/drawing/2014/main" id="{6F55058D-E9DF-45A1-A723-F8381E5FF006}"/>
               </a:ext>
             </a:extLst>
           </p:cNvPr>
@@ -12524,7 +12524,7 @@
           <p:cNvPr id="13" name="">
             <a:extLst xmlns:a="http://schemas.openxmlformats.org/drawingml/2006/main">
               <a:ext uri="{FF2B5EF4-FFF2-40B4-BE49-F238E27FC236}">
-                <a16:creationId xmlns:a16="http://schemas.microsoft.com/office/drawing/2014/main" id="{880FE39D-D801-4815-87FC-652B9B660571}"/>
+                <a16:creationId xmlns:a16="http://schemas.microsoft.com/office/drawing/2014/main" id="{EFA3C39B-3707-4DA4-A304-CEA6A86F744D}"/>
               </a:ext>
             </a:extLst>
           </p:cNvPr>
@@ -12704,7 +12704,7 @@
           <p:cNvPr id="14" name="">
             <a:extLst xmlns:a="http://schemas.openxmlformats.org/drawingml/2006/main">
               <a:ext uri="{FF2B5EF4-FFF2-40B4-BE49-F238E27FC236}">
-                <a16:creationId xmlns:a16="http://schemas.microsoft.com/office/drawing/2014/main" id="{67C3D0B5-4353-4F98-86F6-A6A29F7E0379}"/>
+                <a16:creationId xmlns:a16="http://schemas.microsoft.com/office/drawing/2014/main" id="{D1B2B2E2-C7B2-4461-A029-C83BA86D8F43}"/>
               </a:ext>
             </a:extLst>
           </p:cNvPr>
@@ -12861,7 +12861,7 @@
           <p:cNvPr id="15" name="">
             <a:extLst xmlns:a="http://schemas.openxmlformats.org/drawingml/2006/main">
               <a:ext uri="{FF2B5EF4-FFF2-40B4-BE49-F238E27FC236}">
-                <a16:creationId xmlns:a16="http://schemas.microsoft.com/office/drawing/2014/main" id="{021A4F33-6776-4BD1-BE70-92323DBC1B5D}"/>
+                <a16:creationId xmlns:a16="http://schemas.microsoft.com/office/drawing/2014/main" id="{2C41F1FE-7A72-4C78-B01C-14D12799219C}"/>
               </a:ext>
             </a:extLst>
           </p:cNvPr>
@@ -12892,7 +12892,7 @@
           <p:cNvPr id="16" name="">
             <a:extLst xmlns:a="http://schemas.openxmlformats.org/drawingml/2006/main">
               <a:ext uri="{FF2B5EF4-FFF2-40B4-BE49-F238E27FC236}">
-                <a16:creationId xmlns:a16="http://schemas.microsoft.com/office/drawing/2014/main" id="{BD33FC41-8FCE-422E-8100-BECAA41DBB34}"/>
+                <a16:creationId xmlns:a16="http://schemas.microsoft.com/office/drawing/2014/main" id="{FFF326C6-1EDB-4D00-8E0B-FB5B4FBCED6D}"/>
               </a:ext>
             </a:extLst>
           </p:cNvPr>
@@ -13072,7 +13072,7 @@
           <p:cNvPr id="17" name="">
             <a:extLst xmlns:a="http://schemas.openxmlformats.org/drawingml/2006/main">
               <a:ext uri="{FF2B5EF4-FFF2-40B4-BE49-F238E27FC236}">
-                <a16:creationId xmlns:a16="http://schemas.microsoft.com/office/drawing/2014/main" id="{75A3DC89-7AE5-4F1C-8D35-EA8528A7DC51}"/>
+                <a16:creationId xmlns:a16="http://schemas.microsoft.com/office/drawing/2014/main" id="{FBAF4E65-A2AE-46DC-91E7-3048A42B56F4}"/>
               </a:ext>
             </a:extLst>
           </p:cNvPr>
@@ -13432,7 +13432,7 @@
           <p:cNvPr id="18" name="">
             <a:extLst xmlns:a="http://schemas.openxmlformats.org/drawingml/2006/main">
               <a:ext uri="{FF2B5EF4-FFF2-40B4-BE49-F238E27FC236}">
-                <a16:creationId xmlns:a16="http://schemas.microsoft.com/office/drawing/2014/main" id="{EB8A9277-C76A-44B4-82D3-481B61CAE105}"/>
+                <a16:creationId xmlns:a16="http://schemas.microsoft.com/office/drawing/2014/main" id="{0533ED10-9146-4E03-A969-193DD665765D}"/>
               </a:ext>
             </a:extLst>
           </p:cNvPr>
@@ -13587,7 +13587,7 @@
     </p:spTree>
     <p:extLst>
       <p:ext uri="{BB962C8B-B14F-4D97-AF65-F5344CB8AC3E}">
-        <p14:creationId xmlns:p14="http://schemas.microsoft.com/office/powerpoint/2010/main" val="287037744"/>
+        <p14:creationId xmlns:p14="http://schemas.microsoft.com/office/powerpoint/2010/main" val="887839256"/>
       </p:ext>
     </p:extLst>
   </p:cSld>
@@ -13618,7 +13618,7 @@
           <p:cNvPr id="26" name="">
             <a:extLst xmlns:a="http://schemas.openxmlformats.org/drawingml/2006/main">
               <a:ext uri="{FF2B5EF4-FFF2-40B4-BE49-F238E27FC236}">
-                <a16:creationId xmlns:a16="http://schemas.microsoft.com/office/drawing/2014/main" id="{7C54A32A-3815-4072-8486-DA61AAA7CEFA}"/>
+                <a16:creationId xmlns:a16="http://schemas.microsoft.com/office/drawing/2014/main" id="{CA6AAAA5-8A81-404D-869A-1530C6BEF761}"/>
               </a:ext>
             </a:extLst>
           </p:cNvPr>
@@ -13775,7 +13775,7 @@
           <p:cNvPr id="2" name="">
             <a:extLst xmlns:a="http://schemas.openxmlformats.org/drawingml/2006/main">
               <a:ext uri="{FF2B5EF4-FFF2-40B4-BE49-F238E27FC236}">
-                <a16:creationId xmlns:a16="http://schemas.microsoft.com/office/drawing/2014/main" id="{EEF84E9F-F821-4D0F-ACB2-2691702161EB}"/>
+                <a16:creationId xmlns:a16="http://schemas.microsoft.com/office/drawing/2014/main" id="{49F9F680-E2D0-4128-A289-3EC56C92B8FE}"/>
               </a:ext>
             </a:extLst>
           </p:cNvPr>
@@ -13806,7 +13806,7 @@
           <p:cNvPr id="3" name="">
             <a:extLst xmlns:a="http://schemas.openxmlformats.org/drawingml/2006/main">
               <a:ext uri="{FF2B5EF4-FFF2-40B4-BE49-F238E27FC236}">
-                <a16:creationId xmlns:a16="http://schemas.microsoft.com/office/drawing/2014/main" id="{DF7D03EA-7A13-4015-AEE4-FC506B6FFDEE}"/>
+                <a16:creationId xmlns:a16="http://schemas.microsoft.com/office/drawing/2014/main" id="{9CF89B9C-AF2F-4F57-BF57-7DD4BD461FF7}"/>
               </a:ext>
             </a:extLst>
           </p:cNvPr>
@@ -13963,7 +13963,7 @@
           <p:cNvPr id="4" name="">
             <a:extLst xmlns:a="http://schemas.openxmlformats.org/drawingml/2006/main">
               <a:ext uri="{FF2B5EF4-FFF2-40B4-BE49-F238E27FC236}">
-                <a16:creationId xmlns:a16="http://schemas.microsoft.com/office/drawing/2014/main" id="{8799C24C-7741-4DE9-BA30-050DFBD9CD3E}"/>
+                <a16:creationId xmlns:a16="http://schemas.microsoft.com/office/drawing/2014/main" id="{68EB617C-500B-4820-9C80-90353321A234}"/>
               </a:ext>
             </a:extLst>
           </p:cNvPr>
@@ -13996,7 +13996,7 @@
           <p:cNvPr id="5" name="">
             <a:extLst xmlns:a="http://schemas.openxmlformats.org/drawingml/2006/main">
               <a:ext uri="{FF2B5EF4-FFF2-40B4-BE49-F238E27FC236}">
-                <a16:creationId xmlns:a16="http://schemas.microsoft.com/office/drawing/2014/main" id="{DD2475DB-F152-48B4-8504-591CC1B4FECF}"/>
+                <a16:creationId xmlns:a16="http://schemas.microsoft.com/office/drawing/2014/main" id="{84FE4167-8D13-43EB-BCFD-255503E158D6}"/>
               </a:ext>
             </a:extLst>
           </p:cNvPr>
@@ -14153,7 +14153,7 @@
           <p:cNvPr id="6" name="">
             <a:extLst xmlns:a="http://schemas.openxmlformats.org/drawingml/2006/main">
               <a:ext uri="{FF2B5EF4-FFF2-40B4-BE49-F238E27FC236}">
-                <a16:creationId xmlns:a16="http://schemas.microsoft.com/office/drawing/2014/main" id="{DC6A51D9-2DC9-44F4-B5F0-0D70868856B3}"/>
+                <a16:creationId xmlns:a16="http://schemas.microsoft.com/office/drawing/2014/main" id="{CA2CFBB4-CDA7-478F-A861-6BEE78FB5A89}"/>
               </a:ext>
             </a:extLst>
           </p:cNvPr>
@@ -14333,7 +14333,7 @@
           <p:cNvPr id="7" name="">
             <a:extLst xmlns:a="http://schemas.openxmlformats.org/drawingml/2006/main">
               <a:ext uri="{FF2B5EF4-FFF2-40B4-BE49-F238E27FC236}">
-                <a16:creationId xmlns:a16="http://schemas.microsoft.com/office/drawing/2014/main" id="{34C51783-D148-48A6-B5C7-F1B7C4A5574C}"/>
+                <a16:creationId xmlns:a16="http://schemas.microsoft.com/office/drawing/2014/main" id="{7F814513-A9B6-4BDF-A5C6-A88733040A7C}"/>
               </a:ext>
             </a:extLst>
           </p:cNvPr>
@@ -14364,7 +14364,7 @@
           <p:cNvPr id="8" name="">
             <a:extLst xmlns:a="http://schemas.openxmlformats.org/drawingml/2006/main">
               <a:ext uri="{FF2B5EF4-FFF2-40B4-BE49-F238E27FC236}">
-                <a16:creationId xmlns:a16="http://schemas.microsoft.com/office/drawing/2014/main" id="{61B41862-A24B-48E0-B6A5-D1C27CDD7CF0}"/>
+                <a16:creationId xmlns:a16="http://schemas.microsoft.com/office/drawing/2014/main" id="{89142216-456F-4880-9374-9B2891577593}"/>
               </a:ext>
             </a:extLst>
           </p:cNvPr>
@@ -14397,7 +14397,7 @@
           <p:cNvPr id="9" name="">
             <a:extLst xmlns:a="http://schemas.openxmlformats.org/drawingml/2006/main">
               <a:ext uri="{FF2B5EF4-FFF2-40B4-BE49-F238E27FC236}">
-                <a16:creationId xmlns:a16="http://schemas.microsoft.com/office/drawing/2014/main" id="{5B484FC7-01D9-462E-B4CB-6895ECF6BB64}"/>
+                <a16:creationId xmlns:a16="http://schemas.microsoft.com/office/drawing/2014/main" id="{DEF1C42D-798C-423E-ACAC-9D25D88C12F7}"/>
               </a:ext>
             </a:extLst>
           </p:cNvPr>
@@ -14554,7 +14554,7 @@
           <p:cNvPr id="10" name="">
             <a:extLst xmlns:a="http://schemas.openxmlformats.org/drawingml/2006/main">
               <a:ext uri="{FF2B5EF4-FFF2-40B4-BE49-F238E27FC236}">
-                <a16:creationId xmlns:a16="http://schemas.microsoft.com/office/drawing/2014/main" id="{71302469-6CC9-4F7C-9B97-8FAE74FC215A}"/>
+                <a16:creationId xmlns:a16="http://schemas.microsoft.com/office/drawing/2014/main" id="{011DCD78-B12E-4CBF-BA8E-643DDB68814A}"/>
               </a:ext>
             </a:extLst>
           </p:cNvPr>
@@ -14734,7 +14734,7 @@
           <p:cNvPr id="11" name="">
             <a:extLst xmlns:a="http://schemas.openxmlformats.org/drawingml/2006/main">
               <a:ext uri="{FF2B5EF4-FFF2-40B4-BE49-F238E27FC236}">
-                <a16:creationId xmlns:a16="http://schemas.microsoft.com/office/drawing/2014/main" id="{D3EFF310-008B-47FA-BD80-847EB8A68CEE}"/>
+                <a16:creationId xmlns:a16="http://schemas.microsoft.com/office/drawing/2014/main" id="{9F05C906-3EE0-4D9C-A760-0D1080DE0403}"/>
               </a:ext>
             </a:extLst>
           </p:cNvPr>
@@ -14765,7 +14765,7 @@
           <p:cNvPr id="12" name="">
             <a:extLst xmlns:a="http://schemas.openxmlformats.org/drawingml/2006/main">
               <a:ext uri="{FF2B5EF4-FFF2-40B4-BE49-F238E27FC236}">
-                <a16:creationId xmlns:a16="http://schemas.microsoft.com/office/drawing/2014/main" id="{8BAF8364-FAFF-4773-A78A-36A09628980F}"/>
+                <a16:creationId xmlns:a16="http://schemas.microsoft.com/office/drawing/2014/main" id="{5C956702-670C-4726-932A-0DC167881E22}"/>
               </a:ext>
             </a:extLst>
           </p:cNvPr>
@@ -14798,7 +14798,7 @@
           <p:cNvPr id="13" name="">
             <a:extLst xmlns:a="http://schemas.openxmlformats.org/drawingml/2006/main">
               <a:ext uri="{FF2B5EF4-FFF2-40B4-BE49-F238E27FC236}">
-                <a16:creationId xmlns:a16="http://schemas.microsoft.com/office/drawing/2014/main" id="{92E658B0-509A-45CD-AB37-501FB5A5F7F3}"/>
+                <a16:creationId xmlns:a16="http://schemas.microsoft.com/office/drawing/2014/main" id="{6F32E454-C378-4049-ACF3-D7B6F2A30D37}"/>
               </a:ext>
             </a:extLst>
           </p:cNvPr>
@@ -14955,7 +14955,7 @@
           <p:cNvPr id="14" name="">
             <a:extLst xmlns:a="http://schemas.openxmlformats.org/drawingml/2006/main">
               <a:ext uri="{FF2B5EF4-FFF2-40B4-BE49-F238E27FC236}">
-                <a16:creationId xmlns:a16="http://schemas.microsoft.com/office/drawing/2014/main" id="{F838A9EE-8511-4B48-9D54-C53DFFC79CA9}"/>
+                <a16:creationId xmlns:a16="http://schemas.microsoft.com/office/drawing/2014/main" id="{DE6CA61B-C77E-4D2E-92D5-DF4054819DE2}"/>
               </a:ext>
             </a:extLst>
           </p:cNvPr>
@@ -15135,7 +15135,7 @@
           <p:cNvPr id="15" name="">
             <a:extLst xmlns:a="http://schemas.openxmlformats.org/drawingml/2006/main">
               <a:ext uri="{FF2B5EF4-FFF2-40B4-BE49-F238E27FC236}">
-                <a16:creationId xmlns:a16="http://schemas.microsoft.com/office/drawing/2014/main" id="{E02E4491-AA08-4887-9931-8307BDB4F129}"/>
+                <a16:creationId xmlns:a16="http://schemas.microsoft.com/office/drawing/2014/main" id="{22185392-B8B1-43F2-BA18-FB90F9F5B26E}"/>
               </a:ext>
             </a:extLst>
           </p:cNvPr>
@@ -15166,7 +15166,7 @@
           <p:cNvPr id="16" name="">
             <a:extLst xmlns:a="http://schemas.openxmlformats.org/drawingml/2006/main">
               <a:ext uri="{FF2B5EF4-FFF2-40B4-BE49-F238E27FC236}">
-                <a16:creationId xmlns:a16="http://schemas.microsoft.com/office/drawing/2014/main" id="{A205E000-F341-40D8-81C0-7244F806C4AF}"/>
+                <a16:creationId xmlns:a16="http://schemas.microsoft.com/office/drawing/2014/main" id="{4F689F70-6776-4695-AF83-D604A29D1576}"/>
               </a:ext>
             </a:extLst>
           </p:cNvPr>
@@ -15199,7 +15199,7 @@
           <p:cNvPr id="17" name="">
             <a:extLst xmlns:a="http://schemas.openxmlformats.org/drawingml/2006/main">
               <a:ext uri="{FF2B5EF4-FFF2-40B4-BE49-F238E27FC236}">
-                <a16:creationId xmlns:a16="http://schemas.microsoft.com/office/drawing/2014/main" id="{DFE85D7B-491C-4A42-AD59-1E1E85B14ED6}"/>
+                <a16:creationId xmlns:a16="http://schemas.microsoft.com/office/drawing/2014/main" id="{98E06B08-7ADF-4859-8855-D497B72EF748}"/>
               </a:ext>
             </a:extLst>
           </p:cNvPr>
@@ -15356,7 +15356,7 @@
           <p:cNvPr id="18" name="">
             <a:extLst xmlns:a="http://schemas.openxmlformats.org/drawingml/2006/main">
               <a:ext uri="{FF2B5EF4-FFF2-40B4-BE49-F238E27FC236}">
-                <a16:creationId xmlns:a16="http://schemas.microsoft.com/office/drawing/2014/main" id="{9B2C2A19-1A26-400F-89F8-A9337B455F2D}"/>
+                <a16:creationId xmlns:a16="http://schemas.microsoft.com/office/drawing/2014/main" id="{41CBC1F0-4C0A-46D4-8A68-4E935BDFC655}"/>
               </a:ext>
             </a:extLst>
           </p:cNvPr>
@@ -15536,7 +15536,7 @@
           <p:cNvPr id="19" name="">
             <a:extLst xmlns:a="http://schemas.openxmlformats.org/drawingml/2006/main">
               <a:ext uri="{FF2B5EF4-FFF2-40B4-BE49-F238E27FC236}">
-                <a16:creationId xmlns:a16="http://schemas.microsoft.com/office/drawing/2014/main" id="{55F3A9AA-F8AF-4753-AE1F-D63D04AA61F0}"/>
+                <a16:creationId xmlns:a16="http://schemas.microsoft.com/office/drawing/2014/main" id="{100955FA-7BEA-414F-90D4-3EB79131816F}"/>
               </a:ext>
             </a:extLst>
           </p:cNvPr>
@@ -15693,7 +15693,7 @@
           <p:cNvPr id="20" name="">
             <a:extLst xmlns:a="http://schemas.openxmlformats.org/drawingml/2006/main">
               <a:ext uri="{FF2B5EF4-FFF2-40B4-BE49-F238E27FC236}">
-                <a16:creationId xmlns:a16="http://schemas.microsoft.com/office/drawing/2014/main" id="{8CABED76-DB69-4D7C-B5A4-EEDEC4927743}"/>
+                <a16:creationId xmlns:a16="http://schemas.microsoft.com/office/drawing/2014/main" id="{F327A761-63B2-41A5-A8A4-E771DAD3C47F}"/>
               </a:ext>
             </a:extLst>
           </p:cNvPr>
@@ -15850,7 +15850,7 @@
           <p:cNvPr id="21" name="">
             <a:extLst xmlns:a="http://schemas.openxmlformats.org/drawingml/2006/main">
               <a:ext uri="{FF2B5EF4-FFF2-40B4-BE49-F238E27FC236}">
-                <a16:creationId xmlns:a16="http://schemas.microsoft.com/office/drawing/2014/main" id="{4893A5DE-E21F-45EC-A9FA-07104CC1D90E}"/>
+                <a16:creationId xmlns:a16="http://schemas.microsoft.com/office/drawing/2014/main" id="{4D1FE740-07BD-4F31-A429-7736ACDC3572}"/>
               </a:ext>
             </a:extLst>
           </p:cNvPr>
@@ -16007,7 +16007,7 @@
           <p:cNvPr id="22" name="">
             <a:extLst xmlns:a="http://schemas.openxmlformats.org/drawingml/2006/main">
               <a:ext uri="{FF2B5EF4-FFF2-40B4-BE49-F238E27FC236}">
-                <a16:creationId xmlns:a16="http://schemas.microsoft.com/office/drawing/2014/main" id="{D06D525F-C610-4B79-899A-C25AD4F8E432}"/>
+                <a16:creationId xmlns:a16="http://schemas.microsoft.com/office/drawing/2014/main" id="{A88D7CC2-634C-4FB3-97CD-5298B2987476}"/>
               </a:ext>
             </a:extLst>
           </p:cNvPr>
@@ -16164,7 +16164,7 @@
           <p:cNvPr id="23" name="">
             <a:extLst xmlns:a="http://schemas.openxmlformats.org/drawingml/2006/main">
               <a:ext uri="{FF2B5EF4-FFF2-40B4-BE49-F238E27FC236}">
-                <a16:creationId xmlns:a16="http://schemas.microsoft.com/office/drawing/2014/main" id="{AB50BCBA-9868-4DC3-8A60-26F64F2328B2}"/>
+                <a16:creationId xmlns:a16="http://schemas.microsoft.com/office/drawing/2014/main" id="{6FD7E6D3-8D13-4660-AC5A-5378837E6BED}"/>
               </a:ext>
             </a:extLst>
           </p:cNvPr>
@@ -16321,7 +16321,7 @@
           <p:cNvPr id="24" name="">
             <a:extLst xmlns:a="http://schemas.openxmlformats.org/drawingml/2006/main">
               <a:ext uri="{FF2B5EF4-FFF2-40B4-BE49-F238E27FC236}">
-                <a16:creationId xmlns:a16="http://schemas.microsoft.com/office/drawing/2014/main" id="{BD4A4B69-103C-4BB1-8BDC-D5D0D6E1079D}"/>
+                <a16:creationId xmlns:a16="http://schemas.microsoft.com/office/drawing/2014/main" id="{2E5D38BC-04CF-466C-AF4E-9D56666E97B5}"/>
               </a:ext>
             </a:extLst>
           </p:cNvPr>
@@ -16478,7 +16478,7 @@
           <p:cNvPr id="25" name="">
             <a:extLst xmlns:a="http://schemas.openxmlformats.org/drawingml/2006/main">
               <a:ext uri="{FF2B5EF4-FFF2-40B4-BE49-F238E27FC236}">
-                <a16:creationId xmlns:a16="http://schemas.microsoft.com/office/drawing/2014/main" id="{843731BD-EB19-4E39-9E28-D993F8188C19}"/>
+                <a16:creationId xmlns:a16="http://schemas.microsoft.com/office/drawing/2014/main" id="{98318B96-8611-4B20-AE9E-4DF387E6E98F}"/>
               </a:ext>
             </a:extLst>
           </p:cNvPr>
@@ -16633,7 +16633,7 @@
     </p:spTree>
     <p:extLst>
       <p:ext uri="{BB962C8B-B14F-4D97-AF65-F5344CB8AC3E}">
-        <p14:creationId xmlns:p14="http://schemas.microsoft.com/office/powerpoint/2010/main" val="2031457124"/>
+        <p14:creationId xmlns:p14="http://schemas.microsoft.com/office/powerpoint/2010/main" val="822681312"/>
       </p:ext>
     </p:extLst>
   </p:cSld>
@@ -16664,7 +16664,7 @@
           <p:cNvPr id="10" name="">
             <a:extLst xmlns:a="http://schemas.openxmlformats.org/drawingml/2006/main">
               <a:ext uri="{FF2B5EF4-FFF2-40B4-BE49-F238E27FC236}">
-                <a16:creationId xmlns:a16="http://schemas.microsoft.com/office/drawing/2014/main" id="{39824401-A2FF-4923-850C-32A21930D602}"/>
+                <a16:creationId xmlns:a16="http://schemas.microsoft.com/office/drawing/2014/main" id="{827E1D44-52B2-4DD6-B323-96469FED7AC5}"/>
               </a:ext>
             </a:extLst>
           </p:cNvPr>
@@ -16821,7 +16821,7 @@
           <p:cNvPr id="2" name="">
             <a:extLst xmlns:a="http://schemas.openxmlformats.org/drawingml/2006/main">
               <a:ext uri="{FF2B5EF4-FFF2-40B4-BE49-F238E27FC236}">
-                <a16:creationId xmlns:a16="http://schemas.microsoft.com/office/drawing/2014/main" id="{7AB70AD3-96B8-4569-82ED-2EA1FF2B7AF0}"/>
+                <a16:creationId xmlns:a16="http://schemas.microsoft.com/office/drawing/2014/main" id="{C25FBDE0-CAED-4B13-8CA4-EFA74F3105C8}"/>
               </a:ext>
             </a:extLst>
           </p:cNvPr>
@@ -16852,7 +16852,7 @@
           <p:cNvPr id="3" name="">
             <a:extLst xmlns:a="http://schemas.openxmlformats.org/drawingml/2006/main">
               <a:ext uri="{FF2B5EF4-FFF2-40B4-BE49-F238E27FC236}">
-                <a16:creationId xmlns:a16="http://schemas.microsoft.com/office/drawing/2014/main" id="{C239289C-1576-476C-9E77-B90166812299}"/>
+                <a16:creationId xmlns:a16="http://schemas.microsoft.com/office/drawing/2014/main" id="{C4F2A122-EA6C-493A-B3D2-04A04FB5B013}"/>
               </a:ext>
             </a:extLst>
           </p:cNvPr>
@@ -17009,7 +17009,7 @@
           <p:cNvPr id="4" name="Chart">
             <a:extLst xmlns:a="http://schemas.openxmlformats.org/drawingml/2006/main">
               <a:ext uri="{FF2B5EF4-FFF2-40B4-BE49-F238E27FC236}">
-                <a16:creationId xmlns:a16="http://schemas.microsoft.com/office/drawing/2014/main" id="{F71DAC06-0777-4BF8-A0EE-8E2D0C09123C}"/>
+                <a16:creationId xmlns:a16="http://schemas.microsoft.com/office/drawing/2014/main" id="{7F80B7D5-A039-4FF2-BCA3-D9F0400A34EE}"/>
               </a:ext>
             </a:extLst>
           </p:cNvPr>
@@ -17022,7 +17022,7 @@
         </p:xfrm>
         <a:graphic xmlns:a="http://schemas.openxmlformats.org/drawingml/2006/main">
           <a:graphicData uri="http://schemas.openxmlformats.org/drawingml/2006/chart">
-            <c:chart xmlns:r="http://schemas.openxmlformats.org/officeDocument/2006/relationships" xmlns:c="http://schemas.openxmlformats.org/drawingml/2006/chart" r:id="R3692c6145d6849ab"/>
+            <c:chart xmlns:r="http://schemas.openxmlformats.org/officeDocument/2006/relationships" xmlns:c="http://schemas.openxmlformats.org/drawingml/2006/chart" r:id="Rea2270456c4643af"/>
           </a:graphicData>
         </a:graphic>
       </p:graphicFrame>
@@ -17031,7 +17031,7 @@
           <p:cNvPr id="5" name="">
             <a:extLst xmlns:a="http://schemas.openxmlformats.org/drawingml/2006/main">
               <a:ext uri="{FF2B5EF4-FFF2-40B4-BE49-F238E27FC236}">
-                <a16:creationId xmlns:a16="http://schemas.microsoft.com/office/drawing/2014/main" id="{5D26C32D-B5F5-4D40-9C4E-E9B02252B8FC}"/>
+                <a16:creationId xmlns:a16="http://schemas.microsoft.com/office/drawing/2014/main" id="{8B48AC75-7E67-460B-8B01-11D9812A29A5}"/>
               </a:ext>
             </a:extLst>
           </p:cNvPr>
@@ -17188,7 +17188,7 @@
           <p:cNvPr id="6" name="">
             <a:extLst xmlns:a="http://schemas.openxmlformats.org/drawingml/2006/main">
               <a:ext uri="{FF2B5EF4-FFF2-40B4-BE49-F238E27FC236}">
-                <a16:creationId xmlns:a16="http://schemas.microsoft.com/office/drawing/2014/main" id="{535D4636-7F0A-4897-9BC2-4ED949BD4D3E}"/>
+                <a16:creationId xmlns:a16="http://schemas.microsoft.com/office/drawing/2014/main" id="{26805666-5702-4DCF-8E50-538EFD015313}"/>
               </a:ext>
             </a:extLst>
           </p:cNvPr>
@@ -17368,7 +17368,7 @@
           <p:cNvPr id="7" name="">
             <a:extLst xmlns:a="http://schemas.openxmlformats.org/drawingml/2006/main">
               <a:ext uri="{FF2B5EF4-FFF2-40B4-BE49-F238E27FC236}">
-                <a16:creationId xmlns:a16="http://schemas.microsoft.com/office/drawing/2014/main" id="{0F441457-465D-4496-BBA3-F46305840B2C}"/>
+                <a16:creationId xmlns:a16="http://schemas.microsoft.com/office/drawing/2014/main" id="{9B6548B0-EA86-4C6A-88DD-CB05CCE7C75C}"/>
               </a:ext>
             </a:extLst>
           </p:cNvPr>
@@ -17525,7 +17525,7 @@
           <p:cNvPr id="8" name="">
             <a:extLst xmlns:a="http://schemas.openxmlformats.org/drawingml/2006/main">
               <a:ext uri="{FF2B5EF4-FFF2-40B4-BE49-F238E27FC236}">
-                <a16:creationId xmlns:a16="http://schemas.microsoft.com/office/drawing/2014/main" id="{62982E7C-3436-4F8E-BAB3-E7A4EFEADC53}"/>
+                <a16:creationId xmlns:a16="http://schemas.microsoft.com/office/drawing/2014/main" id="{BD8800B9-4675-4A16-99B2-EBF2B10258CF}"/>
               </a:ext>
             </a:extLst>
           </p:cNvPr>
@@ -17705,7 +17705,7 @@
           <p:cNvPr id="9" name="">
             <a:extLst xmlns:a="http://schemas.openxmlformats.org/drawingml/2006/main">
               <a:ext uri="{FF2B5EF4-FFF2-40B4-BE49-F238E27FC236}">
-                <a16:creationId xmlns:a16="http://schemas.microsoft.com/office/drawing/2014/main" id="{33021AE7-55E6-4B31-B8B3-72F0ACF46B7A}"/>
+                <a16:creationId xmlns:a16="http://schemas.microsoft.com/office/drawing/2014/main" id="{B00991AF-3FEE-4D6D-ADC3-B8F28C7159D2}"/>
               </a:ext>
             </a:extLst>
           </p:cNvPr>
@@ -17860,7 +17860,7 @@
     </p:spTree>
     <p:extLst>
       <p:ext uri="{BB962C8B-B14F-4D97-AF65-F5344CB8AC3E}">
-        <p14:creationId xmlns:p14="http://schemas.microsoft.com/office/powerpoint/2010/main" val="1296423497"/>
+        <p14:creationId xmlns:p14="http://schemas.microsoft.com/office/powerpoint/2010/main" val="438219839"/>
       </p:ext>
     </p:extLst>
   </p:cSld>
@@ -17891,7 +17891,7 @@
           <p:cNvPr id="22" name="">
             <a:extLst xmlns:a="http://schemas.openxmlformats.org/drawingml/2006/main">
               <a:ext uri="{FF2B5EF4-FFF2-40B4-BE49-F238E27FC236}">
-                <a16:creationId xmlns:a16="http://schemas.microsoft.com/office/drawing/2014/main" id="{8BB83147-70FF-4C5D-8A9B-E19679610433}"/>
+                <a16:creationId xmlns:a16="http://schemas.microsoft.com/office/drawing/2014/main" id="{B5C55D2F-0A5D-45F2-827E-E7AC93E1D2CE}"/>
               </a:ext>
             </a:extLst>
           </p:cNvPr>
@@ -18048,7 +18048,7 @@
           <p:cNvPr id="2" name="">
             <a:extLst xmlns:a="http://schemas.openxmlformats.org/drawingml/2006/main">
               <a:ext uri="{FF2B5EF4-FFF2-40B4-BE49-F238E27FC236}">
-                <a16:creationId xmlns:a16="http://schemas.microsoft.com/office/drawing/2014/main" id="{F2341EFA-81E8-4E97-BA59-56C9699FC6EF}"/>
+                <a16:creationId xmlns:a16="http://schemas.microsoft.com/office/drawing/2014/main" id="{DEE34D6B-1F84-45AE-BA29-F043329F89DB}"/>
               </a:ext>
             </a:extLst>
           </p:cNvPr>
@@ -18079,7 +18079,7 @@
           <p:cNvPr id="3" name="">
             <a:extLst xmlns:a="http://schemas.openxmlformats.org/drawingml/2006/main">
               <a:ext uri="{FF2B5EF4-FFF2-40B4-BE49-F238E27FC236}">
-                <a16:creationId xmlns:a16="http://schemas.microsoft.com/office/drawing/2014/main" id="{97E90A8B-B01F-40B8-8278-2C810D1881E1}"/>
+                <a16:creationId xmlns:a16="http://schemas.microsoft.com/office/drawing/2014/main" id="{1CDDF730-D2EF-42FC-95CF-ADACA15016E0}"/>
               </a:ext>
             </a:extLst>
           </p:cNvPr>
@@ -18236,7 +18236,7 @@
           <p:cNvPr id="4" name="">
             <a:extLst xmlns:a="http://schemas.openxmlformats.org/drawingml/2006/main">
               <a:ext uri="{FF2B5EF4-FFF2-40B4-BE49-F238E27FC236}">
-                <a16:creationId xmlns:a16="http://schemas.microsoft.com/office/drawing/2014/main" id="{5FCAA8BD-F85D-4850-AFFD-22AED759E74A}"/>
+                <a16:creationId xmlns:a16="http://schemas.microsoft.com/office/drawing/2014/main" id="{6584A696-0255-4A44-9944-4A64F7918C59}"/>
               </a:ext>
             </a:extLst>
           </p:cNvPr>
@@ -18269,7 +18269,7 @@
           <p:cNvPr id="5" name="">
             <a:extLst xmlns:a="http://schemas.openxmlformats.org/drawingml/2006/main">
               <a:ext uri="{FF2B5EF4-FFF2-40B4-BE49-F238E27FC236}">
-                <a16:creationId xmlns:a16="http://schemas.microsoft.com/office/drawing/2014/main" id="{6130BC16-A951-4C84-990E-165BD534CA6B}"/>
+                <a16:creationId xmlns:a16="http://schemas.microsoft.com/office/drawing/2014/main" id="{88BB3B60-0AA5-4447-A6D0-A62A0A199A00}"/>
               </a:ext>
             </a:extLst>
           </p:cNvPr>
@@ -18426,7 +18426,7 @@
           <p:cNvPr id="6" name="">
             <a:extLst xmlns:a="http://schemas.openxmlformats.org/drawingml/2006/main">
               <a:ext uri="{FF2B5EF4-FFF2-40B4-BE49-F238E27FC236}">
-                <a16:creationId xmlns:a16="http://schemas.microsoft.com/office/drawing/2014/main" id="{7AB90C10-1792-4EFC-B7C9-237D5832F8CB}"/>
+                <a16:creationId xmlns:a16="http://schemas.microsoft.com/office/drawing/2014/main" id="{302AE72C-B386-4296-9B8C-8618FFBCCAE0}"/>
               </a:ext>
             </a:extLst>
           </p:cNvPr>
@@ -18606,7 +18606,7 @@
           <p:cNvPr id="7" name="">
             <a:extLst xmlns:a="http://schemas.openxmlformats.org/drawingml/2006/main">
               <a:ext uri="{FF2B5EF4-FFF2-40B4-BE49-F238E27FC236}">
-                <a16:creationId xmlns:a16="http://schemas.microsoft.com/office/drawing/2014/main" id="{16A05DA6-E003-40CD-90F4-DF83213B0FCF}"/>
+                <a16:creationId xmlns:a16="http://schemas.microsoft.com/office/drawing/2014/main" id="{7CB74898-EDE8-43D7-9A4D-B1B80F4589AD}"/>
               </a:ext>
             </a:extLst>
           </p:cNvPr>
@@ -18637,7 +18637,7 @@
           <p:cNvPr id="8" name="">
             <a:extLst xmlns:a="http://schemas.openxmlformats.org/drawingml/2006/main">
               <a:ext uri="{FF2B5EF4-FFF2-40B4-BE49-F238E27FC236}">
-                <a16:creationId xmlns:a16="http://schemas.microsoft.com/office/drawing/2014/main" id="{2C8FC47E-D920-46CE-B84B-2C9FBD126AED}"/>
+                <a16:creationId xmlns:a16="http://schemas.microsoft.com/office/drawing/2014/main" id="{8E71071A-73B8-4524-9654-668C40992601}"/>
               </a:ext>
             </a:extLst>
           </p:cNvPr>
@@ -18670,7 +18670,7 @@
           <p:cNvPr id="9" name="">
             <a:extLst xmlns:a="http://schemas.openxmlformats.org/drawingml/2006/main">
               <a:ext uri="{FF2B5EF4-FFF2-40B4-BE49-F238E27FC236}">
-                <a16:creationId xmlns:a16="http://schemas.microsoft.com/office/drawing/2014/main" id="{07F420B3-5ACB-4A2F-9ECE-75DD56566C24}"/>
+                <a16:creationId xmlns:a16="http://schemas.microsoft.com/office/drawing/2014/main" id="{419274F3-6FC4-4657-809F-B211F5775E7F}"/>
               </a:ext>
             </a:extLst>
           </p:cNvPr>
@@ -18827,7 +18827,7 @@
           <p:cNvPr id="10" name="">
             <a:extLst xmlns:a="http://schemas.openxmlformats.org/drawingml/2006/main">
               <a:ext uri="{FF2B5EF4-FFF2-40B4-BE49-F238E27FC236}">
-                <a16:creationId xmlns:a16="http://schemas.microsoft.com/office/drawing/2014/main" id="{56EDDB5B-2DFF-4F49-9FEF-99C671700051}"/>
+                <a16:creationId xmlns:a16="http://schemas.microsoft.com/office/drawing/2014/main" id="{9B6C4376-14CD-4DB0-8CB6-53549FBFE04D}"/>
               </a:ext>
             </a:extLst>
           </p:cNvPr>
@@ -19007,7 +19007,7 @@
           <p:cNvPr id="11" name="">
             <a:extLst xmlns:a="http://schemas.openxmlformats.org/drawingml/2006/main">
               <a:ext uri="{FF2B5EF4-FFF2-40B4-BE49-F238E27FC236}">
-                <a16:creationId xmlns:a16="http://schemas.microsoft.com/office/drawing/2014/main" id="{FFF45D9B-07DE-4DD2-9AC5-CE3E3AE105B9}"/>
+                <a16:creationId xmlns:a16="http://schemas.microsoft.com/office/drawing/2014/main" id="{CE53EA7E-3C47-4759-BD53-F5838173D3AD}"/>
               </a:ext>
             </a:extLst>
           </p:cNvPr>
@@ -19038,7 +19038,7 @@
           <p:cNvPr id="12" name="">
             <a:extLst xmlns:a="http://schemas.openxmlformats.org/drawingml/2006/main">
               <a:ext uri="{FF2B5EF4-FFF2-40B4-BE49-F238E27FC236}">
-                <a16:creationId xmlns:a16="http://schemas.microsoft.com/office/drawing/2014/main" id="{4FE0872E-458C-4520-AC58-8E9D0306F372}"/>
+                <a16:creationId xmlns:a16="http://schemas.microsoft.com/office/drawing/2014/main" id="{F746E4AD-92A0-435D-82ED-FFE8962BC2A6}"/>
               </a:ext>
             </a:extLst>
           </p:cNvPr>
@@ -19071,7 +19071,7 @@
           <p:cNvPr id="13" name="">
             <a:extLst xmlns:a="http://schemas.openxmlformats.org/drawingml/2006/main">
               <a:ext uri="{FF2B5EF4-FFF2-40B4-BE49-F238E27FC236}">
-                <a16:creationId xmlns:a16="http://schemas.microsoft.com/office/drawing/2014/main" id="{C11D8DD7-2613-4CEE-B2C7-9CC4E4C2A5AC}"/>
+                <a16:creationId xmlns:a16="http://schemas.microsoft.com/office/drawing/2014/main" id="{5C35EE1B-E3DA-43F2-A4BE-19B194BBEBE4}"/>
               </a:ext>
             </a:extLst>
           </p:cNvPr>
@@ -19228,7 +19228,7 @@
           <p:cNvPr id="14" name="">
             <a:extLst xmlns:a="http://schemas.openxmlformats.org/drawingml/2006/main">
               <a:ext uri="{FF2B5EF4-FFF2-40B4-BE49-F238E27FC236}">
-                <a16:creationId xmlns:a16="http://schemas.microsoft.com/office/drawing/2014/main" id="{57C662A7-08FA-4185-8F5D-E2F276BCF434}"/>
+                <a16:creationId xmlns:a16="http://schemas.microsoft.com/office/drawing/2014/main" id="{DEF5E91F-AC5C-4B67-8849-09C59C28C9F5}"/>
               </a:ext>
             </a:extLst>
           </p:cNvPr>
@@ -19408,7 +19408,7 @@
           <p:cNvPr id="15" name="">
             <a:extLst xmlns:a="http://schemas.openxmlformats.org/drawingml/2006/main">
               <a:ext uri="{FF2B5EF4-FFF2-40B4-BE49-F238E27FC236}">
-                <a16:creationId xmlns:a16="http://schemas.microsoft.com/office/drawing/2014/main" id="{3765E0F4-5593-40EA-812A-2ABA82084DEC}"/>
+                <a16:creationId xmlns:a16="http://schemas.microsoft.com/office/drawing/2014/main" id="{EE206A27-4B1D-40F3-9EA9-A2EEFAA3FFEB}"/>
               </a:ext>
             </a:extLst>
           </p:cNvPr>
@@ -19439,7 +19439,7 @@
           <p:cNvPr id="16" name="">
             <a:extLst xmlns:a="http://schemas.openxmlformats.org/drawingml/2006/main">
               <a:ext uri="{FF2B5EF4-FFF2-40B4-BE49-F238E27FC236}">
-                <a16:creationId xmlns:a16="http://schemas.microsoft.com/office/drawing/2014/main" id="{A569B14A-0369-4A6E-9A1A-20109F7521FD}"/>
+                <a16:creationId xmlns:a16="http://schemas.microsoft.com/office/drawing/2014/main" id="{D4D06EC3-3629-4156-9704-4C30144B88DD}"/>
               </a:ext>
             </a:extLst>
           </p:cNvPr>
@@ -19472,7 +19472,7 @@
           <p:cNvPr id="17" name="">
             <a:extLst xmlns:a="http://schemas.openxmlformats.org/drawingml/2006/main">
               <a:ext uri="{FF2B5EF4-FFF2-40B4-BE49-F238E27FC236}">
-                <a16:creationId xmlns:a16="http://schemas.microsoft.com/office/drawing/2014/main" id="{3F563FBB-23D0-4E41-AB90-A72C7E2E5FA9}"/>
+                <a16:creationId xmlns:a16="http://schemas.microsoft.com/office/drawing/2014/main" id="{395BBF70-8A3D-40FF-9E08-2006EB23D32C}"/>
               </a:ext>
             </a:extLst>
           </p:cNvPr>
@@ -19629,7 +19629,7 @@
           <p:cNvPr id="18" name="">
             <a:extLst xmlns:a="http://schemas.openxmlformats.org/drawingml/2006/main">
               <a:ext uri="{FF2B5EF4-FFF2-40B4-BE49-F238E27FC236}">
-                <a16:creationId xmlns:a16="http://schemas.microsoft.com/office/drawing/2014/main" id="{1FB4908D-AFC9-4FA4-B124-BAAB37E7BB0D}"/>
+                <a16:creationId xmlns:a16="http://schemas.microsoft.com/office/drawing/2014/main" id="{BF9BB27A-6AA5-4223-AFF3-705DEE8C848D}"/>
               </a:ext>
             </a:extLst>
           </p:cNvPr>
@@ -19809,7 +19809,7 @@
           <p:cNvPr id="19" name="">
             <a:extLst xmlns:a="http://schemas.openxmlformats.org/drawingml/2006/main">
               <a:ext uri="{FF2B5EF4-FFF2-40B4-BE49-F238E27FC236}">
-                <a16:creationId xmlns:a16="http://schemas.microsoft.com/office/drawing/2014/main" id="{A57F2E6E-5167-471E-9F01-14B11B4F4353}"/>
+                <a16:creationId xmlns:a16="http://schemas.microsoft.com/office/drawing/2014/main" id="{60D151DB-CAB7-4687-AAA7-03843430E1CA}"/>
               </a:ext>
             </a:extLst>
           </p:cNvPr>
@@ -19966,7 +19966,7 @@
           <p:cNvPr id="20" name="">
             <a:extLst xmlns:a="http://schemas.openxmlformats.org/drawingml/2006/main">
               <a:ext uri="{FF2B5EF4-FFF2-40B4-BE49-F238E27FC236}">
-                <a16:creationId xmlns:a16="http://schemas.microsoft.com/office/drawing/2014/main" id="{9FB8E4FC-111D-46C7-996E-EBC01870D415}"/>
+                <a16:creationId xmlns:a16="http://schemas.microsoft.com/office/drawing/2014/main" id="{2ECE8AE2-6764-4B39-8E8C-69CBF31306A7}"/>
               </a:ext>
             </a:extLst>
           </p:cNvPr>
@@ -20123,7 +20123,7 @@
           <p:cNvPr id="21" name="">
             <a:extLst xmlns:a="http://schemas.openxmlformats.org/drawingml/2006/main">
               <a:ext uri="{FF2B5EF4-FFF2-40B4-BE49-F238E27FC236}">
-                <a16:creationId xmlns:a16="http://schemas.microsoft.com/office/drawing/2014/main" id="{028760A6-4088-4C89-BE30-6F54C86F40EA}"/>
+                <a16:creationId xmlns:a16="http://schemas.microsoft.com/office/drawing/2014/main" id="{688AD89F-D93F-4D81-9D4D-DDE808F1E153}"/>
               </a:ext>
             </a:extLst>
           </p:cNvPr>
@@ -20278,7 +20278,7 @@
     </p:spTree>
     <p:extLst>
       <p:ext uri="{BB962C8B-B14F-4D97-AF65-F5344CB8AC3E}">
-        <p14:creationId xmlns:p14="http://schemas.microsoft.com/office/powerpoint/2010/main" val="477139536"/>
+        <p14:creationId xmlns:p14="http://schemas.microsoft.com/office/powerpoint/2010/main" val="1385242354"/>
       </p:ext>
     </p:extLst>
   </p:cSld>
@@ -20309,7 +20309,7 @@
           <p:cNvPr id="9" name="">
             <a:extLst xmlns:a="http://schemas.openxmlformats.org/drawingml/2006/main">
               <a:ext uri="{FF2B5EF4-FFF2-40B4-BE49-F238E27FC236}">
-                <a16:creationId xmlns:a16="http://schemas.microsoft.com/office/drawing/2014/main" id="{7F5514F3-8FC6-4CE1-BEF9-609D044E059E}"/>
+                <a16:creationId xmlns:a16="http://schemas.microsoft.com/office/drawing/2014/main" id="{65F5070D-560E-4CBF-B1EB-344E623FD37C}"/>
               </a:ext>
             </a:extLst>
           </p:cNvPr>
@@ -20466,7 +20466,7 @@
           <p:cNvPr id="2" name="">
             <a:extLst xmlns:a="http://schemas.openxmlformats.org/drawingml/2006/main">
               <a:ext uri="{FF2B5EF4-FFF2-40B4-BE49-F238E27FC236}">
-                <a16:creationId xmlns:a16="http://schemas.microsoft.com/office/drawing/2014/main" id="{F9ADA627-4962-43BB-98E4-7374B9EAAC27}"/>
+                <a16:creationId xmlns:a16="http://schemas.microsoft.com/office/drawing/2014/main" id="{235B5882-9D58-41F4-859E-070EF8723512}"/>
               </a:ext>
             </a:extLst>
           </p:cNvPr>
@@ -20497,7 +20497,7 @@
           <p:cNvPr id="3" name="">
             <a:extLst xmlns:a="http://schemas.openxmlformats.org/drawingml/2006/main">
               <a:ext uri="{FF2B5EF4-FFF2-40B4-BE49-F238E27FC236}">
-                <a16:creationId xmlns:a16="http://schemas.microsoft.com/office/drawing/2014/main" id="{1AD2A69A-6D2A-4AB9-9C18-0556BAE46724}"/>
+                <a16:creationId xmlns:a16="http://schemas.microsoft.com/office/drawing/2014/main" id="{1CD969E5-DBB1-4432-8E7F-1ACAB052AECF}"/>
               </a:ext>
             </a:extLst>
           </p:cNvPr>
@@ -20654,7 +20654,7 @@
           <p:cNvPr id="4" name="Chart">
             <a:extLst xmlns:a="http://schemas.openxmlformats.org/drawingml/2006/main">
               <a:ext uri="{FF2B5EF4-FFF2-40B4-BE49-F238E27FC236}">
-                <a16:creationId xmlns:a16="http://schemas.microsoft.com/office/drawing/2014/main" id="{50041597-BCD4-400F-BD2C-A1FF41C2B8C9}"/>
+                <a16:creationId xmlns:a16="http://schemas.microsoft.com/office/drawing/2014/main" id="{E40E3257-79C1-46D4-B993-8FCE999E8D15}"/>
               </a:ext>
             </a:extLst>
           </p:cNvPr>
@@ -20667,7 +20667,7 @@
         </p:xfrm>
         <a:graphic xmlns:a="http://schemas.openxmlformats.org/drawingml/2006/main">
           <a:graphicData uri="http://schemas.openxmlformats.org/drawingml/2006/chart">
-            <c:chart xmlns:r="http://schemas.openxmlformats.org/officeDocument/2006/relationships" xmlns:c="http://schemas.openxmlformats.org/drawingml/2006/chart" r:id="R4f8a1eeb9bf84bdc"/>
+            <c:chart xmlns:r="http://schemas.openxmlformats.org/officeDocument/2006/relationships" xmlns:c="http://schemas.openxmlformats.org/drawingml/2006/chart" r:id="Raffd7ab425ac4ed8"/>
           </a:graphicData>
         </a:graphic>
       </p:graphicFrame>
@@ -20676,7 +20676,7 @@
           <p:cNvPr id="5" name="">
             <a:extLst xmlns:a="http://schemas.openxmlformats.org/drawingml/2006/main">
               <a:ext uri="{FF2B5EF4-FFF2-40B4-BE49-F238E27FC236}">
-                <a16:creationId xmlns:a16="http://schemas.microsoft.com/office/drawing/2014/main" id="{16664D95-A9AA-4E5F-A06F-9186ABED66B2}"/>
+                <a16:creationId xmlns:a16="http://schemas.microsoft.com/office/drawing/2014/main" id="{9BFB3EDF-855B-4605-9B02-41727417BA69}"/>
               </a:ext>
             </a:extLst>
           </p:cNvPr>
@@ -20833,7 +20833,7 @@
           <p:cNvPr id="6" name="">
             <a:extLst xmlns:a="http://schemas.openxmlformats.org/drawingml/2006/main">
               <a:ext uri="{FF2B5EF4-FFF2-40B4-BE49-F238E27FC236}">
-                <a16:creationId xmlns:a16="http://schemas.microsoft.com/office/drawing/2014/main" id="{B5589F02-8D02-4C82-9F14-AF00C279DF65}"/>
+                <a16:creationId xmlns:a16="http://schemas.microsoft.com/office/drawing/2014/main" id="{3A1E2A7F-162E-4F9A-A7EA-30061948E6B3}"/>
               </a:ext>
             </a:extLst>
           </p:cNvPr>
@@ -21036,7 +21036,7 @@
           <p:cNvPr id="7" name="">
             <a:extLst xmlns:a="http://schemas.openxmlformats.org/drawingml/2006/main">
               <a:ext uri="{FF2B5EF4-FFF2-40B4-BE49-F238E27FC236}">
-                <a16:creationId xmlns:a16="http://schemas.microsoft.com/office/drawing/2014/main" id="{AAD7C755-7C71-4C1C-865F-EEC46ADD2CB8}"/>
+                <a16:creationId xmlns:a16="http://schemas.microsoft.com/office/drawing/2014/main" id="{39472697-926F-4D1B-B203-417646FD62EB}"/>
               </a:ext>
             </a:extLst>
           </p:cNvPr>
@@ -21216,7 +21216,7 @@
           <p:cNvPr id="8" name="">
             <a:extLst xmlns:a="http://schemas.openxmlformats.org/drawingml/2006/main">
               <a:ext uri="{FF2B5EF4-FFF2-40B4-BE49-F238E27FC236}">
-                <a16:creationId xmlns:a16="http://schemas.microsoft.com/office/drawing/2014/main" id="{82D4A88C-3A1C-4BBC-B59F-A92081C9E975}"/>
+                <a16:creationId xmlns:a16="http://schemas.microsoft.com/office/drawing/2014/main" id="{0F6316E7-DBB9-4967-AE37-60A8CBC847AD}"/>
               </a:ext>
             </a:extLst>
           </p:cNvPr>
@@ -21371,7 +21371,7 @@
     </p:spTree>
     <p:extLst>
       <p:ext uri="{BB962C8B-B14F-4D97-AF65-F5344CB8AC3E}">
-        <p14:creationId xmlns:p14="http://schemas.microsoft.com/office/powerpoint/2010/main" val="2042590800"/>
+        <p14:creationId xmlns:p14="http://schemas.microsoft.com/office/powerpoint/2010/main" val="1467365695"/>
       </p:ext>
     </p:extLst>
   </p:cSld>
@@ -21399,10 +21399,10 @@
       </p:grpSpPr>
       <p:sp>
         <p:nvSpPr>
-          <p:cNvPr id="28" name="">
+          <p:cNvPr id="32" name="">
             <a:extLst xmlns:a="http://schemas.openxmlformats.org/drawingml/2006/main">
               <a:ext uri="{FF2B5EF4-FFF2-40B4-BE49-F238E27FC236}">
-                <a16:creationId xmlns:a16="http://schemas.microsoft.com/office/drawing/2014/main" id="{1F6F87D8-5156-4B00-B3EF-1CF3A2F2D734}"/>
+                <a16:creationId xmlns:a16="http://schemas.microsoft.com/office/drawing/2014/main" id="{7C4EA1B4-7E57-4437-BD1B-F15E57BB0B1C}"/>
               </a:ext>
             </a:extLst>
           </p:cNvPr>
@@ -21549,7 +21549,7 @@
                 <a:ea typeface="Arial"/>
                 <a:cs typeface="Arial"/>
               </a:rPr>
-              <a:t>Agentic selection: working loop + planned routing</a:t>
+              <a:t>AI agent architecture: implemented and planned</a:t>
             </a:r>
           </a:p>
         </p:txBody>
@@ -21559,7 +21559,7 @@
           <p:cNvPr id="2" name="">
             <a:extLst xmlns:a="http://schemas.openxmlformats.org/drawingml/2006/main">
               <a:ext uri="{FF2B5EF4-FFF2-40B4-BE49-F238E27FC236}">
-                <a16:creationId xmlns:a16="http://schemas.microsoft.com/office/drawing/2014/main" id="{645F72AC-F092-4246-BCB8-A733BD199CA6}"/>
+                <a16:creationId xmlns:a16="http://schemas.microsoft.com/office/drawing/2014/main" id="{039C4DD4-ADD1-4923-8A26-A2F8FF4739F9}"/>
               </a:ext>
             </a:extLst>
           </p:cNvPr>
@@ -21590,7 +21590,7 @@
           <p:cNvPr id="3" name="">
             <a:extLst xmlns:a="http://schemas.openxmlformats.org/drawingml/2006/main">
               <a:ext uri="{FF2B5EF4-FFF2-40B4-BE49-F238E27FC236}">
-                <a16:creationId xmlns:a16="http://schemas.microsoft.com/office/drawing/2014/main" id="{90D461DC-4710-424A-B01F-6B63E1B19B95}"/>
+                <a16:creationId xmlns:a16="http://schemas.microsoft.com/office/drawing/2014/main" id="{654CB6DF-B8EB-4E08-8950-6F6A704F194B}"/>
               </a:ext>
             </a:extLst>
           </p:cNvPr>
@@ -21747,7 +21747,7 @@
           <p:cNvPr id="4" name="">
             <a:extLst xmlns:a="http://schemas.openxmlformats.org/drawingml/2006/main">
               <a:ext uri="{FF2B5EF4-FFF2-40B4-BE49-F238E27FC236}">
-                <a16:creationId xmlns:a16="http://schemas.microsoft.com/office/drawing/2014/main" id="{8CD81C88-1557-4C74-AD12-5FC6EB0ADD53}"/>
+                <a16:creationId xmlns:a16="http://schemas.microsoft.com/office/drawing/2014/main" id="{0AAB9F11-F63C-4443-8DE9-4FB7FA26FC16}"/>
               </a:ext>
             </a:extLst>
           </p:cNvPr>
@@ -21758,8 +21758,8 @@
         </p:nvSpPr>
         <p:spPr>
           <a:xfrm xmlns:a="http://schemas.openxmlformats.org/drawingml/2006/main">
-            <a:off x="685800" y="1362075"/>
-            <a:ext cx="8096250" cy="333375"/>
+            <a:off x="685800" y="1304925"/>
+            <a:ext cx="6191250" cy="266700"/>
           </a:xfrm>
           <a:prstGeom xmlns:a="http://schemas.openxmlformats.org/drawingml/2006/main" prst="rect">
             <a:avLst/>
@@ -21774,7 +21774,7 @@
           <a:bodyPr xmlns:a="http://schemas.openxmlformats.org/drawingml/2006/main" lIns="0" tIns="0" rIns="0" bIns="0"/>
           <a:lstStyle xmlns:a="http://schemas.openxmlformats.org/drawingml/2006/main">
             <a:defPPr>
-              <a:defRPr sz="1950" b="1">
+              <a:defRPr sz="1650" b="1">
                 <a:solidFill>
                   <a:srgbClr val="18856B"/>
                 </a:solidFill>
@@ -21784,7 +21784,7 @@
               </a:defRPr>
             </a:defPPr>
             <a:lvl1pPr>
-              <a:defRPr sz="1950" b="1">
+              <a:defRPr sz="1650" b="1">
                 <a:solidFill>
                   <a:srgbClr val="18856B"/>
                 </a:solidFill>
@@ -21794,7 +21794,7 @@
               </a:defRPr>
             </a:lvl1pPr>
             <a:lvl2pPr>
-              <a:defRPr sz="1950" b="1">
+              <a:defRPr sz="1650" b="1">
                 <a:solidFill>
                   <a:srgbClr val="18856B"/>
                 </a:solidFill>
@@ -21804,7 +21804,7 @@
               </a:defRPr>
             </a:lvl2pPr>
             <a:lvl3pPr>
-              <a:defRPr sz="1950" b="1">
+              <a:defRPr sz="1650" b="1">
                 <a:solidFill>
                   <a:srgbClr val="18856B"/>
                 </a:solidFill>
@@ -21814,7 +21814,7 @@
               </a:defRPr>
             </a:lvl3pPr>
             <a:lvl4pPr>
-              <a:defRPr sz="1950" b="1">
+              <a:defRPr sz="1650" b="1">
                 <a:solidFill>
                   <a:srgbClr val="18856B"/>
                 </a:solidFill>
@@ -21824,7 +21824,7 @@
               </a:defRPr>
             </a:lvl4pPr>
             <a:lvl5pPr>
-              <a:defRPr sz="1950" b="1">
+              <a:defRPr sz="1650" b="1">
                 <a:solidFill>
                   <a:srgbClr val="18856B"/>
                 </a:solidFill>
@@ -21834,7 +21834,7 @@
               </a:defRPr>
             </a:lvl5pPr>
             <a:lvl6pPr>
-              <a:defRPr sz="1950" b="1">
+              <a:defRPr sz="1650" b="1">
                 <a:solidFill>
                   <a:srgbClr val="18856B"/>
                 </a:solidFill>
@@ -21844,7 +21844,7 @@
               </a:defRPr>
             </a:lvl6pPr>
             <a:lvl7pPr>
-              <a:defRPr sz="1950" b="1">
+              <a:defRPr sz="1650" b="1">
                 <a:solidFill>
                   <a:srgbClr val="18856B"/>
                 </a:solidFill>
@@ -21854,7 +21854,7 @@
               </a:defRPr>
             </a:lvl7pPr>
             <a:lvl8pPr>
-              <a:defRPr sz="1950" b="1">
+              <a:defRPr sz="1650" b="1">
                 <a:solidFill>
                   <a:srgbClr val="18856B"/>
                 </a:solidFill>
@@ -21864,7 +21864,7 @@
               </a:defRPr>
             </a:lvl8pPr>
             <a:lvl9pPr>
-              <a:defRPr sz="1950" b="1">
+              <a:defRPr sz="1650" b="1">
                 <a:solidFill>
                   <a:srgbClr val="18856B"/>
                 </a:solidFill>
@@ -21876,7 +21876,7 @@
           </a:lstStyle>
           <a:p xmlns:a="http://schemas.openxmlformats.org/drawingml/2006/main">
             <a:pPr>
-              <a:defRPr sz="1950" b="1">
+              <a:defRPr sz="1650" b="1">
                 <a:solidFill>
                   <a:srgbClr val="18856B"/>
                 </a:solidFill>
@@ -21886,7 +21886,7 @@
               </a:defRPr>
             </a:pPr>
             <a:r>
-              <a:rPr sz="1950" b="1">
+              <a:rPr sz="1650" b="1">
                 <a:solidFill>
                   <a:srgbClr val="18856B"/>
                 </a:solidFill>
@@ -21894,7 +21894,7 @@
                 <a:ea typeface="Arial"/>
                 <a:cs typeface="Arial"/>
               </a:rPr>
-              <a:t>WORKING  |  Bounded agentic loop</a:t>
+              <a:t>WORKING CORE</a:t>
             </a:r>
           </a:p>
         </p:txBody>
@@ -21904,7 +21904,7 @@
           <p:cNvPr id="5" name="">
             <a:extLst xmlns:a="http://schemas.openxmlformats.org/drawingml/2006/main">
               <a:ext uri="{FF2B5EF4-FFF2-40B4-BE49-F238E27FC236}">
-                <a16:creationId xmlns:a16="http://schemas.microsoft.com/office/drawing/2014/main" id="{3AA55555-A058-4EA7-8593-D3CCF11454D8}"/>
+                <a16:creationId xmlns:a16="http://schemas.microsoft.com/office/drawing/2014/main" id="{FE4CC4A6-116A-4439-B54D-25F9BE3CD96D}"/>
               </a:ext>
             </a:extLst>
           </p:cNvPr>
@@ -21915,7 +21915,7 @@
         </p:nvSpPr>
         <p:spPr>
           <a:xfrm xmlns:a="http://schemas.openxmlformats.org/drawingml/2006/main">
-            <a:off x="685800" y="1809750"/>
+            <a:off x="685800" y="1704975"/>
             <a:ext cx="2333625" cy="1238250"/>
           </a:xfrm>
           <a:prstGeom xmlns:a="http://schemas.openxmlformats.org/drawingml/2006/main" prst="rect">
@@ -21937,7 +21937,7 @@
           <p:cNvPr id="6" name="">
             <a:extLst xmlns:a="http://schemas.openxmlformats.org/drawingml/2006/main">
               <a:ext uri="{FF2B5EF4-FFF2-40B4-BE49-F238E27FC236}">
-                <a16:creationId xmlns:a16="http://schemas.microsoft.com/office/drawing/2014/main" id="{5144366A-615E-4FD0-A220-F89A9578651A}"/>
+                <a16:creationId xmlns:a16="http://schemas.microsoft.com/office/drawing/2014/main" id="{F6CB5A87-DF5B-44DB-B658-0FCC2AD5696D}"/>
               </a:ext>
             </a:extLst>
           </p:cNvPr>
@@ -21948,7 +21948,7 @@
         </p:nvSpPr>
         <p:spPr>
           <a:xfrm xmlns:a="http://schemas.openxmlformats.org/drawingml/2006/main">
-            <a:off x="819150" y="1943100"/>
+            <a:off x="819150" y="1838325"/>
             <a:ext cx="2066925" cy="361950"/>
           </a:xfrm>
           <a:prstGeom xmlns:a="http://schemas.openxmlformats.org/drawingml/2006/main" prst="rect">
@@ -22084,7 +22084,7 @@
                 <a:ea typeface="Arial"/>
                 <a:cs typeface="Arial"/>
               </a:rPr>
-              <a:t>Inspect</a:t>
+              <a:t>Analyze + predict</a:t>
             </a:r>
           </a:p>
         </p:txBody>
@@ -22094,7 +22094,7 @@
           <p:cNvPr id="7" name="">
             <a:extLst xmlns:a="http://schemas.openxmlformats.org/drawingml/2006/main">
               <a:ext uri="{FF2B5EF4-FFF2-40B4-BE49-F238E27FC236}">
-                <a16:creationId xmlns:a16="http://schemas.microsoft.com/office/drawing/2014/main" id="{E3CFB900-E239-43AF-B508-EBAA32AC901D}"/>
+                <a16:creationId xmlns:a16="http://schemas.microsoft.com/office/drawing/2014/main" id="{BFD99474-62AF-443F-BD7F-CD28D9C0DDB4}"/>
               </a:ext>
             </a:extLst>
           </p:cNvPr>
@@ -22105,7 +22105,7 @@
         </p:nvSpPr>
         <p:spPr>
           <a:xfrm xmlns:a="http://schemas.openxmlformats.org/drawingml/2006/main">
-            <a:off x="819150" y="2352675"/>
+            <a:off x="819150" y="2247900"/>
             <a:ext cx="2066925" cy="619125"/>
           </a:xfrm>
           <a:prstGeom xmlns:a="http://schemas.openxmlformats.org/drawingml/2006/main" prst="rect">
@@ -22241,7 +22241,7 @@
                 <a:ea typeface="Arial"/>
                 <a:cs typeface="Arial"/>
               </a:rPr>
-              <a:t>Candidates +</a:t>
+              <a:t>Legal candidates</a:t>
             </a:r>
           </a:p>
           <a:p xmlns:a="http://schemas.openxmlformats.org/drawingml/2006/main">
@@ -22264,7 +22264,7 @@
                 <a:ea typeface="Arial"/>
                 <a:cs typeface="Arial"/>
               </a:rPr>
-              <a:t>constraints</a:t>
+              <a:t>XGBoost rankings</a:t>
             </a:r>
           </a:p>
         </p:txBody>
@@ -22274,7 +22274,7 @@
           <p:cNvPr id="8" name="">
             <a:extLst xmlns:a="http://schemas.openxmlformats.org/drawingml/2006/main">
               <a:ext uri="{FF2B5EF4-FFF2-40B4-BE49-F238E27FC236}">
-                <a16:creationId xmlns:a16="http://schemas.microsoft.com/office/drawing/2014/main" id="{7F8D4179-B94A-445D-8945-BBC4D8C32674}"/>
+                <a16:creationId xmlns:a16="http://schemas.microsoft.com/office/drawing/2014/main" id="{2C637E2E-B8D5-4903-977A-9058EA1D5A4C}"/>
               </a:ext>
             </a:extLst>
           </p:cNvPr>
@@ -22285,7 +22285,7 @@
         </p:nvSpPr>
         <p:spPr>
           <a:xfrm xmlns:a="http://schemas.openxmlformats.org/drawingml/2006/main">
-            <a:off x="3105150" y="2314575"/>
+            <a:off x="3105150" y="2209800"/>
             <a:ext cx="285750" cy="228600"/>
           </a:xfrm>
           <a:prstGeom xmlns:a="http://schemas.openxmlformats.org/drawingml/2006/main" prst="rightArrow">
@@ -22305,7 +22305,7 @@
           <p:cNvPr id="9" name="">
             <a:extLst xmlns:a="http://schemas.openxmlformats.org/drawingml/2006/main">
               <a:ext uri="{FF2B5EF4-FFF2-40B4-BE49-F238E27FC236}">
-                <a16:creationId xmlns:a16="http://schemas.microsoft.com/office/drawing/2014/main" id="{B22B1B9C-0D19-4753-88FE-7F806BFC4155}"/>
+                <a16:creationId xmlns:a16="http://schemas.microsoft.com/office/drawing/2014/main" id="{7C3FFA60-67BF-4A55-8C56-7CD8F165538B}"/>
               </a:ext>
             </a:extLst>
           </p:cNvPr>
@@ -22316,7 +22316,7 @@
         </p:nvSpPr>
         <p:spPr>
           <a:xfrm xmlns:a="http://schemas.openxmlformats.org/drawingml/2006/main">
-            <a:off x="3476625" y="1809750"/>
+            <a:off x="3476625" y="1704975"/>
             <a:ext cx="2333625" cy="1238250"/>
           </a:xfrm>
           <a:prstGeom xmlns:a="http://schemas.openxmlformats.org/drawingml/2006/main" prst="rect">
@@ -22338,7 +22338,7 @@
           <p:cNvPr id="10" name="">
             <a:extLst xmlns:a="http://schemas.openxmlformats.org/drawingml/2006/main">
               <a:ext uri="{FF2B5EF4-FFF2-40B4-BE49-F238E27FC236}">
-                <a16:creationId xmlns:a16="http://schemas.microsoft.com/office/drawing/2014/main" id="{3B90B13F-F785-41BA-BEC6-95EF418E8C6E}"/>
+                <a16:creationId xmlns:a16="http://schemas.microsoft.com/office/drawing/2014/main" id="{BC48235C-C345-4362-8D01-25670CAD7D3A}"/>
               </a:ext>
             </a:extLst>
           </p:cNvPr>
@@ -22349,7 +22349,7 @@
         </p:nvSpPr>
         <p:spPr>
           <a:xfrm xmlns:a="http://schemas.openxmlformats.org/drawingml/2006/main">
-            <a:off x="3609975" y="1943100"/>
+            <a:off x="3609975" y="1838325"/>
             <a:ext cx="2066925" cy="361950"/>
           </a:xfrm>
           <a:prstGeom xmlns:a="http://schemas.openxmlformats.org/drawingml/2006/main" prst="rect">
@@ -22485,7 +22485,7 @@
                 <a:ea typeface="Arial"/>
                 <a:cs typeface="Arial"/>
               </a:rPr>
-              <a:t>Predict</a:t>
+              <a:t>LLM decision</a:t>
             </a:r>
           </a:p>
         </p:txBody>
@@ -22495,7 +22495,7 @@
           <p:cNvPr id="11" name="">
             <a:extLst xmlns:a="http://schemas.openxmlformats.org/drawingml/2006/main">
               <a:ext uri="{FF2B5EF4-FFF2-40B4-BE49-F238E27FC236}">
-                <a16:creationId xmlns:a16="http://schemas.microsoft.com/office/drawing/2014/main" id="{2AE23380-326C-45B3-AC66-80BAA6D79D97}"/>
+                <a16:creationId xmlns:a16="http://schemas.microsoft.com/office/drawing/2014/main" id="{03008F08-BC59-4720-BFF5-F9BF0C6E70F9}"/>
               </a:ext>
             </a:extLst>
           </p:cNvPr>
@@ -22506,7 +22506,7 @@
         </p:nvSpPr>
         <p:spPr>
           <a:xfrm xmlns:a="http://schemas.openxmlformats.org/drawingml/2006/main">
-            <a:off x="3609975" y="2352675"/>
+            <a:off x="3609975" y="2247900"/>
             <a:ext cx="2066925" cy="619125"/>
           </a:xfrm>
           <a:prstGeom xmlns:a="http://schemas.openxmlformats.org/drawingml/2006/main" prst="rect">
@@ -22642,7 +22642,7 @@
                 <a:ea typeface="Arial"/>
                 <a:cs typeface="Arial"/>
               </a:rPr>
-              <a:t>XGBoost score</a:t>
+              <a:t>Structured outputs</a:t>
             </a:r>
           </a:p>
           <a:p xmlns:a="http://schemas.openxmlformats.org/drawingml/2006/main">
@@ -22665,7 +22665,7 @@
                 <a:ea typeface="Arial"/>
                 <a:cs typeface="Arial"/>
               </a:rPr>
-              <a:t>+ diagnostics</a:t>
+              <a:t>Function calling</a:t>
             </a:r>
           </a:p>
         </p:txBody>
@@ -22675,7 +22675,7 @@
           <p:cNvPr id="12" name="">
             <a:extLst xmlns:a="http://schemas.openxmlformats.org/drawingml/2006/main">
               <a:ext uri="{FF2B5EF4-FFF2-40B4-BE49-F238E27FC236}">
-                <a16:creationId xmlns:a16="http://schemas.microsoft.com/office/drawing/2014/main" id="{474A0469-5D53-4B2D-B6D3-B19B04E3258E}"/>
+                <a16:creationId xmlns:a16="http://schemas.microsoft.com/office/drawing/2014/main" id="{31918A14-6498-48E9-A81D-D662CBE5E2F7}"/>
               </a:ext>
             </a:extLst>
           </p:cNvPr>
@@ -22686,7 +22686,7 @@
         </p:nvSpPr>
         <p:spPr>
           <a:xfrm xmlns:a="http://schemas.openxmlformats.org/drawingml/2006/main">
-            <a:off x="5895975" y="2314575"/>
+            <a:off x="5895975" y="2209800"/>
             <a:ext cx="285750" cy="228600"/>
           </a:xfrm>
           <a:prstGeom xmlns:a="http://schemas.openxmlformats.org/drawingml/2006/main" prst="rightArrow">
@@ -22706,7 +22706,7 @@
           <p:cNvPr id="13" name="">
             <a:extLst xmlns:a="http://schemas.openxmlformats.org/drawingml/2006/main">
               <a:ext uri="{FF2B5EF4-FFF2-40B4-BE49-F238E27FC236}">
-                <a16:creationId xmlns:a16="http://schemas.microsoft.com/office/drawing/2014/main" id="{E0D97C5A-7EFA-44F6-9D7A-6064EE127CEF}"/>
+                <a16:creationId xmlns:a16="http://schemas.microsoft.com/office/drawing/2014/main" id="{4B42574A-B697-4A26-B472-36E749E30857}"/>
               </a:ext>
             </a:extLst>
           </p:cNvPr>
@@ -22717,7 +22717,7 @@
         </p:nvSpPr>
         <p:spPr>
           <a:xfrm xmlns:a="http://schemas.openxmlformats.org/drawingml/2006/main">
-            <a:off x="6267450" y="1809750"/>
+            <a:off x="6267450" y="1704975"/>
             <a:ext cx="2333625" cy="1238250"/>
           </a:xfrm>
           <a:prstGeom xmlns:a="http://schemas.openxmlformats.org/drawingml/2006/main" prst="rect">
@@ -22739,7 +22739,7 @@
           <p:cNvPr id="14" name="">
             <a:extLst xmlns:a="http://schemas.openxmlformats.org/drawingml/2006/main">
               <a:ext uri="{FF2B5EF4-FFF2-40B4-BE49-F238E27FC236}">
-                <a16:creationId xmlns:a16="http://schemas.microsoft.com/office/drawing/2014/main" id="{9CA856A7-ECAB-4A7C-AA99-8D039714E90D}"/>
+                <a16:creationId xmlns:a16="http://schemas.microsoft.com/office/drawing/2014/main" id="{810D161B-F4B3-4921-B635-F238454633D9}"/>
               </a:ext>
             </a:extLst>
           </p:cNvPr>
@@ -22750,7 +22750,7 @@
         </p:nvSpPr>
         <p:spPr>
           <a:xfrm xmlns:a="http://schemas.openxmlformats.org/drawingml/2006/main">
-            <a:off x="6400800" y="1943100"/>
+            <a:off x="6400800" y="1838325"/>
             <a:ext cx="2066925" cy="361950"/>
           </a:xfrm>
           <a:prstGeom xmlns:a="http://schemas.openxmlformats.org/drawingml/2006/main" prst="rect">
@@ -22886,7 +22886,7 @@
                 <a:ea typeface="Arial"/>
                 <a:cs typeface="Arial"/>
               </a:rPr>
-              <a:t>Measure</a:t>
+              <a:t>Host + tools</a:t>
             </a:r>
           </a:p>
         </p:txBody>
@@ -22896,7 +22896,7 @@
           <p:cNvPr id="15" name="">
             <a:extLst xmlns:a="http://schemas.openxmlformats.org/drawingml/2006/main">
               <a:ext uri="{FF2B5EF4-FFF2-40B4-BE49-F238E27FC236}">
-                <a16:creationId xmlns:a16="http://schemas.microsoft.com/office/drawing/2014/main" id="{DFC213C7-9A50-47A3-94F3-5313D97B12AF}"/>
+                <a16:creationId xmlns:a16="http://schemas.microsoft.com/office/drawing/2014/main" id="{FB083D02-4218-49AE-877F-4DA392710793}"/>
               </a:ext>
             </a:extLst>
           </p:cNvPr>
@@ -22907,7 +22907,7 @@
         </p:nvSpPr>
         <p:spPr>
           <a:xfrm xmlns:a="http://schemas.openxmlformats.org/drawingml/2006/main">
-            <a:off x="6400800" y="2352675"/>
+            <a:off x="6400800" y="2247900"/>
             <a:ext cx="2066925" cy="619125"/>
           </a:xfrm>
           <a:prstGeom xmlns:a="http://schemas.openxmlformats.org/drawingml/2006/main" prst="rect">
@@ -23043,7 +23043,7 @@
                 <a:ea typeface="Arial"/>
                 <a:cs typeface="Arial"/>
               </a:rPr>
-              <a:t>Pay one attempt;</a:t>
+              <a:t>Budget guardrails</a:t>
             </a:r>
           </a:p>
           <a:p xmlns:a="http://schemas.openxmlformats.org/drawingml/2006/main">
@@ -23066,7 +23066,7 @@
                 <a:ea typeface="Arial"/>
                 <a:cs typeface="Arial"/>
               </a:rPr>
-              <a:t>verify outcome</a:t>
+              <a:t>Measure / finalize</a:t>
             </a:r>
           </a:p>
         </p:txBody>
@@ -23076,7 +23076,7 @@
           <p:cNvPr id="16" name="">
             <a:extLst xmlns:a="http://schemas.openxmlformats.org/drawingml/2006/main">
               <a:ext uri="{FF2B5EF4-FFF2-40B4-BE49-F238E27FC236}">
-                <a16:creationId xmlns:a16="http://schemas.microsoft.com/office/drawing/2014/main" id="{84694FA6-683B-4C5F-B040-24088EC6F520}"/>
+                <a16:creationId xmlns:a16="http://schemas.microsoft.com/office/drawing/2014/main" id="{211B8142-F11D-4260-BA82-4E00AF58B65A}"/>
               </a:ext>
             </a:extLst>
           </p:cNvPr>
@@ -23087,7 +23087,7 @@
         </p:nvSpPr>
         <p:spPr>
           <a:xfrm xmlns:a="http://schemas.openxmlformats.org/drawingml/2006/main">
-            <a:off x="8686800" y="2314575"/>
+            <a:off x="8686800" y="2209800"/>
             <a:ext cx="285750" cy="228600"/>
           </a:xfrm>
           <a:prstGeom xmlns:a="http://schemas.openxmlformats.org/drawingml/2006/main" prst="rightArrow">
@@ -23107,7 +23107,7 @@
           <p:cNvPr id="17" name="">
             <a:extLst xmlns:a="http://schemas.openxmlformats.org/drawingml/2006/main">
               <a:ext uri="{FF2B5EF4-FFF2-40B4-BE49-F238E27FC236}">
-                <a16:creationId xmlns:a16="http://schemas.microsoft.com/office/drawing/2014/main" id="{856A03AA-D39F-4A81-8FDA-FF400BA121B4}"/>
+                <a16:creationId xmlns:a16="http://schemas.microsoft.com/office/drawing/2014/main" id="{06EDD9F3-C591-4905-840A-0EB12B75DEA4}"/>
               </a:ext>
             </a:extLst>
           </p:cNvPr>
@@ -23118,7 +23118,7 @@
         </p:nvSpPr>
         <p:spPr>
           <a:xfrm xmlns:a="http://schemas.openxmlformats.org/drawingml/2006/main">
-            <a:off x="9058275" y="1809750"/>
+            <a:off x="9058275" y="1704975"/>
             <a:ext cx="2333625" cy="1238250"/>
           </a:xfrm>
           <a:prstGeom xmlns:a="http://schemas.openxmlformats.org/drawingml/2006/main" prst="rect">
@@ -23140,7 +23140,7 @@
           <p:cNvPr id="18" name="">
             <a:extLst xmlns:a="http://schemas.openxmlformats.org/drawingml/2006/main">
               <a:ext uri="{FF2B5EF4-FFF2-40B4-BE49-F238E27FC236}">
-                <a16:creationId xmlns:a16="http://schemas.microsoft.com/office/drawing/2014/main" id="{EAF482B6-E189-402B-B256-78343339B92E}"/>
+                <a16:creationId xmlns:a16="http://schemas.microsoft.com/office/drawing/2014/main" id="{42D9594C-4845-4F97-BFE7-E47059F9E770}"/>
               </a:ext>
             </a:extLst>
           </p:cNvPr>
@@ -23151,7 +23151,7 @@
         </p:nvSpPr>
         <p:spPr>
           <a:xfrm xmlns:a="http://schemas.openxmlformats.org/drawingml/2006/main">
-            <a:off x="9191625" y="1943100"/>
+            <a:off x="9191625" y="1838325"/>
             <a:ext cx="2066925" cy="361950"/>
           </a:xfrm>
           <a:prstGeom xmlns:a="http://schemas.openxmlformats.org/drawingml/2006/main" prst="rect">
@@ -23287,7 +23287,7 @@
                 <a:ea typeface="Arial"/>
                 <a:cs typeface="Arial"/>
               </a:rPr>
-              <a:t>Finalize</a:t>
+              <a:t>Agent memory</a:t>
             </a:r>
           </a:p>
         </p:txBody>
@@ -23297,7 +23297,7 @@
           <p:cNvPr id="19" name="">
             <a:extLst xmlns:a="http://schemas.openxmlformats.org/drawingml/2006/main">
               <a:ext uri="{FF2B5EF4-FFF2-40B4-BE49-F238E27FC236}">
-                <a16:creationId xmlns:a16="http://schemas.microsoft.com/office/drawing/2014/main" id="{24A4BF89-96BD-4FD7-BF20-E5ED2F67F325}"/>
+                <a16:creationId xmlns:a16="http://schemas.microsoft.com/office/drawing/2014/main" id="{69837D50-0605-4E93-87D2-25C5407DE9B7}"/>
               </a:ext>
             </a:extLst>
           </p:cNvPr>
@@ -23308,7 +23308,7 @@
         </p:nvSpPr>
         <p:spPr>
           <a:xfrm xmlns:a="http://schemas.openxmlformats.org/drawingml/2006/main">
-            <a:off x="9191625" y="2352675"/>
+            <a:off x="9191625" y="2247900"/>
             <a:ext cx="2066925" cy="619125"/>
           </a:xfrm>
           <a:prstGeom xmlns:a="http://schemas.openxmlformats.org/drawingml/2006/main" prst="rect">
@@ -23444,7 +23444,7 @@
                 <a:ea typeface="Arial"/>
                 <a:cs typeface="Arial"/>
               </a:rPr>
-              <a:t>Best verified</a:t>
+              <a:t>Cycles, area, timing</a:t>
             </a:r>
           </a:p>
           <a:p xmlns:a="http://schemas.openxmlformats.org/drawingml/2006/main">
@@ -23467,7 +23467,7 @@
                 <a:ea typeface="Arial"/>
                 <a:cs typeface="Arial"/>
               </a:rPr>
-              <a:t>feasible result</a:t>
+              <a:t>Persistent ledger</a:t>
             </a:r>
           </a:p>
         </p:txBody>
@@ -23477,7 +23477,7 @@
           <p:cNvPr id="20" name="">
             <a:extLst xmlns:a="http://schemas.openxmlformats.org/drawingml/2006/main">
               <a:ext uri="{FF2B5EF4-FFF2-40B4-BE49-F238E27FC236}">
-                <a16:creationId xmlns:a16="http://schemas.microsoft.com/office/drawing/2014/main" id="{4BACE5E2-AD62-49A3-846D-1D1D14731E58}"/>
+                <a16:creationId xmlns:a16="http://schemas.microsoft.com/office/drawing/2014/main" id="{928DCEFA-20E6-4942-8CB5-5329E0D9C1AF}"/>
               </a:ext>
             </a:extLst>
           </p:cNvPr>
@@ -23488,7 +23488,7 @@
         </p:nvSpPr>
         <p:spPr>
           <a:xfrm xmlns:a="http://schemas.openxmlformats.org/drawingml/2006/main">
-            <a:off x="10363200" y="3086100"/>
+            <a:off x="10363200" y="3028950"/>
             <a:ext cx="0" cy="219075"/>
           </a:xfrm>
           <a:prstGeom xmlns:a="http://schemas.openxmlformats.org/drawingml/2006/main" prst="line">
@@ -23497,7 +23497,7 @@
           <a:noFill xmlns:a="http://schemas.openxmlformats.org/drawingml/2006/main"/>
           <a:ln xmlns:a="http://schemas.openxmlformats.org/drawingml/2006/main" w="19050">
             <a:solidFill>
-              <a:srgbClr val="2878A8"/>
+              <a:srgbClr val="18856B"/>
             </a:solidFill>
             <a:prstDash val="solid"/>
           </a:ln>
@@ -23508,7 +23508,7 @@
           <p:cNvPr id="21" name="">
             <a:extLst xmlns:a="http://schemas.openxmlformats.org/drawingml/2006/main">
               <a:ext uri="{FF2B5EF4-FFF2-40B4-BE49-F238E27FC236}">
-                <a16:creationId xmlns:a16="http://schemas.microsoft.com/office/drawing/2014/main" id="{7B20ED7B-28DA-4037-8D5A-D6E1DC20D4E6}"/>
+                <a16:creationId xmlns:a16="http://schemas.microsoft.com/office/drawing/2014/main" id="{D72D2221-ED6D-48E8-BF7E-3C6ABD77D896}"/>
               </a:ext>
             </a:extLst>
           </p:cNvPr>
@@ -23519,8 +23519,8 @@
         </p:nvSpPr>
         <p:spPr>
           <a:xfrm xmlns:a="http://schemas.openxmlformats.org/drawingml/2006/main">
-            <a:off x="3952875" y="3305175"/>
-            <a:ext cx="6410325" cy="0"/>
+            <a:off x="4095750" y="3248025"/>
+            <a:ext cx="6267450" cy="0"/>
           </a:xfrm>
           <a:prstGeom xmlns:a="http://schemas.openxmlformats.org/drawingml/2006/main" prst="line">
             <a:avLst/>
@@ -23528,7 +23528,7 @@
           <a:noFill xmlns:a="http://schemas.openxmlformats.org/drawingml/2006/main"/>
           <a:ln xmlns:a="http://schemas.openxmlformats.org/drawingml/2006/main" w="19050">
             <a:solidFill>
-              <a:srgbClr val="2878A8"/>
+              <a:srgbClr val="18856B"/>
             </a:solidFill>
             <a:prstDash val="solid"/>
           </a:ln>
@@ -23539,7 +23539,7 @@
           <p:cNvPr id="22" name="">
             <a:extLst xmlns:a="http://schemas.openxmlformats.org/drawingml/2006/main">
               <a:ext uri="{FF2B5EF4-FFF2-40B4-BE49-F238E27FC236}">
-                <a16:creationId xmlns:a16="http://schemas.microsoft.com/office/drawing/2014/main" id="{670B2C8B-7F11-4354-80CF-3AE7BA78F915}"/>
+                <a16:creationId xmlns:a16="http://schemas.microsoft.com/office/drawing/2014/main" id="{B8A20A28-8871-43B8-AA13-128D7127E4CF}"/>
               </a:ext>
             </a:extLst>
           </p:cNvPr>
@@ -23550,8 +23550,8 @@
         </p:nvSpPr>
         <p:spPr>
           <a:xfrm xmlns:a="http://schemas.openxmlformats.org/drawingml/2006/main">
-            <a:off x="4095750" y="3400425"/>
-            <a:ext cx="6667500" cy="323850"/>
+            <a:off x="4000500" y="3333750"/>
+            <a:ext cx="7239000" cy="295275"/>
           </a:xfrm>
           <a:prstGeom xmlns:a="http://schemas.openxmlformats.org/drawingml/2006/main" prst="rect">
             <a:avLst/>
@@ -23568,7 +23568,7 @@
             <a:defPPr>
               <a:defRPr sz="1725" b="1">
                 <a:solidFill>
-                  <a:srgbClr val="2878A8"/>
+                  <a:srgbClr val="18856B"/>
                 </a:solidFill>
                 <a:latin typeface="Arial"/>
                 <a:ea typeface="Arial"/>
@@ -23578,7 +23578,7 @@
             <a:lvl1pPr>
               <a:defRPr sz="1725" b="1">
                 <a:solidFill>
-                  <a:srgbClr val="2878A8"/>
+                  <a:srgbClr val="18856B"/>
                 </a:solidFill>
                 <a:latin typeface="Arial"/>
                 <a:ea typeface="Arial"/>
@@ -23588,7 +23588,7 @@
             <a:lvl2pPr>
               <a:defRPr sz="1725" b="1">
                 <a:solidFill>
-                  <a:srgbClr val="2878A8"/>
+                  <a:srgbClr val="18856B"/>
                 </a:solidFill>
                 <a:latin typeface="Arial"/>
                 <a:ea typeface="Arial"/>
@@ -23598,7 +23598,7 @@
             <a:lvl3pPr>
               <a:defRPr sz="1725" b="1">
                 <a:solidFill>
-                  <a:srgbClr val="2878A8"/>
+                  <a:srgbClr val="18856B"/>
                 </a:solidFill>
                 <a:latin typeface="Arial"/>
                 <a:ea typeface="Arial"/>
@@ -23608,7 +23608,7 @@
             <a:lvl4pPr>
               <a:defRPr sz="1725" b="1">
                 <a:solidFill>
-                  <a:srgbClr val="2878A8"/>
+                  <a:srgbClr val="18856B"/>
                 </a:solidFill>
                 <a:latin typeface="Arial"/>
                 <a:ea typeface="Arial"/>
@@ -23618,7 +23618,7 @@
             <a:lvl5pPr>
               <a:defRPr sz="1725" b="1">
                 <a:solidFill>
-                  <a:srgbClr val="2878A8"/>
+                  <a:srgbClr val="18856B"/>
                 </a:solidFill>
                 <a:latin typeface="Arial"/>
                 <a:ea typeface="Arial"/>
@@ -23628,7 +23628,7 @@
             <a:lvl6pPr>
               <a:defRPr sz="1725" b="1">
                 <a:solidFill>
-                  <a:srgbClr val="2878A8"/>
+                  <a:srgbClr val="18856B"/>
                 </a:solidFill>
                 <a:latin typeface="Arial"/>
                 <a:ea typeface="Arial"/>
@@ -23638,7 +23638,7 @@
             <a:lvl7pPr>
               <a:defRPr sz="1725" b="1">
                 <a:solidFill>
-                  <a:srgbClr val="2878A8"/>
+                  <a:srgbClr val="18856B"/>
                 </a:solidFill>
                 <a:latin typeface="Arial"/>
                 <a:ea typeface="Arial"/>
@@ -23648,7 +23648,7 @@
             <a:lvl8pPr>
               <a:defRPr sz="1725" b="1">
                 <a:solidFill>
-                  <a:srgbClr val="2878A8"/>
+                  <a:srgbClr val="18856B"/>
                 </a:solidFill>
                 <a:latin typeface="Arial"/>
                 <a:ea typeface="Arial"/>
@@ -23658,7 +23658,7 @@
             <a:lvl9pPr>
               <a:defRPr sz="1725" b="1">
                 <a:solidFill>
-                  <a:srgbClr val="2878A8"/>
+                  <a:srgbClr val="18856B"/>
                 </a:solidFill>
                 <a:latin typeface="Arial"/>
                 <a:ea typeface="Arial"/>
@@ -23670,7 +23670,7 @@
             <a:pPr>
               <a:defRPr sz="1725" b="1">
                 <a:solidFill>
-                  <a:srgbClr val="2878A8"/>
+                  <a:srgbClr val="18856B"/>
                 </a:solidFill>
                 <a:latin typeface="Arial"/>
                 <a:ea typeface="Arial"/>
@@ -23680,13 +23680,13 @@
             <a:r>
               <a:rPr sz="1725" b="1">
                 <a:solidFill>
-                  <a:srgbClr val="2878A8"/>
+                  <a:srgbClr val="18856B"/>
                 </a:solidFill>
                 <a:latin typeface="Arial"/>
                 <a:ea typeface="Arial"/>
                 <a:cs typeface="Arial"/>
               </a:rPr>
-              <a:t>Paid outcomes inform the next decision</a:t>
+              <a:t>Paid observations feed the next decision</a:t>
             </a:r>
           </a:p>
         </p:txBody>
@@ -23696,7 +23696,7 @@
           <p:cNvPr id="23" name="">
             <a:extLst xmlns:a="http://schemas.openxmlformats.org/drawingml/2006/main">
               <a:ext uri="{FF2B5EF4-FFF2-40B4-BE49-F238E27FC236}">
-                <a16:creationId xmlns:a16="http://schemas.microsoft.com/office/drawing/2014/main" id="{B0EE5137-1136-4853-9266-322624EF39A2}"/>
+                <a16:creationId xmlns:a16="http://schemas.microsoft.com/office/drawing/2014/main" id="{A9DE638A-388C-4B39-B4FE-3329052784F3}"/>
               </a:ext>
             </a:extLst>
           </p:cNvPr>
@@ -23707,7 +23707,7 @@
         </p:nvSpPr>
         <p:spPr>
           <a:xfrm xmlns:a="http://schemas.openxmlformats.org/drawingml/2006/main">
-            <a:off x="685800" y="3914775"/>
+            <a:off x="685800" y="3762375"/>
             <a:ext cx="10820400" cy="0"/>
           </a:xfrm>
           <a:prstGeom xmlns:a="http://schemas.openxmlformats.org/drawingml/2006/main" prst="line">
@@ -23727,7 +23727,7 @@
           <p:cNvPr id="24" name="">
             <a:extLst xmlns:a="http://schemas.openxmlformats.org/drawingml/2006/main">
               <a:ext uri="{FF2B5EF4-FFF2-40B4-BE49-F238E27FC236}">
-                <a16:creationId xmlns:a16="http://schemas.microsoft.com/office/drawing/2014/main" id="{41462B26-B4FE-470C-9468-339482C2C499}"/>
+                <a16:creationId xmlns:a16="http://schemas.microsoft.com/office/drawing/2014/main" id="{291CC844-D9A7-4797-9D61-6F0860935792}"/>
               </a:ext>
             </a:extLst>
           </p:cNvPr>
@@ -23738,8 +23738,8 @@
         </p:nvSpPr>
         <p:spPr>
           <a:xfrm xmlns:a="http://schemas.openxmlformats.org/drawingml/2006/main">
-            <a:off x="685800" y="4095750"/>
-            <a:ext cx="7810500" cy="342900"/>
+            <a:off x="685800" y="3914775"/>
+            <a:ext cx="5095875" cy="285750"/>
           </a:xfrm>
           <a:prstGeom xmlns:a="http://schemas.openxmlformats.org/drawingml/2006/main" prst="rect">
             <a:avLst/>
@@ -23754,7 +23754,7 @@
           <a:bodyPr xmlns:a="http://schemas.openxmlformats.org/drawingml/2006/main" lIns="0" tIns="0" rIns="0" bIns="0"/>
           <a:lstStyle xmlns:a="http://schemas.openxmlformats.org/drawingml/2006/main">
             <a:defPPr>
-              <a:defRPr sz="1950" b="1">
+              <a:defRPr sz="1725" b="1">
                 <a:solidFill>
                   <a:srgbClr val="A65A00"/>
                 </a:solidFill>
@@ -23764,7 +23764,7 @@
               </a:defRPr>
             </a:defPPr>
             <a:lvl1pPr>
-              <a:defRPr sz="1950" b="1">
+              <a:defRPr sz="1725" b="1">
                 <a:solidFill>
                   <a:srgbClr val="A65A00"/>
                 </a:solidFill>
@@ -23774,7 +23774,7 @@
               </a:defRPr>
             </a:lvl1pPr>
             <a:lvl2pPr>
-              <a:defRPr sz="1950" b="1">
+              <a:defRPr sz="1725" b="1">
                 <a:solidFill>
                   <a:srgbClr val="A65A00"/>
                 </a:solidFill>
@@ -23784,7 +23784,7 @@
               </a:defRPr>
             </a:lvl2pPr>
             <a:lvl3pPr>
-              <a:defRPr sz="1950" b="1">
+              <a:defRPr sz="1725" b="1">
                 <a:solidFill>
                   <a:srgbClr val="A65A00"/>
                 </a:solidFill>
@@ -23794,7 +23794,7 @@
               </a:defRPr>
             </a:lvl3pPr>
             <a:lvl4pPr>
-              <a:defRPr sz="1950" b="1">
+              <a:defRPr sz="1725" b="1">
                 <a:solidFill>
                   <a:srgbClr val="A65A00"/>
                 </a:solidFill>
@@ -23804,7 +23804,7 @@
               </a:defRPr>
             </a:lvl4pPr>
             <a:lvl5pPr>
-              <a:defRPr sz="1950" b="1">
+              <a:defRPr sz="1725" b="1">
                 <a:solidFill>
                   <a:srgbClr val="A65A00"/>
                 </a:solidFill>
@@ -23814,7 +23814,7 @@
               </a:defRPr>
             </a:lvl5pPr>
             <a:lvl6pPr>
-              <a:defRPr sz="1950" b="1">
+              <a:defRPr sz="1725" b="1">
                 <a:solidFill>
                   <a:srgbClr val="A65A00"/>
                 </a:solidFill>
@@ -23824,7 +23824,7 @@
               </a:defRPr>
             </a:lvl6pPr>
             <a:lvl7pPr>
-              <a:defRPr sz="1950" b="1">
+              <a:defRPr sz="1725" b="1">
                 <a:solidFill>
                   <a:srgbClr val="A65A00"/>
                 </a:solidFill>
@@ -23834,7 +23834,7 @@
               </a:defRPr>
             </a:lvl7pPr>
             <a:lvl8pPr>
-              <a:defRPr sz="1950" b="1">
+              <a:defRPr sz="1725" b="1">
                 <a:solidFill>
                   <a:srgbClr val="A65A00"/>
                 </a:solidFill>
@@ -23844,7 +23844,7 @@
               </a:defRPr>
             </a:lvl8pPr>
             <a:lvl9pPr>
-              <a:defRPr sz="1950" b="1">
+              <a:defRPr sz="1725" b="1">
                 <a:solidFill>
                   <a:srgbClr val="A65A00"/>
                 </a:solidFill>
@@ -23856,7 +23856,7 @@
           </a:lstStyle>
           <a:p xmlns:a="http://schemas.openxmlformats.org/drawingml/2006/main">
             <a:pPr>
-              <a:defRPr sz="1950" b="1">
+              <a:defRPr sz="1725" b="1">
                 <a:solidFill>
                   <a:srgbClr val="A65A00"/>
                 </a:solidFill>
@@ -23866,7 +23866,7 @@
               </a:defRPr>
             </a:pPr>
             <a:r>
-              <a:rPr sz="1950" b="1">
+              <a:rPr sz="1725" b="1">
                 <a:solidFill>
                   <a:srgbClr val="A65A00"/>
                 </a:solidFill>
@@ -23874,7 +23874,7 @@
                 <a:ea typeface="Arial"/>
                 <a:cs typeface="Arial"/>
               </a:rPr>
-              <a:t>PLANNED  |  Dynamic LLM routing</a:t>
+              <a:t>PLANNED DECISION LAYER</a:t>
             </a:r>
           </a:p>
         </p:txBody>
@@ -23884,7 +23884,7 @@
           <p:cNvPr id="25" name="">
             <a:extLst xmlns:a="http://schemas.openxmlformats.org/drawingml/2006/main">
               <a:ext uri="{FF2B5EF4-FFF2-40B4-BE49-F238E27FC236}">
-                <a16:creationId xmlns:a16="http://schemas.microsoft.com/office/drawing/2014/main" id="{DEFCC824-9482-4F68-ACDC-CC7D9EF259FF}"/>
+                <a16:creationId xmlns:a16="http://schemas.microsoft.com/office/drawing/2014/main" id="{BFCD71AC-5E2E-42C6-BACA-318DB1CF2F86}"/>
               </a:ext>
             </a:extLst>
           </p:cNvPr>
@@ -23895,8 +23895,8 @@
         </p:nvSpPr>
         <p:spPr>
           <a:xfrm xmlns:a="http://schemas.openxmlformats.org/drawingml/2006/main">
-            <a:off x="685800" y="4543425"/>
-            <a:ext cx="9906000" cy="381000"/>
+            <a:off x="685800" y="4314825"/>
+            <a:ext cx="5286375" cy="723900"/>
           </a:xfrm>
           <a:prstGeom xmlns:a="http://schemas.openxmlformats.org/drawingml/2006/main" prst="rect">
             <a:avLst/>
@@ -23911,9 +23911,9 @@
           <a:bodyPr xmlns:a="http://schemas.openxmlformats.org/drawingml/2006/main" lIns="0" tIns="0" rIns="0" bIns="0"/>
           <a:lstStyle xmlns:a="http://schemas.openxmlformats.org/drawingml/2006/main">
             <a:defPPr>
-              <a:defRPr sz="2025" b="1">
-                <a:solidFill>
-                  <a:srgbClr val="17324D"/>
+              <a:defRPr sz="1800" b="0">
+                <a:solidFill>
+                  <a:srgbClr val="263648"/>
                 </a:solidFill>
                 <a:latin typeface="Arial"/>
                 <a:ea typeface="Arial"/>
@@ -23921,9 +23921,9 @@
               </a:defRPr>
             </a:defPPr>
             <a:lvl1pPr>
-              <a:defRPr sz="2025" b="1">
-                <a:solidFill>
-                  <a:srgbClr val="17324D"/>
+              <a:defRPr sz="1800" b="0">
+                <a:solidFill>
+                  <a:srgbClr val="263648"/>
                 </a:solidFill>
                 <a:latin typeface="Arial"/>
                 <a:ea typeface="Arial"/>
@@ -23931,9 +23931,9 @@
               </a:defRPr>
             </a:lvl1pPr>
             <a:lvl2pPr>
-              <a:defRPr sz="2025" b="1">
-                <a:solidFill>
-                  <a:srgbClr val="17324D"/>
+              <a:defRPr sz="1800" b="0">
+                <a:solidFill>
+                  <a:srgbClr val="263648"/>
                 </a:solidFill>
                 <a:latin typeface="Arial"/>
                 <a:ea typeface="Arial"/>
@@ -23941,9 +23941,9 @@
               </a:defRPr>
             </a:lvl2pPr>
             <a:lvl3pPr>
-              <a:defRPr sz="2025" b="1">
-                <a:solidFill>
-                  <a:srgbClr val="17324D"/>
+              <a:defRPr sz="1800" b="0">
+                <a:solidFill>
+                  <a:srgbClr val="263648"/>
                 </a:solidFill>
                 <a:latin typeface="Arial"/>
                 <a:ea typeface="Arial"/>
@@ -23951,9 +23951,9 @@
               </a:defRPr>
             </a:lvl3pPr>
             <a:lvl4pPr>
-              <a:defRPr sz="2025" b="1">
-                <a:solidFill>
-                  <a:srgbClr val="17324D"/>
+              <a:defRPr sz="1800" b="0">
+                <a:solidFill>
+                  <a:srgbClr val="263648"/>
                 </a:solidFill>
                 <a:latin typeface="Arial"/>
                 <a:ea typeface="Arial"/>
@@ -23961,9 +23961,9 @@
               </a:defRPr>
             </a:lvl4pPr>
             <a:lvl5pPr>
-              <a:defRPr sz="2025" b="1">
-                <a:solidFill>
-                  <a:srgbClr val="17324D"/>
+              <a:defRPr sz="1800" b="0">
+                <a:solidFill>
+                  <a:srgbClr val="263648"/>
                 </a:solidFill>
                 <a:latin typeface="Arial"/>
                 <a:ea typeface="Arial"/>
@@ -23971,9 +23971,9 @@
               </a:defRPr>
             </a:lvl5pPr>
             <a:lvl6pPr>
-              <a:defRPr sz="2025" b="1">
-                <a:solidFill>
-                  <a:srgbClr val="17324D"/>
+              <a:defRPr sz="1800" b="0">
+                <a:solidFill>
+                  <a:srgbClr val="263648"/>
                 </a:solidFill>
                 <a:latin typeface="Arial"/>
                 <a:ea typeface="Arial"/>
@@ -23981,9 +23981,9 @@
               </a:defRPr>
             </a:lvl6pPr>
             <a:lvl7pPr>
-              <a:defRPr sz="2025" b="1">
-                <a:solidFill>
-                  <a:srgbClr val="17324D"/>
+              <a:defRPr sz="1800" b="0">
+                <a:solidFill>
+                  <a:srgbClr val="263648"/>
                 </a:solidFill>
                 <a:latin typeface="Arial"/>
                 <a:ea typeface="Arial"/>
@@ -23991,9 +23991,9 @@
               </a:defRPr>
             </a:lvl7pPr>
             <a:lvl8pPr>
-              <a:defRPr sz="2025" b="1">
-                <a:solidFill>
-                  <a:srgbClr val="17324D"/>
+              <a:defRPr sz="1800" b="0">
+                <a:solidFill>
+                  <a:srgbClr val="263648"/>
                 </a:solidFill>
                 <a:latin typeface="Arial"/>
                 <a:ea typeface="Arial"/>
@@ -24001,9 +24001,9 @@
               </a:defRPr>
             </a:lvl8pPr>
             <a:lvl9pPr>
-              <a:defRPr sz="2025" b="1">
-                <a:solidFill>
-                  <a:srgbClr val="17324D"/>
+              <a:defRPr sz="1800" b="0">
+                <a:solidFill>
+                  <a:srgbClr val="263648"/>
                 </a:solidFill>
                 <a:latin typeface="Arial"/>
                 <a:ea typeface="Arial"/>
@@ -24013,9 +24013,9 @@
           </a:lstStyle>
           <a:p xmlns:a="http://schemas.openxmlformats.org/drawingml/2006/main">
             <a:pPr>
-              <a:defRPr sz="2025" b="1">
-                <a:solidFill>
-                  <a:srgbClr val="17324D"/>
+              <a:defRPr sz="1800" b="0">
+                <a:solidFill>
+                  <a:srgbClr val="263648"/>
                 </a:solidFill>
                 <a:latin typeface="Arial"/>
                 <a:ea typeface="Arial"/>
@@ -24023,15 +24023,38 @@
               </a:defRPr>
             </a:pPr>
             <a:r>
-              <a:rPr sz="2025" b="1">
-                <a:solidFill>
-                  <a:srgbClr val="17324D"/>
+              <a:rPr sz="1800" b="0">
+                <a:solidFill>
+                  <a:srgbClr val="263648"/>
                 </a:solidFill>
                 <a:latin typeface="Arial"/>
                 <a:ea typeface="Arial"/>
                 <a:cs typeface="Arial"/>
               </a:rPr>
-              <a:t>Small model → escalate difficult cases → stronger model</a:t>
+              <a:t>Context window + token budget</a:t>
+            </a:r>
+          </a:p>
+          <a:p xmlns:a="http://schemas.openxmlformats.org/drawingml/2006/main">
+            <a:pPr>
+              <a:defRPr sz="1800" b="0">
+                <a:solidFill>
+                  <a:srgbClr val="263648"/>
+                </a:solidFill>
+                <a:latin typeface="Arial"/>
+                <a:ea typeface="Arial"/>
+                <a:cs typeface="Arial"/>
+              </a:defRPr>
+            </a:pPr>
+            <a:r>
+              <a:rPr sz="1800" b="0">
+                <a:solidFill>
+                  <a:srgbClr val="263648"/>
+                </a:solidFill>
+                <a:latin typeface="Arial"/>
+                <a:ea typeface="Arial"/>
+                <a:cs typeface="Arial"/>
+              </a:rPr>
+              <a:t>Small LLM → escalate → strong LLM</a:t>
             </a:r>
           </a:p>
         </p:txBody>
@@ -24041,7 +24064,7 @@
           <p:cNvPr id="26" name="">
             <a:extLst xmlns:a="http://schemas.openxmlformats.org/drawingml/2006/main">
               <a:ext uri="{FF2B5EF4-FFF2-40B4-BE49-F238E27FC236}">
-                <a16:creationId xmlns:a16="http://schemas.microsoft.com/office/drawing/2014/main" id="{8F5A3EC3-3C97-417A-815D-9F5BCBE9137A}"/>
+                <a16:creationId xmlns:a16="http://schemas.microsoft.com/office/drawing/2014/main" id="{47EFA70A-10E9-45EC-A888-827CE5512827}"/>
               </a:ext>
             </a:extLst>
           </p:cNvPr>
@@ -24052,7 +24075,532 @@
         </p:nvSpPr>
         <p:spPr>
           <a:xfrm xmlns:a="http://schemas.openxmlformats.org/drawingml/2006/main">
-            <a:off x="685800" y="5057775"/>
+            <a:off x="6477000" y="3914775"/>
+            <a:ext cx="5048250" cy="285750"/>
+          </a:xfrm>
+          <a:prstGeom xmlns:a="http://schemas.openxmlformats.org/drawingml/2006/main" prst="rect">
+            <a:avLst/>
+          </a:prstGeom>
+          <a:noFill xmlns:a="http://schemas.openxmlformats.org/drawingml/2006/main"/>
+          <a:ln xmlns:a="http://schemas.openxmlformats.org/drawingml/2006/main" w="0">
+            <a:noFill/>
+            <a:prstDash val="solid"/>
+          </a:ln>
+        </p:spPr>
+        <p:txBody>
+          <a:bodyPr xmlns:a="http://schemas.openxmlformats.org/drawingml/2006/main" lIns="0" tIns="0" rIns="0" bIns="0"/>
+          <a:lstStyle xmlns:a="http://schemas.openxmlformats.org/drawingml/2006/main">
+            <a:defPPr>
+              <a:defRPr sz="1725" b="1">
+                <a:solidFill>
+                  <a:srgbClr val="A65A00"/>
+                </a:solidFill>
+                <a:latin typeface="Arial"/>
+                <a:ea typeface="Arial"/>
+                <a:cs typeface="Arial"/>
+              </a:defRPr>
+            </a:defPPr>
+            <a:lvl1pPr>
+              <a:defRPr sz="1725" b="1">
+                <a:solidFill>
+                  <a:srgbClr val="A65A00"/>
+                </a:solidFill>
+                <a:latin typeface="Arial"/>
+                <a:ea typeface="Arial"/>
+                <a:cs typeface="Arial"/>
+              </a:defRPr>
+            </a:lvl1pPr>
+            <a:lvl2pPr>
+              <a:defRPr sz="1725" b="1">
+                <a:solidFill>
+                  <a:srgbClr val="A65A00"/>
+                </a:solidFill>
+                <a:latin typeface="Arial"/>
+                <a:ea typeface="Arial"/>
+                <a:cs typeface="Arial"/>
+              </a:defRPr>
+            </a:lvl2pPr>
+            <a:lvl3pPr>
+              <a:defRPr sz="1725" b="1">
+                <a:solidFill>
+                  <a:srgbClr val="A65A00"/>
+                </a:solidFill>
+                <a:latin typeface="Arial"/>
+                <a:ea typeface="Arial"/>
+                <a:cs typeface="Arial"/>
+              </a:defRPr>
+            </a:lvl3pPr>
+            <a:lvl4pPr>
+              <a:defRPr sz="1725" b="1">
+                <a:solidFill>
+                  <a:srgbClr val="A65A00"/>
+                </a:solidFill>
+                <a:latin typeface="Arial"/>
+                <a:ea typeface="Arial"/>
+                <a:cs typeface="Arial"/>
+              </a:defRPr>
+            </a:lvl4pPr>
+            <a:lvl5pPr>
+              <a:defRPr sz="1725" b="1">
+                <a:solidFill>
+                  <a:srgbClr val="A65A00"/>
+                </a:solidFill>
+                <a:latin typeface="Arial"/>
+                <a:ea typeface="Arial"/>
+                <a:cs typeface="Arial"/>
+              </a:defRPr>
+            </a:lvl5pPr>
+            <a:lvl6pPr>
+              <a:defRPr sz="1725" b="1">
+                <a:solidFill>
+                  <a:srgbClr val="A65A00"/>
+                </a:solidFill>
+                <a:latin typeface="Arial"/>
+                <a:ea typeface="Arial"/>
+                <a:cs typeface="Arial"/>
+              </a:defRPr>
+            </a:lvl6pPr>
+            <a:lvl7pPr>
+              <a:defRPr sz="1725" b="1">
+                <a:solidFill>
+                  <a:srgbClr val="A65A00"/>
+                </a:solidFill>
+                <a:latin typeface="Arial"/>
+                <a:ea typeface="Arial"/>
+                <a:cs typeface="Arial"/>
+              </a:defRPr>
+            </a:lvl7pPr>
+            <a:lvl8pPr>
+              <a:defRPr sz="1725" b="1">
+                <a:solidFill>
+                  <a:srgbClr val="A65A00"/>
+                </a:solidFill>
+                <a:latin typeface="Arial"/>
+                <a:ea typeface="Arial"/>
+                <a:cs typeface="Arial"/>
+              </a:defRPr>
+            </a:lvl8pPr>
+            <a:lvl9pPr>
+              <a:defRPr sz="1725" b="1">
+                <a:solidFill>
+                  <a:srgbClr val="A65A00"/>
+                </a:solidFill>
+                <a:latin typeface="Arial"/>
+                <a:ea typeface="Arial"/>
+                <a:cs typeface="Arial"/>
+              </a:defRPr>
+            </a:lvl9pPr>
+          </a:lstStyle>
+          <a:p xmlns:a="http://schemas.openxmlformats.org/drawingml/2006/main">
+            <a:pPr>
+              <a:defRPr sz="1725" b="1">
+                <a:solidFill>
+                  <a:srgbClr val="A65A00"/>
+                </a:solidFill>
+                <a:latin typeface="Arial"/>
+                <a:ea typeface="Arial"/>
+                <a:cs typeface="Arial"/>
+              </a:defRPr>
+            </a:pPr>
+            <a:r>
+              <a:rPr sz="1725" b="1">
+                <a:solidFill>
+                  <a:srgbClr val="A65A00"/>
+                </a:solidFill>
+                <a:latin typeface="Arial"/>
+                <a:ea typeface="Arial"/>
+                <a:cs typeface="Arial"/>
+              </a:rPr>
+              <a:t>OPTIONAL KNOWLEDGE LAYER</a:t>
+            </a:r>
+          </a:p>
+        </p:txBody>
+      </p:sp>
+      <p:sp>
+        <p:nvSpPr>
+          <p:cNvPr id="27" name="">
+            <a:extLst xmlns:a="http://schemas.openxmlformats.org/drawingml/2006/main">
+              <a:ext uri="{FF2B5EF4-FFF2-40B4-BE49-F238E27FC236}">
+                <a16:creationId xmlns:a16="http://schemas.microsoft.com/office/drawing/2014/main" id="{7A855CDF-D2F5-450C-9EB5-39055A3182FC}"/>
+              </a:ext>
+            </a:extLst>
+          </p:cNvPr>
+          <p:cNvSpPr>
+            <a:spLocks xmlns:a="http://schemas.openxmlformats.org/drawingml/2006/main" noGrp="1"/>
+          </p:cNvSpPr>
+          <p:nvPr/>
+        </p:nvSpPr>
+        <p:spPr>
+          <a:xfrm xmlns:a="http://schemas.openxmlformats.org/drawingml/2006/main">
+            <a:off x="6477000" y="4314825"/>
+            <a:ext cx="5048250" cy="723900"/>
+          </a:xfrm>
+          <a:prstGeom xmlns:a="http://schemas.openxmlformats.org/drawingml/2006/main" prst="rect">
+            <a:avLst/>
+          </a:prstGeom>
+          <a:noFill xmlns:a="http://schemas.openxmlformats.org/drawingml/2006/main"/>
+          <a:ln xmlns:a="http://schemas.openxmlformats.org/drawingml/2006/main" w="0">
+            <a:noFill/>
+            <a:prstDash val="solid"/>
+          </a:ln>
+        </p:spPr>
+        <p:txBody>
+          <a:bodyPr xmlns:a="http://schemas.openxmlformats.org/drawingml/2006/main" lIns="0" tIns="0" rIns="0" bIns="0"/>
+          <a:lstStyle xmlns:a="http://schemas.openxmlformats.org/drawingml/2006/main">
+            <a:defPPr>
+              <a:defRPr sz="1800" b="0">
+                <a:solidFill>
+                  <a:srgbClr val="263648"/>
+                </a:solidFill>
+                <a:latin typeface="Arial"/>
+                <a:ea typeface="Arial"/>
+                <a:cs typeface="Arial"/>
+              </a:defRPr>
+            </a:defPPr>
+            <a:lvl1pPr>
+              <a:defRPr sz="1800" b="0">
+                <a:solidFill>
+                  <a:srgbClr val="263648"/>
+                </a:solidFill>
+                <a:latin typeface="Arial"/>
+                <a:ea typeface="Arial"/>
+                <a:cs typeface="Arial"/>
+              </a:defRPr>
+            </a:lvl1pPr>
+            <a:lvl2pPr>
+              <a:defRPr sz="1800" b="0">
+                <a:solidFill>
+                  <a:srgbClr val="263648"/>
+                </a:solidFill>
+                <a:latin typeface="Arial"/>
+                <a:ea typeface="Arial"/>
+                <a:cs typeface="Arial"/>
+              </a:defRPr>
+            </a:lvl2pPr>
+            <a:lvl3pPr>
+              <a:defRPr sz="1800" b="0">
+                <a:solidFill>
+                  <a:srgbClr val="263648"/>
+                </a:solidFill>
+                <a:latin typeface="Arial"/>
+                <a:ea typeface="Arial"/>
+                <a:cs typeface="Arial"/>
+              </a:defRPr>
+            </a:lvl3pPr>
+            <a:lvl4pPr>
+              <a:defRPr sz="1800" b="0">
+                <a:solidFill>
+                  <a:srgbClr val="263648"/>
+                </a:solidFill>
+                <a:latin typeface="Arial"/>
+                <a:ea typeface="Arial"/>
+                <a:cs typeface="Arial"/>
+              </a:defRPr>
+            </a:lvl4pPr>
+            <a:lvl5pPr>
+              <a:defRPr sz="1800" b="0">
+                <a:solidFill>
+                  <a:srgbClr val="263648"/>
+                </a:solidFill>
+                <a:latin typeface="Arial"/>
+                <a:ea typeface="Arial"/>
+                <a:cs typeface="Arial"/>
+              </a:defRPr>
+            </a:lvl5pPr>
+            <a:lvl6pPr>
+              <a:defRPr sz="1800" b="0">
+                <a:solidFill>
+                  <a:srgbClr val="263648"/>
+                </a:solidFill>
+                <a:latin typeface="Arial"/>
+                <a:ea typeface="Arial"/>
+                <a:cs typeface="Arial"/>
+              </a:defRPr>
+            </a:lvl6pPr>
+            <a:lvl7pPr>
+              <a:defRPr sz="1800" b="0">
+                <a:solidFill>
+                  <a:srgbClr val="263648"/>
+                </a:solidFill>
+                <a:latin typeface="Arial"/>
+                <a:ea typeface="Arial"/>
+                <a:cs typeface="Arial"/>
+              </a:defRPr>
+            </a:lvl7pPr>
+            <a:lvl8pPr>
+              <a:defRPr sz="1800" b="0">
+                <a:solidFill>
+                  <a:srgbClr val="263648"/>
+                </a:solidFill>
+                <a:latin typeface="Arial"/>
+                <a:ea typeface="Arial"/>
+                <a:cs typeface="Arial"/>
+              </a:defRPr>
+            </a:lvl8pPr>
+            <a:lvl9pPr>
+              <a:defRPr sz="1800" b="0">
+                <a:solidFill>
+                  <a:srgbClr val="263648"/>
+                </a:solidFill>
+                <a:latin typeface="Arial"/>
+                <a:ea typeface="Arial"/>
+                <a:cs typeface="Arial"/>
+              </a:defRPr>
+            </a:lvl9pPr>
+          </a:lstStyle>
+          <a:p xmlns:a="http://schemas.openxmlformats.org/drawingml/2006/main">
+            <a:pPr>
+              <a:defRPr sz="1800" b="0">
+                <a:solidFill>
+                  <a:srgbClr val="263648"/>
+                </a:solidFill>
+                <a:latin typeface="Arial"/>
+                <a:ea typeface="Arial"/>
+                <a:cs typeface="Arial"/>
+              </a:defRPr>
+            </a:pPr>
+            <a:r>
+              <a:rPr sz="1800" b="0">
+                <a:solidFill>
+                  <a:srgbClr val="263648"/>
+                </a:solidFill>
+                <a:latin typeface="Arial"/>
+                <a:ea typeface="Arial"/>
+                <a:cs typeface="Arial"/>
+              </a:rPr>
+              <a:t>Approved history → chunk + embed</a:t>
+            </a:r>
+          </a:p>
+          <a:p xmlns:a="http://schemas.openxmlformats.org/drawingml/2006/main">
+            <a:pPr>
+              <a:defRPr sz="1800" b="0">
+                <a:solidFill>
+                  <a:srgbClr val="263648"/>
+                </a:solidFill>
+                <a:latin typeface="Arial"/>
+                <a:ea typeface="Arial"/>
+                <a:cs typeface="Arial"/>
+              </a:defRPr>
+            </a:pPr>
+            <a:r>
+              <a:rPr sz="1800" b="0">
+                <a:solidFill>
+                  <a:srgbClr val="263648"/>
+                </a:solidFill>
+                <a:latin typeface="Arial"/>
+                <a:ea typeface="Arial"/>
+                <a:cs typeface="Arial"/>
+              </a:rPr>
+              <a:t>Hybrid search → rerank → RAG context</a:t>
+            </a:r>
+          </a:p>
+        </p:txBody>
+      </p:sp>
+      <p:sp>
+        <p:nvSpPr>
+          <p:cNvPr id="28" name="">
+            <a:extLst xmlns:a="http://schemas.openxmlformats.org/drawingml/2006/main">
+              <a:ext uri="{FF2B5EF4-FFF2-40B4-BE49-F238E27FC236}">
+                <a16:creationId xmlns:a16="http://schemas.microsoft.com/office/drawing/2014/main" id="{E47F65BF-4BE8-4959-95B8-B18E11451F44}"/>
+              </a:ext>
+            </a:extLst>
+          </p:cNvPr>
+          <p:cNvSpPr>
+            <a:spLocks xmlns:a="http://schemas.openxmlformats.org/drawingml/2006/main" noGrp="1"/>
+          </p:cNvSpPr>
+          <p:nvPr/>
+        </p:nvSpPr>
+        <p:spPr>
+          <a:xfrm xmlns:a="http://schemas.openxmlformats.org/drawingml/2006/main">
+            <a:off x="685800" y="5143500"/>
+            <a:ext cx="10820400" cy="304800"/>
+          </a:xfrm>
+          <a:prstGeom xmlns:a="http://schemas.openxmlformats.org/drawingml/2006/main" prst="rect">
+            <a:avLst/>
+          </a:prstGeom>
+          <a:noFill xmlns:a="http://schemas.openxmlformats.org/drawingml/2006/main"/>
+          <a:ln xmlns:a="http://schemas.openxmlformats.org/drawingml/2006/main" w="0">
+            <a:noFill/>
+            <a:prstDash val="solid"/>
+          </a:ln>
+        </p:spPr>
+        <p:txBody>
+          <a:bodyPr xmlns:a="http://schemas.openxmlformats.org/drawingml/2006/main" lIns="0" tIns="0" rIns="0" bIns="0"/>
+          <a:lstStyle xmlns:a="http://schemas.openxmlformats.org/drawingml/2006/main">
+            <a:defPPr>
+              <a:defRPr sz="1650" b="0">
+                <a:solidFill>
+                  <a:srgbClr val="607286"/>
+                </a:solidFill>
+                <a:latin typeface="Arial"/>
+                <a:ea typeface="Arial"/>
+                <a:cs typeface="Arial"/>
+              </a:defRPr>
+            </a:defPPr>
+            <a:lvl1pPr>
+              <a:defRPr sz="1650" b="0">
+                <a:solidFill>
+                  <a:srgbClr val="607286"/>
+                </a:solidFill>
+                <a:latin typeface="Arial"/>
+                <a:ea typeface="Arial"/>
+                <a:cs typeface="Arial"/>
+              </a:defRPr>
+            </a:lvl1pPr>
+            <a:lvl2pPr>
+              <a:defRPr sz="1650" b="0">
+                <a:solidFill>
+                  <a:srgbClr val="607286"/>
+                </a:solidFill>
+                <a:latin typeface="Arial"/>
+                <a:ea typeface="Arial"/>
+                <a:cs typeface="Arial"/>
+              </a:defRPr>
+            </a:lvl2pPr>
+            <a:lvl3pPr>
+              <a:defRPr sz="1650" b="0">
+                <a:solidFill>
+                  <a:srgbClr val="607286"/>
+                </a:solidFill>
+                <a:latin typeface="Arial"/>
+                <a:ea typeface="Arial"/>
+                <a:cs typeface="Arial"/>
+              </a:defRPr>
+            </a:lvl3pPr>
+            <a:lvl4pPr>
+              <a:defRPr sz="1650" b="0">
+                <a:solidFill>
+                  <a:srgbClr val="607286"/>
+                </a:solidFill>
+                <a:latin typeface="Arial"/>
+                <a:ea typeface="Arial"/>
+                <a:cs typeface="Arial"/>
+              </a:defRPr>
+            </a:lvl4pPr>
+            <a:lvl5pPr>
+              <a:defRPr sz="1650" b="0">
+                <a:solidFill>
+                  <a:srgbClr val="607286"/>
+                </a:solidFill>
+                <a:latin typeface="Arial"/>
+                <a:ea typeface="Arial"/>
+                <a:cs typeface="Arial"/>
+              </a:defRPr>
+            </a:lvl5pPr>
+            <a:lvl6pPr>
+              <a:defRPr sz="1650" b="0">
+                <a:solidFill>
+                  <a:srgbClr val="607286"/>
+                </a:solidFill>
+                <a:latin typeface="Arial"/>
+                <a:ea typeface="Arial"/>
+                <a:cs typeface="Arial"/>
+              </a:defRPr>
+            </a:lvl6pPr>
+            <a:lvl7pPr>
+              <a:defRPr sz="1650" b="0">
+                <a:solidFill>
+                  <a:srgbClr val="607286"/>
+                </a:solidFill>
+                <a:latin typeface="Arial"/>
+                <a:ea typeface="Arial"/>
+                <a:cs typeface="Arial"/>
+              </a:defRPr>
+            </a:lvl7pPr>
+            <a:lvl8pPr>
+              <a:defRPr sz="1650" b="0">
+                <a:solidFill>
+                  <a:srgbClr val="607286"/>
+                </a:solidFill>
+                <a:latin typeface="Arial"/>
+                <a:ea typeface="Arial"/>
+                <a:cs typeface="Arial"/>
+              </a:defRPr>
+            </a:lvl8pPr>
+            <a:lvl9pPr>
+              <a:defRPr sz="1650" b="0">
+                <a:solidFill>
+                  <a:srgbClr val="607286"/>
+                </a:solidFill>
+                <a:latin typeface="Arial"/>
+                <a:ea typeface="Arial"/>
+                <a:cs typeface="Arial"/>
+              </a:defRPr>
+            </a:lvl9pPr>
+          </a:lstStyle>
+          <a:p xmlns:a="http://schemas.openxmlformats.org/drawingml/2006/main">
+            <a:pPr>
+              <a:defRPr sz="1650" b="0">
+                <a:solidFill>
+                  <a:srgbClr val="607286"/>
+                </a:solidFill>
+                <a:latin typeface="Arial"/>
+                <a:ea typeface="Arial"/>
+                <a:cs typeface="Arial"/>
+              </a:defRPr>
+            </a:pPr>
+            <a:r>
+              <a:rPr sz="1650" b="0">
+                <a:solidFill>
+                  <a:srgbClr val="607286"/>
+                </a:solidFill>
+                <a:latin typeface="Arial"/>
+                <a:ea typeface="Arial"/>
+                <a:cs typeface="Arial"/>
+              </a:rPr>
+              <a:t>Both feed the LLM decision. Hidden target outcomes stay excluded.</a:t>
+            </a:r>
+          </a:p>
+        </p:txBody>
+      </p:sp>
+      <p:sp>
+        <p:nvSpPr>
+          <p:cNvPr id="29" name="">
+            <a:extLst xmlns:a="http://schemas.openxmlformats.org/drawingml/2006/main">
+              <a:ext uri="{FF2B5EF4-FFF2-40B4-BE49-F238E27FC236}">
+                <a16:creationId xmlns:a16="http://schemas.microsoft.com/office/drawing/2014/main" id="{BFE834BB-43F6-4508-A1BA-4BC8E4F8015A}"/>
+              </a:ext>
+            </a:extLst>
+          </p:cNvPr>
+          <p:cNvSpPr>
+            <a:spLocks xmlns:a="http://schemas.openxmlformats.org/drawingml/2006/main" noGrp="1"/>
+          </p:cNvSpPr>
+          <p:nvPr/>
+        </p:nvSpPr>
+        <p:spPr>
+          <a:xfrm xmlns:a="http://schemas.openxmlformats.org/drawingml/2006/main">
+            <a:off x="685800" y="5591175"/>
+            <a:ext cx="10820400" cy="0"/>
+          </a:xfrm>
+          <a:prstGeom xmlns:a="http://schemas.openxmlformats.org/drawingml/2006/main" prst="line">
+            <a:avLst/>
+          </a:prstGeom>
+          <a:noFill xmlns:a="http://schemas.openxmlformats.org/drawingml/2006/main"/>
+          <a:ln xmlns:a="http://schemas.openxmlformats.org/drawingml/2006/main" w="9525">
+            <a:solidFill>
+              <a:srgbClr val="D9E1E8"/>
+            </a:solidFill>
+            <a:prstDash val="solid"/>
+          </a:ln>
+        </p:spPr>
+      </p:sp>
+      <p:sp>
+        <p:nvSpPr>
+          <p:cNvPr id="30" name="">
+            <a:extLst xmlns:a="http://schemas.openxmlformats.org/drawingml/2006/main">
+              <a:ext uri="{FF2B5EF4-FFF2-40B4-BE49-F238E27FC236}">
+                <a16:creationId xmlns:a16="http://schemas.microsoft.com/office/drawing/2014/main" id="{AC8AEC06-3CAA-430C-A3ED-AA3A4830630C}"/>
+              </a:ext>
+            </a:extLst>
+          </p:cNvPr>
+          <p:cNvSpPr>
+            <a:spLocks xmlns:a="http://schemas.openxmlformats.org/drawingml/2006/main" noGrp="1"/>
+          </p:cNvSpPr>
+          <p:nvPr/>
+        </p:nvSpPr>
+        <p:spPr>
+          <a:xfrm xmlns:a="http://schemas.openxmlformats.org/drawingml/2006/main">
+            <a:off x="685800" y="5734050"/>
             <a:ext cx="10820400" cy="342900"/>
           </a:xfrm>
           <a:prstGeom xmlns:a="http://schemas.openxmlformats.org/drawingml/2006/main" prst="rect">
@@ -24068,9 +24616,9 @@
           <a:bodyPr xmlns:a="http://schemas.openxmlformats.org/drawingml/2006/main" lIns="0" tIns="0" rIns="0" bIns="0"/>
           <a:lstStyle xmlns:a="http://schemas.openxmlformats.org/drawingml/2006/main">
             <a:defPPr>
-              <a:defRPr sz="1875" b="0">
-                <a:solidFill>
-                  <a:srgbClr val="263648"/>
+              <a:defRPr sz="1875" b="1">
+                <a:solidFill>
+                  <a:srgbClr val="17324D"/>
                 </a:solidFill>
                 <a:latin typeface="Arial"/>
                 <a:ea typeface="Arial"/>
@@ -24078,9 +24626,9 @@
               </a:defRPr>
             </a:defPPr>
             <a:lvl1pPr>
-              <a:defRPr sz="1875" b="0">
-                <a:solidFill>
-                  <a:srgbClr val="263648"/>
+              <a:defRPr sz="1875" b="1">
+                <a:solidFill>
+                  <a:srgbClr val="17324D"/>
                 </a:solidFill>
                 <a:latin typeface="Arial"/>
                 <a:ea typeface="Arial"/>
@@ -24088,9 +24636,9 @@
               </a:defRPr>
             </a:lvl1pPr>
             <a:lvl2pPr>
-              <a:defRPr sz="1875" b="0">
-                <a:solidFill>
-                  <a:srgbClr val="263648"/>
+              <a:defRPr sz="1875" b="1">
+                <a:solidFill>
+                  <a:srgbClr val="17324D"/>
                 </a:solidFill>
                 <a:latin typeface="Arial"/>
                 <a:ea typeface="Arial"/>
@@ -24098,9 +24646,9 @@
               </a:defRPr>
             </a:lvl2pPr>
             <a:lvl3pPr>
-              <a:defRPr sz="1875" b="0">
-                <a:solidFill>
-                  <a:srgbClr val="263648"/>
+              <a:defRPr sz="1875" b="1">
+                <a:solidFill>
+                  <a:srgbClr val="17324D"/>
                 </a:solidFill>
                 <a:latin typeface="Arial"/>
                 <a:ea typeface="Arial"/>
@@ -24108,9 +24656,9 @@
               </a:defRPr>
             </a:lvl3pPr>
             <a:lvl4pPr>
-              <a:defRPr sz="1875" b="0">
-                <a:solidFill>
-                  <a:srgbClr val="263648"/>
+              <a:defRPr sz="1875" b="1">
+                <a:solidFill>
+                  <a:srgbClr val="17324D"/>
                 </a:solidFill>
                 <a:latin typeface="Arial"/>
                 <a:ea typeface="Arial"/>
@@ -24118,9 +24666,9 @@
               </a:defRPr>
             </a:lvl4pPr>
             <a:lvl5pPr>
-              <a:defRPr sz="1875" b="0">
-                <a:solidFill>
-                  <a:srgbClr val="263648"/>
+              <a:defRPr sz="1875" b="1">
+                <a:solidFill>
+                  <a:srgbClr val="17324D"/>
                 </a:solidFill>
                 <a:latin typeface="Arial"/>
                 <a:ea typeface="Arial"/>
@@ -24128,9 +24676,9 @@
               </a:defRPr>
             </a:lvl5pPr>
             <a:lvl6pPr>
-              <a:defRPr sz="1875" b="0">
-                <a:solidFill>
-                  <a:srgbClr val="263648"/>
+              <a:defRPr sz="1875" b="1">
+                <a:solidFill>
+                  <a:srgbClr val="17324D"/>
                 </a:solidFill>
                 <a:latin typeface="Arial"/>
                 <a:ea typeface="Arial"/>
@@ -24138,9 +24686,9 @@
               </a:defRPr>
             </a:lvl6pPr>
             <a:lvl7pPr>
-              <a:defRPr sz="1875" b="0">
-                <a:solidFill>
-                  <a:srgbClr val="263648"/>
+              <a:defRPr sz="1875" b="1">
+                <a:solidFill>
+                  <a:srgbClr val="17324D"/>
                 </a:solidFill>
                 <a:latin typeface="Arial"/>
                 <a:ea typeface="Arial"/>
@@ -24148,9 +24696,9 @@
               </a:defRPr>
             </a:lvl7pPr>
             <a:lvl8pPr>
-              <a:defRPr sz="1875" b="0">
-                <a:solidFill>
-                  <a:srgbClr val="263648"/>
+              <a:defRPr sz="1875" b="1">
+                <a:solidFill>
+                  <a:srgbClr val="17324D"/>
                 </a:solidFill>
                 <a:latin typeface="Arial"/>
                 <a:ea typeface="Arial"/>
@@ -24158,9 +24706,9 @@
               </a:defRPr>
             </a:lvl8pPr>
             <a:lvl9pPr>
-              <a:defRPr sz="1875" b="0">
-                <a:solidFill>
-                  <a:srgbClr val="263648"/>
+              <a:defRPr sz="1875" b="1">
+                <a:solidFill>
+                  <a:srgbClr val="17324D"/>
                 </a:solidFill>
                 <a:latin typeface="Arial"/>
                 <a:ea typeface="Arial"/>
@@ -24170,9 +24718,9 @@
           </a:lstStyle>
           <a:p xmlns:a="http://schemas.openxmlformats.org/drawingml/2006/main">
             <a:pPr>
-              <a:defRPr sz="1875" b="0">
-                <a:solidFill>
-                  <a:srgbClr val="263648"/>
+              <a:defRPr sz="1875" b="1">
+                <a:solidFill>
+                  <a:srgbClr val="17324D"/>
                 </a:solidFill>
                 <a:latin typeface="Arial"/>
                 <a:ea typeface="Arial"/>
@@ -24180,25 +24728,25 @@
               </a:defRPr>
             </a:pPr>
             <a:r>
-              <a:rPr sz="1875" b="0">
-                <a:solidFill>
-                  <a:srgbClr val="263648"/>
+              <a:rPr sz="1875" b="1">
+                <a:solidFill>
+                  <a:srgbClr val="17324D"/>
                 </a:solidFill>
                 <a:latin typeface="Arial"/>
                 <a:ea typeface="Arial"/>
                 <a:cs typeface="Arial"/>
               </a:rPr>
-              <a:t>Structured outputs • tool guardrails • bounded context / memory</a:t>
+              <a:t>LLMOps plan: version → evaluate → monitor → deploy</a:t>
             </a:r>
           </a:p>
         </p:txBody>
       </p:sp>
       <p:sp>
         <p:nvSpPr>
-          <p:cNvPr id="27" name="">
+          <p:cNvPr id="31" name="">
             <a:extLst xmlns:a="http://schemas.openxmlformats.org/drawingml/2006/main">
               <a:ext uri="{FF2B5EF4-FFF2-40B4-BE49-F238E27FC236}">
-                <a16:creationId xmlns:a16="http://schemas.microsoft.com/office/drawing/2014/main" id="{A1C0C8EC-A0A1-4C01-ADF7-6C5439EB1503}"/>
+                <a16:creationId xmlns:a16="http://schemas.microsoft.com/office/drawing/2014/main" id="{BD3FCDD6-2607-4778-B51B-EE39F1CE058F}"/>
               </a:ext>
             </a:extLst>
           </p:cNvPr>
@@ -24209,8 +24757,8 @@
         </p:nvSpPr>
         <p:spPr>
           <a:xfrm xmlns:a="http://schemas.openxmlformats.org/drawingml/2006/main">
-            <a:off x="685800" y="5553075"/>
-            <a:ext cx="10820400" cy="428625"/>
+            <a:off x="685800" y="6134100"/>
+            <a:ext cx="10820400" cy="276225"/>
           </a:xfrm>
           <a:prstGeom xmlns:a="http://schemas.openxmlformats.org/drawingml/2006/main" prst="rect">
             <a:avLst/>
@@ -24225,7 +24773,7 @@
           <a:bodyPr xmlns:a="http://schemas.openxmlformats.org/drawingml/2006/main" lIns="0" tIns="0" rIns="0" bIns="0"/>
           <a:lstStyle xmlns:a="http://schemas.openxmlformats.org/drawingml/2006/main">
             <a:defPPr>
-              <a:defRPr sz="1725" b="0">
+              <a:defRPr sz="1575" b="0">
                 <a:solidFill>
                   <a:srgbClr val="607286"/>
                 </a:solidFill>
@@ -24235,7 +24783,7 @@
               </a:defRPr>
             </a:defPPr>
             <a:lvl1pPr>
-              <a:defRPr sz="1725" b="0">
+              <a:defRPr sz="1575" b="0">
                 <a:solidFill>
                   <a:srgbClr val="607286"/>
                 </a:solidFill>
@@ -24245,7 +24793,7 @@
               </a:defRPr>
             </a:lvl1pPr>
             <a:lvl2pPr>
-              <a:defRPr sz="1725" b="0">
+              <a:defRPr sz="1575" b="0">
                 <a:solidFill>
                   <a:srgbClr val="607286"/>
                 </a:solidFill>
@@ -24255,7 +24803,7 @@
               </a:defRPr>
             </a:lvl2pPr>
             <a:lvl3pPr>
-              <a:defRPr sz="1725" b="0">
+              <a:defRPr sz="1575" b="0">
                 <a:solidFill>
                   <a:srgbClr val="607286"/>
                 </a:solidFill>
@@ -24265,7 +24813,7 @@
               </a:defRPr>
             </a:lvl3pPr>
             <a:lvl4pPr>
-              <a:defRPr sz="1725" b="0">
+              <a:defRPr sz="1575" b="0">
                 <a:solidFill>
                   <a:srgbClr val="607286"/>
                 </a:solidFill>
@@ -24275,7 +24823,7 @@
               </a:defRPr>
             </a:lvl4pPr>
             <a:lvl5pPr>
-              <a:defRPr sz="1725" b="0">
+              <a:defRPr sz="1575" b="0">
                 <a:solidFill>
                   <a:srgbClr val="607286"/>
                 </a:solidFill>
@@ -24285,7 +24833,7 @@
               </a:defRPr>
             </a:lvl5pPr>
             <a:lvl6pPr>
-              <a:defRPr sz="1725" b="0">
+              <a:defRPr sz="1575" b="0">
                 <a:solidFill>
                   <a:srgbClr val="607286"/>
                 </a:solidFill>
@@ -24295,7 +24843,7 @@
               </a:defRPr>
             </a:lvl6pPr>
             <a:lvl7pPr>
-              <a:defRPr sz="1725" b="0">
+              <a:defRPr sz="1575" b="0">
                 <a:solidFill>
                   <a:srgbClr val="607286"/>
                 </a:solidFill>
@@ -24305,7 +24853,7 @@
               </a:defRPr>
             </a:lvl7pPr>
             <a:lvl8pPr>
-              <a:defRPr sz="1725" b="0">
+              <a:defRPr sz="1575" b="0">
                 <a:solidFill>
                   <a:srgbClr val="607286"/>
                 </a:solidFill>
@@ -24315,7 +24863,7 @@
               </a:defRPr>
             </a:lvl8pPr>
             <a:lvl9pPr>
-              <a:defRPr sz="1725" b="0">
+              <a:defRPr sz="1575" b="0">
                 <a:solidFill>
                   <a:srgbClr val="607286"/>
                 </a:solidFill>
@@ -24327,7 +24875,7 @@
           </a:lstStyle>
           <a:p xmlns:a="http://schemas.openxmlformats.org/drawingml/2006/main">
             <a:pPr>
-              <a:defRPr sz="1725" b="0">
+              <a:defRPr sz="1575" b="0">
                 <a:solidFill>
                   <a:srgbClr val="607286"/>
                 </a:solidFill>
@@ -24337,7 +24885,7 @@
               </a:defRPr>
             </a:pPr>
             <a:r>
-              <a:rPr sz="1725" b="0">
+              <a:rPr sz="1575" b="0">
                 <a:solidFill>
                   <a:srgbClr val="607286"/>
                 </a:solidFill>
@@ -24345,7 +24893,7 @@
                 <a:ea typeface="Arial"/>
                 <a:cs typeface="Arial"/>
               </a:rPr>
-              <a:t>Evaluate selection quality, token cost and latency against fixed-model controls.</a:t>
+              <a:t>Track feasible speedup, evaluation cost, tool errors, tokens and latency.</a:t>
             </a:r>
           </a:p>
         </p:txBody>
@@ -24353,7 +24901,7 @@
     </p:spTree>
     <p:extLst>
       <p:ext uri="{BB962C8B-B14F-4D97-AF65-F5344CB8AC3E}">
-        <p14:creationId xmlns:p14="http://schemas.microsoft.com/office/powerpoint/2010/main" val="802705811"/>
+        <p14:creationId xmlns:p14="http://schemas.microsoft.com/office/powerpoint/2010/main" val="1440399007"/>
       </p:ext>
     </p:extLst>
   </p:cSld>
@@ -24384,7 +24932,7 @@
           <p:cNvPr id="9" name="">
             <a:extLst xmlns:a="http://schemas.openxmlformats.org/drawingml/2006/main">
               <a:ext uri="{FF2B5EF4-FFF2-40B4-BE49-F238E27FC236}">
-                <a16:creationId xmlns:a16="http://schemas.microsoft.com/office/drawing/2014/main" id="{7FFD8C33-606F-4D79-8E6B-C56214C9086D}"/>
+                <a16:creationId xmlns:a16="http://schemas.microsoft.com/office/drawing/2014/main" id="{E598CAF0-D42A-4FD8-AE02-0D40A3742DC4}"/>
               </a:ext>
             </a:extLst>
           </p:cNvPr>
@@ -24541,7 +25089,7 @@
           <p:cNvPr id="2" name="">
             <a:extLst xmlns:a="http://schemas.openxmlformats.org/drawingml/2006/main">
               <a:ext uri="{FF2B5EF4-FFF2-40B4-BE49-F238E27FC236}">
-                <a16:creationId xmlns:a16="http://schemas.microsoft.com/office/drawing/2014/main" id="{DAF19AC1-8B58-4B55-8EFA-8C44396E91A4}"/>
+                <a16:creationId xmlns:a16="http://schemas.microsoft.com/office/drawing/2014/main" id="{DAABC640-715C-434F-AA22-55A0845C51DB}"/>
               </a:ext>
             </a:extLst>
           </p:cNvPr>
@@ -24572,7 +25120,7 @@
           <p:cNvPr id="3" name="">
             <a:extLst xmlns:a="http://schemas.openxmlformats.org/drawingml/2006/main">
               <a:ext uri="{FF2B5EF4-FFF2-40B4-BE49-F238E27FC236}">
-                <a16:creationId xmlns:a16="http://schemas.microsoft.com/office/drawing/2014/main" id="{F75E4ACD-55DB-4F18-8FD2-CDA2A71E4305}"/>
+                <a16:creationId xmlns:a16="http://schemas.microsoft.com/office/drawing/2014/main" id="{863C23D1-0A4B-4D9D-ABE7-57A1A1A9B6A8}"/>
               </a:ext>
             </a:extLst>
           </p:cNvPr>
@@ -24729,7 +25277,7 @@
           <p:cNvPr id="4" name="">
             <a:extLst xmlns:a="http://schemas.openxmlformats.org/drawingml/2006/main">
               <a:ext uri="{FF2B5EF4-FFF2-40B4-BE49-F238E27FC236}">
-                <a16:creationId xmlns:a16="http://schemas.microsoft.com/office/drawing/2014/main" id="{A5CB04C1-313E-4537-ABD7-2C0AFD351567}"/>
+                <a16:creationId xmlns:a16="http://schemas.microsoft.com/office/drawing/2014/main" id="{1B11AD35-46BA-4C8E-864E-383F06B44164}"/>
               </a:ext>
             </a:extLst>
           </p:cNvPr>
@@ -24886,7 +25434,7 @@
           <p:cNvPr id="5" name="">
             <a:extLst xmlns:a="http://schemas.openxmlformats.org/drawingml/2006/main">
               <a:ext uri="{FF2B5EF4-FFF2-40B4-BE49-F238E27FC236}">
-                <a16:creationId xmlns:a16="http://schemas.microsoft.com/office/drawing/2014/main" id="{4042B578-8559-4C5C-9999-D61DB6AF6340}"/>
+                <a16:creationId xmlns:a16="http://schemas.microsoft.com/office/drawing/2014/main" id="{434023F9-6090-4268-A9D0-7857A59C0A24}"/>
               </a:ext>
             </a:extLst>
           </p:cNvPr>
@@ -25135,7 +25683,7 @@
           <p:cNvPr id="6" name="">
             <a:extLst xmlns:a="http://schemas.openxmlformats.org/drawingml/2006/main">
               <a:ext uri="{FF2B5EF4-FFF2-40B4-BE49-F238E27FC236}">
-                <a16:creationId xmlns:a16="http://schemas.microsoft.com/office/drawing/2014/main" id="{F493FB19-9EB1-47F7-9CFE-F99BBA2F4B5A}"/>
+                <a16:creationId xmlns:a16="http://schemas.microsoft.com/office/drawing/2014/main" id="{E954E5B3-1761-4776-AAD0-B83E12F7B2F2}"/>
               </a:ext>
             </a:extLst>
           </p:cNvPr>
@@ -25292,7 +25840,7 @@
           <p:cNvPr id="7" name="">
             <a:extLst xmlns:a="http://schemas.openxmlformats.org/drawingml/2006/main">
               <a:ext uri="{FF2B5EF4-FFF2-40B4-BE49-F238E27FC236}">
-                <a16:creationId xmlns:a16="http://schemas.microsoft.com/office/drawing/2014/main" id="{039F23AB-C514-47D1-8018-6DE0A4AD187C}"/>
+                <a16:creationId xmlns:a16="http://schemas.microsoft.com/office/drawing/2014/main" id="{2B4E21F0-7FE3-4E29-BA90-90102AA04F04}"/>
               </a:ext>
             </a:extLst>
           </p:cNvPr>
@@ -25541,7 +26089,7 @@
           <p:cNvPr id="8" name="">
             <a:extLst xmlns:a="http://schemas.openxmlformats.org/drawingml/2006/main">
               <a:ext uri="{FF2B5EF4-FFF2-40B4-BE49-F238E27FC236}">
-                <a16:creationId xmlns:a16="http://schemas.microsoft.com/office/drawing/2014/main" id="{4FB425EB-277B-444C-9675-52FDBC46929C}"/>
+                <a16:creationId xmlns:a16="http://schemas.microsoft.com/office/drawing/2014/main" id="{9BF7DD08-9C51-4EF6-B679-D80B1DC8CF24}"/>
               </a:ext>
             </a:extLst>
           </p:cNvPr>
@@ -25696,7 +26244,7 @@
     </p:spTree>
     <p:extLst>
       <p:ext uri="{BB962C8B-B14F-4D97-AF65-F5344CB8AC3E}">
-        <p14:creationId xmlns:p14="http://schemas.microsoft.com/office/powerpoint/2010/main" val="1168189479"/>
+        <p14:creationId xmlns:p14="http://schemas.microsoft.com/office/powerpoint/2010/main" val="68266509"/>
       </p:ext>
     </p:extLst>
   </p:cSld>

</xml_diff>

<commit_message>
Preserve live Luna memory comparison and update presentation evidence
</commit_message>
<xml_diff>
--- a/submissions/midterm-2026-10-28/isaforge-midterm-progress-slides-final.pptx
+++ b/submissions/midterm-2026-10-28/isaforge-midterm-progress-slides-final.pptx
@@ -2,23 +2,23 @@
 <file path=ppt/presentation.xml><?xml version="1.0" encoding="utf-8"?>
 <p:presentation xmlns:p="http://schemas.openxmlformats.org/presentationml/2006/main">
   <p:sldMasterIdLst>
-    <p:sldMasterId xmlns:r="http://schemas.openxmlformats.org/officeDocument/2006/relationships" id="2147483648" r:id="R8ebc841738ec473d"/>
+    <p:sldMasterId xmlns:r="http://schemas.openxmlformats.org/officeDocument/2006/relationships" id="2147483648" r:id="R17e2deac2d6c4415"/>
   </p:sldMasterIdLst>
   <p:notesMasterIdLst>
-    <p:notesMasterId xmlns:r="http://schemas.openxmlformats.org/officeDocument/2006/relationships" r:id="R60c33dc9c5f74c8c"/>
+    <p:notesMasterId xmlns:r="http://schemas.openxmlformats.org/officeDocument/2006/relationships" r:id="R6b49ecc12d514351"/>
   </p:notesMasterIdLst>
   <p:sldIdLst>
-    <p:sldId xmlns:r="http://schemas.openxmlformats.org/officeDocument/2006/relationships" id="256" r:id="R48db7e12abed41f1"/>
-    <p:sldId xmlns:r="http://schemas.openxmlformats.org/officeDocument/2006/relationships" id="257" r:id="R7fc2ccb2889d4404"/>
-    <p:sldId xmlns:r="http://schemas.openxmlformats.org/officeDocument/2006/relationships" id="258" r:id="R771d43a1639c4355"/>
-    <p:sldId xmlns:r="http://schemas.openxmlformats.org/officeDocument/2006/relationships" id="259" r:id="Rd973772c751f4ea7"/>
-    <p:sldId xmlns:r="http://schemas.openxmlformats.org/officeDocument/2006/relationships" id="260" r:id="R82e657a477224b46"/>
-    <p:sldId xmlns:r="http://schemas.openxmlformats.org/officeDocument/2006/relationships" id="261" r:id="R8eb2d17197ce475c"/>
-    <p:sldId xmlns:r="http://schemas.openxmlformats.org/officeDocument/2006/relationships" id="262" r:id="Re5e18ef191724f2a"/>
-    <p:sldId xmlns:r="http://schemas.openxmlformats.org/officeDocument/2006/relationships" id="263" r:id="Re19ff4317cec4749"/>
-    <p:sldId xmlns:r="http://schemas.openxmlformats.org/officeDocument/2006/relationships" id="264" r:id="R83c88b8e4ab64824"/>
-    <p:sldId xmlns:r="http://schemas.openxmlformats.org/officeDocument/2006/relationships" id="265" r:id="Rd05e980fe587428f"/>
-    <p:sldId xmlns:r="http://schemas.openxmlformats.org/officeDocument/2006/relationships" id="266" r:id="R2434c7f3d0a14d72"/>
+    <p:sldId xmlns:r="http://schemas.openxmlformats.org/officeDocument/2006/relationships" id="256" r:id="R4340560391d0423f"/>
+    <p:sldId xmlns:r="http://schemas.openxmlformats.org/officeDocument/2006/relationships" id="257" r:id="Red7af7e38f234990"/>
+    <p:sldId xmlns:r="http://schemas.openxmlformats.org/officeDocument/2006/relationships" id="258" r:id="R7ed3aa8364d24f02"/>
+    <p:sldId xmlns:r="http://schemas.openxmlformats.org/officeDocument/2006/relationships" id="259" r:id="R398e31c0a49f4767"/>
+    <p:sldId xmlns:r="http://schemas.openxmlformats.org/officeDocument/2006/relationships" id="260" r:id="R774ce37b0f8a4cd7"/>
+    <p:sldId xmlns:r="http://schemas.openxmlformats.org/officeDocument/2006/relationships" id="261" r:id="Rf1e5e1425be74682"/>
+    <p:sldId xmlns:r="http://schemas.openxmlformats.org/officeDocument/2006/relationships" id="262" r:id="Red4a95df077e4a1f"/>
+    <p:sldId xmlns:r="http://schemas.openxmlformats.org/officeDocument/2006/relationships" id="263" r:id="R946d4eb77111467a"/>
+    <p:sldId xmlns:r="http://schemas.openxmlformats.org/officeDocument/2006/relationships" id="264" r:id="R89e1f7ea3d6c4afb"/>
+    <p:sldId xmlns:r="http://schemas.openxmlformats.org/officeDocument/2006/relationships" id="265" r:id="R645099bc4c1b4f14"/>
+    <p:sldId xmlns:r="http://schemas.openxmlformats.org/officeDocument/2006/relationships" id="266" r:id="R97c951a6683c4be8"/>
   </p:sldIdLst>
   <p:sldSz cx="12192000" cy="6858000"/>
   <p:notesSz cx="6858000" cy="9144000"/>
@@ -1387,7 +1387,7 @@
           </a:p>
           <a:p xmlns:a="http://schemas.openxmlformats.org/drawingml/2006/main">
             <a:r>
-              <a:t>Our agent has four stages: analyze candidates and query ML predictions, choose a structured action, execute it through host guardrails, and record measured evidence. Paid observations feed the next decision. The lower half shows planned extensions. A bounded context builder would route routine decisions to a smaller language model and escalate difficult cases to a stronger one. Optional retrieval could supply approved historical evidence using chunking, embeddings, hybrid search and reranking. These components are not implemented yet. Across the system, LLMOps would version releases and track quality, tokens, latency and cost. We will judge every addition by verified feasible performance under the same measurement budget.</a:t>
+              <a:t>Our agent combines predictions, function calling, measured feedback and persistent memory. Historical retrieval uses lexical and latent-semantic search with hybrid rank fusion. Versioned runs and SQL traces connect decisions to tool outcomes. We tested this with two fresh GPT-6 Luna agents on archived SHA256 measurements. Both found the same verified 1.0214-times speedup. The hybrid-memory agent used two queries and four decision turns. The no-retrieval agent used three queries and nine turns, including three rejected infeasible finalizations. This demonstrates live agent behavior and guardrails. It does not prove memory caused the difference, and the latency-cost heuristic found the optimum in one query.</a:t>
             </a:r>
           </a:p>
           <a:p xmlns:a="http://schemas.openxmlformats.org/drawingml/2006/main">
@@ -1402,7 +1402,7 @@
           </a:p>
           <a:p xmlns:a="http://schemas.openxmlformats.org/drawingml/2006/main">
             <a:r>
-              <a:t>Implemented: isaforge/bounded_selector.py, isaforge/selection_provider.py, scripts/run_codex_chat_selector.py; four tools list_candidates, predict, measure, finalize. Remote provider records model, tool calls, usage and latency where returned; active chat does not expose exact deployment ID or model-only usage. EDN consumed replay; Ascon three native measurements and live GP update defect fixed afterward. Proposed: smaller/stronger model routing, context/token budgets, retrieval, and complete cost/quality evaluation. No dynamic LLM routing, RAG/vector database, MCP integration, LangGraph, Ragas or production observability is claimed. See agent-architecture-plan.md.</a:t>
+              <a:t>October 28 implementation: isaforge/agent_memory.py, isaforge/routed_selection.py, isaforge/bounded_selector.py, scripts/export_agent_observability.py, scripts/evaluate_agent_memory.py. Semantic retrieval is TF-IDF plus truncated SVD and cosine similarity, not pretrained language embeddings. Hybrid search uses reciprocal rank fusion with k=60. Historical records are already host-filtered; target groups and exact formulas receive an additional exclusion check before index fitting. Retrieval is automatically injected before a decision, not a fifth LLM tool. Function calling retains list_candidates, predict, measure, finalize. Routing escalates once only for InvalidActionError, not calibrated decision uncertainty. Trace exporter verifies sealed artifact hashes and creates a derived SQLite database. LLMOps here means versioned protocols, source/prompt/model identity, offline evaluation and local trace inspection; cloud deployment and live monitoring remain future work. Offline controls ignore retrieval and prove noninterference only. Live pilot results/2026-10-28-live-luna-memory: two fresh configured gpt-6-luna medium agents, no inherited context, instruction-enforced public-file access. No retrieval: 9 live turns, 3 queries, 3 rejected finalizations. Hybrid: 4 live turns, 2 queries, 0 rejections. Both select add(in0,slli(in1,21)): 26135630 to 25588430 cycles, +50 LUT4, 65.99353 MHz. Both reach pool oracle. Frequency and latency/cost reach it at query 1. One sample per arm, consumed data, unknown token usage and model-only latency. Real LLM choices, no fresh hardware. No causal or superiority claim. Semantic method is local LSA; no live routing escalation was exercised. https://scikit-learn.org/stable/modules/generated/sklearn.decomposition.TruncatedSVD.html; docs/agent-memory-operations.md.</a:t>
             </a:r>
           </a:p>
         </p:txBody>
@@ -1549,7 +1549,7 @@
           <p:cNvPr id="3" name="Title">
             <a:extLst xmlns:a="http://schemas.openxmlformats.org/drawingml/2006/main">
               <a:ext uri="{FF2B5EF4-FFF2-40B4-BE49-F238E27FC236}">
-                <a16:creationId xmlns:a16="http://schemas.microsoft.com/office/drawing/2014/main" id="{72307348-B6D2-473A-81E8-41787642BBA4}"/>
+                <a16:creationId xmlns:a16="http://schemas.microsoft.com/office/drawing/2014/main" id="{A08A72A4-672A-44A0-96A6-088D2E728F54}"/>
               </a:ext>
             </a:extLst>
           </p:cNvPr>
@@ -1778,7 +1778,7 @@
           <p:cNvPr id="2" name="Subtitle">
             <a:extLst xmlns:a="http://schemas.openxmlformats.org/drawingml/2006/main">
               <a:ext uri="{FF2B5EF4-FFF2-40B4-BE49-F238E27FC236}">
-                <a16:creationId xmlns:a16="http://schemas.microsoft.com/office/drawing/2014/main" id="{3E53BD86-1243-4B5B-A123-9072B05C2994}"/>
+                <a16:creationId xmlns:a16="http://schemas.microsoft.com/office/drawing/2014/main" id="{B2966ED2-EB7A-4D98-B219-0CEF1910F4F4}"/>
               </a:ext>
             </a:extLst>
           </p:cNvPr>
@@ -2024,7 +2024,7 @@
           <p:cNvPr id="2" name="Section title">
             <a:extLst xmlns:a="http://schemas.openxmlformats.org/drawingml/2006/main">
               <a:ext uri="{FF2B5EF4-FFF2-40B4-BE49-F238E27FC236}">
-                <a16:creationId xmlns:a16="http://schemas.microsoft.com/office/drawing/2014/main" id="{DDE61444-4CAF-4F4B-B134-AD342A152D2E}"/>
+                <a16:creationId xmlns:a16="http://schemas.microsoft.com/office/drawing/2014/main" id="{D7A6C2A3-5250-41CA-822B-87FA2EFB0C89}"/>
               </a:ext>
             </a:extLst>
           </p:cNvPr>
@@ -2270,7 +2270,7 @@
           <p:cNvPr id="3" name="Title">
             <a:extLst xmlns:a="http://schemas.openxmlformats.org/drawingml/2006/main">
               <a:ext uri="{FF2B5EF4-FFF2-40B4-BE49-F238E27FC236}">
-                <a16:creationId xmlns:a16="http://schemas.microsoft.com/office/drawing/2014/main" id="{59DCD876-0C97-4610-888D-798BCB60C2F0}"/>
+                <a16:creationId xmlns:a16="http://schemas.microsoft.com/office/drawing/2014/main" id="{D168C17B-EE26-4688-97AE-ABFC7C69D1C8}"/>
               </a:ext>
             </a:extLst>
           </p:cNvPr>
@@ -2499,7 +2499,7 @@
           <p:cNvPr id="2" name="Body">
             <a:extLst xmlns:a="http://schemas.openxmlformats.org/drawingml/2006/main">
               <a:ext uri="{FF2B5EF4-FFF2-40B4-BE49-F238E27FC236}">
-                <a16:creationId xmlns:a16="http://schemas.microsoft.com/office/drawing/2014/main" id="{7D688D27-92CE-433F-8E21-07DB29A8AEAC}"/>
+                <a16:creationId xmlns:a16="http://schemas.microsoft.com/office/drawing/2014/main" id="{F8CC820B-708F-4226-9AB1-938F30DF8A5F}"/>
               </a:ext>
             </a:extLst>
           </p:cNvPr>
@@ -2745,7 +2745,7 @@
           <p:cNvPr id="4" name="Title">
             <a:extLst xmlns:a="http://schemas.openxmlformats.org/drawingml/2006/main">
               <a:ext uri="{FF2B5EF4-FFF2-40B4-BE49-F238E27FC236}">
-                <a16:creationId xmlns:a16="http://schemas.microsoft.com/office/drawing/2014/main" id="{89A581D9-B3A9-4D4F-8FEB-7671CC135E4B}"/>
+                <a16:creationId xmlns:a16="http://schemas.microsoft.com/office/drawing/2014/main" id="{C29E4D6B-609A-44D0-88CF-1F9BD381275A}"/>
               </a:ext>
             </a:extLst>
           </p:cNvPr>
@@ -2974,7 +2974,7 @@
           <p:cNvPr id="2" name="Left column">
             <a:extLst xmlns:a="http://schemas.openxmlformats.org/drawingml/2006/main">
               <a:ext uri="{FF2B5EF4-FFF2-40B4-BE49-F238E27FC236}">
-                <a16:creationId xmlns:a16="http://schemas.microsoft.com/office/drawing/2014/main" id="{59D9C728-2618-4FD1-9A96-47A7EF27DC74}"/>
+                <a16:creationId xmlns:a16="http://schemas.microsoft.com/office/drawing/2014/main" id="{4EA71E68-B903-4079-8942-3F30082A10C6}"/>
               </a:ext>
             </a:extLst>
           </p:cNvPr>
@@ -3203,7 +3203,7 @@
           <p:cNvPr id="3" name="Right column">
             <a:extLst xmlns:a="http://schemas.openxmlformats.org/drawingml/2006/main">
               <a:ext uri="{FF2B5EF4-FFF2-40B4-BE49-F238E27FC236}">
-                <a16:creationId xmlns:a16="http://schemas.microsoft.com/office/drawing/2014/main" id="{A7A23E8C-1D08-418D-A242-462F8626046D}"/>
+                <a16:creationId xmlns:a16="http://schemas.microsoft.com/office/drawing/2014/main" id="{9350E96F-BB75-4B4D-8381-080BE7A695F7}"/>
               </a:ext>
             </a:extLst>
           </p:cNvPr>
@@ -3449,7 +3449,7 @@
           <p:cNvPr id="3" name="Title">
             <a:extLst xmlns:a="http://schemas.openxmlformats.org/drawingml/2006/main">
               <a:ext uri="{FF2B5EF4-FFF2-40B4-BE49-F238E27FC236}">
-                <a16:creationId xmlns:a16="http://schemas.microsoft.com/office/drawing/2014/main" id="{81037DA8-DFBE-44A1-BEDC-7BFA8D039E53}"/>
+                <a16:creationId xmlns:a16="http://schemas.microsoft.com/office/drawing/2014/main" id="{9775C8B3-138E-4DCC-90F4-8A52D7BCB52B}"/>
               </a:ext>
             </a:extLst>
           </p:cNvPr>
@@ -3678,7 +3678,7 @@
           <p:cNvPr id="2" name="Left column">
             <a:extLst xmlns:a="http://schemas.openxmlformats.org/drawingml/2006/main">
               <a:ext uri="{FF2B5EF4-FFF2-40B4-BE49-F238E27FC236}">
-                <a16:creationId xmlns:a16="http://schemas.microsoft.com/office/drawing/2014/main" id="{3E40825F-7AA3-45B1-B0DA-E23973CA8391}"/>
+                <a16:creationId xmlns:a16="http://schemas.microsoft.com/office/drawing/2014/main" id="{3D55DCBC-8050-429D-A4C1-91F83D1E36B4}"/>
               </a:ext>
             </a:extLst>
           </p:cNvPr>
@@ -3945,12 +3945,12 @@
   </p:cSld>
   <p:clrMap bg1="lt1" tx1="dk1" bg2="lt2" tx2="dk2" accent1="accent1" accent2="accent2" accent3="accent3" accent4="accent4" accent5="accent5" accent6="accent6" hlink="hlink" folHlink="folHlink"/>
   <p:sldLayoutIdLst>
-    <p:sldLayoutId xmlns:r="http://schemas.openxmlformats.org/officeDocument/2006/relationships" id="2147483649" r:id="Ra767641b8df945f7"/>
-    <p:sldLayoutId xmlns:r="http://schemas.openxmlformats.org/officeDocument/2006/relationships" id="2147483650" r:id="Rddaadcdc26934d02"/>
-    <p:sldLayoutId xmlns:r="http://schemas.openxmlformats.org/officeDocument/2006/relationships" id="2147483651" r:id="R5c9d73e702b9411d"/>
-    <p:sldLayoutId xmlns:r="http://schemas.openxmlformats.org/officeDocument/2006/relationships" id="2147483652" r:id="Rdf5d2dc555244f8b"/>
-    <p:sldLayoutId xmlns:r="http://schemas.openxmlformats.org/officeDocument/2006/relationships" id="2147483653" r:id="R2eb80be27cd14107"/>
-    <p:sldLayoutId xmlns:r="http://schemas.openxmlformats.org/officeDocument/2006/relationships" id="2147483654" r:id="Rb3a0ec51bb6b4d4d"/>
+    <p:sldLayoutId xmlns:r="http://schemas.openxmlformats.org/officeDocument/2006/relationships" id="2147483649" r:id="Rbe349ead795a4349"/>
+    <p:sldLayoutId xmlns:r="http://schemas.openxmlformats.org/officeDocument/2006/relationships" id="2147483650" r:id="Rcb4329e9bcc542d9"/>
+    <p:sldLayoutId xmlns:r="http://schemas.openxmlformats.org/officeDocument/2006/relationships" id="2147483651" r:id="R711f4fd155cc4459"/>
+    <p:sldLayoutId xmlns:r="http://schemas.openxmlformats.org/officeDocument/2006/relationships" id="2147483652" r:id="R401e0b45273f4044"/>
+    <p:sldLayoutId xmlns:r="http://schemas.openxmlformats.org/officeDocument/2006/relationships" id="2147483653" r:id="R8e80ba2f7c2d4e7f"/>
+    <p:sldLayoutId xmlns:r="http://schemas.openxmlformats.org/officeDocument/2006/relationships" id="2147483654" r:id="R88dea2a177f640e1"/>
   </p:sldLayoutIdLst>
   <p:txStyles>
     <p:titleStyle>
@@ -5273,7 +5273,7 @@
           <p:cNvPr id="8" name="">
             <a:extLst xmlns:a="http://schemas.openxmlformats.org/drawingml/2006/main">
               <a:ext uri="{FF2B5EF4-FFF2-40B4-BE49-F238E27FC236}">
-                <a16:creationId xmlns:a16="http://schemas.microsoft.com/office/drawing/2014/main" id="{C34444A3-D815-4FD0-9B24-C58F48A74036}"/>
+                <a16:creationId xmlns:a16="http://schemas.microsoft.com/office/drawing/2014/main" id="{C8FE138A-38DE-4624-A429-C5F7660531F4}"/>
               </a:ext>
             </a:extLst>
           </p:cNvPr>
@@ -5430,7 +5430,7 @@
           <p:cNvPr id="2" name="">
             <a:extLst xmlns:a="http://schemas.openxmlformats.org/drawingml/2006/main">
               <a:ext uri="{FF2B5EF4-FFF2-40B4-BE49-F238E27FC236}">
-                <a16:creationId xmlns:a16="http://schemas.microsoft.com/office/drawing/2014/main" id="{50C4A47E-EF77-4EB7-83E0-5B44E61AE895}"/>
+                <a16:creationId xmlns:a16="http://schemas.microsoft.com/office/drawing/2014/main" id="{78E4E03F-9CFE-4871-B64B-4E9123538FC8}"/>
               </a:ext>
             </a:extLst>
           </p:cNvPr>
@@ -5461,7 +5461,7 @@
           <p:cNvPr id="3" name="">
             <a:extLst xmlns:a="http://schemas.openxmlformats.org/drawingml/2006/main">
               <a:ext uri="{FF2B5EF4-FFF2-40B4-BE49-F238E27FC236}">
-                <a16:creationId xmlns:a16="http://schemas.microsoft.com/office/drawing/2014/main" id="{B9850BB5-49B3-4D6A-A1AA-6A392EDEB68F}"/>
+                <a16:creationId xmlns:a16="http://schemas.microsoft.com/office/drawing/2014/main" id="{4944C6C9-0710-4126-A570-B9BBD1EE75F2}"/>
               </a:ext>
             </a:extLst>
           </p:cNvPr>
@@ -5618,7 +5618,7 @@
           <p:cNvPr id="4" name="">
             <a:extLst xmlns:a="http://schemas.openxmlformats.org/drawingml/2006/main">
               <a:ext uri="{FF2B5EF4-FFF2-40B4-BE49-F238E27FC236}">
-                <a16:creationId xmlns:a16="http://schemas.microsoft.com/office/drawing/2014/main" id="{4FED64FA-7EDA-4806-B12B-64F95EF58E44}"/>
+                <a16:creationId xmlns:a16="http://schemas.microsoft.com/office/drawing/2014/main" id="{0ECC52B0-4611-4FBE-BE59-1A3402C98400}"/>
               </a:ext>
             </a:extLst>
           </p:cNvPr>
@@ -5775,7 +5775,7 @@
           <p:cNvPr id="5" name="">
             <a:extLst xmlns:a="http://schemas.openxmlformats.org/drawingml/2006/main">
               <a:ext uri="{FF2B5EF4-FFF2-40B4-BE49-F238E27FC236}">
-                <a16:creationId xmlns:a16="http://schemas.microsoft.com/office/drawing/2014/main" id="{31DE9723-1CC9-4295-AA61-42900C7AB9C9}"/>
+                <a16:creationId xmlns:a16="http://schemas.microsoft.com/office/drawing/2014/main" id="{DF43CF4F-FAE1-42CE-9BFE-E460F865B8C4}"/>
               </a:ext>
             </a:extLst>
           </p:cNvPr>
@@ -5955,7 +5955,7 @@
           <p:cNvPr id="6" name="">
             <a:extLst xmlns:a="http://schemas.openxmlformats.org/drawingml/2006/main">
               <a:ext uri="{FF2B5EF4-FFF2-40B4-BE49-F238E27FC236}">
-                <a16:creationId xmlns:a16="http://schemas.microsoft.com/office/drawing/2014/main" id="{8FD39306-4A0A-4276-B751-51409E0FB316}"/>
+                <a16:creationId xmlns:a16="http://schemas.microsoft.com/office/drawing/2014/main" id="{CFFEF3C3-B07C-4934-B21B-CACDB08EBF2D}"/>
               </a:ext>
             </a:extLst>
           </p:cNvPr>
@@ -6112,7 +6112,7 @@
           <p:cNvPr id="7" name="">
             <a:extLst xmlns:a="http://schemas.openxmlformats.org/drawingml/2006/main">
               <a:ext uri="{FF2B5EF4-FFF2-40B4-BE49-F238E27FC236}">
-                <a16:creationId xmlns:a16="http://schemas.microsoft.com/office/drawing/2014/main" id="{790F2771-130E-48AC-A457-5B08B11BF7BD}"/>
+                <a16:creationId xmlns:a16="http://schemas.microsoft.com/office/drawing/2014/main" id="{E3184B46-16C6-4023-B321-2DE1B686D2E3}"/>
               </a:ext>
             </a:extLst>
           </p:cNvPr>
@@ -6267,7 +6267,7 @@
     </p:spTree>
     <p:extLst>
       <p:ext uri="{BB962C8B-B14F-4D97-AF65-F5344CB8AC3E}">
-        <p14:creationId xmlns:p14="http://schemas.microsoft.com/office/powerpoint/2010/main" val="1295815358"/>
+        <p14:creationId xmlns:p14="http://schemas.microsoft.com/office/powerpoint/2010/main" val="1468735295"/>
       </p:ext>
     </p:extLst>
   </p:cSld>
@@ -6298,7 +6298,7 @@
           <p:cNvPr id="9" name="">
             <a:extLst xmlns:a="http://schemas.openxmlformats.org/drawingml/2006/main">
               <a:ext uri="{FF2B5EF4-FFF2-40B4-BE49-F238E27FC236}">
-                <a16:creationId xmlns:a16="http://schemas.microsoft.com/office/drawing/2014/main" id="{EB162AE5-C97B-4A42-BD2E-37B8C1965F23}"/>
+                <a16:creationId xmlns:a16="http://schemas.microsoft.com/office/drawing/2014/main" id="{6CD101DC-9499-4DA4-9076-2F4C904301E3}"/>
               </a:ext>
             </a:extLst>
           </p:cNvPr>
@@ -6455,7 +6455,7 @@
           <p:cNvPr id="2" name="">
             <a:extLst xmlns:a="http://schemas.openxmlformats.org/drawingml/2006/main">
               <a:ext uri="{FF2B5EF4-FFF2-40B4-BE49-F238E27FC236}">
-                <a16:creationId xmlns:a16="http://schemas.microsoft.com/office/drawing/2014/main" id="{226CCE9E-2FC6-4809-97F0-41B197178896}"/>
+                <a16:creationId xmlns:a16="http://schemas.microsoft.com/office/drawing/2014/main" id="{09DB80F6-F22C-4FD4-8FE9-53D3315DB5F9}"/>
               </a:ext>
             </a:extLst>
           </p:cNvPr>
@@ -6486,7 +6486,7 @@
           <p:cNvPr id="3" name="">
             <a:extLst xmlns:a="http://schemas.openxmlformats.org/drawingml/2006/main">
               <a:ext uri="{FF2B5EF4-FFF2-40B4-BE49-F238E27FC236}">
-                <a16:creationId xmlns:a16="http://schemas.microsoft.com/office/drawing/2014/main" id="{4C224B04-4CA2-48B0-A0C0-B03CFC0D7DDD}"/>
+                <a16:creationId xmlns:a16="http://schemas.microsoft.com/office/drawing/2014/main" id="{19926254-DB3F-4717-B2E8-53D9FBF24846}"/>
               </a:ext>
             </a:extLst>
           </p:cNvPr>
@@ -6643,7 +6643,7 @@
           <p:cNvPr id="4" name="Chart">
             <a:extLst xmlns:a="http://schemas.openxmlformats.org/drawingml/2006/main">
               <a:ext uri="{FF2B5EF4-FFF2-40B4-BE49-F238E27FC236}">
-                <a16:creationId xmlns:a16="http://schemas.microsoft.com/office/drawing/2014/main" id="{AE9BCCBC-E2D3-4B1B-A95B-EDBC70FB42BE}"/>
+                <a16:creationId xmlns:a16="http://schemas.microsoft.com/office/drawing/2014/main" id="{DCF0DDE6-BF5A-4FD7-9A4D-75CAB6C5FE47}"/>
               </a:ext>
             </a:extLst>
           </p:cNvPr>
@@ -6656,7 +6656,7 @@
         </p:xfrm>
         <a:graphic xmlns:a="http://schemas.openxmlformats.org/drawingml/2006/main">
           <a:graphicData uri="http://schemas.openxmlformats.org/drawingml/2006/chart">
-            <c:chart xmlns:r="http://schemas.openxmlformats.org/officeDocument/2006/relationships" xmlns:c="http://schemas.openxmlformats.org/drawingml/2006/chart" r:id="R52c28a42d3e9481c"/>
+            <c:chart xmlns:r="http://schemas.openxmlformats.org/officeDocument/2006/relationships" xmlns:c="http://schemas.openxmlformats.org/drawingml/2006/chart" r:id="R353d654bf58343f4"/>
           </a:graphicData>
         </a:graphic>
       </p:graphicFrame>
@@ -6665,7 +6665,7 @@
           <p:cNvPr id="5" name="">
             <a:extLst xmlns:a="http://schemas.openxmlformats.org/drawingml/2006/main">
               <a:ext uri="{FF2B5EF4-FFF2-40B4-BE49-F238E27FC236}">
-                <a16:creationId xmlns:a16="http://schemas.microsoft.com/office/drawing/2014/main" id="{32D93178-6E8E-41F8-B9C0-F6AD4F590800}"/>
+                <a16:creationId xmlns:a16="http://schemas.microsoft.com/office/drawing/2014/main" id="{25649CA5-D035-4ADC-8F29-921CB069E5BD}"/>
               </a:ext>
             </a:extLst>
           </p:cNvPr>
@@ -6822,7 +6822,7 @@
           <p:cNvPr id="6" name="">
             <a:extLst xmlns:a="http://schemas.openxmlformats.org/drawingml/2006/main">
               <a:ext uri="{FF2B5EF4-FFF2-40B4-BE49-F238E27FC236}">
-                <a16:creationId xmlns:a16="http://schemas.microsoft.com/office/drawing/2014/main" id="{B91C8CB1-0E9B-4E7F-9916-CA541FC8926F}"/>
+                <a16:creationId xmlns:a16="http://schemas.microsoft.com/office/drawing/2014/main" id="{A678252D-BDFB-4CFA-BA1F-A4D53F52BE66}"/>
               </a:ext>
             </a:extLst>
           </p:cNvPr>
@@ -7053,7 +7053,7 @@
           <p:cNvPr id="7" name="">
             <a:extLst xmlns:a="http://schemas.openxmlformats.org/drawingml/2006/main">
               <a:ext uri="{FF2B5EF4-FFF2-40B4-BE49-F238E27FC236}">
-                <a16:creationId xmlns:a16="http://schemas.microsoft.com/office/drawing/2014/main" id="{97E3E5DE-06D9-46E9-8803-E4B1801CA5B0}"/>
+                <a16:creationId xmlns:a16="http://schemas.microsoft.com/office/drawing/2014/main" id="{7E0199C4-32D0-4673-B7CD-BA9D11C07324}"/>
               </a:ext>
             </a:extLst>
           </p:cNvPr>
@@ -7233,7 +7233,7 @@
           <p:cNvPr id="8" name="">
             <a:extLst xmlns:a="http://schemas.openxmlformats.org/drawingml/2006/main">
               <a:ext uri="{FF2B5EF4-FFF2-40B4-BE49-F238E27FC236}">
-                <a16:creationId xmlns:a16="http://schemas.microsoft.com/office/drawing/2014/main" id="{494310CE-C657-4595-BC0C-885D115C068A}"/>
+                <a16:creationId xmlns:a16="http://schemas.microsoft.com/office/drawing/2014/main" id="{94223E1F-2F97-4F7B-9798-78D94B62FC65}"/>
               </a:ext>
             </a:extLst>
           </p:cNvPr>
@@ -7388,7 +7388,7 @@
     </p:spTree>
     <p:extLst>
       <p:ext uri="{BB962C8B-B14F-4D97-AF65-F5344CB8AC3E}">
-        <p14:creationId xmlns:p14="http://schemas.microsoft.com/office/powerpoint/2010/main" val="1261694005"/>
+        <p14:creationId xmlns:p14="http://schemas.microsoft.com/office/powerpoint/2010/main" val="1740081155"/>
       </p:ext>
     </p:extLst>
   </p:cSld>
@@ -7419,7 +7419,7 @@
           <p:cNvPr id="9" name="">
             <a:extLst xmlns:a="http://schemas.openxmlformats.org/drawingml/2006/main">
               <a:ext uri="{FF2B5EF4-FFF2-40B4-BE49-F238E27FC236}">
-                <a16:creationId xmlns:a16="http://schemas.microsoft.com/office/drawing/2014/main" id="{E9D89C25-E844-4FF2-ACE6-BD89C6122301}"/>
+                <a16:creationId xmlns:a16="http://schemas.microsoft.com/office/drawing/2014/main" id="{4BB8B465-6673-4D74-B4D2-263D7886A7BF}"/>
               </a:ext>
             </a:extLst>
           </p:cNvPr>
@@ -7576,7 +7576,7 @@
           <p:cNvPr id="2" name="">
             <a:extLst xmlns:a="http://schemas.openxmlformats.org/drawingml/2006/main">
               <a:ext uri="{FF2B5EF4-FFF2-40B4-BE49-F238E27FC236}">
-                <a16:creationId xmlns:a16="http://schemas.microsoft.com/office/drawing/2014/main" id="{26ECF756-3699-414C-8CBD-5941EB514DE9}"/>
+                <a16:creationId xmlns:a16="http://schemas.microsoft.com/office/drawing/2014/main" id="{506C4991-6D72-4511-AA86-03186D5D21BD}"/>
               </a:ext>
             </a:extLst>
           </p:cNvPr>
@@ -7607,7 +7607,7 @@
           <p:cNvPr id="3" name="">
             <a:extLst xmlns:a="http://schemas.openxmlformats.org/drawingml/2006/main">
               <a:ext uri="{FF2B5EF4-FFF2-40B4-BE49-F238E27FC236}">
-                <a16:creationId xmlns:a16="http://schemas.microsoft.com/office/drawing/2014/main" id="{F1DC2800-899D-465B-A901-2B1667361A77}"/>
+                <a16:creationId xmlns:a16="http://schemas.microsoft.com/office/drawing/2014/main" id="{F1B94049-7C00-49DC-BC7B-61948BAA7B46}"/>
               </a:ext>
             </a:extLst>
           </p:cNvPr>
@@ -7764,7 +7764,7 @@
           <p:cNvPr id="4" name="">
             <a:extLst xmlns:a="http://schemas.openxmlformats.org/drawingml/2006/main">
               <a:ext uri="{FF2B5EF4-FFF2-40B4-BE49-F238E27FC236}">
-                <a16:creationId xmlns:a16="http://schemas.microsoft.com/office/drawing/2014/main" id="{CD93CE44-D9D2-4D47-BAF9-51111EEFA0BD}"/>
+                <a16:creationId xmlns:a16="http://schemas.microsoft.com/office/drawing/2014/main" id="{2E35206C-F53A-43B4-8C62-E852AF1E6FA5}"/>
               </a:ext>
             </a:extLst>
           </p:cNvPr>
@@ -7921,7 +7921,7 @@
           <p:cNvPr id="5" name="">
             <a:extLst xmlns:a="http://schemas.openxmlformats.org/drawingml/2006/main">
               <a:ext uri="{FF2B5EF4-FFF2-40B4-BE49-F238E27FC236}">
-                <a16:creationId xmlns:a16="http://schemas.microsoft.com/office/drawing/2014/main" id="{B04C563C-6283-4FF9-995D-36BF33E7D423}"/>
+                <a16:creationId xmlns:a16="http://schemas.microsoft.com/office/drawing/2014/main" id="{3BFA2032-270F-4A57-9B41-C35D524B83BB}"/>
               </a:ext>
             </a:extLst>
           </p:cNvPr>
@@ -8147,7 +8147,7 @@
           <p:cNvPr id="6" name="">
             <a:extLst xmlns:a="http://schemas.openxmlformats.org/drawingml/2006/main">
               <a:ext uri="{FF2B5EF4-FFF2-40B4-BE49-F238E27FC236}">
-                <a16:creationId xmlns:a16="http://schemas.microsoft.com/office/drawing/2014/main" id="{ED8E2509-146F-442E-B361-165A997BCE76}"/>
+                <a16:creationId xmlns:a16="http://schemas.microsoft.com/office/drawing/2014/main" id="{C2E954B5-9CDE-4100-B306-CF44B18D1B97}"/>
               </a:ext>
             </a:extLst>
           </p:cNvPr>
@@ -8304,7 +8304,7 @@
           <p:cNvPr id="7" name="">
             <a:extLst xmlns:a="http://schemas.openxmlformats.org/drawingml/2006/main">
               <a:ext uri="{FF2B5EF4-FFF2-40B4-BE49-F238E27FC236}">
-                <a16:creationId xmlns:a16="http://schemas.microsoft.com/office/drawing/2014/main" id="{66F41877-9B07-4F00-94E3-10D5500524CD}"/>
+                <a16:creationId xmlns:a16="http://schemas.microsoft.com/office/drawing/2014/main" id="{61196CB4-0F5F-469F-8C1F-97B43DD3C81E}"/>
               </a:ext>
             </a:extLst>
           </p:cNvPr>
@@ -8530,7 +8530,7 @@
           <p:cNvPr id="8" name="">
             <a:extLst xmlns:a="http://schemas.openxmlformats.org/drawingml/2006/main">
               <a:ext uri="{FF2B5EF4-FFF2-40B4-BE49-F238E27FC236}">
-                <a16:creationId xmlns:a16="http://schemas.microsoft.com/office/drawing/2014/main" id="{098106AB-A410-437D-92A8-35DAB5F23B9F}"/>
+                <a16:creationId xmlns:a16="http://schemas.microsoft.com/office/drawing/2014/main" id="{7EB0BA5B-7DD0-480A-BE0A-78C4B5D3605C}"/>
               </a:ext>
             </a:extLst>
           </p:cNvPr>
@@ -8685,7 +8685,7 @@
     </p:spTree>
     <p:extLst>
       <p:ext uri="{BB962C8B-B14F-4D97-AF65-F5344CB8AC3E}">
-        <p14:creationId xmlns:p14="http://schemas.microsoft.com/office/powerpoint/2010/main" val="1777061452"/>
+        <p14:creationId xmlns:p14="http://schemas.microsoft.com/office/powerpoint/2010/main" val="558855516"/>
       </p:ext>
     </p:extLst>
   </p:cSld>
@@ -8716,7 +8716,7 @@
           <p:cNvPr id="20" name="">
             <a:extLst xmlns:a="http://schemas.openxmlformats.org/drawingml/2006/main">
               <a:ext uri="{FF2B5EF4-FFF2-40B4-BE49-F238E27FC236}">
-                <a16:creationId xmlns:a16="http://schemas.microsoft.com/office/drawing/2014/main" id="{CA5124AC-1D9E-4C71-9941-B5727905B126}"/>
+                <a16:creationId xmlns:a16="http://schemas.microsoft.com/office/drawing/2014/main" id="{FDACF11D-6190-4068-B2ED-E9ACC9799892}"/>
               </a:ext>
             </a:extLst>
           </p:cNvPr>
@@ -8873,7 +8873,7 @@
           <p:cNvPr id="2" name="">
             <a:extLst xmlns:a="http://schemas.openxmlformats.org/drawingml/2006/main">
               <a:ext uri="{FF2B5EF4-FFF2-40B4-BE49-F238E27FC236}">
-                <a16:creationId xmlns:a16="http://schemas.microsoft.com/office/drawing/2014/main" id="{C2744CB8-80CB-45FD-AC34-E984FCBA8906}"/>
+                <a16:creationId xmlns:a16="http://schemas.microsoft.com/office/drawing/2014/main" id="{91B2963D-F13A-4476-B545-CD4897C1768E}"/>
               </a:ext>
             </a:extLst>
           </p:cNvPr>
@@ -8904,7 +8904,7 @@
           <p:cNvPr id="3" name="">
             <a:extLst xmlns:a="http://schemas.openxmlformats.org/drawingml/2006/main">
               <a:ext uri="{FF2B5EF4-FFF2-40B4-BE49-F238E27FC236}">
-                <a16:creationId xmlns:a16="http://schemas.microsoft.com/office/drawing/2014/main" id="{ADFDC56E-4523-487B-9638-6C8EC671FAF4}"/>
+                <a16:creationId xmlns:a16="http://schemas.microsoft.com/office/drawing/2014/main" id="{F5C0EF14-6BFE-4574-8C98-331F6B6362C7}"/>
               </a:ext>
             </a:extLst>
           </p:cNvPr>
@@ -9061,7 +9061,7 @@
           <p:cNvPr id="4" name="">
             <a:extLst xmlns:a="http://schemas.openxmlformats.org/drawingml/2006/main">
               <a:ext uri="{FF2B5EF4-FFF2-40B4-BE49-F238E27FC236}">
-                <a16:creationId xmlns:a16="http://schemas.microsoft.com/office/drawing/2014/main" id="{BD6A92DA-FAC3-472F-9670-0E15CF94D5E1}"/>
+                <a16:creationId xmlns:a16="http://schemas.microsoft.com/office/drawing/2014/main" id="{2762470D-ACFA-4520-94C8-B43295A00B42}"/>
               </a:ext>
             </a:extLst>
           </p:cNvPr>
@@ -9218,7 +9218,7 @@
           <p:cNvPr id="5" name="">
             <a:extLst xmlns:a="http://schemas.openxmlformats.org/drawingml/2006/main">
               <a:ext uri="{FF2B5EF4-FFF2-40B4-BE49-F238E27FC236}">
-                <a16:creationId xmlns:a16="http://schemas.microsoft.com/office/drawing/2014/main" id="{0B5AC5C5-6EB7-42DA-8688-937AA722630C}"/>
+                <a16:creationId xmlns:a16="http://schemas.microsoft.com/office/drawing/2014/main" id="{A26E7F02-3D0D-4C16-AECA-23DDD085E113}"/>
               </a:ext>
             </a:extLst>
           </p:cNvPr>
@@ -9375,7 +9375,7 @@
           <p:cNvPr id="6" name="">
             <a:extLst xmlns:a="http://schemas.openxmlformats.org/drawingml/2006/main">
               <a:ext uri="{FF2B5EF4-FFF2-40B4-BE49-F238E27FC236}">
-                <a16:creationId xmlns:a16="http://schemas.microsoft.com/office/drawing/2014/main" id="{9D3213FA-0E95-4FB0-B9ED-E52BBB061AE5}"/>
+                <a16:creationId xmlns:a16="http://schemas.microsoft.com/office/drawing/2014/main" id="{798B58B3-AF3D-46FA-86DC-55A80B2DBD8B}"/>
               </a:ext>
             </a:extLst>
           </p:cNvPr>
@@ -9532,7 +9532,7 @@
           <p:cNvPr id="7" name="">
             <a:extLst xmlns:a="http://schemas.openxmlformats.org/drawingml/2006/main">
               <a:ext uri="{FF2B5EF4-FFF2-40B4-BE49-F238E27FC236}">
-                <a16:creationId xmlns:a16="http://schemas.microsoft.com/office/drawing/2014/main" id="{1BF04074-6CDF-42E9-8AEA-6BA3D87850D7}"/>
+                <a16:creationId xmlns:a16="http://schemas.microsoft.com/office/drawing/2014/main" id="{D3528A16-A510-4CB1-82FC-292A621058D7}"/>
               </a:ext>
             </a:extLst>
           </p:cNvPr>
@@ -9563,7 +9563,7 @@
           <p:cNvPr id="8" name="">
             <a:extLst xmlns:a="http://schemas.openxmlformats.org/drawingml/2006/main">
               <a:ext uri="{FF2B5EF4-FFF2-40B4-BE49-F238E27FC236}">
-                <a16:creationId xmlns:a16="http://schemas.microsoft.com/office/drawing/2014/main" id="{7DC99C30-0B9B-4F0B-9EC6-5FCD53761A33}"/>
+                <a16:creationId xmlns:a16="http://schemas.microsoft.com/office/drawing/2014/main" id="{5A63CB5F-CAE0-41CD-99C7-7A06B9AB044D}"/>
               </a:ext>
             </a:extLst>
           </p:cNvPr>
@@ -9720,7 +9720,7 @@
           <p:cNvPr id="9" name="">
             <a:extLst xmlns:a="http://schemas.openxmlformats.org/drawingml/2006/main">
               <a:ext uri="{FF2B5EF4-FFF2-40B4-BE49-F238E27FC236}">
-                <a16:creationId xmlns:a16="http://schemas.microsoft.com/office/drawing/2014/main" id="{688E743D-481B-413A-8E71-F85F602D536C}"/>
+                <a16:creationId xmlns:a16="http://schemas.microsoft.com/office/drawing/2014/main" id="{1839C3ED-DC42-4BC7-B3EB-11A01E9CDE27}"/>
               </a:ext>
             </a:extLst>
           </p:cNvPr>
@@ -9877,7 +9877,7 @@
           <p:cNvPr id="10" name="">
             <a:extLst xmlns:a="http://schemas.openxmlformats.org/drawingml/2006/main">
               <a:ext uri="{FF2B5EF4-FFF2-40B4-BE49-F238E27FC236}">
-                <a16:creationId xmlns:a16="http://schemas.microsoft.com/office/drawing/2014/main" id="{F5500841-BDAE-46DC-A7BC-9AEA43DBF2D1}"/>
+                <a16:creationId xmlns:a16="http://schemas.microsoft.com/office/drawing/2014/main" id="{D0C44949-BAB0-4F94-A201-C95540F717C0}"/>
               </a:ext>
             </a:extLst>
           </p:cNvPr>
@@ -10034,7 +10034,7 @@
           <p:cNvPr id="11" name="">
             <a:extLst xmlns:a="http://schemas.openxmlformats.org/drawingml/2006/main">
               <a:ext uri="{FF2B5EF4-FFF2-40B4-BE49-F238E27FC236}">
-                <a16:creationId xmlns:a16="http://schemas.microsoft.com/office/drawing/2014/main" id="{6EADE166-3170-41B9-9625-7E860196B2E6}"/>
+                <a16:creationId xmlns:a16="http://schemas.microsoft.com/office/drawing/2014/main" id="{B08470A7-0A0F-412F-AFBB-3EDDA60FB4BD}"/>
               </a:ext>
             </a:extLst>
           </p:cNvPr>
@@ -10065,7 +10065,7 @@
           <p:cNvPr id="12" name="">
             <a:extLst xmlns:a="http://schemas.openxmlformats.org/drawingml/2006/main">
               <a:ext uri="{FF2B5EF4-FFF2-40B4-BE49-F238E27FC236}">
-                <a16:creationId xmlns:a16="http://schemas.microsoft.com/office/drawing/2014/main" id="{CAF29F5F-54CA-43A5-A7F1-CB727520709B}"/>
+                <a16:creationId xmlns:a16="http://schemas.microsoft.com/office/drawing/2014/main" id="{DC14D848-2EAC-49DC-86DE-2FB4449C6285}"/>
               </a:ext>
             </a:extLst>
           </p:cNvPr>
@@ -10222,7 +10222,7 @@
           <p:cNvPr id="13" name="">
             <a:extLst xmlns:a="http://schemas.openxmlformats.org/drawingml/2006/main">
               <a:ext uri="{FF2B5EF4-FFF2-40B4-BE49-F238E27FC236}">
-                <a16:creationId xmlns:a16="http://schemas.microsoft.com/office/drawing/2014/main" id="{D9214BE0-9A4B-4738-A49D-043499C43636}"/>
+                <a16:creationId xmlns:a16="http://schemas.microsoft.com/office/drawing/2014/main" id="{1F03307A-BD74-4A79-88CE-6BD261B085E6}"/>
               </a:ext>
             </a:extLst>
           </p:cNvPr>
@@ -10379,7 +10379,7 @@
           <p:cNvPr id="14" name="">
             <a:extLst xmlns:a="http://schemas.openxmlformats.org/drawingml/2006/main">
               <a:ext uri="{FF2B5EF4-FFF2-40B4-BE49-F238E27FC236}">
-                <a16:creationId xmlns:a16="http://schemas.microsoft.com/office/drawing/2014/main" id="{5CD8EE5E-98D5-4ED5-B8CD-4BCA57C81F40}"/>
+                <a16:creationId xmlns:a16="http://schemas.microsoft.com/office/drawing/2014/main" id="{46D63877-D22C-4F67-8B79-C9E1D3417909}"/>
               </a:ext>
             </a:extLst>
           </p:cNvPr>
@@ -10536,7 +10536,7 @@
           <p:cNvPr id="15" name="">
             <a:extLst xmlns:a="http://schemas.openxmlformats.org/drawingml/2006/main">
               <a:ext uri="{FF2B5EF4-FFF2-40B4-BE49-F238E27FC236}">
-                <a16:creationId xmlns:a16="http://schemas.microsoft.com/office/drawing/2014/main" id="{8199F29C-C446-4FBC-8871-1DD5E35C30FF}"/>
+                <a16:creationId xmlns:a16="http://schemas.microsoft.com/office/drawing/2014/main" id="{04793E67-E3C6-4F3A-9828-B5A721DA26C5}"/>
               </a:ext>
             </a:extLst>
           </p:cNvPr>
@@ -10567,7 +10567,7 @@
           <p:cNvPr id="16" name="">
             <a:extLst xmlns:a="http://schemas.openxmlformats.org/drawingml/2006/main">
               <a:ext uri="{FF2B5EF4-FFF2-40B4-BE49-F238E27FC236}">
-                <a16:creationId xmlns:a16="http://schemas.microsoft.com/office/drawing/2014/main" id="{40BCD80A-8F23-4481-8591-8FC7F8E9CCA8}"/>
+                <a16:creationId xmlns:a16="http://schemas.microsoft.com/office/drawing/2014/main" id="{58B1B65F-9664-4503-9584-7AA25D2377B1}"/>
               </a:ext>
             </a:extLst>
           </p:cNvPr>
@@ -10724,7 +10724,7 @@
           <p:cNvPr id="17" name="">
             <a:extLst xmlns:a="http://schemas.openxmlformats.org/drawingml/2006/main">
               <a:ext uri="{FF2B5EF4-FFF2-40B4-BE49-F238E27FC236}">
-                <a16:creationId xmlns:a16="http://schemas.microsoft.com/office/drawing/2014/main" id="{DD9E2C47-7A92-4E01-824F-D8A41384DEDF}"/>
+                <a16:creationId xmlns:a16="http://schemas.microsoft.com/office/drawing/2014/main" id="{57039641-7673-4BF4-9639-D51B88FBF877}"/>
               </a:ext>
             </a:extLst>
           </p:cNvPr>
@@ -10881,7 +10881,7 @@
           <p:cNvPr id="18" name="">
             <a:extLst xmlns:a="http://schemas.openxmlformats.org/drawingml/2006/main">
               <a:ext uri="{FF2B5EF4-FFF2-40B4-BE49-F238E27FC236}">
-                <a16:creationId xmlns:a16="http://schemas.microsoft.com/office/drawing/2014/main" id="{27F0BC98-2BCC-4F62-981C-37A12018D659}"/>
+                <a16:creationId xmlns:a16="http://schemas.microsoft.com/office/drawing/2014/main" id="{FE8717A4-C36C-4649-A7AC-9F5EEAA5DE6D}"/>
               </a:ext>
             </a:extLst>
           </p:cNvPr>
@@ -11038,7 +11038,7 @@
           <p:cNvPr id="19" name="">
             <a:extLst xmlns:a="http://schemas.openxmlformats.org/drawingml/2006/main">
               <a:ext uri="{FF2B5EF4-FFF2-40B4-BE49-F238E27FC236}">
-                <a16:creationId xmlns:a16="http://schemas.microsoft.com/office/drawing/2014/main" id="{17C56CF3-15A0-42C8-852C-3E678DFC7BCA}"/>
+                <a16:creationId xmlns:a16="http://schemas.microsoft.com/office/drawing/2014/main" id="{A78995D0-285C-4EE5-BAD4-71A3EF473EB2}"/>
               </a:ext>
             </a:extLst>
           </p:cNvPr>
@@ -11193,7 +11193,7 @@
     </p:spTree>
     <p:extLst>
       <p:ext uri="{BB962C8B-B14F-4D97-AF65-F5344CB8AC3E}">
-        <p14:creationId xmlns:p14="http://schemas.microsoft.com/office/powerpoint/2010/main" val="1975162308"/>
+        <p14:creationId xmlns:p14="http://schemas.microsoft.com/office/powerpoint/2010/main" val="2045768437"/>
       </p:ext>
     </p:extLst>
   </p:cSld>
@@ -11224,7 +11224,7 @@
           <p:cNvPr id="19" name="">
             <a:extLst xmlns:a="http://schemas.openxmlformats.org/drawingml/2006/main">
               <a:ext uri="{FF2B5EF4-FFF2-40B4-BE49-F238E27FC236}">
-                <a16:creationId xmlns:a16="http://schemas.microsoft.com/office/drawing/2014/main" id="{D9BE1A81-483C-4207-B51E-C1959D253096}"/>
+                <a16:creationId xmlns:a16="http://schemas.microsoft.com/office/drawing/2014/main" id="{E6E7160A-4C0D-47FB-B53F-0536DF5AEDE2}"/>
               </a:ext>
             </a:extLst>
           </p:cNvPr>
@@ -11381,7 +11381,7 @@
           <p:cNvPr id="2" name="">
             <a:extLst xmlns:a="http://schemas.openxmlformats.org/drawingml/2006/main">
               <a:ext uri="{FF2B5EF4-FFF2-40B4-BE49-F238E27FC236}">
-                <a16:creationId xmlns:a16="http://schemas.microsoft.com/office/drawing/2014/main" id="{C2A7CB12-7ABF-4289-8FD1-C35D6225F3D6}"/>
+                <a16:creationId xmlns:a16="http://schemas.microsoft.com/office/drawing/2014/main" id="{7A0178C4-90BF-46AF-B9D7-AF9BDBA73938}"/>
               </a:ext>
             </a:extLst>
           </p:cNvPr>
@@ -11412,7 +11412,7 @@
           <p:cNvPr id="3" name="">
             <a:extLst xmlns:a="http://schemas.openxmlformats.org/drawingml/2006/main">
               <a:ext uri="{FF2B5EF4-FFF2-40B4-BE49-F238E27FC236}">
-                <a16:creationId xmlns:a16="http://schemas.microsoft.com/office/drawing/2014/main" id="{5AFBE873-BD6A-4BE2-BC2D-58D5C01FBF88}"/>
+                <a16:creationId xmlns:a16="http://schemas.microsoft.com/office/drawing/2014/main" id="{20263ABF-B8DF-4E23-8A1E-A4673FF89670}"/>
               </a:ext>
             </a:extLst>
           </p:cNvPr>
@@ -11569,7 +11569,7 @@
           <p:cNvPr id="4" name="">
             <a:extLst xmlns:a="http://schemas.openxmlformats.org/drawingml/2006/main">
               <a:ext uri="{FF2B5EF4-FFF2-40B4-BE49-F238E27FC236}">
-                <a16:creationId xmlns:a16="http://schemas.microsoft.com/office/drawing/2014/main" id="{EA8E970D-8772-4A1B-87BD-85C4E225B6EF}"/>
+                <a16:creationId xmlns:a16="http://schemas.microsoft.com/office/drawing/2014/main" id="{EE84447D-EBCE-4ECE-A01F-4AB3A48B6ACC}"/>
               </a:ext>
             </a:extLst>
           </p:cNvPr>
@@ -11600,7 +11600,7 @@
           <p:cNvPr id="5" name="">
             <a:extLst xmlns:a="http://schemas.openxmlformats.org/drawingml/2006/main">
               <a:ext uri="{FF2B5EF4-FFF2-40B4-BE49-F238E27FC236}">
-                <a16:creationId xmlns:a16="http://schemas.microsoft.com/office/drawing/2014/main" id="{58E62A5D-99EE-42CC-957B-B6F9FAEDEFF1}"/>
+                <a16:creationId xmlns:a16="http://schemas.microsoft.com/office/drawing/2014/main" id="{BE73AB22-6A2A-41B0-8410-A127A7B87EFC}"/>
               </a:ext>
             </a:extLst>
           </p:cNvPr>
@@ -11757,7 +11757,7 @@
           <p:cNvPr id="6" name="">
             <a:extLst xmlns:a="http://schemas.openxmlformats.org/drawingml/2006/main">
               <a:ext uri="{FF2B5EF4-FFF2-40B4-BE49-F238E27FC236}">
-                <a16:creationId xmlns:a16="http://schemas.microsoft.com/office/drawing/2014/main" id="{8C2DB62B-A619-4621-9EFC-CE8001E0D9DF}"/>
+                <a16:creationId xmlns:a16="http://schemas.microsoft.com/office/drawing/2014/main" id="{3ABFEA4D-0CC9-49E4-9BCF-54A6DF3DA0A3}"/>
               </a:ext>
             </a:extLst>
           </p:cNvPr>
@@ -11788,7 +11788,7 @@
           <p:cNvPr id="7" name="">
             <a:extLst xmlns:a="http://schemas.openxmlformats.org/drawingml/2006/main">
               <a:ext uri="{FF2B5EF4-FFF2-40B4-BE49-F238E27FC236}">
-                <a16:creationId xmlns:a16="http://schemas.microsoft.com/office/drawing/2014/main" id="{42570FBF-5D40-481C-906F-416B2C1E0D67}"/>
+                <a16:creationId xmlns:a16="http://schemas.microsoft.com/office/drawing/2014/main" id="{F2CB4845-5C53-41BA-8FC7-E37419B7CB5C}"/>
               </a:ext>
             </a:extLst>
           </p:cNvPr>
@@ -11968,7 +11968,7 @@
           <p:cNvPr id="8" name="">
             <a:extLst xmlns:a="http://schemas.openxmlformats.org/drawingml/2006/main">
               <a:ext uri="{FF2B5EF4-FFF2-40B4-BE49-F238E27FC236}">
-                <a16:creationId xmlns:a16="http://schemas.microsoft.com/office/drawing/2014/main" id="{FFB41E35-88E9-41F1-9B0F-1F2B90656553}"/>
+                <a16:creationId xmlns:a16="http://schemas.microsoft.com/office/drawing/2014/main" id="{D033D732-F1BC-4C73-B6F2-548D8FFCB25C}"/>
               </a:ext>
             </a:extLst>
           </p:cNvPr>
@@ -12125,7 +12125,7 @@
           <p:cNvPr id="9" name="">
             <a:extLst xmlns:a="http://schemas.openxmlformats.org/drawingml/2006/main">
               <a:ext uri="{FF2B5EF4-FFF2-40B4-BE49-F238E27FC236}">
-                <a16:creationId xmlns:a16="http://schemas.microsoft.com/office/drawing/2014/main" id="{E2FC2F1E-D091-4E15-891E-9D6B9D508515}"/>
+                <a16:creationId xmlns:a16="http://schemas.microsoft.com/office/drawing/2014/main" id="{644CEF67-6F7D-48D9-AE53-84DE61C82729}"/>
               </a:ext>
             </a:extLst>
           </p:cNvPr>
@@ -12156,7 +12156,7 @@
           <p:cNvPr id="10" name="">
             <a:extLst xmlns:a="http://schemas.openxmlformats.org/drawingml/2006/main">
               <a:ext uri="{FF2B5EF4-FFF2-40B4-BE49-F238E27FC236}">
-                <a16:creationId xmlns:a16="http://schemas.microsoft.com/office/drawing/2014/main" id="{4DC48254-C1DC-4FDC-8E05-B0553A1FD2EC}"/>
+                <a16:creationId xmlns:a16="http://schemas.microsoft.com/office/drawing/2014/main" id="{EEF46753-D0F2-45DE-B9C7-2A19020BC16B}"/>
               </a:ext>
             </a:extLst>
           </p:cNvPr>
@@ -12336,7 +12336,7 @@
           <p:cNvPr id="11" name="">
             <a:extLst xmlns:a="http://schemas.openxmlformats.org/drawingml/2006/main">
               <a:ext uri="{FF2B5EF4-FFF2-40B4-BE49-F238E27FC236}">
-                <a16:creationId xmlns:a16="http://schemas.microsoft.com/office/drawing/2014/main" id="{0CE808C4-BA93-4D12-8288-EB55F8B718AE}"/>
+                <a16:creationId xmlns:a16="http://schemas.microsoft.com/office/drawing/2014/main" id="{F1C31354-874F-4BA1-AECC-D6CA07C28E5A}"/>
               </a:ext>
             </a:extLst>
           </p:cNvPr>
@@ -12493,7 +12493,7 @@
           <p:cNvPr id="12" name="">
             <a:extLst xmlns:a="http://schemas.openxmlformats.org/drawingml/2006/main">
               <a:ext uri="{FF2B5EF4-FFF2-40B4-BE49-F238E27FC236}">
-                <a16:creationId xmlns:a16="http://schemas.microsoft.com/office/drawing/2014/main" id="{6F55058D-E9DF-45A1-A723-F8381E5FF006}"/>
+                <a16:creationId xmlns:a16="http://schemas.microsoft.com/office/drawing/2014/main" id="{54ECC2CB-72F8-48FB-A76B-4681874C0482}"/>
               </a:ext>
             </a:extLst>
           </p:cNvPr>
@@ -12524,7 +12524,7 @@
           <p:cNvPr id="13" name="">
             <a:extLst xmlns:a="http://schemas.openxmlformats.org/drawingml/2006/main">
               <a:ext uri="{FF2B5EF4-FFF2-40B4-BE49-F238E27FC236}">
-                <a16:creationId xmlns:a16="http://schemas.microsoft.com/office/drawing/2014/main" id="{EFA3C39B-3707-4DA4-A304-CEA6A86F744D}"/>
+                <a16:creationId xmlns:a16="http://schemas.microsoft.com/office/drawing/2014/main" id="{84B76CE5-BFF8-44C6-BD6C-782F1C4B68F7}"/>
               </a:ext>
             </a:extLst>
           </p:cNvPr>
@@ -12704,7 +12704,7 @@
           <p:cNvPr id="14" name="">
             <a:extLst xmlns:a="http://schemas.openxmlformats.org/drawingml/2006/main">
               <a:ext uri="{FF2B5EF4-FFF2-40B4-BE49-F238E27FC236}">
-                <a16:creationId xmlns:a16="http://schemas.microsoft.com/office/drawing/2014/main" id="{D1B2B2E2-C7B2-4461-A029-C83BA86D8F43}"/>
+                <a16:creationId xmlns:a16="http://schemas.microsoft.com/office/drawing/2014/main" id="{B33EBCAC-710F-4943-8945-5749B0A13826}"/>
               </a:ext>
             </a:extLst>
           </p:cNvPr>
@@ -12861,7 +12861,7 @@
           <p:cNvPr id="15" name="">
             <a:extLst xmlns:a="http://schemas.openxmlformats.org/drawingml/2006/main">
               <a:ext uri="{FF2B5EF4-FFF2-40B4-BE49-F238E27FC236}">
-                <a16:creationId xmlns:a16="http://schemas.microsoft.com/office/drawing/2014/main" id="{2C41F1FE-7A72-4C78-B01C-14D12799219C}"/>
+                <a16:creationId xmlns:a16="http://schemas.microsoft.com/office/drawing/2014/main" id="{660748A5-49DA-417C-BEC7-2C586797E918}"/>
               </a:ext>
             </a:extLst>
           </p:cNvPr>
@@ -12892,7 +12892,7 @@
           <p:cNvPr id="16" name="">
             <a:extLst xmlns:a="http://schemas.openxmlformats.org/drawingml/2006/main">
               <a:ext uri="{FF2B5EF4-FFF2-40B4-BE49-F238E27FC236}">
-                <a16:creationId xmlns:a16="http://schemas.microsoft.com/office/drawing/2014/main" id="{FFF326C6-1EDB-4D00-8E0B-FB5B4FBCED6D}"/>
+                <a16:creationId xmlns:a16="http://schemas.microsoft.com/office/drawing/2014/main" id="{60E37C53-FE9A-4664-A9FA-6F043F6182E9}"/>
               </a:ext>
             </a:extLst>
           </p:cNvPr>
@@ -13072,7 +13072,7 @@
           <p:cNvPr id="17" name="">
             <a:extLst xmlns:a="http://schemas.openxmlformats.org/drawingml/2006/main">
               <a:ext uri="{FF2B5EF4-FFF2-40B4-BE49-F238E27FC236}">
-                <a16:creationId xmlns:a16="http://schemas.microsoft.com/office/drawing/2014/main" id="{FBAF4E65-A2AE-46DC-91E7-3048A42B56F4}"/>
+                <a16:creationId xmlns:a16="http://schemas.microsoft.com/office/drawing/2014/main" id="{30A912A8-1A71-48BF-A31B-3BB3D1ABD437}"/>
               </a:ext>
             </a:extLst>
           </p:cNvPr>
@@ -13432,7 +13432,7 @@
           <p:cNvPr id="18" name="">
             <a:extLst xmlns:a="http://schemas.openxmlformats.org/drawingml/2006/main">
               <a:ext uri="{FF2B5EF4-FFF2-40B4-BE49-F238E27FC236}">
-                <a16:creationId xmlns:a16="http://schemas.microsoft.com/office/drawing/2014/main" id="{0533ED10-9146-4E03-A969-193DD665765D}"/>
+                <a16:creationId xmlns:a16="http://schemas.microsoft.com/office/drawing/2014/main" id="{C00F2BAA-2F8E-43D5-8EDE-06203CE557F2}"/>
               </a:ext>
             </a:extLst>
           </p:cNvPr>
@@ -13587,7 +13587,7 @@
     </p:spTree>
     <p:extLst>
       <p:ext uri="{BB962C8B-B14F-4D97-AF65-F5344CB8AC3E}">
-        <p14:creationId xmlns:p14="http://schemas.microsoft.com/office/powerpoint/2010/main" val="887839256"/>
+        <p14:creationId xmlns:p14="http://schemas.microsoft.com/office/powerpoint/2010/main" val="2080555939"/>
       </p:ext>
     </p:extLst>
   </p:cSld>
@@ -13618,7 +13618,7 @@
           <p:cNvPr id="26" name="">
             <a:extLst xmlns:a="http://schemas.openxmlformats.org/drawingml/2006/main">
               <a:ext uri="{FF2B5EF4-FFF2-40B4-BE49-F238E27FC236}">
-                <a16:creationId xmlns:a16="http://schemas.microsoft.com/office/drawing/2014/main" id="{CA6AAAA5-8A81-404D-869A-1530C6BEF761}"/>
+                <a16:creationId xmlns:a16="http://schemas.microsoft.com/office/drawing/2014/main" id="{958D64D6-9D15-4585-A631-089001E23984}"/>
               </a:ext>
             </a:extLst>
           </p:cNvPr>
@@ -13775,7 +13775,7 @@
           <p:cNvPr id="2" name="">
             <a:extLst xmlns:a="http://schemas.openxmlformats.org/drawingml/2006/main">
               <a:ext uri="{FF2B5EF4-FFF2-40B4-BE49-F238E27FC236}">
-                <a16:creationId xmlns:a16="http://schemas.microsoft.com/office/drawing/2014/main" id="{49F9F680-E2D0-4128-A289-3EC56C92B8FE}"/>
+                <a16:creationId xmlns:a16="http://schemas.microsoft.com/office/drawing/2014/main" id="{9773E2E4-F2E3-4AC1-A024-F184DE132D00}"/>
               </a:ext>
             </a:extLst>
           </p:cNvPr>
@@ -13806,7 +13806,7 @@
           <p:cNvPr id="3" name="">
             <a:extLst xmlns:a="http://schemas.openxmlformats.org/drawingml/2006/main">
               <a:ext uri="{FF2B5EF4-FFF2-40B4-BE49-F238E27FC236}">
-                <a16:creationId xmlns:a16="http://schemas.microsoft.com/office/drawing/2014/main" id="{9CF89B9C-AF2F-4F57-BF57-7DD4BD461FF7}"/>
+                <a16:creationId xmlns:a16="http://schemas.microsoft.com/office/drawing/2014/main" id="{FD200A27-3870-4FA1-9A65-4E3385C606A9}"/>
               </a:ext>
             </a:extLst>
           </p:cNvPr>
@@ -13963,7 +13963,7 @@
           <p:cNvPr id="4" name="">
             <a:extLst xmlns:a="http://schemas.openxmlformats.org/drawingml/2006/main">
               <a:ext uri="{FF2B5EF4-FFF2-40B4-BE49-F238E27FC236}">
-                <a16:creationId xmlns:a16="http://schemas.microsoft.com/office/drawing/2014/main" id="{68EB617C-500B-4820-9C80-90353321A234}"/>
+                <a16:creationId xmlns:a16="http://schemas.microsoft.com/office/drawing/2014/main" id="{E1A07117-9BCE-45F1-B9CA-7437856C7474}"/>
               </a:ext>
             </a:extLst>
           </p:cNvPr>
@@ -13996,7 +13996,7 @@
           <p:cNvPr id="5" name="">
             <a:extLst xmlns:a="http://schemas.openxmlformats.org/drawingml/2006/main">
               <a:ext uri="{FF2B5EF4-FFF2-40B4-BE49-F238E27FC236}">
-                <a16:creationId xmlns:a16="http://schemas.microsoft.com/office/drawing/2014/main" id="{84FE4167-8D13-43EB-BCFD-255503E158D6}"/>
+                <a16:creationId xmlns:a16="http://schemas.microsoft.com/office/drawing/2014/main" id="{8EF52269-052E-4388-B9E7-DE474051C975}"/>
               </a:ext>
             </a:extLst>
           </p:cNvPr>
@@ -14153,7 +14153,7 @@
           <p:cNvPr id="6" name="">
             <a:extLst xmlns:a="http://schemas.openxmlformats.org/drawingml/2006/main">
               <a:ext uri="{FF2B5EF4-FFF2-40B4-BE49-F238E27FC236}">
-                <a16:creationId xmlns:a16="http://schemas.microsoft.com/office/drawing/2014/main" id="{CA2CFBB4-CDA7-478F-A861-6BEE78FB5A89}"/>
+                <a16:creationId xmlns:a16="http://schemas.microsoft.com/office/drawing/2014/main" id="{72B3B4C3-D306-4C9C-9499-2819228E5BE8}"/>
               </a:ext>
             </a:extLst>
           </p:cNvPr>
@@ -14333,7 +14333,7 @@
           <p:cNvPr id="7" name="">
             <a:extLst xmlns:a="http://schemas.openxmlformats.org/drawingml/2006/main">
               <a:ext uri="{FF2B5EF4-FFF2-40B4-BE49-F238E27FC236}">
-                <a16:creationId xmlns:a16="http://schemas.microsoft.com/office/drawing/2014/main" id="{7F814513-A9B6-4BDF-A5C6-A88733040A7C}"/>
+                <a16:creationId xmlns:a16="http://schemas.microsoft.com/office/drawing/2014/main" id="{793B27CD-7C53-45C1-B523-C55C48BFDF0B}"/>
               </a:ext>
             </a:extLst>
           </p:cNvPr>
@@ -14364,7 +14364,7 @@
           <p:cNvPr id="8" name="">
             <a:extLst xmlns:a="http://schemas.openxmlformats.org/drawingml/2006/main">
               <a:ext uri="{FF2B5EF4-FFF2-40B4-BE49-F238E27FC236}">
-                <a16:creationId xmlns:a16="http://schemas.microsoft.com/office/drawing/2014/main" id="{89142216-456F-4880-9374-9B2891577593}"/>
+                <a16:creationId xmlns:a16="http://schemas.microsoft.com/office/drawing/2014/main" id="{400D6224-1DEB-4ED2-8CF9-C9DF2429AA8F}"/>
               </a:ext>
             </a:extLst>
           </p:cNvPr>
@@ -14397,7 +14397,7 @@
           <p:cNvPr id="9" name="">
             <a:extLst xmlns:a="http://schemas.openxmlformats.org/drawingml/2006/main">
               <a:ext uri="{FF2B5EF4-FFF2-40B4-BE49-F238E27FC236}">
-                <a16:creationId xmlns:a16="http://schemas.microsoft.com/office/drawing/2014/main" id="{DEF1C42D-798C-423E-ACAC-9D25D88C12F7}"/>
+                <a16:creationId xmlns:a16="http://schemas.microsoft.com/office/drawing/2014/main" id="{18925FD7-DC88-4A6E-8008-54FCD246041D}"/>
               </a:ext>
             </a:extLst>
           </p:cNvPr>
@@ -14554,7 +14554,7 @@
           <p:cNvPr id="10" name="">
             <a:extLst xmlns:a="http://schemas.openxmlformats.org/drawingml/2006/main">
               <a:ext uri="{FF2B5EF4-FFF2-40B4-BE49-F238E27FC236}">
-                <a16:creationId xmlns:a16="http://schemas.microsoft.com/office/drawing/2014/main" id="{011DCD78-B12E-4CBF-BA8E-643DDB68814A}"/>
+                <a16:creationId xmlns:a16="http://schemas.microsoft.com/office/drawing/2014/main" id="{D78B6770-738B-4027-B33F-50B9F799AE8B}"/>
               </a:ext>
             </a:extLst>
           </p:cNvPr>
@@ -14734,7 +14734,7 @@
           <p:cNvPr id="11" name="">
             <a:extLst xmlns:a="http://schemas.openxmlformats.org/drawingml/2006/main">
               <a:ext uri="{FF2B5EF4-FFF2-40B4-BE49-F238E27FC236}">
-                <a16:creationId xmlns:a16="http://schemas.microsoft.com/office/drawing/2014/main" id="{9F05C906-3EE0-4D9C-A760-0D1080DE0403}"/>
+                <a16:creationId xmlns:a16="http://schemas.microsoft.com/office/drawing/2014/main" id="{8C212C2B-4AFE-47B7-8E9C-9D2E7BE77715}"/>
               </a:ext>
             </a:extLst>
           </p:cNvPr>
@@ -14765,7 +14765,7 @@
           <p:cNvPr id="12" name="">
             <a:extLst xmlns:a="http://schemas.openxmlformats.org/drawingml/2006/main">
               <a:ext uri="{FF2B5EF4-FFF2-40B4-BE49-F238E27FC236}">
-                <a16:creationId xmlns:a16="http://schemas.microsoft.com/office/drawing/2014/main" id="{5C956702-670C-4726-932A-0DC167881E22}"/>
+                <a16:creationId xmlns:a16="http://schemas.microsoft.com/office/drawing/2014/main" id="{D7F5E2D8-A5B4-4D0B-99C0-E26ADF0BBA46}"/>
               </a:ext>
             </a:extLst>
           </p:cNvPr>
@@ -14798,7 +14798,7 @@
           <p:cNvPr id="13" name="">
             <a:extLst xmlns:a="http://schemas.openxmlformats.org/drawingml/2006/main">
               <a:ext uri="{FF2B5EF4-FFF2-40B4-BE49-F238E27FC236}">
-                <a16:creationId xmlns:a16="http://schemas.microsoft.com/office/drawing/2014/main" id="{6F32E454-C378-4049-ACF3-D7B6F2A30D37}"/>
+                <a16:creationId xmlns:a16="http://schemas.microsoft.com/office/drawing/2014/main" id="{A211B5DF-5085-4E3E-A994-3445D5732780}"/>
               </a:ext>
             </a:extLst>
           </p:cNvPr>
@@ -14955,7 +14955,7 @@
           <p:cNvPr id="14" name="">
             <a:extLst xmlns:a="http://schemas.openxmlformats.org/drawingml/2006/main">
               <a:ext uri="{FF2B5EF4-FFF2-40B4-BE49-F238E27FC236}">
-                <a16:creationId xmlns:a16="http://schemas.microsoft.com/office/drawing/2014/main" id="{DE6CA61B-C77E-4D2E-92D5-DF4054819DE2}"/>
+                <a16:creationId xmlns:a16="http://schemas.microsoft.com/office/drawing/2014/main" id="{6770C422-92B7-422F-BA3F-88DCEBFD8F0B}"/>
               </a:ext>
             </a:extLst>
           </p:cNvPr>
@@ -15135,7 +15135,7 @@
           <p:cNvPr id="15" name="">
             <a:extLst xmlns:a="http://schemas.openxmlformats.org/drawingml/2006/main">
               <a:ext uri="{FF2B5EF4-FFF2-40B4-BE49-F238E27FC236}">
-                <a16:creationId xmlns:a16="http://schemas.microsoft.com/office/drawing/2014/main" id="{22185392-B8B1-43F2-BA18-FB90F9F5B26E}"/>
+                <a16:creationId xmlns:a16="http://schemas.microsoft.com/office/drawing/2014/main" id="{599663CE-62D8-4C1D-8335-1C9FE0C3A3DB}"/>
               </a:ext>
             </a:extLst>
           </p:cNvPr>
@@ -15166,7 +15166,7 @@
           <p:cNvPr id="16" name="">
             <a:extLst xmlns:a="http://schemas.openxmlformats.org/drawingml/2006/main">
               <a:ext uri="{FF2B5EF4-FFF2-40B4-BE49-F238E27FC236}">
-                <a16:creationId xmlns:a16="http://schemas.microsoft.com/office/drawing/2014/main" id="{4F689F70-6776-4695-AF83-D604A29D1576}"/>
+                <a16:creationId xmlns:a16="http://schemas.microsoft.com/office/drawing/2014/main" id="{45139269-6EF1-4068-A701-1A69AF085362}"/>
               </a:ext>
             </a:extLst>
           </p:cNvPr>
@@ -15199,7 +15199,7 @@
           <p:cNvPr id="17" name="">
             <a:extLst xmlns:a="http://schemas.openxmlformats.org/drawingml/2006/main">
               <a:ext uri="{FF2B5EF4-FFF2-40B4-BE49-F238E27FC236}">
-                <a16:creationId xmlns:a16="http://schemas.microsoft.com/office/drawing/2014/main" id="{98E06B08-7ADF-4859-8855-D497B72EF748}"/>
+                <a16:creationId xmlns:a16="http://schemas.microsoft.com/office/drawing/2014/main" id="{EEB8C509-8F16-423E-83DC-9C73F507F95F}"/>
               </a:ext>
             </a:extLst>
           </p:cNvPr>
@@ -15356,7 +15356,7 @@
           <p:cNvPr id="18" name="">
             <a:extLst xmlns:a="http://schemas.openxmlformats.org/drawingml/2006/main">
               <a:ext uri="{FF2B5EF4-FFF2-40B4-BE49-F238E27FC236}">
-                <a16:creationId xmlns:a16="http://schemas.microsoft.com/office/drawing/2014/main" id="{41CBC1F0-4C0A-46D4-8A68-4E935BDFC655}"/>
+                <a16:creationId xmlns:a16="http://schemas.microsoft.com/office/drawing/2014/main" id="{0D2A0A91-A645-4F79-98D2-32A867F73FD7}"/>
               </a:ext>
             </a:extLst>
           </p:cNvPr>
@@ -15536,7 +15536,7 @@
           <p:cNvPr id="19" name="">
             <a:extLst xmlns:a="http://schemas.openxmlformats.org/drawingml/2006/main">
               <a:ext uri="{FF2B5EF4-FFF2-40B4-BE49-F238E27FC236}">
-                <a16:creationId xmlns:a16="http://schemas.microsoft.com/office/drawing/2014/main" id="{100955FA-7BEA-414F-90D4-3EB79131816F}"/>
+                <a16:creationId xmlns:a16="http://schemas.microsoft.com/office/drawing/2014/main" id="{4A57C369-B749-4FC3-A67E-124962215493}"/>
               </a:ext>
             </a:extLst>
           </p:cNvPr>
@@ -15693,7 +15693,7 @@
           <p:cNvPr id="20" name="">
             <a:extLst xmlns:a="http://schemas.openxmlformats.org/drawingml/2006/main">
               <a:ext uri="{FF2B5EF4-FFF2-40B4-BE49-F238E27FC236}">
-                <a16:creationId xmlns:a16="http://schemas.microsoft.com/office/drawing/2014/main" id="{F327A761-63B2-41A5-A8A4-E771DAD3C47F}"/>
+                <a16:creationId xmlns:a16="http://schemas.microsoft.com/office/drawing/2014/main" id="{B6CED84B-28E9-4896-873B-93BA066832D6}"/>
               </a:ext>
             </a:extLst>
           </p:cNvPr>
@@ -15850,7 +15850,7 @@
           <p:cNvPr id="21" name="">
             <a:extLst xmlns:a="http://schemas.openxmlformats.org/drawingml/2006/main">
               <a:ext uri="{FF2B5EF4-FFF2-40B4-BE49-F238E27FC236}">
-                <a16:creationId xmlns:a16="http://schemas.microsoft.com/office/drawing/2014/main" id="{4D1FE740-07BD-4F31-A429-7736ACDC3572}"/>
+                <a16:creationId xmlns:a16="http://schemas.microsoft.com/office/drawing/2014/main" id="{B183FBE7-E41F-4D23-BD1E-68D316C66950}"/>
               </a:ext>
             </a:extLst>
           </p:cNvPr>
@@ -16007,7 +16007,7 @@
           <p:cNvPr id="22" name="">
             <a:extLst xmlns:a="http://schemas.openxmlformats.org/drawingml/2006/main">
               <a:ext uri="{FF2B5EF4-FFF2-40B4-BE49-F238E27FC236}">
-                <a16:creationId xmlns:a16="http://schemas.microsoft.com/office/drawing/2014/main" id="{A88D7CC2-634C-4FB3-97CD-5298B2987476}"/>
+                <a16:creationId xmlns:a16="http://schemas.microsoft.com/office/drawing/2014/main" id="{4E7BEA8B-224F-4863-B451-3DDE4D296841}"/>
               </a:ext>
             </a:extLst>
           </p:cNvPr>
@@ -16164,7 +16164,7 @@
           <p:cNvPr id="23" name="">
             <a:extLst xmlns:a="http://schemas.openxmlformats.org/drawingml/2006/main">
               <a:ext uri="{FF2B5EF4-FFF2-40B4-BE49-F238E27FC236}">
-                <a16:creationId xmlns:a16="http://schemas.microsoft.com/office/drawing/2014/main" id="{6FD7E6D3-8D13-4660-AC5A-5378837E6BED}"/>
+                <a16:creationId xmlns:a16="http://schemas.microsoft.com/office/drawing/2014/main" id="{7467ADAC-E613-4FE0-8BCE-0D166AE80110}"/>
               </a:ext>
             </a:extLst>
           </p:cNvPr>
@@ -16321,7 +16321,7 @@
           <p:cNvPr id="24" name="">
             <a:extLst xmlns:a="http://schemas.openxmlformats.org/drawingml/2006/main">
               <a:ext uri="{FF2B5EF4-FFF2-40B4-BE49-F238E27FC236}">
-                <a16:creationId xmlns:a16="http://schemas.microsoft.com/office/drawing/2014/main" id="{2E5D38BC-04CF-466C-AF4E-9D56666E97B5}"/>
+                <a16:creationId xmlns:a16="http://schemas.microsoft.com/office/drawing/2014/main" id="{3361E997-60DB-4C29-AC43-F86B4F9C5D24}"/>
               </a:ext>
             </a:extLst>
           </p:cNvPr>
@@ -16478,7 +16478,7 @@
           <p:cNvPr id="25" name="">
             <a:extLst xmlns:a="http://schemas.openxmlformats.org/drawingml/2006/main">
               <a:ext uri="{FF2B5EF4-FFF2-40B4-BE49-F238E27FC236}">
-                <a16:creationId xmlns:a16="http://schemas.microsoft.com/office/drawing/2014/main" id="{98318B96-8611-4B20-AE9E-4DF387E6E98F}"/>
+                <a16:creationId xmlns:a16="http://schemas.microsoft.com/office/drawing/2014/main" id="{FB604CAB-21C6-4ACB-8E0A-F6A34BF9F1C9}"/>
               </a:ext>
             </a:extLst>
           </p:cNvPr>
@@ -16633,7 +16633,7 @@
     </p:spTree>
     <p:extLst>
       <p:ext uri="{BB962C8B-B14F-4D97-AF65-F5344CB8AC3E}">
-        <p14:creationId xmlns:p14="http://schemas.microsoft.com/office/powerpoint/2010/main" val="822681312"/>
+        <p14:creationId xmlns:p14="http://schemas.microsoft.com/office/powerpoint/2010/main" val="520668725"/>
       </p:ext>
     </p:extLst>
   </p:cSld>
@@ -16664,7 +16664,7 @@
           <p:cNvPr id="10" name="">
             <a:extLst xmlns:a="http://schemas.openxmlformats.org/drawingml/2006/main">
               <a:ext uri="{FF2B5EF4-FFF2-40B4-BE49-F238E27FC236}">
-                <a16:creationId xmlns:a16="http://schemas.microsoft.com/office/drawing/2014/main" id="{827E1D44-52B2-4DD6-B323-96469FED7AC5}"/>
+                <a16:creationId xmlns:a16="http://schemas.microsoft.com/office/drawing/2014/main" id="{89644560-B42B-440F-BEA7-4E45F5555A12}"/>
               </a:ext>
             </a:extLst>
           </p:cNvPr>
@@ -16821,7 +16821,7 @@
           <p:cNvPr id="2" name="">
             <a:extLst xmlns:a="http://schemas.openxmlformats.org/drawingml/2006/main">
               <a:ext uri="{FF2B5EF4-FFF2-40B4-BE49-F238E27FC236}">
-                <a16:creationId xmlns:a16="http://schemas.microsoft.com/office/drawing/2014/main" id="{C25FBDE0-CAED-4B13-8CA4-EFA74F3105C8}"/>
+                <a16:creationId xmlns:a16="http://schemas.microsoft.com/office/drawing/2014/main" id="{A615BAC3-488A-45E4-9580-8421364AF028}"/>
               </a:ext>
             </a:extLst>
           </p:cNvPr>
@@ -16852,7 +16852,7 @@
           <p:cNvPr id="3" name="">
             <a:extLst xmlns:a="http://schemas.openxmlformats.org/drawingml/2006/main">
               <a:ext uri="{FF2B5EF4-FFF2-40B4-BE49-F238E27FC236}">
-                <a16:creationId xmlns:a16="http://schemas.microsoft.com/office/drawing/2014/main" id="{C4F2A122-EA6C-493A-B3D2-04A04FB5B013}"/>
+                <a16:creationId xmlns:a16="http://schemas.microsoft.com/office/drawing/2014/main" id="{4DE888CD-CB90-42D1-BBCF-BE8D4649F442}"/>
               </a:ext>
             </a:extLst>
           </p:cNvPr>
@@ -17009,7 +17009,7 @@
           <p:cNvPr id="4" name="Chart">
             <a:extLst xmlns:a="http://schemas.openxmlformats.org/drawingml/2006/main">
               <a:ext uri="{FF2B5EF4-FFF2-40B4-BE49-F238E27FC236}">
-                <a16:creationId xmlns:a16="http://schemas.microsoft.com/office/drawing/2014/main" id="{7F80B7D5-A039-4FF2-BCA3-D9F0400A34EE}"/>
+                <a16:creationId xmlns:a16="http://schemas.microsoft.com/office/drawing/2014/main" id="{7442A556-D6CE-435E-9282-4EEB58C0A07C}"/>
               </a:ext>
             </a:extLst>
           </p:cNvPr>
@@ -17022,7 +17022,7 @@
         </p:xfrm>
         <a:graphic xmlns:a="http://schemas.openxmlformats.org/drawingml/2006/main">
           <a:graphicData uri="http://schemas.openxmlformats.org/drawingml/2006/chart">
-            <c:chart xmlns:r="http://schemas.openxmlformats.org/officeDocument/2006/relationships" xmlns:c="http://schemas.openxmlformats.org/drawingml/2006/chart" r:id="Rea2270456c4643af"/>
+            <c:chart xmlns:r="http://schemas.openxmlformats.org/officeDocument/2006/relationships" xmlns:c="http://schemas.openxmlformats.org/drawingml/2006/chart" r:id="R64503476498e4809"/>
           </a:graphicData>
         </a:graphic>
       </p:graphicFrame>
@@ -17031,7 +17031,7 @@
           <p:cNvPr id="5" name="">
             <a:extLst xmlns:a="http://schemas.openxmlformats.org/drawingml/2006/main">
               <a:ext uri="{FF2B5EF4-FFF2-40B4-BE49-F238E27FC236}">
-                <a16:creationId xmlns:a16="http://schemas.microsoft.com/office/drawing/2014/main" id="{8B48AC75-7E67-460B-8B01-11D9812A29A5}"/>
+                <a16:creationId xmlns:a16="http://schemas.microsoft.com/office/drawing/2014/main" id="{A485E016-8FE2-4F1D-9731-32D57438BD50}"/>
               </a:ext>
             </a:extLst>
           </p:cNvPr>
@@ -17188,7 +17188,7 @@
           <p:cNvPr id="6" name="">
             <a:extLst xmlns:a="http://schemas.openxmlformats.org/drawingml/2006/main">
               <a:ext uri="{FF2B5EF4-FFF2-40B4-BE49-F238E27FC236}">
-                <a16:creationId xmlns:a16="http://schemas.microsoft.com/office/drawing/2014/main" id="{26805666-5702-4DCF-8E50-538EFD015313}"/>
+                <a16:creationId xmlns:a16="http://schemas.microsoft.com/office/drawing/2014/main" id="{B9BE23DF-4175-4232-916F-7F5187A63617}"/>
               </a:ext>
             </a:extLst>
           </p:cNvPr>
@@ -17368,7 +17368,7 @@
           <p:cNvPr id="7" name="">
             <a:extLst xmlns:a="http://schemas.openxmlformats.org/drawingml/2006/main">
               <a:ext uri="{FF2B5EF4-FFF2-40B4-BE49-F238E27FC236}">
-                <a16:creationId xmlns:a16="http://schemas.microsoft.com/office/drawing/2014/main" id="{9B6548B0-EA86-4C6A-88DD-CB05CCE7C75C}"/>
+                <a16:creationId xmlns:a16="http://schemas.microsoft.com/office/drawing/2014/main" id="{B6AE2BED-8B8A-4229-9E27-DC3B6EB3A55A}"/>
               </a:ext>
             </a:extLst>
           </p:cNvPr>
@@ -17525,7 +17525,7 @@
           <p:cNvPr id="8" name="">
             <a:extLst xmlns:a="http://schemas.openxmlformats.org/drawingml/2006/main">
               <a:ext uri="{FF2B5EF4-FFF2-40B4-BE49-F238E27FC236}">
-                <a16:creationId xmlns:a16="http://schemas.microsoft.com/office/drawing/2014/main" id="{BD8800B9-4675-4A16-99B2-EBF2B10258CF}"/>
+                <a16:creationId xmlns:a16="http://schemas.microsoft.com/office/drawing/2014/main" id="{9655C29C-76FA-44FA-9D58-8CFD0B8A3C04}"/>
               </a:ext>
             </a:extLst>
           </p:cNvPr>
@@ -17705,7 +17705,7 @@
           <p:cNvPr id="9" name="">
             <a:extLst xmlns:a="http://schemas.openxmlformats.org/drawingml/2006/main">
               <a:ext uri="{FF2B5EF4-FFF2-40B4-BE49-F238E27FC236}">
-                <a16:creationId xmlns:a16="http://schemas.microsoft.com/office/drawing/2014/main" id="{B00991AF-3FEE-4D6D-ADC3-B8F28C7159D2}"/>
+                <a16:creationId xmlns:a16="http://schemas.microsoft.com/office/drawing/2014/main" id="{1E1C25C1-8EB8-40E4-9AF2-E83BBDF5A5D3}"/>
               </a:ext>
             </a:extLst>
           </p:cNvPr>
@@ -17860,7 +17860,7 @@
     </p:spTree>
     <p:extLst>
       <p:ext uri="{BB962C8B-B14F-4D97-AF65-F5344CB8AC3E}">
-        <p14:creationId xmlns:p14="http://schemas.microsoft.com/office/powerpoint/2010/main" val="438219839"/>
+        <p14:creationId xmlns:p14="http://schemas.microsoft.com/office/powerpoint/2010/main" val="360834284"/>
       </p:ext>
     </p:extLst>
   </p:cSld>
@@ -17891,7 +17891,7 @@
           <p:cNvPr id="22" name="">
             <a:extLst xmlns:a="http://schemas.openxmlformats.org/drawingml/2006/main">
               <a:ext uri="{FF2B5EF4-FFF2-40B4-BE49-F238E27FC236}">
-                <a16:creationId xmlns:a16="http://schemas.microsoft.com/office/drawing/2014/main" id="{B5C55D2F-0A5D-45F2-827E-E7AC93E1D2CE}"/>
+                <a16:creationId xmlns:a16="http://schemas.microsoft.com/office/drawing/2014/main" id="{5B61C0F7-ECC7-4E88-9375-E3A62EFF921A}"/>
               </a:ext>
             </a:extLst>
           </p:cNvPr>
@@ -18048,7 +18048,7 @@
           <p:cNvPr id="2" name="">
             <a:extLst xmlns:a="http://schemas.openxmlformats.org/drawingml/2006/main">
               <a:ext uri="{FF2B5EF4-FFF2-40B4-BE49-F238E27FC236}">
-                <a16:creationId xmlns:a16="http://schemas.microsoft.com/office/drawing/2014/main" id="{DEE34D6B-1F84-45AE-BA29-F043329F89DB}"/>
+                <a16:creationId xmlns:a16="http://schemas.microsoft.com/office/drawing/2014/main" id="{A42C0149-7EDC-49F3-B9E2-959DDA9A3AF7}"/>
               </a:ext>
             </a:extLst>
           </p:cNvPr>
@@ -18079,7 +18079,7 @@
           <p:cNvPr id="3" name="">
             <a:extLst xmlns:a="http://schemas.openxmlformats.org/drawingml/2006/main">
               <a:ext uri="{FF2B5EF4-FFF2-40B4-BE49-F238E27FC236}">
-                <a16:creationId xmlns:a16="http://schemas.microsoft.com/office/drawing/2014/main" id="{1CDDF730-D2EF-42FC-95CF-ADACA15016E0}"/>
+                <a16:creationId xmlns:a16="http://schemas.microsoft.com/office/drawing/2014/main" id="{5F89FB63-0B25-4791-AAF2-2BE17387A7F4}"/>
               </a:ext>
             </a:extLst>
           </p:cNvPr>
@@ -18236,7 +18236,7 @@
           <p:cNvPr id="4" name="">
             <a:extLst xmlns:a="http://schemas.openxmlformats.org/drawingml/2006/main">
               <a:ext uri="{FF2B5EF4-FFF2-40B4-BE49-F238E27FC236}">
-                <a16:creationId xmlns:a16="http://schemas.microsoft.com/office/drawing/2014/main" id="{6584A696-0255-4A44-9944-4A64F7918C59}"/>
+                <a16:creationId xmlns:a16="http://schemas.microsoft.com/office/drawing/2014/main" id="{7B98C661-C519-4704-8F06-5676B1B18749}"/>
               </a:ext>
             </a:extLst>
           </p:cNvPr>
@@ -18269,7 +18269,7 @@
           <p:cNvPr id="5" name="">
             <a:extLst xmlns:a="http://schemas.openxmlformats.org/drawingml/2006/main">
               <a:ext uri="{FF2B5EF4-FFF2-40B4-BE49-F238E27FC236}">
-                <a16:creationId xmlns:a16="http://schemas.microsoft.com/office/drawing/2014/main" id="{88BB3B60-0AA5-4447-A6D0-A62A0A199A00}"/>
+                <a16:creationId xmlns:a16="http://schemas.microsoft.com/office/drawing/2014/main" id="{3D266EAA-D928-40E1-A4E7-192DE34F25EE}"/>
               </a:ext>
             </a:extLst>
           </p:cNvPr>
@@ -18426,7 +18426,7 @@
           <p:cNvPr id="6" name="">
             <a:extLst xmlns:a="http://schemas.openxmlformats.org/drawingml/2006/main">
               <a:ext uri="{FF2B5EF4-FFF2-40B4-BE49-F238E27FC236}">
-                <a16:creationId xmlns:a16="http://schemas.microsoft.com/office/drawing/2014/main" id="{302AE72C-B386-4296-9B8C-8618FFBCCAE0}"/>
+                <a16:creationId xmlns:a16="http://schemas.microsoft.com/office/drawing/2014/main" id="{8B58BD07-E8E2-461F-B2B6-30C33745359C}"/>
               </a:ext>
             </a:extLst>
           </p:cNvPr>
@@ -18606,7 +18606,7 @@
           <p:cNvPr id="7" name="">
             <a:extLst xmlns:a="http://schemas.openxmlformats.org/drawingml/2006/main">
               <a:ext uri="{FF2B5EF4-FFF2-40B4-BE49-F238E27FC236}">
-                <a16:creationId xmlns:a16="http://schemas.microsoft.com/office/drawing/2014/main" id="{7CB74898-EDE8-43D7-9A4D-B1B80F4589AD}"/>
+                <a16:creationId xmlns:a16="http://schemas.microsoft.com/office/drawing/2014/main" id="{CF5486AD-A3CA-42B4-9B1B-D6A8C53020D9}"/>
               </a:ext>
             </a:extLst>
           </p:cNvPr>
@@ -18637,7 +18637,7 @@
           <p:cNvPr id="8" name="">
             <a:extLst xmlns:a="http://schemas.openxmlformats.org/drawingml/2006/main">
               <a:ext uri="{FF2B5EF4-FFF2-40B4-BE49-F238E27FC236}">
-                <a16:creationId xmlns:a16="http://schemas.microsoft.com/office/drawing/2014/main" id="{8E71071A-73B8-4524-9654-668C40992601}"/>
+                <a16:creationId xmlns:a16="http://schemas.microsoft.com/office/drawing/2014/main" id="{0734769A-1BCF-4A5B-8741-9D69BCD2E8BA}"/>
               </a:ext>
             </a:extLst>
           </p:cNvPr>
@@ -18670,7 +18670,7 @@
           <p:cNvPr id="9" name="">
             <a:extLst xmlns:a="http://schemas.openxmlformats.org/drawingml/2006/main">
               <a:ext uri="{FF2B5EF4-FFF2-40B4-BE49-F238E27FC236}">
-                <a16:creationId xmlns:a16="http://schemas.microsoft.com/office/drawing/2014/main" id="{419274F3-6FC4-4657-809F-B211F5775E7F}"/>
+                <a16:creationId xmlns:a16="http://schemas.microsoft.com/office/drawing/2014/main" id="{66F59E9D-F0EE-44C6-ABA1-81EDD52532D9}"/>
               </a:ext>
             </a:extLst>
           </p:cNvPr>
@@ -18827,7 +18827,7 @@
           <p:cNvPr id="10" name="">
             <a:extLst xmlns:a="http://schemas.openxmlformats.org/drawingml/2006/main">
               <a:ext uri="{FF2B5EF4-FFF2-40B4-BE49-F238E27FC236}">
-                <a16:creationId xmlns:a16="http://schemas.microsoft.com/office/drawing/2014/main" id="{9B6C4376-14CD-4DB0-8CB6-53549FBFE04D}"/>
+                <a16:creationId xmlns:a16="http://schemas.microsoft.com/office/drawing/2014/main" id="{19333320-635C-460E-8785-5DC2B21A3E0F}"/>
               </a:ext>
             </a:extLst>
           </p:cNvPr>
@@ -19007,7 +19007,7 @@
           <p:cNvPr id="11" name="">
             <a:extLst xmlns:a="http://schemas.openxmlformats.org/drawingml/2006/main">
               <a:ext uri="{FF2B5EF4-FFF2-40B4-BE49-F238E27FC236}">
-                <a16:creationId xmlns:a16="http://schemas.microsoft.com/office/drawing/2014/main" id="{CE53EA7E-3C47-4759-BD53-F5838173D3AD}"/>
+                <a16:creationId xmlns:a16="http://schemas.microsoft.com/office/drawing/2014/main" id="{C2D774B1-3E47-4E46-B0D1-AE060F82DF3E}"/>
               </a:ext>
             </a:extLst>
           </p:cNvPr>
@@ -19038,7 +19038,7 @@
           <p:cNvPr id="12" name="">
             <a:extLst xmlns:a="http://schemas.openxmlformats.org/drawingml/2006/main">
               <a:ext uri="{FF2B5EF4-FFF2-40B4-BE49-F238E27FC236}">
-                <a16:creationId xmlns:a16="http://schemas.microsoft.com/office/drawing/2014/main" id="{F746E4AD-92A0-435D-82ED-FFE8962BC2A6}"/>
+                <a16:creationId xmlns:a16="http://schemas.microsoft.com/office/drawing/2014/main" id="{88874F1A-10EE-463F-B102-5DFBE4564DDC}"/>
               </a:ext>
             </a:extLst>
           </p:cNvPr>
@@ -19071,7 +19071,7 @@
           <p:cNvPr id="13" name="">
             <a:extLst xmlns:a="http://schemas.openxmlformats.org/drawingml/2006/main">
               <a:ext uri="{FF2B5EF4-FFF2-40B4-BE49-F238E27FC236}">
-                <a16:creationId xmlns:a16="http://schemas.microsoft.com/office/drawing/2014/main" id="{5C35EE1B-E3DA-43F2-A4BE-19B194BBEBE4}"/>
+                <a16:creationId xmlns:a16="http://schemas.microsoft.com/office/drawing/2014/main" id="{145516F4-D48A-4E39-A6D3-B02E1E327580}"/>
               </a:ext>
             </a:extLst>
           </p:cNvPr>
@@ -19228,7 +19228,7 @@
           <p:cNvPr id="14" name="">
             <a:extLst xmlns:a="http://schemas.openxmlformats.org/drawingml/2006/main">
               <a:ext uri="{FF2B5EF4-FFF2-40B4-BE49-F238E27FC236}">
-                <a16:creationId xmlns:a16="http://schemas.microsoft.com/office/drawing/2014/main" id="{DEF5E91F-AC5C-4B67-8849-09C59C28C9F5}"/>
+                <a16:creationId xmlns:a16="http://schemas.microsoft.com/office/drawing/2014/main" id="{669DA20C-36AB-457C-9615-E580F02841C6}"/>
               </a:ext>
             </a:extLst>
           </p:cNvPr>
@@ -19408,7 +19408,7 @@
           <p:cNvPr id="15" name="">
             <a:extLst xmlns:a="http://schemas.openxmlformats.org/drawingml/2006/main">
               <a:ext uri="{FF2B5EF4-FFF2-40B4-BE49-F238E27FC236}">
-                <a16:creationId xmlns:a16="http://schemas.microsoft.com/office/drawing/2014/main" id="{EE206A27-4B1D-40F3-9EA9-A2EEFAA3FFEB}"/>
+                <a16:creationId xmlns:a16="http://schemas.microsoft.com/office/drawing/2014/main" id="{BCBE3F8A-EC6D-498E-B0B9-3EC729697AC4}"/>
               </a:ext>
             </a:extLst>
           </p:cNvPr>
@@ -19439,7 +19439,7 @@
           <p:cNvPr id="16" name="">
             <a:extLst xmlns:a="http://schemas.openxmlformats.org/drawingml/2006/main">
               <a:ext uri="{FF2B5EF4-FFF2-40B4-BE49-F238E27FC236}">
-                <a16:creationId xmlns:a16="http://schemas.microsoft.com/office/drawing/2014/main" id="{D4D06EC3-3629-4156-9704-4C30144B88DD}"/>
+                <a16:creationId xmlns:a16="http://schemas.microsoft.com/office/drawing/2014/main" id="{A6881B2D-3872-4D7D-8C80-48024DA0E304}"/>
               </a:ext>
             </a:extLst>
           </p:cNvPr>
@@ -19472,7 +19472,7 @@
           <p:cNvPr id="17" name="">
             <a:extLst xmlns:a="http://schemas.openxmlformats.org/drawingml/2006/main">
               <a:ext uri="{FF2B5EF4-FFF2-40B4-BE49-F238E27FC236}">
-                <a16:creationId xmlns:a16="http://schemas.microsoft.com/office/drawing/2014/main" id="{395BBF70-8A3D-40FF-9E08-2006EB23D32C}"/>
+                <a16:creationId xmlns:a16="http://schemas.microsoft.com/office/drawing/2014/main" id="{F63B5A56-E518-47E7-98F2-19CBDCE83A6E}"/>
               </a:ext>
             </a:extLst>
           </p:cNvPr>
@@ -19629,7 +19629,7 @@
           <p:cNvPr id="18" name="">
             <a:extLst xmlns:a="http://schemas.openxmlformats.org/drawingml/2006/main">
               <a:ext uri="{FF2B5EF4-FFF2-40B4-BE49-F238E27FC236}">
-                <a16:creationId xmlns:a16="http://schemas.microsoft.com/office/drawing/2014/main" id="{BF9BB27A-6AA5-4223-AFF3-705DEE8C848D}"/>
+                <a16:creationId xmlns:a16="http://schemas.microsoft.com/office/drawing/2014/main" id="{AC1D1654-AD46-48A8-BC99-DA87AB4E0BB2}"/>
               </a:ext>
             </a:extLst>
           </p:cNvPr>
@@ -19809,7 +19809,7 @@
           <p:cNvPr id="19" name="">
             <a:extLst xmlns:a="http://schemas.openxmlformats.org/drawingml/2006/main">
               <a:ext uri="{FF2B5EF4-FFF2-40B4-BE49-F238E27FC236}">
-                <a16:creationId xmlns:a16="http://schemas.microsoft.com/office/drawing/2014/main" id="{60D151DB-CAB7-4687-AAA7-03843430E1CA}"/>
+                <a16:creationId xmlns:a16="http://schemas.microsoft.com/office/drawing/2014/main" id="{19A3987E-8FEA-40D4-91DE-017CC975C167}"/>
               </a:ext>
             </a:extLst>
           </p:cNvPr>
@@ -19966,7 +19966,7 @@
           <p:cNvPr id="20" name="">
             <a:extLst xmlns:a="http://schemas.openxmlformats.org/drawingml/2006/main">
               <a:ext uri="{FF2B5EF4-FFF2-40B4-BE49-F238E27FC236}">
-                <a16:creationId xmlns:a16="http://schemas.microsoft.com/office/drawing/2014/main" id="{2ECE8AE2-6764-4B39-8E8C-69CBF31306A7}"/>
+                <a16:creationId xmlns:a16="http://schemas.microsoft.com/office/drawing/2014/main" id="{96CDC9AC-345E-49E5-AB86-2EA5794A9D2F}"/>
               </a:ext>
             </a:extLst>
           </p:cNvPr>
@@ -20123,7 +20123,7 @@
           <p:cNvPr id="21" name="">
             <a:extLst xmlns:a="http://schemas.openxmlformats.org/drawingml/2006/main">
               <a:ext uri="{FF2B5EF4-FFF2-40B4-BE49-F238E27FC236}">
-                <a16:creationId xmlns:a16="http://schemas.microsoft.com/office/drawing/2014/main" id="{688AD89F-D93F-4D81-9D4D-DDE808F1E153}"/>
+                <a16:creationId xmlns:a16="http://schemas.microsoft.com/office/drawing/2014/main" id="{A32443D3-765C-43F5-95B9-49AE7A5937EB}"/>
               </a:ext>
             </a:extLst>
           </p:cNvPr>
@@ -20278,7 +20278,7 @@
     </p:spTree>
     <p:extLst>
       <p:ext uri="{BB962C8B-B14F-4D97-AF65-F5344CB8AC3E}">
-        <p14:creationId xmlns:p14="http://schemas.microsoft.com/office/powerpoint/2010/main" val="1385242354"/>
+        <p14:creationId xmlns:p14="http://schemas.microsoft.com/office/powerpoint/2010/main" val="350558268"/>
       </p:ext>
     </p:extLst>
   </p:cSld>
@@ -20309,7 +20309,7 @@
           <p:cNvPr id="9" name="">
             <a:extLst xmlns:a="http://schemas.openxmlformats.org/drawingml/2006/main">
               <a:ext uri="{FF2B5EF4-FFF2-40B4-BE49-F238E27FC236}">
-                <a16:creationId xmlns:a16="http://schemas.microsoft.com/office/drawing/2014/main" id="{65F5070D-560E-4CBF-B1EB-344E623FD37C}"/>
+                <a16:creationId xmlns:a16="http://schemas.microsoft.com/office/drawing/2014/main" id="{74700264-A634-496F-A740-36820E43AD5C}"/>
               </a:ext>
             </a:extLst>
           </p:cNvPr>
@@ -20466,7 +20466,7 @@
           <p:cNvPr id="2" name="">
             <a:extLst xmlns:a="http://schemas.openxmlformats.org/drawingml/2006/main">
               <a:ext uri="{FF2B5EF4-FFF2-40B4-BE49-F238E27FC236}">
-                <a16:creationId xmlns:a16="http://schemas.microsoft.com/office/drawing/2014/main" id="{235B5882-9D58-41F4-859E-070EF8723512}"/>
+                <a16:creationId xmlns:a16="http://schemas.microsoft.com/office/drawing/2014/main" id="{692FD77A-D375-4A4B-9A68-DCFBC4CFB329}"/>
               </a:ext>
             </a:extLst>
           </p:cNvPr>
@@ -20497,7 +20497,7 @@
           <p:cNvPr id="3" name="">
             <a:extLst xmlns:a="http://schemas.openxmlformats.org/drawingml/2006/main">
               <a:ext uri="{FF2B5EF4-FFF2-40B4-BE49-F238E27FC236}">
-                <a16:creationId xmlns:a16="http://schemas.microsoft.com/office/drawing/2014/main" id="{1CD969E5-DBB1-4432-8E7F-1ACAB052AECF}"/>
+                <a16:creationId xmlns:a16="http://schemas.microsoft.com/office/drawing/2014/main" id="{9684AC0F-765D-46FF-B613-9E9AF66E3838}"/>
               </a:ext>
             </a:extLst>
           </p:cNvPr>
@@ -20654,7 +20654,7 @@
           <p:cNvPr id="4" name="Chart">
             <a:extLst xmlns:a="http://schemas.openxmlformats.org/drawingml/2006/main">
               <a:ext uri="{FF2B5EF4-FFF2-40B4-BE49-F238E27FC236}">
-                <a16:creationId xmlns:a16="http://schemas.microsoft.com/office/drawing/2014/main" id="{E40E3257-79C1-46D4-B993-8FCE999E8D15}"/>
+                <a16:creationId xmlns:a16="http://schemas.microsoft.com/office/drawing/2014/main" id="{6FC305A9-D9AD-4D04-B0D8-C2BAE6BB1405}"/>
               </a:ext>
             </a:extLst>
           </p:cNvPr>
@@ -20667,7 +20667,7 @@
         </p:xfrm>
         <a:graphic xmlns:a="http://schemas.openxmlformats.org/drawingml/2006/main">
           <a:graphicData uri="http://schemas.openxmlformats.org/drawingml/2006/chart">
-            <c:chart xmlns:r="http://schemas.openxmlformats.org/officeDocument/2006/relationships" xmlns:c="http://schemas.openxmlformats.org/drawingml/2006/chart" r:id="Raffd7ab425ac4ed8"/>
+            <c:chart xmlns:r="http://schemas.openxmlformats.org/officeDocument/2006/relationships" xmlns:c="http://schemas.openxmlformats.org/drawingml/2006/chart" r:id="R57251c7349884079"/>
           </a:graphicData>
         </a:graphic>
       </p:graphicFrame>
@@ -20676,7 +20676,7 @@
           <p:cNvPr id="5" name="">
             <a:extLst xmlns:a="http://schemas.openxmlformats.org/drawingml/2006/main">
               <a:ext uri="{FF2B5EF4-FFF2-40B4-BE49-F238E27FC236}">
-                <a16:creationId xmlns:a16="http://schemas.microsoft.com/office/drawing/2014/main" id="{9BFB3EDF-855B-4605-9B02-41727417BA69}"/>
+                <a16:creationId xmlns:a16="http://schemas.microsoft.com/office/drawing/2014/main" id="{69722A52-03B6-4F14-825B-AEDF07802712}"/>
               </a:ext>
             </a:extLst>
           </p:cNvPr>
@@ -20833,7 +20833,7 @@
           <p:cNvPr id="6" name="">
             <a:extLst xmlns:a="http://schemas.openxmlformats.org/drawingml/2006/main">
               <a:ext uri="{FF2B5EF4-FFF2-40B4-BE49-F238E27FC236}">
-                <a16:creationId xmlns:a16="http://schemas.microsoft.com/office/drawing/2014/main" id="{3A1E2A7F-162E-4F9A-A7EA-30061948E6B3}"/>
+                <a16:creationId xmlns:a16="http://schemas.microsoft.com/office/drawing/2014/main" id="{3839B158-778B-4332-96EE-748E24B7B66C}"/>
               </a:ext>
             </a:extLst>
           </p:cNvPr>
@@ -21036,7 +21036,7 @@
           <p:cNvPr id="7" name="">
             <a:extLst xmlns:a="http://schemas.openxmlformats.org/drawingml/2006/main">
               <a:ext uri="{FF2B5EF4-FFF2-40B4-BE49-F238E27FC236}">
-                <a16:creationId xmlns:a16="http://schemas.microsoft.com/office/drawing/2014/main" id="{39472697-926F-4D1B-B203-417646FD62EB}"/>
+                <a16:creationId xmlns:a16="http://schemas.microsoft.com/office/drawing/2014/main" id="{C562CD0F-ECB4-467E-B459-67B11B9CC121}"/>
               </a:ext>
             </a:extLst>
           </p:cNvPr>
@@ -21216,7 +21216,7 @@
           <p:cNvPr id="8" name="">
             <a:extLst xmlns:a="http://schemas.openxmlformats.org/drawingml/2006/main">
               <a:ext uri="{FF2B5EF4-FFF2-40B4-BE49-F238E27FC236}">
-                <a16:creationId xmlns:a16="http://schemas.microsoft.com/office/drawing/2014/main" id="{0F6316E7-DBB9-4967-AE37-60A8CBC847AD}"/>
+                <a16:creationId xmlns:a16="http://schemas.microsoft.com/office/drawing/2014/main" id="{2AA10A0A-BEF3-4F7A-915B-7FF93EA46CF4}"/>
               </a:ext>
             </a:extLst>
           </p:cNvPr>
@@ -21371,7 +21371,7 @@
     </p:spTree>
     <p:extLst>
       <p:ext uri="{BB962C8B-B14F-4D97-AF65-F5344CB8AC3E}">
-        <p14:creationId xmlns:p14="http://schemas.microsoft.com/office/powerpoint/2010/main" val="1467365695"/>
+        <p14:creationId xmlns:p14="http://schemas.microsoft.com/office/powerpoint/2010/main" val="1298631063"/>
       </p:ext>
     </p:extLst>
   </p:cSld>
@@ -21402,7 +21402,7 @@
           <p:cNvPr id="32" name="">
             <a:extLst xmlns:a="http://schemas.openxmlformats.org/drawingml/2006/main">
               <a:ext uri="{FF2B5EF4-FFF2-40B4-BE49-F238E27FC236}">
-                <a16:creationId xmlns:a16="http://schemas.microsoft.com/office/drawing/2014/main" id="{7C4EA1B4-7E57-4437-BD1B-F15E57BB0B1C}"/>
+                <a16:creationId xmlns:a16="http://schemas.microsoft.com/office/drawing/2014/main" id="{DBB4B4E2-B5A4-4859-B701-5368DF2CE34C}"/>
               </a:ext>
             </a:extLst>
           </p:cNvPr>
@@ -21549,7 +21549,7 @@
                 <a:ea typeface="Arial"/>
                 <a:cs typeface="Arial"/>
               </a:rPr>
-              <a:t>AI agent architecture: implemented and planned</a:t>
+              <a:t>Agent architecture and live LLM pilot</a:t>
             </a:r>
           </a:p>
         </p:txBody>
@@ -21559,7 +21559,7 @@
           <p:cNvPr id="2" name="">
             <a:extLst xmlns:a="http://schemas.openxmlformats.org/drawingml/2006/main">
               <a:ext uri="{FF2B5EF4-FFF2-40B4-BE49-F238E27FC236}">
-                <a16:creationId xmlns:a16="http://schemas.microsoft.com/office/drawing/2014/main" id="{039C4DD4-ADD1-4923-8A26-A2F8FF4739F9}"/>
+                <a16:creationId xmlns:a16="http://schemas.microsoft.com/office/drawing/2014/main" id="{5AE286B6-DA19-4DF5-BF2D-29A4AA2F4254}"/>
               </a:ext>
             </a:extLst>
           </p:cNvPr>
@@ -21590,7 +21590,7 @@
           <p:cNvPr id="3" name="">
             <a:extLst xmlns:a="http://schemas.openxmlformats.org/drawingml/2006/main">
               <a:ext uri="{FF2B5EF4-FFF2-40B4-BE49-F238E27FC236}">
-                <a16:creationId xmlns:a16="http://schemas.microsoft.com/office/drawing/2014/main" id="{654CB6DF-B8EB-4E08-8950-6F6A704F194B}"/>
+                <a16:creationId xmlns:a16="http://schemas.microsoft.com/office/drawing/2014/main" id="{B3D0FC1B-0613-4B62-A184-5CF646DA201A}"/>
               </a:ext>
             </a:extLst>
           </p:cNvPr>
@@ -21747,7 +21747,7 @@
           <p:cNvPr id="4" name="">
             <a:extLst xmlns:a="http://schemas.openxmlformats.org/drawingml/2006/main">
               <a:ext uri="{FF2B5EF4-FFF2-40B4-BE49-F238E27FC236}">
-                <a16:creationId xmlns:a16="http://schemas.microsoft.com/office/drawing/2014/main" id="{0AAB9F11-F63C-4443-8DE9-4FB7FA26FC16}"/>
+                <a16:creationId xmlns:a16="http://schemas.microsoft.com/office/drawing/2014/main" id="{ED7BD71B-950E-42BB-8277-C1689FECBBB6}"/>
               </a:ext>
             </a:extLst>
           </p:cNvPr>
@@ -21894,7 +21894,7 @@
                 <a:ea typeface="Arial"/>
                 <a:cs typeface="Arial"/>
               </a:rPr>
-              <a:t>WORKING CORE</a:t>
+              <a:t>BOUNDED AGENTIC LOOP</a:t>
             </a:r>
           </a:p>
         </p:txBody>
@@ -21904,7 +21904,7 @@
           <p:cNvPr id="5" name="">
             <a:extLst xmlns:a="http://schemas.openxmlformats.org/drawingml/2006/main">
               <a:ext uri="{FF2B5EF4-FFF2-40B4-BE49-F238E27FC236}">
-                <a16:creationId xmlns:a16="http://schemas.microsoft.com/office/drawing/2014/main" id="{FE4CC4A6-116A-4439-B54D-25F9BE3CD96D}"/>
+                <a16:creationId xmlns:a16="http://schemas.microsoft.com/office/drawing/2014/main" id="{1311B39A-8B5E-406E-848F-1DE54162D35F}"/>
               </a:ext>
             </a:extLst>
           </p:cNvPr>
@@ -21937,7 +21937,7 @@
           <p:cNvPr id="6" name="">
             <a:extLst xmlns:a="http://schemas.openxmlformats.org/drawingml/2006/main">
               <a:ext uri="{FF2B5EF4-FFF2-40B4-BE49-F238E27FC236}">
-                <a16:creationId xmlns:a16="http://schemas.microsoft.com/office/drawing/2014/main" id="{F6CB5A87-DF5B-44DB-B658-0FCC2AD5696D}"/>
+                <a16:creationId xmlns:a16="http://schemas.microsoft.com/office/drawing/2014/main" id="{9AC25C53-A266-455C-808D-0E2790607BD8}"/>
               </a:ext>
             </a:extLst>
           </p:cNvPr>
@@ -22094,7 +22094,7 @@
           <p:cNvPr id="7" name="">
             <a:extLst xmlns:a="http://schemas.openxmlformats.org/drawingml/2006/main">
               <a:ext uri="{FF2B5EF4-FFF2-40B4-BE49-F238E27FC236}">
-                <a16:creationId xmlns:a16="http://schemas.microsoft.com/office/drawing/2014/main" id="{BFD99474-62AF-443F-BD7F-CD28D9C0DDB4}"/>
+                <a16:creationId xmlns:a16="http://schemas.microsoft.com/office/drawing/2014/main" id="{92A7823A-3496-4E0C-A5CF-8660828A71F1}"/>
               </a:ext>
             </a:extLst>
           </p:cNvPr>
@@ -22274,7 +22274,7 @@
           <p:cNvPr id="8" name="">
             <a:extLst xmlns:a="http://schemas.openxmlformats.org/drawingml/2006/main">
               <a:ext uri="{FF2B5EF4-FFF2-40B4-BE49-F238E27FC236}">
-                <a16:creationId xmlns:a16="http://schemas.microsoft.com/office/drawing/2014/main" id="{2C637E2E-B8D5-4903-977A-9058EA1D5A4C}"/>
+                <a16:creationId xmlns:a16="http://schemas.microsoft.com/office/drawing/2014/main" id="{3C3C3BAA-CC9A-4414-8F71-848E39612631}"/>
               </a:ext>
             </a:extLst>
           </p:cNvPr>
@@ -22305,7 +22305,7 @@
           <p:cNvPr id="9" name="">
             <a:extLst xmlns:a="http://schemas.openxmlformats.org/drawingml/2006/main">
               <a:ext uri="{FF2B5EF4-FFF2-40B4-BE49-F238E27FC236}">
-                <a16:creationId xmlns:a16="http://schemas.microsoft.com/office/drawing/2014/main" id="{7C3FFA60-67BF-4A55-8C56-7CD8F165538B}"/>
+                <a16:creationId xmlns:a16="http://schemas.microsoft.com/office/drawing/2014/main" id="{785B3232-70F8-488C-962C-0FD7E21D7F1C}"/>
               </a:ext>
             </a:extLst>
           </p:cNvPr>
@@ -22338,7 +22338,7 @@
           <p:cNvPr id="10" name="">
             <a:extLst xmlns:a="http://schemas.openxmlformats.org/drawingml/2006/main">
               <a:ext uri="{FF2B5EF4-FFF2-40B4-BE49-F238E27FC236}">
-                <a16:creationId xmlns:a16="http://schemas.microsoft.com/office/drawing/2014/main" id="{BC48235C-C345-4362-8D01-25670CAD7D3A}"/>
+                <a16:creationId xmlns:a16="http://schemas.microsoft.com/office/drawing/2014/main" id="{AD6FDA9C-6729-4BD3-978A-209977E2EB68}"/>
               </a:ext>
             </a:extLst>
           </p:cNvPr>
@@ -22495,7 +22495,7 @@
           <p:cNvPr id="11" name="">
             <a:extLst xmlns:a="http://schemas.openxmlformats.org/drawingml/2006/main">
               <a:ext uri="{FF2B5EF4-FFF2-40B4-BE49-F238E27FC236}">
-                <a16:creationId xmlns:a16="http://schemas.microsoft.com/office/drawing/2014/main" id="{03008F08-BC59-4720-BFF5-F9BF0C6E70F9}"/>
+                <a16:creationId xmlns:a16="http://schemas.microsoft.com/office/drawing/2014/main" id="{CD290FEB-CD0A-4DDB-A6FD-0C56EEDE2FE2}"/>
               </a:ext>
             </a:extLst>
           </p:cNvPr>
@@ -22642,7 +22642,7 @@
                 <a:ea typeface="Arial"/>
                 <a:cs typeface="Arial"/>
               </a:rPr>
-              <a:t>Structured outputs</a:t>
+              <a:t>Function calling</a:t>
             </a:r>
           </a:p>
           <a:p xmlns:a="http://schemas.openxmlformats.org/drawingml/2006/main">
@@ -22665,7 +22665,7 @@
                 <a:ea typeface="Arial"/>
                 <a:cs typeface="Arial"/>
               </a:rPr>
-              <a:t>Function calling</a:t>
+              <a:t>Routing tested offline</a:t>
             </a:r>
           </a:p>
         </p:txBody>
@@ -22675,7 +22675,7 @@
           <p:cNvPr id="12" name="">
             <a:extLst xmlns:a="http://schemas.openxmlformats.org/drawingml/2006/main">
               <a:ext uri="{FF2B5EF4-FFF2-40B4-BE49-F238E27FC236}">
-                <a16:creationId xmlns:a16="http://schemas.microsoft.com/office/drawing/2014/main" id="{31918A14-6498-48E9-A81D-D662CBE5E2F7}"/>
+                <a16:creationId xmlns:a16="http://schemas.microsoft.com/office/drawing/2014/main" id="{FF76E606-DADA-42B5-B390-180BCC9F7821}"/>
               </a:ext>
             </a:extLst>
           </p:cNvPr>
@@ -22706,7 +22706,7 @@
           <p:cNvPr id="13" name="">
             <a:extLst xmlns:a="http://schemas.openxmlformats.org/drawingml/2006/main">
               <a:ext uri="{FF2B5EF4-FFF2-40B4-BE49-F238E27FC236}">
-                <a16:creationId xmlns:a16="http://schemas.microsoft.com/office/drawing/2014/main" id="{4B42574A-B697-4A26-B472-36E749E30857}"/>
+                <a16:creationId xmlns:a16="http://schemas.microsoft.com/office/drawing/2014/main" id="{2AC10A38-46E7-4A63-9112-79E473E81815}"/>
               </a:ext>
             </a:extLst>
           </p:cNvPr>
@@ -22739,7 +22739,7 @@
           <p:cNvPr id="14" name="">
             <a:extLst xmlns:a="http://schemas.openxmlformats.org/drawingml/2006/main">
               <a:ext uri="{FF2B5EF4-FFF2-40B4-BE49-F238E27FC236}">
-                <a16:creationId xmlns:a16="http://schemas.microsoft.com/office/drawing/2014/main" id="{810D161B-F4B3-4921-B635-F238454633D9}"/>
+                <a16:creationId xmlns:a16="http://schemas.microsoft.com/office/drawing/2014/main" id="{06C12FF5-468C-47BA-B74D-98F0F26DE7DF}"/>
               </a:ext>
             </a:extLst>
           </p:cNvPr>
@@ -22896,7 +22896,7 @@
           <p:cNvPr id="15" name="">
             <a:extLst xmlns:a="http://schemas.openxmlformats.org/drawingml/2006/main">
               <a:ext uri="{FF2B5EF4-FFF2-40B4-BE49-F238E27FC236}">
-                <a16:creationId xmlns:a16="http://schemas.microsoft.com/office/drawing/2014/main" id="{FB083D02-4218-49AE-877F-4DA392710793}"/>
+                <a16:creationId xmlns:a16="http://schemas.microsoft.com/office/drawing/2014/main" id="{5250D05E-F324-4F89-B1FA-AEECE0DA2F7F}"/>
               </a:ext>
             </a:extLst>
           </p:cNvPr>
@@ -23076,7 +23076,7 @@
           <p:cNvPr id="16" name="">
             <a:extLst xmlns:a="http://schemas.openxmlformats.org/drawingml/2006/main">
               <a:ext uri="{FF2B5EF4-FFF2-40B4-BE49-F238E27FC236}">
-                <a16:creationId xmlns:a16="http://schemas.microsoft.com/office/drawing/2014/main" id="{211B8142-F11D-4260-BA82-4E00AF58B65A}"/>
+                <a16:creationId xmlns:a16="http://schemas.microsoft.com/office/drawing/2014/main" id="{F0FBF785-6F4B-49C8-8013-6001962DADE0}"/>
               </a:ext>
             </a:extLst>
           </p:cNvPr>
@@ -23107,7 +23107,7 @@
           <p:cNvPr id="17" name="">
             <a:extLst xmlns:a="http://schemas.openxmlformats.org/drawingml/2006/main">
               <a:ext uri="{FF2B5EF4-FFF2-40B4-BE49-F238E27FC236}">
-                <a16:creationId xmlns:a16="http://schemas.microsoft.com/office/drawing/2014/main" id="{06EDD9F3-C591-4905-840A-0EB12B75DEA4}"/>
+                <a16:creationId xmlns:a16="http://schemas.microsoft.com/office/drawing/2014/main" id="{EAC53F8A-2D87-48ED-8F8C-10E679422600}"/>
               </a:ext>
             </a:extLst>
           </p:cNvPr>
@@ -23140,7 +23140,7 @@
           <p:cNvPr id="18" name="">
             <a:extLst xmlns:a="http://schemas.openxmlformats.org/drawingml/2006/main">
               <a:ext uri="{FF2B5EF4-FFF2-40B4-BE49-F238E27FC236}">
-                <a16:creationId xmlns:a16="http://schemas.microsoft.com/office/drawing/2014/main" id="{42D9594C-4845-4F97-BFE7-E47059F9E770}"/>
+                <a16:creationId xmlns:a16="http://schemas.microsoft.com/office/drawing/2014/main" id="{DE4179FA-C7D1-4636-8E97-AC594548560F}"/>
               </a:ext>
             </a:extLst>
           </p:cNvPr>
@@ -23287,7 +23287,7 @@
                 <a:ea typeface="Arial"/>
                 <a:cs typeface="Arial"/>
               </a:rPr>
-              <a:t>Agent memory</a:t>
+              <a:t>Episode memory</a:t>
             </a:r>
           </a:p>
         </p:txBody>
@@ -23297,7 +23297,7 @@
           <p:cNvPr id="19" name="">
             <a:extLst xmlns:a="http://schemas.openxmlformats.org/drawingml/2006/main">
               <a:ext uri="{FF2B5EF4-FFF2-40B4-BE49-F238E27FC236}">
-                <a16:creationId xmlns:a16="http://schemas.microsoft.com/office/drawing/2014/main" id="{69837D50-0605-4E93-87D2-25C5407DE9B7}"/>
+                <a16:creationId xmlns:a16="http://schemas.microsoft.com/office/drawing/2014/main" id="{37D6CD5A-1F65-423A-BB75-9DEB89B8C389}"/>
               </a:ext>
             </a:extLst>
           </p:cNvPr>
@@ -23444,7 +23444,7 @@
                 <a:ea typeface="Arial"/>
                 <a:cs typeface="Arial"/>
               </a:rPr>
-              <a:t>Cycles, area, timing</a:t>
+              <a:t>Paid results</a:t>
             </a:r>
           </a:p>
           <a:p xmlns:a="http://schemas.openxmlformats.org/drawingml/2006/main">
@@ -23467,7 +23467,7 @@
                 <a:ea typeface="Arial"/>
                 <a:cs typeface="Arial"/>
               </a:rPr>
-              <a:t>Persistent ledger</a:t>
+              <a:t>Best feasible design</a:t>
             </a:r>
           </a:p>
         </p:txBody>
@@ -23477,7 +23477,7 @@
           <p:cNvPr id="20" name="">
             <a:extLst xmlns:a="http://schemas.openxmlformats.org/drawingml/2006/main">
               <a:ext uri="{FF2B5EF4-FFF2-40B4-BE49-F238E27FC236}">
-                <a16:creationId xmlns:a16="http://schemas.microsoft.com/office/drawing/2014/main" id="{928DCEFA-20E6-4942-8CB5-5329E0D9C1AF}"/>
+                <a16:creationId xmlns:a16="http://schemas.microsoft.com/office/drawing/2014/main" id="{405626F2-EC26-4408-97C3-A43BEE252EF4}"/>
               </a:ext>
             </a:extLst>
           </p:cNvPr>
@@ -23508,7 +23508,7 @@
           <p:cNvPr id="21" name="">
             <a:extLst xmlns:a="http://schemas.openxmlformats.org/drawingml/2006/main">
               <a:ext uri="{FF2B5EF4-FFF2-40B4-BE49-F238E27FC236}">
-                <a16:creationId xmlns:a16="http://schemas.microsoft.com/office/drawing/2014/main" id="{D72D2221-ED6D-48E8-BF7E-3C6ABD77D896}"/>
+                <a16:creationId xmlns:a16="http://schemas.microsoft.com/office/drawing/2014/main" id="{B6F75E46-F041-4187-8CBA-7A365B0E3F7D}"/>
               </a:ext>
             </a:extLst>
           </p:cNvPr>
@@ -23539,7 +23539,7 @@
           <p:cNvPr id="22" name="">
             <a:extLst xmlns:a="http://schemas.openxmlformats.org/drawingml/2006/main">
               <a:ext uri="{FF2B5EF4-FFF2-40B4-BE49-F238E27FC236}">
-                <a16:creationId xmlns:a16="http://schemas.microsoft.com/office/drawing/2014/main" id="{B8A20A28-8871-43B8-AA13-128D7127E4CF}"/>
+                <a16:creationId xmlns:a16="http://schemas.microsoft.com/office/drawing/2014/main" id="{C5C83B03-6C26-4C51-B7D1-3717A0760B3E}"/>
               </a:ext>
             </a:extLst>
           </p:cNvPr>
@@ -23686,7 +23686,7 @@
                 <a:ea typeface="Arial"/>
                 <a:cs typeface="Arial"/>
               </a:rPr>
-              <a:t>Paid observations feed the next decision</a:t>
+              <a:t>Loop engineering: observe, act, update, stop</a:t>
             </a:r>
           </a:p>
         </p:txBody>
@@ -23696,7 +23696,7 @@
           <p:cNvPr id="23" name="">
             <a:extLst xmlns:a="http://schemas.openxmlformats.org/drawingml/2006/main">
               <a:ext uri="{FF2B5EF4-FFF2-40B4-BE49-F238E27FC236}">
-                <a16:creationId xmlns:a16="http://schemas.microsoft.com/office/drawing/2014/main" id="{A9DE638A-388C-4B39-B4FE-3329052784F3}"/>
+                <a16:creationId xmlns:a16="http://schemas.microsoft.com/office/drawing/2014/main" id="{D93F4718-6336-4AEA-AB1D-A058474E20EB}"/>
               </a:ext>
             </a:extLst>
           </p:cNvPr>
@@ -23727,7 +23727,7 @@
           <p:cNvPr id="24" name="">
             <a:extLst xmlns:a="http://schemas.openxmlformats.org/drawingml/2006/main">
               <a:ext uri="{FF2B5EF4-FFF2-40B4-BE49-F238E27FC236}">
-                <a16:creationId xmlns:a16="http://schemas.microsoft.com/office/drawing/2014/main" id="{291CC844-D9A7-4797-9D61-6F0860935792}"/>
+                <a16:creationId xmlns:a16="http://schemas.microsoft.com/office/drawing/2014/main" id="{AE55F372-D425-44D5-A730-988D74C0212D}"/>
               </a:ext>
             </a:extLst>
           </p:cNvPr>
@@ -23756,7 +23756,7 @@
             <a:defPPr>
               <a:defRPr sz="1725" b="1">
                 <a:solidFill>
-                  <a:srgbClr val="A65A00"/>
+                  <a:srgbClr val="2878A8"/>
                 </a:solidFill>
                 <a:latin typeface="Arial"/>
                 <a:ea typeface="Arial"/>
@@ -23766,7 +23766,7 @@
             <a:lvl1pPr>
               <a:defRPr sz="1725" b="1">
                 <a:solidFill>
-                  <a:srgbClr val="A65A00"/>
+                  <a:srgbClr val="2878A8"/>
                 </a:solidFill>
                 <a:latin typeface="Arial"/>
                 <a:ea typeface="Arial"/>
@@ -23776,7 +23776,7 @@
             <a:lvl2pPr>
               <a:defRPr sz="1725" b="1">
                 <a:solidFill>
-                  <a:srgbClr val="A65A00"/>
+                  <a:srgbClr val="2878A8"/>
                 </a:solidFill>
                 <a:latin typeface="Arial"/>
                 <a:ea typeface="Arial"/>
@@ -23786,7 +23786,7 @@
             <a:lvl3pPr>
               <a:defRPr sz="1725" b="1">
                 <a:solidFill>
-                  <a:srgbClr val="A65A00"/>
+                  <a:srgbClr val="2878A8"/>
                 </a:solidFill>
                 <a:latin typeface="Arial"/>
                 <a:ea typeface="Arial"/>
@@ -23796,7 +23796,7 @@
             <a:lvl4pPr>
               <a:defRPr sz="1725" b="1">
                 <a:solidFill>
-                  <a:srgbClr val="A65A00"/>
+                  <a:srgbClr val="2878A8"/>
                 </a:solidFill>
                 <a:latin typeface="Arial"/>
                 <a:ea typeface="Arial"/>
@@ -23806,7 +23806,7 @@
             <a:lvl5pPr>
               <a:defRPr sz="1725" b="1">
                 <a:solidFill>
-                  <a:srgbClr val="A65A00"/>
+                  <a:srgbClr val="2878A8"/>
                 </a:solidFill>
                 <a:latin typeface="Arial"/>
                 <a:ea typeface="Arial"/>
@@ -23816,7 +23816,7 @@
             <a:lvl6pPr>
               <a:defRPr sz="1725" b="1">
                 <a:solidFill>
-                  <a:srgbClr val="A65A00"/>
+                  <a:srgbClr val="2878A8"/>
                 </a:solidFill>
                 <a:latin typeface="Arial"/>
                 <a:ea typeface="Arial"/>
@@ -23826,7 +23826,7 @@
             <a:lvl7pPr>
               <a:defRPr sz="1725" b="1">
                 <a:solidFill>
-                  <a:srgbClr val="A65A00"/>
+                  <a:srgbClr val="2878A8"/>
                 </a:solidFill>
                 <a:latin typeface="Arial"/>
                 <a:ea typeface="Arial"/>
@@ -23836,7 +23836,7 @@
             <a:lvl8pPr>
               <a:defRPr sz="1725" b="1">
                 <a:solidFill>
-                  <a:srgbClr val="A65A00"/>
+                  <a:srgbClr val="2878A8"/>
                 </a:solidFill>
                 <a:latin typeface="Arial"/>
                 <a:ea typeface="Arial"/>
@@ -23846,7 +23846,7 @@
             <a:lvl9pPr>
               <a:defRPr sz="1725" b="1">
                 <a:solidFill>
-                  <a:srgbClr val="A65A00"/>
+                  <a:srgbClr val="2878A8"/>
                 </a:solidFill>
                 <a:latin typeface="Arial"/>
                 <a:ea typeface="Arial"/>
@@ -23858,7 +23858,7 @@
             <a:pPr>
               <a:defRPr sz="1725" b="1">
                 <a:solidFill>
-                  <a:srgbClr val="A65A00"/>
+                  <a:srgbClr val="2878A8"/>
                 </a:solidFill>
                 <a:latin typeface="Arial"/>
                 <a:ea typeface="Arial"/>
@@ -23868,13 +23868,13 @@
             <a:r>
               <a:rPr sz="1725" b="1">
                 <a:solidFill>
-                  <a:srgbClr val="A65A00"/>
+                  <a:srgbClr val="2878A8"/>
                 </a:solidFill>
                 <a:latin typeface="Arial"/>
                 <a:ea typeface="Arial"/>
                 <a:cs typeface="Arial"/>
               </a:rPr>
-              <a:t>PLANNED DECISION LAYER</a:t>
+              <a:t>HISTORICAL MEMORY</a:t>
             </a:r>
           </a:p>
         </p:txBody>
@@ -23884,7 +23884,7 @@
           <p:cNvPr id="25" name="">
             <a:extLst xmlns:a="http://schemas.openxmlformats.org/drawingml/2006/main">
               <a:ext uri="{FF2B5EF4-FFF2-40B4-BE49-F238E27FC236}">
-                <a16:creationId xmlns:a16="http://schemas.microsoft.com/office/drawing/2014/main" id="{BFCD71AC-5E2E-42C6-BACA-318DB1CF2F86}"/>
+                <a16:creationId xmlns:a16="http://schemas.microsoft.com/office/drawing/2014/main" id="{92ACEECE-4E78-401A-BE83-10206741EF08}"/>
               </a:ext>
             </a:extLst>
           </p:cNvPr>
@@ -24031,7 +24031,7 @@
                 <a:ea typeface="Arial"/>
                 <a:cs typeface="Arial"/>
               </a:rPr>
-              <a:t>Context window + token budget</a:t>
+              <a:t>Lexical + latent-semantic search</a:t>
             </a:r>
           </a:p>
           <a:p xmlns:a="http://schemas.openxmlformats.org/drawingml/2006/main">
@@ -24054,7 +24054,7 @@
                 <a:ea typeface="Arial"/>
                 <a:cs typeface="Arial"/>
               </a:rPr>
-              <a:t>Small LLM → escalate → strong LLM</a:t>
+              <a:t>Rank fusion feeds approved evidence</a:t>
             </a:r>
           </a:p>
         </p:txBody>
@@ -24064,7 +24064,7 @@
           <p:cNvPr id="26" name="">
             <a:extLst xmlns:a="http://schemas.openxmlformats.org/drawingml/2006/main">
               <a:ext uri="{FF2B5EF4-FFF2-40B4-BE49-F238E27FC236}">
-                <a16:creationId xmlns:a16="http://schemas.microsoft.com/office/drawing/2014/main" id="{47EFA70A-10E9-45EC-A888-827CE5512827}"/>
+                <a16:creationId xmlns:a16="http://schemas.microsoft.com/office/drawing/2014/main" id="{AE6DD6C2-D603-440E-AB60-298660029A33}"/>
               </a:ext>
             </a:extLst>
           </p:cNvPr>
@@ -24093,7 +24093,7 @@
             <a:defPPr>
               <a:defRPr sz="1725" b="1">
                 <a:solidFill>
-                  <a:srgbClr val="A65A00"/>
+                  <a:srgbClr val="2878A8"/>
                 </a:solidFill>
                 <a:latin typeface="Arial"/>
                 <a:ea typeface="Arial"/>
@@ -24103,7 +24103,7 @@
             <a:lvl1pPr>
               <a:defRPr sz="1725" b="1">
                 <a:solidFill>
-                  <a:srgbClr val="A65A00"/>
+                  <a:srgbClr val="2878A8"/>
                 </a:solidFill>
                 <a:latin typeface="Arial"/>
                 <a:ea typeface="Arial"/>
@@ -24113,7 +24113,7 @@
             <a:lvl2pPr>
               <a:defRPr sz="1725" b="1">
                 <a:solidFill>
-                  <a:srgbClr val="A65A00"/>
+                  <a:srgbClr val="2878A8"/>
                 </a:solidFill>
                 <a:latin typeface="Arial"/>
                 <a:ea typeface="Arial"/>
@@ -24123,7 +24123,7 @@
             <a:lvl3pPr>
               <a:defRPr sz="1725" b="1">
                 <a:solidFill>
-                  <a:srgbClr val="A65A00"/>
+                  <a:srgbClr val="2878A8"/>
                 </a:solidFill>
                 <a:latin typeface="Arial"/>
                 <a:ea typeface="Arial"/>
@@ -24133,7 +24133,7 @@
             <a:lvl4pPr>
               <a:defRPr sz="1725" b="1">
                 <a:solidFill>
-                  <a:srgbClr val="A65A00"/>
+                  <a:srgbClr val="2878A8"/>
                 </a:solidFill>
                 <a:latin typeface="Arial"/>
                 <a:ea typeface="Arial"/>
@@ -24143,7 +24143,7 @@
             <a:lvl5pPr>
               <a:defRPr sz="1725" b="1">
                 <a:solidFill>
-                  <a:srgbClr val="A65A00"/>
+                  <a:srgbClr val="2878A8"/>
                 </a:solidFill>
                 <a:latin typeface="Arial"/>
                 <a:ea typeface="Arial"/>
@@ -24153,7 +24153,7 @@
             <a:lvl6pPr>
               <a:defRPr sz="1725" b="1">
                 <a:solidFill>
-                  <a:srgbClr val="A65A00"/>
+                  <a:srgbClr val="2878A8"/>
                 </a:solidFill>
                 <a:latin typeface="Arial"/>
                 <a:ea typeface="Arial"/>
@@ -24163,7 +24163,7 @@
             <a:lvl7pPr>
               <a:defRPr sz="1725" b="1">
                 <a:solidFill>
-                  <a:srgbClr val="A65A00"/>
+                  <a:srgbClr val="2878A8"/>
                 </a:solidFill>
                 <a:latin typeface="Arial"/>
                 <a:ea typeface="Arial"/>
@@ -24173,7 +24173,7 @@
             <a:lvl8pPr>
               <a:defRPr sz="1725" b="1">
                 <a:solidFill>
-                  <a:srgbClr val="A65A00"/>
+                  <a:srgbClr val="2878A8"/>
                 </a:solidFill>
                 <a:latin typeface="Arial"/>
                 <a:ea typeface="Arial"/>
@@ -24183,7 +24183,7 @@
             <a:lvl9pPr>
               <a:defRPr sz="1725" b="1">
                 <a:solidFill>
-                  <a:srgbClr val="A65A00"/>
+                  <a:srgbClr val="2878A8"/>
                 </a:solidFill>
                 <a:latin typeface="Arial"/>
                 <a:ea typeface="Arial"/>
@@ -24195,7 +24195,7 @@
             <a:pPr>
               <a:defRPr sz="1725" b="1">
                 <a:solidFill>
-                  <a:srgbClr val="A65A00"/>
+                  <a:srgbClr val="2878A8"/>
                 </a:solidFill>
                 <a:latin typeface="Arial"/>
                 <a:ea typeface="Arial"/>
@@ -24205,13 +24205,13 @@
             <a:r>
               <a:rPr sz="1725" b="1">
                 <a:solidFill>
-                  <a:srgbClr val="A65A00"/>
+                  <a:srgbClr val="2878A8"/>
                 </a:solidFill>
                 <a:latin typeface="Arial"/>
                 <a:ea typeface="Arial"/>
                 <a:cs typeface="Arial"/>
               </a:rPr>
-              <a:t>OPTIONAL KNOWLEDGE LAYER</a:t>
+              <a:t>LLMOPS + OBSERVABILITY</a:t>
             </a:r>
           </a:p>
         </p:txBody>
@@ -24221,7 +24221,7 @@
           <p:cNvPr id="27" name="">
             <a:extLst xmlns:a="http://schemas.openxmlformats.org/drawingml/2006/main">
               <a:ext uri="{FF2B5EF4-FFF2-40B4-BE49-F238E27FC236}">
-                <a16:creationId xmlns:a16="http://schemas.microsoft.com/office/drawing/2014/main" id="{7A855CDF-D2F5-450C-9EB5-39055A3182FC}"/>
+                <a16:creationId xmlns:a16="http://schemas.microsoft.com/office/drawing/2014/main" id="{64E15A73-64F7-48EF-9C48-0368C6459B11}"/>
               </a:ext>
             </a:extLst>
           </p:cNvPr>
@@ -24368,7 +24368,7 @@
                 <a:ea typeface="Arial"/>
                 <a:cs typeface="Arial"/>
               </a:rPr>
-              <a:t>Approved history → chunk + embed</a:t>
+              <a:t>Versioned runs and offline evaluation</a:t>
             </a:r>
           </a:p>
           <a:p xmlns:a="http://schemas.openxmlformats.org/drawingml/2006/main">
@@ -24391,7 +24391,7 @@
                 <a:ea typeface="Arial"/>
                 <a:cs typeface="Arial"/>
               </a:rPr>
-              <a:t>Hybrid search → rerank → RAG context</a:t>
+              <a:t>SQLite: decisions, calls, tools, results</a:t>
             </a:r>
           </a:p>
         </p:txBody>
@@ -24401,7 +24401,7 @@
           <p:cNvPr id="28" name="">
             <a:extLst xmlns:a="http://schemas.openxmlformats.org/drawingml/2006/main">
               <a:ext uri="{FF2B5EF4-FFF2-40B4-BE49-F238E27FC236}">
-                <a16:creationId xmlns:a16="http://schemas.microsoft.com/office/drawing/2014/main" id="{E47F65BF-4BE8-4959-95B8-B18E11451F44}"/>
+                <a16:creationId xmlns:a16="http://schemas.microsoft.com/office/drawing/2014/main" id="{CA7C42F5-5E63-43BF-8677-907C6DB82951}"/>
               </a:ext>
             </a:extLst>
           </p:cNvPr>
@@ -24548,7 +24548,7 @@
                 <a:ea typeface="Arial"/>
                 <a:cs typeface="Arial"/>
               </a:rPr>
-              <a:t>Both feed the LLM decision. Hidden target outcomes stay excluded.</a:t>
+              <a:t>Source hashes and tool traces; live token counts and inference latency unavailable</a:t>
             </a:r>
           </a:p>
         </p:txBody>
@@ -24558,7 +24558,7 @@
           <p:cNvPr id="29" name="">
             <a:extLst xmlns:a="http://schemas.openxmlformats.org/drawingml/2006/main">
               <a:ext uri="{FF2B5EF4-FFF2-40B4-BE49-F238E27FC236}">
-                <a16:creationId xmlns:a16="http://schemas.microsoft.com/office/drawing/2014/main" id="{BFE834BB-43F6-4508-A1BA-4BC8E4F8015A}"/>
+                <a16:creationId xmlns:a16="http://schemas.microsoft.com/office/drawing/2014/main" id="{A31B2FB8-F128-406C-B559-1DEFDEFD811C}"/>
               </a:ext>
             </a:extLst>
           </p:cNvPr>
@@ -24589,7 +24589,7 @@
           <p:cNvPr id="30" name="">
             <a:extLst xmlns:a="http://schemas.openxmlformats.org/drawingml/2006/main">
               <a:ext uri="{FF2B5EF4-FFF2-40B4-BE49-F238E27FC236}">
-                <a16:creationId xmlns:a16="http://schemas.microsoft.com/office/drawing/2014/main" id="{AC8AEC06-3CAA-430C-A3ED-AA3A4830630C}"/>
+                <a16:creationId xmlns:a16="http://schemas.microsoft.com/office/drawing/2014/main" id="{F8BBE761-EDCB-4521-B6D0-4199D9C2653E}"/>
               </a:ext>
             </a:extLst>
           </p:cNvPr>
@@ -24618,7 +24618,7 @@
             <a:defPPr>
               <a:defRPr sz="1875" b="1">
                 <a:solidFill>
-                  <a:srgbClr val="17324D"/>
+                  <a:srgbClr val="A65A00"/>
                 </a:solidFill>
                 <a:latin typeface="Arial"/>
                 <a:ea typeface="Arial"/>
@@ -24628,7 +24628,7 @@
             <a:lvl1pPr>
               <a:defRPr sz="1875" b="1">
                 <a:solidFill>
-                  <a:srgbClr val="17324D"/>
+                  <a:srgbClr val="A65A00"/>
                 </a:solidFill>
                 <a:latin typeface="Arial"/>
                 <a:ea typeface="Arial"/>
@@ -24638,7 +24638,7 @@
             <a:lvl2pPr>
               <a:defRPr sz="1875" b="1">
                 <a:solidFill>
-                  <a:srgbClr val="17324D"/>
+                  <a:srgbClr val="A65A00"/>
                 </a:solidFill>
                 <a:latin typeface="Arial"/>
                 <a:ea typeface="Arial"/>
@@ -24648,7 +24648,7 @@
             <a:lvl3pPr>
               <a:defRPr sz="1875" b="1">
                 <a:solidFill>
-                  <a:srgbClr val="17324D"/>
+                  <a:srgbClr val="A65A00"/>
                 </a:solidFill>
                 <a:latin typeface="Arial"/>
                 <a:ea typeface="Arial"/>
@@ -24658,7 +24658,7 @@
             <a:lvl4pPr>
               <a:defRPr sz="1875" b="1">
                 <a:solidFill>
-                  <a:srgbClr val="17324D"/>
+                  <a:srgbClr val="A65A00"/>
                 </a:solidFill>
                 <a:latin typeface="Arial"/>
                 <a:ea typeface="Arial"/>
@@ -24668,7 +24668,7 @@
             <a:lvl5pPr>
               <a:defRPr sz="1875" b="1">
                 <a:solidFill>
-                  <a:srgbClr val="17324D"/>
+                  <a:srgbClr val="A65A00"/>
                 </a:solidFill>
                 <a:latin typeface="Arial"/>
                 <a:ea typeface="Arial"/>
@@ -24678,7 +24678,7 @@
             <a:lvl6pPr>
               <a:defRPr sz="1875" b="1">
                 <a:solidFill>
-                  <a:srgbClr val="17324D"/>
+                  <a:srgbClr val="A65A00"/>
                 </a:solidFill>
                 <a:latin typeface="Arial"/>
                 <a:ea typeface="Arial"/>
@@ -24688,7 +24688,7 @@
             <a:lvl7pPr>
               <a:defRPr sz="1875" b="1">
                 <a:solidFill>
-                  <a:srgbClr val="17324D"/>
+                  <a:srgbClr val="A65A00"/>
                 </a:solidFill>
                 <a:latin typeface="Arial"/>
                 <a:ea typeface="Arial"/>
@@ -24698,7 +24698,7 @@
             <a:lvl8pPr>
               <a:defRPr sz="1875" b="1">
                 <a:solidFill>
-                  <a:srgbClr val="17324D"/>
+                  <a:srgbClr val="A65A00"/>
                 </a:solidFill>
                 <a:latin typeface="Arial"/>
                 <a:ea typeface="Arial"/>
@@ -24708,7 +24708,7 @@
             <a:lvl9pPr>
               <a:defRPr sz="1875" b="1">
                 <a:solidFill>
-                  <a:srgbClr val="17324D"/>
+                  <a:srgbClr val="A65A00"/>
                 </a:solidFill>
                 <a:latin typeface="Arial"/>
                 <a:ea typeface="Arial"/>
@@ -24720,7 +24720,7 @@
             <a:pPr>
               <a:defRPr sz="1875" b="1">
                 <a:solidFill>
-                  <a:srgbClr val="17324D"/>
+                  <a:srgbClr val="A65A00"/>
                 </a:solidFill>
                 <a:latin typeface="Arial"/>
                 <a:ea typeface="Arial"/>
@@ -24730,13 +24730,13 @@
             <a:r>
               <a:rPr sz="1875" b="1">
                 <a:solidFill>
-                  <a:srgbClr val="17324D"/>
+                  <a:srgbClr val="A65A00"/>
                 </a:solidFill>
                 <a:latin typeface="Arial"/>
                 <a:ea typeface="Arial"/>
                 <a:cs typeface="Arial"/>
               </a:rPr>
-              <a:t>LLMOps plan: version → evaluate → monitor → deploy</a:t>
+              <a:t>Live Luna: 3 vs 2 queries, both reach 1.0214× speedup</a:t>
             </a:r>
           </a:p>
         </p:txBody>
@@ -24746,7 +24746,7 @@
           <p:cNvPr id="31" name="">
             <a:extLst xmlns:a="http://schemas.openxmlformats.org/drawingml/2006/main">
               <a:ext uri="{FF2B5EF4-FFF2-40B4-BE49-F238E27FC236}">
-                <a16:creationId xmlns:a16="http://schemas.microsoft.com/office/drawing/2014/main" id="{BD3FCDD6-2607-4778-B51B-EE39F1CE058F}"/>
+                <a16:creationId xmlns:a16="http://schemas.microsoft.com/office/drawing/2014/main" id="{E2427DC6-83F7-483D-846D-4CABA4CC7419}"/>
               </a:ext>
             </a:extLst>
           </p:cNvPr>
@@ -24893,7 +24893,7 @@
                 <a:ea typeface="Arial"/>
                 <a:cs typeface="Arial"/>
               </a:rPr>
-              <a:t>Track feasible speedup, evaluation cost, tool errors, tokens and latency.</a:t>
+              <a:t>One trial per arm on archived SHA256. Latency/cost heuristic needs 1 query.</a:t>
             </a:r>
           </a:p>
         </p:txBody>
@@ -24901,7 +24901,7 @@
     </p:spTree>
     <p:extLst>
       <p:ext uri="{BB962C8B-B14F-4D97-AF65-F5344CB8AC3E}">
-        <p14:creationId xmlns:p14="http://schemas.microsoft.com/office/powerpoint/2010/main" val="1440399007"/>
+        <p14:creationId xmlns:p14="http://schemas.microsoft.com/office/powerpoint/2010/main" val="233536424"/>
       </p:ext>
     </p:extLst>
   </p:cSld>
@@ -24932,7 +24932,7 @@
           <p:cNvPr id="9" name="">
             <a:extLst xmlns:a="http://schemas.openxmlformats.org/drawingml/2006/main">
               <a:ext uri="{FF2B5EF4-FFF2-40B4-BE49-F238E27FC236}">
-                <a16:creationId xmlns:a16="http://schemas.microsoft.com/office/drawing/2014/main" id="{E598CAF0-D42A-4FD8-AE02-0D40A3742DC4}"/>
+                <a16:creationId xmlns:a16="http://schemas.microsoft.com/office/drawing/2014/main" id="{74453C13-6E6E-4461-948C-080060993D62}"/>
               </a:ext>
             </a:extLst>
           </p:cNvPr>
@@ -25089,7 +25089,7 @@
           <p:cNvPr id="2" name="">
             <a:extLst xmlns:a="http://schemas.openxmlformats.org/drawingml/2006/main">
               <a:ext uri="{FF2B5EF4-FFF2-40B4-BE49-F238E27FC236}">
-                <a16:creationId xmlns:a16="http://schemas.microsoft.com/office/drawing/2014/main" id="{DAABC640-715C-434F-AA22-55A0845C51DB}"/>
+                <a16:creationId xmlns:a16="http://schemas.microsoft.com/office/drawing/2014/main" id="{6BCE6DB0-F1F2-485C-BEF8-9FCFA5DFC725}"/>
               </a:ext>
             </a:extLst>
           </p:cNvPr>
@@ -25120,7 +25120,7 @@
           <p:cNvPr id="3" name="">
             <a:extLst xmlns:a="http://schemas.openxmlformats.org/drawingml/2006/main">
               <a:ext uri="{FF2B5EF4-FFF2-40B4-BE49-F238E27FC236}">
-                <a16:creationId xmlns:a16="http://schemas.microsoft.com/office/drawing/2014/main" id="{863C23D1-0A4B-4D9D-ABE7-57A1A1A9B6A8}"/>
+                <a16:creationId xmlns:a16="http://schemas.microsoft.com/office/drawing/2014/main" id="{CEA4BA58-F3E8-4430-BB84-FAD926031A1D}"/>
               </a:ext>
             </a:extLst>
           </p:cNvPr>
@@ -25277,7 +25277,7 @@
           <p:cNvPr id="4" name="">
             <a:extLst xmlns:a="http://schemas.openxmlformats.org/drawingml/2006/main">
               <a:ext uri="{FF2B5EF4-FFF2-40B4-BE49-F238E27FC236}">
-                <a16:creationId xmlns:a16="http://schemas.microsoft.com/office/drawing/2014/main" id="{1B11AD35-46BA-4C8E-864E-383F06B44164}"/>
+                <a16:creationId xmlns:a16="http://schemas.microsoft.com/office/drawing/2014/main" id="{A5EB4FBA-49A0-43CE-92D7-814953DFE089}"/>
               </a:ext>
             </a:extLst>
           </p:cNvPr>
@@ -25434,7 +25434,7 @@
           <p:cNvPr id="5" name="">
             <a:extLst xmlns:a="http://schemas.openxmlformats.org/drawingml/2006/main">
               <a:ext uri="{FF2B5EF4-FFF2-40B4-BE49-F238E27FC236}">
-                <a16:creationId xmlns:a16="http://schemas.microsoft.com/office/drawing/2014/main" id="{434023F9-6090-4268-A9D0-7857A59C0A24}"/>
+                <a16:creationId xmlns:a16="http://schemas.microsoft.com/office/drawing/2014/main" id="{B7CB1591-114D-4E61-846E-1D14FE52C406}"/>
               </a:ext>
             </a:extLst>
           </p:cNvPr>
@@ -25683,7 +25683,7 @@
           <p:cNvPr id="6" name="">
             <a:extLst xmlns:a="http://schemas.openxmlformats.org/drawingml/2006/main">
               <a:ext uri="{FF2B5EF4-FFF2-40B4-BE49-F238E27FC236}">
-                <a16:creationId xmlns:a16="http://schemas.microsoft.com/office/drawing/2014/main" id="{E954E5B3-1761-4776-AAD0-B83E12F7B2F2}"/>
+                <a16:creationId xmlns:a16="http://schemas.microsoft.com/office/drawing/2014/main" id="{91AC786D-16E2-477F-8E33-C9D40BB2481C}"/>
               </a:ext>
             </a:extLst>
           </p:cNvPr>
@@ -25840,7 +25840,7 @@
           <p:cNvPr id="7" name="">
             <a:extLst xmlns:a="http://schemas.openxmlformats.org/drawingml/2006/main">
               <a:ext uri="{FF2B5EF4-FFF2-40B4-BE49-F238E27FC236}">
-                <a16:creationId xmlns:a16="http://schemas.microsoft.com/office/drawing/2014/main" id="{2B4E21F0-7FE3-4E29-BA90-90102AA04F04}"/>
+                <a16:creationId xmlns:a16="http://schemas.microsoft.com/office/drawing/2014/main" id="{E4343614-4355-4E75-9E3A-3F6B390AD72C}"/>
               </a:ext>
             </a:extLst>
           </p:cNvPr>
@@ -26089,7 +26089,7 @@
           <p:cNvPr id="8" name="">
             <a:extLst xmlns:a="http://schemas.openxmlformats.org/drawingml/2006/main">
               <a:ext uri="{FF2B5EF4-FFF2-40B4-BE49-F238E27FC236}">
-                <a16:creationId xmlns:a16="http://schemas.microsoft.com/office/drawing/2014/main" id="{9BF7DD08-9C51-4EF6-B679-D80B1DC8CF24}"/>
+                <a16:creationId xmlns:a16="http://schemas.microsoft.com/office/drawing/2014/main" id="{7DED4B66-04C1-47B1-8149-A02135D0E13B}"/>
               </a:ext>
             </a:extLst>
           </p:cNvPr>
@@ -26244,7 +26244,7 @@
     </p:spTree>
     <p:extLst>
       <p:ext uri="{BB962C8B-B14F-4D97-AF65-F5344CB8AC3E}">
-        <p14:creationId xmlns:p14="http://schemas.microsoft.com/office/powerpoint/2010/main" val="68266509"/>
+        <p14:creationId xmlns:p14="http://schemas.microsoft.com/office/powerpoint/2010/main" val="1752232785"/>
       </p:ext>
     </p:extLst>
   </p:cSld>

</xml_diff>

<commit_message>
Harden selector v2 incumbent finalization
</commit_message>
<xml_diff>
--- a/submissions/midterm-2026-10-28/isaforge-midterm-progress-slides-final.pptx
+++ b/submissions/midterm-2026-10-28/isaforge-midterm-progress-slides-final.pptx
@@ -2,23 +2,23 @@
 <file path=ppt/presentation.xml><?xml version="1.0" encoding="utf-8"?>
 <p:presentation xmlns:p="http://schemas.openxmlformats.org/presentationml/2006/main">
   <p:sldMasterIdLst>
-    <p:sldMasterId xmlns:r="http://schemas.openxmlformats.org/officeDocument/2006/relationships" id="2147483648" r:id="R3a91e13b51344367"/>
+    <p:sldMasterId xmlns:r="http://schemas.openxmlformats.org/officeDocument/2006/relationships" id="2147483648" r:id="R1c94bd6ee3ad4b21"/>
   </p:sldMasterIdLst>
   <p:notesMasterIdLst>
-    <p:notesMasterId xmlns:r="http://schemas.openxmlformats.org/officeDocument/2006/relationships" r:id="Rd808ddaa58374a7c"/>
+    <p:notesMasterId xmlns:r="http://schemas.openxmlformats.org/officeDocument/2006/relationships" r:id="R86abf2fdc7554040"/>
   </p:notesMasterIdLst>
   <p:sldIdLst>
-    <p:sldId xmlns:r="http://schemas.openxmlformats.org/officeDocument/2006/relationships" id="256" r:id="R50fc319032354b5e"/>
-    <p:sldId xmlns:r="http://schemas.openxmlformats.org/officeDocument/2006/relationships" id="257" r:id="Rb2c187d66e034025"/>
-    <p:sldId xmlns:r="http://schemas.openxmlformats.org/officeDocument/2006/relationships" id="258" r:id="Rfa6254baf7154760"/>
-    <p:sldId xmlns:r="http://schemas.openxmlformats.org/officeDocument/2006/relationships" id="259" r:id="R2f29c408948144a3"/>
-    <p:sldId xmlns:r="http://schemas.openxmlformats.org/officeDocument/2006/relationships" id="260" r:id="Rfb4cfc0f649e4aaa"/>
-    <p:sldId xmlns:r="http://schemas.openxmlformats.org/officeDocument/2006/relationships" id="261" r:id="Ra2034ae45f4e44c6"/>
-    <p:sldId xmlns:r="http://schemas.openxmlformats.org/officeDocument/2006/relationships" id="262" r:id="R3aec17febdf347f8"/>
-    <p:sldId xmlns:r="http://schemas.openxmlformats.org/officeDocument/2006/relationships" id="263" r:id="Rc0b2c01eecc441bf"/>
-    <p:sldId xmlns:r="http://schemas.openxmlformats.org/officeDocument/2006/relationships" id="264" r:id="R938fb8e31f65401d"/>
-    <p:sldId xmlns:r="http://schemas.openxmlformats.org/officeDocument/2006/relationships" id="265" r:id="Rb16de08247824a9d"/>
-    <p:sldId xmlns:r="http://schemas.openxmlformats.org/officeDocument/2006/relationships" id="266" r:id="R4f02117d33c14612"/>
+    <p:sldId xmlns:r="http://schemas.openxmlformats.org/officeDocument/2006/relationships" id="256" r:id="Rf5aceed2145e4c0e"/>
+    <p:sldId xmlns:r="http://schemas.openxmlformats.org/officeDocument/2006/relationships" id="257" r:id="Rd2ce32f7eece4398"/>
+    <p:sldId xmlns:r="http://schemas.openxmlformats.org/officeDocument/2006/relationships" id="258" r:id="Rdf8d38067d7e476e"/>
+    <p:sldId xmlns:r="http://schemas.openxmlformats.org/officeDocument/2006/relationships" id="259" r:id="Rfed0eee642df4af5"/>
+    <p:sldId xmlns:r="http://schemas.openxmlformats.org/officeDocument/2006/relationships" id="260" r:id="R1b6894cf95b648ac"/>
+    <p:sldId xmlns:r="http://schemas.openxmlformats.org/officeDocument/2006/relationships" id="261" r:id="R929db504ebaa466d"/>
+    <p:sldId xmlns:r="http://schemas.openxmlformats.org/officeDocument/2006/relationships" id="262" r:id="R3949d609c3914d58"/>
+    <p:sldId xmlns:r="http://schemas.openxmlformats.org/officeDocument/2006/relationships" id="263" r:id="R641b8a5043b9432b"/>
+    <p:sldId xmlns:r="http://schemas.openxmlformats.org/officeDocument/2006/relationships" id="264" r:id="R17fb6bf419844cc6"/>
+    <p:sldId xmlns:r="http://schemas.openxmlformats.org/officeDocument/2006/relationships" id="265" r:id="R629caccfb6dc4b8b"/>
+    <p:sldId xmlns:r="http://schemas.openxmlformats.org/officeDocument/2006/relationships" id="266" r:id="Rb51ce2f589ee4bf4"/>
   </p:sldIdLst>
   <p:sldSz cx="12192000" cy="6858000"/>
   <p:notesSz cx="6858000" cy="9144000"/>
@@ -682,7 +682,7 @@
           </a:p>
           <a:p xmlns:a="http://schemas.openxmlformats.org/drawingml/2006/main">
             <a:r>
-              <a:t>docs/HANDOFF.md; docs/ACTIVE_GOAL.md. Research paused at presentation checkpoint; no new collection implied by this deck. Next experiments require frozen controllers/policies, legal lowering and blind measurement contracts. Keep the original CRC32 and aha-mont64 experiments and all negative outcomes. No RTL-rewriting optimization agent.</a:t>
+              <a:t>docs/HANDOFF.md; docs/ACTIVE_GOAL.md. Owner resumed a 10-hour evidence-driven improvement block on October 28; no new workload labels were produced in this checkpoint. Next experiments require frozen controllers/policies, legal lowering and blind measurement contracts. Keep the original CRC32 and aha-mont64 experiments and all negative outcomes. No RTL-rewriting optimization agent.</a:t>
             </a:r>
           </a:p>
         </p:txBody>
@@ -1087,7 +1087,7 @@
           </a:p>
           <a:p xmlns:a="http://schemas.openxmlformats.org/drawingml/2006/main">
             <a:r>
-              <a:t>Our first hardware-cost study grew from 301 to 713 distinct synthesized formulas across benchmark collections. Those isolated LUT labels are separate from the current whole-program dataset: 122 candidate-program measurements across fourteen workload groups, plus four charged failures. The chart shows its three benchmark suites. We hold out entire workloads. Our thirteen-policy screen includes 2,925 replays of existing measurements, not new hardware runs.</a:t>
+              <a:t>Our first hardware-cost study grew from 301 to 713 distinct synthesized formulas across benchmark collections. Those isolated LUT labels are separate from the current whole-program dataset: 122 candidate-program measurements across fourteen workload groups, plus four charged failures: two candidate correctness failures and two censored evaluations. The chart shows its three benchmark suites. We hold out entire workloads. Our thirteen-policy screen includes 2,925 replays of existing measurements, not new hardware runs.</a:t>
             </a:r>
           </a:p>
           <a:p xmlns:a="http://schemas.openxmlformats.org/drawingml/2006/main">
@@ -1102,7 +1102,7 @@
           </a:p>
           <a:p xmlns:a="http://schemas.openxmlformats.org/drawingml/2006/main">
             <a:r>
-              <a:t>Earlier area study: initial 301 formulas, later three collections 1,098 program/formula rows and 713 distinct formulas from 17 candidate-bearing programs; isolated LUT4 labels, not processor cycles. The frozen original-301 model evaluated 331 novel final formulas: structural linear 23.154 LUT4 MAE versus original XGBoost 87.595. Later all-713 deployment refit lacks a fresh independent test. See results/2026-10-13-prospective/README.md and docs/methodology-history.md. Current dataset: submissions/midterm-2026-10-28/dataset/; results/2026-10-27-final-selection-scorecard/scorecard.json. 15 build/input contexts;12 complete measured-pool oracles,2 censored. Embench39 labels/6 groups; BEEBS48/5; TACLeBench35/3. Original teammate hardware-branch data uses a distinct context and is not silently merged.</a:t>
+              <a:t>Earlier area study: initial 301 formulas, later three collections 1,098 program/formula rows and 713 distinct formulas from 17 candidate-bearing programs; isolated LUT4 labels, not processor cycles. The frozen original-301 model evaluated 331 novel final formulas: structural linear 23.154 LUT4 MAE versus original XGBoost 87.595. Later all-713 deployment refit lacks a fresh independent test. See results/2026-10-13-prospective/README.md and docs/methodology-history.md. Current dataset: submissions/midterm-2026-10-28/dataset/; results/2026-10-27-final-selection-scorecard/scorecard.json. 15 build/input contexts;12 complete measured-pool oracles,2 censored. Embench39 labels/6 groups; BEEBS48/5; TACLeBench35/3. Original teammate hardware-branch data uses a distinct context and is not silently merged. Why few new workload labels: the fixed pool gate rejects countnegative (4 legal of 12 required), stringsearch (2), fannkuch-redux (2), and strstr (0). These are pre-measurement rejections, not missing or silently dropped data. The four charged failures are separate: EDN memory-guard violation at address 5956; UD self-check output flag zero; UD storage below 2 GiB; G.723 nextpnr route seed 3 exceeded 180 seconds. The last two are censored and have no performance/hardware label.</a:t>
             </a:r>
           </a:p>
         </p:txBody>
@@ -1287,7 +1287,7 @@
           </a:p>
           <a:p xmlns:a="http://schemas.openxmlformats.org/drawingml/2006/main">
             <a:r>
-              <a:t>The language model is a decision-maker, not the numeric predictor. It sees legal candidates, constraints, predictions it requests, and paid observations. Hybrid retrieval adds relevant approved history. The agent chooses one structured action at a time; the host executes it and returns evidence. The language model itself is not retrained. In our live Luna pilot, hybrid memory reached the same feasible design in two queries and four turns, versus three queries and nine turns without retrieval. Three invalid finalizations were rejected. This is one archived-data trial per arm, and the strongest heuristic needed only one query.</a:t>
+              <a:t>The LLM chooses which candidate to measure; XGBoost and heuristics score it. The host owns charging, correctness, and area/timing checks. In one archived SHA-256 pilot, hybrid memory reached the feasible design in two measurements; no retrieval took three and made three rejected finalization requests. The strongest heuristic needed one. Selector v2 now exposes the host-computed incumbent, rejects stale final choices, and returns measured facts separately from the model note. We have not rerun the LLM under v2.</a:t>
             </a:r>
           </a:p>
           <a:p xmlns:a="http://schemas.openxmlformats.org/drawingml/2006/main">
@@ -1302,7 +1302,7 @@
           </a:p>
           <a:p xmlns:a="http://schemas.openxmlformats.org/drawingml/2006/main">
             <a:r>
-              <a:t>isaforge/agent_memory.py: fixed query from unattempted formulas; TF-IDF cosine + SVD cosine, RRF k60, top3 source-linked approved historical records. Semantic search is local latent-semantic analysis, not pretrained embeddings. Full historical information is available in both arms; retrieval changes ordering/emphasis. The agent does not issue arbitrary searches. isaforge/bounded_selector.py owns budget and final acceptance. Four structured actions. Episode memory includes attempts, paid outcomes, incumbent and remaining budget. Frozen ranker not retrained; configured hardware GP can update on paid successes. No LLM fine-tuning. Schema-recovery primary/secondary routing is implemented and offline-tested, not used in this live same-model pilot. results/2026-10-28-live-luna-memory/README.md: configured gpt-6-luna medium, fresh contexts, cooperative file restrictions. Hybrid predict→measure→measure→finalize, no retrieval9 turns with3 rejected finalizations. Both1.0213847x,+50LUT4,65.99353MHz. Historical hardware outcomes, no new synthesis or causal retrieval claim.</a:t>
+              <a:t>isaforge/agent_memory.py: fixed query over unattempted formulas; local TF-IDF/LSA hybrid, RRF k60, top3 source-linked history; not pretrained embeddings or general RAG. Both arms can access full history; retrieval changes ordering/emphasis. Four structured tools; host owns attempt charging and final acceptance. The ranker is not retrained; configured hardware GP can update on paid successes. The live Luna pilot is one archived-data trial per arm with cooperative file restrictions; hybrid used two queries/four turns, no retrieval three queries/nine turns, three rejected finalizations, and both reached 1.0213847x, +50 LUT4, 65.99353 MHz. The heuristic reached the same design in one query. Selector v2 now names the incumbent, enforces it at finalize, and returns canonical measured fields separately from unverified agent_summary. 79 tests and 10-policy/30-endpoint control replay pass; zero live LLM or native jobs for v2. No causal memory or superiority claim.</a:t>
             </a:r>
           </a:p>
         </p:txBody>
@@ -1387,7 +1387,7 @@
           </a:p>
           <a:p xmlns:a="http://schemas.openxmlformats.org/drawingml/2006/main">
             <a:r>
-              <a:t>Our four tools separate language-model proposals from trusted execution. List exposes legal candidates; predict returns model estimates; measure charges an attempt before evaluation; finalize accepts only a paid, verified feasible improvement or baseline. Invalid and repeated measurement attempts still cost budget. Observability connects each decision to its tool call, retrieved record and outcome. We version the protocol and source hashes, preserve failed actions, and export verified traces to SQLite. These are working local LLMOps components. The live pilot has thirteen recorded model turns, but token usage and model-only latency are unavailable. Production deployment and automated restart remain future work.</a:t>
+              <a:t>Our four tools separate language-model proposals from trusted execution. List exposes legal candidates; predict returns model estimates; measure charges an attempt before evaluation; finalize accepts only the host-computed best paid, verified feasible improvement; baseline is allowed only when none exists. Invalid and repeated measurement attempts still cost budget. Observability connects each decision to its tool call, retrieved record and outcome. We version the protocol and source hashes, preserve failed actions, and export verified traces to SQLite. These are working local LLMOps components. The live pilot has thirteen recorded model turns, but token usage and model-only latency are unavailable. Production deployment and automated restart remain future work.</a:t>
             </a:r>
           </a:p>
           <a:p xmlns:a="http://schemas.openxmlformats.org/drawingml/2006/main">
@@ -1402,7 +1402,7 @@
           </a:p>
           <a:p xmlns:a="http://schemas.openxmlformats.org/drawingml/2006/main">
             <a:r>
-              <a:t>Tools: isaforge/selection_provider.py strict remote function schemas; isaforge/codex_chat_selector.py interactive JSON bridge. Host: bounded_selector.py. Measure reserves charge before lookup while budget remains. Invalid/repeated attempts count; repeats do not redispatch evaluator. Finalize checks paid observation, correctness, device fit, area cap, clock floor and speedup&gt;1 or null baseline. Finite model/tool calls, incumbent fallback, fresh output paths; no restart/resume guarantee. Observability: export_agent_observability.py verifies manifest/protocol/ledger hashes and creates releases, episodes, decisions, model_calls, retrievals and tools tables. Raw ledgers authoritative. Live13 turns,4 retrievals; 3 rejected finalizations. Interactive elapsed time includes orchestration; tokens SQLNULL. Remote provider records tokens only if returned. LLMOps here is local versioning, reproducible evaluation and inspection, not production cloud operations. 84 focused tests at release500dd989. Retrieval fits are not new speedup model versions.</a:t>
+              <a:t>Tools: isaforge/selection_provider.py strict remote function schemas; isaforge/codex_chat_selector.py interactive JSON bridge. Host: bounded_selector.py. Measure reserves charge before lookup while budget remains. Invalid/repeated attempts count; repeats do not redispatch evaluator. Finalize accepts only the current host-computed best paid feasible improvement; null is allowed only with no improvement. Host returns canonical measured fields; the model text is an unverified agent_summary. Finite model/tool calls, incumbent fallback, fresh output paths; no restart/resume guarantee. Observability: export_agent_observability.py verifies manifest/protocol/ledger hashes and creates releases, episodes, decisions, model_calls, retrievals and tools tables. Raw ledgers authoritative. Live13 turns,4 retrievals; 3 rejected finalizations. Interactive elapsed time includes orchestration; tokens SQLNULL. Remote provider records tokens only if returned. LLMOps here is local versioning, reproducible evaluation and inspection, not production cloud operations. Selector v2 passes 79 focused tests; a 10-policy/30-endpoint SHA256 control replay matches archived trajectories exactly, with zero LLM/native jobs. Retrieval fits are not new speedup model versions.</a:t>
             </a:r>
           </a:p>
         </p:txBody>
@@ -1549,7 +1549,7 @@
           <p:cNvPr id="3" name="Title">
             <a:extLst xmlns:a="http://schemas.openxmlformats.org/drawingml/2006/main">
               <a:ext uri="{FF2B5EF4-FFF2-40B4-BE49-F238E27FC236}">
-                <a16:creationId xmlns:a16="http://schemas.microsoft.com/office/drawing/2014/main" id="{10EA2856-5293-4D12-B51B-3D6577893CE8}"/>
+                <a16:creationId xmlns:a16="http://schemas.microsoft.com/office/drawing/2014/main" id="{5513BE8A-C64D-4A99-A47D-3B997666F5EB}"/>
               </a:ext>
             </a:extLst>
           </p:cNvPr>
@@ -1778,7 +1778,7 @@
           <p:cNvPr id="2" name="Subtitle">
             <a:extLst xmlns:a="http://schemas.openxmlformats.org/drawingml/2006/main">
               <a:ext uri="{FF2B5EF4-FFF2-40B4-BE49-F238E27FC236}">
-                <a16:creationId xmlns:a16="http://schemas.microsoft.com/office/drawing/2014/main" id="{DDAC924C-9A4D-4C38-8472-C31CB683F8CB}"/>
+                <a16:creationId xmlns:a16="http://schemas.microsoft.com/office/drawing/2014/main" id="{6C91BBA7-CB79-4C3B-9649-EBEA7D27F4C8}"/>
               </a:ext>
             </a:extLst>
           </p:cNvPr>
@@ -2024,7 +2024,7 @@
           <p:cNvPr id="2" name="Section title">
             <a:extLst xmlns:a="http://schemas.openxmlformats.org/drawingml/2006/main">
               <a:ext uri="{FF2B5EF4-FFF2-40B4-BE49-F238E27FC236}">
-                <a16:creationId xmlns:a16="http://schemas.microsoft.com/office/drawing/2014/main" id="{208B0EA0-B28F-4FD6-90BA-25DA4F511CED}"/>
+                <a16:creationId xmlns:a16="http://schemas.microsoft.com/office/drawing/2014/main" id="{F631BDD3-0401-448E-B115-4017531B9D52}"/>
               </a:ext>
             </a:extLst>
           </p:cNvPr>
@@ -2270,7 +2270,7 @@
           <p:cNvPr id="3" name="Title">
             <a:extLst xmlns:a="http://schemas.openxmlformats.org/drawingml/2006/main">
               <a:ext uri="{FF2B5EF4-FFF2-40B4-BE49-F238E27FC236}">
-                <a16:creationId xmlns:a16="http://schemas.microsoft.com/office/drawing/2014/main" id="{AF075825-6FF7-4F0D-AF31-53E5157602C0}"/>
+                <a16:creationId xmlns:a16="http://schemas.microsoft.com/office/drawing/2014/main" id="{7F473609-5592-4305-B439-AED263ABD32D}"/>
               </a:ext>
             </a:extLst>
           </p:cNvPr>
@@ -2499,7 +2499,7 @@
           <p:cNvPr id="2" name="Body">
             <a:extLst xmlns:a="http://schemas.openxmlformats.org/drawingml/2006/main">
               <a:ext uri="{FF2B5EF4-FFF2-40B4-BE49-F238E27FC236}">
-                <a16:creationId xmlns:a16="http://schemas.microsoft.com/office/drawing/2014/main" id="{EBE48CAF-AFD8-4BEB-AC5E-E1BF033127CF}"/>
+                <a16:creationId xmlns:a16="http://schemas.microsoft.com/office/drawing/2014/main" id="{2E2B4F50-6501-4665-A7AB-64699FE9BBCE}"/>
               </a:ext>
             </a:extLst>
           </p:cNvPr>
@@ -2745,7 +2745,7 @@
           <p:cNvPr id="4" name="Title">
             <a:extLst xmlns:a="http://schemas.openxmlformats.org/drawingml/2006/main">
               <a:ext uri="{FF2B5EF4-FFF2-40B4-BE49-F238E27FC236}">
-                <a16:creationId xmlns:a16="http://schemas.microsoft.com/office/drawing/2014/main" id="{EAA7CCB3-11FE-49A5-A5EA-26313F09F3B5}"/>
+                <a16:creationId xmlns:a16="http://schemas.microsoft.com/office/drawing/2014/main" id="{8C6E3C1A-8AE5-428E-954A-D316E5B1E07D}"/>
               </a:ext>
             </a:extLst>
           </p:cNvPr>
@@ -2974,7 +2974,7 @@
           <p:cNvPr id="2" name="Left column">
             <a:extLst xmlns:a="http://schemas.openxmlformats.org/drawingml/2006/main">
               <a:ext uri="{FF2B5EF4-FFF2-40B4-BE49-F238E27FC236}">
-                <a16:creationId xmlns:a16="http://schemas.microsoft.com/office/drawing/2014/main" id="{24EA4B7B-C522-48D7-8684-97BAD8ED58F9}"/>
+                <a16:creationId xmlns:a16="http://schemas.microsoft.com/office/drawing/2014/main" id="{2ECE4D62-CCC5-45B4-9E10-9ECBA27D8554}"/>
               </a:ext>
             </a:extLst>
           </p:cNvPr>
@@ -3203,7 +3203,7 @@
           <p:cNvPr id="3" name="Right column">
             <a:extLst xmlns:a="http://schemas.openxmlformats.org/drawingml/2006/main">
               <a:ext uri="{FF2B5EF4-FFF2-40B4-BE49-F238E27FC236}">
-                <a16:creationId xmlns:a16="http://schemas.microsoft.com/office/drawing/2014/main" id="{85B18395-7B3E-47A8-8D1C-CDE560E9EB00}"/>
+                <a16:creationId xmlns:a16="http://schemas.microsoft.com/office/drawing/2014/main" id="{4B667AEB-CB9E-43FB-B51E-EFC585CCC244}"/>
               </a:ext>
             </a:extLst>
           </p:cNvPr>
@@ -3449,7 +3449,7 @@
           <p:cNvPr id="3" name="Title">
             <a:extLst xmlns:a="http://schemas.openxmlformats.org/drawingml/2006/main">
               <a:ext uri="{FF2B5EF4-FFF2-40B4-BE49-F238E27FC236}">
-                <a16:creationId xmlns:a16="http://schemas.microsoft.com/office/drawing/2014/main" id="{8DB72ABF-0817-42D2-AA5E-ECA0F212854D}"/>
+                <a16:creationId xmlns:a16="http://schemas.microsoft.com/office/drawing/2014/main" id="{E40448DD-8E9B-4F49-A453-3253D314B4C6}"/>
               </a:ext>
             </a:extLst>
           </p:cNvPr>
@@ -3678,7 +3678,7 @@
           <p:cNvPr id="2" name="Left column">
             <a:extLst xmlns:a="http://schemas.openxmlformats.org/drawingml/2006/main">
               <a:ext uri="{FF2B5EF4-FFF2-40B4-BE49-F238E27FC236}">
-                <a16:creationId xmlns:a16="http://schemas.microsoft.com/office/drawing/2014/main" id="{8037BD4C-9B79-482F-AD77-2BF0C6D98BA2}"/>
+                <a16:creationId xmlns:a16="http://schemas.microsoft.com/office/drawing/2014/main" id="{48D21222-97B3-48EE-A2F3-FFE00E88A7C3}"/>
               </a:ext>
             </a:extLst>
           </p:cNvPr>
@@ -3945,12 +3945,12 @@
   </p:cSld>
   <p:clrMap bg1="lt1" tx1="dk1" bg2="lt2" tx2="dk2" accent1="accent1" accent2="accent2" accent3="accent3" accent4="accent4" accent5="accent5" accent6="accent6" hlink="hlink" folHlink="folHlink"/>
   <p:sldLayoutIdLst>
-    <p:sldLayoutId xmlns:r="http://schemas.openxmlformats.org/officeDocument/2006/relationships" id="2147483649" r:id="R00e76b2d281d4322"/>
-    <p:sldLayoutId xmlns:r="http://schemas.openxmlformats.org/officeDocument/2006/relationships" id="2147483650" r:id="R2a35689e21444f57"/>
-    <p:sldLayoutId xmlns:r="http://schemas.openxmlformats.org/officeDocument/2006/relationships" id="2147483651" r:id="R483da67a99d4404b"/>
-    <p:sldLayoutId xmlns:r="http://schemas.openxmlformats.org/officeDocument/2006/relationships" id="2147483652" r:id="R80e02efdaf61427b"/>
-    <p:sldLayoutId xmlns:r="http://schemas.openxmlformats.org/officeDocument/2006/relationships" id="2147483653" r:id="R5e14b1566e0d490c"/>
-    <p:sldLayoutId xmlns:r="http://schemas.openxmlformats.org/officeDocument/2006/relationships" id="2147483654" r:id="R08d040b791554ed9"/>
+    <p:sldLayoutId xmlns:r="http://schemas.openxmlformats.org/officeDocument/2006/relationships" id="2147483649" r:id="R79bea9d0617846a8"/>
+    <p:sldLayoutId xmlns:r="http://schemas.openxmlformats.org/officeDocument/2006/relationships" id="2147483650" r:id="Rb1d17e2a67fc4261"/>
+    <p:sldLayoutId xmlns:r="http://schemas.openxmlformats.org/officeDocument/2006/relationships" id="2147483651" r:id="Rd6d68d7c3c8147f2"/>
+    <p:sldLayoutId xmlns:r="http://schemas.openxmlformats.org/officeDocument/2006/relationships" id="2147483652" r:id="Rcca3edbfb2044a9f"/>
+    <p:sldLayoutId xmlns:r="http://schemas.openxmlformats.org/officeDocument/2006/relationships" id="2147483653" r:id="Ra26045650aba4d99"/>
+    <p:sldLayoutId xmlns:r="http://schemas.openxmlformats.org/officeDocument/2006/relationships" id="2147483654" r:id="Rac64838366494228"/>
   </p:sldLayoutIdLst>
   <p:txStyles>
     <p:titleStyle>
@@ -5273,7 +5273,7 @@
           <p:cNvPr id="8" name="">
             <a:extLst xmlns:a="http://schemas.openxmlformats.org/drawingml/2006/main">
               <a:ext uri="{FF2B5EF4-FFF2-40B4-BE49-F238E27FC236}">
-                <a16:creationId xmlns:a16="http://schemas.microsoft.com/office/drawing/2014/main" id="{35B8DC94-7ABC-4647-885C-1AC3EB441B22}"/>
+                <a16:creationId xmlns:a16="http://schemas.microsoft.com/office/drawing/2014/main" id="{CE21B89F-E955-4F78-9766-3ACBF6B51F4B}"/>
               </a:ext>
             </a:extLst>
           </p:cNvPr>
@@ -5430,7 +5430,7 @@
           <p:cNvPr id="2" name="">
             <a:extLst xmlns:a="http://schemas.openxmlformats.org/drawingml/2006/main">
               <a:ext uri="{FF2B5EF4-FFF2-40B4-BE49-F238E27FC236}">
-                <a16:creationId xmlns:a16="http://schemas.microsoft.com/office/drawing/2014/main" id="{5077E63B-EA7F-45DA-8840-8638860541C8}"/>
+                <a16:creationId xmlns:a16="http://schemas.microsoft.com/office/drawing/2014/main" id="{4A2579E4-89FE-4BEF-B318-5D0320D6078F}"/>
               </a:ext>
             </a:extLst>
           </p:cNvPr>
@@ -5461,7 +5461,7 @@
           <p:cNvPr id="3" name="">
             <a:extLst xmlns:a="http://schemas.openxmlformats.org/drawingml/2006/main">
               <a:ext uri="{FF2B5EF4-FFF2-40B4-BE49-F238E27FC236}">
-                <a16:creationId xmlns:a16="http://schemas.microsoft.com/office/drawing/2014/main" id="{BCC178EC-7E8C-4DF9-877B-54A9AC75854C}"/>
+                <a16:creationId xmlns:a16="http://schemas.microsoft.com/office/drawing/2014/main" id="{04CB9177-0813-4C9D-BE4B-8B5D40128F11}"/>
               </a:ext>
             </a:extLst>
           </p:cNvPr>
@@ -5618,7 +5618,7 @@
           <p:cNvPr id="4" name="">
             <a:extLst xmlns:a="http://schemas.openxmlformats.org/drawingml/2006/main">
               <a:ext uri="{FF2B5EF4-FFF2-40B4-BE49-F238E27FC236}">
-                <a16:creationId xmlns:a16="http://schemas.microsoft.com/office/drawing/2014/main" id="{C4EE8DDC-398E-4BF8-A62D-2A8643372D1E}"/>
+                <a16:creationId xmlns:a16="http://schemas.microsoft.com/office/drawing/2014/main" id="{B88DC9F3-BC0F-4C30-8DB7-F0BE859A4C91}"/>
               </a:ext>
             </a:extLst>
           </p:cNvPr>
@@ -5775,7 +5775,7 @@
           <p:cNvPr id="5" name="">
             <a:extLst xmlns:a="http://schemas.openxmlformats.org/drawingml/2006/main">
               <a:ext uri="{FF2B5EF4-FFF2-40B4-BE49-F238E27FC236}">
-                <a16:creationId xmlns:a16="http://schemas.microsoft.com/office/drawing/2014/main" id="{6DB8CFFF-ED16-4C4F-A4BD-1C2A37FA7A34}"/>
+                <a16:creationId xmlns:a16="http://schemas.microsoft.com/office/drawing/2014/main" id="{84F3C2AD-8880-4D04-AA77-BEAB13E00FC4}"/>
               </a:ext>
             </a:extLst>
           </p:cNvPr>
@@ -5955,7 +5955,7 @@
           <p:cNvPr id="6" name="">
             <a:extLst xmlns:a="http://schemas.openxmlformats.org/drawingml/2006/main">
               <a:ext uri="{FF2B5EF4-FFF2-40B4-BE49-F238E27FC236}">
-                <a16:creationId xmlns:a16="http://schemas.microsoft.com/office/drawing/2014/main" id="{205E33DB-A294-46F6-A122-839B621FC548}"/>
+                <a16:creationId xmlns:a16="http://schemas.microsoft.com/office/drawing/2014/main" id="{D2DBD6C3-1071-4EF5-BC40-48460B0F8C61}"/>
               </a:ext>
             </a:extLst>
           </p:cNvPr>
@@ -6112,7 +6112,7 @@
           <p:cNvPr id="7" name="">
             <a:extLst xmlns:a="http://schemas.openxmlformats.org/drawingml/2006/main">
               <a:ext uri="{FF2B5EF4-FFF2-40B4-BE49-F238E27FC236}">
-                <a16:creationId xmlns:a16="http://schemas.microsoft.com/office/drawing/2014/main" id="{112B12D8-EE3A-4BA2-B800-24E119D33426}"/>
+                <a16:creationId xmlns:a16="http://schemas.microsoft.com/office/drawing/2014/main" id="{754242D2-DB50-4056-9CEF-64C3D0ADCD0C}"/>
               </a:ext>
             </a:extLst>
           </p:cNvPr>
@@ -6267,7 +6267,7 @@
     </p:spTree>
     <p:extLst>
       <p:ext uri="{BB962C8B-B14F-4D97-AF65-F5344CB8AC3E}">
-        <p14:creationId xmlns:p14="http://schemas.microsoft.com/office/powerpoint/2010/main" val="1476303525"/>
+        <p14:creationId xmlns:p14="http://schemas.microsoft.com/office/powerpoint/2010/main" val="1493702407"/>
       </p:ext>
     </p:extLst>
   </p:cSld>
@@ -6298,7 +6298,7 @@
           <p:cNvPr id="9" name="">
             <a:extLst xmlns:a="http://schemas.openxmlformats.org/drawingml/2006/main">
               <a:ext uri="{FF2B5EF4-FFF2-40B4-BE49-F238E27FC236}">
-                <a16:creationId xmlns:a16="http://schemas.microsoft.com/office/drawing/2014/main" id="{21A3A332-318B-4436-897D-450BA26A49FB}"/>
+                <a16:creationId xmlns:a16="http://schemas.microsoft.com/office/drawing/2014/main" id="{01448DCD-9FA3-47AE-AD8E-FE2815FBF7E1}"/>
               </a:ext>
             </a:extLst>
           </p:cNvPr>
@@ -6455,7 +6455,7 @@
           <p:cNvPr id="2" name="">
             <a:extLst xmlns:a="http://schemas.openxmlformats.org/drawingml/2006/main">
               <a:ext uri="{FF2B5EF4-FFF2-40B4-BE49-F238E27FC236}">
-                <a16:creationId xmlns:a16="http://schemas.microsoft.com/office/drawing/2014/main" id="{E5EAE3CA-5DBF-401B-B5C8-37117A12736D}"/>
+                <a16:creationId xmlns:a16="http://schemas.microsoft.com/office/drawing/2014/main" id="{8FA94971-4E53-4838-AADB-E3B1E91FE9A8}"/>
               </a:ext>
             </a:extLst>
           </p:cNvPr>
@@ -6486,7 +6486,7 @@
           <p:cNvPr id="3" name="">
             <a:extLst xmlns:a="http://schemas.openxmlformats.org/drawingml/2006/main">
               <a:ext uri="{FF2B5EF4-FFF2-40B4-BE49-F238E27FC236}">
-                <a16:creationId xmlns:a16="http://schemas.microsoft.com/office/drawing/2014/main" id="{7DA998D2-2D59-4BFC-9D33-78D1FC6AA188}"/>
+                <a16:creationId xmlns:a16="http://schemas.microsoft.com/office/drawing/2014/main" id="{AF17F67E-09FF-4D56-9038-B6EF48D601E4}"/>
               </a:ext>
             </a:extLst>
           </p:cNvPr>
@@ -6643,7 +6643,7 @@
           <p:cNvPr id="4" name="Chart">
             <a:extLst xmlns:a="http://schemas.openxmlformats.org/drawingml/2006/main">
               <a:ext uri="{FF2B5EF4-FFF2-40B4-BE49-F238E27FC236}">
-                <a16:creationId xmlns:a16="http://schemas.microsoft.com/office/drawing/2014/main" id="{BE8B66A2-6C7B-421C-A683-A44F88B3CBE7}"/>
+                <a16:creationId xmlns:a16="http://schemas.microsoft.com/office/drawing/2014/main" id="{AF3C75F5-6A94-46A8-93D9-4439F185D240}"/>
               </a:ext>
             </a:extLst>
           </p:cNvPr>
@@ -6656,7 +6656,7 @@
         </p:xfrm>
         <a:graphic xmlns:a="http://schemas.openxmlformats.org/drawingml/2006/main">
           <a:graphicData uri="http://schemas.openxmlformats.org/drawingml/2006/chart">
-            <c:chart xmlns:r="http://schemas.openxmlformats.org/officeDocument/2006/relationships" xmlns:c="http://schemas.openxmlformats.org/drawingml/2006/chart" r:id="R640d5e6e7a964667"/>
+            <c:chart xmlns:r="http://schemas.openxmlformats.org/officeDocument/2006/relationships" xmlns:c="http://schemas.openxmlformats.org/drawingml/2006/chart" r:id="Rbfc2e2bee1b7490a"/>
           </a:graphicData>
         </a:graphic>
       </p:graphicFrame>
@@ -6665,7 +6665,7 @@
           <p:cNvPr id="5" name="">
             <a:extLst xmlns:a="http://schemas.openxmlformats.org/drawingml/2006/main">
               <a:ext uri="{FF2B5EF4-FFF2-40B4-BE49-F238E27FC236}">
-                <a16:creationId xmlns:a16="http://schemas.microsoft.com/office/drawing/2014/main" id="{95444458-2D30-4F9D-B32C-CED0EAA82240}"/>
+                <a16:creationId xmlns:a16="http://schemas.microsoft.com/office/drawing/2014/main" id="{7CB293C1-51D3-4CE9-9570-4DAD29DC0044}"/>
               </a:ext>
             </a:extLst>
           </p:cNvPr>
@@ -6822,7 +6822,7 @@
           <p:cNvPr id="6" name="">
             <a:extLst xmlns:a="http://schemas.openxmlformats.org/drawingml/2006/main">
               <a:ext uri="{FF2B5EF4-FFF2-40B4-BE49-F238E27FC236}">
-                <a16:creationId xmlns:a16="http://schemas.microsoft.com/office/drawing/2014/main" id="{C658DA1A-9CBF-4775-A772-11C645A7D905}"/>
+                <a16:creationId xmlns:a16="http://schemas.microsoft.com/office/drawing/2014/main" id="{FD3E0FEA-296E-4B00-B6EC-C6E0EC75F375}"/>
               </a:ext>
             </a:extLst>
           </p:cNvPr>
@@ -7053,7 +7053,7 @@
           <p:cNvPr id="7" name="">
             <a:extLst xmlns:a="http://schemas.openxmlformats.org/drawingml/2006/main">
               <a:ext uri="{FF2B5EF4-FFF2-40B4-BE49-F238E27FC236}">
-                <a16:creationId xmlns:a16="http://schemas.microsoft.com/office/drawing/2014/main" id="{365048EE-F96F-434E-A21A-AAFCF0F9E454}"/>
+                <a16:creationId xmlns:a16="http://schemas.microsoft.com/office/drawing/2014/main" id="{A0C6BFE4-DE9A-4FAE-9623-CA734E70A92E}"/>
               </a:ext>
             </a:extLst>
           </p:cNvPr>
@@ -7233,7 +7233,7 @@
           <p:cNvPr id="8" name="">
             <a:extLst xmlns:a="http://schemas.openxmlformats.org/drawingml/2006/main">
               <a:ext uri="{FF2B5EF4-FFF2-40B4-BE49-F238E27FC236}">
-                <a16:creationId xmlns:a16="http://schemas.microsoft.com/office/drawing/2014/main" id="{4ECB7BDB-F711-41E9-B291-B14AE9EB6986}"/>
+                <a16:creationId xmlns:a16="http://schemas.microsoft.com/office/drawing/2014/main" id="{95C5DBDC-1F16-4D0B-98EA-6B7CC26E5DEC}"/>
               </a:ext>
             </a:extLst>
           </p:cNvPr>
@@ -7388,7 +7388,7 @@
     </p:spTree>
     <p:extLst>
       <p:ext uri="{BB962C8B-B14F-4D97-AF65-F5344CB8AC3E}">
-        <p14:creationId xmlns:p14="http://schemas.microsoft.com/office/powerpoint/2010/main" val="2072427501"/>
+        <p14:creationId xmlns:p14="http://schemas.microsoft.com/office/powerpoint/2010/main" val="1976786798"/>
       </p:ext>
     </p:extLst>
   </p:cSld>
@@ -7419,7 +7419,7 @@
           <p:cNvPr id="9" name="">
             <a:extLst xmlns:a="http://schemas.openxmlformats.org/drawingml/2006/main">
               <a:ext uri="{FF2B5EF4-FFF2-40B4-BE49-F238E27FC236}">
-                <a16:creationId xmlns:a16="http://schemas.microsoft.com/office/drawing/2014/main" id="{9F70242D-1009-48E2-BC5B-1D90A3D318FC}"/>
+                <a16:creationId xmlns:a16="http://schemas.microsoft.com/office/drawing/2014/main" id="{9264B8D7-5548-4600-ABD1-1824E37A4ACD}"/>
               </a:ext>
             </a:extLst>
           </p:cNvPr>
@@ -7576,7 +7576,7 @@
           <p:cNvPr id="2" name="">
             <a:extLst xmlns:a="http://schemas.openxmlformats.org/drawingml/2006/main">
               <a:ext uri="{FF2B5EF4-FFF2-40B4-BE49-F238E27FC236}">
-                <a16:creationId xmlns:a16="http://schemas.microsoft.com/office/drawing/2014/main" id="{DB4AF498-D1F0-40E6-A724-320F45B43BA2}"/>
+                <a16:creationId xmlns:a16="http://schemas.microsoft.com/office/drawing/2014/main" id="{A3A76AD5-F76C-4317-BB16-20AC80D9DC9C}"/>
               </a:ext>
             </a:extLst>
           </p:cNvPr>
@@ -7607,7 +7607,7 @@
           <p:cNvPr id="3" name="">
             <a:extLst xmlns:a="http://schemas.openxmlformats.org/drawingml/2006/main">
               <a:ext uri="{FF2B5EF4-FFF2-40B4-BE49-F238E27FC236}">
-                <a16:creationId xmlns:a16="http://schemas.microsoft.com/office/drawing/2014/main" id="{5DACED78-2D22-493E-A1FE-D1D161852E92}"/>
+                <a16:creationId xmlns:a16="http://schemas.microsoft.com/office/drawing/2014/main" id="{6EF9E416-D741-4653-A4A5-E9190082EF3B}"/>
               </a:ext>
             </a:extLst>
           </p:cNvPr>
@@ -7764,7 +7764,7 @@
           <p:cNvPr id="4" name="">
             <a:extLst xmlns:a="http://schemas.openxmlformats.org/drawingml/2006/main">
               <a:ext uri="{FF2B5EF4-FFF2-40B4-BE49-F238E27FC236}">
-                <a16:creationId xmlns:a16="http://schemas.microsoft.com/office/drawing/2014/main" id="{21CDE240-E164-40E7-BC1F-9AA59981799D}"/>
+                <a16:creationId xmlns:a16="http://schemas.microsoft.com/office/drawing/2014/main" id="{65FBD8E6-36F9-4897-9E7F-36286773CEF7}"/>
               </a:ext>
             </a:extLst>
           </p:cNvPr>
@@ -7921,7 +7921,7 @@
           <p:cNvPr id="5" name="">
             <a:extLst xmlns:a="http://schemas.openxmlformats.org/drawingml/2006/main">
               <a:ext uri="{FF2B5EF4-FFF2-40B4-BE49-F238E27FC236}">
-                <a16:creationId xmlns:a16="http://schemas.microsoft.com/office/drawing/2014/main" id="{08790689-205B-469B-A7E0-DEFF2876548F}"/>
+                <a16:creationId xmlns:a16="http://schemas.microsoft.com/office/drawing/2014/main" id="{4676B083-CCEB-463A-BFC3-20F59324D617}"/>
               </a:ext>
             </a:extLst>
           </p:cNvPr>
@@ -8147,7 +8147,7 @@
           <p:cNvPr id="6" name="">
             <a:extLst xmlns:a="http://schemas.openxmlformats.org/drawingml/2006/main">
               <a:ext uri="{FF2B5EF4-FFF2-40B4-BE49-F238E27FC236}">
-                <a16:creationId xmlns:a16="http://schemas.microsoft.com/office/drawing/2014/main" id="{DDEBEF48-A6A5-41B3-A4D5-96AE7E5671A8}"/>
+                <a16:creationId xmlns:a16="http://schemas.microsoft.com/office/drawing/2014/main" id="{17CF0056-1B24-4B01-8E40-3560F0620AB9}"/>
               </a:ext>
             </a:extLst>
           </p:cNvPr>
@@ -8304,7 +8304,7 @@
           <p:cNvPr id="7" name="">
             <a:extLst xmlns:a="http://schemas.openxmlformats.org/drawingml/2006/main">
               <a:ext uri="{FF2B5EF4-FFF2-40B4-BE49-F238E27FC236}">
-                <a16:creationId xmlns:a16="http://schemas.microsoft.com/office/drawing/2014/main" id="{AF90BCAC-3CF8-41F6-8ED1-6A1F33AEC290}"/>
+                <a16:creationId xmlns:a16="http://schemas.microsoft.com/office/drawing/2014/main" id="{78E10646-F271-41CC-872B-166A7A484CD3}"/>
               </a:ext>
             </a:extLst>
           </p:cNvPr>
@@ -8530,7 +8530,7 @@
           <p:cNvPr id="8" name="">
             <a:extLst xmlns:a="http://schemas.openxmlformats.org/drawingml/2006/main">
               <a:ext uri="{FF2B5EF4-FFF2-40B4-BE49-F238E27FC236}">
-                <a16:creationId xmlns:a16="http://schemas.microsoft.com/office/drawing/2014/main" id="{7E8E17BC-57B9-4937-9F59-A2607B37755C}"/>
+                <a16:creationId xmlns:a16="http://schemas.microsoft.com/office/drawing/2014/main" id="{300F4741-105E-4B27-BDBD-4BAF2EB8BFE0}"/>
               </a:ext>
             </a:extLst>
           </p:cNvPr>
@@ -8685,7 +8685,7 @@
     </p:spTree>
     <p:extLst>
       <p:ext uri="{BB962C8B-B14F-4D97-AF65-F5344CB8AC3E}">
-        <p14:creationId xmlns:p14="http://schemas.microsoft.com/office/powerpoint/2010/main" val="1177940951"/>
+        <p14:creationId xmlns:p14="http://schemas.microsoft.com/office/powerpoint/2010/main" val="1491182226"/>
       </p:ext>
     </p:extLst>
   </p:cSld>
@@ -8716,7 +8716,7 @@
           <p:cNvPr id="20" name="">
             <a:extLst xmlns:a="http://schemas.openxmlformats.org/drawingml/2006/main">
               <a:ext uri="{FF2B5EF4-FFF2-40B4-BE49-F238E27FC236}">
-                <a16:creationId xmlns:a16="http://schemas.microsoft.com/office/drawing/2014/main" id="{A6E970FE-859D-4BCC-BF23-9BA7696EC387}"/>
+                <a16:creationId xmlns:a16="http://schemas.microsoft.com/office/drawing/2014/main" id="{5D29C35B-4399-42C1-A12E-EB216102E6CE}"/>
               </a:ext>
             </a:extLst>
           </p:cNvPr>
@@ -8873,7 +8873,7 @@
           <p:cNvPr id="2" name="">
             <a:extLst xmlns:a="http://schemas.openxmlformats.org/drawingml/2006/main">
               <a:ext uri="{FF2B5EF4-FFF2-40B4-BE49-F238E27FC236}">
-                <a16:creationId xmlns:a16="http://schemas.microsoft.com/office/drawing/2014/main" id="{504AB056-9AF4-430F-879B-80E81E2324F4}"/>
+                <a16:creationId xmlns:a16="http://schemas.microsoft.com/office/drawing/2014/main" id="{A84E293E-9C2A-4F40-A38A-597C75BEE26F}"/>
               </a:ext>
             </a:extLst>
           </p:cNvPr>
@@ -8904,7 +8904,7 @@
           <p:cNvPr id="3" name="">
             <a:extLst xmlns:a="http://schemas.openxmlformats.org/drawingml/2006/main">
               <a:ext uri="{FF2B5EF4-FFF2-40B4-BE49-F238E27FC236}">
-                <a16:creationId xmlns:a16="http://schemas.microsoft.com/office/drawing/2014/main" id="{D3135653-F2A5-4E5E-8F4A-8AC2F0E5C57B}"/>
+                <a16:creationId xmlns:a16="http://schemas.microsoft.com/office/drawing/2014/main" id="{26275ABA-B531-44CA-AECC-A82F314688B6}"/>
               </a:ext>
             </a:extLst>
           </p:cNvPr>
@@ -9061,7 +9061,7 @@
           <p:cNvPr id="4" name="">
             <a:extLst xmlns:a="http://schemas.openxmlformats.org/drawingml/2006/main">
               <a:ext uri="{FF2B5EF4-FFF2-40B4-BE49-F238E27FC236}">
-                <a16:creationId xmlns:a16="http://schemas.microsoft.com/office/drawing/2014/main" id="{D15BA93B-C452-4706-B4DF-8BA420DA4726}"/>
+                <a16:creationId xmlns:a16="http://schemas.microsoft.com/office/drawing/2014/main" id="{3A0B725F-2E6C-4B05-8F87-CB2E4F1920C6}"/>
               </a:ext>
             </a:extLst>
           </p:cNvPr>
@@ -9218,7 +9218,7 @@
           <p:cNvPr id="5" name="">
             <a:extLst xmlns:a="http://schemas.openxmlformats.org/drawingml/2006/main">
               <a:ext uri="{FF2B5EF4-FFF2-40B4-BE49-F238E27FC236}">
-                <a16:creationId xmlns:a16="http://schemas.microsoft.com/office/drawing/2014/main" id="{3FF48749-94C2-43D0-844A-8861D0814C4B}"/>
+                <a16:creationId xmlns:a16="http://schemas.microsoft.com/office/drawing/2014/main" id="{D1CF167D-E57A-4422-8BAF-C1402CEE7D49}"/>
               </a:ext>
             </a:extLst>
           </p:cNvPr>
@@ -9375,7 +9375,7 @@
           <p:cNvPr id="6" name="">
             <a:extLst xmlns:a="http://schemas.openxmlformats.org/drawingml/2006/main">
               <a:ext uri="{FF2B5EF4-FFF2-40B4-BE49-F238E27FC236}">
-                <a16:creationId xmlns:a16="http://schemas.microsoft.com/office/drawing/2014/main" id="{EA28BF4F-CB6D-4FAD-B9FC-18CA66FFEDC9}"/>
+                <a16:creationId xmlns:a16="http://schemas.microsoft.com/office/drawing/2014/main" id="{CEDA91A6-AAA1-40E3-99B1-D03CC20467E6}"/>
               </a:ext>
             </a:extLst>
           </p:cNvPr>
@@ -9532,7 +9532,7 @@
           <p:cNvPr id="7" name="">
             <a:extLst xmlns:a="http://schemas.openxmlformats.org/drawingml/2006/main">
               <a:ext uri="{FF2B5EF4-FFF2-40B4-BE49-F238E27FC236}">
-                <a16:creationId xmlns:a16="http://schemas.microsoft.com/office/drawing/2014/main" id="{09C608E9-FE9E-47C6-8233-107A5187152E}"/>
+                <a16:creationId xmlns:a16="http://schemas.microsoft.com/office/drawing/2014/main" id="{8B7E23A8-5E07-4927-B1D1-BA3E270A4816}"/>
               </a:ext>
             </a:extLst>
           </p:cNvPr>
@@ -9563,7 +9563,7 @@
           <p:cNvPr id="8" name="">
             <a:extLst xmlns:a="http://schemas.openxmlformats.org/drawingml/2006/main">
               <a:ext uri="{FF2B5EF4-FFF2-40B4-BE49-F238E27FC236}">
-                <a16:creationId xmlns:a16="http://schemas.microsoft.com/office/drawing/2014/main" id="{6B0B631E-7A70-4119-ABFC-589DC8F716F6}"/>
+                <a16:creationId xmlns:a16="http://schemas.microsoft.com/office/drawing/2014/main" id="{CDFC2FDB-2596-4745-B8A1-EF3D667373F3}"/>
               </a:ext>
             </a:extLst>
           </p:cNvPr>
@@ -9720,7 +9720,7 @@
           <p:cNvPr id="9" name="">
             <a:extLst xmlns:a="http://schemas.openxmlformats.org/drawingml/2006/main">
               <a:ext uri="{FF2B5EF4-FFF2-40B4-BE49-F238E27FC236}">
-                <a16:creationId xmlns:a16="http://schemas.microsoft.com/office/drawing/2014/main" id="{9D979B49-7ADA-4967-A298-98C3061DA4AF}"/>
+                <a16:creationId xmlns:a16="http://schemas.microsoft.com/office/drawing/2014/main" id="{B27FBE96-A1FE-47D0-8B68-14ABA8F3F9E2}"/>
               </a:ext>
             </a:extLst>
           </p:cNvPr>
@@ -9877,7 +9877,7 @@
           <p:cNvPr id="10" name="">
             <a:extLst xmlns:a="http://schemas.openxmlformats.org/drawingml/2006/main">
               <a:ext uri="{FF2B5EF4-FFF2-40B4-BE49-F238E27FC236}">
-                <a16:creationId xmlns:a16="http://schemas.microsoft.com/office/drawing/2014/main" id="{45D9BD32-85FB-4804-A097-B458916D3709}"/>
+                <a16:creationId xmlns:a16="http://schemas.microsoft.com/office/drawing/2014/main" id="{5F075E4F-14AA-42E8-BDFC-F202B844C4C2}"/>
               </a:ext>
             </a:extLst>
           </p:cNvPr>
@@ -10034,7 +10034,7 @@
           <p:cNvPr id="11" name="">
             <a:extLst xmlns:a="http://schemas.openxmlformats.org/drawingml/2006/main">
               <a:ext uri="{FF2B5EF4-FFF2-40B4-BE49-F238E27FC236}">
-                <a16:creationId xmlns:a16="http://schemas.microsoft.com/office/drawing/2014/main" id="{D24913EB-3795-4BDD-BC3E-E48EEA3993A8}"/>
+                <a16:creationId xmlns:a16="http://schemas.microsoft.com/office/drawing/2014/main" id="{B6FCFA83-2378-42AE-A258-B343C2DE4FDC}"/>
               </a:ext>
             </a:extLst>
           </p:cNvPr>
@@ -10065,7 +10065,7 @@
           <p:cNvPr id="12" name="">
             <a:extLst xmlns:a="http://schemas.openxmlformats.org/drawingml/2006/main">
               <a:ext uri="{FF2B5EF4-FFF2-40B4-BE49-F238E27FC236}">
-                <a16:creationId xmlns:a16="http://schemas.microsoft.com/office/drawing/2014/main" id="{19044E4D-AE7E-433B-9113-01C772B509F1}"/>
+                <a16:creationId xmlns:a16="http://schemas.microsoft.com/office/drawing/2014/main" id="{20C9F1B6-5FFD-4C9D-83A3-509756208283}"/>
               </a:ext>
             </a:extLst>
           </p:cNvPr>
@@ -10222,7 +10222,7 @@
           <p:cNvPr id="13" name="">
             <a:extLst xmlns:a="http://schemas.openxmlformats.org/drawingml/2006/main">
               <a:ext uri="{FF2B5EF4-FFF2-40B4-BE49-F238E27FC236}">
-                <a16:creationId xmlns:a16="http://schemas.microsoft.com/office/drawing/2014/main" id="{9362040C-9A96-4620-B2FC-4C3DFEA4065A}"/>
+                <a16:creationId xmlns:a16="http://schemas.microsoft.com/office/drawing/2014/main" id="{CF90C0CB-5994-4C0C-A30B-0D90C2F37110}"/>
               </a:ext>
             </a:extLst>
           </p:cNvPr>
@@ -10379,7 +10379,7 @@
           <p:cNvPr id="14" name="">
             <a:extLst xmlns:a="http://schemas.openxmlformats.org/drawingml/2006/main">
               <a:ext uri="{FF2B5EF4-FFF2-40B4-BE49-F238E27FC236}">
-                <a16:creationId xmlns:a16="http://schemas.microsoft.com/office/drawing/2014/main" id="{F24773C7-C99A-4684-98B4-D435AC94CEFC}"/>
+                <a16:creationId xmlns:a16="http://schemas.microsoft.com/office/drawing/2014/main" id="{2DE99573-347B-4AC9-A2D9-9EED0E8BA163}"/>
               </a:ext>
             </a:extLst>
           </p:cNvPr>
@@ -10536,7 +10536,7 @@
           <p:cNvPr id="15" name="">
             <a:extLst xmlns:a="http://schemas.openxmlformats.org/drawingml/2006/main">
               <a:ext uri="{FF2B5EF4-FFF2-40B4-BE49-F238E27FC236}">
-                <a16:creationId xmlns:a16="http://schemas.microsoft.com/office/drawing/2014/main" id="{4B5857AF-9393-4020-8AD1-F7BDDC12AC6D}"/>
+                <a16:creationId xmlns:a16="http://schemas.microsoft.com/office/drawing/2014/main" id="{215E08A7-1E74-4D01-9C7E-3EF3A7FD4710}"/>
               </a:ext>
             </a:extLst>
           </p:cNvPr>
@@ -10567,7 +10567,7 @@
           <p:cNvPr id="16" name="">
             <a:extLst xmlns:a="http://schemas.openxmlformats.org/drawingml/2006/main">
               <a:ext uri="{FF2B5EF4-FFF2-40B4-BE49-F238E27FC236}">
-                <a16:creationId xmlns:a16="http://schemas.microsoft.com/office/drawing/2014/main" id="{40C28FA3-2269-48CB-A9FB-A71A307A2E5F}"/>
+                <a16:creationId xmlns:a16="http://schemas.microsoft.com/office/drawing/2014/main" id="{AC61FD6A-6231-41DB-B910-BB5F6E558313}"/>
               </a:ext>
             </a:extLst>
           </p:cNvPr>
@@ -10724,7 +10724,7 @@
           <p:cNvPr id="17" name="">
             <a:extLst xmlns:a="http://schemas.openxmlformats.org/drawingml/2006/main">
               <a:ext uri="{FF2B5EF4-FFF2-40B4-BE49-F238E27FC236}">
-                <a16:creationId xmlns:a16="http://schemas.microsoft.com/office/drawing/2014/main" id="{C7760C35-403A-4470-B9A8-4D130F4C1C84}"/>
+                <a16:creationId xmlns:a16="http://schemas.microsoft.com/office/drawing/2014/main" id="{F458B9C2-BC06-46D4-91D3-DBC69622291F}"/>
               </a:ext>
             </a:extLst>
           </p:cNvPr>
@@ -10881,7 +10881,7 @@
           <p:cNvPr id="18" name="">
             <a:extLst xmlns:a="http://schemas.openxmlformats.org/drawingml/2006/main">
               <a:ext uri="{FF2B5EF4-FFF2-40B4-BE49-F238E27FC236}">
-                <a16:creationId xmlns:a16="http://schemas.microsoft.com/office/drawing/2014/main" id="{7C7E163D-7FB7-49C7-A7D5-814595ED2A54}"/>
+                <a16:creationId xmlns:a16="http://schemas.microsoft.com/office/drawing/2014/main" id="{E8C78DAF-F7B1-4DB6-9FDA-8DFEEE9B9897}"/>
               </a:ext>
             </a:extLst>
           </p:cNvPr>
@@ -11038,7 +11038,7 @@
           <p:cNvPr id="19" name="">
             <a:extLst xmlns:a="http://schemas.openxmlformats.org/drawingml/2006/main">
               <a:ext uri="{FF2B5EF4-FFF2-40B4-BE49-F238E27FC236}">
-                <a16:creationId xmlns:a16="http://schemas.microsoft.com/office/drawing/2014/main" id="{ACEB729A-5FFC-416B-96BC-BDBEE5D46368}"/>
+                <a16:creationId xmlns:a16="http://schemas.microsoft.com/office/drawing/2014/main" id="{EFF92EDE-64B1-4D8A-83F8-7E90A7836FBB}"/>
               </a:ext>
             </a:extLst>
           </p:cNvPr>
@@ -11193,7 +11193,7 @@
     </p:spTree>
     <p:extLst>
       <p:ext uri="{BB962C8B-B14F-4D97-AF65-F5344CB8AC3E}">
-        <p14:creationId xmlns:p14="http://schemas.microsoft.com/office/powerpoint/2010/main" val="524900853"/>
+        <p14:creationId xmlns:p14="http://schemas.microsoft.com/office/powerpoint/2010/main" val="1641346742"/>
       </p:ext>
     </p:extLst>
   </p:cSld>
@@ -11224,7 +11224,7 @@
           <p:cNvPr id="19" name="">
             <a:extLst xmlns:a="http://schemas.openxmlformats.org/drawingml/2006/main">
               <a:ext uri="{FF2B5EF4-FFF2-40B4-BE49-F238E27FC236}">
-                <a16:creationId xmlns:a16="http://schemas.microsoft.com/office/drawing/2014/main" id="{3C8E233F-74DC-4B27-ADAB-582151591C8E}"/>
+                <a16:creationId xmlns:a16="http://schemas.microsoft.com/office/drawing/2014/main" id="{5BA32DAF-0B45-45B5-A495-457C1A9A1183}"/>
               </a:ext>
             </a:extLst>
           </p:cNvPr>
@@ -11381,7 +11381,7 @@
           <p:cNvPr id="2" name="">
             <a:extLst xmlns:a="http://schemas.openxmlformats.org/drawingml/2006/main">
               <a:ext uri="{FF2B5EF4-FFF2-40B4-BE49-F238E27FC236}">
-                <a16:creationId xmlns:a16="http://schemas.microsoft.com/office/drawing/2014/main" id="{927D7FE9-D7F2-4823-82B6-B00774B9CA31}"/>
+                <a16:creationId xmlns:a16="http://schemas.microsoft.com/office/drawing/2014/main" id="{D144B03A-745A-4878-955D-CDA7FA2172DC}"/>
               </a:ext>
             </a:extLst>
           </p:cNvPr>
@@ -11412,7 +11412,7 @@
           <p:cNvPr id="3" name="">
             <a:extLst xmlns:a="http://schemas.openxmlformats.org/drawingml/2006/main">
               <a:ext uri="{FF2B5EF4-FFF2-40B4-BE49-F238E27FC236}">
-                <a16:creationId xmlns:a16="http://schemas.microsoft.com/office/drawing/2014/main" id="{A4C38157-1636-4D36-8A7B-EDF519E51891}"/>
+                <a16:creationId xmlns:a16="http://schemas.microsoft.com/office/drawing/2014/main" id="{C04265B6-0428-4E41-B654-C49551808401}"/>
               </a:ext>
             </a:extLst>
           </p:cNvPr>
@@ -11569,7 +11569,7 @@
           <p:cNvPr id="4" name="">
             <a:extLst xmlns:a="http://schemas.openxmlformats.org/drawingml/2006/main">
               <a:ext uri="{FF2B5EF4-FFF2-40B4-BE49-F238E27FC236}">
-                <a16:creationId xmlns:a16="http://schemas.microsoft.com/office/drawing/2014/main" id="{BE8F91AF-448A-4A5E-99E3-893C6D03BD3E}"/>
+                <a16:creationId xmlns:a16="http://schemas.microsoft.com/office/drawing/2014/main" id="{CEACC56D-A660-45EB-A41F-8C1593F72110}"/>
               </a:ext>
             </a:extLst>
           </p:cNvPr>
@@ -11600,7 +11600,7 @@
           <p:cNvPr id="5" name="">
             <a:extLst xmlns:a="http://schemas.openxmlformats.org/drawingml/2006/main">
               <a:ext uri="{FF2B5EF4-FFF2-40B4-BE49-F238E27FC236}">
-                <a16:creationId xmlns:a16="http://schemas.microsoft.com/office/drawing/2014/main" id="{459CC09A-11CD-4200-AED1-96661F3A961B}"/>
+                <a16:creationId xmlns:a16="http://schemas.microsoft.com/office/drawing/2014/main" id="{B2E7A285-E5BD-4F61-8189-44F625073065}"/>
               </a:ext>
             </a:extLst>
           </p:cNvPr>
@@ -11757,7 +11757,7 @@
           <p:cNvPr id="6" name="">
             <a:extLst xmlns:a="http://schemas.openxmlformats.org/drawingml/2006/main">
               <a:ext uri="{FF2B5EF4-FFF2-40B4-BE49-F238E27FC236}">
-                <a16:creationId xmlns:a16="http://schemas.microsoft.com/office/drawing/2014/main" id="{63B6E72A-C442-4FF8-BC59-9270901DB90E}"/>
+                <a16:creationId xmlns:a16="http://schemas.microsoft.com/office/drawing/2014/main" id="{B935CE71-118F-41DE-9468-2BE4A8AE9A05}"/>
               </a:ext>
             </a:extLst>
           </p:cNvPr>
@@ -11788,7 +11788,7 @@
           <p:cNvPr id="7" name="">
             <a:extLst xmlns:a="http://schemas.openxmlformats.org/drawingml/2006/main">
               <a:ext uri="{FF2B5EF4-FFF2-40B4-BE49-F238E27FC236}">
-                <a16:creationId xmlns:a16="http://schemas.microsoft.com/office/drawing/2014/main" id="{A275DCEF-F30B-4210-B88F-5F68F462CB51}"/>
+                <a16:creationId xmlns:a16="http://schemas.microsoft.com/office/drawing/2014/main" id="{10B04718-C443-4269-BEF7-13B4F71C4FAA}"/>
               </a:ext>
             </a:extLst>
           </p:cNvPr>
@@ -11968,7 +11968,7 @@
           <p:cNvPr id="8" name="">
             <a:extLst xmlns:a="http://schemas.openxmlformats.org/drawingml/2006/main">
               <a:ext uri="{FF2B5EF4-FFF2-40B4-BE49-F238E27FC236}">
-                <a16:creationId xmlns:a16="http://schemas.microsoft.com/office/drawing/2014/main" id="{0FED7EDD-3078-4BDE-B42C-242307CDA88B}"/>
+                <a16:creationId xmlns:a16="http://schemas.microsoft.com/office/drawing/2014/main" id="{32A0B2C4-5EB0-44CD-AF67-06F22C394463}"/>
               </a:ext>
             </a:extLst>
           </p:cNvPr>
@@ -12125,7 +12125,7 @@
           <p:cNvPr id="9" name="">
             <a:extLst xmlns:a="http://schemas.openxmlformats.org/drawingml/2006/main">
               <a:ext uri="{FF2B5EF4-FFF2-40B4-BE49-F238E27FC236}">
-                <a16:creationId xmlns:a16="http://schemas.microsoft.com/office/drawing/2014/main" id="{D706A85C-AC5B-4888-BF93-964BE343A151}"/>
+                <a16:creationId xmlns:a16="http://schemas.microsoft.com/office/drawing/2014/main" id="{7B5CC611-625F-4FD6-9F34-9B2616035D62}"/>
               </a:ext>
             </a:extLst>
           </p:cNvPr>
@@ -12156,7 +12156,7 @@
           <p:cNvPr id="10" name="">
             <a:extLst xmlns:a="http://schemas.openxmlformats.org/drawingml/2006/main">
               <a:ext uri="{FF2B5EF4-FFF2-40B4-BE49-F238E27FC236}">
-                <a16:creationId xmlns:a16="http://schemas.microsoft.com/office/drawing/2014/main" id="{485C4DAC-6734-40A6-8C0C-0B2F34C82D94}"/>
+                <a16:creationId xmlns:a16="http://schemas.microsoft.com/office/drawing/2014/main" id="{4B6CDA47-7DFE-497D-AD35-16CAAF409036}"/>
               </a:ext>
             </a:extLst>
           </p:cNvPr>
@@ -12336,7 +12336,7 @@
           <p:cNvPr id="11" name="">
             <a:extLst xmlns:a="http://schemas.openxmlformats.org/drawingml/2006/main">
               <a:ext uri="{FF2B5EF4-FFF2-40B4-BE49-F238E27FC236}">
-                <a16:creationId xmlns:a16="http://schemas.microsoft.com/office/drawing/2014/main" id="{41B5E8A9-4105-4AAD-947E-99785840055F}"/>
+                <a16:creationId xmlns:a16="http://schemas.microsoft.com/office/drawing/2014/main" id="{0BA4F50B-9729-4AA5-A2FF-A6247A95091C}"/>
               </a:ext>
             </a:extLst>
           </p:cNvPr>
@@ -12493,7 +12493,7 @@
           <p:cNvPr id="12" name="">
             <a:extLst xmlns:a="http://schemas.openxmlformats.org/drawingml/2006/main">
               <a:ext uri="{FF2B5EF4-FFF2-40B4-BE49-F238E27FC236}">
-                <a16:creationId xmlns:a16="http://schemas.microsoft.com/office/drawing/2014/main" id="{EB77B75B-8394-4545-809D-C1ED79F28D35}"/>
+                <a16:creationId xmlns:a16="http://schemas.microsoft.com/office/drawing/2014/main" id="{037EA34F-702E-43A3-9E5F-34587504B872}"/>
               </a:ext>
             </a:extLst>
           </p:cNvPr>
@@ -12524,7 +12524,7 @@
           <p:cNvPr id="13" name="">
             <a:extLst xmlns:a="http://schemas.openxmlformats.org/drawingml/2006/main">
               <a:ext uri="{FF2B5EF4-FFF2-40B4-BE49-F238E27FC236}">
-                <a16:creationId xmlns:a16="http://schemas.microsoft.com/office/drawing/2014/main" id="{BC2EF0CB-ABB2-4D2D-AF36-6D6A6EC7751D}"/>
+                <a16:creationId xmlns:a16="http://schemas.microsoft.com/office/drawing/2014/main" id="{3B605F9D-DC83-4B1B-A967-D9D2665CCA73}"/>
               </a:ext>
             </a:extLst>
           </p:cNvPr>
@@ -12704,7 +12704,7 @@
           <p:cNvPr id="14" name="">
             <a:extLst xmlns:a="http://schemas.openxmlformats.org/drawingml/2006/main">
               <a:ext uri="{FF2B5EF4-FFF2-40B4-BE49-F238E27FC236}">
-                <a16:creationId xmlns:a16="http://schemas.microsoft.com/office/drawing/2014/main" id="{816AD093-03BB-4849-9D3E-960423C75C26}"/>
+                <a16:creationId xmlns:a16="http://schemas.microsoft.com/office/drawing/2014/main" id="{DC7D3ECE-D3B3-4F81-81EC-A2E68AA70F25}"/>
               </a:ext>
             </a:extLst>
           </p:cNvPr>
@@ -12861,7 +12861,7 @@
           <p:cNvPr id="15" name="">
             <a:extLst xmlns:a="http://schemas.openxmlformats.org/drawingml/2006/main">
               <a:ext uri="{FF2B5EF4-FFF2-40B4-BE49-F238E27FC236}">
-                <a16:creationId xmlns:a16="http://schemas.microsoft.com/office/drawing/2014/main" id="{97A43541-25DE-4A67-B587-47E7678ACA25}"/>
+                <a16:creationId xmlns:a16="http://schemas.microsoft.com/office/drawing/2014/main" id="{09722D35-B0B0-4F49-AF40-D6B34009D1ED}"/>
               </a:ext>
             </a:extLst>
           </p:cNvPr>
@@ -12892,7 +12892,7 @@
           <p:cNvPr id="16" name="">
             <a:extLst xmlns:a="http://schemas.openxmlformats.org/drawingml/2006/main">
               <a:ext uri="{FF2B5EF4-FFF2-40B4-BE49-F238E27FC236}">
-                <a16:creationId xmlns:a16="http://schemas.microsoft.com/office/drawing/2014/main" id="{E4F6862A-1D3A-4CF7-A15E-2A72084F4ECE}"/>
+                <a16:creationId xmlns:a16="http://schemas.microsoft.com/office/drawing/2014/main" id="{F2CF7C75-4034-4C0D-BCA3-DE656CF88CFC}"/>
               </a:ext>
             </a:extLst>
           </p:cNvPr>
@@ -13072,7 +13072,7 @@
           <p:cNvPr id="17" name="">
             <a:extLst xmlns:a="http://schemas.openxmlformats.org/drawingml/2006/main">
               <a:ext uri="{FF2B5EF4-FFF2-40B4-BE49-F238E27FC236}">
-                <a16:creationId xmlns:a16="http://schemas.microsoft.com/office/drawing/2014/main" id="{7D7AE747-0F1D-4B8B-9B63-3008D5209091}"/>
+                <a16:creationId xmlns:a16="http://schemas.microsoft.com/office/drawing/2014/main" id="{F21445CC-5C6B-4E19-BEB0-3F59CE0DC89A}"/>
               </a:ext>
             </a:extLst>
           </p:cNvPr>
@@ -13432,7 +13432,7 @@
           <p:cNvPr id="18" name="">
             <a:extLst xmlns:a="http://schemas.openxmlformats.org/drawingml/2006/main">
               <a:ext uri="{FF2B5EF4-FFF2-40B4-BE49-F238E27FC236}">
-                <a16:creationId xmlns:a16="http://schemas.microsoft.com/office/drawing/2014/main" id="{521FFA89-C9A6-4A79-9E95-D442DCBA6A39}"/>
+                <a16:creationId xmlns:a16="http://schemas.microsoft.com/office/drawing/2014/main" id="{8EC29BF8-9B1A-465B-B788-44B595128050}"/>
               </a:ext>
             </a:extLst>
           </p:cNvPr>
@@ -13587,7 +13587,7 @@
     </p:spTree>
     <p:extLst>
       <p:ext uri="{BB962C8B-B14F-4D97-AF65-F5344CB8AC3E}">
-        <p14:creationId xmlns:p14="http://schemas.microsoft.com/office/powerpoint/2010/main" val="2103894122"/>
+        <p14:creationId xmlns:p14="http://schemas.microsoft.com/office/powerpoint/2010/main" val="1575368137"/>
       </p:ext>
     </p:extLst>
   </p:cSld>
@@ -13618,7 +13618,7 @@
           <p:cNvPr id="26" name="">
             <a:extLst xmlns:a="http://schemas.openxmlformats.org/drawingml/2006/main">
               <a:ext uri="{FF2B5EF4-FFF2-40B4-BE49-F238E27FC236}">
-                <a16:creationId xmlns:a16="http://schemas.microsoft.com/office/drawing/2014/main" id="{6CC93A78-5B15-4AE3-82D3-82F5054C16A1}"/>
+                <a16:creationId xmlns:a16="http://schemas.microsoft.com/office/drawing/2014/main" id="{34D8DE16-8C4C-4B85-9773-25C4D64D4C92}"/>
               </a:ext>
             </a:extLst>
           </p:cNvPr>
@@ -13775,7 +13775,7 @@
           <p:cNvPr id="2" name="">
             <a:extLst xmlns:a="http://schemas.openxmlformats.org/drawingml/2006/main">
               <a:ext uri="{FF2B5EF4-FFF2-40B4-BE49-F238E27FC236}">
-                <a16:creationId xmlns:a16="http://schemas.microsoft.com/office/drawing/2014/main" id="{B5535EA9-F0AE-4F01-A832-F1CF257B8DAE}"/>
+                <a16:creationId xmlns:a16="http://schemas.microsoft.com/office/drawing/2014/main" id="{09ADC8C3-7312-45F3-9CAE-DCA34307FABC}"/>
               </a:ext>
             </a:extLst>
           </p:cNvPr>
@@ -13806,7 +13806,7 @@
           <p:cNvPr id="3" name="">
             <a:extLst xmlns:a="http://schemas.openxmlformats.org/drawingml/2006/main">
               <a:ext uri="{FF2B5EF4-FFF2-40B4-BE49-F238E27FC236}">
-                <a16:creationId xmlns:a16="http://schemas.microsoft.com/office/drawing/2014/main" id="{FDC6CC02-2DA8-49EE-AFD3-19816C7EAF24}"/>
+                <a16:creationId xmlns:a16="http://schemas.microsoft.com/office/drawing/2014/main" id="{6FD8C5BE-BD8A-4D69-9CDF-D0A39FB79BF2}"/>
               </a:ext>
             </a:extLst>
           </p:cNvPr>
@@ -13963,7 +13963,7 @@
           <p:cNvPr id="4" name="">
             <a:extLst xmlns:a="http://schemas.openxmlformats.org/drawingml/2006/main">
               <a:ext uri="{FF2B5EF4-FFF2-40B4-BE49-F238E27FC236}">
-                <a16:creationId xmlns:a16="http://schemas.microsoft.com/office/drawing/2014/main" id="{96974B0D-DC7E-4EEC-B16E-627A7745ECB3}"/>
+                <a16:creationId xmlns:a16="http://schemas.microsoft.com/office/drawing/2014/main" id="{8E368BD7-5A73-4714-A072-8D225A216827}"/>
               </a:ext>
             </a:extLst>
           </p:cNvPr>
@@ -13996,7 +13996,7 @@
           <p:cNvPr id="5" name="">
             <a:extLst xmlns:a="http://schemas.openxmlformats.org/drawingml/2006/main">
               <a:ext uri="{FF2B5EF4-FFF2-40B4-BE49-F238E27FC236}">
-                <a16:creationId xmlns:a16="http://schemas.microsoft.com/office/drawing/2014/main" id="{2542C57D-BACC-4D39-9C5F-F9C252E6B578}"/>
+                <a16:creationId xmlns:a16="http://schemas.microsoft.com/office/drawing/2014/main" id="{57E90828-0E59-47DD-AABC-161B18B75C31}"/>
               </a:ext>
             </a:extLst>
           </p:cNvPr>
@@ -14153,7 +14153,7 @@
           <p:cNvPr id="6" name="">
             <a:extLst xmlns:a="http://schemas.openxmlformats.org/drawingml/2006/main">
               <a:ext uri="{FF2B5EF4-FFF2-40B4-BE49-F238E27FC236}">
-                <a16:creationId xmlns:a16="http://schemas.microsoft.com/office/drawing/2014/main" id="{5DCDE05C-FFD0-4E39-8137-99FCDFCBB8CB}"/>
+                <a16:creationId xmlns:a16="http://schemas.microsoft.com/office/drawing/2014/main" id="{13CA7CD4-1DF1-4B44-963E-CCA0D153376B}"/>
               </a:ext>
             </a:extLst>
           </p:cNvPr>
@@ -14333,7 +14333,7 @@
           <p:cNvPr id="7" name="">
             <a:extLst xmlns:a="http://schemas.openxmlformats.org/drawingml/2006/main">
               <a:ext uri="{FF2B5EF4-FFF2-40B4-BE49-F238E27FC236}">
-                <a16:creationId xmlns:a16="http://schemas.microsoft.com/office/drawing/2014/main" id="{5C34FF7D-6D2B-4284-83AD-09E00720F541}"/>
+                <a16:creationId xmlns:a16="http://schemas.microsoft.com/office/drawing/2014/main" id="{6381AA77-2D4A-440E-B934-55B612814D49}"/>
               </a:ext>
             </a:extLst>
           </p:cNvPr>
@@ -14364,7 +14364,7 @@
           <p:cNvPr id="8" name="">
             <a:extLst xmlns:a="http://schemas.openxmlformats.org/drawingml/2006/main">
               <a:ext uri="{FF2B5EF4-FFF2-40B4-BE49-F238E27FC236}">
-                <a16:creationId xmlns:a16="http://schemas.microsoft.com/office/drawing/2014/main" id="{DA2C2AFD-EA0F-4536-8E84-58FA450D9607}"/>
+                <a16:creationId xmlns:a16="http://schemas.microsoft.com/office/drawing/2014/main" id="{32118A52-DE58-4EC5-9D43-B25F444AB2D7}"/>
               </a:ext>
             </a:extLst>
           </p:cNvPr>
@@ -14397,7 +14397,7 @@
           <p:cNvPr id="9" name="">
             <a:extLst xmlns:a="http://schemas.openxmlformats.org/drawingml/2006/main">
               <a:ext uri="{FF2B5EF4-FFF2-40B4-BE49-F238E27FC236}">
-                <a16:creationId xmlns:a16="http://schemas.microsoft.com/office/drawing/2014/main" id="{4C16EEFB-38A4-41AE-A890-AB1DB1B31229}"/>
+                <a16:creationId xmlns:a16="http://schemas.microsoft.com/office/drawing/2014/main" id="{1290BC6C-A22C-4456-9EFC-AE776ABAB5E3}"/>
               </a:ext>
             </a:extLst>
           </p:cNvPr>
@@ -14554,7 +14554,7 @@
           <p:cNvPr id="10" name="">
             <a:extLst xmlns:a="http://schemas.openxmlformats.org/drawingml/2006/main">
               <a:ext uri="{FF2B5EF4-FFF2-40B4-BE49-F238E27FC236}">
-                <a16:creationId xmlns:a16="http://schemas.microsoft.com/office/drawing/2014/main" id="{336116DB-A297-4925-B10F-46E19820B74E}"/>
+                <a16:creationId xmlns:a16="http://schemas.microsoft.com/office/drawing/2014/main" id="{6CDBCF89-2B0E-48DE-8788-BE7DECA44312}"/>
               </a:ext>
             </a:extLst>
           </p:cNvPr>
@@ -14734,7 +14734,7 @@
           <p:cNvPr id="11" name="">
             <a:extLst xmlns:a="http://schemas.openxmlformats.org/drawingml/2006/main">
               <a:ext uri="{FF2B5EF4-FFF2-40B4-BE49-F238E27FC236}">
-                <a16:creationId xmlns:a16="http://schemas.microsoft.com/office/drawing/2014/main" id="{89490618-50DD-436A-8B8C-4AD152099264}"/>
+                <a16:creationId xmlns:a16="http://schemas.microsoft.com/office/drawing/2014/main" id="{8D040A47-CCCD-4BC9-BD30-1395ECD9A558}"/>
               </a:ext>
             </a:extLst>
           </p:cNvPr>
@@ -14765,7 +14765,7 @@
           <p:cNvPr id="12" name="">
             <a:extLst xmlns:a="http://schemas.openxmlformats.org/drawingml/2006/main">
               <a:ext uri="{FF2B5EF4-FFF2-40B4-BE49-F238E27FC236}">
-                <a16:creationId xmlns:a16="http://schemas.microsoft.com/office/drawing/2014/main" id="{46099B58-0405-49E5-8C2D-A4599695FC73}"/>
+                <a16:creationId xmlns:a16="http://schemas.microsoft.com/office/drawing/2014/main" id="{3F7A6D1B-67CC-4EDE-9AEF-476A3615D952}"/>
               </a:ext>
             </a:extLst>
           </p:cNvPr>
@@ -14798,7 +14798,7 @@
           <p:cNvPr id="13" name="">
             <a:extLst xmlns:a="http://schemas.openxmlformats.org/drawingml/2006/main">
               <a:ext uri="{FF2B5EF4-FFF2-40B4-BE49-F238E27FC236}">
-                <a16:creationId xmlns:a16="http://schemas.microsoft.com/office/drawing/2014/main" id="{197442F6-C780-46DA-AA9C-4FEB22B10A2C}"/>
+                <a16:creationId xmlns:a16="http://schemas.microsoft.com/office/drawing/2014/main" id="{2A74580C-AEAA-4885-B2A3-E2D315D18AFB}"/>
               </a:ext>
             </a:extLst>
           </p:cNvPr>
@@ -14955,7 +14955,7 @@
           <p:cNvPr id="14" name="">
             <a:extLst xmlns:a="http://schemas.openxmlformats.org/drawingml/2006/main">
               <a:ext uri="{FF2B5EF4-FFF2-40B4-BE49-F238E27FC236}">
-                <a16:creationId xmlns:a16="http://schemas.microsoft.com/office/drawing/2014/main" id="{14FC7D54-6837-4820-83AA-77005CB17911}"/>
+                <a16:creationId xmlns:a16="http://schemas.microsoft.com/office/drawing/2014/main" id="{981D3365-8926-4FFD-8455-E0AEBCF27E20}"/>
               </a:ext>
             </a:extLst>
           </p:cNvPr>
@@ -15135,7 +15135,7 @@
           <p:cNvPr id="15" name="">
             <a:extLst xmlns:a="http://schemas.openxmlformats.org/drawingml/2006/main">
               <a:ext uri="{FF2B5EF4-FFF2-40B4-BE49-F238E27FC236}">
-                <a16:creationId xmlns:a16="http://schemas.microsoft.com/office/drawing/2014/main" id="{73973FAE-1A28-4226-A7A4-484629FB78D8}"/>
+                <a16:creationId xmlns:a16="http://schemas.microsoft.com/office/drawing/2014/main" id="{BEB62677-8AE8-4BCE-B922-839D2D39951A}"/>
               </a:ext>
             </a:extLst>
           </p:cNvPr>
@@ -15166,7 +15166,7 @@
           <p:cNvPr id="16" name="">
             <a:extLst xmlns:a="http://schemas.openxmlformats.org/drawingml/2006/main">
               <a:ext uri="{FF2B5EF4-FFF2-40B4-BE49-F238E27FC236}">
-                <a16:creationId xmlns:a16="http://schemas.microsoft.com/office/drawing/2014/main" id="{288596DD-94D7-44D5-9484-AFC398CE3005}"/>
+                <a16:creationId xmlns:a16="http://schemas.microsoft.com/office/drawing/2014/main" id="{2BF91937-FC12-4C59-9CEB-27A034B3C759}"/>
               </a:ext>
             </a:extLst>
           </p:cNvPr>
@@ -15199,7 +15199,7 @@
           <p:cNvPr id="17" name="">
             <a:extLst xmlns:a="http://schemas.openxmlformats.org/drawingml/2006/main">
               <a:ext uri="{FF2B5EF4-FFF2-40B4-BE49-F238E27FC236}">
-                <a16:creationId xmlns:a16="http://schemas.microsoft.com/office/drawing/2014/main" id="{CB2CE307-345A-4A1B-91E6-1BCC59CF3A38}"/>
+                <a16:creationId xmlns:a16="http://schemas.microsoft.com/office/drawing/2014/main" id="{DFC355FE-5946-4217-A975-71C7A8439C03}"/>
               </a:ext>
             </a:extLst>
           </p:cNvPr>
@@ -15356,7 +15356,7 @@
           <p:cNvPr id="18" name="">
             <a:extLst xmlns:a="http://schemas.openxmlformats.org/drawingml/2006/main">
               <a:ext uri="{FF2B5EF4-FFF2-40B4-BE49-F238E27FC236}">
-                <a16:creationId xmlns:a16="http://schemas.microsoft.com/office/drawing/2014/main" id="{D75B6433-7589-46F1-827D-65509A9BF300}"/>
+                <a16:creationId xmlns:a16="http://schemas.microsoft.com/office/drawing/2014/main" id="{530E08B9-A0BC-4857-89EB-1C2C60FE7034}"/>
               </a:ext>
             </a:extLst>
           </p:cNvPr>
@@ -15536,7 +15536,7 @@
           <p:cNvPr id="19" name="">
             <a:extLst xmlns:a="http://schemas.openxmlformats.org/drawingml/2006/main">
               <a:ext uri="{FF2B5EF4-FFF2-40B4-BE49-F238E27FC236}">
-                <a16:creationId xmlns:a16="http://schemas.microsoft.com/office/drawing/2014/main" id="{FA0E586B-873D-416F-9A56-C88667836B52}"/>
+                <a16:creationId xmlns:a16="http://schemas.microsoft.com/office/drawing/2014/main" id="{014C85DC-AF1D-4CDD-A332-696541C0C2F8}"/>
               </a:ext>
             </a:extLst>
           </p:cNvPr>
@@ -15693,7 +15693,7 @@
           <p:cNvPr id="20" name="">
             <a:extLst xmlns:a="http://schemas.openxmlformats.org/drawingml/2006/main">
               <a:ext uri="{FF2B5EF4-FFF2-40B4-BE49-F238E27FC236}">
-                <a16:creationId xmlns:a16="http://schemas.microsoft.com/office/drawing/2014/main" id="{CBBE86E9-2518-4A7B-9360-88B556081912}"/>
+                <a16:creationId xmlns:a16="http://schemas.microsoft.com/office/drawing/2014/main" id="{CFEFE6AB-C2A0-426C-87C9-89E85530AE2C}"/>
               </a:ext>
             </a:extLst>
           </p:cNvPr>
@@ -15850,7 +15850,7 @@
           <p:cNvPr id="21" name="">
             <a:extLst xmlns:a="http://schemas.openxmlformats.org/drawingml/2006/main">
               <a:ext uri="{FF2B5EF4-FFF2-40B4-BE49-F238E27FC236}">
-                <a16:creationId xmlns:a16="http://schemas.microsoft.com/office/drawing/2014/main" id="{A3D7B54D-8A13-467C-86BE-B4025B444E05}"/>
+                <a16:creationId xmlns:a16="http://schemas.microsoft.com/office/drawing/2014/main" id="{3770C5BB-FBF6-4329-B478-7CED89A77E5A}"/>
               </a:ext>
             </a:extLst>
           </p:cNvPr>
@@ -16007,7 +16007,7 @@
           <p:cNvPr id="22" name="">
             <a:extLst xmlns:a="http://schemas.openxmlformats.org/drawingml/2006/main">
               <a:ext uri="{FF2B5EF4-FFF2-40B4-BE49-F238E27FC236}">
-                <a16:creationId xmlns:a16="http://schemas.microsoft.com/office/drawing/2014/main" id="{2C2F010E-3FF7-4899-98C3-4AC23CC2E07E}"/>
+                <a16:creationId xmlns:a16="http://schemas.microsoft.com/office/drawing/2014/main" id="{948F36FE-9D63-4477-88E1-6CFD450381C8}"/>
               </a:ext>
             </a:extLst>
           </p:cNvPr>
@@ -16164,7 +16164,7 @@
           <p:cNvPr id="23" name="">
             <a:extLst xmlns:a="http://schemas.openxmlformats.org/drawingml/2006/main">
               <a:ext uri="{FF2B5EF4-FFF2-40B4-BE49-F238E27FC236}">
-                <a16:creationId xmlns:a16="http://schemas.microsoft.com/office/drawing/2014/main" id="{334417A1-8324-4CFB-B3A9-75DEFE8104D9}"/>
+                <a16:creationId xmlns:a16="http://schemas.microsoft.com/office/drawing/2014/main" id="{06476118-0A90-445F-8F77-556006290AC6}"/>
               </a:ext>
             </a:extLst>
           </p:cNvPr>
@@ -16321,7 +16321,7 @@
           <p:cNvPr id="24" name="">
             <a:extLst xmlns:a="http://schemas.openxmlformats.org/drawingml/2006/main">
               <a:ext uri="{FF2B5EF4-FFF2-40B4-BE49-F238E27FC236}">
-                <a16:creationId xmlns:a16="http://schemas.microsoft.com/office/drawing/2014/main" id="{9D1BA594-3B02-42D0-A249-6B229B8BF02F}"/>
+                <a16:creationId xmlns:a16="http://schemas.microsoft.com/office/drawing/2014/main" id="{9623F0FC-6E01-45FC-9006-79E5EF1E86B9}"/>
               </a:ext>
             </a:extLst>
           </p:cNvPr>
@@ -16478,7 +16478,7 @@
           <p:cNvPr id="25" name="">
             <a:extLst xmlns:a="http://schemas.openxmlformats.org/drawingml/2006/main">
               <a:ext uri="{FF2B5EF4-FFF2-40B4-BE49-F238E27FC236}">
-                <a16:creationId xmlns:a16="http://schemas.microsoft.com/office/drawing/2014/main" id="{ACB1C106-3736-4C60-BE99-8E38124F51F1}"/>
+                <a16:creationId xmlns:a16="http://schemas.microsoft.com/office/drawing/2014/main" id="{0F0AC0E7-F10B-4178-B9C9-EA78B5FD165E}"/>
               </a:ext>
             </a:extLst>
           </p:cNvPr>
@@ -16633,7 +16633,7 @@
     </p:spTree>
     <p:extLst>
       <p:ext uri="{BB962C8B-B14F-4D97-AF65-F5344CB8AC3E}">
-        <p14:creationId xmlns:p14="http://schemas.microsoft.com/office/powerpoint/2010/main" val="1715253767"/>
+        <p14:creationId xmlns:p14="http://schemas.microsoft.com/office/powerpoint/2010/main" val="953366793"/>
       </p:ext>
     </p:extLst>
   </p:cSld>
@@ -16664,7 +16664,7 @@
           <p:cNvPr id="10" name="">
             <a:extLst xmlns:a="http://schemas.openxmlformats.org/drawingml/2006/main">
               <a:ext uri="{FF2B5EF4-FFF2-40B4-BE49-F238E27FC236}">
-                <a16:creationId xmlns:a16="http://schemas.microsoft.com/office/drawing/2014/main" id="{151D67D2-F8E0-44A7-9362-B7197179BF77}"/>
+                <a16:creationId xmlns:a16="http://schemas.microsoft.com/office/drawing/2014/main" id="{4321A20F-A84F-4B0E-A199-3CF441712055}"/>
               </a:ext>
             </a:extLst>
           </p:cNvPr>
@@ -16821,7 +16821,7 @@
           <p:cNvPr id="2" name="">
             <a:extLst xmlns:a="http://schemas.openxmlformats.org/drawingml/2006/main">
               <a:ext uri="{FF2B5EF4-FFF2-40B4-BE49-F238E27FC236}">
-                <a16:creationId xmlns:a16="http://schemas.microsoft.com/office/drawing/2014/main" id="{75E811E1-1049-464E-BF7F-F16101D9BC6B}"/>
+                <a16:creationId xmlns:a16="http://schemas.microsoft.com/office/drawing/2014/main" id="{33C097DB-F25E-40E6-B7D9-553BE629FD14}"/>
               </a:ext>
             </a:extLst>
           </p:cNvPr>
@@ -16852,7 +16852,7 @@
           <p:cNvPr id="3" name="">
             <a:extLst xmlns:a="http://schemas.openxmlformats.org/drawingml/2006/main">
               <a:ext uri="{FF2B5EF4-FFF2-40B4-BE49-F238E27FC236}">
-                <a16:creationId xmlns:a16="http://schemas.microsoft.com/office/drawing/2014/main" id="{A666DE94-6A8D-4492-A5A4-FC9A68B9F8EE}"/>
+                <a16:creationId xmlns:a16="http://schemas.microsoft.com/office/drawing/2014/main" id="{AE1D7426-10A2-469B-AC07-9301BF0D674D}"/>
               </a:ext>
             </a:extLst>
           </p:cNvPr>
@@ -17009,7 +17009,7 @@
           <p:cNvPr id="4" name="Chart">
             <a:extLst xmlns:a="http://schemas.openxmlformats.org/drawingml/2006/main">
               <a:ext uri="{FF2B5EF4-FFF2-40B4-BE49-F238E27FC236}">
-                <a16:creationId xmlns:a16="http://schemas.microsoft.com/office/drawing/2014/main" id="{6286154C-EB5A-4072-86DC-4B922E84C25E}"/>
+                <a16:creationId xmlns:a16="http://schemas.microsoft.com/office/drawing/2014/main" id="{494F2B38-7DD9-418E-9E36-77008F8C0986}"/>
               </a:ext>
             </a:extLst>
           </p:cNvPr>
@@ -17022,7 +17022,7 @@
         </p:xfrm>
         <a:graphic xmlns:a="http://schemas.openxmlformats.org/drawingml/2006/main">
           <a:graphicData uri="http://schemas.openxmlformats.org/drawingml/2006/chart">
-            <c:chart xmlns:r="http://schemas.openxmlformats.org/officeDocument/2006/relationships" xmlns:c="http://schemas.openxmlformats.org/drawingml/2006/chart" r:id="Rcbf9b3322f6e4227"/>
+            <c:chart xmlns:r="http://schemas.openxmlformats.org/officeDocument/2006/relationships" xmlns:c="http://schemas.openxmlformats.org/drawingml/2006/chart" r:id="Rd2870902efce4ce2"/>
           </a:graphicData>
         </a:graphic>
       </p:graphicFrame>
@@ -17031,7 +17031,7 @@
           <p:cNvPr id="5" name="">
             <a:extLst xmlns:a="http://schemas.openxmlformats.org/drawingml/2006/main">
               <a:ext uri="{FF2B5EF4-FFF2-40B4-BE49-F238E27FC236}">
-                <a16:creationId xmlns:a16="http://schemas.microsoft.com/office/drawing/2014/main" id="{E4E7ED0B-B1C2-4ED0-93E7-734EFDB0AB3C}"/>
+                <a16:creationId xmlns:a16="http://schemas.microsoft.com/office/drawing/2014/main" id="{DF132460-3931-4E49-A888-F811E853CCD3}"/>
               </a:ext>
             </a:extLst>
           </p:cNvPr>
@@ -17188,7 +17188,7 @@
           <p:cNvPr id="6" name="">
             <a:extLst xmlns:a="http://schemas.openxmlformats.org/drawingml/2006/main">
               <a:ext uri="{FF2B5EF4-FFF2-40B4-BE49-F238E27FC236}">
-                <a16:creationId xmlns:a16="http://schemas.microsoft.com/office/drawing/2014/main" id="{4929E1B0-4003-44F2-ADAA-4E75E2E4720F}"/>
+                <a16:creationId xmlns:a16="http://schemas.microsoft.com/office/drawing/2014/main" id="{5D1A102B-E361-4B15-B9AF-D319B53C80CC}"/>
               </a:ext>
             </a:extLst>
           </p:cNvPr>
@@ -17368,7 +17368,7 @@
           <p:cNvPr id="7" name="">
             <a:extLst xmlns:a="http://schemas.openxmlformats.org/drawingml/2006/main">
               <a:ext uri="{FF2B5EF4-FFF2-40B4-BE49-F238E27FC236}">
-                <a16:creationId xmlns:a16="http://schemas.microsoft.com/office/drawing/2014/main" id="{31EB1656-0901-430E-8C01-F269A824B1F6}"/>
+                <a16:creationId xmlns:a16="http://schemas.microsoft.com/office/drawing/2014/main" id="{F76CF80E-52C2-4E8D-857E-CFC98239B80A}"/>
               </a:ext>
             </a:extLst>
           </p:cNvPr>
@@ -17525,7 +17525,7 @@
           <p:cNvPr id="8" name="">
             <a:extLst xmlns:a="http://schemas.openxmlformats.org/drawingml/2006/main">
               <a:ext uri="{FF2B5EF4-FFF2-40B4-BE49-F238E27FC236}">
-                <a16:creationId xmlns:a16="http://schemas.microsoft.com/office/drawing/2014/main" id="{1F0FFB9B-F95A-42EB-86F0-7371AB7CFE8A}"/>
+                <a16:creationId xmlns:a16="http://schemas.microsoft.com/office/drawing/2014/main" id="{10B07685-6F6D-4F83-B802-F0BB41D81CC4}"/>
               </a:ext>
             </a:extLst>
           </p:cNvPr>
@@ -17705,7 +17705,7 @@
           <p:cNvPr id="9" name="">
             <a:extLst xmlns:a="http://schemas.openxmlformats.org/drawingml/2006/main">
               <a:ext uri="{FF2B5EF4-FFF2-40B4-BE49-F238E27FC236}">
-                <a16:creationId xmlns:a16="http://schemas.microsoft.com/office/drawing/2014/main" id="{D91FE581-6E9E-4B76-BB32-4C5D6F9D304E}"/>
+                <a16:creationId xmlns:a16="http://schemas.microsoft.com/office/drawing/2014/main" id="{C6E4ABE5-AAAF-45A4-8366-14C059AF854B}"/>
               </a:ext>
             </a:extLst>
           </p:cNvPr>
@@ -17860,7 +17860,7 @@
     </p:spTree>
     <p:extLst>
       <p:ext uri="{BB962C8B-B14F-4D97-AF65-F5344CB8AC3E}">
-        <p14:creationId xmlns:p14="http://schemas.microsoft.com/office/powerpoint/2010/main" val="1235419557"/>
+        <p14:creationId xmlns:p14="http://schemas.microsoft.com/office/powerpoint/2010/main" val="24854728"/>
       </p:ext>
     </p:extLst>
   </p:cSld>
@@ -17891,7 +17891,7 @@
           <p:cNvPr id="15" name="">
             <a:extLst xmlns:a="http://schemas.openxmlformats.org/drawingml/2006/main">
               <a:ext uri="{FF2B5EF4-FFF2-40B4-BE49-F238E27FC236}">
-                <a16:creationId xmlns:a16="http://schemas.microsoft.com/office/drawing/2014/main" id="{81F627D7-F0C6-4847-8758-EDE6F60000B8}"/>
+                <a16:creationId xmlns:a16="http://schemas.microsoft.com/office/drawing/2014/main" id="{8512C753-FD2B-406B-94F2-2A5427439B0F}"/>
               </a:ext>
             </a:extLst>
           </p:cNvPr>
@@ -18048,7 +18048,7 @@
           <p:cNvPr id="2" name="">
             <a:extLst xmlns:a="http://schemas.openxmlformats.org/drawingml/2006/main">
               <a:ext uri="{FF2B5EF4-FFF2-40B4-BE49-F238E27FC236}">
-                <a16:creationId xmlns:a16="http://schemas.microsoft.com/office/drawing/2014/main" id="{7249A483-264B-4527-89C8-334AA8BA0170}"/>
+                <a16:creationId xmlns:a16="http://schemas.microsoft.com/office/drawing/2014/main" id="{029EBE89-01E4-463B-AA10-81E07D5216EC}"/>
               </a:ext>
             </a:extLst>
           </p:cNvPr>
@@ -18079,7 +18079,7 @@
           <p:cNvPr id="3" name="">
             <a:extLst xmlns:a="http://schemas.openxmlformats.org/drawingml/2006/main">
               <a:ext uri="{FF2B5EF4-FFF2-40B4-BE49-F238E27FC236}">
-                <a16:creationId xmlns:a16="http://schemas.microsoft.com/office/drawing/2014/main" id="{619EFA43-C43B-4877-ACBF-84E89902769E}"/>
+                <a16:creationId xmlns:a16="http://schemas.microsoft.com/office/drawing/2014/main" id="{3084CDDA-5B26-4696-A053-237AEE9A0765}"/>
               </a:ext>
             </a:extLst>
           </p:cNvPr>
@@ -18236,7 +18236,7 @@
           <p:cNvPr id="4" name="">
             <a:extLst xmlns:a="http://schemas.openxmlformats.org/drawingml/2006/main">
               <a:ext uri="{FF2B5EF4-FFF2-40B4-BE49-F238E27FC236}">
-                <a16:creationId xmlns:a16="http://schemas.microsoft.com/office/drawing/2014/main" id="{C91095DC-BF2E-417A-94BC-AB3DB0A237E1}"/>
+                <a16:creationId xmlns:a16="http://schemas.microsoft.com/office/drawing/2014/main" id="{893DBFF5-6757-4419-87C7-D6CF3F06B359}"/>
               </a:ext>
             </a:extLst>
           </p:cNvPr>
@@ -18393,7 +18393,7 @@
           <p:cNvPr id="5" name="">
             <a:extLst xmlns:a="http://schemas.openxmlformats.org/drawingml/2006/main">
               <a:ext uri="{FF2B5EF4-FFF2-40B4-BE49-F238E27FC236}">
-                <a16:creationId xmlns:a16="http://schemas.microsoft.com/office/drawing/2014/main" id="{A2224143-EB14-48CA-BD0A-34FB4899D839}"/>
+                <a16:creationId xmlns:a16="http://schemas.microsoft.com/office/drawing/2014/main" id="{D706821E-5782-43DC-B4CA-BD4983E3BD79}"/>
               </a:ext>
             </a:extLst>
           </p:cNvPr>
@@ -18550,7 +18550,7 @@
           <p:cNvPr id="6" name="">
             <a:extLst xmlns:a="http://schemas.openxmlformats.org/drawingml/2006/main">
               <a:ext uri="{FF2B5EF4-FFF2-40B4-BE49-F238E27FC236}">
-                <a16:creationId xmlns:a16="http://schemas.microsoft.com/office/drawing/2014/main" id="{9DBF0729-6101-46F8-9549-F687CF831794}"/>
+                <a16:creationId xmlns:a16="http://schemas.microsoft.com/office/drawing/2014/main" id="{6016196D-910D-4722-ACCB-B4EC28535651}"/>
               </a:ext>
             </a:extLst>
           </p:cNvPr>
@@ -18730,7 +18730,7 @@
           <p:cNvPr id="7" name="">
             <a:extLst xmlns:a="http://schemas.openxmlformats.org/drawingml/2006/main">
               <a:ext uri="{FF2B5EF4-FFF2-40B4-BE49-F238E27FC236}">
-                <a16:creationId xmlns:a16="http://schemas.microsoft.com/office/drawing/2014/main" id="{34F7D009-E827-4D92-9084-37F09CC64D97}"/>
+                <a16:creationId xmlns:a16="http://schemas.microsoft.com/office/drawing/2014/main" id="{57E2E9FE-6B99-4C75-A245-09BF37C6F574}"/>
               </a:ext>
             </a:extLst>
           </p:cNvPr>
@@ -18887,7 +18887,7 @@
           <p:cNvPr id="8" name="">
             <a:extLst xmlns:a="http://schemas.openxmlformats.org/drawingml/2006/main">
               <a:ext uri="{FF2B5EF4-FFF2-40B4-BE49-F238E27FC236}">
-                <a16:creationId xmlns:a16="http://schemas.microsoft.com/office/drawing/2014/main" id="{B1F082C5-6A4C-46D4-AB7A-5788DB339E98}"/>
+                <a16:creationId xmlns:a16="http://schemas.microsoft.com/office/drawing/2014/main" id="{61FC311E-9D8D-4388-8C76-B55888588D6A}"/>
               </a:ext>
             </a:extLst>
           </p:cNvPr>
@@ -19067,7 +19067,7 @@
           <p:cNvPr id="9" name="">
             <a:extLst xmlns:a="http://schemas.openxmlformats.org/drawingml/2006/main">
               <a:ext uri="{FF2B5EF4-FFF2-40B4-BE49-F238E27FC236}">
-                <a16:creationId xmlns:a16="http://schemas.microsoft.com/office/drawing/2014/main" id="{2F6FA530-2D49-4426-AF6B-A26B74219543}"/>
+                <a16:creationId xmlns:a16="http://schemas.microsoft.com/office/drawing/2014/main" id="{AE601F65-B6DF-4E30-869C-F1AEF4CCAF62}"/>
               </a:ext>
             </a:extLst>
           </p:cNvPr>
@@ -19224,7 +19224,7 @@
           <p:cNvPr id="10" name="">
             <a:extLst xmlns:a="http://schemas.openxmlformats.org/drawingml/2006/main">
               <a:ext uri="{FF2B5EF4-FFF2-40B4-BE49-F238E27FC236}">
-                <a16:creationId xmlns:a16="http://schemas.microsoft.com/office/drawing/2014/main" id="{789E302D-089C-4BC0-8684-22F1ECC04C27}"/>
+                <a16:creationId xmlns:a16="http://schemas.microsoft.com/office/drawing/2014/main" id="{2194869C-6F99-499A-9E6B-CB873237E20F}"/>
               </a:ext>
             </a:extLst>
           </p:cNvPr>
@@ -19381,7 +19381,7 @@
           <p:cNvPr id="11" name="">
             <a:extLst xmlns:a="http://schemas.openxmlformats.org/drawingml/2006/main">
               <a:ext uri="{FF2B5EF4-FFF2-40B4-BE49-F238E27FC236}">
-                <a16:creationId xmlns:a16="http://schemas.microsoft.com/office/drawing/2014/main" id="{50F065E9-CF46-46AE-8519-F20F1253559B}"/>
+                <a16:creationId xmlns:a16="http://schemas.microsoft.com/office/drawing/2014/main" id="{F31431F7-94CF-48AF-94EA-C7B936FC9CFD}"/>
               </a:ext>
             </a:extLst>
           </p:cNvPr>
@@ -19538,7 +19538,7 @@
           <p:cNvPr id="12" name="Chart">
             <a:extLst xmlns:a="http://schemas.openxmlformats.org/drawingml/2006/main">
               <a:ext uri="{FF2B5EF4-FFF2-40B4-BE49-F238E27FC236}">
-                <a16:creationId xmlns:a16="http://schemas.microsoft.com/office/drawing/2014/main" id="{6C94B470-2395-480E-86CD-68E18C1FF478}"/>
+                <a16:creationId xmlns:a16="http://schemas.microsoft.com/office/drawing/2014/main" id="{94956780-E794-4628-845D-70737944A640}"/>
               </a:ext>
             </a:extLst>
           </p:cNvPr>
@@ -19551,7 +19551,7 @@
         </p:xfrm>
         <a:graphic xmlns:a="http://schemas.openxmlformats.org/drawingml/2006/main">
           <a:graphicData uri="http://schemas.openxmlformats.org/drawingml/2006/chart">
-            <c:chart xmlns:r="http://schemas.openxmlformats.org/officeDocument/2006/relationships" xmlns:c="http://schemas.openxmlformats.org/drawingml/2006/chart" r:id="Rb1874ec1c4fa4d02"/>
+            <c:chart xmlns:r="http://schemas.openxmlformats.org/officeDocument/2006/relationships" xmlns:c="http://schemas.openxmlformats.org/drawingml/2006/chart" r:id="R432e243be71f40e1"/>
           </a:graphicData>
         </a:graphic>
       </p:graphicFrame>
@@ -19560,7 +19560,7 @@
           <p:cNvPr id="13" name="">
             <a:extLst xmlns:a="http://schemas.openxmlformats.org/drawingml/2006/main">
               <a:ext uri="{FF2B5EF4-FFF2-40B4-BE49-F238E27FC236}">
-                <a16:creationId xmlns:a16="http://schemas.microsoft.com/office/drawing/2014/main" id="{AAFA2717-28F7-4B37-A1AB-83A8120D701C}"/>
+                <a16:creationId xmlns:a16="http://schemas.microsoft.com/office/drawing/2014/main" id="{84F450B2-632E-4F31-A35E-4BAC3171D1EE}"/>
               </a:ext>
             </a:extLst>
           </p:cNvPr>
@@ -19717,7 +19717,7 @@
           <p:cNvPr id="14" name="">
             <a:extLst xmlns:a="http://schemas.openxmlformats.org/drawingml/2006/main">
               <a:ext uri="{FF2B5EF4-FFF2-40B4-BE49-F238E27FC236}">
-                <a16:creationId xmlns:a16="http://schemas.microsoft.com/office/drawing/2014/main" id="{14A91C8B-6903-4D79-802F-BCD047C1165D}"/>
+                <a16:creationId xmlns:a16="http://schemas.microsoft.com/office/drawing/2014/main" id="{9751FCCD-A3A3-4B6C-87E6-0F04E3BDE9AF}"/>
               </a:ext>
             </a:extLst>
           </p:cNvPr>
@@ -19872,7 +19872,7 @@
     </p:spTree>
     <p:extLst>
       <p:ext uri="{BB962C8B-B14F-4D97-AF65-F5344CB8AC3E}">
-        <p14:creationId xmlns:p14="http://schemas.microsoft.com/office/powerpoint/2010/main" val="2009562287"/>
+        <p14:creationId xmlns:p14="http://schemas.microsoft.com/office/powerpoint/2010/main" val="1806643875"/>
       </p:ext>
     </p:extLst>
   </p:cSld>
@@ -19903,7 +19903,7 @@
           <p:cNvPr id="33" name="">
             <a:extLst xmlns:a="http://schemas.openxmlformats.org/drawingml/2006/main">
               <a:ext uri="{FF2B5EF4-FFF2-40B4-BE49-F238E27FC236}">
-                <a16:creationId xmlns:a16="http://schemas.microsoft.com/office/drawing/2014/main" id="{BD4D102D-2486-4D51-AB8D-6FC728C75ED4}"/>
+                <a16:creationId xmlns:a16="http://schemas.microsoft.com/office/drawing/2014/main" id="{D1C424AD-CBB6-4BA1-8D67-513A9299E3ED}"/>
               </a:ext>
             </a:extLst>
           </p:cNvPr>
@@ -20060,7 +20060,7 @@
           <p:cNvPr id="2" name="">
             <a:extLst xmlns:a="http://schemas.openxmlformats.org/drawingml/2006/main">
               <a:ext uri="{FF2B5EF4-FFF2-40B4-BE49-F238E27FC236}">
-                <a16:creationId xmlns:a16="http://schemas.microsoft.com/office/drawing/2014/main" id="{05BC4881-2173-4078-9BB8-4ACE7D24364B}"/>
+                <a16:creationId xmlns:a16="http://schemas.microsoft.com/office/drawing/2014/main" id="{EDCA45F3-BB68-44A7-857C-0B09B812C765}"/>
               </a:ext>
             </a:extLst>
           </p:cNvPr>
@@ -20091,7 +20091,7 @@
           <p:cNvPr id="3" name="">
             <a:extLst xmlns:a="http://schemas.openxmlformats.org/drawingml/2006/main">
               <a:ext uri="{FF2B5EF4-FFF2-40B4-BE49-F238E27FC236}">
-                <a16:creationId xmlns:a16="http://schemas.microsoft.com/office/drawing/2014/main" id="{A1DD0AB2-5948-40D6-8D45-5E6D294F3560}"/>
+                <a16:creationId xmlns:a16="http://schemas.microsoft.com/office/drawing/2014/main" id="{F48322F9-6D5A-4289-B760-4BC2CBD5D316}"/>
               </a:ext>
             </a:extLst>
           </p:cNvPr>
@@ -20248,7 +20248,7 @@
           <p:cNvPr id="4" name="">
             <a:extLst xmlns:a="http://schemas.openxmlformats.org/drawingml/2006/main">
               <a:ext uri="{FF2B5EF4-FFF2-40B4-BE49-F238E27FC236}">
-                <a16:creationId xmlns:a16="http://schemas.microsoft.com/office/drawing/2014/main" id="{9FEA2FE8-8C9B-4339-B7C1-E1BE03396B61}"/>
+                <a16:creationId xmlns:a16="http://schemas.microsoft.com/office/drawing/2014/main" id="{11FE8B0A-DCEB-47DE-9E4E-54CDFDBD5D35}"/>
               </a:ext>
             </a:extLst>
           </p:cNvPr>
@@ -20279,7 +20279,7 @@
           <p:cNvPr id="5" name="">
             <a:extLst xmlns:a="http://schemas.openxmlformats.org/drawingml/2006/main">
               <a:ext uri="{FF2B5EF4-FFF2-40B4-BE49-F238E27FC236}">
-                <a16:creationId xmlns:a16="http://schemas.microsoft.com/office/drawing/2014/main" id="{D7C3562B-614D-45A7-9DCB-D7B444FA742A}"/>
+                <a16:creationId xmlns:a16="http://schemas.microsoft.com/office/drawing/2014/main" id="{6EF19C95-A731-48DC-912A-736418768AFE}"/>
               </a:ext>
             </a:extLst>
           </p:cNvPr>
@@ -20436,7 +20436,7 @@
           <p:cNvPr id="6" name="">
             <a:extLst xmlns:a="http://schemas.openxmlformats.org/drawingml/2006/main">
               <a:ext uri="{FF2B5EF4-FFF2-40B4-BE49-F238E27FC236}">
-                <a16:creationId xmlns:a16="http://schemas.microsoft.com/office/drawing/2014/main" id="{E7D81877-B7A3-435E-847C-2E4C4E028C14}"/>
+                <a16:creationId xmlns:a16="http://schemas.microsoft.com/office/drawing/2014/main" id="{CCE5B2F1-1702-458B-B390-CAA1C244836C}"/>
               </a:ext>
             </a:extLst>
           </p:cNvPr>
@@ -20471,7 +20471,7 @@
           <p:cNvPr id="7" name="">
             <a:extLst xmlns:a="http://schemas.openxmlformats.org/drawingml/2006/main">
               <a:ext uri="{FF2B5EF4-FFF2-40B4-BE49-F238E27FC236}">
-                <a16:creationId xmlns:a16="http://schemas.microsoft.com/office/drawing/2014/main" id="{6BF6C389-8C8C-4540-809D-5E01EF63F9B3}"/>
+                <a16:creationId xmlns:a16="http://schemas.microsoft.com/office/drawing/2014/main" id="{E6235C72-3C86-4187-BC10-D697F9015E1B}"/>
               </a:ext>
             </a:extLst>
           </p:cNvPr>
@@ -20628,7 +20628,7 @@
           <p:cNvPr id="8" name="">
             <a:extLst xmlns:a="http://schemas.openxmlformats.org/drawingml/2006/main">
               <a:ext uri="{FF2B5EF4-FFF2-40B4-BE49-F238E27FC236}">
-                <a16:creationId xmlns:a16="http://schemas.microsoft.com/office/drawing/2014/main" id="{5DFABB23-8901-4B02-AEC9-EB22CAA42BDD}"/>
+                <a16:creationId xmlns:a16="http://schemas.microsoft.com/office/drawing/2014/main" id="{78B3DF28-0D8D-41FB-A903-045143C40ACB}"/>
               </a:ext>
             </a:extLst>
           </p:cNvPr>
@@ -20808,7 +20808,7 @@
           <p:cNvPr id="9" name="">
             <a:extLst xmlns:a="http://schemas.openxmlformats.org/drawingml/2006/main">
               <a:ext uri="{FF2B5EF4-FFF2-40B4-BE49-F238E27FC236}">
-                <a16:creationId xmlns:a16="http://schemas.microsoft.com/office/drawing/2014/main" id="{C9C1120D-7748-4F32-9CAF-7DB32781B3DA}"/>
+                <a16:creationId xmlns:a16="http://schemas.microsoft.com/office/drawing/2014/main" id="{FCBE67B1-BC50-4BE9-B878-285E67600994}"/>
               </a:ext>
             </a:extLst>
           </p:cNvPr>
@@ -20839,7 +20839,7 @@
           <p:cNvPr id="10" name="">
             <a:extLst xmlns:a="http://schemas.openxmlformats.org/drawingml/2006/main">
               <a:ext uri="{FF2B5EF4-FFF2-40B4-BE49-F238E27FC236}">
-                <a16:creationId xmlns:a16="http://schemas.microsoft.com/office/drawing/2014/main" id="{DAED1810-5F7C-497F-8654-A383EE890731}"/>
+                <a16:creationId xmlns:a16="http://schemas.microsoft.com/office/drawing/2014/main" id="{D144117B-90BC-4127-9301-4584E1C7A5B7}"/>
               </a:ext>
             </a:extLst>
           </p:cNvPr>
@@ -20874,7 +20874,7 @@
           <p:cNvPr id="11" name="">
             <a:extLst xmlns:a="http://schemas.openxmlformats.org/drawingml/2006/main">
               <a:ext uri="{FF2B5EF4-FFF2-40B4-BE49-F238E27FC236}">
-                <a16:creationId xmlns:a16="http://schemas.microsoft.com/office/drawing/2014/main" id="{74FAB0BD-004D-4CEB-BD70-33B12E21E895}"/>
+                <a16:creationId xmlns:a16="http://schemas.microsoft.com/office/drawing/2014/main" id="{D98435DD-E2BB-4C8E-A29D-2627ACD600EE}"/>
               </a:ext>
             </a:extLst>
           </p:cNvPr>
@@ -21031,7 +21031,7 @@
           <p:cNvPr id="12" name="">
             <a:extLst xmlns:a="http://schemas.openxmlformats.org/drawingml/2006/main">
               <a:ext uri="{FF2B5EF4-FFF2-40B4-BE49-F238E27FC236}">
-                <a16:creationId xmlns:a16="http://schemas.microsoft.com/office/drawing/2014/main" id="{C794D869-D824-41DC-8B99-7BDAB1201816}"/>
+                <a16:creationId xmlns:a16="http://schemas.microsoft.com/office/drawing/2014/main" id="{243B4AC3-79DD-4DBC-B232-C02DF55F673F}"/>
               </a:ext>
             </a:extLst>
           </p:cNvPr>
@@ -21211,7 +21211,7 @@
           <p:cNvPr id="13" name="">
             <a:extLst xmlns:a="http://schemas.openxmlformats.org/drawingml/2006/main">
               <a:ext uri="{FF2B5EF4-FFF2-40B4-BE49-F238E27FC236}">
-                <a16:creationId xmlns:a16="http://schemas.microsoft.com/office/drawing/2014/main" id="{2C6F67F8-272E-44EE-8843-FA0F11F0952D}"/>
+                <a16:creationId xmlns:a16="http://schemas.microsoft.com/office/drawing/2014/main" id="{6966D749-2974-411D-9DF9-43C68B64EDA3}"/>
               </a:ext>
             </a:extLst>
           </p:cNvPr>
@@ -21242,7 +21242,7 @@
           <p:cNvPr id="14" name="">
             <a:extLst xmlns:a="http://schemas.openxmlformats.org/drawingml/2006/main">
               <a:ext uri="{FF2B5EF4-FFF2-40B4-BE49-F238E27FC236}">
-                <a16:creationId xmlns:a16="http://schemas.microsoft.com/office/drawing/2014/main" id="{A517E472-E686-493C-B746-0BED55842D63}"/>
+                <a16:creationId xmlns:a16="http://schemas.microsoft.com/office/drawing/2014/main" id="{9E2EC2A4-1F60-40D3-93E7-84A7C3717ED1}"/>
               </a:ext>
             </a:extLst>
           </p:cNvPr>
@@ -21277,7 +21277,7 @@
           <p:cNvPr id="15" name="">
             <a:extLst xmlns:a="http://schemas.openxmlformats.org/drawingml/2006/main">
               <a:ext uri="{FF2B5EF4-FFF2-40B4-BE49-F238E27FC236}">
-                <a16:creationId xmlns:a16="http://schemas.microsoft.com/office/drawing/2014/main" id="{747E1FEB-0648-4102-88B4-B2B9EA7F2E3E}"/>
+                <a16:creationId xmlns:a16="http://schemas.microsoft.com/office/drawing/2014/main" id="{7CF65B96-D2F8-4E85-AFDB-0AB2C0DC8FB9}"/>
               </a:ext>
             </a:extLst>
           </p:cNvPr>
@@ -21434,7 +21434,7 @@
           <p:cNvPr id="16" name="">
             <a:extLst xmlns:a="http://schemas.openxmlformats.org/drawingml/2006/main">
               <a:ext uri="{FF2B5EF4-FFF2-40B4-BE49-F238E27FC236}">
-                <a16:creationId xmlns:a16="http://schemas.microsoft.com/office/drawing/2014/main" id="{486E6EBA-EF5E-48BE-A2A9-627F1001EF13}"/>
+                <a16:creationId xmlns:a16="http://schemas.microsoft.com/office/drawing/2014/main" id="{5F72A607-0968-4B7D-8497-1EB418E62B2E}"/>
               </a:ext>
             </a:extLst>
           </p:cNvPr>
@@ -21614,7 +21614,7 @@
           <p:cNvPr id="17" name="">
             <a:extLst xmlns:a="http://schemas.openxmlformats.org/drawingml/2006/main">
               <a:ext uri="{FF2B5EF4-FFF2-40B4-BE49-F238E27FC236}">
-                <a16:creationId xmlns:a16="http://schemas.microsoft.com/office/drawing/2014/main" id="{0435FBE9-DDB1-4C99-8E16-5F5F3F2BA245}"/>
+                <a16:creationId xmlns:a16="http://schemas.microsoft.com/office/drawing/2014/main" id="{BB9959E9-1C95-4807-B986-F818AB9DC095}"/>
               </a:ext>
             </a:extLst>
           </p:cNvPr>
@@ -21645,7 +21645,7 @@
           <p:cNvPr id="18" name="">
             <a:extLst xmlns:a="http://schemas.openxmlformats.org/drawingml/2006/main">
               <a:ext uri="{FF2B5EF4-FFF2-40B4-BE49-F238E27FC236}">
-                <a16:creationId xmlns:a16="http://schemas.microsoft.com/office/drawing/2014/main" id="{71A1F845-64AC-47EA-97CC-EA1CC281231C}"/>
+                <a16:creationId xmlns:a16="http://schemas.microsoft.com/office/drawing/2014/main" id="{FF993588-C449-4AB9-9E42-7263DABA0CF8}"/>
               </a:ext>
             </a:extLst>
           </p:cNvPr>
@@ -21680,7 +21680,7 @@
           <p:cNvPr id="19" name="">
             <a:extLst xmlns:a="http://schemas.openxmlformats.org/drawingml/2006/main">
               <a:ext uri="{FF2B5EF4-FFF2-40B4-BE49-F238E27FC236}">
-                <a16:creationId xmlns:a16="http://schemas.microsoft.com/office/drawing/2014/main" id="{557AEF38-C733-4F7D-BB1D-D18EA1A3FDE5}"/>
+                <a16:creationId xmlns:a16="http://schemas.microsoft.com/office/drawing/2014/main" id="{97D200B5-1A2B-4FF3-BE8D-A9492A1BAD60}"/>
               </a:ext>
             </a:extLst>
           </p:cNvPr>
@@ -21837,7 +21837,7 @@
           <p:cNvPr id="20" name="">
             <a:extLst xmlns:a="http://schemas.openxmlformats.org/drawingml/2006/main">
               <a:ext uri="{FF2B5EF4-FFF2-40B4-BE49-F238E27FC236}">
-                <a16:creationId xmlns:a16="http://schemas.microsoft.com/office/drawing/2014/main" id="{879A7B1C-1734-41F2-94B4-3FF053549F20}"/>
+                <a16:creationId xmlns:a16="http://schemas.microsoft.com/office/drawing/2014/main" id="{DC7371C8-CCDB-436A-B59A-40E5451A1569}"/>
               </a:ext>
             </a:extLst>
           </p:cNvPr>
@@ -22017,7 +22017,7 @@
           <p:cNvPr id="21" name="">
             <a:extLst xmlns:a="http://schemas.openxmlformats.org/drawingml/2006/main">
               <a:ext uri="{FF2B5EF4-FFF2-40B4-BE49-F238E27FC236}">
-                <a16:creationId xmlns:a16="http://schemas.microsoft.com/office/drawing/2014/main" id="{E72FBF11-B859-48DA-8045-2F97285AD32C}"/>
+                <a16:creationId xmlns:a16="http://schemas.microsoft.com/office/drawing/2014/main" id="{32B5D3EA-5BB2-40D2-8802-4B143185C1E5}"/>
               </a:ext>
             </a:extLst>
           </p:cNvPr>
@@ -22048,7 +22048,7 @@
           <p:cNvPr id="22" name="">
             <a:extLst xmlns:a="http://schemas.openxmlformats.org/drawingml/2006/main">
               <a:ext uri="{FF2B5EF4-FFF2-40B4-BE49-F238E27FC236}">
-                <a16:creationId xmlns:a16="http://schemas.microsoft.com/office/drawing/2014/main" id="{E0415458-2B93-4C02-8D02-5C012E16738B}"/>
+                <a16:creationId xmlns:a16="http://schemas.microsoft.com/office/drawing/2014/main" id="{E5C83BF3-0921-4CCB-8AB4-4F77AFC1B3C3}"/>
               </a:ext>
             </a:extLst>
           </p:cNvPr>
@@ -22079,7 +22079,7 @@
           <p:cNvPr id="23" name="">
             <a:extLst xmlns:a="http://schemas.openxmlformats.org/drawingml/2006/main">
               <a:ext uri="{FF2B5EF4-FFF2-40B4-BE49-F238E27FC236}">
-                <a16:creationId xmlns:a16="http://schemas.microsoft.com/office/drawing/2014/main" id="{BDD2C684-B78B-4EAE-A7AC-279ADCDF940A}"/>
+                <a16:creationId xmlns:a16="http://schemas.microsoft.com/office/drawing/2014/main" id="{8B42F366-2B97-4FFF-8A3A-AF700F64FD1A}"/>
               </a:ext>
             </a:extLst>
           </p:cNvPr>
@@ -22110,7 +22110,7 @@
           <p:cNvPr id="24" name="">
             <a:extLst xmlns:a="http://schemas.openxmlformats.org/drawingml/2006/main">
               <a:ext uri="{FF2B5EF4-FFF2-40B4-BE49-F238E27FC236}">
-                <a16:creationId xmlns:a16="http://schemas.microsoft.com/office/drawing/2014/main" id="{C42A61D5-6684-4632-B093-25CE3DE4271E}"/>
+                <a16:creationId xmlns:a16="http://schemas.microsoft.com/office/drawing/2014/main" id="{78F580C4-3368-4B79-A741-7ACCC664DF98}"/>
               </a:ext>
             </a:extLst>
           </p:cNvPr>
@@ -22267,7 +22267,7 @@
           <p:cNvPr id="25" name="">
             <a:extLst xmlns:a="http://schemas.openxmlformats.org/drawingml/2006/main">
               <a:ext uri="{FF2B5EF4-FFF2-40B4-BE49-F238E27FC236}">
-                <a16:creationId xmlns:a16="http://schemas.microsoft.com/office/drawing/2014/main" id="{33DA9845-4F89-44A6-8963-57DDB14DA4E2}"/>
+                <a16:creationId xmlns:a16="http://schemas.microsoft.com/office/drawing/2014/main" id="{F6DC3174-85C0-474D-9B48-5E9181779CAC}"/>
               </a:ext>
             </a:extLst>
           </p:cNvPr>
@@ -22424,7 +22424,7 @@
           <p:cNvPr id="26" name="">
             <a:extLst xmlns:a="http://schemas.openxmlformats.org/drawingml/2006/main">
               <a:ext uri="{FF2B5EF4-FFF2-40B4-BE49-F238E27FC236}">
-                <a16:creationId xmlns:a16="http://schemas.microsoft.com/office/drawing/2014/main" id="{36314A21-D732-42F5-B7A6-B4BF3C7B7639}"/>
+                <a16:creationId xmlns:a16="http://schemas.microsoft.com/office/drawing/2014/main" id="{1796B679-2256-4551-B99F-852FB0D2A495}"/>
               </a:ext>
             </a:extLst>
           </p:cNvPr>
@@ -22581,7 +22581,7 @@
           <p:cNvPr id="27" name="">
             <a:extLst xmlns:a="http://schemas.openxmlformats.org/drawingml/2006/main">
               <a:ext uri="{FF2B5EF4-FFF2-40B4-BE49-F238E27FC236}">
-                <a16:creationId xmlns:a16="http://schemas.microsoft.com/office/drawing/2014/main" id="{D39F5486-5AA2-4219-AF6B-F570CF24D126}"/>
+                <a16:creationId xmlns:a16="http://schemas.microsoft.com/office/drawing/2014/main" id="{DFC0A4D8-2E77-4337-9B85-46635E679A41}"/>
               </a:ext>
             </a:extLst>
           </p:cNvPr>
@@ -22761,7 +22761,7 @@
           <p:cNvPr id="28" name="">
             <a:extLst xmlns:a="http://schemas.openxmlformats.org/drawingml/2006/main">
               <a:ext uri="{FF2B5EF4-FFF2-40B4-BE49-F238E27FC236}">
-                <a16:creationId xmlns:a16="http://schemas.microsoft.com/office/drawing/2014/main" id="{9F596885-E039-46C8-824D-B866443D9171}"/>
+                <a16:creationId xmlns:a16="http://schemas.microsoft.com/office/drawing/2014/main" id="{D1E8BBB7-AEF0-4481-A3AC-D85B79440311}"/>
               </a:ext>
             </a:extLst>
           </p:cNvPr>
@@ -22918,7 +22918,7 @@
           <p:cNvPr id="29" name="">
             <a:extLst xmlns:a="http://schemas.openxmlformats.org/drawingml/2006/main">
               <a:ext uri="{FF2B5EF4-FFF2-40B4-BE49-F238E27FC236}">
-                <a16:creationId xmlns:a16="http://schemas.microsoft.com/office/drawing/2014/main" id="{52A88253-769B-4CAB-A43E-056181DD40C2}"/>
+                <a16:creationId xmlns:a16="http://schemas.microsoft.com/office/drawing/2014/main" id="{69AB5FD5-0A3F-482B-AE72-274A4F3791CC}"/>
               </a:ext>
             </a:extLst>
           </p:cNvPr>
@@ -23098,7 +23098,7 @@
           <p:cNvPr id="30" name="">
             <a:extLst xmlns:a="http://schemas.openxmlformats.org/drawingml/2006/main">
               <a:ext uri="{FF2B5EF4-FFF2-40B4-BE49-F238E27FC236}">
-                <a16:creationId xmlns:a16="http://schemas.microsoft.com/office/drawing/2014/main" id="{65A32B05-3146-406A-885D-E69CF9B48D26}"/>
+                <a16:creationId xmlns:a16="http://schemas.microsoft.com/office/drawing/2014/main" id="{19612863-C24C-4E05-9FE8-8359C68CA244}"/>
               </a:ext>
             </a:extLst>
           </p:cNvPr>
@@ -23255,7 +23255,7 @@
           <p:cNvPr id="31" name="">
             <a:extLst xmlns:a="http://schemas.openxmlformats.org/drawingml/2006/main">
               <a:ext uri="{FF2B5EF4-FFF2-40B4-BE49-F238E27FC236}">
-                <a16:creationId xmlns:a16="http://schemas.microsoft.com/office/drawing/2014/main" id="{CC7583A0-B830-4102-B2CF-8BDFE7BCB9B8}"/>
+                <a16:creationId xmlns:a16="http://schemas.microsoft.com/office/drawing/2014/main" id="{3DC8FB6C-99F3-437E-B38D-B63716DD30C2}"/>
               </a:ext>
             </a:extLst>
           </p:cNvPr>
@@ -23435,7 +23435,7 @@
           <p:cNvPr id="32" name="">
             <a:extLst xmlns:a="http://schemas.openxmlformats.org/drawingml/2006/main">
               <a:ext uri="{FF2B5EF4-FFF2-40B4-BE49-F238E27FC236}">
-                <a16:creationId xmlns:a16="http://schemas.microsoft.com/office/drawing/2014/main" id="{524CB2FF-B642-405D-9A01-C881718009F7}"/>
+                <a16:creationId xmlns:a16="http://schemas.microsoft.com/office/drawing/2014/main" id="{9B847720-64A3-4CD4-9AC6-11962801279C}"/>
               </a:ext>
             </a:extLst>
           </p:cNvPr>
@@ -23582,7 +23582,7 @@
                 <a:ea typeface="Arial"/>
                 <a:cs typeface="Arial"/>
               </a:rPr>
-              <a:t>One trial per arm on archived SHA256. Strong cost heuristic: 1 query.</a:t>
+              <a:t>One archived trial per arm. v2 guards the incumbent; no live v2 LLM run. Strong heuristic: 1 query.</a:t>
             </a:r>
           </a:p>
         </p:txBody>
@@ -23590,7 +23590,7 @@
     </p:spTree>
     <p:extLst>
       <p:ext uri="{BB962C8B-B14F-4D97-AF65-F5344CB8AC3E}">
-        <p14:creationId xmlns:p14="http://schemas.microsoft.com/office/powerpoint/2010/main" val="1632871869"/>
+        <p14:creationId xmlns:p14="http://schemas.microsoft.com/office/powerpoint/2010/main" val="1386606448"/>
       </p:ext>
     </p:extLst>
   </p:cSld>
@@ -23621,7 +23621,7 @@
           <p:cNvPr id="26" name="">
             <a:extLst xmlns:a="http://schemas.openxmlformats.org/drawingml/2006/main">
               <a:ext uri="{FF2B5EF4-FFF2-40B4-BE49-F238E27FC236}">
-                <a16:creationId xmlns:a16="http://schemas.microsoft.com/office/drawing/2014/main" id="{CA108D60-8DF9-4661-BC87-E3D0A94246D6}"/>
+                <a16:creationId xmlns:a16="http://schemas.microsoft.com/office/drawing/2014/main" id="{5733CB69-0345-466C-8F50-701CA27A16A4}"/>
               </a:ext>
             </a:extLst>
           </p:cNvPr>
@@ -23778,7 +23778,7 @@
           <p:cNvPr id="2" name="">
             <a:extLst xmlns:a="http://schemas.openxmlformats.org/drawingml/2006/main">
               <a:ext uri="{FF2B5EF4-FFF2-40B4-BE49-F238E27FC236}">
-                <a16:creationId xmlns:a16="http://schemas.microsoft.com/office/drawing/2014/main" id="{083AB77F-26BF-477B-A307-A574D80E7F17}"/>
+                <a16:creationId xmlns:a16="http://schemas.microsoft.com/office/drawing/2014/main" id="{580671D1-BD7A-437C-B3EE-436B6C7BDBD2}"/>
               </a:ext>
             </a:extLst>
           </p:cNvPr>
@@ -23809,7 +23809,7 @@
           <p:cNvPr id="3" name="">
             <a:extLst xmlns:a="http://schemas.openxmlformats.org/drawingml/2006/main">
               <a:ext uri="{FF2B5EF4-FFF2-40B4-BE49-F238E27FC236}">
-                <a16:creationId xmlns:a16="http://schemas.microsoft.com/office/drawing/2014/main" id="{95C1256E-7F15-445E-BD6A-C5529BE77E90}"/>
+                <a16:creationId xmlns:a16="http://schemas.microsoft.com/office/drawing/2014/main" id="{91FE8355-EA37-4BD8-84E0-A1EB80C02A07}"/>
               </a:ext>
             </a:extLst>
           </p:cNvPr>
@@ -23966,7 +23966,7 @@
           <p:cNvPr id="4" name="">
             <a:extLst xmlns:a="http://schemas.openxmlformats.org/drawingml/2006/main">
               <a:ext uri="{FF2B5EF4-FFF2-40B4-BE49-F238E27FC236}">
-                <a16:creationId xmlns:a16="http://schemas.microsoft.com/office/drawing/2014/main" id="{5EA66D21-7B68-48BD-8C3D-E0546240D01D}"/>
+                <a16:creationId xmlns:a16="http://schemas.microsoft.com/office/drawing/2014/main" id="{62087063-DAEC-4B57-BB41-BB768AE10615}"/>
               </a:ext>
             </a:extLst>
           </p:cNvPr>
@@ -24123,7 +24123,7 @@
           <p:cNvPr id="5" name="">
             <a:extLst xmlns:a="http://schemas.openxmlformats.org/drawingml/2006/main">
               <a:ext uri="{FF2B5EF4-FFF2-40B4-BE49-F238E27FC236}">
-                <a16:creationId xmlns:a16="http://schemas.microsoft.com/office/drawing/2014/main" id="{328E6A60-7C63-4202-A8D1-854BC3F4DB49}"/>
+                <a16:creationId xmlns:a16="http://schemas.microsoft.com/office/drawing/2014/main" id="{9B3C2959-F775-46B7-AE6E-312C866C6B54}"/>
               </a:ext>
             </a:extLst>
           </p:cNvPr>
@@ -24280,7 +24280,7 @@
           <p:cNvPr id="6" name="">
             <a:extLst xmlns:a="http://schemas.openxmlformats.org/drawingml/2006/main">
               <a:ext uri="{FF2B5EF4-FFF2-40B4-BE49-F238E27FC236}">
-                <a16:creationId xmlns:a16="http://schemas.microsoft.com/office/drawing/2014/main" id="{B854EF13-ED12-4E0F-A198-67DFBA386D55}"/>
+                <a16:creationId xmlns:a16="http://schemas.microsoft.com/office/drawing/2014/main" id="{0F3120B0-6ED1-4FA7-8BCD-F7F13714E648}"/>
               </a:ext>
             </a:extLst>
           </p:cNvPr>
@@ -24437,7 +24437,7 @@
           <p:cNvPr id="7" name="">
             <a:extLst xmlns:a="http://schemas.openxmlformats.org/drawingml/2006/main">
               <a:ext uri="{FF2B5EF4-FFF2-40B4-BE49-F238E27FC236}">
-                <a16:creationId xmlns:a16="http://schemas.microsoft.com/office/drawing/2014/main" id="{83DA896E-1640-4A6B-8E32-E430384EB24F}"/>
+                <a16:creationId xmlns:a16="http://schemas.microsoft.com/office/drawing/2014/main" id="{0FD2F632-06C0-46B8-96BE-D9A94A0568CA}"/>
               </a:ext>
             </a:extLst>
           </p:cNvPr>
@@ -24468,7 +24468,7 @@
           <p:cNvPr id="8" name="">
             <a:extLst xmlns:a="http://schemas.openxmlformats.org/drawingml/2006/main">
               <a:ext uri="{FF2B5EF4-FFF2-40B4-BE49-F238E27FC236}">
-                <a16:creationId xmlns:a16="http://schemas.microsoft.com/office/drawing/2014/main" id="{3606BAD4-D911-4290-A4BD-2EA052776B8D}"/>
+                <a16:creationId xmlns:a16="http://schemas.microsoft.com/office/drawing/2014/main" id="{9A39D7DA-CE78-4E02-9DFB-328A00131FD7}"/>
               </a:ext>
             </a:extLst>
           </p:cNvPr>
@@ -24625,7 +24625,7 @@
           <p:cNvPr id="9" name="">
             <a:extLst xmlns:a="http://schemas.openxmlformats.org/drawingml/2006/main">
               <a:ext uri="{FF2B5EF4-FFF2-40B4-BE49-F238E27FC236}">
-                <a16:creationId xmlns:a16="http://schemas.microsoft.com/office/drawing/2014/main" id="{2231E649-6D70-4980-9F68-BCD8F764AE4A}"/>
+                <a16:creationId xmlns:a16="http://schemas.microsoft.com/office/drawing/2014/main" id="{C372258A-AEF5-4C25-A89D-930E1410E687}"/>
               </a:ext>
             </a:extLst>
           </p:cNvPr>
@@ -24782,7 +24782,7 @@
           <p:cNvPr id="10" name="">
             <a:extLst xmlns:a="http://schemas.openxmlformats.org/drawingml/2006/main">
               <a:ext uri="{FF2B5EF4-FFF2-40B4-BE49-F238E27FC236}">
-                <a16:creationId xmlns:a16="http://schemas.microsoft.com/office/drawing/2014/main" id="{70C40F92-6581-4354-9E40-03D18638C8B9}"/>
+                <a16:creationId xmlns:a16="http://schemas.microsoft.com/office/drawing/2014/main" id="{96D96B58-6954-4650-9842-999C69566065}"/>
               </a:ext>
             </a:extLst>
           </p:cNvPr>
@@ -24813,7 +24813,7 @@
           <p:cNvPr id="11" name="">
             <a:extLst xmlns:a="http://schemas.openxmlformats.org/drawingml/2006/main">
               <a:ext uri="{FF2B5EF4-FFF2-40B4-BE49-F238E27FC236}">
-                <a16:creationId xmlns:a16="http://schemas.microsoft.com/office/drawing/2014/main" id="{288937EF-94C8-4CAB-87CB-6F397547249F}"/>
+                <a16:creationId xmlns:a16="http://schemas.microsoft.com/office/drawing/2014/main" id="{7B3F0ADF-7AE9-4260-AB88-DEA6620772A0}"/>
               </a:ext>
             </a:extLst>
           </p:cNvPr>
@@ -24970,7 +24970,7 @@
           <p:cNvPr id="12" name="">
             <a:extLst xmlns:a="http://schemas.openxmlformats.org/drawingml/2006/main">
               <a:ext uri="{FF2B5EF4-FFF2-40B4-BE49-F238E27FC236}">
-                <a16:creationId xmlns:a16="http://schemas.microsoft.com/office/drawing/2014/main" id="{5A816A2D-4820-45CF-A762-28C053198B73}"/>
+                <a16:creationId xmlns:a16="http://schemas.microsoft.com/office/drawing/2014/main" id="{C933A764-DB1B-4FFA-9FB0-236A26B6D03D}"/>
               </a:ext>
             </a:extLst>
           </p:cNvPr>
@@ -25127,7 +25127,7 @@
           <p:cNvPr id="13" name="">
             <a:extLst xmlns:a="http://schemas.openxmlformats.org/drawingml/2006/main">
               <a:ext uri="{FF2B5EF4-FFF2-40B4-BE49-F238E27FC236}">
-                <a16:creationId xmlns:a16="http://schemas.microsoft.com/office/drawing/2014/main" id="{7E43CEAA-002F-4697-8837-25ACA70675FF}"/>
+                <a16:creationId xmlns:a16="http://schemas.microsoft.com/office/drawing/2014/main" id="{09594004-9015-4BA9-8B6C-0CF2C61E7EBF}"/>
               </a:ext>
             </a:extLst>
           </p:cNvPr>
@@ -25158,7 +25158,7 @@
           <p:cNvPr id="14" name="">
             <a:extLst xmlns:a="http://schemas.openxmlformats.org/drawingml/2006/main">
               <a:ext uri="{FF2B5EF4-FFF2-40B4-BE49-F238E27FC236}">
-                <a16:creationId xmlns:a16="http://schemas.microsoft.com/office/drawing/2014/main" id="{C45A521A-63AE-43D1-B893-38F1B461C50B}"/>
+                <a16:creationId xmlns:a16="http://schemas.microsoft.com/office/drawing/2014/main" id="{64E28372-4745-40B7-9775-E4D4890F5CA2}"/>
               </a:ext>
             </a:extLst>
           </p:cNvPr>
@@ -25315,7 +25315,7 @@
           <p:cNvPr id="15" name="">
             <a:extLst xmlns:a="http://schemas.openxmlformats.org/drawingml/2006/main">
               <a:ext uri="{FF2B5EF4-FFF2-40B4-BE49-F238E27FC236}">
-                <a16:creationId xmlns:a16="http://schemas.microsoft.com/office/drawing/2014/main" id="{86D79242-AC0B-43E2-9799-AF7940442A44}"/>
+                <a16:creationId xmlns:a16="http://schemas.microsoft.com/office/drawing/2014/main" id="{0A424985-1AEB-4607-A2B3-E6D03D9E0514}"/>
               </a:ext>
             </a:extLst>
           </p:cNvPr>
@@ -25462,7 +25462,7 @@
                 <a:ea typeface="Arial"/>
                 <a:cs typeface="Arial"/>
               </a:rPr>
-              <a:t>Accept verified design or baseline</a:t>
+              <a:t>Finalize the host-computed best measured feasible result</a:t>
             </a:r>
           </a:p>
         </p:txBody>
@@ -25472,7 +25472,7 @@
           <p:cNvPr id="16" name="">
             <a:extLst xmlns:a="http://schemas.openxmlformats.org/drawingml/2006/main">
               <a:ext uri="{FF2B5EF4-FFF2-40B4-BE49-F238E27FC236}">
-                <a16:creationId xmlns:a16="http://schemas.microsoft.com/office/drawing/2014/main" id="{9D703F09-0176-4927-8820-04A558EDF281}"/>
+                <a16:creationId xmlns:a16="http://schemas.microsoft.com/office/drawing/2014/main" id="{117E102C-9617-4989-857F-C447FBD37B82}"/>
               </a:ext>
             </a:extLst>
           </p:cNvPr>
@@ -25503,7 +25503,7 @@
           <p:cNvPr id="17" name="">
             <a:extLst xmlns:a="http://schemas.openxmlformats.org/drawingml/2006/main">
               <a:ext uri="{FF2B5EF4-FFF2-40B4-BE49-F238E27FC236}">
-                <a16:creationId xmlns:a16="http://schemas.microsoft.com/office/drawing/2014/main" id="{D96089D0-C46B-48DB-BEEF-E78252DA03E0}"/>
+                <a16:creationId xmlns:a16="http://schemas.microsoft.com/office/drawing/2014/main" id="{8CDBD5A7-E564-4DFF-9111-CFC7DC610487}"/>
               </a:ext>
             </a:extLst>
           </p:cNvPr>
@@ -25660,7 +25660,7 @@
           <p:cNvPr id="18" name="">
             <a:extLst xmlns:a="http://schemas.openxmlformats.org/drawingml/2006/main">
               <a:ext uri="{FF2B5EF4-FFF2-40B4-BE49-F238E27FC236}">
-                <a16:creationId xmlns:a16="http://schemas.microsoft.com/office/drawing/2014/main" id="{59565326-3B28-4F75-B7FF-18B71B07EC40}"/>
+                <a16:creationId xmlns:a16="http://schemas.microsoft.com/office/drawing/2014/main" id="{58A599C0-2659-4F16-AEA8-E20C2847824C}"/>
               </a:ext>
             </a:extLst>
           </p:cNvPr>
@@ -25817,7 +25817,7 @@
           <p:cNvPr id="19" name="">
             <a:extLst xmlns:a="http://schemas.openxmlformats.org/drawingml/2006/main">
               <a:ext uri="{FF2B5EF4-FFF2-40B4-BE49-F238E27FC236}">
-                <a16:creationId xmlns:a16="http://schemas.microsoft.com/office/drawing/2014/main" id="{BB24FAAA-2EED-41DD-9C59-71F6B9EF05B0}"/>
+                <a16:creationId xmlns:a16="http://schemas.microsoft.com/office/drawing/2014/main" id="{82A09D9A-ADD1-488D-B513-1A9017FBB189}"/>
               </a:ext>
             </a:extLst>
           </p:cNvPr>
@@ -25974,7 +25974,7 @@
           <p:cNvPr id="20" name="">
             <a:extLst xmlns:a="http://schemas.openxmlformats.org/drawingml/2006/main">
               <a:ext uri="{FF2B5EF4-FFF2-40B4-BE49-F238E27FC236}">
-                <a16:creationId xmlns:a16="http://schemas.microsoft.com/office/drawing/2014/main" id="{3E0BA9E5-898F-4FE5-A92B-8230048FB737}"/>
+                <a16:creationId xmlns:a16="http://schemas.microsoft.com/office/drawing/2014/main" id="{54F408E0-F95D-414D-BB2B-3CF22B020710}"/>
               </a:ext>
             </a:extLst>
           </p:cNvPr>
@@ -26131,7 +26131,7 @@
           <p:cNvPr id="21" name="">
             <a:extLst xmlns:a="http://schemas.openxmlformats.org/drawingml/2006/main">
               <a:ext uri="{FF2B5EF4-FFF2-40B4-BE49-F238E27FC236}">
-                <a16:creationId xmlns:a16="http://schemas.microsoft.com/office/drawing/2014/main" id="{487A3695-D4A2-417F-8FF0-3AA61A4ADC1B}"/>
+                <a16:creationId xmlns:a16="http://schemas.microsoft.com/office/drawing/2014/main" id="{1F5A3732-1FE8-4067-B222-42247FDB8432}"/>
               </a:ext>
             </a:extLst>
           </p:cNvPr>
@@ -26311,7 +26311,7 @@
           <p:cNvPr id="22" name="">
             <a:extLst xmlns:a="http://schemas.openxmlformats.org/drawingml/2006/main">
               <a:ext uri="{FF2B5EF4-FFF2-40B4-BE49-F238E27FC236}">
-                <a16:creationId xmlns:a16="http://schemas.microsoft.com/office/drawing/2014/main" id="{2674A91A-0EA8-471A-ABD4-466B6C0CE69A}"/>
+                <a16:creationId xmlns:a16="http://schemas.microsoft.com/office/drawing/2014/main" id="{4B89A15C-9921-4655-A342-A1830396BDF2}"/>
               </a:ext>
             </a:extLst>
           </p:cNvPr>
@@ -26468,7 +26468,7 @@
           <p:cNvPr id="23" name="">
             <a:extLst xmlns:a="http://schemas.openxmlformats.org/drawingml/2006/main">
               <a:ext uri="{FF2B5EF4-FFF2-40B4-BE49-F238E27FC236}">
-                <a16:creationId xmlns:a16="http://schemas.microsoft.com/office/drawing/2014/main" id="{9879477D-1048-45CB-B27D-282C00D43F99}"/>
+                <a16:creationId xmlns:a16="http://schemas.microsoft.com/office/drawing/2014/main" id="{700D768B-10B7-4A88-A55B-F56422BDD637}"/>
               </a:ext>
             </a:extLst>
           </p:cNvPr>
@@ -26648,7 +26648,7 @@
           <p:cNvPr id="24" name="">
             <a:extLst xmlns:a="http://schemas.openxmlformats.org/drawingml/2006/main">
               <a:ext uri="{FF2B5EF4-FFF2-40B4-BE49-F238E27FC236}">
-                <a16:creationId xmlns:a16="http://schemas.microsoft.com/office/drawing/2014/main" id="{16E47FF3-5978-4C0D-BB63-591A4DF2D9B6}"/>
+                <a16:creationId xmlns:a16="http://schemas.microsoft.com/office/drawing/2014/main" id="{19871C10-CC46-4E3A-B976-6CE45E31CA77}"/>
               </a:ext>
             </a:extLst>
           </p:cNvPr>
@@ -26675,7 +26675,7 @@
           <a:bodyPr xmlns:a="http://schemas.openxmlformats.org/drawingml/2006/main" lIns="0" tIns="0" rIns="0" bIns="0"/>
           <a:lstStyle xmlns:a="http://schemas.openxmlformats.org/drawingml/2006/main">
             <a:defPPr>
-              <a:defRPr sz="2025" b="1">
+              <a:defRPr sz="1875" b="1">
                 <a:solidFill>
                   <a:srgbClr val="18856B"/>
                 </a:solidFill>
@@ -26685,7 +26685,7 @@
               </a:defRPr>
             </a:defPPr>
             <a:lvl1pPr>
-              <a:defRPr sz="2025" b="1">
+              <a:defRPr sz="1875" b="1">
                 <a:solidFill>
                   <a:srgbClr val="18856B"/>
                 </a:solidFill>
@@ -26695,7 +26695,7 @@
               </a:defRPr>
             </a:lvl1pPr>
             <a:lvl2pPr>
-              <a:defRPr sz="2025" b="1">
+              <a:defRPr sz="1875" b="1">
                 <a:solidFill>
                   <a:srgbClr val="18856B"/>
                 </a:solidFill>
@@ -26705,7 +26705,7 @@
               </a:defRPr>
             </a:lvl2pPr>
             <a:lvl3pPr>
-              <a:defRPr sz="2025" b="1">
+              <a:defRPr sz="1875" b="1">
                 <a:solidFill>
                   <a:srgbClr val="18856B"/>
                 </a:solidFill>
@@ -26715,7 +26715,7 @@
               </a:defRPr>
             </a:lvl3pPr>
             <a:lvl4pPr>
-              <a:defRPr sz="2025" b="1">
+              <a:defRPr sz="1875" b="1">
                 <a:solidFill>
                   <a:srgbClr val="18856B"/>
                 </a:solidFill>
@@ -26725,7 +26725,7 @@
               </a:defRPr>
             </a:lvl4pPr>
             <a:lvl5pPr>
-              <a:defRPr sz="2025" b="1">
+              <a:defRPr sz="1875" b="1">
                 <a:solidFill>
                   <a:srgbClr val="18856B"/>
                 </a:solidFill>
@@ -26735,7 +26735,7 @@
               </a:defRPr>
             </a:lvl5pPr>
             <a:lvl6pPr>
-              <a:defRPr sz="2025" b="1">
+              <a:defRPr sz="1875" b="1">
                 <a:solidFill>
                   <a:srgbClr val="18856B"/>
                 </a:solidFill>
@@ -26745,7 +26745,7 @@
               </a:defRPr>
             </a:lvl6pPr>
             <a:lvl7pPr>
-              <a:defRPr sz="2025" b="1">
+              <a:defRPr sz="1875" b="1">
                 <a:solidFill>
                   <a:srgbClr val="18856B"/>
                 </a:solidFill>
@@ -26755,7 +26755,7 @@
               </a:defRPr>
             </a:lvl7pPr>
             <a:lvl8pPr>
-              <a:defRPr sz="2025" b="1">
+              <a:defRPr sz="1875" b="1">
                 <a:solidFill>
                   <a:srgbClr val="18856B"/>
                 </a:solidFill>
@@ -26765,7 +26765,7 @@
               </a:defRPr>
             </a:lvl8pPr>
             <a:lvl9pPr>
-              <a:defRPr sz="2025" b="1">
+              <a:defRPr sz="1875" b="1">
                 <a:solidFill>
                   <a:srgbClr val="18856B"/>
                 </a:solidFill>
@@ -26777,7 +26777,7 @@
           </a:lstStyle>
           <a:p xmlns:a="http://schemas.openxmlformats.org/drawingml/2006/main">
             <a:pPr>
-              <a:defRPr sz="2025" b="1">
+              <a:defRPr sz="1875" b="1">
                 <a:solidFill>
                   <a:srgbClr val="18856B"/>
                 </a:solidFill>
@@ -26787,7 +26787,7 @@
               </a:defRPr>
             </a:pPr>
             <a:r>
-              <a:rPr sz="2025" b="1">
+              <a:rPr sz="1875" b="1">
                 <a:solidFill>
                   <a:srgbClr val="18856B"/>
                 </a:solidFill>
@@ -26795,7 +26795,7 @@
                 <a:ea typeface="Arial"/>
                 <a:cs typeface="Arial"/>
               </a:rPr>
-              <a:t>Host guardrails: correctness + area + timing + finite budgets</a:t>
+              <a:t>Host guardrails: correctness + area + timing + incumbent + finite budgets</a:t>
             </a:r>
           </a:p>
         </p:txBody>
@@ -26805,7 +26805,7 @@
           <p:cNvPr id="25" name="">
             <a:extLst xmlns:a="http://schemas.openxmlformats.org/drawingml/2006/main">
               <a:ext uri="{FF2B5EF4-FFF2-40B4-BE49-F238E27FC236}">
-                <a16:creationId xmlns:a16="http://schemas.microsoft.com/office/drawing/2014/main" id="{ED716829-42FF-46EE-A97B-E555D9AD694D}"/>
+                <a16:creationId xmlns:a16="http://schemas.microsoft.com/office/drawing/2014/main" id="{E9B81A57-AF93-4373-9C05-0B378A0C98E9}"/>
               </a:ext>
             </a:extLst>
           </p:cNvPr>
@@ -26952,7 +26952,7 @@
                 <a:ea typeface="Arial"/>
                 <a:cs typeface="Arial"/>
               </a:rPr>
-              <a:t>Live tokens / inference latency unavailable. Deployment and restart remain planned.</a:t>
+              <a:t>79 focused tests pass. No live v2 LLM run; tokens / inference latency unavailable.</a:t>
             </a:r>
           </a:p>
         </p:txBody>
@@ -26960,7 +26960,7 @@
     </p:spTree>
     <p:extLst>
       <p:ext uri="{BB962C8B-B14F-4D97-AF65-F5344CB8AC3E}">
-        <p14:creationId xmlns:p14="http://schemas.microsoft.com/office/powerpoint/2010/main" val="1566903959"/>
+        <p14:creationId xmlns:p14="http://schemas.microsoft.com/office/powerpoint/2010/main" val="651194943"/>
       </p:ext>
     </p:extLst>
   </p:cSld>
@@ -26991,7 +26991,7 @@
           <p:cNvPr id="9" name="">
             <a:extLst xmlns:a="http://schemas.openxmlformats.org/drawingml/2006/main">
               <a:ext uri="{FF2B5EF4-FFF2-40B4-BE49-F238E27FC236}">
-                <a16:creationId xmlns:a16="http://schemas.microsoft.com/office/drawing/2014/main" id="{1FA5ED67-8548-4D31-BDB9-3AAD802AC7A9}"/>
+                <a16:creationId xmlns:a16="http://schemas.microsoft.com/office/drawing/2014/main" id="{DF89F5EE-E54E-4D09-8764-4626351D8A6A}"/>
               </a:ext>
             </a:extLst>
           </p:cNvPr>
@@ -27148,7 +27148,7 @@
           <p:cNvPr id="2" name="">
             <a:extLst xmlns:a="http://schemas.openxmlformats.org/drawingml/2006/main">
               <a:ext uri="{FF2B5EF4-FFF2-40B4-BE49-F238E27FC236}">
-                <a16:creationId xmlns:a16="http://schemas.microsoft.com/office/drawing/2014/main" id="{0C42CAA3-67AF-40E1-84CB-45D802D9F60A}"/>
+                <a16:creationId xmlns:a16="http://schemas.microsoft.com/office/drawing/2014/main" id="{8F2E9B25-78AF-4EA1-A402-EC7E4042A029}"/>
               </a:ext>
             </a:extLst>
           </p:cNvPr>
@@ -27179,7 +27179,7 @@
           <p:cNvPr id="3" name="">
             <a:extLst xmlns:a="http://schemas.openxmlformats.org/drawingml/2006/main">
               <a:ext uri="{FF2B5EF4-FFF2-40B4-BE49-F238E27FC236}">
-                <a16:creationId xmlns:a16="http://schemas.microsoft.com/office/drawing/2014/main" id="{FD73903E-4418-4421-BA6F-1D14A21F9DAA}"/>
+                <a16:creationId xmlns:a16="http://schemas.microsoft.com/office/drawing/2014/main" id="{A9C29A7A-8AC8-45D3-87EC-720AEB8329DB}"/>
               </a:ext>
             </a:extLst>
           </p:cNvPr>
@@ -27336,7 +27336,7 @@
           <p:cNvPr id="4" name="">
             <a:extLst xmlns:a="http://schemas.openxmlformats.org/drawingml/2006/main">
               <a:ext uri="{FF2B5EF4-FFF2-40B4-BE49-F238E27FC236}">
-                <a16:creationId xmlns:a16="http://schemas.microsoft.com/office/drawing/2014/main" id="{3852873B-A433-4724-B46F-9905BE8A1EF1}"/>
+                <a16:creationId xmlns:a16="http://schemas.microsoft.com/office/drawing/2014/main" id="{DB6BD014-F337-408F-9EA6-05BB67857AE9}"/>
               </a:ext>
             </a:extLst>
           </p:cNvPr>
@@ -27493,7 +27493,7 @@
           <p:cNvPr id="5" name="">
             <a:extLst xmlns:a="http://schemas.openxmlformats.org/drawingml/2006/main">
               <a:ext uri="{FF2B5EF4-FFF2-40B4-BE49-F238E27FC236}">
-                <a16:creationId xmlns:a16="http://schemas.microsoft.com/office/drawing/2014/main" id="{4F73E411-5D11-4487-BD68-6EE0DA736E1B}"/>
+                <a16:creationId xmlns:a16="http://schemas.microsoft.com/office/drawing/2014/main" id="{AFB80D61-A31F-43F5-AA1F-93BEDA76247D}"/>
               </a:ext>
             </a:extLst>
           </p:cNvPr>
@@ -27742,7 +27742,7 @@
           <p:cNvPr id="6" name="">
             <a:extLst xmlns:a="http://schemas.openxmlformats.org/drawingml/2006/main">
               <a:ext uri="{FF2B5EF4-FFF2-40B4-BE49-F238E27FC236}">
-                <a16:creationId xmlns:a16="http://schemas.microsoft.com/office/drawing/2014/main" id="{31B37541-1A61-4F24-8B20-090AEA7B4444}"/>
+                <a16:creationId xmlns:a16="http://schemas.microsoft.com/office/drawing/2014/main" id="{0DBDA63F-5D17-4C66-8C23-0771D4C28B4A}"/>
               </a:ext>
             </a:extLst>
           </p:cNvPr>
@@ -27899,7 +27899,7 @@
           <p:cNvPr id="7" name="">
             <a:extLst xmlns:a="http://schemas.openxmlformats.org/drawingml/2006/main">
               <a:ext uri="{FF2B5EF4-FFF2-40B4-BE49-F238E27FC236}">
-                <a16:creationId xmlns:a16="http://schemas.microsoft.com/office/drawing/2014/main" id="{0AFACA5F-2503-4389-80FB-12C40058A770}"/>
+                <a16:creationId xmlns:a16="http://schemas.microsoft.com/office/drawing/2014/main" id="{36D64CF6-5447-4903-9B33-C222F5577F89}"/>
               </a:ext>
             </a:extLst>
           </p:cNvPr>
@@ -28148,7 +28148,7 @@
           <p:cNvPr id="8" name="">
             <a:extLst xmlns:a="http://schemas.openxmlformats.org/drawingml/2006/main">
               <a:ext uri="{FF2B5EF4-FFF2-40B4-BE49-F238E27FC236}">
-                <a16:creationId xmlns:a16="http://schemas.microsoft.com/office/drawing/2014/main" id="{43C4D61D-36CE-4D16-BCBD-69A8BE8E8910}"/>
+                <a16:creationId xmlns:a16="http://schemas.microsoft.com/office/drawing/2014/main" id="{D234410C-3F84-4228-ADC1-0E95A5C32778}"/>
               </a:ext>
             </a:extLst>
           </p:cNvPr>
@@ -28303,7 +28303,7 @@
     </p:spTree>
     <p:extLst>
       <p:ext uri="{BB962C8B-B14F-4D97-AF65-F5344CB8AC3E}">
-        <p14:creationId xmlns:p14="http://schemas.microsoft.com/office/powerpoint/2010/main" val="1367705306"/>
+        <p14:creationId xmlns:p14="http://schemas.microsoft.com/office/powerpoint/2010/main" val="1689300256"/>
       </p:ext>
     </p:extLst>
   </p:cSld>

</xml_diff>

<commit_message>
Add host-feedback recovery to bounded LLM router
</commit_message>
<xml_diff>
--- a/submissions/midterm-2026-10-28/isaforge-midterm-progress-slides-final.pptx
+++ b/submissions/midterm-2026-10-28/isaforge-midterm-progress-slides-final.pptx
@@ -2,23 +2,23 @@
 <file path=ppt/presentation.xml><?xml version="1.0" encoding="utf-8"?>
 <p:presentation xmlns:p="http://schemas.openxmlformats.org/presentationml/2006/main">
   <p:sldMasterIdLst>
-    <p:sldMasterId xmlns:r="http://schemas.openxmlformats.org/officeDocument/2006/relationships" id="2147483648" r:id="R1c94bd6ee3ad4b21"/>
+    <p:sldMasterId xmlns:r="http://schemas.openxmlformats.org/officeDocument/2006/relationships" id="2147483648" r:id="R1f42b87f858541ab"/>
   </p:sldMasterIdLst>
   <p:notesMasterIdLst>
-    <p:notesMasterId xmlns:r="http://schemas.openxmlformats.org/officeDocument/2006/relationships" r:id="R86abf2fdc7554040"/>
+    <p:notesMasterId xmlns:r="http://schemas.openxmlformats.org/officeDocument/2006/relationships" r:id="Rf5bcd90d174a4340"/>
   </p:notesMasterIdLst>
   <p:sldIdLst>
-    <p:sldId xmlns:r="http://schemas.openxmlformats.org/officeDocument/2006/relationships" id="256" r:id="Rf5aceed2145e4c0e"/>
-    <p:sldId xmlns:r="http://schemas.openxmlformats.org/officeDocument/2006/relationships" id="257" r:id="Rd2ce32f7eece4398"/>
-    <p:sldId xmlns:r="http://schemas.openxmlformats.org/officeDocument/2006/relationships" id="258" r:id="Rdf8d38067d7e476e"/>
-    <p:sldId xmlns:r="http://schemas.openxmlformats.org/officeDocument/2006/relationships" id="259" r:id="Rfed0eee642df4af5"/>
-    <p:sldId xmlns:r="http://schemas.openxmlformats.org/officeDocument/2006/relationships" id="260" r:id="R1b6894cf95b648ac"/>
-    <p:sldId xmlns:r="http://schemas.openxmlformats.org/officeDocument/2006/relationships" id="261" r:id="R929db504ebaa466d"/>
-    <p:sldId xmlns:r="http://schemas.openxmlformats.org/officeDocument/2006/relationships" id="262" r:id="R3949d609c3914d58"/>
-    <p:sldId xmlns:r="http://schemas.openxmlformats.org/officeDocument/2006/relationships" id="263" r:id="R641b8a5043b9432b"/>
-    <p:sldId xmlns:r="http://schemas.openxmlformats.org/officeDocument/2006/relationships" id="264" r:id="R17fb6bf419844cc6"/>
-    <p:sldId xmlns:r="http://schemas.openxmlformats.org/officeDocument/2006/relationships" id="265" r:id="R629caccfb6dc4b8b"/>
-    <p:sldId xmlns:r="http://schemas.openxmlformats.org/officeDocument/2006/relationships" id="266" r:id="Rb51ce2f589ee4bf4"/>
+    <p:sldId xmlns:r="http://schemas.openxmlformats.org/officeDocument/2006/relationships" id="256" r:id="R5f379f32487c46ce"/>
+    <p:sldId xmlns:r="http://schemas.openxmlformats.org/officeDocument/2006/relationships" id="257" r:id="R23d6a3f531684974"/>
+    <p:sldId xmlns:r="http://schemas.openxmlformats.org/officeDocument/2006/relationships" id="258" r:id="R19a7c18fd230477b"/>
+    <p:sldId xmlns:r="http://schemas.openxmlformats.org/officeDocument/2006/relationships" id="259" r:id="R8f2e8abb1cfa4d1a"/>
+    <p:sldId xmlns:r="http://schemas.openxmlformats.org/officeDocument/2006/relationships" id="260" r:id="R3dcfd28e9d014167"/>
+    <p:sldId xmlns:r="http://schemas.openxmlformats.org/officeDocument/2006/relationships" id="261" r:id="R1fa0472dd8b94087"/>
+    <p:sldId xmlns:r="http://schemas.openxmlformats.org/officeDocument/2006/relationships" id="262" r:id="R8b6454466e764d3b"/>
+    <p:sldId xmlns:r="http://schemas.openxmlformats.org/officeDocument/2006/relationships" id="263" r:id="R06a3c9f606b5467f"/>
+    <p:sldId xmlns:r="http://schemas.openxmlformats.org/officeDocument/2006/relationships" id="264" r:id="R61bb36557def4795"/>
+    <p:sldId xmlns:r="http://schemas.openxmlformats.org/officeDocument/2006/relationships" id="265" r:id="Rcb4b4c1450d04142"/>
+    <p:sldId xmlns:r="http://schemas.openxmlformats.org/officeDocument/2006/relationships" id="266" r:id="R44f6c748708a449d"/>
   </p:sldIdLst>
   <p:sldSz cx="12192000" cy="6858000"/>
   <p:notesSz cx="6858000" cy="9144000"/>
@@ -1287,7 +1287,7 @@
           </a:p>
           <a:p xmlns:a="http://schemas.openxmlformats.org/drawingml/2006/main">
             <a:r>
-              <a:t>The LLM chooses which candidate to measure; XGBoost and heuristics score it. The host owns charging, correctness, and area/timing checks. In one archived SHA-256 pilot, hybrid memory reached the feasible design in two measurements; no retrieval took three and made three rejected finalization requests. The strongest heuristic needed one. Selector v2 now exposes the host-computed incumbent, rejects stale final choices, and returns measured facts separately from the model note. We have not rerun the LLM under v2.</a:t>
+              <a:t>The LLM chooses which candidate to measure; XGBoost and heuristics score it. The host owns charging, correctness, and area/timing checks. In one archived SHA-256 pilot, hybrid memory reached the feasible design in two measurements; no retrieval took three and made three rejected finalization requests. The strongest heuristic needed one. Selector v2 exposes the host-computed incumbent, rejects stale final choices, and returns measured facts separately from the model note. The router now permits one stronger-model recovery after malformed output or a host incumbent correction. This recovery path has software tests, but we have not run a live v2 comparison.</a:t>
             </a:r>
           </a:p>
           <a:p xmlns:a="http://schemas.openxmlformats.org/drawingml/2006/main">
@@ -1302,7 +1302,7 @@
           </a:p>
           <a:p xmlns:a="http://schemas.openxmlformats.org/drawingml/2006/main">
             <a:r>
-              <a:t>isaforge/agent_memory.py: fixed query over unattempted formulas; local TF-IDF/LSA hybrid, RRF k60, top3 source-linked history; not pretrained embeddings or general RAG. Both arms can access full history; retrieval changes ordering/emphasis. Four structured tools; host owns attempt charging and final acceptance. The ranker is not retrained; configured hardware GP can update on paid successes. The live Luna pilot is one archived-data trial per arm with cooperative file restrictions; hybrid used two queries/four turns, no retrieval three queries/nine turns, three rejected finalizations, and both reached 1.0213847x, +50 LUT4, 65.99353 MHz. The heuristic reached the same design in one query. Selector v2 now names the incumbent, enforces it at finalize, and returns canonical measured fields separately from unverified agent_summary. 79 tests and 10-policy/30-endpoint control replay pass; zero live LLM or native jobs for v2. No causal memory or superiority claim.</a:t>
+              <a:t>isaforge/agent_memory.py: fixed query over unattempted formulas; local TF-IDF/LSA hybrid, RRF k60, top3 source-linked history; not pretrained embeddings or general RAG. Both arms can access full history; retrieval changes ordering/emphasis. Four structured tools; host owns attempt charging and final acceptance. The ranker is not retrained; configured hardware GP can update on paid successes. The live Luna pilot is one archived-data trial per arm with cooperative file restrictions; hybrid used two queries/four turns, no retrieval three queries/nine turns, three rejected finalizations, and both reached 1.0213847x, +50 LUT4, 65.99353 MHz. The heuristic reached the same design in one query. Selector v2 names the incumbent, enforces it at finalize, and returns canonical measured fields separately from unverified agent_summary. Recovery router v2 escalates once after a malformed structured action or an explicit host incumbent correction, under the shared model-call cap; it does not retry measurement or transport failures. 84 focused tests pass; zero live v2 LLM calls or native jobs. No causal memory or superiority claim.</a:t>
             </a:r>
           </a:p>
         </p:txBody>
@@ -1387,7 +1387,7 @@
           </a:p>
           <a:p xmlns:a="http://schemas.openxmlformats.org/drawingml/2006/main">
             <a:r>
-              <a:t>Our four tools separate language-model proposals from trusted execution. List exposes legal candidates; predict returns model estimates; measure charges an attempt before evaluation; finalize accepts only the host-computed best paid, verified feasible improvement; baseline is allowed only when none exists. Invalid and repeated measurement attempts still cost budget. Observability connects each decision to its tool call, retrieved record and outcome. We version the protocol and source hashes, preserve failed actions, and export verified traces to SQLite. These are working local LLMOps components. The live pilot has thirteen recorded model turns, but token usage and model-only latency are unavailable. Production deployment and automated restart remain future work.</a:t>
+              <a:t>Our four tools separate language-model proposals from trusted execution. List exposes legal candidates; predict returns model estimates; measure charges an attempt before evaluation; finalize accepts only the host-computed best paid, verified feasible improvement; baseline is allowed only when none exists. Invalid and repeated measurement attempts still cost budget. Observability connects each decision to its tool call, retrieved record and outcome. We version the protocol and source hashes, preserve failed actions, and export verified traces to SQLite. The router records whether an escalation followed malformed output or a host incumbent correction. These are working local LLMOps components. The live pilot has thirteen recorded model turns, but token usage and model-only latency are unavailable. Production deployment and automated restart remain future work.</a:t>
             </a:r>
           </a:p>
           <a:p xmlns:a="http://schemas.openxmlformats.org/drawingml/2006/main">
@@ -1402,7 +1402,7 @@
           </a:p>
           <a:p xmlns:a="http://schemas.openxmlformats.org/drawingml/2006/main">
             <a:r>
-              <a:t>Tools: isaforge/selection_provider.py strict remote function schemas; isaforge/codex_chat_selector.py interactive JSON bridge. Host: bounded_selector.py. Measure reserves charge before lookup while budget remains. Invalid/repeated attempts count; repeats do not redispatch evaluator. Finalize accepts only the current host-computed best paid feasible improvement; null is allowed only with no improvement. Host returns canonical measured fields; the model text is an unverified agent_summary. Finite model/tool calls, incumbent fallback, fresh output paths; no restart/resume guarantee. Observability: export_agent_observability.py verifies manifest/protocol/ledger hashes and creates releases, episodes, decisions, model_calls, retrievals and tools tables. Raw ledgers authoritative. Live13 turns,4 retrievals; 3 rejected finalizations. Interactive elapsed time includes orchestration; tokens SQLNULL. Remote provider records tokens only if returned. LLMOps here is local versioning, reproducible evaluation and inspection, not production cloud operations. Selector v2 passes 79 focused tests; a 10-policy/30-endpoint SHA256 control replay matches archived trajectories exactly, with zero LLM/native jobs. Retrieval fits are not new speedup model versions.</a:t>
+              <a:t>Tools: isaforge/selection_provider.py strict remote function schemas; isaforge/codex_chat_selector.py interactive JSON bridge. Host: bounded_selector.py. Measure reserves charge before lookup while budget remains. Invalid/repeated attempts count; repeats do not redispatch evaluator. Finalize accepts only the current host-computed best paid feasible improvement; null is allowed only with no improvement. Host returns canonical measured fields; the model text is an unverified agent_summary. Finite model/tool calls, incumbent fallback, fresh output paths; no restart/resume guarantee. Observability: export_agent_observability.py verifies manifest/protocol/ledger hashes and creates releases, episodes, decisions, model_calls, retrievals and tools tables. Raw ledgers authoritative. Live13 turns,4 retrievals; 3 rejected finalizations. Interactive elapsed time includes orchestration; tokens SQLNULL. Remote provider records tokens only if returned. LLMOps here is local versioning, reproducible evaluation and inspection, not production cloud operations. Selector v2 and recovery routing pass 84 focused tests; recovery routing has no live v2 comparison. A 10-policy/30-endpoint SHA256 control replay matches archived trajectories exactly, with zero LLM/native jobs. Retrieval fits are not new speedup model versions.</a:t>
             </a:r>
           </a:p>
         </p:txBody>
@@ -1549,7 +1549,7 @@
           <p:cNvPr id="3" name="Title">
             <a:extLst xmlns:a="http://schemas.openxmlformats.org/drawingml/2006/main">
               <a:ext uri="{FF2B5EF4-FFF2-40B4-BE49-F238E27FC236}">
-                <a16:creationId xmlns:a16="http://schemas.microsoft.com/office/drawing/2014/main" id="{5513BE8A-C64D-4A99-A47D-3B997666F5EB}"/>
+                <a16:creationId xmlns:a16="http://schemas.microsoft.com/office/drawing/2014/main" id="{538589F6-52DA-47E3-ACD3-5765685235F0}"/>
               </a:ext>
             </a:extLst>
           </p:cNvPr>
@@ -1778,7 +1778,7 @@
           <p:cNvPr id="2" name="Subtitle">
             <a:extLst xmlns:a="http://schemas.openxmlformats.org/drawingml/2006/main">
               <a:ext uri="{FF2B5EF4-FFF2-40B4-BE49-F238E27FC236}">
-                <a16:creationId xmlns:a16="http://schemas.microsoft.com/office/drawing/2014/main" id="{6C91BBA7-CB79-4C3B-9649-EBEA7D27F4C8}"/>
+                <a16:creationId xmlns:a16="http://schemas.microsoft.com/office/drawing/2014/main" id="{FCB0E82D-8439-43CA-9B0C-363C0DB8CA0F}"/>
               </a:ext>
             </a:extLst>
           </p:cNvPr>
@@ -2024,7 +2024,7 @@
           <p:cNvPr id="2" name="Section title">
             <a:extLst xmlns:a="http://schemas.openxmlformats.org/drawingml/2006/main">
               <a:ext uri="{FF2B5EF4-FFF2-40B4-BE49-F238E27FC236}">
-                <a16:creationId xmlns:a16="http://schemas.microsoft.com/office/drawing/2014/main" id="{F631BDD3-0401-448E-B115-4017531B9D52}"/>
+                <a16:creationId xmlns:a16="http://schemas.microsoft.com/office/drawing/2014/main" id="{977B2C04-8620-482D-ABBC-6B7335C57439}"/>
               </a:ext>
             </a:extLst>
           </p:cNvPr>
@@ -2270,7 +2270,7 @@
           <p:cNvPr id="3" name="Title">
             <a:extLst xmlns:a="http://schemas.openxmlformats.org/drawingml/2006/main">
               <a:ext uri="{FF2B5EF4-FFF2-40B4-BE49-F238E27FC236}">
-                <a16:creationId xmlns:a16="http://schemas.microsoft.com/office/drawing/2014/main" id="{7F473609-5592-4305-B439-AED263ABD32D}"/>
+                <a16:creationId xmlns:a16="http://schemas.microsoft.com/office/drawing/2014/main" id="{5B419E7E-74D7-4B78-A55A-EA4F1406ABEC}"/>
               </a:ext>
             </a:extLst>
           </p:cNvPr>
@@ -2499,7 +2499,7 @@
           <p:cNvPr id="2" name="Body">
             <a:extLst xmlns:a="http://schemas.openxmlformats.org/drawingml/2006/main">
               <a:ext uri="{FF2B5EF4-FFF2-40B4-BE49-F238E27FC236}">
-                <a16:creationId xmlns:a16="http://schemas.microsoft.com/office/drawing/2014/main" id="{2E2B4F50-6501-4665-A7AB-64699FE9BBCE}"/>
+                <a16:creationId xmlns:a16="http://schemas.microsoft.com/office/drawing/2014/main" id="{2A36EFC5-B10A-442B-8A67-4B51913C3D39}"/>
               </a:ext>
             </a:extLst>
           </p:cNvPr>
@@ -2745,7 +2745,7 @@
           <p:cNvPr id="4" name="Title">
             <a:extLst xmlns:a="http://schemas.openxmlformats.org/drawingml/2006/main">
               <a:ext uri="{FF2B5EF4-FFF2-40B4-BE49-F238E27FC236}">
-                <a16:creationId xmlns:a16="http://schemas.microsoft.com/office/drawing/2014/main" id="{8C6E3C1A-8AE5-428E-954A-D316E5B1E07D}"/>
+                <a16:creationId xmlns:a16="http://schemas.microsoft.com/office/drawing/2014/main" id="{553B9917-0994-4328-BD0D-8F9A83DFDB94}"/>
               </a:ext>
             </a:extLst>
           </p:cNvPr>
@@ -2974,7 +2974,7 @@
           <p:cNvPr id="2" name="Left column">
             <a:extLst xmlns:a="http://schemas.openxmlformats.org/drawingml/2006/main">
               <a:ext uri="{FF2B5EF4-FFF2-40B4-BE49-F238E27FC236}">
-                <a16:creationId xmlns:a16="http://schemas.microsoft.com/office/drawing/2014/main" id="{2ECE4D62-CCC5-45B4-9E10-9ECBA27D8554}"/>
+                <a16:creationId xmlns:a16="http://schemas.microsoft.com/office/drawing/2014/main" id="{45BF310D-24D6-4167-A3CB-1F88A9063326}"/>
               </a:ext>
             </a:extLst>
           </p:cNvPr>
@@ -3203,7 +3203,7 @@
           <p:cNvPr id="3" name="Right column">
             <a:extLst xmlns:a="http://schemas.openxmlformats.org/drawingml/2006/main">
               <a:ext uri="{FF2B5EF4-FFF2-40B4-BE49-F238E27FC236}">
-                <a16:creationId xmlns:a16="http://schemas.microsoft.com/office/drawing/2014/main" id="{4B667AEB-CB9E-43FB-B51E-EFC585CCC244}"/>
+                <a16:creationId xmlns:a16="http://schemas.microsoft.com/office/drawing/2014/main" id="{FBDB66F8-FDAC-4DD5-A2FB-A9A1A94DB670}"/>
               </a:ext>
             </a:extLst>
           </p:cNvPr>
@@ -3449,7 +3449,7 @@
           <p:cNvPr id="3" name="Title">
             <a:extLst xmlns:a="http://schemas.openxmlformats.org/drawingml/2006/main">
               <a:ext uri="{FF2B5EF4-FFF2-40B4-BE49-F238E27FC236}">
-                <a16:creationId xmlns:a16="http://schemas.microsoft.com/office/drawing/2014/main" id="{E40448DD-8E9B-4F49-A453-3253D314B4C6}"/>
+                <a16:creationId xmlns:a16="http://schemas.microsoft.com/office/drawing/2014/main" id="{097D22EE-6814-4001-965E-B825BBBFB70A}"/>
               </a:ext>
             </a:extLst>
           </p:cNvPr>
@@ -3678,7 +3678,7 @@
           <p:cNvPr id="2" name="Left column">
             <a:extLst xmlns:a="http://schemas.openxmlformats.org/drawingml/2006/main">
               <a:ext uri="{FF2B5EF4-FFF2-40B4-BE49-F238E27FC236}">
-                <a16:creationId xmlns:a16="http://schemas.microsoft.com/office/drawing/2014/main" id="{48D21222-97B3-48EE-A2F3-FFE00E88A7C3}"/>
+                <a16:creationId xmlns:a16="http://schemas.microsoft.com/office/drawing/2014/main" id="{C946CF09-8FD2-4793-93AD-0CF1045E1453}"/>
               </a:ext>
             </a:extLst>
           </p:cNvPr>
@@ -3945,12 +3945,12 @@
   </p:cSld>
   <p:clrMap bg1="lt1" tx1="dk1" bg2="lt2" tx2="dk2" accent1="accent1" accent2="accent2" accent3="accent3" accent4="accent4" accent5="accent5" accent6="accent6" hlink="hlink" folHlink="folHlink"/>
   <p:sldLayoutIdLst>
-    <p:sldLayoutId xmlns:r="http://schemas.openxmlformats.org/officeDocument/2006/relationships" id="2147483649" r:id="R79bea9d0617846a8"/>
-    <p:sldLayoutId xmlns:r="http://schemas.openxmlformats.org/officeDocument/2006/relationships" id="2147483650" r:id="Rb1d17e2a67fc4261"/>
-    <p:sldLayoutId xmlns:r="http://schemas.openxmlformats.org/officeDocument/2006/relationships" id="2147483651" r:id="Rd6d68d7c3c8147f2"/>
-    <p:sldLayoutId xmlns:r="http://schemas.openxmlformats.org/officeDocument/2006/relationships" id="2147483652" r:id="Rcca3edbfb2044a9f"/>
-    <p:sldLayoutId xmlns:r="http://schemas.openxmlformats.org/officeDocument/2006/relationships" id="2147483653" r:id="Ra26045650aba4d99"/>
-    <p:sldLayoutId xmlns:r="http://schemas.openxmlformats.org/officeDocument/2006/relationships" id="2147483654" r:id="Rac64838366494228"/>
+    <p:sldLayoutId xmlns:r="http://schemas.openxmlformats.org/officeDocument/2006/relationships" id="2147483649" r:id="Rd6fc4cee12d24a3c"/>
+    <p:sldLayoutId xmlns:r="http://schemas.openxmlformats.org/officeDocument/2006/relationships" id="2147483650" r:id="R67a4aec8172349d3"/>
+    <p:sldLayoutId xmlns:r="http://schemas.openxmlformats.org/officeDocument/2006/relationships" id="2147483651" r:id="Ra5b94f3ca74a4869"/>
+    <p:sldLayoutId xmlns:r="http://schemas.openxmlformats.org/officeDocument/2006/relationships" id="2147483652" r:id="R0e2572e4926d4022"/>
+    <p:sldLayoutId xmlns:r="http://schemas.openxmlformats.org/officeDocument/2006/relationships" id="2147483653" r:id="R177a607d607542a1"/>
+    <p:sldLayoutId xmlns:r="http://schemas.openxmlformats.org/officeDocument/2006/relationships" id="2147483654" r:id="R3abf34b303a14775"/>
   </p:sldLayoutIdLst>
   <p:txStyles>
     <p:titleStyle>
@@ -5273,7 +5273,7 @@
           <p:cNvPr id="8" name="">
             <a:extLst xmlns:a="http://schemas.openxmlformats.org/drawingml/2006/main">
               <a:ext uri="{FF2B5EF4-FFF2-40B4-BE49-F238E27FC236}">
-                <a16:creationId xmlns:a16="http://schemas.microsoft.com/office/drawing/2014/main" id="{CE21B89F-E955-4F78-9766-3ACBF6B51F4B}"/>
+                <a16:creationId xmlns:a16="http://schemas.microsoft.com/office/drawing/2014/main" id="{DB6F0F5B-E92B-40BD-9EE0-DF6574ED011D}"/>
               </a:ext>
             </a:extLst>
           </p:cNvPr>
@@ -5430,7 +5430,7 @@
           <p:cNvPr id="2" name="">
             <a:extLst xmlns:a="http://schemas.openxmlformats.org/drawingml/2006/main">
               <a:ext uri="{FF2B5EF4-FFF2-40B4-BE49-F238E27FC236}">
-                <a16:creationId xmlns:a16="http://schemas.microsoft.com/office/drawing/2014/main" id="{4A2579E4-89FE-4BEF-B318-5D0320D6078F}"/>
+                <a16:creationId xmlns:a16="http://schemas.microsoft.com/office/drawing/2014/main" id="{287B79C4-1156-46D3-ACDD-280F8308B547}"/>
               </a:ext>
             </a:extLst>
           </p:cNvPr>
@@ -5461,7 +5461,7 @@
           <p:cNvPr id="3" name="">
             <a:extLst xmlns:a="http://schemas.openxmlformats.org/drawingml/2006/main">
               <a:ext uri="{FF2B5EF4-FFF2-40B4-BE49-F238E27FC236}">
-                <a16:creationId xmlns:a16="http://schemas.microsoft.com/office/drawing/2014/main" id="{04CB9177-0813-4C9D-BE4B-8B5D40128F11}"/>
+                <a16:creationId xmlns:a16="http://schemas.microsoft.com/office/drawing/2014/main" id="{D306E147-C3D0-4FC9-BD08-AF28F3803598}"/>
               </a:ext>
             </a:extLst>
           </p:cNvPr>
@@ -5618,7 +5618,7 @@
           <p:cNvPr id="4" name="">
             <a:extLst xmlns:a="http://schemas.openxmlformats.org/drawingml/2006/main">
               <a:ext uri="{FF2B5EF4-FFF2-40B4-BE49-F238E27FC236}">
-                <a16:creationId xmlns:a16="http://schemas.microsoft.com/office/drawing/2014/main" id="{B88DC9F3-BC0F-4C30-8DB7-F0BE859A4C91}"/>
+                <a16:creationId xmlns:a16="http://schemas.microsoft.com/office/drawing/2014/main" id="{EFB1C53D-E0FA-4FB8-9072-734474BAB250}"/>
               </a:ext>
             </a:extLst>
           </p:cNvPr>
@@ -5775,7 +5775,7 @@
           <p:cNvPr id="5" name="">
             <a:extLst xmlns:a="http://schemas.openxmlformats.org/drawingml/2006/main">
               <a:ext uri="{FF2B5EF4-FFF2-40B4-BE49-F238E27FC236}">
-                <a16:creationId xmlns:a16="http://schemas.microsoft.com/office/drawing/2014/main" id="{84F3C2AD-8880-4D04-AA77-BEAB13E00FC4}"/>
+                <a16:creationId xmlns:a16="http://schemas.microsoft.com/office/drawing/2014/main" id="{5B58B7E2-C818-491D-B935-6D62640434FB}"/>
               </a:ext>
             </a:extLst>
           </p:cNvPr>
@@ -5955,7 +5955,7 @@
           <p:cNvPr id="6" name="">
             <a:extLst xmlns:a="http://schemas.openxmlformats.org/drawingml/2006/main">
               <a:ext uri="{FF2B5EF4-FFF2-40B4-BE49-F238E27FC236}">
-                <a16:creationId xmlns:a16="http://schemas.microsoft.com/office/drawing/2014/main" id="{D2DBD6C3-1071-4EF5-BC40-48460B0F8C61}"/>
+                <a16:creationId xmlns:a16="http://schemas.microsoft.com/office/drawing/2014/main" id="{D93E4776-929E-4531-9468-AFD924A077CC}"/>
               </a:ext>
             </a:extLst>
           </p:cNvPr>
@@ -6112,7 +6112,7 @@
           <p:cNvPr id="7" name="">
             <a:extLst xmlns:a="http://schemas.openxmlformats.org/drawingml/2006/main">
               <a:ext uri="{FF2B5EF4-FFF2-40B4-BE49-F238E27FC236}">
-                <a16:creationId xmlns:a16="http://schemas.microsoft.com/office/drawing/2014/main" id="{754242D2-DB50-4056-9CEF-64C3D0ADCD0C}"/>
+                <a16:creationId xmlns:a16="http://schemas.microsoft.com/office/drawing/2014/main" id="{1F430FDF-557D-4231-8FFA-4D06FE714F02}"/>
               </a:ext>
             </a:extLst>
           </p:cNvPr>
@@ -6267,7 +6267,7 @@
     </p:spTree>
     <p:extLst>
       <p:ext uri="{BB962C8B-B14F-4D97-AF65-F5344CB8AC3E}">
-        <p14:creationId xmlns:p14="http://schemas.microsoft.com/office/powerpoint/2010/main" val="1493702407"/>
+        <p14:creationId xmlns:p14="http://schemas.microsoft.com/office/powerpoint/2010/main" val="1395172699"/>
       </p:ext>
     </p:extLst>
   </p:cSld>
@@ -6298,7 +6298,7 @@
           <p:cNvPr id="9" name="">
             <a:extLst xmlns:a="http://schemas.openxmlformats.org/drawingml/2006/main">
               <a:ext uri="{FF2B5EF4-FFF2-40B4-BE49-F238E27FC236}">
-                <a16:creationId xmlns:a16="http://schemas.microsoft.com/office/drawing/2014/main" id="{01448DCD-9FA3-47AE-AD8E-FE2815FBF7E1}"/>
+                <a16:creationId xmlns:a16="http://schemas.microsoft.com/office/drawing/2014/main" id="{2B3ABDBC-9D3A-4C00-9ED7-4A4578502237}"/>
               </a:ext>
             </a:extLst>
           </p:cNvPr>
@@ -6455,7 +6455,7 @@
           <p:cNvPr id="2" name="">
             <a:extLst xmlns:a="http://schemas.openxmlformats.org/drawingml/2006/main">
               <a:ext uri="{FF2B5EF4-FFF2-40B4-BE49-F238E27FC236}">
-                <a16:creationId xmlns:a16="http://schemas.microsoft.com/office/drawing/2014/main" id="{8FA94971-4E53-4838-AADB-E3B1E91FE9A8}"/>
+                <a16:creationId xmlns:a16="http://schemas.microsoft.com/office/drawing/2014/main" id="{9C1DF459-95DA-4DF2-BA86-ACC1490E809C}"/>
               </a:ext>
             </a:extLst>
           </p:cNvPr>
@@ -6486,7 +6486,7 @@
           <p:cNvPr id="3" name="">
             <a:extLst xmlns:a="http://schemas.openxmlformats.org/drawingml/2006/main">
               <a:ext uri="{FF2B5EF4-FFF2-40B4-BE49-F238E27FC236}">
-                <a16:creationId xmlns:a16="http://schemas.microsoft.com/office/drawing/2014/main" id="{AF17F67E-09FF-4D56-9038-B6EF48D601E4}"/>
+                <a16:creationId xmlns:a16="http://schemas.microsoft.com/office/drawing/2014/main" id="{C3FC5D79-D8DF-49E5-A585-D48C86335620}"/>
               </a:ext>
             </a:extLst>
           </p:cNvPr>
@@ -6643,7 +6643,7 @@
           <p:cNvPr id="4" name="Chart">
             <a:extLst xmlns:a="http://schemas.openxmlformats.org/drawingml/2006/main">
               <a:ext uri="{FF2B5EF4-FFF2-40B4-BE49-F238E27FC236}">
-                <a16:creationId xmlns:a16="http://schemas.microsoft.com/office/drawing/2014/main" id="{AF3C75F5-6A94-46A8-93D9-4439F185D240}"/>
+                <a16:creationId xmlns:a16="http://schemas.microsoft.com/office/drawing/2014/main" id="{75F2B8EF-DC6C-49B8-804B-EA4D166BCFD2}"/>
               </a:ext>
             </a:extLst>
           </p:cNvPr>
@@ -6656,7 +6656,7 @@
         </p:xfrm>
         <a:graphic xmlns:a="http://schemas.openxmlformats.org/drawingml/2006/main">
           <a:graphicData uri="http://schemas.openxmlformats.org/drawingml/2006/chart">
-            <c:chart xmlns:r="http://schemas.openxmlformats.org/officeDocument/2006/relationships" xmlns:c="http://schemas.openxmlformats.org/drawingml/2006/chart" r:id="Rbfc2e2bee1b7490a"/>
+            <c:chart xmlns:r="http://schemas.openxmlformats.org/officeDocument/2006/relationships" xmlns:c="http://schemas.openxmlformats.org/drawingml/2006/chart" r:id="Rb906a647000944f8"/>
           </a:graphicData>
         </a:graphic>
       </p:graphicFrame>
@@ -6665,7 +6665,7 @@
           <p:cNvPr id="5" name="">
             <a:extLst xmlns:a="http://schemas.openxmlformats.org/drawingml/2006/main">
               <a:ext uri="{FF2B5EF4-FFF2-40B4-BE49-F238E27FC236}">
-                <a16:creationId xmlns:a16="http://schemas.microsoft.com/office/drawing/2014/main" id="{7CB293C1-51D3-4CE9-9570-4DAD29DC0044}"/>
+                <a16:creationId xmlns:a16="http://schemas.microsoft.com/office/drawing/2014/main" id="{7F8ADDF5-E394-45A0-807D-C39CBB86B5A9}"/>
               </a:ext>
             </a:extLst>
           </p:cNvPr>
@@ -6822,7 +6822,7 @@
           <p:cNvPr id="6" name="">
             <a:extLst xmlns:a="http://schemas.openxmlformats.org/drawingml/2006/main">
               <a:ext uri="{FF2B5EF4-FFF2-40B4-BE49-F238E27FC236}">
-                <a16:creationId xmlns:a16="http://schemas.microsoft.com/office/drawing/2014/main" id="{FD3E0FEA-296E-4B00-B6EC-C6E0EC75F375}"/>
+                <a16:creationId xmlns:a16="http://schemas.microsoft.com/office/drawing/2014/main" id="{F4D167B5-1895-4D3B-B150-ADC1562725CD}"/>
               </a:ext>
             </a:extLst>
           </p:cNvPr>
@@ -7053,7 +7053,7 @@
           <p:cNvPr id="7" name="">
             <a:extLst xmlns:a="http://schemas.openxmlformats.org/drawingml/2006/main">
               <a:ext uri="{FF2B5EF4-FFF2-40B4-BE49-F238E27FC236}">
-                <a16:creationId xmlns:a16="http://schemas.microsoft.com/office/drawing/2014/main" id="{A0C6BFE4-DE9A-4FAE-9623-CA734E70A92E}"/>
+                <a16:creationId xmlns:a16="http://schemas.microsoft.com/office/drawing/2014/main" id="{1A346A80-E56D-412B-A205-531B18D61836}"/>
               </a:ext>
             </a:extLst>
           </p:cNvPr>
@@ -7233,7 +7233,7 @@
           <p:cNvPr id="8" name="">
             <a:extLst xmlns:a="http://schemas.openxmlformats.org/drawingml/2006/main">
               <a:ext uri="{FF2B5EF4-FFF2-40B4-BE49-F238E27FC236}">
-                <a16:creationId xmlns:a16="http://schemas.microsoft.com/office/drawing/2014/main" id="{95C5DBDC-1F16-4D0B-98EA-6B7CC26E5DEC}"/>
+                <a16:creationId xmlns:a16="http://schemas.microsoft.com/office/drawing/2014/main" id="{F8DB59C3-DE35-41EB-8905-951723077170}"/>
               </a:ext>
             </a:extLst>
           </p:cNvPr>
@@ -7388,7 +7388,7 @@
     </p:spTree>
     <p:extLst>
       <p:ext uri="{BB962C8B-B14F-4D97-AF65-F5344CB8AC3E}">
-        <p14:creationId xmlns:p14="http://schemas.microsoft.com/office/powerpoint/2010/main" val="1976786798"/>
+        <p14:creationId xmlns:p14="http://schemas.microsoft.com/office/powerpoint/2010/main" val="1898035131"/>
       </p:ext>
     </p:extLst>
   </p:cSld>
@@ -7419,7 +7419,7 @@
           <p:cNvPr id="9" name="">
             <a:extLst xmlns:a="http://schemas.openxmlformats.org/drawingml/2006/main">
               <a:ext uri="{FF2B5EF4-FFF2-40B4-BE49-F238E27FC236}">
-                <a16:creationId xmlns:a16="http://schemas.microsoft.com/office/drawing/2014/main" id="{9264B8D7-5548-4600-ABD1-1824E37A4ACD}"/>
+                <a16:creationId xmlns:a16="http://schemas.microsoft.com/office/drawing/2014/main" id="{2BF8C18B-6BD5-4074-A765-A0B60183F8EF}"/>
               </a:ext>
             </a:extLst>
           </p:cNvPr>
@@ -7576,7 +7576,7 @@
           <p:cNvPr id="2" name="">
             <a:extLst xmlns:a="http://schemas.openxmlformats.org/drawingml/2006/main">
               <a:ext uri="{FF2B5EF4-FFF2-40B4-BE49-F238E27FC236}">
-                <a16:creationId xmlns:a16="http://schemas.microsoft.com/office/drawing/2014/main" id="{A3A76AD5-F76C-4317-BB16-20AC80D9DC9C}"/>
+                <a16:creationId xmlns:a16="http://schemas.microsoft.com/office/drawing/2014/main" id="{B427115C-CED6-468D-BCBE-3EA46C1BE4A8}"/>
               </a:ext>
             </a:extLst>
           </p:cNvPr>
@@ -7607,7 +7607,7 @@
           <p:cNvPr id="3" name="">
             <a:extLst xmlns:a="http://schemas.openxmlformats.org/drawingml/2006/main">
               <a:ext uri="{FF2B5EF4-FFF2-40B4-BE49-F238E27FC236}">
-                <a16:creationId xmlns:a16="http://schemas.microsoft.com/office/drawing/2014/main" id="{6EF9E416-D741-4653-A4A5-E9190082EF3B}"/>
+                <a16:creationId xmlns:a16="http://schemas.microsoft.com/office/drawing/2014/main" id="{0710392D-E7DA-466F-B0EC-936E8D0ABD4A}"/>
               </a:ext>
             </a:extLst>
           </p:cNvPr>
@@ -7764,7 +7764,7 @@
           <p:cNvPr id="4" name="">
             <a:extLst xmlns:a="http://schemas.openxmlformats.org/drawingml/2006/main">
               <a:ext uri="{FF2B5EF4-FFF2-40B4-BE49-F238E27FC236}">
-                <a16:creationId xmlns:a16="http://schemas.microsoft.com/office/drawing/2014/main" id="{65FBD8E6-36F9-4897-9E7F-36286773CEF7}"/>
+                <a16:creationId xmlns:a16="http://schemas.microsoft.com/office/drawing/2014/main" id="{AF7D0A78-ED95-4238-B85C-2297CC0CC55B}"/>
               </a:ext>
             </a:extLst>
           </p:cNvPr>
@@ -7921,7 +7921,7 @@
           <p:cNvPr id="5" name="">
             <a:extLst xmlns:a="http://schemas.openxmlformats.org/drawingml/2006/main">
               <a:ext uri="{FF2B5EF4-FFF2-40B4-BE49-F238E27FC236}">
-                <a16:creationId xmlns:a16="http://schemas.microsoft.com/office/drawing/2014/main" id="{4676B083-CCEB-463A-BFC3-20F59324D617}"/>
+                <a16:creationId xmlns:a16="http://schemas.microsoft.com/office/drawing/2014/main" id="{A9459BA6-5874-4AA6-956E-2D151F00797D}"/>
               </a:ext>
             </a:extLst>
           </p:cNvPr>
@@ -8147,7 +8147,7 @@
           <p:cNvPr id="6" name="">
             <a:extLst xmlns:a="http://schemas.openxmlformats.org/drawingml/2006/main">
               <a:ext uri="{FF2B5EF4-FFF2-40B4-BE49-F238E27FC236}">
-                <a16:creationId xmlns:a16="http://schemas.microsoft.com/office/drawing/2014/main" id="{17CF0056-1B24-4B01-8E40-3560F0620AB9}"/>
+                <a16:creationId xmlns:a16="http://schemas.microsoft.com/office/drawing/2014/main" id="{4E3EAEF0-C220-4D00-9F7B-F43924D0DFF6}"/>
               </a:ext>
             </a:extLst>
           </p:cNvPr>
@@ -8304,7 +8304,7 @@
           <p:cNvPr id="7" name="">
             <a:extLst xmlns:a="http://schemas.openxmlformats.org/drawingml/2006/main">
               <a:ext uri="{FF2B5EF4-FFF2-40B4-BE49-F238E27FC236}">
-                <a16:creationId xmlns:a16="http://schemas.microsoft.com/office/drawing/2014/main" id="{78E10646-F271-41CC-872B-166A7A484CD3}"/>
+                <a16:creationId xmlns:a16="http://schemas.microsoft.com/office/drawing/2014/main" id="{1F7E5FAC-6B28-43B7-B5AA-B4B90FD50356}"/>
               </a:ext>
             </a:extLst>
           </p:cNvPr>
@@ -8530,7 +8530,7 @@
           <p:cNvPr id="8" name="">
             <a:extLst xmlns:a="http://schemas.openxmlformats.org/drawingml/2006/main">
               <a:ext uri="{FF2B5EF4-FFF2-40B4-BE49-F238E27FC236}">
-                <a16:creationId xmlns:a16="http://schemas.microsoft.com/office/drawing/2014/main" id="{300F4741-105E-4B27-BDBD-4BAF2EB8BFE0}"/>
+                <a16:creationId xmlns:a16="http://schemas.microsoft.com/office/drawing/2014/main" id="{69A02A47-E8FA-410D-8089-679CCE6E8ADC}"/>
               </a:ext>
             </a:extLst>
           </p:cNvPr>
@@ -8685,7 +8685,7 @@
     </p:spTree>
     <p:extLst>
       <p:ext uri="{BB962C8B-B14F-4D97-AF65-F5344CB8AC3E}">
-        <p14:creationId xmlns:p14="http://schemas.microsoft.com/office/powerpoint/2010/main" val="1491182226"/>
+        <p14:creationId xmlns:p14="http://schemas.microsoft.com/office/powerpoint/2010/main" val="1199632463"/>
       </p:ext>
     </p:extLst>
   </p:cSld>
@@ -8716,7 +8716,7 @@
           <p:cNvPr id="20" name="">
             <a:extLst xmlns:a="http://schemas.openxmlformats.org/drawingml/2006/main">
               <a:ext uri="{FF2B5EF4-FFF2-40B4-BE49-F238E27FC236}">
-                <a16:creationId xmlns:a16="http://schemas.microsoft.com/office/drawing/2014/main" id="{5D29C35B-4399-42C1-A12E-EB216102E6CE}"/>
+                <a16:creationId xmlns:a16="http://schemas.microsoft.com/office/drawing/2014/main" id="{56C58C9C-8380-4AFC-9D5A-62838D165B2B}"/>
               </a:ext>
             </a:extLst>
           </p:cNvPr>
@@ -8873,7 +8873,7 @@
           <p:cNvPr id="2" name="">
             <a:extLst xmlns:a="http://schemas.openxmlformats.org/drawingml/2006/main">
               <a:ext uri="{FF2B5EF4-FFF2-40B4-BE49-F238E27FC236}">
-                <a16:creationId xmlns:a16="http://schemas.microsoft.com/office/drawing/2014/main" id="{A84E293E-9C2A-4F40-A38A-597C75BEE26F}"/>
+                <a16:creationId xmlns:a16="http://schemas.microsoft.com/office/drawing/2014/main" id="{A9D20C09-79DA-43CD-9405-99937E3B9B84}"/>
               </a:ext>
             </a:extLst>
           </p:cNvPr>
@@ -8904,7 +8904,7 @@
           <p:cNvPr id="3" name="">
             <a:extLst xmlns:a="http://schemas.openxmlformats.org/drawingml/2006/main">
               <a:ext uri="{FF2B5EF4-FFF2-40B4-BE49-F238E27FC236}">
-                <a16:creationId xmlns:a16="http://schemas.microsoft.com/office/drawing/2014/main" id="{26275ABA-B531-44CA-AECC-A82F314688B6}"/>
+                <a16:creationId xmlns:a16="http://schemas.microsoft.com/office/drawing/2014/main" id="{ABC5AA38-DA3C-49F3-9034-A924C31BA43E}"/>
               </a:ext>
             </a:extLst>
           </p:cNvPr>
@@ -9061,7 +9061,7 @@
           <p:cNvPr id="4" name="">
             <a:extLst xmlns:a="http://schemas.openxmlformats.org/drawingml/2006/main">
               <a:ext uri="{FF2B5EF4-FFF2-40B4-BE49-F238E27FC236}">
-                <a16:creationId xmlns:a16="http://schemas.microsoft.com/office/drawing/2014/main" id="{3A0B725F-2E6C-4B05-8F87-CB2E4F1920C6}"/>
+                <a16:creationId xmlns:a16="http://schemas.microsoft.com/office/drawing/2014/main" id="{B6ECC990-ACEB-4072-AB4B-A0049173027B}"/>
               </a:ext>
             </a:extLst>
           </p:cNvPr>
@@ -9218,7 +9218,7 @@
           <p:cNvPr id="5" name="">
             <a:extLst xmlns:a="http://schemas.openxmlformats.org/drawingml/2006/main">
               <a:ext uri="{FF2B5EF4-FFF2-40B4-BE49-F238E27FC236}">
-                <a16:creationId xmlns:a16="http://schemas.microsoft.com/office/drawing/2014/main" id="{D1CF167D-E57A-4422-8BAF-C1402CEE7D49}"/>
+                <a16:creationId xmlns:a16="http://schemas.microsoft.com/office/drawing/2014/main" id="{283B1131-C811-427F-AF11-A2279C22D604}"/>
               </a:ext>
             </a:extLst>
           </p:cNvPr>
@@ -9375,7 +9375,7 @@
           <p:cNvPr id="6" name="">
             <a:extLst xmlns:a="http://schemas.openxmlformats.org/drawingml/2006/main">
               <a:ext uri="{FF2B5EF4-FFF2-40B4-BE49-F238E27FC236}">
-                <a16:creationId xmlns:a16="http://schemas.microsoft.com/office/drawing/2014/main" id="{CEDA91A6-AAA1-40E3-99B1-D03CC20467E6}"/>
+                <a16:creationId xmlns:a16="http://schemas.microsoft.com/office/drawing/2014/main" id="{83B8EDE1-FDEF-40DC-9832-93C1E4257C20}"/>
               </a:ext>
             </a:extLst>
           </p:cNvPr>
@@ -9532,7 +9532,7 @@
           <p:cNvPr id="7" name="">
             <a:extLst xmlns:a="http://schemas.openxmlformats.org/drawingml/2006/main">
               <a:ext uri="{FF2B5EF4-FFF2-40B4-BE49-F238E27FC236}">
-                <a16:creationId xmlns:a16="http://schemas.microsoft.com/office/drawing/2014/main" id="{8B7E23A8-5E07-4927-B1D1-BA3E270A4816}"/>
+                <a16:creationId xmlns:a16="http://schemas.microsoft.com/office/drawing/2014/main" id="{5A99FE21-5CC8-4E52-8277-74A849F7B051}"/>
               </a:ext>
             </a:extLst>
           </p:cNvPr>
@@ -9563,7 +9563,7 @@
           <p:cNvPr id="8" name="">
             <a:extLst xmlns:a="http://schemas.openxmlformats.org/drawingml/2006/main">
               <a:ext uri="{FF2B5EF4-FFF2-40B4-BE49-F238E27FC236}">
-                <a16:creationId xmlns:a16="http://schemas.microsoft.com/office/drawing/2014/main" id="{CDFC2FDB-2596-4745-B8A1-EF3D667373F3}"/>
+                <a16:creationId xmlns:a16="http://schemas.microsoft.com/office/drawing/2014/main" id="{2BD6ECE7-BEDB-45F5-B447-3CA009E083D1}"/>
               </a:ext>
             </a:extLst>
           </p:cNvPr>
@@ -9720,7 +9720,7 @@
           <p:cNvPr id="9" name="">
             <a:extLst xmlns:a="http://schemas.openxmlformats.org/drawingml/2006/main">
               <a:ext uri="{FF2B5EF4-FFF2-40B4-BE49-F238E27FC236}">
-                <a16:creationId xmlns:a16="http://schemas.microsoft.com/office/drawing/2014/main" id="{B27FBE96-A1FE-47D0-8B68-14ABA8F3F9E2}"/>
+                <a16:creationId xmlns:a16="http://schemas.microsoft.com/office/drawing/2014/main" id="{8A5AEFDF-7D2D-42C6-922C-A31812E15636}"/>
               </a:ext>
             </a:extLst>
           </p:cNvPr>
@@ -9877,7 +9877,7 @@
           <p:cNvPr id="10" name="">
             <a:extLst xmlns:a="http://schemas.openxmlformats.org/drawingml/2006/main">
               <a:ext uri="{FF2B5EF4-FFF2-40B4-BE49-F238E27FC236}">
-                <a16:creationId xmlns:a16="http://schemas.microsoft.com/office/drawing/2014/main" id="{5F075E4F-14AA-42E8-BDFC-F202B844C4C2}"/>
+                <a16:creationId xmlns:a16="http://schemas.microsoft.com/office/drawing/2014/main" id="{916D3FBE-A7F8-45EA-9300-2AB986C4D76F}"/>
               </a:ext>
             </a:extLst>
           </p:cNvPr>
@@ -10034,7 +10034,7 @@
           <p:cNvPr id="11" name="">
             <a:extLst xmlns:a="http://schemas.openxmlformats.org/drawingml/2006/main">
               <a:ext uri="{FF2B5EF4-FFF2-40B4-BE49-F238E27FC236}">
-                <a16:creationId xmlns:a16="http://schemas.microsoft.com/office/drawing/2014/main" id="{B6FCFA83-2378-42AE-A258-B343C2DE4FDC}"/>
+                <a16:creationId xmlns:a16="http://schemas.microsoft.com/office/drawing/2014/main" id="{2970E9CC-E5BD-430B-B940-19E4D9EFAE2D}"/>
               </a:ext>
             </a:extLst>
           </p:cNvPr>
@@ -10065,7 +10065,7 @@
           <p:cNvPr id="12" name="">
             <a:extLst xmlns:a="http://schemas.openxmlformats.org/drawingml/2006/main">
               <a:ext uri="{FF2B5EF4-FFF2-40B4-BE49-F238E27FC236}">
-                <a16:creationId xmlns:a16="http://schemas.microsoft.com/office/drawing/2014/main" id="{20C9F1B6-5FFD-4C9D-83A3-509756208283}"/>
+                <a16:creationId xmlns:a16="http://schemas.microsoft.com/office/drawing/2014/main" id="{432863A8-E251-4068-A8D4-B4717227038E}"/>
               </a:ext>
             </a:extLst>
           </p:cNvPr>
@@ -10222,7 +10222,7 @@
           <p:cNvPr id="13" name="">
             <a:extLst xmlns:a="http://schemas.openxmlformats.org/drawingml/2006/main">
               <a:ext uri="{FF2B5EF4-FFF2-40B4-BE49-F238E27FC236}">
-                <a16:creationId xmlns:a16="http://schemas.microsoft.com/office/drawing/2014/main" id="{CF90C0CB-5994-4C0C-A30B-0D90C2F37110}"/>
+                <a16:creationId xmlns:a16="http://schemas.microsoft.com/office/drawing/2014/main" id="{80D94ACF-A948-4B40-BF15-795453EACEBA}"/>
               </a:ext>
             </a:extLst>
           </p:cNvPr>
@@ -10379,7 +10379,7 @@
           <p:cNvPr id="14" name="">
             <a:extLst xmlns:a="http://schemas.openxmlformats.org/drawingml/2006/main">
               <a:ext uri="{FF2B5EF4-FFF2-40B4-BE49-F238E27FC236}">
-                <a16:creationId xmlns:a16="http://schemas.microsoft.com/office/drawing/2014/main" id="{2DE99573-347B-4AC9-A2D9-9EED0E8BA163}"/>
+                <a16:creationId xmlns:a16="http://schemas.microsoft.com/office/drawing/2014/main" id="{5D10F5F1-D0CB-46AC-9FFD-A3B52B2B54D5}"/>
               </a:ext>
             </a:extLst>
           </p:cNvPr>
@@ -10536,7 +10536,7 @@
           <p:cNvPr id="15" name="">
             <a:extLst xmlns:a="http://schemas.openxmlformats.org/drawingml/2006/main">
               <a:ext uri="{FF2B5EF4-FFF2-40B4-BE49-F238E27FC236}">
-                <a16:creationId xmlns:a16="http://schemas.microsoft.com/office/drawing/2014/main" id="{215E08A7-1E74-4D01-9C7E-3EF3A7FD4710}"/>
+                <a16:creationId xmlns:a16="http://schemas.microsoft.com/office/drawing/2014/main" id="{1AA7CCF2-735F-4BE2-B48F-0EDF710BF476}"/>
               </a:ext>
             </a:extLst>
           </p:cNvPr>
@@ -10567,7 +10567,7 @@
           <p:cNvPr id="16" name="">
             <a:extLst xmlns:a="http://schemas.openxmlformats.org/drawingml/2006/main">
               <a:ext uri="{FF2B5EF4-FFF2-40B4-BE49-F238E27FC236}">
-                <a16:creationId xmlns:a16="http://schemas.microsoft.com/office/drawing/2014/main" id="{AC61FD6A-6231-41DB-B910-BB5F6E558313}"/>
+                <a16:creationId xmlns:a16="http://schemas.microsoft.com/office/drawing/2014/main" id="{1897E889-81A7-4CFE-9A66-6F1FB1A0AB69}"/>
               </a:ext>
             </a:extLst>
           </p:cNvPr>
@@ -10724,7 +10724,7 @@
           <p:cNvPr id="17" name="">
             <a:extLst xmlns:a="http://schemas.openxmlformats.org/drawingml/2006/main">
               <a:ext uri="{FF2B5EF4-FFF2-40B4-BE49-F238E27FC236}">
-                <a16:creationId xmlns:a16="http://schemas.microsoft.com/office/drawing/2014/main" id="{F458B9C2-BC06-46D4-91D3-DBC69622291F}"/>
+                <a16:creationId xmlns:a16="http://schemas.microsoft.com/office/drawing/2014/main" id="{379B058D-7B69-465A-9660-E5DA5C16F3EA}"/>
               </a:ext>
             </a:extLst>
           </p:cNvPr>
@@ -10881,7 +10881,7 @@
           <p:cNvPr id="18" name="">
             <a:extLst xmlns:a="http://schemas.openxmlformats.org/drawingml/2006/main">
               <a:ext uri="{FF2B5EF4-FFF2-40B4-BE49-F238E27FC236}">
-                <a16:creationId xmlns:a16="http://schemas.microsoft.com/office/drawing/2014/main" id="{E8C78DAF-F7B1-4DB6-9FDA-8DFEEE9B9897}"/>
+                <a16:creationId xmlns:a16="http://schemas.microsoft.com/office/drawing/2014/main" id="{5FFA2269-0385-413C-9225-E7EDBB2021C2}"/>
               </a:ext>
             </a:extLst>
           </p:cNvPr>
@@ -11038,7 +11038,7 @@
           <p:cNvPr id="19" name="">
             <a:extLst xmlns:a="http://schemas.openxmlformats.org/drawingml/2006/main">
               <a:ext uri="{FF2B5EF4-FFF2-40B4-BE49-F238E27FC236}">
-                <a16:creationId xmlns:a16="http://schemas.microsoft.com/office/drawing/2014/main" id="{EFF92EDE-64B1-4D8A-83F8-7E90A7836FBB}"/>
+                <a16:creationId xmlns:a16="http://schemas.microsoft.com/office/drawing/2014/main" id="{D5B25544-8F9A-433F-9C4C-447763912780}"/>
               </a:ext>
             </a:extLst>
           </p:cNvPr>
@@ -11193,7 +11193,7 @@
     </p:spTree>
     <p:extLst>
       <p:ext uri="{BB962C8B-B14F-4D97-AF65-F5344CB8AC3E}">
-        <p14:creationId xmlns:p14="http://schemas.microsoft.com/office/powerpoint/2010/main" val="1641346742"/>
+        <p14:creationId xmlns:p14="http://schemas.microsoft.com/office/powerpoint/2010/main" val="1659389663"/>
       </p:ext>
     </p:extLst>
   </p:cSld>
@@ -11224,7 +11224,7 @@
           <p:cNvPr id="19" name="">
             <a:extLst xmlns:a="http://schemas.openxmlformats.org/drawingml/2006/main">
               <a:ext uri="{FF2B5EF4-FFF2-40B4-BE49-F238E27FC236}">
-                <a16:creationId xmlns:a16="http://schemas.microsoft.com/office/drawing/2014/main" id="{5BA32DAF-0B45-45B5-A495-457C1A9A1183}"/>
+                <a16:creationId xmlns:a16="http://schemas.microsoft.com/office/drawing/2014/main" id="{754EF060-D746-4E17-948E-D28412290C69}"/>
               </a:ext>
             </a:extLst>
           </p:cNvPr>
@@ -11381,7 +11381,7 @@
           <p:cNvPr id="2" name="">
             <a:extLst xmlns:a="http://schemas.openxmlformats.org/drawingml/2006/main">
               <a:ext uri="{FF2B5EF4-FFF2-40B4-BE49-F238E27FC236}">
-                <a16:creationId xmlns:a16="http://schemas.microsoft.com/office/drawing/2014/main" id="{D144B03A-745A-4878-955D-CDA7FA2172DC}"/>
+                <a16:creationId xmlns:a16="http://schemas.microsoft.com/office/drawing/2014/main" id="{C72A29BE-C1F3-4DB6-A346-FD0ACCB8E260}"/>
               </a:ext>
             </a:extLst>
           </p:cNvPr>
@@ -11412,7 +11412,7 @@
           <p:cNvPr id="3" name="">
             <a:extLst xmlns:a="http://schemas.openxmlformats.org/drawingml/2006/main">
               <a:ext uri="{FF2B5EF4-FFF2-40B4-BE49-F238E27FC236}">
-                <a16:creationId xmlns:a16="http://schemas.microsoft.com/office/drawing/2014/main" id="{C04265B6-0428-4E41-B654-C49551808401}"/>
+                <a16:creationId xmlns:a16="http://schemas.microsoft.com/office/drawing/2014/main" id="{D9699B17-CC1F-4A69-8458-F56CBBBB49F9}"/>
               </a:ext>
             </a:extLst>
           </p:cNvPr>
@@ -11569,7 +11569,7 @@
           <p:cNvPr id="4" name="">
             <a:extLst xmlns:a="http://schemas.openxmlformats.org/drawingml/2006/main">
               <a:ext uri="{FF2B5EF4-FFF2-40B4-BE49-F238E27FC236}">
-                <a16:creationId xmlns:a16="http://schemas.microsoft.com/office/drawing/2014/main" id="{CEACC56D-A660-45EB-A41F-8C1593F72110}"/>
+                <a16:creationId xmlns:a16="http://schemas.microsoft.com/office/drawing/2014/main" id="{F23EAA62-F892-405F-85D1-000B15228119}"/>
               </a:ext>
             </a:extLst>
           </p:cNvPr>
@@ -11600,7 +11600,7 @@
           <p:cNvPr id="5" name="">
             <a:extLst xmlns:a="http://schemas.openxmlformats.org/drawingml/2006/main">
               <a:ext uri="{FF2B5EF4-FFF2-40B4-BE49-F238E27FC236}">
-                <a16:creationId xmlns:a16="http://schemas.microsoft.com/office/drawing/2014/main" id="{B2E7A285-E5BD-4F61-8189-44F625073065}"/>
+                <a16:creationId xmlns:a16="http://schemas.microsoft.com/office/drawing/2014/main" id="{DE0472A1-36EA-4694-BDCE-B36D167F894C}"/>
               </a:ext>
             </a:extLst>
           </p:cNvPr>
@@ -11757,7 +11757,7 @@
           <p:cNvPr id="6" name="">
             <a:extLst xmlns:a="http://schemas.openxmlformats.org/drawingml/2006/main">
               <a:ext uri="{FF2B5EF4-FFF2-40B4-BE49-F238E27FC236}">
-                <a16:creationId xmlns:a16="http://schemas.microsoft.com/office/drawing/2014/main" id="{B935CE71-118F-41DE-9468-2BE4A8AE9A05}"/>
+                <a16:creationId xmlns:a16="http://schemas.microsoft.com/office/drawing/2014/main" id="{22D8AE22-405A-4F2C-AB36-A07A19BA264D}"/>
               </a:ext>
             </a:extLst>
           </p:cNvPr>
@@ -11788,7 +11788,7 @@
           <p:cNvPr id="7" name="">
             <a:extLst xmlns:a="http://schemas.openxmlformats.org/drawingml/2006/main">
               <a:ext uri="{FF2B5EF4-FFF2-40B4-BE49-F238E27FC236}">
-                <a16:creationId xmlns:a16="http://schemas.microsoft.com/office/drawing/2014/main" id="{10B04718-C443-4269-BEF7-13B4F71C4FAA}"/>
+                <a16:creationId xmlns:a16="http://schemas.microsoft.com/office/drawing/2014/main" id="{B7723C03-3AA0-4D2E-A3CC-8BB1240993E0}"/>
               </a:ext>
             </a:extLst>
           </p:cNvPr>
@@ -11968,7 +11968,7 @@
           <p:cNvPr id="8" name="">
             <a:extLst xmlns:a="http://schemas.openxmlformats.org/drawingml/2006/main">
               <a:ext uri="{FF2B5EF4-FFF2-40B4-BE49-F238E27FC236}">
-                <a16:creationId xmlns:a16="http://schemas.microsoft.com/office/drawing/2014/main" id="{32A0B2C4-5EB0-44CD-AF67-06F22C394463}"/>
+                <a16:creationId xmlns:a16="http://schemas.microsoft.com/office/drawing/2014/main" id="{D8B50F4B-7AAA-4F97-B208-B8AFF82650AF}"/>
               </a:ext>
             </a:extLst>
           </p:cNvPr>
@@ -12125,7 +12125,7 @@
           <p:cNvPr id="9" name="">
             <a:extLst xmlns:a="http://schemas.openxmlformats.org/drawingml/2006/main">
               <a:ext uri="{FF2B5EF4-FFF2-40B4-BE49-F238E27FC236}">
-                <a16:creationId xmlns:a16="http://schemas.microsoft.com/office/drawing/2014/main" id="{7B5CC611-625F-4FD6-9F34-9B2616035D62}"/>
+                <a16:creationId xmlns:a16="http://schemas.microsoft.com/office/drawing/2014/main" id="{94F83EC6-E0B7-4C84-8E8F-3C1BE5D9F22A}"/>
               </a:ext>
             </a:extLst>
           </p:cNvPr>
@@ -12156,7 +12156,7 @@
           <p:cNvPr id="10" name="">
             <a:extLst xmlns:a="http://schemas.openxmlformats.org/drawingml/2006/main">
               <a:ext uri="{FF2B5EF4-FFF2-40B4-BE49-F238E27FC236}">
-                <a16:creationId xmlns:a16="http://schemas.microsoft.com/office/drawing/2014/main" id="{4B6CDA47-7DFE-497D-AD35-16CAAF409036}"/>
+                <a16:creationId xmlns:a16="http://schemas.microsoft.com/office/drawing/2014/main" id="{8FF76CE3-55D2-4BF1-B905-512039104A10}"/>
               </a:ext>
             </a:extLst>
           </p:cNvPr>
@@ -12336,7 +12336,7 @@
           <p:cNvPr id="11" name="">
             <a:extLst xmlns:a="http://schemas.openxmlformats.org/drawingml/2006/main">
               <a:ext uri="{FF2B5EF4-FFF2-40B4-BE49-F238E27FC236}">
-                <a16:creationId xmlns:a16="http://schemas.microsoft.com/office/drawing/2014/main" id="{0BA4F50B-9729-4AA5-A2FF-A6247A95091C}"/>
+                <a16:creationId xmlns:a16="http://schemas.microsoft.com/office/drawing/2014/main" id="{2109DD22-85D6-49D6-A4D0-6637C8FC7EC4}"/>
               </a:ext>
             </a:extLst>
           </p:cNvPr>
@@ -12493,7 +12493,7 @@
           <p:cNvPr id="12" name="">
             <a:extLst xmlns:a="http://schemas.openxmlformats.org/drawingml/2006/main">
               <a:ext uri="{FF2B5EF4-FFF2-40B4-BE49-F238E27FC236}">
-                <a16:creationId xmlns:a16="http://schemas.microsoft.com/office/drawing/2014/main" id="{037EA34F-702E-43A3-9E5F-34587504B872}"/>
+                <a16:creationId xmlns:a16="http://schemas.microsoft.com/office/drawing/2014/main" id="{16AC54E6-A600-40B7-9827-BD170F06F4B6}"/>
               </a:ext>
             </a:extLst>
           </p:cNvPr>
@@ -12524,7 +12524,7 @@
           <p:cNvPr id="13" name="">
             <a:extLst xmlns:a="http://schemas.openxmlformats.org/drawingml/2006/main">
               <a:ext uri="{FF2B5EF4-FFF2-40B4-BE49-F238E27FC236}">
-                <a16:creationId xmlns:a16="http://schemas.microsoft.com/office/drawing/2014/main" id="{3B605F9D-DC83-4B1B-A967-D9D2665CCA73}"/>
+                <a16:creationId xmlns:a16="http://schemas.microsoft.com/office/drawing/2014/main" id="{6821C4B1-A367-42B6-96E0-19156F8E3C1B}"/>
               </a:ext>
             </a:extLst>
           </p:cNvPr>
@@ -12704,7 +12704,7 @@
           <p:cNvPr id="14" name="">
             <a:extLst xmlns:a="http://schemas.openxmlformats.org/drawingml/2006/main">
               <a:ext uri="{FF2B5EF4-FFF2-40B4-BE49-F238E27FC236}">
-                <a16:creationId xmlns:a16="http://schemas.microsoft.com/office/drawing/2014/main" id="{DC7D3ECE-D3B3-4F81-81EC-A2E68AA70F25}"/>
+                <a16:creationId xmlns:a16="http://schemas.microsoft.com/office/drawing/2014/main" id="{36FD6AEA-AFE1-44AD-8C23-80A9CD88714C}"/>
               </a:ext>
             </a:extLst>
           </p:cNvPr>
@@ -12861,7 +12861,7 @@
           <p:cNvPr id="15" name="">
             <a:extLst xmlns:a="http://schemas.openxmlformats.org/drawingml/2006/main">
               <a:ext uri="{FF2B5EF4-FFF2-40B4-BE49-F238E27FC236}">
-                <a16:creationId xmlns:a16="http://schemas.microsoft.com/office/drawing/2014/main" id="{09722D35-B0B0-4F49-AF40-D6B34009D1ED}"/>
+                <a16:creationId xmlns:a16="http://schemas.microsoft.com/office/drawing/2014/main" id="{27327773-3398-435C-82A9-8B0FCBB06EE5}"/>
               </a:ext>
             </a:extLst>
           </p:cNvPr>
@@ -12892,7 +12892,7 @@
           <p:cNvPr id="16" name="">
             <a:extLst xmlns:a="http://schemas.openxmlformats.org/drawingml/2006/main">
               <a:ext uri="{FF2B5EF4-FFF2-40B4-BE49-F238E27FC236}">
-                <a16:creationId xmlns:a16="http://schemas.microsoft.com/office/drawing/2014/main" id="{F2CF7C75-4034-4C0D-BCA3-DE656CF88CFC}"/>
+                <a16:creationId xmlns:a16="http://schemas.microsoft.com/office/drawing/2014/main" id="{8B16A2ED-3CAE-4B7A-98C2-EBACEC30F949}"/>
               </a:ext>
             </a:extLst>
           </p:cNvPr>
@@ -13072,7 +13072,7 @@
           <p:cNvPr id="17" name="">
             <a:extLst xmlns:a="http://schemas.openxmlformats.org/drawingml/2006/main">
               <a:ext uri="{FF2B5EF4-FFF2-40B4-BE49-F238E27FC236}">
-                <a16:creationId xmlns:a16="http://schemas.microsoft.com/office/drawing/2014/main" id="{F21445CC-5C6B-4E19-BEB0-3F59CE0DC89A}"/>
+                <a16:creationId xmlns:a16="http://schemas.microsoft.com/office/drawing/2014/main" id="{AC65861A-DE6F-4E4E-8CEF-E3F8305E6F7C}"/>
               </a:ext>
             </a:extLst>
           </p:cNvPr>
@@ -13432,7 +13432,7 @@
           <p:cNvPr id="18" name="">
             <a:extLst xmlns:a="http://schemas.openxmlformats.org/drawingml/2006/main">
               <a:ext uri="{FF2B5EF4-FFF2-40B4-BE49-F238E27FC236}">
-                <a16:creationId xmlns:a16="http://schemas.microsoft.com/office/drawing/2014/main" id="{8EC29BF8-9B1A-465B-B788-44B595128050}"/>
+                <a16:creationId xmlns:a16="http://schemas.microsoft.com/office/drawing/2014/main" id="{55BF77B2-C2A8-497E-B5FD-B965B1C91A58}"/>
               </a:ext>
             </a:extLst>
           </p:cNvPr>
@@ -13587,7 +13587,7 @@
     </p:spTree>
     <p:extLst>
       <p:ext uri="{BB962C8B-B14F-4D97-AF65-F5344CB8AC3E}">
-        <p14:creationId xmlns:p14="http://schemas.microsoft.com/office/powerpoint/2010/main" val="1575368137"/>
+        <p14:creationId xmlns:p14="http://schemas.microsoft.com/office/powerpoint/2010/main" val="1676009891"/>
       </p:ext>
     </p:extLst>
   </p:cSld>
@@ -13618,7 +13618,7 @@
           <p:cNvPr id="26" name="">
             <a:extLst xmlns:a="http://schemas.openxmlformats.org/drawingml/2006/main">
               <a:ext uri="{FF2B5EF4-FFF2-40B4-BE49-F238E27FC236}">
-                <a16:creationId xmlns:a16="http://schemas.microsoft.com/office/drawing/2014/main" id="{34D8DE16-8C4C-4B85-9773-25C4D64D4C92}"/>
+                <a16:creationId xmlns:a16="http://schemas.microsoft.com/office/drawing/2014/main" id="{FF1399B4-7050-426C-A7F7-BD9634550186}"/>
               </a:ext>
             </a:extLst>
           </p:cNvPr>
@@ -13775,7 +13775,7 @@
           <p:cNvPr id="2" name="">
             <a:extLst xmlns:a="http://schemas.openxmlformats.org/drawingml/2006/main">
               <a:ext uri="{FF2B5EF4-FFF2-40B4-BE49-F238E27FC236}">
-                <a16:creationId xmlns:a16="http://schemas.microsoft.com/office/drawing/2014/main" id="{09ADC8C3-7312-45F3-9CAE-DCA34307FABC}"/>
+                <a16:creationId xmlns:a16="http://schemas.microsoft.com/office/drawing/2014/main" id="{DCF4ABF7-468D-47DF-9F98-C5E2CEC487BB}"/>
               </a:ext>
             </a:extLst>
           </p:cNvPr>
@@ -13806,7 +13806,7 @@
           <p:cNvPr id="3" name="">
             <a:extLst xmlns:a="http://schemas.openxmlformats.org/drawingml/2006/main">
               <a:ext uri="{FF2B5EF4-FFF2-40B4-BE49-F238E27FC236}">
-                <a16:creationId xmlns:a16="http://schemas.microsoft.com/office/drawing/2014/main" id="{6FD8C5BE-BD8A-4D69-9CDF-D0A39FB79BF2}"/>
+                <a16:creationId xmlns:a16="http://schemas.microsoft.com/office/drawing/2014/main" id="{E53C35A5-ECDB-4897-B823-4B46DB020E07}"/>
               </a:ext>
             </a:extLst>
           </p:cNvPr>
@@ -13963,7 +13963,7 @@
           <p:cNvPr id="4" name="">
             <a:extLst xmlns:a="http://schemas.openxmlformats.org/drawingml/2006/main">
               <a:ext uri="{FF2B5EF4-FFF2-40B4-BE49-F238E27FC236}">
-                <a16:creationId xmlns:a16="http://schemas.microsoft.com/office/drawing/2014/main" id="{8E368BD7-5A73-4714-A072-8D225A216827}"/>
+                <a16:creationId xmlns:a16="http://schemas.microsoft.com/office/drawing/2014/main" id="{1161FB71-1AFB-4CFB-8220-809E5705DCB1}"/>
               </a:ext>
             </a:extLst>
           </p:cNvPr>
@@ -13996,7 +13996,7 @@
           <p:cNvPr id="5" name="">
             <a:extLst xmlns:a="http://schemas.openxmlformats.org/drawingml/2006/main">
               <a:ext uri="{FF2B5EF4-FFF2-40B4-BE49-F238E27FC236}">
-                <a16:creationId xmlns:a16="http://schemas.microsoft.com/office/drawing/2014/main" id="{57E90828-0E59-47DD-AABC-161B18B75C31}"/>
+                <a16:creationId xmlns:a16="http://schemas.microsoft.com/office/drawing/2014/main" id="{1B923395-3D8B-4E83-8D12-573EACAA261F}"/>
               </a:ext>
             </a:extLst>
           </p:cNvPr>
@@ -14153,7 +14153,7 @@
           <p:cNvPr id="6" name="">
             <a:extLst xmlns:a="http://schemas.openxmlformats.org/drawingml/2006/main">
               <a:ext uri="{FF2B5EF4-FFF2-40B4-BE49-F238E27FC236}">
-                <a16:creationId xmlns:a16="http://schemas.microsoft.com/office/drawing/2014/main" id="{13CA7CD4-1DF1-4B44-963E-CCA0D153376B}"/>
+                <a16:creationId xmlns:a16="http://schemas.microsoft.com/office/drawing/2014/main" id="{73598B81-F51E-4452-847A-47BF7E8ADFA6}"/>
               </a:ext>
             </a:extLst>
           </p:cNvPr>
@@ -14333,7 +14333,7 @@
           <p:cNvPr id="7" name="">
             <a:extLst xmlns:a="http://schemas.openxmlformats.org/drawingml/2006/main">
               <a:ext uri="{FF2B5EF4-FFF2-40B4-BE49-F238E27FC236}">
-                <a16:creationId xmlns:a16="http://schemas.microsoft.com/office/drawing/2014/main" id="{6381AA77-2D4A-440E-B934-55B612814D49}"/>
+                <a16:creationId xmlns:a16="http://schemas.microsoft.com/office/drawing/2014/main" id="{53E97DF3-4B82-4E08-91DF-435735E2E3C6}"/>
               </a:ext>
             </a:extLst>
           </p:cNvPr>
@@ -14364,7 +14364,7 @@
           <p:cNvPr id="8" name="">
             <a:extLst xmlns:a="http://schemas.openxmlformats.org/drawingml/2006/main">
               <a:ext uri="{FF2B5EF4-FFF2-40B4-BE49-F238E27FC236}">
-                <a16:creationId xmlns:a16="http://schemas.microsoft.com/office/drawing/2014/main" id="{32118A52-DE58-4EC5-9D43-B25F444AB2D7}"/>
+                <a16:creationId xmlns:a16="http://schemas.microsoft.com/office/drawing/2014/main" id="{ADBA765C-0974-4FE6-8872-D2D214B9114D}"/>
               </a:ext>
             </a:extLst>
           </p:cNvPr>
@@ -14397,7 +14397,7 @@
           <p:cNvPr id="9" name="">
             <a:extLst xmlns:a="http://schemas.openxmlformats.org/drawingml/2006/main">
               <a:ext uri="{FF2B5EF4-FFF2-40B4-BE49-F238E27FC236}">
-                <a16:creationId xmlns:a16="http://schemas.microsoft.com/office/drawing/2014/main" id="{1290BC6C-A22C-4456-9EFC-AE776ABAB5E3}"/>
+                <a16:creationId xmlns:a16="http://schemas.microsoft.com/office/drawing/2014/main" id="{04A42597-254D-4C6C-8131-E60B5F3E78B4}"/>
               </a:ext>
             </a:extLst>
           </p:cNvPr>
@@ -14554,7 +14554,7 @@
           <p:cNvPr id="10" name="">
             <a:extLst xmlns:a="http://schemas.openxmlformats.org/drawingml/2006/main">
               <a:ext uri="{FF2B5EF4-FFF2-40B4-BE49-F238E27FC236}">
-                <a16:creationId xmlns:a16="http://schemas.microsoft.com/office/drawing/2014/main" id="{6CDBCF89-2B0E-48DE-8788-BE7DECA44312}"/>
+                <a16:creationId xmlns:a16="http://schemas.microsoft.com/office/drawing/2014/main" id="{8E03143B-268E-4A94-8F9E-E635BA9A0A20}"/>
               </a:ext>
             </a:extLst>
           </p:cNvPr>
@@ -14734,7 +14734,7 @@
           <p:cNvPr id="11" name="">
             <a:extLst xmlns:a="http://schemas.openxmlformats.org/drawingml/2006/main">
               <a:ext uri="{FF2B5EF4-FFF2-40B4-BE49-F238E27FC236}">
-                <a16:creationId xmlns:a16="http://schemas.microsoft.com/office/drawing/2014/main" id="{8D040A47-CCCD-4BC9-BD30-1395ECD9A558}"/>
+                <a16:creationId xmlns:a16="http://schemas.microsoft.com/office/drawing/2014/main" id="{BF2E5407-C03D-4697-9614-C6207E67BA32}"/>
               </a:ext>
             </a:extLst>
           </p:cNvPr>
@@ -14765,7 +14765,7 @@
           <p:cNvPr id="12" name="">
             <a:extLst xmlns:a="http://schemas.openxmlformats.org/drawingml/2006/main">
               <a:ext uri="{FF2B5EF4-FFF2-40B4-BE49-F238E27FC236}">
-                <a16:creationId xmlns:a16="http://schemas.microsoft.com/office/drawing/2014/main" id="{3F7A6D1B-67CC-4EDE-9AEF-476A3615D952}"/>
+                <a16:creationId xmlns:a16="http://schemas.microsoft.com/office/drawing/2014/main" id="{C23F2CBA-6193-44A0-929D-A5DA1129698F}"/>
               </a:ext>
             </a:extLst>
           </p:cNvPr>
@@ -14798,7 +14798,7 @@
           <p:cNvPr id="13" name="">
             <a:extLst xmlns:a="http://schemas.openxmlformats.org/drawingml/2006/main">
               <a:ext uri="{FF2B5EF4-FFF2-40B4-BE49-F238E27FC236}">
-                <a16:creationId xmlns:a16="http://schemas.microsoft.com/office/drawing/2014/main" id="{2A74580C-AEAA-4885-B2A3-E2D315D18AFB}"/>
+                <a16:creationId xmlns:a16="http://schemas.microsoft.com/office/drawing/2014/main" id="{13C52A5C-C2C0-4200-9E98-FEA69F298FE3}"/>
               </a:ext>
             </a:extLst>
           </p:cNvPr>
@@ -14955,7 +14955,7 @@
           <p:cNvPr id="14" name="">
             <a:extLst xmlns:a="http://schemas.openxmlformats.org/drawingml/2006/main">
               <a:ext uri="{FF2B5EF4-FFF2-40B4-BE49-F238E27FC236}">
-                <a16:creationId xmlns:a16="http://schemas.microsoft.com/office/drawing/2014/main" id="{981D3365-8926-4FFD-8455-E0AEBCF27E20}"/>
+                <a16:creationId xmlns:a16="http://schemas.microsoft.com/office/drawing/2014/main" id="{52F8D332-673E-4695-B35A-4F71C003D74F}"/>
               </a:ext>
             </a:extLst>
           </p:cNvPr>
@@ -15135,7 +15135,7 @@
           <p:cNvPr id="15" name="">
             <a:extLst xmlns:a="http://schemas.openxmlformats.org/drawingml/2006/main">
               <a:ext uri="{FF2B5EF4-FFF2-40B4-BE49-F238E27FC236}">
-                <a16:creationId xmlns:a16="http://schemas.microsoft.com/office/drawing/2014/main" id="{BEB62677-8AE8-4BCE-B922-839D2D39951A}"/>
+                <a16:creationId xmlns:a16="http://schemas.microsoft.com/office/drawing/2014/main" id="{EC9C3CBA-841D-4AE0-93A2-E88CB0F11E53}"/>
               </a:ext>
             </a:extLst>
           </p:cNvPr>
@@ -15166,7 +15166,7 @@
           <p:cNvPr id="16" name="">
             <a:extLst xmlns:a="http://schemas.openxmlformats.org/drawingml/2006/main">
               <a:ext uri="{FF2B5EF4-FFF2-40B4-BE49-F238E27FC236}">
-                <a16:creationId xmlns:a16="http://schemas.microsoft.com/office/drawing/2014/main" id="{2BF91937-FC12-4C59-9CEB-27A034B3C759}"/>
+                <a16:creationId xmlns:a16="http://schemas.microsoft.com/office/drawing/2014/main" id="{48D85234-63F2-4AD2-B535-E4AA07698157}"/>
               </a:ext>
             </a:extLst>
           </p:cNvPr>
@@ -15199,7 +15199,7 @@
           <p:cNvPr id="17" name="">
             <a:extLst xmlns:a="http://schemas.openxmlformats.org/drawingml/2006/main">
               <a:ext uri="{FF2B5EF4-FFF2-40B4-BE49-F238E27FC236}">
-                <a16:creationId xmlns:a16="http://schemas.microsoft.com/office/drawing/2014/main" id="{DFC355FE-5946-4217-A975-71C7A8439C03}"/>
+                <a16:creationId xmlns:a16="http://schemas.microsoft.com/office/drawing/2014/main" id="{1919F2B2-312C-41BD-94B2-82F651055FFE}"/>
               </a:ext>
             </a:extLst>
           </p:cNvPr>
@@ -15356,7 +15356,7 @@
           <p:cNvPr id="18" name="">
             <a:extLst xmlns:a="http://schemas.openxmlformats.org/drawingml/2006/main">
               <a:ext uri="{FF2B5EF4-FFF2-40B4-BE49-F238E27FC236}">
-                <a16:creationId xmlns:a16="http://schemas.microsoft.com/office/drawing/2014/main" id="{530E08B9-A0BC-4857-89EB-1C2C60FE7034}"/>
+                <a16:creationId xmlns:a16="http://schemas.microsoft.com/office/drawing/2014/main" id="{0A5BE7DB-E752-48E3-8FFE-BDD08804905B}"/>
               </a:ext>
             </a:extLst>
           </p:cNvPr>
@@ -15536,7 +15536,7 @@
           <p:cNvPr id="19" name="">
             <a:extLst xmlns:a="http://schemas.openxmlformats.org/drawingml/2006/main">
               <a:ext uri="{FF2B5EF4-FFF2-40B4-BE49-F238E27FC236}">
-                <a16:creationId xmlns:a16="http://schemas.microsoft.com/office/drawing/2014/main" id="{014C85DC-AF1D-4CDD-A332-696541C0C2F8}"/>
+                <a16:creationId xmlns:a16="http://schemas.microsoft.com/office/drawing/2014/main" id="{D617E99D-0512-4B4E-ABF2-95D5B87525A0}"/>
               </a:ext>
             </a:extLst>
           </p:cNvPr>
@@ -15693,7 +15693,7 @@
           <p:cNvPr id="20" name="">
             <a:extLst xmlns:a="http://schemas.openxmlformats.org/drawingml/2006/main">
               <a:ext uri="{FF2B5EF4-FFF2-40B4-BE49-F238E27FC236}">
-                <a16:creationId xmlns:a16="http://schemas.microsoft.com/office/drawing/2014/main" id="{CFEFE6AB-C2A0-426C-87C9-89E85530AE2C}"/>
+                <a16:creationId xmlns:a16="http://schemas.microsoft.com/office/drawing/2014/main" id="{E2092F32-1CE3-4B68-8B7E-83D5D30CF303}"/>
               </a:ext>
             </a:extLst>
           </p:cNvPr>
@@ -15850,7 +15850,7 @@
           <p:cNvPr id="21" name="">
             <a:extLst xmlns:a="http://schemas.openxmlformats.org/drawingml/2006/main">
               <a:ext uri="{FF2B5EF4-FFF2-40B4-BE49-F238E27FC236}">
-                <a16:creationId xmlns:a16="http://schemas.microsoft.com/office/drawing/2014/main" id="{3770C5BB-FBF6-4329-B478-7CED89A77E5A}"/>
+                <a16:creationId xmlns:a16="http://schemas.microsoft.com/office/drawing/2014/main" id="{F69352AB-61FB-453C-9965-9E0CD18AAB9C}"/>
               </a:ext>
             </a:extLst>
           </p:cNvPr>
@@ -16007,7 +16007,7 @@
           <p:cNvPr id="22" name="">
             <a:extLst xmlns:a="http://schemas.openxmlformats.org/drawingml/2006/main">
               <a:ext uri="{FF2B5EF4-FFF2-40B4-BE49-F238E27FC236}">
-                <a16:creationId xmlns:a16="http://schemas.microsoft.com/office/drawing/2014/main" id="{948F36FE-9D63-4477-88E1-6CFD450381C8}"/>
+                <a16:creationId xmlns:a16="http://schemas.microsoft.com/office/drawing/2014/main" id="{C7B202AB-8B6B-4540-8DD4-CF980F72B345}"/>
               </a:ext>
             </a:extLst>
           </p:cNvPr>
@@ -16164,7 +16164,7 @@
           <p:cNvPr id="23" name="">
             <a:extLst xmlns:a="http://schemas.openxmlformats.org/drawingml/2006/main">
               <a:ext uri="{FF2B5EF4-FFF2-40B4-BE49-F238E27FC236}">
-                <a16:creationId xmlns:a16="http://schemas.microsoft.com/office/drawing/2014/main" id="{06476118-0A90-445F-8F77-556006290AC6}"/>
+                <a16:creationId xmlns:a16="http://schemas.microsoft.com/office/drawing/2014/main" id="{16462915-9C17-49BC-A1D3-D37B5540CC9E}"/>
               </a:ext>
             </a:extLst>
           </p:cNvPr>
@@ -16321,7 +16321,7 @@
           <p:cNvPr id="24" name="">
             <a:extLst xmlns:a="http://schemas.openxmlformats.org/drawingml/2006/main">
               <a:ext uri="{FF2B5EF4-FFF2-40B4-BE49-F238E27FC236}">
-                <a16:creationId xmlns:a16="http://schemas.microsoft.com/office/drawing/2014/main" id="{9623F0FC-6E01-45FC-9006-79E5EF1E86B9}"/>
+                <a16:creationId xmlns:a16="http://schemas.microsoft.com/office/drawing/2014/main" id="{B947418D-4085-4EA2-8174-830FB450687C}"/>
               </a:ext>
             </a:extLst>
           </p:cNvPr>
@@ -16478,7 +16478,7 @@
           <p:cNvPr id="25" name="">
             <a:extLst xmlns:a="http://schemas.openxmlformats.org/drawingml/2006/main">
               <a:ext uri="{FF2B5EF4-FFF2-40B4-BE49-F238E27FC236}">
-                <a16:creationId xmlns:a16="http://schemas.microsoft.com/office/drawing/2014/main" id="{0F0AC0E7-F10B-4178-B9C9-EA78B5FD165E}"/>
+                <a16:creationId xmlns:a16="http://schemas.microsoft.com/office/drawing/2014/main" id="{288361E2-F4B4-4CF3-820B-33C402D253D7}"/>
               </a:ext>
             </a:extLst>
           </p:cNvPr>
@@ -16633,7 +16633,7 @@
     </p:spTree>
     <p:extLst>
       <p:ext uri="{BB962C8B-B14F-4D97-AF65-F5344CB8AC3E}">
-        <p14:creationId xmlns:p14="http://schemas.microsoft.com/office/powerpoint/2010/main" val="953366793"/>
+        <p14:creationId xmlns:p14="http://schemas.microsoft.com/office/powerpoint/2010/main" val="1071790973"/>
       </p:ext>
     </p:extLst>
   </p:cSld>
@@ -16664,7 +16664,7 @@
           <p:cNvPr id="10" name="">
             <a:extLst xmlns:a="http://schemas.openxmlformats.org/drawingml/2006/main">
               <a:ext uri="{FF2B5EF4-FFF2-40B4-BE49-F238E27FC236}">
-                <a16:creationId xmlns:a16="http://schemas.microsoft.com/office/drawing/2014/main" id="{4321A20F-A84F-4B0E-A199-3CF441712055}"/>
+                <a16:creationId xmlns:a16="http://schemas.microsoft.com/office/drawing/2014/main" id="{CDBF78C6-AADB-4293-80AC-6B7F7FE4F3A1}"/>
               </a:ext>
             </a:extLst>
           </p:cNvPr>
@@ -16821,7 +16821,7 @@
           <p:cNvPr id="2" name="">
             <a:extLst xmlns:a="http://schemas.openxmlformats.org/drawingml/2006/main">
               <a:ext uri="{FF2B5EF4-FFF2-40B4-BE49-F238E27FC236}">
-                <a16:creationId xmlns:a16="http://schemas.microsoft.com/office/drawing/2014/main" id="{33C097DB-F25E-40E6-B7D9-553BE629FD14}"/>
+                <a16:creationId xmlns:a16="http://schemas.microsoft.com/office/drawing/2014/main" id="{79D56314-892E-4B9A-B071-84F4FAFE89B5}"/>
               </a:ext>
             </a:extLst>
           </p:cNvPr>
@@ -16852,7 +16852,7 @@
           <p:cNvPr id="3" name="">
             <a:extLst xmlns:a="http://schemas.openxmlformats.org/drawingml/2006/main">
               <a:ext uri="{FF2B5EF4-FFF2-40B4-BE49-F238E27FC236}">
-                <a16:creationId xmlns:a16="http://schemas.microsoft.com/office/drawing/2014/main" id="{AE1D7426-10A2-469B-AC07-9301BF0D674D}"/>
+                <a16:creationId xmlns:a16="http://schemas.microsoft.com/office/drawing/2014/main" id="{871D5269-6054-4D22-A740-CA3E24F6D3DA}"/>
               </a:ext>
             </a:extLst>
           </p:cNvPr>
@@ -17009,7 +17009,7 @@
           <p:cNvPr id="4" name="Chart">
             <a:extLst xmlns:a="http://schemas.openxmlformats.org/drawingml/2006/main">
               <a:ext uri="{FF2B5EF4-FFF2-40B4-BE49-F238E27FC236}">
-                <a16:creationId xmlns:a16="http://schemas.microsoft.com/office/drawing/2014/main" id="{494F2B38-7DD9-418E-9E36-77008F8C0986}"/>
+                <a16:creationId xmlns:a16="http://schemas.microsoft.com/office/drawing/2014/main" id="{73D9DC31-FA18-46E2-892E-1E997B9A4645}"/>
               </a:ext>
             </a:extLst>
           </p:cNvPr>
@@ -17022,7 +17022,7 @@
         </p:xfrm>
         <a:graphic xmlns:a="http://schemas.openxmlformats.org/drawingml/2006/main">
           <a:graphicData uri="http://schemas.openxmlformats.org/drawingml/2006/chart">
-            <c:chart xmlns:r="http://schemas.openxmlformats.org/officeDocument/2006/relationships" xmlns:c="http://schemas.openxmlformats.org/drawingml/2006/chart" r:id="Rd2870902efce4ce2"/>
+            <c:chart xmlns:r="http://schemas.openxmlformats.org/officeDocument/2006/relationships" xmlns:c="http://schemas.openxmlformats.org/drawingml/2006/chart" r:id="R0e0eea19c5aa42bd"/>
           </a:graphicData>
         </a:graphic>
       </p:graphicFrame>
@@ -17031,7 +17031,7 @@
           <p:cNvPr id="5" name="">
             <a:extLst xmlns:a="http://schemas.openxmlformats.org/drawingml/2006/main">
               <a:ext uri="{FF2B5EF4-FFF2-40B4-BE49-F238E27FC236}">
-                <a16:creationId xmlns:a16="http://schemas.microsoft.com/office/drawing/2014/main" id="{DF132460-3931-4E49-A888-F811E853CCD3}"/>
+                <a16:creationId xmlns:a16="http://schemas.microsoft.com/office/drawing/2014/main" id="{9A06988B-92E5-4EE3-AB41-79DB130BFBAD}"/>
               </a:ext>
             </a:extLst>
           </p:cNvPr>
@@ -17188,7 +17188,7 @@
           <p:cNvPr id="6" name="">
             <a:extLst xmlns:a="http://schemas.openxmlformats.org/drawingml/2006/main">
               <a:ext uri="{FF2B5EF4-FFF2-40B4-BE49-F238E27FC236}">
-                <a16:creationId xmlns:a16="http://schemas.microsoft.com/office/drawing/2014/main" id="{5D1A102B-E361-4B15-B9AF-D319B53C80CC}"/>
+                <a16:creationId xmlns:a16="http://schemas.microsoft.com/office/drawing/2014/main" id="{B27A4666-3F82-4109-890E-2F9F40DD77D0}"/>
               </a:ext>
             </a:extLst>
           </p:cNvPr>
@@ -17368,7 +17368,7 @@
           <p:cNvPr id="7" name="">
             <a:extLst xmlns:a="http://schemas.openxmlformats.org/drawingml/2006/main">
               <a:ext uri="{FF2B5EF4-FFF2-40B4-BE49-F238E27FC236}">
-                <a16:creationId xmlns:a16="http://schemas.microsoft.com/office/drawing/2014/main" id="{F76CF80E-52C2-4E8D-857E-CFC98239B80A}"/>
+                <a16:creationId xmlns:a16="http://schemas.microsoft.com/office/drawing/2014/main" id="{65FC1404-8138-425E-ADD1-57932C50EF43}"/>
               </a:ext>
             </a:extLst>
           </p:cNvPr>
@@ -17525,7 +17525,7 @@
           <p:cNvPr id="8" name="">
             <a:extLst xmlns:a="http://schemas.openxmlformats.org/drawingml/2006/main">
               <a:ext uri="{FF2B5EF4-FFF2-40B4-BE49-F238E27FC236}">
-                <a16:creationId xmlns:a16="http://schemas.microsoft.com/office/drawing/2014/main" id="{10B07685-6F6D-4F83-B802-F0BB41D81CC4}"/>
+                <a16:creationId xmlns:a16="http://schemas.microsoft.com/office/drawing/2014/main" id="{60D978B9-644C-4EAC-857E-A010EF3E3750}"/>
               </a:ext>
             </a:extLst>
           </p:cNvPr>
@@ -17705,7 +17705,7 @@
           <p:cNvPr id="9" name="">
             <a:extLst xmlns:a="http://schemas.openxmlformats.org/drawingml/2006/main">
               <a:ext uri="{FF2B5EF4-FFF2-40B4-BE49-F238E27FC236}">
-                <a16:creationId xmlns:a16="http://schemas.microsoft.com/office/drawing/2014/main" id="{C6E4ABE5-AAAF-45A4-8366-14C059AF854B}"/>
+                <a16:creationId xmlns:a16="http://schemas.microsoft.com/office/drawing/2014/main" id="{C23B20BE-8C37-4EF7-AEDE-F5105018354E}"/>
               </a:ext>
             </a:extLst>
           </p:cNvPr>
@@ -17860,7 +17860,7 @@
     </p:spTree>
     <p:extLst>
       <p:ext uri="{BB962C8B-B14F-4D97-AF65-F5344CB8AC3E}">
-        <p14:creationId xmlns:p14="http://schemas.microsoft.com/office/powerpoint/2010/main" val="24854728"/>
+        <p14:creationId xmlns:p14="http://schemas.microsoft.com/office/powerpoint/2010/main" val="275538072"/>
       </p:ext>
     </p:extLst>
   </p:cSld>
@@ -17891,7 +17891,7 @@
           <p:cNvPr id="15" name="">
             <a:extLst xmlns:a="http://schemas.openxmlformats.org/drawingml/2006/main">
               <a:ext uri="{FF2B5EF4-FFF2-40B4-BE49-F238E27FC236}">
-                <a16:creationId xmlns:a16="http://schemas.microsoft.com/office/drawing/2014/main" id="{8512C753-FD2B-406B-94F2-2A5427439B0F}"/>
+                <a16:creationId xmlns:a16="http://schemas.microsoft.com/office/drawing/2014/main" id="{86641F2C-DA58-4D56-85ED-EB72CC75DE4E}"/>
               </a:ext>
             </a:extLst>
           </p:cNvPr>
@@ -18048,7 +18048,7 @@
           <p:cNvPr id="2" name="">
             <a:extLst xmlns:a="http://schemas.openxmlformats.org/drawingml/2006/main">
               <a:ext uri="{FF2B5EF4-FFF2-40B4-BE49-F238E27FC236}">
-                <a16:creationId xmlns:a16="http://schemas.microsoft.com/office/drawing/2014/main" id="{029EBE89-01E4-463B-AA10-81E07D5216EC}"/>
+                <a16:creationId xmlns:a16="http://schemas.microsoft.com/office/drawing/2014/main" id="{BEDD52E5-851B-48F9-8A98-AAFE402C4519}"/>
               </a:ext>
             </a:extLst>
           </p:cNvPr>
@@ -18079,7 +18079,7 @@
           <p:cNvPr id="3" name="">
             <a:extLst xmlns:a="http://schemas.openxmlformats.org/drawingml/2006/main">
               <a:ext uri="{FF2B5EF4-FFF2-40B4-BE49-F238E27FC236}">
-                <a16:creationId xmlns:a16="http://schemas.microsoft.com/office/drawing/2014/main" id="{3084CDDA-5B26-4696-A053-237AEE9A0765}"/>
+                <a16:creationId xmlns:a16="http://schemas.microsoft.com/office/drawing/2014/main" id="{C8DB924A-CF1C-44FB-BFB6-5308953F361B}"/>
               </a:ext>
             </a:extLst>
           </p:cNvPr>
@@ -18236,7 +18236,7 @@
           <p:cNvPr id="4" name="">
             <a:extLst xmlns:a="http://schemas.openxmlformats.org/drawingml/2006/main">
               <a:ext uri="{FF2B5EF4-FFF2-40B4-BE49-F238E27FC236}">
-                <a16:creationId xmlns:a16="http://schemas.microsoft.com/office/drawing/2014/main" id="{893DBFF5-6757-4419-87C7-D6CF3F06B359}"/>
+                <a16:creationId xmlns:a16="http://schemas.microsoft.com/office/drawing/2014/main" id="{C8506A4D-4025-4BCB-9355-D7BF7F105835}"/>
               </a:ext>
             </a:extLst>
           </p:cNvPr>
@@ -18393,7 +18393,7 @@
           <p:cNvPr id="5" name="">
             <a:extLst xmlns:a="http://schemas.openxmlformats.org/drawingml/2006/main">
               <a:ext uri="{FF2B5EF4-FFF2-40B4-BE49-F238E27FC236}">
-                <a16:creationId xmlns:a16="http://schemas.microsoft.com/office/drawing/2014/main" id="{D706821E-5782-43DC-B4CA-BD4983E3BD79}"/>
+                <a16:creationId xmlns:a16="http://schemas.microsoft.com/office/drawing/2014/main" id="{90D2AD85-F1E7-49BC-8299-E3B522ADFB5C}"/>
               </a:ext>
             </a:extLst>
           </p:cNvPr>
@@ -18550,7 +18550,7 @@
           <p:cNvPr id="6" name="">
             <a:extLst xmlns:a="http://schemas.openxmlformats.org/drawingml/2006/main">
               <a:ext uri="{FF2B5EF4-FFF2-40B4-BE49-F238E27FC236}">
-                <a16:creationId xmlns:a16="http://schemas.microsoft.com/office/drawing/2014/main" id="{6016196D-910D-4722-ACCB-B4EC28535651}"/>
+                <a16:creationId xmlns:a16="http://schemas.microsoft.com/office/drawing/2014/main" id="{9B86C8AF-87B9-4B37-81B6-12257A964043}"/>
               </a:ext>
             </a:extLst>
           </p:cNvPr>
@@ -18730,7 +18730,7 @@
           <p:cNvPr id="7" name="">
             <a:extLst xmlns:a="http://schemas.openxmlformats.org/drawingml/2006/main">
               <a:ext uri="{FF2B5EF4-FFF2-40B4-BE49-F238E27FC236}">
-                <a16:creationId xmlns:a16="http://schemas.microsoft.com/office/drawing/2014/main" id="{57E2E9FE-6B99-4C75-A245-09BF37C6F574}"/>
+                <a16:creationId xmlns:a16="http://schemas.microsoft.com/office/drawing/2014/main" id="{B0372A49-BEB2-4337-9149-1B9BE789873D}"/>
               </a:ext>
             </a:extLst>
           </p:cNvPr>
@@ -18887,7 +18887,7 @@
           <p:cNvPr id="8" name="">
             <a:extLst xmlns:a="http://schemas.openxmlformats.org/drawingml/2006/main">
               <a:ext uri="{FF2B5EF4-FFF2-40B4-BE49-F238E27FC236}">
-                <a16:creationId xmlns:a16="http://schemas.microsoft.com/office/drawing/2014/main" id="{61FC311E-9D8D-4388-8C76-B55888588D6A}"/>
+                <a16:creationId xmlns:a16="http://schemas.microsoft.com/office/drawing/2014/main" id="{08C26409-D84D-443E-9A7C-31137FC4B2F2}"/>
               </a:ext>
             </a:extLst>
           </p:cNvPr>
@@ -19067,7 +19067,7 @@
           <p:cNvPr id="9" name="">
             <a:extLst xmlns:a="http://schemas.openxmlformats.org/drawingml/2006/main">
               <a:ext uri="{FF2B5EF4-FFF2-40B4-BE49-F238E27FC236}">
-                <a16:creationId xmlns:a16="http://schemas.microsoft.com/office/drawing/2014/main" id="{AE601F65-B6DF-4E30-869C-F1AEF4CCAF62}"/>
+                <a16:creationId xmlns:a16="http://schemas.microsoft.com/office/drawing/2014/main" id="{78A1D7F0-51F7-4864-8094-E648CEFC5BA6}"/>
               </a:ext>
             </a:extLst>
           </p:cNvPr>
@@ -19224,7 +19224,7 @@
           <p:cNvPr id="10" name="">
             <a:extLst xmlns:a="http://schemas.openxmlformats.org/drawingml/2006/main">
               <a:ext uri="{FF2B5EF4-FFF2-40B4-BE49-F238E27FC236}">
-                <a16:creationId xmlns:a16="http://schemas.microsoft.com/office/drawing/2014/main" id="{2194869C-6F99-499A-9E6B-CB873237E20F}"/>
+                <a16:creationId xmlns:a16="http://schemas.microsoft.com/office/drawing/2014/main" id="{0768500C-4FEC-4FA5-9ECD-A8D42671E71D}"/>
               </a:ext>
             </a:extLst>
           </p:cNvPr>
@@ -19381,7 +19381,7 @@
           <p:cNvPr id="11" name="">
             <a:extLst xmlns:a="http://schemas.openxmlformats.org/drawingml/2006/main">
               <a:ext uri="{FF2B5EF4-FFF2-40B4-BE49-F238E27FC236}">
-                <a16:creationId xmlns:a16="http://schemas.microsoft.com/office/drawing/2014/main" id="{F31431F7-94CF-48AF-94EA-C7B936FC9CFD}"/>
+                <a16:creationId xmlns:a16="http://schemas.microsoft.com/office/drawing/2014/main" id="{3F9C9CBD-2206-41CA-B560-D9EEEE46EBF8}"/>
               </a:ext>
             </a:extLst>
           </p:cNvPr>
@@ -19538,7 +19538,7 @@
           <p:cNvPr id="12" name="Chart">
             <a:extLst xmlns:a="http://schemas.openxmlformats.org/drawingml/2006/main">
               <a:ext uri="{FF2B5EF4-FFF2-40B4-BE49-F238E27FC236}">
-                <a16:creationId xmlns:a16="http://schemas.microsoft.com/office/drawing/2014/main" id="{94956780-E794-4628-845D-70737944A640}"/>
+                <a16:creationId xmlns:a16="http://schemas.microsoft.com/office/drawing/2014/main" id="{7528D38E-12DB-48A6-91BF-9782F2F8D45A}"/>
               </a:ext>
             </a:extLst>
           </p:cNvPr>
@@ -19551,7 +19551,7 @@
         </p:xfrm>
         <a:graphic xmlns:a="http://schemas.openxmlformats.org/drawingml/2006/main">
           <a:graphicData uri="http://schemas.openxmlformats.org/drawingml/2006/chart">
-            <c:chart xmlns:r="http://schemas.openxmlformats.org/officeDocument/2006/relationships" xmlns:c="http://schemas.openxmlformats.org/drawingml/2006/chart" r:id="R432e243be71f40e1"/>
+            <c:chart xmlns:r="http://schemas.openxmlformats.org/officeDocument/2006/relationships" xmlns:c="http://schemas.openxmlformats.org/drawingml/2006/chart" r:id="R93f9a48d7d99408d"/>
           </a:graphicData>
         </a:graphic>
       </p:graphicFrame>
@@ -19560,7 +19560,7 @@
           <p:cNvPr id="13" name="">
             <a:extLst xmlns:a="http://schemas.openxmlformats.org/drawingml/2006/main">
               <a:ext uri="{FF2B5EF4-FFF2-40B4-BE49-F238E27FC236}">
-                <a16:creationId xmlns:a16="http://schemas.microsoft.com/office/drawing/2014/main" id="{84F450B2-632E-4F31-A35E-4BAC3171D1EE}"/>
+                <a16:creationId xmlns:a16="http://schemas.microsoft.com/office/drawing/2014/main" id="{9B4097BA-F704-45F2-9721-43ADBA10CAC0}"/>
               </a:ext>
             </a:extLst>
           </p:cNvPr>
@@ -19717,7 +19717,7 @@
           <p:cNvPr id="14" name="">
             <a:extLst xmlns:a="http://schemas.openxmlformats.org/drawingml/2006/main">
               <a:ext uri="{FF2B5EF4-FFF2-40B4-BE49-F238E27FC236}">
-                <a16:creationId xmlns:a16="http://schemas.microsoft.com/office/drawing/2014/main" id="{9751FCCD-A3A3-4B6C-87E6-0F04E3BDE9AF}"/>
+                <a16:creationId xmlns:a16="http://schemas.microsoft.com/office/drawing/2014/main" id="{567BF669-D758-41EF-AE8B-4EDE521F21ED}"/>
               </a:ext>
             </a:extLst>
           </p:cNvPr>
@@ -19872,7 +19872,7 @@
     </p:spTree>
     <p:extLst>
       <p:ext uri="{BB962C8B-B14F-4D97-AF65-F5344CB8AC3E}">
-        <p14:creationId xmlns:p14="http://schemas.microsoft.com/office/powerpoint/2010/main" val="1806643875"/>
+        <p14:creationId xmlns:p14="http://schemas.microsoft.com/office/powerpoint/2010/main" val="116793682"/>
       </p:ext>
     </p:extLst>
   </p:cSld>
@@ -19903,7 +19903,7 @@
           <p:cNvPr id="33" name="">
             <a:extLst xmlns:a="http://schemas.openxmlformats.org/drawingml/2006/main">
               <a:ext uri="{FF2B5EF4-FFF2-40B4-BE49-F238E27FC236}">
-                <a16:creationId xmlns:a16="http://schemas.microsoft.com/office/drawing/2014/main" id="{D1C424AD-CBB6-4BA1-8D67-513A9299E3ED}"/>
+                <a16:creationId xmlns:a16="http://schemas.microsoft.com/office/drawing/2014/main" id="{F4419C14-1B66-4740-81D1-DE6BA991A9B5}"/>
               </a:ext>
             </a:extLst>
           </p:cNvPr>
@@ -20060,7 +20060,7 @@
           <p:cNvPr id="2" name="">
             <a:extLst xmlns:a="http://schemas.openxmlformats.org/drawingml/2006/main">
               <a:ext uri="{FF2B5EF4-FFF2-40B4-BE49-F238E27FC236}">
-                <a16:creationId xmlns:a16="http://schemas.microsoft.com/office/drawing/2014/main" id="{EDCA45F3-BB68-44A7-857C-0B09B812C765}"/>
+                <a16:creationId xmlns:a16="http://schemas.microsoft.com/office/drawing/2014/main" id="{D78C6858-3A2A-4505-9821-F795B1FC8A32}"/>
               </a:ext>
             </a:extLst>
           </p:cNvPr>
@@ -20091,7 +20091,7 @@
           <p:cNvPr id="3" name="">
             <a:extLst xmlns:a="http://schemas.openxmlformats.org/drawingml/2006/main">
               <a:ext uri="{FF2B5EF4-FFF2-40B4-BE49-F238E27FC236}">
-                <a16:creationId xmlns:a16="http://schemas.microsoft.com/office/drawing/2014/main" id="{F48322F9-6D5A-4289-B760-4BC2CBD5D316}"/>
+                <a16:creationId xmlns:a16="http://schemas.microsoft.com/office/drawing/2014/main" id="{9C198870-3413-44C9-B00F-99BAE539164D}"/>
               </a:ext>
             </a:extLst>
           </p:cNvPr>
@@ -20248,7 +20248,7 @@
           <p:cNvPr id="4" name="">
             <a:extLst xmlns:a="http://schemas.openxmlformats.org/drawingml/2006/main">
               <a:ext uri="{FF2B5EF4-FFF2-40B4-BE49-F238E27FC236}">
-                <a16:creationId xmlns:a16="http://schemas.microsoft.com/office/drawing/2014/main" id="{11FE8B0A-DCEB-47DE-9E4E-54CDFDBD5D35}"/>
+                <a16:creationId xmlns:a16="http://schemas.microsoft.com/office/drawing/2014/main" id="{9864E847-04DD-4D88-8416-B8E92BDDE563}"/>
               </a:ext>
             </a:extLst>
           </p:cNvPr>
@@ -20279,7 +20279,7 @@
           <p:cNvPr id="5" name="">
             <a:extLst xmlns:a="http://schemas.openxmlformats.org/drawingml/2006/main">
               <a:ext uri="{FF2B5EF4-FFF2-40B4-BE49-F238E27FC236}">
-                <a16:creationId xmlns:a16="http://schemas.microsoft.com/office/drawing/2014/main" id="{6EF19C95-A731-48DC-912A-736418768AFE}"/>
+                <a16:creationId xmlns:a16="http://schemas.microsoft.com/office/drawing/2014/main" id="{5EE55345-F208-47FD-BEEE-8708D1ABD207}"/>
               </a:ext>
             </a:extLst>
           </p:cNvPr>
@@ -20436,7 +20436,7 @@
           <p:cNvPr id="6" name="">
             <a:extLst xmlns:a="http://schemas.openxmlformats.org/drawingml/2006/main">
               <a:ext uri="{FF2B5EF4-FFF2-40B4-BE49-F238E27FC236}">
-                <a16:creationId xmlns:a16="http://schemas.microsoft.com/office/drawing/2014/main" id="{CCE5B2F1-1702-458B-B390-CAA1C244836C}"/>
+                <a16:creationId xmlns:a16="http://schemas.microsoft.com/office/drawing/2014/main" id="{944715FC-3A12-494A-AFEF-47EC3290FDED}"/>
               </a:ext>
             </a:extLst>
           </p:cNvPr>
@@ -20471,7 +20471,7 @@
           <p:cNvPr id="7" name="">
             <a:extLst xmlns:a="http://schemas.openxmlformats.org/drawingml/2006/main">
               <a:ext uri="{FF2B5EF4-FFF2-40B4-BE49-F238E27FC236}">
-                <a16:creationId xmlns:a16="http://schemas.microsoft.com/office/drawing/2014/main" id="{E6235C72-3C86-4187-BC10-D697F9015E1B}"/>
+                <a16:creationId xmlns:a16="http://schemas.microsoft.com/office/drawing/2014/main" id="{9BEB23C8-AD61-4E8C-8571-A30D74777A25}"/>
               </a:ext>
             </a:extLst>
           </p:cNvPr>
@@ -20628,7 +20628,7 @@
           <p:cNvPr id="8" name="">
             <a:extLst xmlns:a="http://schemas.openxmlformats.org/drawingml/2006/main">
               <a:ext uri="{FF2B5EF4-FFF2-40B4-BE49-F238E27FC236}">
-                <a16:creationId xmlns:a16="http://schemas.microsoft.com/office/drawing/2014/main" id="{78B3DF28-0D8D-41FB-A903-045143C40ACB}"/>
+                <a16:creationId xmlns:a16="http://schemas.microsoft.com/office/drawing/2014/main" id="{0767E786-5066-43BF-A177-B473CB01D855}"/>
               </a:ext>
             </a:extLst>
           </p:cNvPr>
@@ -20808,7 +20808,7 @@
           <p:cNvPr id="9" name="">
             <a:extLst xmlns:a="http://schemas.openxmlformats.org/drawingml/2006/main">
               <a:ext uri="{FF2B5EF4-FFF2-40B4-BE49-F238E27FC236}">
-                <a16:creationId xmlns:a16="http://schemas.microsoft.com/office/drawing/2014/main" id="{FCBE67B1-BC50-4BE9-B878-285E67600994}"/>
+                <a16:creationId xmlns:a16="http://schemas.microsoft.com/office/drawing/2014/main" id="{51940C17-A9E9-4AFA-9302-94674BD00632}"/>
               </a:ext>
             </a:extLst>
           </p:cNvPr>
@@ -20839,7 +20839,7 @@
           <p:cNvPr id="10" name="">
             <a:extLst xmlns:a="http://schemas.openxmlformats.org/drawingml/2006/main">
               <a:ext uri="{FF2B5EF4-FFF2-40B4-BE49-F238E27FC236}">
-                <a16:creationId xmlns:a16="http://schemas.microsoft.com/office/drawing/2014/main" id="{D144117B-90BC-4127-9301-4584E1C7A5B7}"/>
+                <a16:creationId xmlns:a16="http://schemas.microsoft.com/office/drawing/2014/main" id="{083378CB-4E60-4466-8523-4574F8605984}"/>
               </a:ext>
             </a:extLst>
           </p:cNvPr>
@@ -20874,7 +20874,7 @@
           <p:cNvPr id="11" name="">
             <a:extLst xmlns:a="http://schemas.openxmlformats.org/drawingml/2006/main">
               <a:ext uri="{FF2B5EF4-FFF2-40B4-BE49-F238E27FC236}">
-                <a16:creationId xmlns:a16="http://schemas.microsoft.com/office/drawing/2014/main" id="{D98435DD-E2BB-4C8E-A29D-2627ACD600EE}"/>
+                <a16:creationId xmlns:a16="http://schemas.microsoft.com/office/drawing/2014/main" id="{99836581-D866-49A4-BE95-B6FB28546C7A}"/>
               </a:ext>
             </a:extLst>
           </p:cNvPr>
@@ -21031,7 +21031,7 @@
           <p:cNvPr id="12" name="">
             <a:extLst xmlns:a="http://schemas.openxmlformats.org/drawingml/2006/main">
               <a:ext uri="{FF2B5EF4-FFF2-40B4-BE49-F238E27FC236}">
-                <a16:creationId xmlns:a16="http://schemas.microsoft.com/office/drawing/2014/main" id="{243B4AC3-79DD-4DBC-B232-C02DF55F673F}"/>
+                <a16:creationId xmlns:a16="http://schemas.microsoft.com/office/drawing/2014/main" id="{88F5BF3C-5327-44B7-8CD1-1E2E5E0E0FCA}"/>
               </a:ext>
             </a:extLst>
           </p:cNvPr>
@@ -21211,7 +21211,7 @@
           <p:cNvPr id="13" name="">
             <a:extLst xmlns:a="http://schemas.openxmlformats.org/drawingml/2006/main">
               <a:ext uri="{FF2B5EF4-FFF2-40B4-BE49-F238E27FC236}">
-                <a16:creationId xmlns:a16="http://schemas.microsoft.com/office/drawing/2014/main" id="{6966D749-2974-411D-9DF9-43C68B64EDA3}"/>
+                <a16:creationId xmlns:a16="http://schemas.microsoft.com/office/drawing/2014/main" id="{3AAC5161-7211-450F-B8A5-1B115D714AC4}"/>
               </a:ext>
             </a:extLst>
           </p:cNvPr>
@@ -21242,7 +21242,7 @@
           <p:cNvPr id="14" name="">
             <a:extLst xmlns:a="http://schemas.openxmlformats.org/drawingml/2006/main">
               <a:ext uri="{FF2B5EF4-FFF2-40B4-BE49-F238E27FC236}">
-                <a16:creationId xmlns:a16="http://schemas.microsoft.com/office/drawing/2014/main" id="{9E2EC2A4-1F60-40D3-93E7-84A7C3717ED1}"/>
+                <a16:creationId xmlns:a16="http://schemas.microsoft.com/office/drawing/2014/main" id="{C8FA8C1D-52D7-40E2-9BC4-C33457D54DE1}"/>
               </a:ext>
             </a:extLst>
           </p:cNvPr>
@@ -21277,7 +21277,7 @@
           <p:cNvPr id="15" name="">
             <a:extLst xmlns:a="http://schemas.openxmlformats.org/drawingml/2006/main">
               <a:ext uri="{FF2B5EF4-FFF2-40B4-BE49-F238E27FC236}">
-                <a16:creationId xmlns:a16="http://schemas.microsoft.com/office/drawing/2014/main" id="{7CF65B96-D2F8-4E85-AFDB-0AB2C0DC8FB9}"/>
+                <a16:creationId xmlns:a16="http://schemas.microsoft.com/office/drawing/2014/main" id="{8D352C47-CD36-438A-95EF-E54375E324AD}"/>
               </a:ext>
             </a:extLst>
           </p:cNvPr>
@@ -21434,7 +21434,7 @@
           <p:cNvPr id="16" name="">
             <a:extLst xmlns:a="http://schemas.openxmlformats.org/drawingml/2006/main">
               <a:ext uri="{FF2B5EF4-FFF2-40B4-BE49-F238E27FC236}">
-                <a16:creationId xmlns:a16="http://schemas.microsoft.com/office/drawing/2014/main" id="{5F72A607-0968-4B7D-8497-1EB418E62B2E}"/>
+                <a16:creationId xmlns:a16="http://schemas.microsoft.com/office/drawing/2014/main" id="{64C62916-F448-4CF2-8036-AEEAD45B76D7}"/>
               </a:ext>
             </a:extLst>
           </p:cNvPr>
@@ -21581,7 +21581,7 @@
                 <a:ea typeface="Arial"/>
                 <a:cs typeface="Arial"/>
               </a:rPr>
-              <a:t>Choose one action</a:t>
+              <a:t>Primary model</a:t>
             </a:r>
           </a:p>
           <a:p xmlns:a="http://schemas.openxmlformats.org/drawingml/2006/main">
@@ -21604,7 +21604,7 @@
                 <a:ea typeface="Arial"/>
                 <a:cs typeface="Arial"/>
               </a:rPr>
-              <a:t>Use fixed LLM</a:t>
+              <a:t>Optional recovery</a:t>
             </a:r>
           </a:p>
         </p:txBody>
@@ -21614,7 +21614,7 @@
           <p:cNvPr id="17" name="">
             <a:extLst xmlns:a="http://schemas.openxmlformats.org/drawingml/2006/main">
               <a:ext uri="{FF2B5EF4-FFF2-40B4-BE49-F238E27FC236}">
-                <a16:creationId xmlns:a16="http://schemas.microsoft.com/office/drawing/2014/main" id="{BB9959E9-1C95-4807-B986-F818AB9DC095}"/>
+                <a16:creationId xmlns:a16="http://schemas.microsoft.com/office/drawing/2014/main" id="{94D36DA3-BB38-46E5-A952-4A5FBB6E464C}"/>
               </a:ext>
             </a:extLst>
           </p:cNvPr>
@@ -21645,7 +21645,7 @@
           <p:cNvPr id="18" name="">
             <a:extLst xmlns:a="http://schemas.openxmlformats.org/drawingml/2006/main">
               <a:ext uri="{FF2B5EF4-FFF2-40B4-BE49-F238E27FC236}">
-                <a16:creationId xmlns:a16="http://schemas.microsoft.com/office/drawing/2014/main" id="{FF993588-C449-4AB9-9E42-7263DABA0CF8}"/>
+                <a16:creationId xmlns:a16="http://schemas.microsoft.com/office/drawing/2014/main" id="{FB699BEC-3802-4F69-9282-D0074C472C85}"/>
               </a:ext>
             </a:extLst>
           </p:cNvPr>
@@ -21680,7 +21680,7 @@
           <p:cNvPr id="19" name="">
             <a:extLst xmlns:a="http://schemas.openxmlformats.org/drawingml/2006/main">
               <a:ext uri="{FF2B5EF4-FFF2-40B4-BE49-F238E27FC236}">
-                <a16:creationId xmlns:a16="http://schemas.microsoft.com/office/drawing/2014/main" id="{97D200B5-1A2B-4FF3-BE8D-A9492A1BAD60}"/>
+                <a16:creationId xmlns:a16="http://schemas.microsoft.com/office/drawing/2014/main" id="{697BE19D-2841-465C-8811-C31614C337B6}"/>
               </a:ext>
             </a:extLst>
           </p:cNvPr>
@@ -21837,7 +21837,7 @@
           <p:cNvPr id="20" name="">
             <a:extLst xmlns:a="http://schemas.openxmlformats.org/drawingml/2006/main">
               <a:ext uri="{FF2B5EF4-FFF2-40B4-BE49-F238E27FC236}">
-                <a16:creationId xmlns:a16="http://schemas.microsoft.com/office/drawing/2014/main" id="{DC7371C8-CCDB-436A-B59A-40E5451A1569}"/>
+                <a16:creationId xmlns:a16="http://schemas.microsoft.com/office/drawing/2014/main" id="{AD64094E-1B0E-4576-88EF-8875765688AA}"/>
               </a:ext>
             </a:extLst>
           </p:cNvPr>
@@ -22017,7 +22017,7 @@
           <p:cNvPr id="21" name="">
             <a:extLst xmlns:a="http://schemas.openxmlformats.org/drawingml/2006/main">
               <a:ext uri="{FF2B5EF4-FFF2-40B4-BE49-F238E27FC236}">
-                <a16:creationId xmlns:a16="http://schemas.microsoft.com/office/drawing/2014/main" id="{32B5D3EA-5BB2-40D2-8802-4B143185C1E5}"/>
+                <a16:creationId xmlns:a16="http://schemas.microsoft.com/office/drawing/2014/main" id="{009C02A0-4CEF-424D-AE89-E620DA0C61C5}"/>
               </a:ext>
             </a:extLst>
           </p:cNvPr>
@@ -22048,7 +22048,7 @@
           <p:cNvPr id="22" name="">
             <a:extLst xmlns:a="http://schemas.openxmlformats.org/drawingml/2006/main">
               <a:ext uri="{FF2B5EF4-FFF2-40B4-BE49-F238E27FC236}">
-                <a16:creationId xmlns:a16="http://schemas.microsoft.com/office/drawing/2014/main" id="{E5C83BF3-0921-4CCB-8AB4-4F77AFC1B3C3}"/>
+                <a16:creationId xmlns:a16="http://schemas.microsoft.com/office/drawing/2014/main" id="{0A11E4AB-A018-4255-8203-12A1D12189B9}"/>
               </a:ext>
             </a:extLst>
           </p:cNvPr>
@@ -22079,7 +22079,7 @@
           <p:cNvPr id="23" name="">
             <a:extLst xmlns:a="http://schemas.openxmlformats.org/drawingml/2006/main">
               <a:ext uri="{FF2B5EF4-FFF2-40B4-BE49-F238E27FC236}">
-                <a16:creationId xmlns:a16="http://schemas.microsoft.com/office/drawing/2014/main" id="{8B42F366-2B97-4FFF-8A3A-AF700F64FD1A}"/>
+                <a16:creationId xmlns:a16="http://schemas.microsoft.com/office/drawing/2014/main" id="{61815E64-2036-4875-9637-F58E79A4A15B}"/>
               </a:ext>
             </a:extLst>
           </p:cNvPr>
@@ -22110,7 +22110,7 @@
           <p:cNvPr id="24" name="">
             <a:extLst xmlns:a="http://schemas.openxmlformats.org/drawingml/2006/main">
               <a:ext uri="{FF2B5EF4-FFF2-40B4-BE49-F238E27FC236}">
-                <a16:creationId xmlns:a16="http://schemas.microsoft.com/office/drawing/2014/main" id="{78F580C4-3368-4B79-A741-7ACCC664DF98}"/>
+                <a16:creationId xmlns:a16="http://schemas.microsoft.com/office/drawing/2014/main" id="{5574F836-D2A6-4DDF-95EB-FF2558B68B3B}"/>
               </a:ext>
             </a:extLst>
           </p:cNvPr>
@@ -22257,7 +22257,7 @@
                 <a:ea typeface="Arial"/>
                 <a:cs typeface="Arial"/>
               </a:rPr>
-              <a:t>Repeat only while budget remains. Stop with a verified feasible result.</a:t>
+              <a:t>Repeat within budget; one stronger-model recovery follows invalid output or host incumbent correction.</a:t>
             </a:r>
           </a:p>
         </p:txBody>
@@ -22267,7 +22267,7 @@
           <p:cNvPr id="25" name="">
             <a:extLst xmlns:a="http://schemas.openxmlformats.org/drawingml/2006/main">
               <a:ext uri="{FF2B5EF4-FFF2-40B4-BE49-F238E27FC236}">
-                <a16:creationId xmlns:a16="http://schemas.microsoft.com/office/drawing/2014/main" id="{F6DC3174-85C0-474D-9B48-5E9181779CAC}"/>
+                <a16:creationId xmlns:a16="http://schemas.microsoft.com/office/drawing/2014/main" id="{63EA2031-87D4-41F6-9B5B-490060A8AEA0}"/>
               </a:ext>
             </a:extLst>
           </p:cNvPr>
@@ -22424,7 +22424,7 @@
           <p:cNvPr id="26" name="">
             <a:extLst xmlns:a="http://schemas.openxmlformats.org/drawingml/2006/main">
               <a:ext uri="{FF2B5EF4-FFF2-40B4-BE49-F238E27FC236}">
-                <a16:creationId xmlns:a16="http://schemas.microsoft.com/office/drawing/2014/main" id="{1796B679-2256-4551-B99F-852FB0D2A495}"/>
+                <a16:creationId xmlns:a16="http://schemas.microsoft.com/office/drawing/2014/main" id="{E267A624-2EEF-416E-AF90-E89228EA333A}"/>
               </a:ext>
             </a:extLst>
           </p:cNvPr>
@@ -22581,7 +22581,7 @@
           <p:cNvPr id="27" name="">
             <a:extLst xmlns:a="http://schemas.openxmlformats.org/drawingml/2006/main">
               <a:ext uri="{FF2B5EF4-FFF2-40B4-BE49-F238E27FC236}">
-                <a16:creationId xmlns:a16="http://schemas.microsoft.com/office/drawing/2014/main" id="{DFC0A4D8-2E77-4337-9B85-46635E679A41}"/>
+                <a16:creationId xmlns:a16="http://schemas.microsoft.com/office/drawing/2014/main" id="{138360D5-1BAC-4140-9E0B-10B904DADE45}"/>
               </a:ext>
             </a:extLst>
           </p:cNvPr>
@@ -22761,7 +22761,7 @@
           <p:cNvPr id="28" name="">
             <a:extLst xmlns:a="http://schemas.openxmlformats.org/drawingml/2006/main">
               <a:ext uri="{FF2B5EF4-FFF2-40B4-BE49-F238E27FC236}">
-                <a16:creationId xmlns:a16="http://schemas.microsoft.com/office/drawing/2014/main" id="{D1E8BBB7-AEF0-4481-A3AC-D85B79440311}"/>
+                <a16:creationId xmlns:a16="http://schemas.microsoft.com/office/drawing/2014/main" id="{6A1282AB-DE58-4843-80AE-F186452A2D7E}"/>
               </a:ext>
             </a:extLst>
           </p:cNvPr>
@@ -22918,7 +22918,7 @@
           <p:cNvPr id="29" name="">
             <a:extLst xmlns:a="http://schemas.openxmlformats.org/drawingml/2006/main">
               <a:ext uri="{FF2B5EF4-FFF2-40B4-BE49-F238E27FC236}">
-                <a16:creationId xmlns:a16="http://schemas.microsoft.com/office/drawing/2014/main" id="{69AB5FD5-0A3F-482B-AE72-274A4F3791CC}"/>
+                <a16:creationId xmlns:a16="http://schemas.microsoft.com/office/drawing/2014/main" id="{5F8FF7CC-6407-48C3-9380-637B54C27832}"/>
               </a:ext>
             </a:extLst>
           </p:cNvPr>
@@ -23098,7 +23098,7 @@
           <p:cNvPr id="30" name="">
             <a:extLst xmlns:a="http://schemas.openxmlformats.org/drawingml/2006/main">
               <a:ext uri="{FF2B5EF4-FFF2-40B4-BE49-F238E27FC236}">
-                <a16:creationId xmlns:a16="http://schemas.microsoft.com/office/drawing/2014/main" id="{19612863-C24C-4E05-9FE8-8359C68CA244}"/>
+                <a16:creationId xmlns:a16="http://schemas.microsoft.com/office/drawing/2014/main" id="{97714D7A-F445-45B7-98ED-7F6482B2605B}"/>
               </a:ext>
             </a:extLst>
           </p:cNvPr>
@@ -23255,7 +23255,7 @@
           <p:cNvPr id="31" name="">
             <a:extLst xmlns:a="http://schemas.openxmlformats.org/drawingml/2006/main">
               <a:ext uri="{FF2B5EF4-FFF2-40B4-BE49-F238E27FC236}">
-                <a16:creationId xmlns:a16="http://schemas.microsoft.com/office/drawing/2014/main" id="{3DC8FB6C-99F3-437E-B38D-B63716DD30C2}"/>
+                <a16:creationId xmlns:a16="http://schemas.microsoft.com/office/drawing/2014/main" id="{548FA199-337C-4A49-B18C-5EA106F1EE65}"/>
               </a:ext>
             </a:extLst>
           </p:cNvPr>
@@ -23435,7 +23435,7 @@
           <p:cNvPr id="32" name="">
             <a:extLst xmlns:a="http://schemas.openxmlformats.org/drawingml/2006/main">
               <a:ext uri="{FF2B5EF4-FFF2-40B4-BE49-F238E27FC236}">
-                <a16:creationId xmlns:a16="http://schemas.microsoft.com/office/drawing/2014/main" id="{9B847720-64A3-4CD4-9AC6-11962801279C}"/>
+                <a16:creationId xmlns:a16="http://schemas.microsoft.com/office/drawing/2014/main" id="{145265F5-02AB-44EB-AB19-3751CEFDA724}"/>
               </a:ext>
             </a:extLst>
           </p:cNvPr>
@@ -23582,7 +23582,7 @@
                 <a:ea typeface="Arial"/>
                 <a:cs typeface="Arial"/>
               </a:rPr>
-              <a:t>One archived trial per arm. v2 guards the incumbent; no live v2 LLM run. Strong heuristic: 1 query.</a:t>
+              <a:t>One archived trial per arm. Recovery is offline-tested; no live v2 LLM run. Heuristic: 1 query.</a:t>
             </a:r>
           </a:p>
         </p:txBody>
@@ -23590,7 +23590,7 @@
     </p:spTree>
     <p:extLst>
       <p:ext uri="{BB962C8B-B14F-4D97-AF65-F5344CB8AC3E}">
-        <p14:creationId xmlns:p14="http://schemas.microsoft.com/office/powerpoint/2010/main" val="1386606448"/>
+        <p14:creationId xmlns:p14="http://schemas.microsoft.com/office/powerpoint/2010/main" val="198145594"/>
       </p:ext>
     </p:extLst>
   </p:cSld>
@@ -23621,7 +23621,7 @@
           <p:cNvPr id="26" name="">
             <a:extLst xmlns:a="http://schemas.openxmlformats.org/drawingml/2006/main">
               <a:ext uri="{FF2B5EF4-FFF2-40B4-BE49-F238E27FC236}">
-                <a16:creationId xmlns:a16="http://schemas.microsoft.com/office/drawing/2014/main" id="{5733CB69-0345-466C-8F50-701CA27A16A4}"/>
+                <a16:creationId xmlns:a16="http://schemas.microsoft.com/office/drawing/2014/main" id="{D6BC54E8-CBCA-4269-9D40-4F2611137272}"/>
               </a:ext>
             </a:extLst>
           </p:cNvPr>
@@ -23778,7 +23778,7 @@
           <p:cNvPr id="2" name="">
             <a:extLst xmlns:a="http://schemas.openxmlformats.org/drawingml/2006/main">
               <a:ext uri="{FF2B5EF4-FFF2-40B4-BE49-F238E27FC236}">
-                <a16:creationId xmlns:a16="http://schemas.microsoft.com/office/drawing/2014/main" id="{580671D1-BD7A-437C-B3EE-436B6C7BDBD2}"/>
+                <a16:creationId xmlns:a16="http://schemas.microsoft.com/office/drawing/2014/main" id="{EAB0EF57-5B47-4D82-A2BD-5377A48D9E3D}"/>
               </a:ext>
             </a:extLst>
           </p:cNvPr>
@@ -23809,7 +23809,7 @@
           <p:cNvPr id="3" name="">
             <a:extLst xmlns:a="http://schemas.openxmlformats.org/drawingml/2006/main">
               <a:ext uri="{FF2B5EF4-FFF2-40B4-BE49-F238E27FC236}">
-                <a16:creationId xmlns:a16="http://schemas.microsoft.com/office/drawing/2014/main" id="{91FE8355-EA37-4BD8-84E0-A1EB80C02A07}"/>
+                <a16:creationId xmlns:a16="http://schemas.microsoft.com/office/drawing/2014/main" id="{4211114C-53BA-4A6F-820C-54B127924255}"/>
               </a:ext>
             </a:extLst>
           </p:cNvPr>
@@ -23966,7 +23966,7 @@
           <p:cNvPr id="4" name="">
             <a:extLst xmlns:a="http://schemas.openxmlformats.org/drawingml/2006/main">
               <a:ext uri="{FF2B5EF4-FFF2-40B4-BE49-F238E27FC236}">
-                <a16:creationId xmlns:a16="http://schemas.microsoft.com/office/drawing/2014/main" id="{62087063-DAEC-4B57-BB41-BB768AE10615}"/>
+                <a16:creationId xmlns:a16="http://schemas.microsoft.com/office/drawing/2014/main" id="{746727D1-FE6F-43C8-9B79-B4D95B716E80}"/>
               </a:ext>
             </a:extLst>
           </p:cNvPr>
@@ -24123,7 +24123,7 @@
           <p:cNvPr id="5" name="">
             <a:extLst xmlns:a="http://schemas.openxmlformats.org/drawingml/2006/main">
               <a:ext uri="{FF2B5EF4-FFF2-40B4-BE49-F238E27FC236}">
-                <a16:creationId xmlns:a16="http://schemas.microsoft.com/office/drawing/2014/main" id="{9B3C2959-F775-46B7-AE6E-312C866C6B54}"/>
+                <a16:creationId xmlns:a16="http://schemas.microsoft.com/office/drawing/2014/main" id="{09B5D634-E4FB-4856-A2ED-DDBCEB911E91}"/>
               </a:ext>
             </a:extLst>
           </p:cNvPr>
@@ -24280,7 +24280,7 @@
           <p:cNvPr id="6" name="">
             <a:extLst xmlns:a="http://schemas.openxmlformats.org/drawingml/2006/main">
               <a:ext uri="{FF2B5EF4-FFF2-40B4-BE49-F238E27FC236}">
-                <a16:creationId xmlns:a16="http://schemas.microsoft.com/office/drawing/2014/main" id="{0F3120B0-6ED1-4FA7-8BCD-F7F13714E648}"/>
+                <a16:creationId xmlns:a16="http://schemas.microsoft.com/office/drawing/2014/main" id="{8438DBB0-6AB4-47E4-8475-8C0EB004C39C}"/>
               </a:ext>
             </a:extLst>
           </p:cNvPr>
@@ -24437,7 +24437,7 @@
           <p:cNvPr id="7" name="">
             <a:extLst xmlns:a="http://schemas.openxmlformats.org/drawingml/2006/main">
               <a:ext uri="{FF2B5EF4-FFF2-40B4-BE49-F238E27FC236}">
-                <a16:creationId xmlns:a16="http://schemas.microsoft.com/office/drawing/2014/main" id="{0FD2F632-06C0-46B8-96BE-D9A94A0568CA}"/>
+                <a16:creationId xmlns:a16="http://schemas.microsoft.com/office/drawing/2014/main" id="{6F274C51-AD2B-4707-8452-BB6EEF803DC6}"/>
               </a:ext>
             </a:extLst>
           </p:cNvPr>
@@ -24468,7 +24468,7 @@
           <p:cNvPr id="8" name="">
             <a:extLst xmlns:a="http://schemas.openxmlformats.org/drawingml/2006/main">
               <a:ext uri="{FF2B5EF4-FFF2-40B4-BE49-F238E27FC236}">
-                <a16:creationId xmlns:a16="http://schemas.microsoft.com/office/drawing/2014/main" id="{9A39D7DA-CE78-4E02-9DFB-328A00131FD7}"/>
+                <a16:creationId xmlns:a16="http://schemas.microsoft.com/office/drawing/2014/main" id="{65439DAF-E269-4176-BFD0-8AD4948129B0}"/>
               </a:ext>
             </a:extLst>
           </p:cNvPr>
@@ -24625,7 +24625,7 @@
           <p:cNvPr id="9" name="">
             <a:extLst xmlns:a="http://schemas.openxmlformats.org/drawingml/2006/main">
               <a:ext uri="{FF2B5EF4-FFF2-40B4-BE49-F238E27FC236}">
-                <a16:creationId xmlns:a16="http://schemas.microsoft.com/office/drawing/2014/main" id="{C372258A-AEF5-4C25-A89D-930E1410E687}"/>
+                <a16:creationId xmlns:a16="http://schemas.microsoft.com/office/drawing/2014/main" id="{B250B03E-8F67-488E-B240-182647BC20AC}"/>
               </a:ext>
             </a:extLst>
           </p:cNvPr>
@@ -24782,7 +24782,7 @@
           <p:cNvPr id="10" name="">
             <a:extLst xmlns:a="http://schemas.openxmlformats.org/drawingml/2006/main">
               <a:ext uri="{FF2B5EF4-FFF2-40B4-BE49-F238E27FC236}">
-                <a16:creationId xmlns:a16="http://schemas.microsoft.com/office/drawing/2014/main" id="{96D96B58-6954-4650-9842-999C69566065}"/>
+                <a16:creationId xmlns:a16="http://schemas.microsoft.com/office/drawing/2014/main" id="{3FA95402-2087-4581-8CBA-B43E85672738}"/>
               </a:ext>
             </a:extLst>
           </p:cNvPr>
@@ -24813,7 +24813,7 @@
           <p:cNvPr id="11" name="">
             <a:extLst xmlns:a="http://schemas.openxmlformats.org/drawingml/2006/main">
               <a:ext uri="{FF2B5EF4-FFF2-40B4-BE49-F238E27FC236}">
-                <a16:creationId xmlns:a16="http://schemas.microsoft.com/office/drawing/2014/main" id="{7B3F0ADF-7AE9-4260-AB88-DEA6620772A0}"/>
+                <a16:creationId xmlns:a16="http://schemas.microsoft.com/office/drawing/2014/main" id="{F42F1EBC-6F0D-4100-B14F-8661C2761C8D}"/>
               </a:ext>
             </a:extLst>
           </p:cNvPr>
@@ -24970,7 +24970,7 @@
           <p:cNvPr id="12" name="">
             <a:extLst xmlns:a="http://schemas.openxmlformats.org/drawingml/2006/main">
               <a:ext uri="{FF2B5EF4-FFF2-40B4-BE49-F238E27FC236}">
-                <a16:creationId xmlns:a16="http://schemas.microsoft.com/office/drawing/2014/main" id="{C933A764-DB1B-4FFA-9FB0-236A26B6D03D}"/>
+                <a16:creationId xmlns:a16="http://schemas.microsoft.com/office/drawing/2014/main" id="{58FB8208-ED8E-4AE0-AA44-1D3EA2AF7E0B}"/>
               </a:ext>
             </a:extLst>
           </p:cNvPr>
@@ -25127,7 +25127,7 @@
           <p:cNvPr id="13" name="">
             <a:extLst xmlns:a="http://schemas.openxmlformats.org/drawingml/2006/main">
               <a:ext uri="{FF2B5EF4-FFF2-40B4-BE49-F238E27FC236}">
-                <a16:creationId xmlns:a16="http://schemas.microsoft.com/office/drawing/2014/main" id="{09594004-9015-4BA9-8B6C-0CF2C61E7EBF}"/>
+                <a16:creationId xmlns:a16="http://schemas.microsoft.com/office/drawing/2014/main" id="{A413EAF3-6E1C-4FC6-A7D2-F5D3C48855D0}"/>
               </a:ext>
             </a:extLst>
           </p:cNvPr>
@@ -25158,7 +25158,7 @@
           <p:cNvPr id="14" name="">
             <a:extLst xmlns:a="http://schemas.openxmlformats.org/drawingml/2006/main">
               <a:ext uri="{FF2B5EF4-FFF2-40B4-BE49-F238E27FC236}">
-                <a16:creationId xmlns:a16="http://schemas.microsoft.com/office/drawing/2014/main" id="{64E28372-4745-40B7-9775-E4D4890F5CA2}"/>
+                <a16:creationId xmlns:a16="http://schemas.microsoft.com/office/drawing/2014/main" id="{D8A2040C-01F2-4C45-B3B0-B61DCA429AC8}"/>
               </a:ext>
             </a:extLst>
           </p:cNvPr>
@@ -25315,7 +25315,7 @@
           <p:cNvPr id="15" name="">
             <a:extLst xmlns:a="http://schemas.openxmlformats.org/drawingml/2006/main">
               <a:ext uri="{FF2B5EF4-FFF2-40B4-BE49-F238E27FC236}">
-                <a16:creationId xmlns:a16="http://schemas.microsoft.com/office/drawing/2014/main" id="{0A424985-1AEB-4607-A2B3-E6D03D9E0514}"/>
+                <a16:creationId xmlns:a16="http://schemas.microsoft.com/office/drawing/2014/main" id="{D0C6E401-2871-4AAE-A904-B39AA099E898}"/>
               </a:ext>
             </a:extLst>
           </p:cNvPr>
@@ -25472,7 +25472,7 @@
           <p:cNvPr id="16" name="">
             <a:extLst xmlns:a="http://schemas.openxmlformats.org/drawingml/2006/main">
               <a:ext uri="{FF2B5EF4-FFF2-40B4-BE49-F238E27FC236}">
-                <a16:creationId xmlns:a16="http://schemas.microsoft.com/office/drawing/2014/main" id="{117E102C-9617-4989-857F-C447FBD37B82}"/>
+                <a16:creationId xmlns:a16="http://schemas.microsoft.com/office/drawing/2014/main" id="{64D6456F-5C62-4E34-9728-9043BC23106B}"/>
               </a:ext>
             </a:extLst>
           </p:cNvPr>
@@ -25503,7 +25503,7 @@
           <p:cNvPr id="17" name="">
             <a:extLst xmlns:a="http://schemas.openxmlformats.org/drawingml/2006/main">
               <a:ext uri="{FF2B5EF4-FFF2-40B4-BE49-F238E27FC236}">
-                <a16:creationId xmlns:a16="http://schemas.microsoft.com/office/drawing/2014/main" id="{8CDBD5A7-E564-4DFF-9111-CFC7DC610487}"/>
+                <a16:creationId xmlns:a16="http://schemas.microsoft.com/office/drawing/2014/main" id="{82A263B3-CBB0-4BF3-A43C-74637CF7DF5F}"/>
               </a:ext>
             </a:extLst>
           </p:cNvPr>
@@ -25660,7 +25660,7 @@
           <p:cNvPr id="18" name="">
             <a:extLst xmlns:a="http://schemas.openxmlformats.org/drawingml/2006/main">
               <a:ext uri="{FF2B5EF4-FFF2-40B4-BE49-F238E27FC236}">
-                <a16:creationId xmlns:a16="http://schemas.microsoft.com/office/drawing/2014/main" id="{58A599C0-2659-4F16-AEA8-E20C2847824C}"/>
+                <a16:creationId xmlns:a16="http://schemas.microsoft.com/office/drawing/2014/main" id="{1CB01E83-EDC6-4FD8-9C6C-C795B5489FB6}"/>
               </a:ext>
             </a:extLst>
           </p:cNvPr>
@@ -25817,7 +25817,7 @@
           <p:cNvPr id="19" name="">
             <a:extLst xmlns:a="http://schemas.openxmlformats.org/drawingml/2006/main">
               <a:ext uri="{FF2B5EF4-FFF2-40B4-BE49-F238E27FC236}">
-                <a16:creationId xmlns:a16="http://schemas.microsoft.com/office/drawing/2014/main" id="{82A09D9A-ADD1-488D-B513-1A9017FBB189}"/>
+                <a16:creationId xmlns:a16="http://schemas.microsoft.com/office/drawing/2014/main" id="{65C449AA-37B3-4C1C-BF31-80E3EFB381F1}"/>
               </a:ext>
             </a:extLst>
           </p:cNvPr>
@@ -25974,7 +25974,7 @@
           <p:cNvPr id="20" name="">
             <a:extLst xmlns:a="http://schemas.openxmlformats.org/drawingml/2006/main">
               <a:ext uri="{FF2B5EF4-FFF2-40B4-BE49-F238E27FC236}">
-                <a16:creationId xmlns:a16="http://schemas.microsoft.com/office/drawing/2014/main" id="{54F408E0-F95D-414D-BB2B-3CF22B020710}"/>
+                <a16:creationId xmlns:a16="http://schemas.microsoft.com/office/drawing/2014/main" id="{2ECEF088-0814-4829-B404-5019D5A5164D}"/>
               </a:ext>
             </a:extLst>
           </p:cNvPr>
@@ -26131,7 +26131,7 @@
           <p:cNvPr id="21" name="">
             <a:extLst xmlns:a="http://schemas.openxmlformats.org/drawingml/2006/main">
               <a:ext uri="{FF2B5EF4-FFF2-40B4-BE49-F238E27FC236}">
-                <a16:creationId xmlns:a16="http://schemas.microsoft.com/office/drawing/2014/main" id="{1F5A3732-1FE8-4067-B222-42247FDB8432}"/>
+                <a16:creationId xmlns:a16="http://schemas.microsoft.com/office/drawing/2014/main" id="{1911A451-7F3A-48DA-819E-202FA091A91E}"/>
               </a:ext>
             </a:extLst>
           </p:cNvPr>
@@ -26311,7 +26311,7 @@
           <p:cNvPr id="22" name="">
             <a:extLst xmlns:a="http://schemas.openxmlformats.org/drawingml/2006/main">
               <a:ext uri="{FF2B5EF4-FFF2-40B4-BE49-F238E27FC236}">
-                <a16:creationId xmlns:a16="http://schemas.microsoft.com/office/drawing/2014/main" id="{4B89A15C-9921-4655-A342-A1830396BDF2}"/>
+                <a16:creationId xmlns:a16="http://schemas.microsoft.com/office/drawing/2014/main" id="{CC8500F8-E0BD-4872-AEEC-734BDAEC7763}"/>
               </a:ext>
             </a:extLst>
           </p:cNvPr>
@@ -26468,7 +26468,7 @@
           <p:cNvPr id="23" name="">
             <a:extLst xmlns:a="http://schemas.openxmlformats.org/drawingml/2006/main">
               <a:ext uri="{FF2B5EF4-FFF2-40B4-BE49-F238E27FC236}">
-                <a16:creationId xmlns:a16="http://schemas.microsoft.com/office/drawing/2014/main" id="{700D768B-10B7-4A88-A55B-F56422BDD637}"/>
+                <a16:creationId xmlns:a16="http://schemas.microsoft.com/office/drawing/2014/main" id="{7692E793-32BB-4C98-A249-75B0C5BE93AD}"/>
               </a:ext>
             </a:extLst>
           </p:cNvPr>
@@ -26615,7 +26615,7 @@
                 <a:ea typeface="Arial"/>
                 <a:cs typeface="Arial"/>
               </a:rPr>
-              <a:t>Inspect all 13 live agent decisions</a:t>
+              <a:t>Inspect decisions, tool calls and recovery trigger</a:t>
             </a:r>
           </a:p>
           <a:p xmlns:a="http://schemas.openxmlformats.org/drawingml/2006/main">
@@ -26648,7 +26648,7 @@
           <p:cNvPr id="24" name="">
             <a:extLst xmlns:a="http://schemas.openxmlformats.org/drawingml/2006/main">
               <a:ext uri="{FF2B5EF4-FFF2-40B4-BE49-F238E27FC236}">
-                <a16:creationId xmlns:a16="http://schemas.microsoft.com/office/drawing/2014/main" id="{19871C10-CC46-4E3A-B976-6CE45E31CA77}"/>
+                <a16:creationId xmlns:a16="http://schemas.microsoft.com/office/drawing/2014/main" id="{1A5FB980-ABEC-4EF0-A015-DA8B54DEAB66}"/>
               </a:ext>
             </a:extLst>
           </p:cNvPr>
@@ -26805,7 +26805,7 @@
           <p:cNvPr id="25" name="">
             <a:extLst xmlns:a="http://schemas.openxmlformats.org/drawingml/2006/main">
               <a:ext uri="{FF2B5EF4-FFF2-40B4-BE49-F238E27FC236}">
-                <a16:creationId xmlns:a16="http://schemas.microsoft.com/office/drawing/2014/main" id="{E9B81A57-AF93-4373-9C05-0B378A0C98E9}"/>
+                <a16:creationId xmlns:a16="http://schemas.microsoft.com/office/drawing/2014/main" id="{B21CE6A3-74E1-4504-BB8B-1BF0E0AFFE7A}"/>
               </a:ext>
             </a:extLst>
           </p:cNvPr>
@@ -26952,7 +26952,7 @@
                 <a:ea typeface="Arial"/>
                 <a:cs typeface="Arial"/>
               </a:rPr>
-              <a:t>79 focused tests pass. No live v2 LLM run; tokens / inference latency unavailable.</a:t>
+              <a:t>84 focused tests pass. Recovery router not live-compared; tokens / inference latency unavailable.</a:t>
             </a:r>
           </a:p>
         </p:txBody>
@@ -26960,7 +26960,7 @@
     </p:spTree>
     <p:extLst>
       <p:ext uri="{BB962C8B-B14F-4D97-AF65-F5344CB8AC3E}">
-        <p14:creationId xmlns:p14="http://schemas.microsoft.com/office/powerpoint/2010/main" val="651194943"/>
+        <p14:creationId xmlns:p14="http://schemas.microsoft.com/office/powerpoint/2010/main" val="835441529"/>
       </p:ext>
     </p:extLst>
   </p:cSld>
@@ -26991,7 +26991,7 @@
           <p:cNvPr id="9" name="">
             <a:extLst xmlns:a="http://schemas.openxmlformats.org/drawingml/2006/main">
               <a:ext uri="{FF2B5EF4-FFF2-40B4-BE49-F238E27FC236}">
-                <a16:creationId xmlns:a16="http://schemas.microsoft.com/office/drawing/2014/main" id="{DF89F5EE-E54E-4D09-8764-4626351D8A6A}"/>
+                <a16:creationId xmlns:a16="http://schemas.microsoft.com/office/drawing/2014/main" id="{06C98519-B810-4060-8D6F-14787579A0CF}"/>
               </a:ext>
             </a:extLst>
           </p:cNvPr>
@@ -27148,7 +27148,7 @@
           <p:cNvPr id="2" name="">
             <a:extLst xmlns:a="http://schemas.openxmlformats.org/drawingml/2006/main">
               <a:ext uri="{FF2B5EF4-FFF2-40B4-BE49-F238E27FC236}">
-                <a16:creationId xmlns:a16="http://schemas.microsoft.com/office/drawing/2014/main" id="{8F2E9B25-78AF-4EA1-A402-EC7E4042A029}"/>
+                <a16:creationId xmlns:a16="http://schemas.microsoft.com/office/drawing/2014/main" id="{33A1ED0C-B095-4C3C-8485-B7C82E9FF190}"/>
               </a:ext>
             </a:extLst>
           </p:cNvPr>
@@ -27179,7 +27179,7 @@
           <p:cNvPr id="3" name="">
             <a:extLst xmlns:a="http://schemas.openxmlformats.org/drawingml/2006/main">
               <a:ext uri="{FF2B5EF4-FFF2-40B4-BE49-F238E27FC236}">
-                <a16:creationId xmlns:a16="http://schemas.microsoft.com/office/drawing/2014/main" id="{A9C29A7A-8AC8-45D3-87EC-720AEB8329DB}"/>
+                <a16:creationId xmlns:a16="http://schemas.microsoft.com/office/drawing/2014/main" id="{9F6491AD-7EAA-455C-8C38-BEF7A7C2826C}"/>
               </a:ext>
             </a:extLst>
           </p:cNvPr>
@@ -27336,7 +27336,7 @@
           <p:cNvPr id="4" name="">
             <a:extLst xmlns:a="http://schemas.openxmlformats.org/drawingml/2006/main">
               <a:ext uri="{FF2B5EF4-FFF2-40B4-BE49-F238E27FC236}">
-                <a16:creationId xmlns:a16="http://schemas.microsoft.com/office/drawing/2014/main" id="{DB6BD014-F337-408F-9EA6-05BB67857AE9}"/>
+                <a16:creationId xmlns:a16="http://schemas.microsoft.com/office/drawing/2014/main" id="{8A3BA4E8-B547-4314-A70C-48703529579D}"/>
               </a:ext>
             </a:extLst>
           </p:cNvPr>
@@ -27493,7 +27493,7 @@
           <p:cNvPr id="5" name="">
             <a:extLst xmlns:a="http://schemas.openxmlformats.org/drawingml/2006/main">
               <a:ext uri="{FF2B5EF4-FFF2-40B4-BE49-F238E27FC236}">
-                <a16:creationId xmlns:a16="http://schemas.microsoft.com/office/drawing/2014/main" id="{AFB80D61-A31F-43F5-AA1F-93BEDA76247D}"/>
+                <a16:creationId xmlns:a16="http://schemas.microsoft.com/office/drawing/2014/main" id="{072A4484-A04E-48D9-889D-E2CFAA6403CE}"/>
               </a:ext>
             </a:extLst>
           </p:cNvPr>
@@ -27742,7 +27742,7 @@
           <p:cNvPr id="6" name="">
             <a:extLst xmlns:a="http://schemas.openxmlformats.org/drawingml/2006/main">
               <a:ext uri="{FF2B5EF4-FFF2-40B4-BE49-F238E27FC236}">
-                <a16:creationId xmlns:a16="http://schemas.microsoft.com/office/drawing/2014/main" id="{0DBDA63F-5D17-4C66-8C23-0771D4C28B4A}"/>
+                <a16:creationId xmlns:a16="http://schemas.microsoft.com/office/drawing/2014/main" id="{5AE53EE8-E6D5-4142-B185-D2A1E4AFA31A}"/>
               </a:ext>
             </a:extLst>
           </p:cNvPr>
@@ -27899,7 +27899,7 @@
           <p:cNvPr id="7" name="">
             <a:extLst xmlns:a="http://schemas.openxmlformats.org/drawingml/2006/main">
               <a:ext uri="{FF2B5EF4-FFF2-40B4-BE49-F238E27FC236}">
-                <a16:creationId xmlns:a16="http://schemas.microsoft.com/office/drawing/2014/main" id="{36D64CF6-5447-4903-9B33-C222F5577F89}"/>
+                <a16:creationId xmlns:a16="http://schemas.microsoft.com/office/drawing/2014/main" id="{38F2BEF9-0A12-43E5-8B61-1D67432A3B9D}"/>
               </a:ext>
             </a:extLst>
           </p:cNvPr>
@@ -28148,7 +28148,7 @@
           <p:cNvPr id="8" name="">
             <a:extLst xmlns:a="http://schemas.openxmlformats.org/drawingml/2006/main">
               <a:ext uri="{FF2B5EF4-FFF2-40B4-BE49-F238E27FC236}">
-                <a16:creationId xmlns:a16="http://schemas.microsoft.com/office/drawing/2014/main" id="{D234410C-3F84-4228-ADC1-0E95A5C32778}"/>
+                <a16:creationId xmlns:a16="http://schemas.microsoft.com/office/drawing/2014/main" id="{47DB7026-E3CF-4EAD-A7BF-AEA50967D45F}"/>
               </a:ext>
             </a:extLst>
           </p:cNvPr>
@@ -28303,7 +28303,7 @@
     </p:spTree>
     <p:extLst>
       <p:ext uri="{BB962C8B-B14F-4D97-AF65-F5344CB8AC3E}">
-        <p14:creationId xmlns:p14="http://schemas.microsoft.com/office/powerpoint/2010/main" val="1689300256"/>
+        <p14:creationId xmlns:p14="http://schemas.microsoft.com/office/powerpoint/2010/main" val="518459209"/>
       </p:ext>
     </p:extLst>
   </p:cSld>

</xml_diff>

<commit_message>
Track LLM recovery triggers in experiment exports
</commit_message>
<xml_diff>
--- a/submissions/midterm-2026-10-28/isaforge-midterm-progress-slides-final.pptx
+++ b/submissions/midterm-2026-10-28/isaforge-midterm-progress-slides-final.pptx
@@ -2,23 +2,23 @@
 <file path=ppt/presentation.xml><?xml version="1.0" encoding="utf-8"?>
 <p:presentation xmlns:p="http://schemas.openxmlformats.org/presentationml/2006/main">
   <p:sldMasterIdLst>
-    <p:sldMasterId xmlns:r="http://schemas.openxmlformats.org/officeDocument/2006/relationships" id="2147483648" r:id="R1f42b87f858541ab"/>
+    <p:sldMasterId xmlns:r="http://schemas.openxmlformats.org/officeDocument/2006/relationships" id="2147483648" r:id="R2f2fe622b955439f"/>
   </p:sldMasterIdLst>
   <p:notesMasterIdLst>
-    <p:notesMasterId xmlns:r="http://schemas.openxmlformats.org/officeDocument/2006/relationships" r:id="Rf5bcd90d174a4340"/>
+    <p:notesMasterId xmlns:r="http://schemas.openxmlformats.org/officeDocument/2006/relationships" r:id="R6892db91a4314186"/>
   </p:notesMasterIdLst>
   <p:sldIdLst>
-    <p:sldId xmlns:r="http://schemas.openxmlformats.org/officeDocument/2006/relationships" id="256" r:id="R5f379f32487c46ce"/>
-    <p:sldId xmlns:r="http://schemas.openxmlformats.org/officeDocument/2006/relationships" id="257" r:id="R23d6a3f531684974"/>
-    <p:sldId xmlns:r="http://schemas.openxmlformats.org/officeDocument/2006/relationships" id="258" r:id="R19a7c18fd230477b"/>
-    <p:sldId xmlns:r="http://schemas.openxmlformats.org/officeDocument/2006/relationships" id="259" r:id="R8f2e8abb1cfa4d1a"/>
-    <p:sldId xmlns:r="http://schemas.openxmlformats.org/officeDocument/2006/relationships" id="260" r:id="R3dcfd28e9d014167"/>
-    <p:sldId xmlns:r="http://schemas.openxmlformats.org/officeDocument/2006/relationships" id="261" r:id="R1fa0472dd8b94087"/>
-    <p:sldId xmlns:r="http://schemas.openxmlformats.org/officeDocument/2006/relationships" id="262" r:id="R8b6454466e764d3b"/>
-    <p:sldId xmlns:r="http://schemas.openxmlformats.org/officeDocument/2006/relationships" id="263" r:id="R06a3c9f606b5467f"/>
-    <p:sldId xmlns:r="http://schemas.openxmlformats.org/officeDocument/2006/relationships" id="264" r:id="R61bb36557def4795"/>
-    <p:sldId xmlns:r="http://schemas.openxmlformats.org/officeDocument/2006/relationships" id="265" r:id="Rcb4b4c1450d04142"/>
-    <p:sldId xmlns:r="http://schemas.openxmlformats.org/officeDocument/2006/relationships" id="266" r:id="R44f6c748708a449d"/>
+    <p:sldId xmlns:r="http://schemas.openxmlformats.org/officeDocument/2006/relationships" id="256" r:id="Ra9cbf65510a44413"/>
+    <p:sldId xmlns:r="http://schemas.openxmlformats.org/officeDocument/2006/relationships" id="257" r:id="Rd9560bfcf1094810"/>
+    <p:sldId xmlns:r="http://schemas.openxmlformats.org/officeDocument/2006/relationships" id="258" r:id="R80e0a4fd09e34bbf"/>
+    <p:sldId xmlns:r="http://schemas.openxmlformats.org/officeDocument/2006/relationships" id="259" r:id="R524816de4a494063"/>
+    <p:sldId xmlns:r="http://schemas.openxmlformats.org/officeDocument/2006/relationships" id="260" r:id="R424d32b3132a41c1"/>
+    <p:sldId xmlns:r="http://schemas.openxmlformats.org/officeDocument/2006/relationships" id="261" r:id="Reaf623fd7f2d47eb"/>
+    <p:sldId xmlns:r="http://schemas.openxmlformats.org/officeDocument/2006/relationships" id="262" r:id="R9ba764aa0ed74c0c"/>
+    <p:sldId xmlns:r="http://schemas.openxmlformats.org/officeDocument/2006/relationships" id="263" r:id="Raad54e3354d641dd"/>
+    <p:sldId xmlns:r="http://schemas.openxmlformats.org/officeDocument/2006/relationships" id="264" r:id="R8d78f40814514e74"/>
+    <p:sldId xmlns:r="http://schemas.openxmlformats.org/officeDocument/2006/relationships" id="265" r:id="Rfd63ed1ee63543f2"/>
+    <p:sldId xmlns:r="http://schemas.openxmlformats.org/officeDocument/2006/relationships" id="266" r:id="R45ec89c2e9d54bdd"/>
   </p:sldIdLst>
   <p:sldSz cx="12192000" cy="6858000"/>
   <p:notesSz cx="6858000" cy="9144000"/>
@@ -1302,7 +1302,7 @@
           </a:p>
           <a:p xmlns:a="http://schemas.openxmlformats.org/drawingml/2006/main">
             <a:r>
-              <a:t>isaforge/agent_memory.py: fixed query over unattempted formulas; local TF-IDF/LSA hybrid, RRF k60, top3 source-linked history; not pretrained embeddings or general RAG. Both arms can access full history; retrieval changes ordering/emphasis. Four structured tools; host owns attempt charging and final acceptance. The ranker is not retrained; configured hardware GP can update on paid successes. The live Luna pilot is one archived-data trial per arm with cooperative file restrictions; hybrid used two queries/four turns, no retrieval three queries/nine turns, three rejected finalizations, and both reached 1.0213847x, +50 LUT4, 65.99353 MHz. The heuristic reached the same design in one query. Selector v2 names the incumbent, enforces it at finalize, and returns canonical measured fields separately from unverified agent_summary. Recovery router v2 escalates once after a malformed structured action or an explicit host incumbent correction, under the shared model-call cap; it does not retry measurement or transport failures. 84 focused tests pass; zero live v2 LLM calls or native jobs. No causal memory or superiority claim.</a:t>
+              <a:t>isaforge/agent_memory.py: fixed query over unattempted formulas; local TF-IDF/LSA hybrid, RRF k60, top3 source-linked history; not pretrained embeddings or general RAG. Both arms can access full history; retrieval changes ordering/emphasis. Four structured tools; host owns attempt charging and final acceptance. The ranker is not retrained; configured hardware GP can update on paid successes. The live Luna pilot is one archived-data trial per arm with cooperative file restrictions; hybrid used two queries/four turns, no retrieval three queries/nine turns, three rejected finalizations, and both reached 1.0213847x, +50 LUT4, 65.99353 MHz. The heuristic reached the same design in one query. Selector v2 names the incumbent, enforces it at finalize, and returns canonical measured fields separately from unverified agent_summary. Recovery router v2 escalates once after a malformed structured action or an explicit host incumbent correction, under the shared model-call cap; it does not retry measurement or transport failures. 85 focused tests pass; zero live v2 LLM calls or native jobs. No causal memory or superiority claim.</a:t>
             </a:r>
           </a:p>
         </p:txBody>
@@ -1402,7 +1402,7 @@
           </a:p>
           <a:p xmlns:a="http://schemas.openxmlformats.org/drawingml/2006/main">
             <a:r>
-              <a:t>Tools: isaforge/selection_provider.py strict remote function schemas; isaforge/codex_chat_selector.py interactive JSON bridge. Host: bounded_selector.py. Measure reserves charge before lookup while budget remains. Invalid/repeated attempts count; repeats do not redispatch evaluator. Finalize accepts only the current host-computed best paid feasible improvement; null is allowed only with no improvement. Host returns canonical measured fields; the model text is an unverified agent_summary. Finite model/tool calls, incumbent fallback, fresh output paths; no restart/resume guarantee. Observability: export_agent_observability.py verifies manifest/protocol/ledger hashes and creates releases, episodes, decisions, model_calls, retrievals and tools tables. Raw ledgers authoritative. Live13 turns,4 retrievals; 3 rejected finalizations. Interactive elapsed time includes orchestration; tokens SQLNULL. Remote provider records tokens only if returned. LLMOps here is local versioning, reproducible evaluation and inspection, not production cloud operations. Selector v2 and recovery routing pass 84 focused tests; recovery routing has no live v2 comparison. A 10-policy/30-endpoint SHA256 control replay matches archived trajectories exactly, with zero LLM/native jobs. Retrieval fits are not new speedup model versions.</a:t>
+              <a:t>Tools: isaforge/selection_provider.py strict remote function schemas; isaforge/codex_chat_selector.py interactive JSON bridge. Host: bounded_selector.py. Measure reserves charge before lookup while budget remains. Invalid/repeated attempts count; repeats do not redispatch evaluator. Finalize accepts only the current host-computed best paid feasible improvement; null is allowed only with no improvement. Host returns canonical measured fields; the model text is an unverified agent_summary. Finite model/tool calls, incumbent fallback, fresh output paths; no restart/resume guarantee. Observability: export_agent_observability.py verifies manifest/protocol/ledger hashes and creates releases, episodes, decisions, model_calls, retrievals and tools tables. Raw ledgers authoritative. Live13 turns,4 retrievals; 3 rejected finalizations. Interactive elapsed time includes orchestration; tokens SQLNULL. Remote provider records tokens only if returned. LLMOps here is local versioning, reproducible evaluation and inspection, not production cloud operations. Selector v2 and recovery routing pass 85 focused tests; recovery routing has no live v2 comparison. A 10-policy/30-endpoint SHA256 control replay matches archived trajectories exactly, with zero LLM/native jobs. Retrieval fits are not new speedup model versions.</a:t>
             </a:r>
           </a:p>
         </p:txBody>
@@ -1549,7 +1549,7 @@
           <p:cNvPr id="3" name="Title">
             <a:extLst xmlns:a="http://schemas.openxmlformats.org/drawingml/2006/main">
               <a:ext uri="{FF2B5EF4-FFF2-40B4-BE49-F238E27FC236}">
-                <a16:creationId xmlns:a16="http://schemas.microsoft.com/office/drawing/2014/main" id="{538589F6-52DA-47E3-ACD3-5765685235F0}"/>
+                <a16:creationId xmlns:a16="http://schemas.microsoft.com/office/drawing/2014/main" id="{02A5D707-731C-4270-81AB-71AC129C6BEE}"/>
               </a:ext>
             </a:extLst>
           </p:cNvPr>
@@ -1778,7 +1778,7 @@
           <p:cNvPr id="2" name="Subtitle">
             <a:extLst xmlns:a="http://schemas.openxmlformats.org/drawingml/2006/main">
               <a:ext uri="{FF2B5EF4-FFF2-40B4-BE49-F238E27FC236}">
-                <a16:creationId xmlns:a16="http://schemas.microsoft.com/office/drawing/2014/main" id="{FCB0E82D-8439-43CA-9B0C-363C0DB8CA0F}"/>
+                <a16:creationId xmlns:a16="http://schemas.microsoft.com/office/drawing/2014/main" id="{D74C3DE2-BEAA-47A9-95F9-7180BABBABE1}"/>
               </a:ext>
             </a:extLst>
           </p:cNvPr>
@@ -2024,7 +2024,7 @@
           <p:cNvPr id="2" name="Section title">
             <a:extLst xmlns:a="http://schemas.openxmlformats.org/drawingml/2006/main">
               <a:ext uri="{FF2B5EF4-FFF2-40B4-BE49-F238E27FC236}">
-                <a16:creationId xmlns:a16="http://schemas.microsoft.com/office/drawing/2014/main" id="{977B2C04-8620-482D-ABBC-6B7335C57439}"/>
+                <a16:creationId xmlns:a16="http://schemas.microsoft.com/office/drawing/2014/main" id="{97C3E4B5-E8B8-461F-B639-22691C650E0B}"/>
               </a:ext>
             </a:extLst>
           </p:cNvPr>
@@ -2270,7 +2270,7 @@
           <p:cNvPr id="3" name="Title">
             <a:extLst xmlns:a="http://schemas.openxmlformats.org/drawingml/2006/main">
               <a:ext uri="{FF2B5EF4-FFF2-40B4-BE49-F238E27FC236}">
-                <a16:creationId xmlns:a16="http://schemas.microsoft.com/office/drawing/2014/main" id="{5B419E7E-74D7-4B78-A55A-EA4F1406ABEC}"/>
+                <a16:creationId xmlns:a16="http://schemas.microsoft.com/office/drawing/2014/main" id="{9D36F912-5AC5-46D6-AFBD-166319C06783}"/>
               </a:ext>
             </a:extLst>
           </p:cNvPr>
@@ -2499,7 +2499,7 @@
           <p:cNvPr id="2" name="Body">
             <a:extLst xmlns:a="http://schemas.openxmlformats.org/drawingml/2006/main">
               <a:ext uri="{FF2B5EF4-FFF2-40B4-BE49-F238E27FC236}">
-                <a16:creationId xmlns:a16="http://schemas.microsoft.com/office/drawing/2014/main" id="{2A36EFC5-B10A-442B-8A67-4B51913C3D39}"/>
+                <a16:creationId xmlns:a16="http://schemas.microsoft.com/office/drawing/2014/main" id="{7EF7510A-4905-4AD3-8C2A-2A41065939E7}"/>
               </a:ext>
             </a:extLst>
           </p:cNvPr>
@@ -2745,7 +2745,7 @@
           <p:cNvPr id="4" name="Title">
             <a:extLst xmlns:a="http://schemas.openxmlformats.org/drawingml/2006/main">
               <a:ext uri="{FF2B5EF4-FFF2-40B4-BE49-F238E27FC236}">
-                <a16:creationId xmlns:a16="http://schemas.microsoft.com/office/drawing/2014/main" id="{553B9917-0994-4328-BD0D-8F9A83DFDB94}"/>
+                <a16:creationId xmlns:a16="http://schemas.microsoft.com/office/drawing/2014/main" id="{9B348B42-5B29-4A6F-B7B9-700F519D52C6}"/>
               </a:ext>
             </a:extLst>
           </p:cNvPr>
@@ -2974,7 +2974,7 @@
           <p:cNvPr id="2" name="Left column">
             <a:extLst xmlns:a="http://schemas.openxmlformats.org/drawingml/2006/main">
               <a:ext uri="{FF2B5EF4-FFF2-40B4-BE49-F238E27FC236}">
-                <a16:creationId xmlns:a16="http://schemas.microsoft.com/office/drawing/2014/main" id="{45BF310D-24D6-4167-A3CB-1F88A9063326}"/>
+                <a16:creationId xmlns:a16="http://schemas.microsoft.com/office/drawing/2014/main" id="{48431858-60A5-4784-BAE3-FCC76D61D27B}"/>
               </a:ext>
             </a:extLst>
           </p:cNvPr>
@@ -3203,7 +3203,7 @@
           <p:cNvPr id="3" name="Right column">
             <a:extLst xmlns:a="http://schemas.openxmlformats.org/drawingml/2006/main">
               <a:ext uri="{FF2B5EF4-FFF2-40B4-BE49-F238E27FC236}">
-                <a16:creationId xmlns:a16="http://schemas.microsoft.com/office/drawing/2014/main" id="{FBDB66F8-FDAC-4DD5-A2FB-A9A1A94DB670}"/>
+                <a16:creationId xmlns:a16="http://schemas.microsoft.com/office/drawing/2014/main" id="{8E26364B-5A8D-46A6-8444-859E76DA1BE6}"/>
               </a:ext>
             </a:extLst>
           </p:cNvPr>
@@ -3449,7 +3449,7 @@
           <p:cNvPr id="3" name="Title">
             <a:extLst xmlns:a="http://schemas.openxmlformats.org/drawingml/2006/main">
               <a:ext uri="{FF2B5EF4-FFF2-40B4-BE49-F238E27FC236}">
-                <a16:creationId xmlns:a16="http://schemas.microsoft.com/office/drawing/2014/main" id="{097D22EE-6814-4001-965E-B825BBBFB70A}"/>
+                <a16:creationId xmlns:a16="http://schemas.microsoft.com/office/drawing/2014/main" id="{9AEDA0A7-64EB-4F85-9339-B797F16A22FF}"/>
               </a:ext>
             </a:extLst>
           </p:cNvPr>
@@ -3678,7 +3678,7 @@
           <p:cNvPr id="2" name="Left column">
             <a:extLst xmlns:a="http://schemas.openxmlformats.org/drawingml/2006/main">
               <a:ext uri="{FF2B5EF4-FFF2-40B4-BE49-F238E27FC236}">
-                <a16:creationId xmlns:a16="http://schemas.microsoft.com/office/drawing/2014/main" id="{C946CF09-8FD2-4793-93AD-0CF1045E1453}"/>
+                <a16:creationId xmlns:a16="http://schemas.microsoft.com/office/drawing/2014/main" id="{3B9AAE31-7788-494E-9C20-7257D05B653A}"/>
               </a:ext>
             </a:extLst>
           </p:cNvPr>
@@ -3945,12 +3945,12 @@
   </p:cSld>
   <p:clrMap bg1="lt1" tx1="dk1" bg2="lt2" tx2="dk2" accent1="accent1" accent2="accent2" accent3="accent3" accent4="accent4" accent5="accent5" accent6="accent6" hlink="hlink" folHlink="folHlink"/>
   <p:sldLayoutIdLst>
-    <p:sldLayoutId xmlns:r="http://schemas.openxmlformats.org/officeDocument/2006/relationships" id="2147483649" r:id="Rd6fc4cee12d24a3c"/>
-    <p:sldLayoutId xmlns:r="http://schemas.openxmlformats.org/officeDocument/2006/relationships" id="2147483650" r:id="R67a4aec8172349d3"/>
-    <p:sldLayoutId xmlns:r="http://schemas.openxmlformats.org/officeDocument/2006/relationships" id="2147483651" r:id="Ra5b94f3ca74a4869"/>
-    <p:sldLayoutId xmlns:r="http://schemas.openxmlformats.org/officeDocument/2006/relationships" id="2147483652" r:id="R0e2572e4926d4022"/>
-    <p:sldLayoutId xmlns:r="http://schemas.openxmlformats.org/officeDocument/2006/relationships" id="2147483653" r:id="R177a607d607542a1"/>
-    <p:sldLayoutId xmlns:r="http://schemas.openxmlformats.org/officeDocument/2006/relationships" id="2147483654" r:id="R3abf34b303a14775"/>
+    <p:sldLayoutId xmlns:r="http://schemas.openxmlformats.org/officeDocument/2006/relationships" id="2147483649" r:id="R9a4ee8671c454c73"/>
+    <p:sldLayoutId xmlns:r="http://schemas.openxmlformats.org/officeDocument/2006/relationships" id="2147483650" r:id="R4df5edfc5caa454f"/>
+    <p:sldLayoutId xmlns:r="http://schemas.openxmlformats.org/officeDocument/2006/relationships" id="2147483651" r:id="R470f8fe465514899"/>
+    <p:sldLayoutId xmlns:r="http://schemas.openxmlformats.org/officeDocument/2006/relationships" id="2147483652" r:id="R342b4f2e0fe34740"/>
+    <p:sldLayoutId xmlns:r="http://schemas.openxmlformats.org/officeDocument/2006/relationships" id="2147483653" r:id="Re5b114cd3271425c"/>
+    <p:sldLayoutId xmlns:r="http://schemas.openxmlformats.org/officeDocument/2006/relationships" id="2147483654" r:id="Ra73379075bc24063"/>
   </p:sldLayoutIdLst>
   <p:txStyles>
     <p:titleStyle>
@@ -5273,7 +5273,7 @@
           <p:cNvPr id="8" name="">
             <a:extLst xmlns:a="http://schemas.openxmlformats.org/drawingml/2006/main">
               <a:ext uri="{FF2B5EF4-FFF2-40B4-BE49-F238E27FC236}">
-                <a16:creationId xmlns:a16="http://schemas.microsoft.com/office/drawing/2014/main" id="{DB6F0F5B-E92B-40BD-9EE0-DF6574ED011D}"/>
+                <a16:creationId xmlns:a16="http://schemas.microsoft.com/office/drawing/2014/main" id="{593A8740-232C-4AB0-8B6E-11D9EDDBE653}"/>
               </a:ext>
             </a:extLst>
           </p:cNvPr>
@@ -5430,7 +5430,7 @@
           <p:cNvPr id="2" name="">
             <a:extLst xmlns:a="http://schemas.openxmlformats.org/drawingml/2006/main">
               <a:ext uri="{FF2B5EF4-FFF2-40B4-BE49-F238E27FC236}">
-                <a16:creationId xmlns:a16="http://schemas.microsoft.com/office/drawing/2014/main" id="{287B79C4-1156-46D3-ACDD-280F8308B547}"/>
+                <a16:creationId xmlns:a16="http://schemas.microsoft.com/office/drawing/2014/main" id="{35418C62-C698-4C29-9085-DF852DCF21C6}"/>
               </a:ext>
             </a:extLst>
           </p:cNvPr>
@@ -5461,7 +5461,7 @@
           <p:cNvPr id="3" name="">
             <a:extLst xmlns:a="http://schemas.openxmlformats.org/drawingml/2006/main">
               <a:ext uri="{FF2B5EF4-FFF2-40B4-BE49-F238E27FC236}">
-                <a16:creationId xmlns:a16="http://schemas.microsoft.com/office/drawing/2014/main" id="{D306E147-C3D0-4FC9-BD08-AF28F3803598}"/>
+                <a16:creationId xmlns:a16="http://schemas.microsoft.com/office/drawing/2014/main" id="{3F670D1E-3042-45EF-A20C-F76E07B349D4}"/>
               </a:ext>
             </a:extLst>
           </p:cNvPr>
@@ -5618,7 +5618,7 @@
           <p:cNvPr id="4" name="">
             <a:extLst xmlns:a="http://schemas.openxmlformats.org/drawingml/2006/main">
               <a:ext uri="{FF2B5EF4-FFF2-40B4-BE49-F238E27FC236}">
-                <a16:creationId xmlns:a16="http://schemas.microsoft.com/office/drawing/2014/main" id="{EFB1C53D-E0FA-4FB8-9072-734474BAB250}"/>
+                <a16:creationId xmlns:a16="http://schemas.microsoft.com/office/drawing/2014/main" id="{7E0E3432-890D-4799-8A7B-B3A71A3343A7}"/>
               </a:ext>
             </a:extLst>
           </p:cNvPr>
@@ -5775,7 +5775,7 @@
           <p:cNvPr id="5" name="">
             <a:extLst xmlns:a="http://schemas.openxmlformats.org/drawingml/2006/main">
               <a:ext uri="{FF2B5EF4-FFF2-40B4-BE49-F238E27FC236}">
-                <a16:creationId xmlns:a16="http://schemas.microsoft.com/office/drawing/2014/main" id="{5B58B7E2-C818-491D-B935-6D62640434FB}"/>
+                <a16:creationId xmlns:a16="http://schemas.microsoft.com/office/drawing/2014/main" id="{433C4DC2-7498-4407-915E-7901EB0BF232}"/>
               </a:ext>
             </a:extLst>
           </p:cNvPr>
@@ -5955,7 +5955,7 @@
           <p:cNvPr id="6" name="">
             <a:extLst xmlns:a="http://schemas.openxmlformats.org/drawingml/2006/main">
               <a:ext uri="{FF2B5EF4-FFF2-40B4-BE49-F238E27FC236}">
-                <a16:creationId xmlns:a16="http://schemas.microsoft.com/office/drawing/2014/main" id="{D93E4776-929E-4531-9468-AFD924A077CC}"/>
+                <a16:creationId xmlns:a16="http://schemas.microsoft.com/office/drawing/2014/main" id="{BB3FF136-F131-42F3-A8E2-0EAFD76FDCDE}"/>
               </a:ext>
             </a:extLst>
           </p:cNvPr>
@@ -6112,7 +6112,7 @@
           <p:cNvPr id="7" name="">
             <a:extLst xmlns:a="http://schemas.openxmlformats.org/drawingml/2006/main">
               <a:ext uri="{FF2B5EF4-FFF2-40B4-BE49-F238E27FC236}">
-                <a16:creationId xmlns:a16="http://schemas.microsoft.com/office/drawing/2014/main" id="{1F430FDF-557D-4231-8FFA-4D06FE714F02}"/>
+                <a16:creationId xmlns:a16="http://schemas.microsoft.com/office/drawing/2014/main" id="{E519F94B-9EF8-4EAB-B507-542EFE2F23D5}"/>
               </a:ext>
             </a:extLst>
           </p:cNvPr>
@@ -6267,7 +6267,7 @@
     </p:spTree>
     <p:extLst>
       <p:ext uri="{BB962C8B-B14F-4D97-AF65-F5344CB8AC3E}">
-        <p14:creationId xmlns:p14="http://schemas.microsoft.com/office/powerpoint/2010/main" val="1395172699"/>
+        <p14:creationId xmlns:p14="http://schemas.microsoft.com/office/powerpoint/2010/main" val="68093082"/>
       </p:ext>
     </p:extLst>
   </p:cSld>
@@ -6298,7 +6298,7 @@
           <p:cNvPr id="9" name="">
             <a:extLst xmlns:a="http://schemas.openxmlformats.org/drawingml/2006/main">
               <a:ext uri="{FF2B5EF4-FFF2-40B4-BE49-F238E27FC236}">
-                <a16:creationId xmlns:a16="http://schemas.microsoft.com/office/drawing/2014/main" id="{2B3ABDBC-9D3A-4C00-9ED7-4A4578502237}"/>
+                <a16:creationId xmlns:a16="http://schemas.microsoft.com/office/drawing/2014/main" id="{9BDADCA8-01CE-42BC-A172-449F51C600D2}"/>
               </a:ext>
             </a:extLst>
           </p:cNvPr>
@@ -6455,7 +6455,7 @@
           <p:cNvPr id="2" name="">
             <a:extLst xmlns:a="http://schemas.openxmlformats.org/drawingml/2006/main">
               <a:ext uri="{FF2B5EF4-FFF2-40B4-BE49-F238E27FC236}">
-                <a16:creationId xmlns:a16="http://schemas.microsoft.com/office/drawing/2014/main" id="{9C1DF459-95DA-4DF2-BA86-ACC1490E809C}"/>
+                <a16:creationId xmlns:a16="http://schemas.microsoft.com/office/drawing/2014/main" id="{AEA828AC-61BC-43A1-8804-F1D7BE562DE9}"/>
               </a:ext>
             </a:extLst>
           </p:cNvPr>
@@ -6486,7 +6486,7 @@
           <p:cNvPr id="3" name="">
             <a:extLst xmlns:a="http://schemas.openxmlformats.org/drawingml/2006/main">
               <a:ext uri="{FF2B5EF4-FFF2-40B4-BE49-F238E27FC236}">
-                <a16:creationId xmlns:a16="http://schemas.microsoft.com/office/drawing/2014/main" id="{C3FC5D79-D8DF-49E5-A585-D48C86335620}"/>
+                <a16:creationId xmlns:a16="http://schemas.microsoft.com/office/drawing/2014/main" id="{4BCF1AF6-BBC0-4C69-9334-7171F479207C}"/>
               </a:ext>
             </a:extLst>
           </p:cNvPr>
@@ -6643,7 +6643,7 @@
           <p:cNvPr id="4" name="Chart">
             <a:extLst xmlns:a="http://schemas.openxmlformats.org/drawingml/2006/main">
               <a:ext uri="{FF2B5EF4-FFF2-40B4-BE49-F238E27FC236}">
-                <a16:creationId xmlns:a16="http://schemas.microsoft.com/office/drawing/2014/main" id="{75F2B8EF-DC6C-49B8-804B-EA4D166BCFD2}"/>
+                <a16:creationId xmlns:a16="http://schemas.microsoft.com/office/drawing/2014/main" id="{3FBBB7F6-1913-4C62-9761-9FE52B593CD4}"/>
               </a:ext>
             </a:extLst>
           </p:cNvPr>
@@ -6656,7 +6656,7 @@
         </p:xfrm>
         <a:graphic xmlns:a="http://schemas.openxmlformats.org/drawingml/2006/main">
           <a:graphicData uri="http://schemas.openxmlformats.org/drawingml/2006/chart">
-            <c:chart xmlns:r="http://schemas.openxmlformats.org/officeDocument/2006/relationships" xmlns:c="http://schemas.openxmlformats.org/drawingml/2006/chart" r:id="Rb906a647000944f8"/>
+            <c:chart xmlns:r="http://schemas.openxmlformats.org/officeDocument/2006/relationships" xmlns:c="http://schemas.openxmlformats.org/drawingml/2006/chart" r:id="Rc2697f6538db4618"/>
           </a:graphicData>
         </a:graphic>
       </p:graphicFrame>
@@ -6665,7 +6665,7 @@
           <p:cNvPr id="5" name="">
             <a:extLst xmlns:a="http://schemas.openxmlformats.org/drawingml/2006/main">
               <a:ext uri="{FF2B5EF4-FFF2-40B4-BE49-F238E27FC236}">
-                <a16:creationId xmlns:a16="http://schemas.microsoft.com/office/drawing/2014/main" id="{7F8ADDF5-E394-45A0-807D-C39CBB86B5A9}"/>
+                <a16:creationId xmlns:a16="http://schemas.microsoft.com/office/drawing/2014/main" id="{181D4887-6E0A-4100-9CBB-DE36ADD8FB88}"/>
               </a:ext>
             </a:extLst>
           </p:cNvPr>
@@ -6822,7 +6822,7 @@
           <p:cNvPr id="6" name="">
             <a:extLst xmlns:a="http://schemas.openxmlformats.org/drawingml/2006/main">
               <a:ext uri="{FF2B5EF4-FFF2-40B4-BE49-F238E27FC236}">
-                <a16:creationId xmlns:a16="http://schemas.microsoft.com/office/drawing/2014/main" id="{F4D167B5-1895-4D3B-B150-ADC1562725CD}"/>
+                <a16:creationId xmlns:a16="http://schemas.microsoft.com/office/drawing/2014/main" id="{7240FD18-FCB8-41F6-9030-A9A95EF29481}"/>
               </a:ext>
             </a:extLst>
           </p:cNvPr>
@@ -7053,7 +7053,7 @@
           <p:cNvPr id="7" name="">
             <a:extLst xmlns:a="http://schemas.openxmlformats.org/drawingml/2006/main">
               <a:ext uri="{FF2B5EF4-FFF2-40B4-BE49-F238E27FC236}">
-                <a16:creationId xmlns:a16="http://schemas.microsoft.com/office/drawing/2014/main" id="{1A346A80-E56D-412B-A205-531B18D61836}"/>
+                <a16:creationId xmlns:a16="http://schemas.microsoft.com/office/drawing/2014/main" id="{DBB40BB8-4866-456E-A5FD-16913D61DAF6}"/>
               </a:ext>
             </a:extLst>
           </p:cNvPr>
@@ -7233,7 +7233,7 @@
           <p:cNvPr id="8" name="">
             <a:extLst xmlns:a="http://schemas.openxmlformats.org/drawingml/2006/main">
               <a:ext uri="{FF2B5EF4-FFF2-40B4-BE49-F238E27FC236}">
-                <a16:creationId xmlns:a16="http://schemas.microsoft.com/office/drawing/2014/main" id="{F8DB59C3-DE35-41EB-8905-951723077170}"/>
+                <a16:creationId xmlns:a16="http://schemas.microsoft.com/office/drawing/2014/main" id="{50F34527-1497-412B-8EB0-DB39F8F2CBBC}"/>
               </a:ext>
             </a:extLst>
           </p:cNvPr>
@@ -7388,7 +7388,7 @@
     </p:spTree>
     <p:extLst>
       <p:ext uri="{BB962C8B-B14F-4D97-AF65-F5344CB8AC3E}">
-        <p14:creationId xmlns:p14="http://schemas.microsoft.com/office/powerpoint/2010/main" val="1898035131"/>
+        <p14:creationId xmlns:p14="http://schemas.microsoft.com/office/powerpoint/2010/main" val="2048910533"/>
       </p:ext>
     </p:extLst>
   </p:cSld>
@@ -7419,7 +7419,7 @@
           <p:cNvPr id="9" name="">
             <a:extLst xmlns:a="http://schemas.openxmlformats.org/drawingml/2006/main">
               <a:ext uri="{FF2B5EF4-FFF2-40B4-BE49-F238E27FC236}">
-                <a16:creationId xmlns:a16="http://schemas.microsoft.com/office/drawing/2014/main" id="{2BF8C18B-6BD5-4074-A765-A0B60183F8EF}"/>
+                <a16:creationId xmlns:a16="http://schemas.microsoft.com/office/drawing/2014/main" id="{B6B8FDFF-F45A-4078-BBE9-68864F1C53E3}"/>
               </a:ext>
             </a:extLst>
           </p:cNvPr>
@@ -7576,7 +7576,7 @@
           <p:cNvPr id="2" name="">
             <a:extLst xmlns:a="http://schemas.openxmlformats.org/drawingml/2006/main">
               <a:ext uri="{FF2B5EF4-FFF2-40B4-BE49-F238E27FC236}">
-                <a16:creationId xmlns:a16="http://schemas.microsoft.com/office/drawing/2014/main" id="{B427115C-CED6-468D-BCBE-3EA46C1BE4A8}"/>
+                <a16:creationId xmlns:a16="http://schemas.microsoft.com/office/drawing/2014/main" id="{E947A855-00CA-4700-8B15-67467E736DBA}"/>
               </a:ext>
             </a:extLst>
           </p:cNvPr>
@@ -7607,7 +7607,7 @@
           <p:cNvPr id="3" name="">
             <a:extLst xmlns:a="http://schemas.openxmlformats.org/drawingml/2006/main">
               <a:ext uri="{FF2B5EF4-FFF2-40B4-BE49-F238E27FC236}">
-                <a16:creationId xmlns:a16="http://schemas.microsoft.com/office/drawing/2014/main" id="{0710392D-E7DA-466F-B0EC-936E8D0ABD4A}"/>
+                <a16:creationId xmlns:a16="http://schemas.microsoft.com/office/drawing/2014/main" id="{99E79FBE-E3FE-4F3D-B7F1-39525F1520EC}"/>
               </a:ext>
             </a:extLst>
           </p:cNvPr>
@@ -7764,7 +7764,7 @@
           <p:cNvPr id="4" name="">
             <a:extLst xmlns:a="http://schemas.openxmlformats.org/drawingml/2006/main">
               <a:ext uri="{FF2B5EF4-FFF2-40B4-BE49-F238E27FC236}">
-                <a16:creationId xmlns:a16="http://schemas.microsoft.com/office/drawing/2014/main" id="{AF7D0A78-ED95-4238-B85C-2297CC0CC55B}"/>
+                <a16:creationId xmlns:a16="http://schemas.microsoft.com/office/drawing/2014/main" id="{913B0013-5BC2-4657-8AAA-F35E542874D5}"/>
               </a:ext>
             </a:extLst>
           </p:cNvPr>
@@ -7921,7 +7921,7 @@
           <p:cNvPr id="5" name="">
             <a:extLst xmlns:a="http://schemas.openxmlformats.org/drawingml/2006/main">
               <a:ext uri="{FF2B5EF4-FFF2-40B4-BE49-F238E27FC236}">
-                <a16:creationId xmlns:a16="http://schemas.microsoft.com/office/drawing/2014/main" id="{A9459BA6-5874-4AA6-956E-2D151F00797D}"/>
+                <a16:creationId xmlns:a16="http://schemas.microsoft.com/office/drawing/2014/main" id="{256B37BD-BEBC-4E42-8313-01405D461DE2}"/>
               </a:ext>
             </a:extLst>
           </p:cNvPr>
@@ -8147,7 +8147,7 @@
           <p:cNvPr id="6" name="">
             <a:extLst xmlns:a="http://schemas.openxmlformats.org/drawingml/2006/main">
               <a:ext uri="{FF2B5EF4-FFF2-40B4-BE49-F238E27FC236}">
-                <a16:creationId xmlns:a16="http://schemas.microsoft.com/office/drawing/2014/main" id="{4E3EAEF0-C220-4D00-9F7B-F43924D0DFF6}"/>
+                <a16:creationId xmlns:a16="http://schemas.microsoft.com/office/drawing/2014/main" id="{4FDC071E-C515-4025-99FB-39660D8774CF}"/>
               </a:ext>
             </a:extLst>
           </p:cNvPr>
@@ -8304,7 +8304,7 @@
           <p:cNvPr id="7" name="">
             <a:extLst xmlns:a="http://schemas.openxmlformats.org/drawingml/2006/main">
               <a:ext uri="{FF2B5EF4-FFF2-40B4-BE49-F238E27FC236}">
-                <a16:creationId xmlns:a16="http://schemas.microsoft.com/office/drawing/2014/main" id="{1F7E5FAC-6B28-43B7-B5AA-B4B90FD50356}"/>
+                <a16:creationId xmlns:a16="http://schemas.microsoft.com/office/drawing/2014/main" id="{1B52FD89-8C28-420E-AB5B-44C06F5A2DC8}"/>
               </a:ext>
             </a:extLst>
           </p:cNvPr>
@@ -8530,7 +8530,7 @@
           <p:cNvPr id="8" name="">
             <a:extLst xmlns:a="http://schemas.openxmlformats.org/drawingml/2006/main">
               <a:ext uri="{FF2B5EF4-FFF2-40B4-BE49-F238E27FC236}">
-                <a16:creationId xmlns:a16="http://schemas.microsoft.com/office/drawing/2014/main" id="{69A02A47-E8FA-410D-8089-679CCE6E8ADC}"/>
+                <a16:creationId xmlns:a16="http://schemas.microsoft.com/office/drawing/2014/main" id="{7D57A3CB-F1E6-479F-ADBF-6FE95DCC7201}"/>
               </a:ext>
             </a:extLst>
           </p:cNvPr>
@@ -8685,7 +8685,7 @@
     </p:spTree>
     <p:extLst>
       <p:ext uri="{BB962C8B-B14F-4D97-AF65-F5344CB8AC3E}">
-        <p14:creationId xmlns:p14="http://schemas.microsoft.com/office/powerpoint/2010/main" val="1199632463"/>
+        <p14:creationId xmlns:p14="http://schemas.microsoft.com/office/powerpoint/2010/main" val="652966469"/>
       </p:ext>
     </p:extLst>
   </p:cSld>
@@ -8716,7 +8716,7 @@
           <p:cNvPr id="20" name="">
             <a:extLst xmlns:a="http://schemas.openxmlformats.org/drawingml/2006/main">
               <a:ext uri="{FF2B5EF4-FFF2-40B4-BE49-F238E27FC236}">
-                <a16:creationId xmlns:a16="http://schemas.microsoft.com/office/drawing/2014/main" id="{56C58C9C-8380-4AFC-9D5A-62838D165B2B}"/>
+                <a16:creationId xmlns:a16="http://schemas.microsoft.com/office/drawing/2014/main" id="{42804773-E544-45E0-8563-852BC4298967}"/>
               </a:ext>
             </a:extLst>
           </p:cNvPr>
@@ -8873,7 +8873,7 @@
           <p:cNvPr id="2" name="">
             <a:extLst xmlns:a="http://schemas.openxmlformats.org/drawingml/2006/main">
               <a:ext uri="{FF2B5EF4-FFF2-40B4-BE49-F238E27FC236}">
-                <a16:creationId xmlns:a16="http://schemas.microsoft.com/office/drawing/2014/main" id="{A9D20C09-79DA-43CD-9405-99937E3B9B84}"/>
+                <a16:creationId xmlns:a16="http://schemas.microsoft.com/office/drawing/2014/main" id="{1A109BD2-B2BB-4077-A6E7-182EA4932558}"/>
               </a:ext>
             </a:extLst>
           </p:cNvPr>
@@ -8904,7 +8904,7 @@
           <p:cNvPr id="3" name="">
             <a:extLst xmlns:a="http://schemas.openxmlformats.org/drawingml/2006/main">
               <a:ext uri="{FF2B5EF4-FFF2-40B4-BE49-F238E27FC236}">
-                <a16:creationId xmlns:a16="http://schemas.microsoft.com/office/drawing/2014/main" id="{ABC5AA38-DA3C-49F3-9034-A924C31BA43E}"/>
+                <a16:creationId xmlns:a16="http://schemas.microsoft.com/office/drawing/2014/main" id="{A51F4E43-CA65-4164-8781-AEC27527C8DD}"/>
               </a:ext>
             </a:extLst>
           </p:cNvPr>
@@ -9061,7 +9061,7 @@
           <p:cNvPr id="4" name="">
             <a:extLst xmlns:a="http://schemas.openxmlformats.org/drawingml/2006/main">
               <a:ext uri="{FF2B5EF4-FFF2-40B4-BE49-F238E27FC236}">
-                <a16:creationId xmlns:a16="http://schemas.microsoft.com/office/drawing/2014/main" id="{B6ECC990-ACEB-4072-AB4B-A0049173027B}"/>
+                <a16:creationId xmlns:a16="http://schemas.microsoft.com/office/drawing/2014/main" id="{0488B218-CF12-49E7-813E-09CA75454B52}"/>
               </a:ext>
             </a:extLst>
           </p:cNvPr>
@@ -9218,7 +9218,7 @@
           <p:cNvPr id="5" name="">
             <a:extLst xmlns:a="http://schemas.openxmlformats.org/drawingml/2006/main">
               <a:ext uri="{FF2B5EF4-FFF2-40B4-BE49-F238E27FC236}">
-                <a16:creationId xmlns:a16="http://schemas.microsoft.com/office/drawing/2014/main" id="{283B1131-C811-427F-AF11-A2279C22D604}"/>
+                <a16:creationId xmlns:a16="http://schemas.microsoft.com/office/drawing/2014/main" id="{0C628356-912B-446D-B3AD-8F5F33CCF954}"/>
               </a:ext>
             </a:extLst>
           </p:cNvPr>
@@ -9375,7 +9375,7 @@
           <p:cNvPr id="6" name="">
             <a:extLst xmlns:a="http://schemas.openxmlformats.org/drawingml/2006/main">
               <a:ext uri="{FF2B5EF4-FFF2-40B4-BE49-F238E27FC236}">
-                <a16:creationId xmlns:a16="http://schemas.microsoft.com/office/drawing/2014/main" id="{83B8EDE1-FDEF-40DC-9832-93C1E4257C20}"/>
+                <a16:creationId xmlns:a16="http://schemas.microsoft.com/office/drawing/2014/main" id="{951067F1-E085-4030-B030-72A9C998D622}"/>
               </a:ext>
             </a:extLst>
           </p:cNvPr>
@@ -9532,7 +9532,7 @@
           <p:cNvPr id="7" name="">
             <a:extLst xmlns:a="http://schemas.openxmlformats.org/drawingml/2006/main">
               <a:ext uri="{FF2B5EF4-FFF2-40B4-BE49-F238E27FC236}">
-                <a16:creationId xmlns:a16="http://schemas.microsoft.com/office/drawing/2014/main" id="{5A99FE21-5CC8-4E52-8277-74A849F7B051}"/>
+                <a16:creationId xmlns:a16="http://schemas.microsoft.com/office/drawing/2014/main" id="{44503C4B-5E3C-451C-B818-369DF546C403}"/>
               </a:ext>
             </a:extLst>
           </p:cNvPr>
@@ -9563,7 +9563,7 @@
           <p:cNvPr id="8" name="">
             <a:extLst xmlns:a="http://schemas.openxmlformats.org/drawingml/2006/main">
               <a:ext uri="{FF2B5EF4-FFF2-40B4-BE49-F238E27FC236}">
-                <a16:creationId xmlns:a16="http://schemas.microsoft.com/office/drawing/2014/main" id="{2BD6ECE7-BEDB-45F5-B447-3CA009E083D1}"/>
+                <a16:creationId xmlns:a16="http://schemas.microsoft.com/office/drawing/2014/main" id="{174C8B4B-FAEB-40D2-885F-8A2F8DE5EC02}"/>
               </a:ext>
             </a:extLst>
           </p:cNvPr>
@@ -9720,7 +9720,7 @@
           <p:cNvPr id="9" name="">
             <a:extLst xmlns:a="http://schemas.openxmlformats.org/drawingml/2006/main">
               <a:ext uri="{FF2B5EF4-FFF2-40B4-BE49-F238E27FC236}">
-                <a16:creationId xmlns:a16="http://schemas.microsoft.com/office/drawing/2014/main" id="{8A5AEFDF-7D2D-42C6-922C-A31812E15636}"/>
+                <a16:creationId xmlns:a16="http://schemas.microsoft.com/office/drawing/2014/main" id="{EDA744E5-073D-4894-A1E0-CA1207D9E043}"/>
               </a:ext>
             </a:extLst>
           </p:cNvPr>
@@ -9877,7 +9877,7 @@
           <p:cNvPr id="10" name="">
             <a:extLst xmlns:a="http://schemas.openxmlformats.org/drawingml/2006/main">
               <a:ext uri="{FF2B5EF4-FFF2-40B4-BE49-F238E27FC236}">
-                <a16:creationId xmlns:a16="http://schemas.microsoft.com/office/drawing/2014/main" id="{916D3FBE-A7F8-45EA-9300-2AB986C4D76F}"/>
+                <a16:creationId xmlns:a16="http://schemas.microsoft.com/office/drawing/2014/main" id="{BDFDF02B-BFFA-465A-B1B6-7F8C53686980}"/>
               </a:ext>
             </a:extLst>
           </p:cNvPr>
@@ -10034,7 +10034,7 @@
           <p:cNvPr id="11" name="">
             <a:extLst xmlns:a="http://schemas.openxmlformats.org/drawingml/2006/main">
               <a:ext uri="{FF2B5EF4-FFF2-40B4-BE49-F238E27FC236}">
-                <a16:creationId xmlns:a16="http://schemas.microsoft.com/office/drawing/2014/main" id="{2970E9CC-E5BD-430B-B940-19E4D9EFAE2D}"/>
+                <a16:creationId xmlns:a16="http://schemas.microsoft.com/office/drawing/2014/main" id="{044349D3-CF85-4227-89EC-AD7A8450D8ED}"/>
               </a:ext>
             </a:extLst>
           </p:cNvPr>
@@ -10065,7 +10065,7 @@
           <p:cNvPr id="12" name="">
             <a:extLst xmlns:a="http://schemas.openxmlformats.org/drawingml/2006/main">
               <a:ext uri="{FF2B5EF4-FFF2-40B4-BE49-F238E27FC236}">
-                <a16:creationId xmlns:a16="http://schemas.microsoft.com/office/drawing/2014/main" id="{432863A8-E251-4068-A8D4-B4717227038E}"/>
+                <a16:creationId xmlns:a16="http://schemas.microsoft.com/office/drawing/2014/main" id="{C5DC581A-541E-4DC9-AF7C-9835390A68B7}"/>
               </a:ext>
             </a:extLst>
           </p:cNvPr>
@@ -10222,7 +10222,7 @@
           <p:cNvPr id="13" name="">
             <a:extLst xmlns:a="http://schemas.openxmlformats.org/drawingml/2006/main">
               <a:ext uri="{FF2B5EF4-FFF2-40B4-BE49-F238E27FC236}">
-                <a16:creationId xmlns:a16="http://schemas.microsoft.com/office/drawing/2014/main" id="{80D94ACF-A948-4B40-BF15-795453EACEBA}"/>
+                <a16:creationId xmlns:a16="http://schemas.microsoft.com/office/drawing/2014/main" id="{7868C03F-CE97-459C-8908-6E18BF4579D0}"/>
               </a:ext>
             </a:extLst>
           </p:cNvPr>
@@ -10379,7 +10379,7 @@
           <p:cNvPr id="14" name="">
             <a:extLst xmlns:a="http://schemas.openxmlformats.org/drawingml/2006/main">
               <a:ext uri="{FF2B5EF4-FFF2-40B4-BE49-F238E27FC236}">
-                <a16:creationId xmlns:a16="http://schemas.microsoft.com/office/drawing/2014/main" id="{5D10F5F1-D0CB-46AC-9FFD-A3B52B2B54D5}"/>
+                <a16:creationId xmlns:a16="http://schemas.microsoft.com/office/drawing/2014/main" id="{66444897-A374-4D89-9DE6-FA7057EAFA14}"/>
               </a:ext>
             </a:extLst>
           </p:cNvPr>
@@ -10536,7 +10536,7 @@
           <p:cNvPr id="15" name="">
             <a:extLst xmlns:a="http://schemas.openxmlformats.org/drawingml/2006/main">
               <a:ext uri="{FF2B5EF4-FFF2-40B4-BE49-F238E27FC236}">
-                <a16:creationId xmlns:a16="http://schemas.microsoft.com/office/drawing/2014/main" id="{1AA7CCF2-735F-4BE2-B48F-0EDF710BF476}"/>
+                <a16:creationId xmlns:a16="http://schemas.microsoft.com/office/drawing/2014/main" id="{B64C849B-59E9-4FC6-8F20-9A9A9D33742B}"/>
               </a:ext>
             </a:extLst>
           </p:cNvPr>
@@ -10567,7 +10567,7 @@
           <p:cNvPr id="16" name="">
             <a:extLst xmlns:a="http://schemas.openxmlformats.org/drawingml/2006/main">
               <a:ext uri="{FF2B5EF4-FFF2-40B4-BE49-F238E27FC236}">
-                <a16:creationId xmlns:a16="http://schemas.microsoft.com/office/drawing/2014/main" id="{1897E889-81A7-4CFE-9A66-6F1FB1A0AB69}"/>
+                <a16:creationId xmlns:a16="http://schemas.microsoft.com/office/drawing/2014/main" id="{E610B4E3-3043-45B2-9EAD-CE8D98755E69}"/>
               </a:ext>
             </a:extLst>
           </p:cNvPr>
@@ -10724,7 +10724,7 @@
           <p:cNvPr id="17" name="">
             <a:extLst xmlns:a="http://schemas.openxmlformats.org/drawingml/2006/main">
               <a:ext uri="{FF2B5EF4-FFF2-40B4-BE49-F238E27FC236}">
-                <a16:creationId xmlns:a16="http://schemas.microsoft.com/office/drawing/2014/main" id="{379B058D-7B69-465A-9660-E5DA5C16F3EA}"/>
+                <a16:creationId xmlns:a16="http://schemas.microsoft.com/office/drawing/2014/main" id="{B846F2EC-0913-4A51-B4F7-5206683F4EC5}"/>
               </a:ext>
             </a:extLst>
           </p:cNvPr>
@@ -10881,7 +10881,7 @@
           <p:cNvPr id="18" name="">
             <a:extLst xmlns:a="http://schemas.openxmlformats.org/drawingml/2006/main">
               <a:ext uri="{FF2B5EF4-FFF2-40B4-BE49-F238E27FC236}">
-                <a16:creationId xmlns:a16="http://schemas.microsoft.com/office/drawing/2014/main" id="{5FFA2269-0385-413C-9225-E7EDBB2021C2}"/>
+                <a16:creationId xmlns:a16="http://schemas.microsoft.com/office/drawing/2014/main" id="{4562CE77-3904-4C8E-A3AE-25BC37CBEE36}"/>
               </a:ext>
             </a:extLst>
           </p:cNvPr>
@@ -11038,7 +11038,7 @@
           <p:cNvPr id="19" name="">
             <a:extLst xmlns:a="http://schemas.openxmlformats.org/drawingml/2006/main">
               <a:ext uri="{FF2B5EF4-FFF2-40B4-BE49-F238E27FC236}">
-                <a16:creationId xmlns:a16="http://schemas.microsoft.com/office/drawing/2014/main" id="{D5B25544-8F9A-433F-9C4C-447763912780}"/>
+                <a16:creationId xmlns:a16="http://schemas.microsoft.com/office/drawing/2014/main" id="{D80F101A-3ABA-4190-A0C5-393CCD9BAA55}"/>
               </a:ext>
             </a:extLst>
           </p:cNvPr>
@@ -11193,7 +11193,7 @@
     </p:spTree>
     <p:extLst>
       <p:ext uri="{BB962C8B-B14F-4D97-AF65-F5344CB8AC3E}">
-        <p14:creationId xmlns:p14="http://schemas.microsoft.com/office/powerpoint/2010/main" val="1659389663"/>
+        <p14:creationId xmlns:p14="http://schemas.microsoft.com/office/powerpoint/2010/main" val="90063416"/>
       </p:ext>
     </p:extLst>
   </p:cSld>
@@ -11224,7 +11224,7 @@
           <p:cNvPr id="19" name="">
             <a:extLst xmlns:a="http://schemas.openxmlformats.org/drawingml/2006/main">
               <a:ext uri="{FF2B5EF4-FFF2-40B4-BE49-F238E27FC236}">
-                <a16:creationId xmlns:a16="http://schemas.microsoft.com/office/drawing/2014/main" id="{754EF060-D746-4E17-948E-D28412290C69}"/>
+                <a16:creationId xmlns:a16="http://schemas.microsoft.com/office/drawing/2014/main" id="{F1D6D411-322E-470B-B65F-86E02F4130EF}"/>
               </a:ext>
             </a:extLst>
           </p:cNvPr>
@@ -11381,7 +11381,7 @@
           <p:cNvPr id="2" name="">
             <a:extLst xmlns:a="http://schemas.openxmlformats.org/drawingml/2006/main">
               <a:ext uri="{FF2B5EF4-FFF2-40B4-BE49-F238E27FC236}">
-                <a16:creationId xmlns:a16="http://schemas.microsoft.com/office/drawing/2014/main" id="{C72A29BE-C1F3-4DB6-A346-FD0ACCB8E260}"/>
+                <a16:creationId xmlns:a16="http://schemas.microsoft.com/office/drawing/2014/main" id="{9C83AA26-16E8-4F51-81F1-70BA8600EC0F}"/>
               </a:ext>
             </a:extLst>
           </p:cNvPr>
@@ -11412,7 +11412,7 @@
           <p:cNvPr id="3" name="">
             <a:extLst xmlns:a="http://schemas.openxmlformats.org/drawingml/2006/main">
               <a:ext uri="{FF2B5EF4-FFF2-40B4-BE49-F238E27FC236}">
-                <a16:creationId xmlns:a16="http://schemas.microsoft.com/office/drawing/2014/main" id="{D9699B17-CC1F-4A69-8458-F56CBBBB49F9}"/>
+                <a16:creationId xmlns:a16="http://schemas.microsoft.com/office/drawing/2014/main" id="{A7C71564-C2ED-49D7-9000-A0FF7284FE04}"/>
               </a:ext>
             </a:extLst>
           </p:cNvPr>
@@ -11569,7 +11569,7 @@
           <p:cNvPr id="4" name="">
             <a:extLst xmlns:a="http://schemas.openxmlformats.org/drawingml/2006/main">
               <a:ext uri="{FF2B5EF4-FFF2-40B4-BE49-F238E27FC236}">
-                <a16:creationId xmlns:a16="http://schemas.microsoft.com/office/drawing/2014/main" id="{F23EAA62-F892-405F-85D1-000B15228119}"/>
+                <a16:creationId xmlns:a16="http://schemas.microsoft.com/office/drawing/2014/main" id="{7593BF5A-935E-4CFA-92C0-33D95B47F27D}"/>
               </a:ext>
             </a:extLst>
           </p:cNvPr>
@@ -11600,7 +11600,7 @@
           <p:cNvPr id="5" name="">
             <a:extLst xmlns:a="http://schemas.openxmlformats.org/drawingml/2006/main">
               <a:ext uri="{FF2B5EF4-FFF2-40B4-BE49-F238E27FC236}">
-                <a16:creationId xmlns:a16="http://schemas.microsoft.com/office/drawing/2014/main" id="{DE0472A1-36EA-4694-BDCE-B36D167F894C}"/>
+                <a16:creationId xmlns:a16="http://schemas.microsoft.com/office/drawing/2014/main" id="{E62EAF62-82F2-4BEA-AAC2-1EFAB59528C8}"/>
               </a:ext>
             </a:extLst>
           </p:cNvPr>
@@ -11757,7 +11757,7 @@
           <p:cNvPr id="6" name="">
             <a:extLst xmlns:a="http://schemas.openxmlformats.org/drawingml/2006/main">
               <a:ext uri="{FF2B5EF4-FFF2-40B4-BE49-F238E27FC236}">
-                <a16:creationId xmlns:a16="http://schemas.microsoft.com/office/drawing/2014/main" id="{22D8AE22-405A-4F2C-AB36-A07A19BA264D}"/>
+                <a16:creationId xmlns:a16="http://schemas.microsoft.com/office/drawing/2014/main" id="{F2A06FCD-1F38-4B3F-B884-3680C26CCAEC}"/>
               </a:ext>
             </a:extLst>
           </p:cNvPr>
@@ -11788,7 +11788,7 @@
           <p:cNvPr id="7" name="">
             <a:extLst xmlns:a="http://schemas.openxmlformats.org/drawingml/2006/main">
               <a:ext uri="{FF2B5EF4-FFF2-40B4-BE49-F238E27FC236}">
-                <a16:creationId xmlns:a16="http://schemas.microsoft.com/office/drawing/2014/main" id="{B7723C03-3AA0-4D2E-A3CC-8BB1240993E0}"/>
+                <a16:creationId xmlns:a16="http://schemas.microsoft.com/office/drawing/2014/main" id="{36AD6819-5B13-4B76-920A-3C9C35A830B5}"/>
               </a:ext>
             </a:extLst>
           </p:cNvPr>
@@ -11968,7 +11968,7 @@
           <p:cNvPr id="8" name="">
             <a:extLst xmlns:a="http://schemas.openxmlformats.org/drawingml/2006/main">
               <a:ext uri="{FF2B5EF4-FFF2-40B4-BE49-F238E27FC236}">
-                <a16:creationId xmlns:a16="http://schemas.microsoft.com/office/drawing/2014/main" id="{D8B50F4B-7AAA-4F97-B208-B8AFF82650AF}"/>
+                <a16:creationId xmlns:a16="http://schemas.microsoft.com/office/drawing/2014/main" id="{266C869A-5DDB-412D-B657-916463916C9A}"/>
               </a:ext>
             </a:extLst>
           </p:cNvPr>
@@ -12125,7 +12125,7 @@
           <p:cNvPr id="9" name="">
             <a:extLst xmlns:a="http://schemas.openxmlformats.org/drawingml/2006/main">
               <a:ext uri="{FF2B5EF4-FFF2-40B4-BE49-F238E27FC236}">
-                <a16:creationId xmlns:a16="http://schemas.microsoft.com/office/drawing/2014/main" id="{94F83EC6-E0B7-4C84-8E8F-3C1BE5D9F22A}"/>
+                <a16:creationId xmlns:a16="http://schemas.microsoft.com/office/drawing/2014/main" id="{AD5FC211-9FF3-47E0-9787-E0B8928507E7}"/>
               </a:ext>
             </a:extLst>
           </p:cNvPr>
@@ -12156,7 +12156,7 @@
           <p:cNvPr id="10" name="">
             <a:extLst xmlns:a="http://schemas.openxmlformats.org/drawingml/2006/main">
               <a:ext uri="{FF2B5EF4-FFF2-40B4-BE49-F238E27FC236}">
-                <a16:creationId xmlns:a16="http://schemas.microsoft.com/office/drawing/2014/main" id="{8FF76CE3-55D2-4BF1-B905-512039104A10}"/>
+                <a16:creationId xmlns:a16="http://schemas.microsoft.com/office/drawing/2014/main" id="{8BF2EE6E-4807-4548-AA60-3D50162123E3}"/>
               </a:ext>
             </a:extLst>
           </p:cNvPr>
@@ -12336,7 +12336,7 @@
           <p:cNvPr id="11" name="">
             <a:extLst xmlns:a="http://schemas.openxmlformats.org/drawingml/2006/main">
               <a:ext uri="{FF2B5EF4-FFF2-40B4-BE49-F238E27FC236}">
-                <a16:creationId xmlns:a16="http://schemas.microsoft.com/office/drawing/2014/main" id="{2109DD22-85D6-49D6-A4D0-6637C8FC7EC4}"/>
+                <a16:creationId xmlns:a16="http://schemas.microsoft.com/office/drawing/2014/main" id="{0E4BA827-807C-4D5D-8807-0252464643F7}"/>
               </a:ext>
             </a:extLst>
           </p:cNvPr>
@@ -12493,7 +12493,7 @@
           <p:cNvPr id="12" name="">
             <a:extLst xmlns:a="http://schemas.openxmlformats.org/drawingml/2006/main">
               <a:ext uri="{FF2B5EF4-FFF2-40B4-BE49-F238E27FC236}">
-                <a16:creationId xmlns:a16="http://schemas.microsoft.com/office/drawing/2014/main" id="{16AC54E6-A600-40B7-9827-BD170F06F4B6}"/>
+                <a16:creationId xmlns:a16="http://schemas.microsoft.com/office/drawing/2014/main" id="{62925082-9DC8-4F1D-88E1-A0DFF1C6C04B}"/>
               </a:ext>
             </a:extLst>
           </p:cNvPr>
@@ -12524,7 +12524,7 @@
           <p:cNvPr id="13" name="">
             <a:extLst xmlns:a="http://schemas.openxmlformats.org/drawingml/2006/main">
               <a:ext uri="{FF2B5EF4-FFF2-40B4-BE49-F238E27FC236}">
-                <a16:creationId xmlns:a16="http://schemas.microsoft.com/office/drawing/2014/main" id="{6821C4B1-A367-42B6-96E0-19156F8E3C1B}"/>
+                <a16:creationId xmlns:a16="http://schemas.microsoft.com/office/drawing/2014/main" id="{B0B56B97-4149-45E1-B82F-9DF0B113B37D}"/>
               </a:ext>
             </a:extLst>
           </p:cNvPr>
@@ -12704,7 +12704,7 @@
           <p:cNvPr id="14" name="">
             <a:extLst xmlns:a="http://schemas.openxmlformats.org/drawingml/2006/main">
               <a:ext uri="{FF2B5EF4-FFF2-40B4-BE49-F238E27FC236}">
-                <a16:creationId xmlns:a16="http://schemas.microsoft.com/office/drawing/2014/main" id="{36FD6AEA-AFE1-44AD-8C23-80A9CD88714C}"/>
+                <a16:creationId xmlns:a16="http://schemas.microsoft.com/office/drawing/2014/main" id="{F633AC5A-F597-4D82-BB06-DB874D47A377}"/>
               </a:ext>
             </a:extLst>
           </p:cNvPr>
@@ -12861,7 +12861,7 @@
           <p:cNvPr id="15" name="">
             <a:extLst xmlns:a="http://schemas.openxmlformats.org/drawingml/2006/main">
               <a:ext uri="{FF2B5EF4-FFF2-40B4-BE49-F238E27FC236}">
-                <a16:creationId xmlns:a16="http://schemas.microsoft.com/office/drawing/2014/main" id="{27327773-3398-435C-82A9-8B0FCBB06EE5}"/>
+                <a16:creationId xmlns:a16="http://schemas.microsoft.com/office/drawing/2014/main" id="{DBC5C90C-5EEC-436B-AB06-C22EAB471E66}"/>
               </a:ext>
             </a:extLst>
           </p:cNvPr>
@@ -12892,7 +12892,7 @@
           <p:cNvPr id="16" name="">
             <a:extLst xmlns:a="http://schemas.openxmlformats.org/drawingml/2006/main">
               <a:ext uri="{FF2B5EF4-FFF2-40B4-BE49-F238E27FC236}">
-                <a16:creationId xmlns:a16="http://schemas.microsoft.com/office/drawing/2014/main" id="{8B16A2ED-3CAE-4B7A-98C2-EBACEC30F949}"/>
+                <a16:creationId xmlns:a16="http://schemas.microsoft.com/office/drawing/2014/main" id="{E38B5A3A-1666-4F1A-9B7D-36CF388E4A54}"/>
               </a:ext>
             </a:extLst>
           </p:cNvPr>
@@ -13072,7 +13072,7 @@
           <p:cNvPr id="17" name="">
             <a:extLst xmlns:a="http://schemas.openxmlformats.org/drawingml/2006/main">
               <a:ext uri="{FF2B5EF4-FFF2-40B4-BE49-F238E27FC236}">
-                <a16:creationId xmlns:a16="http://schemas.microsoft.com/office/drawing/2014/main" id="{AC65861A-DE6F-4E4E-8CEF-E3F8305E6F7C}"/>
+                <a16:creationId xmlns:a16="http://schemas.microsoft.com/office/drawing/2014/main" id="{84FDB88C-8D0F-49A9-B29F-09FBE5CB8E11}"/>
               </a:ext>
             </a:extLst>
           </p:cNvPr>
@@ -13432,7 +13432,7 @@
           <p:cNvPr id="18" name="">
             <a:extLst xmlns:a="http://schemas.openxmlformats.org/drawingml/2006/main">
               <a:ext uri="{FF2B5EF4-FFF2-40B4-BE49-F238E27FC236}">
-                <a16:creationId xmlns:a16="http://schemas.microsoft.com/office/drawing/2014/main" id="{55BF77B2-C2A8-497E-B5FD-B965B1C91A58}"/>
+                <a16:creationId xmlns:a16="http://schemas.microsoft.com/office/drawing/2014/main" id="{AC9036C0-DC4E-446B-BC23-DF6F010E898C}"/>
               </a:ext>
             </a:extLst>
           </p:cNvPr>
@@ -13587,7 +13587,7 @@
     </p:spTree>
     <p:extLst>
       <p:ext uri="{BB962C8B-B14F-4D97-AF65-F5344CB8AC3E}">
-        <p14:creationId xmlns:p14="http://schemas.microsoft.com/office/powerpoint/2010/main" val="1676009891"/>
+        <p14:creationId xmlns:p14="http://schemas.microsoft.com/office/powerpoint/2010/main" val="137969170"/>
       </p:ext>
     </p:extLst>
   </p:cSld>
@@ -13618,7 +13618,7 @@
           <p:cNvPr id="26" name="">
             <a:extLst xmlns:a="http://schemas.openxmlformats.org/drawingml/2006/main">
               <a:ext uri="{FF2B5EF4-FFF2-40B4-BE49-F238E27FC236}">
-                <a16:creationId xmlns:a16="http://schemas.microsoft.com/office/drawing/2014/main" id="{FF1399B4-7050-426C-A7F7-BD9634550186}"/>
+                <a16:creationId xmlns:a16="http://schemas.microsoft.com/office/drawing/2014/main" id="{58E6CD67-0B37-4303-8509-BB685EFEF50A}"/>
               </a:ext>
             </a:extLst>
           </p:cNvPr>
@@ -13775,7 +13775,7 @@
           <p:cNvPr id="2" name="">
             <a:extLst xmlns:a="http://schemas.openxmlformats.org/drawingml/2006/main">
               <a:ext uri="{FF2B5EF4-FFF2-40B4-BE49-F238E27FC236}">
-                <a16:creationId xmlns:a16="http://schemas.microsoft.com/office/drawing/2014/main" id="{DCF4ABF7-468D-47DF-9F98-C5E2CEC487BB}"/>
+                <a16:creationId xmlns:a16="http://schemas.microsoft.com/office/drawing/2014/main" id="{F7C18D40-5BBE-4C43-9873-A716AA102B6B}"/>
               </a:ext>
             </a:extLst>
           </p:cNvPr>
@@ -13806,7 +13806,7 @@
           <p:cNvPr id="3" name="">
             <a:extLst xmlns:a="http://schemas.openxmlformats.org/drawingml/2006/main">
               <a:ext uri="{FF2B5EF4-FFF2-40B4-BE49-F238E27FC236}">
-                <a16:creationId xmlns:a16="http://schemas.microsoft.com/office/drawing/2014/main" id="{E53C35A5-ECDB-4897-B823-4B46DB020E07}"/>
+                <a16:creationId xmlns:a16="http://schemas.microsoft.com/office/drawing/2014/main" id="{DAAAA253-42B0-481A-805C-0F173DBBC3B6}"/>
               </a:ext>
             </a:extLst>
           </p:cNvPr>
@@ -13963,7 +13963,7 @@
           <p:cNvPr id="4" name="">
             <a:extLst xmlns:a="http://schemas.openxmlformats.org/drawingml/2006/main">
               <a:ext uri="{FF2B5EF4-FFF2-40B4-BE49-F238E27FC236}">
-                <a16:creationId xmlns:a16="http://schemas.microsoft.com/office/drawing/2014/main" id="{1161FB71-1AFB-4CFB-8220-809E5705DCB1}"/>
+                <a16:creationId xmlns:a16="http://schemas.microsoft.com/office/drawing/2014/main" id="{C9159C78-A658-444F-90D0-C43389A768D5}"/>
               </a:ext>
             </a:extLst>
           </p:cNvPr>
@@ -13996,7 +13996,7 @@
           <p:cNvPr id="5" name="">
             <a:extLst xmlns:a="http://schemas.openxmlformats.org/drawingml/2006/main">
               <a:ext uri="{FF2B5EF4-FFF2-40B4-BE49-F238E27FC236}">
-                <a16:creationId xmlns:a16="http://schemas.microsoft.com/office/drawing/2014/main" id="{1B923395-3D8B-4E83-8D12-573EACAA261F}"/>
+                <a16:creationId xmlns:a16="http://schemas.microsoft.com/office/drawing/2014/main" id="{E0AE268B-9C74-49F8-949C-1BBA94703C41}"/>
               </a:ext>
             </a:extLst>
           </p:cNvPr>
@@ -14153,7 +14153,7 @@
           <p:cNvPr id="6" name="">
             <a:extLst xmlns:a="http://schemas.openxmlformats.org/drawingml/2006/main">
               <a:ext uri="{FF2B5EF4-FFF2-40B4-BE49-F238E27FC236}">
-                <a16:creationId xmlns:a16="http://schemas.microsoft.com/office/drawing/2014/main" id="{73598B81-F51E-4452-847A-47BF7E8ADFA6}"/>
+                <a16:creationId xmlns:a16="http://schemas.microsoft.com/office/drawing/2014/main" id="{62D75442-A1E5-4C5F-8F12-99BB0671EA78}"/>
               </a:ext>
             </a:extLst>
           </p:cNvPr>
@@ -14333,7 +14333,7 @@
           <p:cNvPr id="7" name="">
             <a:extLst xmlns:a="http://schemas.openxmlformats.org/drawingml/2006/main">
               <a:ext uri="{FF2B5EF4-FFF2-40B4-BE49-F238E27FC236}">
-                <a16:creationId xmlns:a16="http://schemas.microsoft.com/office/drawing/2014/main" id="{53E97DF3-4B82-4E08-91DF-435735E2E3C6}"/>
+                <a16:creationId xmlns:a16="http://schemas.microsoft.com/office/drawing/2014/main" id="{DAF897EF-AD1B-4CBF-82ED-4E3828751D43}"/>
               </a:ext>
             </a:extLst>
           </p:cNvPr>
@@ -14364,7 +14364,7 @@
           <p:cNvPr id="8" name="">
             <a:extLst xmlns:a="http://schemas.openxmlformats.org/drawingml/2006/main">
               <a:ext uri="{FF2B5EF4-FFF2-40B4-BE49-F238E27FC236}">
-                <a16:creationId xmlns:a16="http://schemas.microsoft.com/office/drawing/2014/main" id="{ADBA765C-0974-4FE6-8872-D2D214B9114D}"/>
+                <a16:creationId xmlns:a16="http://schemas.microsoft.com/office/drawing/2014/main" id="{2F8E8624-F978-4939-8794-C8112F6E973A}"/>
               </a:ext>
             </a:extLst>
           </p:cNvPr>
@@ -14397,7 +14397,7 @@
           <p:cNvPr id="9" name="">
             <a:extLst xmlns:a="http://schemas.openxmlformats.org/drawingml/2006/main">
               <a:ext uri="{FF2B5EF4-FFF2-40B4-BE49-F238E27FC236}">
-                <a16:creationId xmlns:a16="http://schemas.microsoft.com/office/drawing/2014/main" id="{04A42597-254D-4C6C-8131-E60B5F3E78B4}"/>
+                <a16:creationId xmlns:a16="http://schemas.microsoft.com/office/drawing/2014/main" id="{BD227F22-B682-4410-B65B-3375B0A594FA}"/>
               </a:ext>
             </a:extLst>
           </p:cNvPr>
@@ -14554,7 +14554,7 @@
           <p:cNvPr id="10" name="">
             <a:extLst xmlns:a="http://schemas.openxmlformats.org/drawingml/2006/main">
               <a:ext uri="{FF2B5EF4-FFF2-40B4-BE49-F238E27FC236}">
-                <a16:creationId xmlns:a16="http://schemas.microsoft.com/office/drawing/2014/main" id="{8E03143B-268E-4A94-8F9E-E635BA9A0A20}"/>
+                <a16:creationId xmlns:a16="http://schemas.microsoft.com/office/drawing/2014/main" id="{4DAD6488-4308-44C7-BF92-5E3C69E24997}"/>
               </a:ext>
             </a:extLst>
           </p:cNvPr>
@@ -14734,7 +14734,7 @@
           <p:cNvPr id="11" name="">
             <a:extLst xmlns:a="http://schemas.openxmlformats.org/drawingml/2006/main">
               <a:ext uri="{FF2B5EF4-FFF2-40B4-BE49-F238E27FC236}">
-                <a16:creationId xmlns:a16="http://schemas.microsoft.com/office/drawing/2014/main" id="{BF2E5407-C03D-4697-9614-C6207E67BA32}"/>
+                <a16:creationId xmlns:a16="http://schemas.microsoft.com/office/drawing/2014/main" id="{6036ADC5-8843-4F83-B81B-F98001909479}"/>
               </a:ext>
             </a:extLst>
           </p:cNvPr>
@@ -14765,7 +14765,7 @@
           <p:cNvPr id="12" name="">
             <a:extLst xmlns:a="http://schemas.openxmlformats.org/drawingml/2006/main">
               <a:ext uri="{FF2B5EF4-FFF2-40B4-BE49-F238E27FC236}">
-                <a16:creationId xmlns:a16="http://schemas.microsoft.com/office/drawing/2014/main" id="{C23F2CBA-6193-44A0-929D-A5DA1129698F}"/>
+                <a16:creationId xmlns:a16="http://schemas.microsoft.com/office/drawing/2014/main" id="{844E7E2A-0217-485F-97C5-DC6532C3E5C9}"/>
               </a:ext>
             </a:extLst>
           </p:cNvPr>
@@ -14798,7 +14798,7 @@
           <p:cNvPr id="13" name="">
             <a:extLst xmlns:a="http://schemas.openxmlformats.org/drawingml/2006/main">
               <a:ext uri="{FF2B5EF4-FFF2-40B4-BE49-F238E27FC236}">
-                <a16:creationId xmlns:a16="http://schemas.microsoft.com/office/drawing/2014/main" id="{13C52A5C-C2C0-4200-9E98-FEA69F298FE3}"/>
+                <a16:creationId xmlns:a16="http://schemas.microsoft.com/office/drawing/2014/main" id="{5E6540A3-8917-433A-BEB3-B345E7CBD7D6}"/>
               </a:ext>
             </a:extLst>
           </p:cNvPr>
@@ -14955,7 +14955,7 @@
           <p:cNvPr id="14" name="">
             <a:extLst xmlns:a="http://schemas.openxmlformats.org/drawingml/2006/main">
               <a:ext uri="{FF2B5EF4-FFF2-40B4-BE49-F238E27FC236}">
-                <a16:creationId xmlns:a16="http://schemas.microsoft.com/office/drawing/2014/main" id="{52F8D332-673E-4695-B35A-4F71C003D74F}"/>
+                <a16:creationId xmlns:a16="http://schemas.microsoft.com/office/drawing/2014/main" id="{D606F8E9-D43D-4870-9B17-6440F6B7D56A}"/>
               </a:ext>
             </a:extLst>
           </p:cNvPr>
@@ -15135,7 +15135,7 @@
           <p:cNvPr id="15" name="">
             <a:extLst xmlns:a="http://schemas.openxmlformats.org/drawingml/2006/main">
               <a:ext uri="{FF2B5EF4-FFF2-40B4-BE49-F238E27FC236}">
-                <a16:creationId xmlns:a16="http://schemas.microsoft.com/office/drawing/2014/main" id="{EC9C3CBA-841D-4AE0-93A2-E88CB0F11E53}"/>
+                <a16:creationId xmlns:a16="http://schemas.microsoft.com/office/drawing/2014/main" id="{64E00BA0-50EB-4842-AAA2-5967BD41B14D}"/>
               </a:ext>
             </a:extLst>
           </p:cNvPr>
@@ -15166,7 +15166,7 @@
           <p:cNvPr id="16" name="">
             <a:extLst xmlns:a="http://schemas.openxmlformats.org/drawingml/2006/main">
               <a:ext uri="{FF2B5EF4-FFF2-40B4-BE49-F238E27FC236}">
-                <a16:creationId xmlns:a16="http://schemas.microsoft.com/office/drawing/2014/main" id="{48D85234-63F2-4AD2-B535-E4AA07698157}"/>
+                <a16:creationId xmlns:a16="http://schemas.microsoft.com/office/drawing/2014/main" id="{D6E33F07-8884-4F18-800B-7D5C9E4EF0D3}"/>
               </a:ext>
             </a:extLst>
           </p:cNvPr>
@@ -15199,7 +15199,7 @@
           <p:cNvPr id="17" name="">
             <a:extLst xmlns:a="http://schemas.openxmlformats.org/drawingml/2006/main">
               <a:ext uri="{FF2B5EF4-FFF2-40B4-BE49-F238E27FC236}">
-                <a16:creationId xmlns:a16="http://schemas.microsoft.com/office/drawing/2014/main" id="{1919F2B2-312C-41BD-94B2-82F651055FFE}"/>
+                <a16:creationId xmlns:a16="http://schemas.microsoft.com/office/drawing/2014/main" id="{FFE01BA6-37B2-4DF6-BF47-FA787EBC011B}"/>
               </a:ext>
             </a:extLst>
           </p:cNvPr>
@@ -15356,7 +15356,7 @@
           <p:cNvPr id="18" name="">
             <a:extLst xmlns:a="http://schemas.openxmlformats.org/drawingml/2006/main">
               <a:ext uri="{FF2B5EF4-FFF2-40B4-BE49-F238E27FC236}">
-                <a16:creationId xmlns:a16="http://schemas.microsoft.com/office/drawing/2014/main" id="{0A5BE7DB-E752-48E3-8FFE-BDD08804905B}"/>
+                <a16:creationId xmlns:a16="http://schemas.microsoft.com/office/drawing/2014/main" id="{5DA18FBC-BC81-4079-A3B5-13138025F8F6}"/>
               </a:ext>
             </a:extLst>
           </p:cNvPr>
@@ -15536,7 +15536,7 @@
           <p:cNvPr id="19" name="">
             <a:extLst xmlns:a="http://schemas.openxmlformats.org/drawingml/2006/main">
               <a:ext uri="{FF2B5EF4-FFF2-40B4-BE49-F238E27FC236}">
-                <a16:creationId xmlns:a16="http://schemas.microsoft.com/office/drawing/2014/main" id="{D617E99D-0512-4B4E-ABF2-95D5B87525A0}"/>
+                <a16:creationId xmlns:a16="http://schemas.microsoft.com/office/drawing/2014/main" id="{66816C35-17FE-47DF-A37A-65D4B6B3FFE2}"/>
               </a:ext>
             </a:extLst>
           </p:cNvPr>
@@ -15693,7 +15693,7 @@
           <p:cNvPr id="20" name="">
             <a:extLst xmlns:a="http://schemas.openxmlformats.org/drawingml/2006/main">
               <a:ext uri="{FF2B5EF4-FFF2-40B4-BE49-F238E27FC236}">
-                <a16:creationId xmlns:a16="http://schemas.microsoft.com/office/drawing/2014/main" id="{E2092F32-1CE3-4B68-8B7E-83D5D30CF303}"/>
+                <a16:creationId xmlns:a16="http://schemas.microsoft.com/office/drawing/2014/main" id="{26D65C62-3D9E-42A1-A190-3AE8F9ECB95E}"/>
               </a:ext>
             </a:extLst>
           </p:cNvPr>
@@ -15850,7 +15850,7 @@
           <p:cNvPr id="21" name="">
             <a:extLst xmlns:a="http://schemas.openxmlformats.org/drawingml/2006/main">
               <a:ext uri="{FF2B5EF4-FFF2-40B4-BE49-F238E27FC236}">
-                <a16:creationId xmlns:a16="http://schemas.microsoft.com/office/drawing/2014/main" id="{F69352AB-61FB-453C-9965-9E0CD18AAB9C}"/>
+                <a16:creationId xmlns:a16="http://schemas.microsoft.com/office/drawing/2014/main" id="{7B6FE939-22E5-400D-87EE-A363B60CD7A9}"/>
               </a:ext>
             </a:extLst>
           </p:cNvPr>
@@ -16007,7 +16007,7 @@
           <p:cNvPr id="22" name="">
             <a:extLst xmlns:a="http://schemas.openxmlformats.org/drawingml/2006/main">
               <a:ext uri="{FF2B5EF4-FFF2-40B4-BE49-F238E27FC236}">
-                <a16:creationId xmlns:a16="http://schemas.microsoft.com/office/drawing/2014/main" id="{C7B202AB-8B6B-4540-8DD4-CF980F72B345}"/>
+                <a16:creationId xmlns:a16="http://schemas.microsoft.com/office/drawing/2014/main" id="{43254886-5E59-4C23-BF89-FF240DD3D6FE}"/>
               </a:ext>
             </a:extLst>
           </p:cNvPr>
@@ -16164,7 +16164,7 @@
           <p:cNvPr id="23" name="">
             <a:extLst xmlns:a="http://schemas.openxmlformats.org/drawingml/2006/main">
               <a:ext uri="{FF2B5EF4-FFF2-40B4-BE49-F238E27FC236}">
-                <a16:creationId xmlns:a16="http://schemas.microsoft.com/office/drawing/2014/main" id="{16462915-9C17-49BC-A1D3-D37B5540CC9E}"/>
+                <a16:creationId xmlns:a16="http://schemas.microsoft.com/office/drawing/2014/main" id="{2736F106-B1E8-400E-9C29-50C48D5AA3BE}"/>
               </a:ext>
             </a:extLst>
           </p:cNvPr>
@@ -16321,7 +16321,7 @@
           <p:cNvPr id="24" name="">
             <a:extLst xmlns:a="http://schemas.openxmlformats.org/drawingml/2006/main">
               <a:ext uri="{FF2B5EF4-FFF2-40B4-BE49-F238E27FC236}">
-                <a16:creationId xmlns:a16="http://schemas.microsoft.com/office/drawing/2014/main" id="{B947418D-4085-4EA2-8174-830FB450687C}"/>
+                <a16:creationId xmlns:a16="http://schemas.microsoft.com/office/drawing/2014/main" id="{74E4274F-77FF-44BF-ADA9-184B3A5907E8}"/>
               </a:ext>
             </a:extLst>
           </p:cNvPr>
@@ -16478,7 +16478,7 @@
           <p:cNvPr id="25" name="">
             <a:extLst xmlns:a="http://schemas.openxmlformats.org/drawingml/2006/main">
               <a:ext uri="{FF2B5EF4-FFF2-40B4-BE49-F238E27FC236}">
-                <a16:creationId xmlns:a16="http://schemas.microsoft.com/office/drawing/2014/main" id="{288361E2-F4B4-4CF3-820B-33C402D253D7}"/>
+                <a16:creationId xmlns:a16="http://schemas.microsoft.com/office/drawing/2014/main" id="{CA1B2FAD-97E7-4030-AF33-E39C0586A8CB}"/>
               </a:ext>
             </a:extLst>
           </p:cNvPr>
@@ -16633,7 +16633,7 @@
     </p:spTree>
     <p:extLst>
       <p:ext uri="{BB962C8B-B14F-4D97-AF65-F5344CB8AC3E}">
-        <p14:creationId xmlns:p14="http://schemas.microsoft.com/office/powerpoint/2010/main" val="1071790973"/>
+        <p14:creationId xmlns:p14="http://schemas.microsoft.com/office/powerpoint/2010/main" val="1740774356"/>
       </p:ext>
     </p:extLst>
   </p:cSld>
@@ -16664,7 +16664,7 @@
           <p:cNvPr id="10" name="">
             <a:extLst xmlns:a="http://schemas.openxmlformats.org/drawingml/2006/main">
               <a:ext uri="{FF2B5EF4-FFF2-40B4-BE49-F238E27FC236}">
-                <a16:creationId xmlns:a16="http://schemas.microsoft.com/office/drawing/2014/main" id="{CDBF78C6-AADB-4293-80AC-6B7F7FE4F3A1}"/>
+                <a16:creationId xmlns:a16="http://schemas.microsoft.com/office/drawing/2014/main" id="{8D113B4C-3403-4876-954B-D1ABE6E496B6}"/>
               </a:ext>
             </a:extLst>
           </p:cNvPr>
@@ -16821,7 +16821,7 @@
           <p:cNvPr id="2" name="">
             <a:extLst xmlns:a="http://schemas.openxmlformats.org/drawingml/2006/main">
               <a:ext uri="{FF2B5EF4-FFF2-40B4-BE49-F238E27FC236}">
-                <a16:creationId xmlns:a16="http://schemas.microsoft.com/office/drawing/2014/main" id="{79D56314-892E-4B9A-B071-84F4FAFE89B5}"/>
+                <a16:creationId xmlns:a16="http://schemas.microsoft.com/office/drawing/2014/main" id="{0BB6126B-87FF-425B-A2CE-3E5DF3CF822C}"/>
               </a:ext>
             </a:extLst>
           </p:cNvPr>
@@ -16852,7 +16852,7 @@
           <p:cNvPr id="3" name="">
             <a:extLst xmlns:a="http://schemas.openxmlformats.org/drawingml/2006/main">
               <a:ext uri="{FF2B5EF4-FFF2-40B4-BE49-F238E27FC236}">
-                <a16:creationId xmlns:a16="http://schemas.microsoft.com/office/drawing/2014/main" id="{871D5269-6054-4D22-A740-CA3E24F6D3DA}"/>
+                <a16:creationId xmlns:a16="http://schemas.microsoft.com/office/drawing/2014/main" id="{18A14D85-E8DA-4140-B3F7-90BC075779A8}"/>
               </a:ext>
             </a:extLst>
           </p:cNvPr>
@@ -17009,7 +17009,7 @@
           <p:cNvPr id="4" name="Chart">
             <a:extLst xmlns:a="http://schemas.openxmlformats.org/drawingml/2006/main">
               <a:ext uri="{FF2B5EF4-FFF2-40B4-BE49-F238E27FC236}">
-                <a16:creationId xmlns:a16="http://schemas.microsoft.com/office/drawing/2014/main" id="{73D9DC31-FA18-46E2-892E-1E997B9A4645}"/>
+                <a16:creationId xmlns:a16="http://schemas.microsoft.com/office/drawing/2014/main" id="{9AE92958-33D2-441D-A13E-35AF1A1D97A1}"/>
               </a:ext>
             </a:extLst>
           </p:cNvPr>
@@ -17022,7 +17022,7 @@
         </p:xfrm>
         <a:graphic xmlns:a="http://schemas.openxmlformats.org/drawingml/2006/main">
           <a:graphicData uri="http://schemas.openxmlformats.org/drawingml/2006/chart">
-            <c:chart xmlns:r="http://schemas.openxmlformats.org/officeDocument/2006/relationships" xmlns:c="http://schemas.openxmlformats.org/drawingml/2006/chart" r:id="R0e0eea19c5aa42bd"/>
+            <c:chart xmlns:r="http://schemas.openxmlformats.org/officeDocument/2006/relationships" xmlns:c="http://schemas.openxmlformats.org/drawingml/2006/chart" r:id="R84c4f161305a42b0"/>
           </a:graphicData>
         </a:graphic>
       </p:graphicFrame>
@@ -17031,7 +17031,7 @@
           <p:cNvPr id="5" name="">
             <a:extLst xmlns:a="http://schemas.openxmlformats.org/drawingml/2006/main">
               <a:ext uri="{FF2B5EF4-FFF2-40B4-BE49-F238E27FC236}">
-                <a16:creationId xmlns:a16="http://schemas.microsoft.com/office/drawing/2014/main" id="{9A06988B-92E5-4EE3-AB41-79DB130BFBAD}"/>
+                <a16:creationId xmlns:a16="http://schemas.microsoft.com/office/drawing/2014/main" id="{B54D09C3-EDF1-4AC0-BA15-A5F7F24D927E}"/>
               </a:ext>
             </a:extLst>
           </p:cNvPr>
@@ -17188,7 +17188,7 @@
           <p:cNvPr id="6" name="">
             <a:extLst xmlns:a="http://schemas.openxmlformats.org/drawingml/2006/main">
               <a:ext uri="{FF2B5EF4-FFF2-40B4-BE49-F238E27FC236}">
-                <a16:creationId xmlns:a16="http://schemas.microsoft.com/office/drawing/2014/main" id="{B27A4666-3F82-4109-890E-2F9F40DD77D0}"/>
+                <a16:creationId xmlns:a16="http://schemas.microsoft.com/office/drawing/2014/main" id="{693CF849-A246-4269-AC98-D8CDF365EE17}"/>
               </a:ext>
             </a:extLst>
           </p:cNvPr>
@@ -17368,7 +17368,7 @@
           <p:cNvPr id="7" name="">
             <a:extLst xmlns:a="http://schemas.openxmlformats.org/drawingml/2006/main">
               <a:ext uri="{FF2B5EF4-FFF2-40B4-BE49-F238E27FC236}">
-                <a16:creationId xmlns:a16="http://schemas.microsoft.com/office/drawing/2014/main" id="{65FC1404-8138-425E-ADD1-57932C50EF43}"/>
+                <a16:creationId xmlns:a16="http://schemas.microsoft.com/office/drawing/2014/main" id="{5878F75A-A97C-44C1-A178-45E0D7E2366C}"/>
               </a:ext>
             </a:extLst>
           </p:cNvPr>
@@ -17525,7 +17525,7 @@
           <p:cNvPr id="8" name="">
             <a:extLst xmlns:a="http://schemas.openxmlformats.org/drawingml/2006/main">
               <a:ext uri="{FF2B5EF4-FFF2-40B4-BE49-F238E27FC236}">
-                <a16:creationId xmlns:a16="http://schemas.microsoft.com/office/drawing/2014/main" id="{60D978B9-644C-4EAC-857E-A010EF3E3750}"/>
+                <a16:creationId xmlns:a16="http://schemas.microsoft.com/office/drawing/2014/main" id="{F64B30B8-E4FC-4200-AFFC-7260985E357F}"/>
               </a:ext>
             </a:extLst>
           </p:cNvPr>
@@ -17705,7 +17705,7 @@
           <p:cNvPr id="9" name="">
             <a:extLst xmlns:a="http://schemas.openxmlformats.org/drawingml/2006/main">
               <a:ext uri="{FF2B5EF4-FFF2-40B4-BE49-F238E27FC236}">
-                <a16:creationId xmlns:a16="http://schemas.microsoft.com/office/drawing/2014/main" id="{C23B20BE-8C37-4EF7-AEDE-F5105018354E}"/>
+                <a16:creationId xmlns:a16="http://schemas.microsoft.com/office/drawing/2014/main" id="{121BD40B-C1E6-4207-A5CC-785CCB07AB05}"/>
               </a:ext>
             </a:extLst>
           </p:cNvPr>
@@ -17860,7 +17860,7 @@
     </p:spTree>
     <p:extLst>
       <p:ext uri="{BB962C8B-B14F-4D97-AF65-F5344CB8AC3E}">
-        <p14:creationId xmlns:p14="http://schemas.microsoft.com/office/powerpoint/2010/main" val="275538072"/>
+        <p14:creationId xmlns:p14="http://schemas.microsoft.com/office/powerpoint/2010/main" val="338665719"/>
       </p:ext>
     </p:extLst>
   </p:cSld>
@@ -17891,7 +17891,7 @@
           <p:cNvPr id="15" name="">
             <a:extLst xmlns:a="http://schemas.openxmlformats.org/drawingml/2006/main">
               <a:ext uri="{FF2B5EF4-FFF2-40B4-BE49-F238E27FC236}">
-                <a16:creationId xmlns:a16="http://schemas.microsoft.com/office/drawing/2014/main" id="{86641F2C-DA58-4D56-85ED-EB72CC75DE4E}"/>
+                <a16:creationId xmlns:a16="http://schemas.microsoft.com/office/drawing/2014/main" id="{ED0E57F9-DC41-4E9F-AA13-8FB0DACEE82A}"/>
               </a:ext>
             </a:extLst>
           </p:cNvPr>
@@ -18048,7 +18048,7 @@
           <p:cNvPr id="2" name="">
             <a:extLst xmlns:a="http://schemas.openxmlformats.org/drawingml/2006/main">
               <a:ext uri="{FF2B5EF4-FFF2-40B4-BE49-F238E27FC236}">
-                <a16:creationId xmlns:a16="http://schemas.microsoft.com/office/drawing/2014/main" id="{BEDD52E5-851B-48F9-8A98-AAFE402C4519}"/>
+                <a16:creationId xmlns:a16="http://schemas.microsoft.com/office/drawing/2014/main" id="{47B7ACDC-2927-423B-99A5-6C3BDF8F9510}"/>
               </a:ext>
             </a:extLst>
           </p:cNvPr>
@@ -18079,7 +18079,7 @@
           <p:cNvPr id="3" name="">
             <a:extLst xmlns:a="http://schemas.openxmlformats.org/drawingml/2006/main">
               <a:ext uri="{FF2B5EF4-FFF2-40B4-BE49-F238E27FC236}">
-                <a16:creationId xmlns:a16="http://schemas.microsoft.com/office/drawing/2014/main" id="{C8DB924A-CF1C-44FB-BFB6-5308953F361B}"/>
+                <a16:creationId xmlns:a16="http://schemas.microsoft.com/office/drawing/2014/main" id="{3C1C26CF-7FBC-4421-A4D8-543E76C996FF}"/>
               </a:ext>
             </a:extLst>
           </p:cNvPr>
@@ -18236,7 +18236,7 @@
           <p:cNvPr id="4" name="">
             <a:extLst xmlns:a="http://schemas.openxmlformats.org/drawingml/2006/main">
               <a:ext uri="{FF2B5EF4-FFF2-40B4-BE49-F238E27FC236}">
-                <a16:creationId xmlns:a16="http://schemas.microsoft.com/office/drawing/2014/main" id="{C8506A4D-4025-4BCB-9355-D7BF7F105835}"/>
+                <a16:creationId xmlns:a16="http://schemas.microsoft.com/office/drawing/2014/main" id="{6ED744D3-E4D9-413C-9793-58D95889C306}"/>
               </a:ext>
             </a:extLst>
           </p:cNvPr>
@@ -18393,7 +18393,7 @@
           <p:cNvPr id="5" name="">
             <a:extLst xmlns:a="http://schemas.openxmlformats.org/drawingml/2006/main">
               <a:ext uri="{FF2B5EF4-FFF2-40B4-BE49-F238E27FC236}">
-                <a16:creationId xmlns:a16="http://schemas.microsoft.com/office/drawing/2014/main" id="{90D2AD85-F1E7-49BC-8299-E3B522ADFB5C}"/>
+                <a16:creationId xmlns:a16="http://schemas.microsoft.com/office/drawing/2014/main" id="{A09DFC21-B500-452F-BF87-28780E27642C}"/>
               </a:ext>
             </a:extLst>
           </p:cNvPr>
@@ -18550,7 +18550,7 @@
           <p:cNvPr id="6" name="">
             <a:extLst xmlns:a="http://schemas.openxmlformats.org/drawingml/2006/main">
               <a:ext uri="{FF2B5EF4-FFF2-40B4-BE49-F238E27FC236}">
-                <a16:creationId xmlns:a16="http://schemas.microsoft.com/office/drawing/2014/main" id="{9B86C8AF-87B9-4B37-81B6-12257A964043}"/>
+                <a16:creationId xmlns:a16="http://schemas.microsoft.com/office/drawing/2014/main" id="{F1CBFB58-8D64-4DC2-9B00-D2B3CC054316}"/>
               </a:ext>
             </a:extLst>
           </p:cNvPr>
@@ -18730,7 +18730,7 @@
           <p:cNvPr id="7" name="">
             <a:extLst xmlns:a="http://schemas.openxmlformats.org/drawingml/2006/main">
               <a:ext uri="{FF2B5EF4-FFF2-40B4-BE49-F238E27FC236}">
-                <a16:creationId xmlns:a16="http://schemas.microsoft.com/office/drawing/2014/main" id="{B0372A49-BEB2-4337-9149-1B9BE789873D}"/>
+                <a16:creationId xmlns:a16="http://schemas.microsoft.com/office/drawing/2014/main" id="{53920C5A-6778-4720-B606-08CCF3C05F7D}"/>
               </a:ext>
             </a:extLst>
           </p:cNvPr>
@@ -18887,7 +18887,7 @@
           <p:cNvPr id="8" name="">
             <a:extLst xmlns:a="http://schemas.openxmlformats.org/drawingml/2006/main">
               <a:ext uri="{FF2B5EF4-FFF2-40B4-BE49-F238E27FC236}">
-                <a16:creationId xmlns:a16="http://schemas.microsoft.com/office/drawing/2014/main" id="{08C26409-D84D-443E-9A7C-31137FC4B2F2}"/>
+                <a16:creationId xmlns:a16="http://schemas.microsoft.com/office/drawing/2014/main" id="{72DB70DB-1006-4D23-83F0-734D1465234A}"/>
               </a:ext>
             </a:extLst>
           </p:cNvPr>
@@ -19067,7 +19067,7 @@
           <p:cNvPr id="9" name="">
             <a:extLst xmlns:a="http://schemas.openxmlformats.org/drawingml/2006/main">
               <a:ext uri="{FF2B5EF4-FFF2-40B4-BE49-F238E27FC236}">
-                <a16:creationId xmlns:a16="http://schemas.microsoft.com/office/drawing/2014/main" id="{78A1D7F0-51F7-4864-8094-E648CEFC5BA6}"/>
+                <a16:creationId xmlns:a16="http://schemas.microsoft.com/office/drawing/2014/main" id="{4E3393CF-7477-4643-816E-5491C7ACA5B2}"/>
               </a:ext>
             </a:extLst>
           </p:cNvPr>
@@ -19224,7 +19224,7 @@
           <p:cNvPr id="10" name="">
             <a:extLst xmlns:a="http://schemas.openxmlformats.org/drawingml/2006/main">
               <a:ext uri="{FF2B5EF4-FFF2-40B4-BE49-F238E27FC236}">
-                <a16:creationId xmlns:a16="http://schemas.microsoft.com/office/drawing/2014/main" id="{0768500C-4FEC-4FA5-9ECD-A8D42671E71D}"/>
+                <a16:creationId xmlns:a16="http://schemas.microsoft.com/office/drawing/2014/main" id="{3CF68083-A246-4DE1-BFFC-780A56A0D4F8}"/>
               </a:ext>
             </a:extLst>
           </p:cNvPr>
@@ -19381,7 +19381,7 @@
           <p:cNvPr id="11" name="">
             <a:extLst xmlns:a="http://schemas.openxmlformats.org/drawingml/2006/main">
               <a:ext uri="{FF2B5EF4-FFF2-40B4-BE49-F238E27FC236}">
-                <a16:creationId xmlns:a16="http://schemas.microsoft.com/office/drawing/2014/main" id="{3F9C9CBD-2206-41CA-B560-D9EEEE46EBF8}"/>
+                <a16:creationId xmlns:a16="http://schemas.microsoft.com/office/drawing/2014/main" id="{05804A28-91F5-44D3-86BB-A5BF907A1F7D}"/>
               </a:ext>
             </a:extLst>
           </p:cNvPr>
@@ -19538,7 +19538,7 @@
           <p:cNvPr id="12" name="Chart">
             <a:extLst xmlns:a="http://schemas.openxmlformats.org/drawingml/2006/main">
               <a:ext uri="{FF2B5EF4-FFF2-40B4-BE49-F238E27FC236}">
-                <a16:creationId xmlns:a16="http://schemas.microsoft.com/office/drawing/2014/main" id="{7528D38E-12DB-48A6-91BF-9782F2F8D45A}"/>
+                <a16:creationId xmlns:a16="http://schemas.microsoft.com/office/drawing/2014/main" id="{B88AD6E1-C421-4E6C-8C88-5DFB9AB05AAF}"/>
               </a:ext>
             </a:extLst>
           </p:cNvPr>
@@ -19551,7 +19551,7 @@
         </p:xfrm>
         <a:graphic xmlns:a="http://schemas.openxmlformats.org/drawingml/2006/main">
           <a:graphicData uri="http://schemas.openxmlformats.org/drawingml/2006/chart">
-            <c:chart xmlns:r="http://schemas.openxmlformats.org/officeDocument/2006/relationships" xmlns:c="http://schemas.openxmlformats.org/drawingml/2006/chart" r:id="R93f9a48d7d99408d"/>
+            <c:chart xmlns:r="http://schemas.openxmlformats.org/officeDocument/2006/relationships" xmlns:c="http://schemas.openxmlformats.org/drawingml/2006/chart" r:id="Rf33a1a47edf0458b"/>
           </a:graphicData>
         </a:graphic>
       </p:graphicFrame>
@@ -19560,7 +19560,7 @@
           <p:cNvPr id="13" name="">
             <a:extLst xmlns:a="http://schemas.openxmlformats.org/drawingml/2006/main">
               <a:ext uri="{FF2B5EF4-FFF2-40B4-BE49-F238E27FC236}">
-                <a16:creationId xmlns:a16="http://schemas.microsoft.com/office/drawing/2014/main" id="{9B4097BA-F704-45F2-9721-43ADBA10CAC0}"/>
+                <a16:creationId xmlns:a16="http://schemas.microsoft.com/office/drawing/2014/main" id="{687B1360-8D36-4019-B7B2-2879AC944F9F}"/>
               </a:ext>
             </a:extLst>
           </p:cNvPr>
@@ -19717,7 +19717,7 @@
           <p:cNvPr id="14" name="">
             <a:extLst xmlns:a="http://schemas.openxmlformats.org/drawingml/2006/main">
               <a:ext uri="{FF2B5EF4-FFF2-40B4-BE49-F238E27FC236}">
-                <a16:creationId xmlns:a16="http://schemas.microsoft.com/office/drawing/2014/main" id="{567BF669-D758-41EF-AE8B-4EDE521F21ED}"/>
+                <a16:creationId xmlns:a16="http://schemas.microsoft.com/office/drawing/2014/main" id="{65CE1C4F-E2ED-490B-AD41-9E5D678A641B}"/>
               </a:ext>
             </a:extLst>
           </p:cNvPr>
@@ -19872,7 +19872,7 @@
     </p:spTree>
     <p:extLst>
       <p:ext uri="{BB962C8B-B14F-4D97-AF65-F5344CB8AC3E}">
-        <p14:creationId xmlns:p14="http://schemas.microsoft.com/office/powerpoint/2010/main" val="116793682"/>
+        <p14:creationId xmlns:p14="http://schemas.microsoft.com/office/powerpoint/2010/main" val="2081173790"/>
       </p:ext>
     </p:extLst>
   </p:cSld>
@@ -19903,7 +19903,7 @@
           <p:cNvPr id="33" name="">
             <a:extLst xmlns:a="http://schemas.openxmlformats.org/drawingml/2006/main">
               <a:ext uri="{FF2B5EF4-FFF2-40B4-BE49-F238E27FC236}">
-                <a16:creationId xmlns:a16="http://schemas.microsoft.com/office/drawing/2014/main" id="{F4419C14-1B66-4740-81D1-DE6BA991A9B5}"/>
+                <a16:creationId xmlns:a16="http://schemas.microsoft.com/office/drawing/2014/main" id="{B4758E8A-6B1E-4F7B-BC2C-F73AA9AEF9D7}"/>
               </a:ext>
             </a:extLst>
           </p:cNvPr>
@@ -20060,7 +20060,7 @@
           <p:cNvPr id="2" name="">
             <a:extLst xmlns:a="http://schemas.openxmlformats.org/drawingml/2006/main">
               <a:ext uri="{FF2B5EF4-FFF2-40B4-BE49-F238E27FC236}">
-                <a16:creationId xmlns:a16="http://schemas.microsoft.com/office/drawing/2014/main" id="{D78C6858-3A2A-4505-9821-F795B1FC8A32}"/>
+                <a16:creationId xmlns:a16="http://schemas.microsoft.com/office/drawing/2014/main" id="{CFED6076-9C97-4813-8A32-F67D799F1C28}"/>
               </a:ext>
             </a:extLst>
           </p:cNvPr>
@@ -20091,7 +20091,7 @@
           <p:cNvPr id="3" name="">
             <a:extLst xmlns:a="http://schemas.openxmlformats.org/drawingml/2006/main">
               <a:ext uri="{FF2B5EF4-FFF2-40B4-BE49-F238E27FC236}">
-                <a16:creationId xmlns:a16="http://schemas.microsoft.com/office/drawing/2014/main" id="{9C198870-3413-44C9-B00F-99BAE539164D}"/>
+                <a16:creationId xmlns:a16="http://schemas.microsoft.com/office/drawing/2014/main" id="{68CF2383-DC9F-45B2-9ADA-FC6BF7FB4DD2}"/>
               </a:ext>
             </a:extLst>
           </p:cNvPr>
@@ -20248,7 +20248,7 @@
           <p:cNvPr id="4" name="">
             <a:extLst xmlns:a="http://schemas.openxmlformats.org/drawingml/2006/main">
               <a:ext uri="{FF2B5EF4-FFF2-40B4-BE49-F238E27FC236}">
-                <a16:creationId xmlns:a16="http://schemas.microsoft.com/office/drawing/2014/main" id="{9864E847-04DD-4D88-8416-B8E92BDDE563}"/>
+                <a16:creationId xmlns:a16="http://schemas.microsoft.com/office/drawing/2014/main" id="{771F0451-BA59-4917-A152-9B44A8332970}"/>
               </a:ext>
             </a:extLst>
           </p:cNvPr>
@@ -20279,7 +20279,7 @@
           <p:cNvPr id="5" name="">
             <a:extLst xmlns:a="http://schemas.openxmlformats.org/drawingml/2006/main">
               <a:ext uri="{FF2B5EF4-FFF2-40B4-BE49-F238E27FC236}">
-                <a16:creationId xmlns:a16="http://schemas.microsoft.com/office/drawing/2014/main" id="{5EE55345-F208-47FD-BEEE-8708D1ABD207}"/>
+                <a16:creationId xmlns:a16="http://schemas.microsoft.com/office/drawing/2014/main" id="{C28686D4-289F-41DB-B03F-F299FD5F39C5}"/>
               </a:ext>
             </a:extLst>
           </p:cNvPr>
@@ -20436,7 +20436,7 @@
           <p:cNvPr id="6" name="">
             <a:extLst xmlns:a="http://schemas.openxmlformats.org/drawingml/2006/main">
               <a:ext uri="{FF2B5EF4-FFF2-40B4-BE49-F238E27FC236}">
-                <a16:creationId xmlns:a16="http://schemas.microsoft.com/office/drawing/2014/main" id="{944715FC-3A12-494A-AFEF-47EC3290FDED}"/>
+                <a16:creationId xmlns:a16="http://schemas.microsoft.com/office/drawing/2014/main" id="{0CABF822-BE24-4991-ACFB-009F3A21850A}"/>
               </a:ext>
             </a:extLst>
           </p:cNvPr>
@@ -20471,7 +20471,7 @@
           <p:cNvPr id="7" name="">
             <a:extLst xmlns:a="http://schemas.openxmlformats.org/drawingml/2006/main">
               <a:ext uri="{FF2B5EF4-FFF2-40B4-BE49-F238E27FC236}">
-                <a16:creationId xmlns:a16="http://schemas.microsoft.com/office/drawing/2014/main" id="{9BEB23C8-AD61-4E8C-8571-A30D74777A25}"/>
+                <a16:creationId xmlns:a16="http://schemas.microsoft.com/office/drawing/2014/main" id="{9419D4AA-B6AB-4891-94FF-7667F9A4C3A5}"/>
               </a:ext>
             </a:extLst>
           </p:cNvPr>
@@ -20628,7 +20628,7 @@
           <p:cNvPr id="8" name="">
             <a:extLst xmlns:a="http://schemas.openxmlformats.org/drawingml/2006/main">
               <a:ext uri="{FF2B5EF4-FFF2-40B4-BE49-F238E27FC236}">
-                <a16:creationId xmlns:a16="http://schemas.microsoft.com/office/drawing/2014/main" id="{0767E786-5066-43BF-A177-B473CB01D855}"/>
+                <a16:creationId xmlns:a16="http://schemas.microsoft.com/office/drawing/2014/main" id="{E9DCF33E-D69D-4E9F-94EF-51898C28FD37}"/>
               </a:ext>
             </a:extLst>
           </p:cNvPr>
@@ -20808,7 +20808,7 @@
           <p:cNvPr id="9" name="">
             <a:extLst xmlns:a="http://schemas.openxmlformats.org/drawingml/2006/main">
               <a:ext uri="{FF2B5EF4-FFF2-40B4-BE49-F238E27FC236}">
-                <a16:creationId xmlns:a16="http://schemas.microsoft.com/office/drawing/2014/main" id="{51940C17-A9E9-4AFA-9302-94674BD00632}"/>
+                <a16:creationId xmlns:a16="http://schemas.microsoft.com/office/drawing/2014/main" id="{DD95BA0C-CB7E-42A8-BB08-A1334B7FB359}"/>
               </a:ext>
             </a:extLst>
           </p:cNvPr>
@@ -20839,7 +20839,7 @@
           <p:cNvPr id="10" name="">
             <a:extLst xmlns:a="http://schemas.openxmlformats.org/drawingml/2006/main">
               <a:ext uri="{FF2B5EF4-FFF2-40B4-BE49-F238E27FC236}">
-                <a16:creationId xmlns:a16="http://schemas.microsoft.com/office/drawing/2014/main" id="{083378CB-4E60-4466-8523-4574F8605984}"/>
+                <a16:creationId xmlns:a16="http://schemas.microsoft.com/office/drawing/2014/main" id="{BC7378D3-6712-4CB7-803C-08A7041DE90F}"/>
               </a:ext>
             </a:extLst>
           </p:cNvPr>
@@ -20874,7 +20874,7 @@
           <p:cNvPr id="11" name="">
             <a:extLst xmlns:a="http://schemas.openxmlformats.org/drawingml/2006/main">
               <a:ext uri="{FF2B5EF4-FFF2-40B4-BE49-F238E27FC236}">
-                <a16:creationId xmlns:a16="http://schemas.microsoft.com/office/drawing/2014/main" id="{99836581-D866-49A4-BE95-B6FB28546C7A}"/>
+                <a16:creationId xmlns:a16="http://schemas.microsoft.com/office/drawing/2014/main" id="{9E4EF870-C990-415B-9832-C0FF073E99E3}"/>
               </a:ext>
             </a:extLst>
           </p:cNvPr>
@@ -21031,7 +21031,7 @@
           <p:cNvPr id="12" name="">
             <a:extLst xmlns:a="http://schemas.openxmlformats.org/drawingml/2006/main">
               <a:ext uri="{FF2B5EF4-FFF2-40B4-BE49-F238E27FC236}">
-                <a16:creationId xmlns:a16="http://schemas.microsoft.com/office/drawing/2014/main" id="{88F5BF3C-5327-44B7-8CD1-1E2E5E0E0FCA}"/>
+                <a16:creationId xmlns:a16="http://schemas.microsoft.com/office/drawing/2014/main" id="{B74EE040-5B12-4954-BC6A-7142CED19E5D}"/>
               </a:ext>
             </a:extLst>
           </p:cNvPr>
@@ -21211,7 +21211,7 @@
           <p:cNvPr id="13" name="">
             <a:extLst xmlns:a="http://schemas.openxmlformats.org/drawingml/2006/main">
               <a:ext uri="{FF2B5EF4-FFF2-40B4-BE49-F238E27FC236}">
-                <a16:creationId xmlns:a16="http://schemas.microsoft.com/office/drawing/2014/main" id="{3AAC5161-7211-450F-B8A5-1B115D714AC4}"/>
+                <a16:creationId xmlns:a16="http://schemas.microsoft.com/office/drawing/2014/main" id="{8BE6521B-0D2A-450F-B699-5D1752B0C145}"/>
               </a:ext>
             </a:extLst>
           </p:cNvPr>
@@ -21242,7 +21242,7 @@
           <p:cNvPr id="14" name="">
             <a:extLst xmlns:a="http://schemas.openxmlformats.org/drawingml/2006/main">
               <a:ext uri="{FF2B5EF4-FFF2-40B4-BE49-F238E27FC236}">
-                <a16:creationId xmlns:a16="http://schemas.microsoft.com/office/drawing/2014/main" id="{C8FA8C1D-52D7-40E2-9BC4-C33457D54DE1}"/>
+                <a16:creationId xmlns:a16="http://schemas.microsoft.com/office/drawing/2014/main" id="{0C4FB5EA-5636-4C79-906B-5DB270EA6925}"/>
               </a:ext>
             </a:extLst>
           </p:cNvPr>
@@ -21277,7 +21277,7 @@
           <p:cNvPr id="15" name="">
             <a:extLst xmlns:a="http://schemas.openxmlformats.org/drawingml/2006/main">
               <a:ext uri="{FF2B5EF4-FFF2-40B4-BE49-F238E27FC236}">
-                <a16:creationId xmlns:a16="http://schemas.microsoft.com/office/drawing/2014/main" id="{8D352C47-CD36-438A-95EF-E54375E324AD}"/>
+                <a16:creationId xmlns:a16="http://schemas.microsoft.com/office/drawing/2014/main" id="{2534F4EE-C441-4CA2-9D5A-02547B2C4D37}"/>
               </a:ext>
             </a:extLst>
           </p:cNvPr>
@@ -21434,7 +21434,7 @@
           <p:cNvPr id="16" name="">
             <a:extLst xmlns:a="http://schemas.openxmlformats.org/drawingml/2006/main">
               <a:ext uri="{FF2B5EF4-FFF2-40B4-BE49-F238E27FC236}">
-                <a16:creationId xmlns:a16="http://schemas.microsoft.com/office/drawing/2014/main" id="{64C62916-F448-4CF2-8036-AEEAD45B76D7}"/>
+                <a16:creationId xmlns:a16="http://schemas.microsoft.com/office/drawing/2014/main" id="{7F40260C-FAF9-4E7F-B1E8-704CD06044C0}"/>
               </a:ext>
             </a:extLst>
           </p:cNvPr>
@@ -21614,7 +21614,7 @@
           <p:cNvPr id="17" name="">
             <a:extLst xmlns:a="http://schemas.openxmlformats.org/drawingml/2006/main">
               <a:ext uri="{FF2B5EF4-FFF2-40B4-BE49-F238E27FC236}">
-                <a16:creationId xmlns:a16="http://schemas.microsoft.com/office/drawing/2014/main" id="{94D36DA3-BB38-46E5-A952-4A5FBB6E464C}"/>
+                <a16:creationId xmlns:a16="http://schemas.microsoft.com/office/drawing/2014/main" id="{12C7E5DD-8BB2-4736-9BC4-283BEAE7A48A}"/>
               </a:ext>
             </a:extLst>
           </p:cNvPr>
@@ -21645,7 +21645,7 @@
           <p:cNvPr id="18" name="">
             <a:extLst xmlns:a="http://schemas.openxmlformats.org/drawingml/2006/main">
               <a:ext uri="{FF2B5EF4-FFF2-40B4-BE49-F238E27FC236}">
-                <a16:creationId xmlns:a16="http://schemas.microsoft.com/office/drawing/2014/main" id="{FB699BEC-3802-4F69-9282-D0074C472C85}"/>
+                <a16:creationId xmlns:a16="http://schemas.microsoft.com/office/drawing/2014/main" id="{04C19110-9230-4C09-B2A9-2C4457F1444D}"/>
               </a:ext>
             </a:extLst>
           </p:cNvPr>
@@ -21680,7 +21680,7 @@
           <p:cNvPr id="19" name="">
             <a:extLst xmlns:a="http://schemas.openxmlformats.org/drawingml/2006/main">
               <a:ext uri="{FF2B5EF4-FFF2-40B4-BE49-F238E27FC236}">
-                <a16:creationId xmlns:a16="http://schemas.microsoft.com/office/drawing/2014/main" id="{697BE19D-2841-465C-8811-C31614C337B6}"/>
+                <a16:creationId xmlns:a16="http://schemas.microsoft.com/office/drawing/2014/main" id="{09B0292C-0856-4AD2-86A9-E1B906721A6E}"/>
               </a:ext>
             </a:extLst>
           </p:cNvPr>
@@ -21837,7 +21837,7 @@
           <p:cNvPr id="20" name="">
             <a:extLst xmlns:a="http://schemas.openxmlformats.org/drawingml/2006/main">
               <a:ext uri="{FF2B5EF4-FFF2-40B4-BE49-F238E27FC236}">
-                <a16:creationId xmlns:a16="http://schemas.microsoft.com/office/drawing/2014/main" id="{AD64094E-1B0E-4576-88EF-8875765688AA}"/>
+                <a16:creationId xmlns:a16="http://schemas.microsoft.com/office/drawing/2014/main" id="{530B5A01-681D-477B-AC97-AB79829F8BFA}"/>
               </a:ext>
             </a:extLst>
           </p:cNvPr>
@@ -22017,7 +22017,7 @@
           <p:cNvPr id="21" name="">
             <a:extLst xmlns:a="http://schemas.openxmlformats.org/drawingml/2006/main">
               <a:ext uri="{FF2B5EF4-FFF2-40B4-BE49-F238E27FC236}">
-                <a16:creationId xmlns:a16="http://schemas.microsoft.com/office/drawing/2014/main" id="{009C02A0-4CEF-424D-AE89-E620DA0C61C5}"/>
+                <a16:creationId xmlns:a16="http://schemas.microsoft.com/office/drawing/2014/main" id="{5963BE41-F828-4608-9449-16754CE13A01}"/>
               </a:ext>
             </a:extLst>
           </p:cNvPr>
@@ -22048,7 +22048,7 @@
           <p:cNvPr id="22" name="">
             <a:extLst xmlns:a="http://schemas.openxmlformats.org/drawingml/2006/main">
               <a:ext uri="{FF2B5EF4-FFF2-40B4-BE49-F238E27FC236}">
-                <a16:creationId xmlns:a16="http://schemas.microsoft.com/office/drawing/2014/main" id="{0A11E4AB-A018-4255-8203-12A1D12189B9}"/>
+                <a16:creationId xmlns:a16="http://schemas.microsoft.com/office/drawing/2014/main" id="{39791F35-A0AE-4286-992C-25EC3C62A3C2}"/>
               </a:ext>
             </a:extLst>
           </p:cNvPr>
@@ -22079,7 +22079,7 @@
           <p:cNvPr id="23" name="">
             <a:extLst xmlns:a="http://schemas.openxmlformats.org/drawingml/2006/main">
               <a:ext uri="{FF2B5EF4-FFF2-40B4-BE49-F238E27FC236}">
-                <a16:creationId xmlns:a16="http://schemas.microsoft.com/office/drawing/2014/main" id="{61815E64-2036-4875-9637-F58E79A4A15B}"/>
+                <a16:creationId xmlns:a16="http://schemas.microsoft.com/office/drawing/2014/main" id="{4D116F53-E3EB-4C6F-97A4-7B47D45F8A45}"/>
               </a:ext>
             </a:extLst>
           </p:cNvPr>
@@ -22110,7 +22110,7 @@
           <p:cNvPr id="24" name="">
             <a:extLst xmlns:a="http://schemas.openxmlformats.org/drawingml/2006/main">
               <a:ext uri="{FF2B5EF4-FFF2-40B4-BE49-F238E27FC236}">
-                <a16:creationId xmlns:a16="http://schemas.microsoft.com/office/drawing/2014/main" id="{5574F836-D2A6-4DDF-95EB-FF2558B68B3B}"/>
+                <a16:creationId xmlns:a16="http://schemas.microsoft.com/office/drawing/2014/main" id="{EF931DAC-1053-4009-ACCE-F921CEE359C2}"/>
               </a:ext>
             </a:extLst>
           </p:cNvPr>
@@ -22267,7 +22267,7 @@
           <p:cNvPr id="25" name="">
             <a:extLst xmlns:a="http://schemas.openxmlformats.org/drawingml/2006/main">
               <a:ext uri="{FF2B5EF4-FFF2-40B4-BE49-F238E27FC236}">
-                <a16:creationId xmlns:a16="http://schemas.microsoft.com/office/drawing/2014/main" id="{63EA2031-87D4-41F6-9B5B-490060A8AEA0}"/>
+                <a16:creationId xmlns:a16="http://schemas.microsoft.com/office/drawing/2014/main" id="{10E6B948-94E6-4427-9B71-A8CFFC9B40AA}"/>
               </a:ext>
             </a:extLst>
           </p:cNvPr>
@@ -22424,7 +22424,7 @@
           <p:cNvPr id="26" name="">
             <a:extLst xmlns:a="http://schemas.openxmlformats.org/drawingml/2006/main">
               <a:ext uri="{FF2B5EF4-FFF2-40B4-BE49-F238E27FC236}">
-                <a16:creationId xmlns:a16="http://schemas.microsoft.com/office/drawing/2014/main" id="{E267A624-2EEF-416E-AF90-E89228EA333A}"/>
+                <a16:creationId xmlns:a16="http://schemas.microsoft.com/office/drawing/2014/main" id="{FC7C04A3-9905-4876-83B4-63D4334F2260}"/>
               </a:ext>
             </a:extLst>
           </p:cNvPr>
@@ -22581,7 +22581,7 @@
           <p:cNvPr id="27" name="">
             <a:extLst xmlns:a="http://schemas.openxmlformats.org/drawingml/2006/main">
               <a:ext uri="{FF2B5EF4-FFF2-40B4-BE49-F238E27FC236}">
-                <a16:creationId xmlns:a16="http://schemas.microsoft.com/office/drawing/2014/main" id="{138360D5-1BAC-4140-9E0B-10B904DADE45}"/>
+                <a16:creationId xmlns:a16="http://schemas.microsoft.com/office/drawing/2014/main" id="{8D7C2DDE-4866-495B-A3B0-E42966D2FCA4}"/>
               </a:ext>
             </a:extLst>
           </p:cNvPr>
@@ -22761,7 +22761,7 @@
           <p:cNvPr id="28" name="">
             <a:extLst xmlns:a="http://schemas.openxmlformats.org/drawingml/2006/main">
               <a:ext uri="{FF2B5EF4-FFF2-40B4-BE49-F238E27FC236}">
-                <a16:creationId xmlns:a16="http://schemas.microsoft.com/office/drawing/2014/main" id="{6A1282AB-DE58-4843-80AE-F186452A2D7E}"/>
+                <a16:creationId xmlns:a16="http://schemas.microsoft.com/office/drawing/2014/main" id="{5E17F121-18BA-4DDF-A421-961E3A540CEE}"/>
               </a:ext>
             </a:extLst>
           </p:cNvPr>
@@ -22918,7 +22918,7 @@
           <p:cNvPr id="29" name="">
             <a:extLst xmlns:a="http://schemas.openxmlformats.org/drawingml/2006/main">
               <a:ext uri="{FF2B5EF4-FFF2-40B4-BE49-F238E27FC236}">
-                <a16:creationId xmlns:a16="http://schemas.microsoft.com/office/drawing/2014/main" id="{5F8FF7CC-6407-48C3-9380-637B54C27832}"/>
+                <a16:creationId xmlns:a16="http://schemas.microsoft.com/office/drawing/2014/main" id="{3BE0CD98-8187-4B49-82F0-F9100BFEE4DB}"/>
               </a:ext>
             </a:extLst>
           </p:cNvPr>
@@ -23098,7 +23098,7 @@
           <p:cNvPr id="30" name="">
             <a:extLst xmlns:a="http://schemas.openxmlformats.org/drawingml/2006/main">
               <a:ext uri="{FF2B5EF4-FFF2-40B4-BE49-F238E27FC236}">
-                <a16:creationId xmlns:a16="http://schemas.microsoft.com/office/drawing/2014/main" id="{97714D7A-F445-45B7-98ED-7F6482B2605B}"/>
+                <a16:creationId xmlns:a16="http://schemas.microsoft.com/office/drawing/2014/main" id="{789D099F-B028-46A4-B40D-C01DA9903DD9}"/>
               </a:ext>
             </a:extLst>
           </p:cNvPr>
@@ -23255,7 +23255,7 @@
           <p:cNvPr id="31" name="">
             <a:extLst xmlns:a="http://schemas.openxmlformats.org/drawingml/2006/main">
               <a:ext uri="{FF2B5EF4-FFF2-40B4-BE49-F238E27FC236}">
-                <a16:creationId xmlns:a16="http://schemas.microsoft.com/office/drawing/2014/main" id="{548FA199-337C-4A49-B18C-5EA106F1EE65}"/>
+                <a16:creationId xmlns:a16="http://schemas.microsoft.com/office/drawing/2014/main" id="{74261840-EA76-4054-99F3-C4AEF129777E}"/>
               </a:ext>
             </a:extLst>
           </p:cNvPr>
@@ -23435,7 +23435,7 @@
           <p:cNvPr id="32" name="">
             <a:extLst xmlns:a="http://schemas.openxmlformats.org/drawingml/2006/main">
               <a:ext uri="{FF2B5EF4-FFF2-40B4-BE49-F238E27FC236}">
-                <a16:creationId xmlns:a16="http://schemas.microsoft.com/office/drawing/2014/main" id="{145265F5-02AB-44EB-AB19-3751CEFDA724}"/>
+                <a16:creationId xmlns:a16="http://schemas.microsoft.com/office/drawing/2014/main" id="{F6614E09-DAA2-4C03-AFFA-BA1747763C31}"/>
               </a:ext>
             </a:extLst>
           </p:cNvPr>
@@ -23590,7 +23590,7 @@
     </p:spTree>
     <p:extLst>
       <p:ext uri="{BB962C8B-B14F-4D97-AF65-F5344CB8AC3E}">
-        <p14:creationId xmlns:p14="http://schemas.microsoft.com/office/powerpoint/2010/main" val="198145594"/>
+        <p14:creationId xmlns:p14="http://schemas.microsoft.com/office/powerpoint/2010/main" val="1353554800"/>
       </p:ext>
     </p:extLst>
   </p:cSld>
@@ -23621,7 +23621,7 @@
           <p:cNvPr id="26" name="">
             <a:extLst xmlns:a="http://schemas.openxmlformats.org/drawingml/2006/main">
               <a:ext uri="{FF2B5EF4-FFF2-40B4-BE49-F238E27FC236}">
-                <a16:creationId xmlns:a16="http://schemas.microsoft.com/office/drawing/2014/main" id="{D6BC54E8-CBCA-4269-9D40-4F2611137272}"/>
+                <a16:creationId xmlns:a16="http://schemas.microsoft.com/office/drawing/2014/main" id="{AE9D3039-9EA3-4F1A-BE8C-523BCF86D8C0}"/>
               </a:ext>
             </a:extLst>
           </p:cNvPr>
@@ -23778,7 +23778,7 @@
           <p:cNvPr id="2" name="">
             <a:extLst xmlns:a="http://schemas.openxmlformats.org/drawingml/2006/main">
               <a:ext uri="{FF2B5EF4-FFF2-40B4-BE49-F238E27FC236}">
-                <a16:creationId xmlns:a16="http://schemas.microsoft.com/office/drawing/2014/main" id="{EAB0EF57-5B47-4D82-A2BD-5377A48D9E3D}"/>
+                <a16:creationId xmlns:a16="http://schemas.microsoft.com/office/drawing/2014/main" id="{23040F2E-B5DF-4738-9F2C-22201199DDA2}"/>
               </a:ext>
             </a:extLst>
           </p:cNvPr>
@@ -23809,7 +23809,7 @@
           <p:cNvPr id="3" name="">
             <a:extLst xmlns:a="http://schemas.openxmlformats.org/drawingml/2006/main">
               <a:ext uri="{FF2B5EF4-FFF2-40B4-BE49-F238E27FC236}">
-                <a16:creationId xmlns:a16="http://schemas.microsoft.com/office/drawing/2014/main" id="{4211114C-53BA-4A6F-820C-54B127924255}"/>
+                <a16:creationId xmlns:a16="http://schemas.microsoft.com/office/drawing/2014/main" id="{433D1355-5AB7-4177-9145-379F9F77DDD7}"/>
               </a:ext>
             </a:extLst>
           </p:cNvPr>
@@ -23966,7 +23966,7 @@
           <p:cNvPr id="4" name="">
             <a:extLst xmlns:a="http://schemas.openxmlformats.org/drawingml/2006/main">
               <a:ext uri="{FF2B5EF4-FFF2-40B4-BE49-F238E27FC236}">
-                <a16:creationId xmlns:a16="http://schemas.microsoft.com/office/drawing/2014/main" id="{746727D1-FE6F-43C8-9B79-B4D95B716E80}"/>
+                <a16:creationId xmlns:a16="http://schemas.microsoft.com/office/drawing/2014/main" id="{A8042ABF-537E-4729-997F-276656DF11BD}"/>
               </a:ext>
             </a:extLst>
           </p:cNvPr>
@@ -24123,7 +24123,7 @@
           <p:cNvPr id="5" name="">
             <a:extLst xmlns:a="http://schemas.openxmlformats.org/drawingml/2006/main">
               <a:ext uri="{FF2B5EF4-FFF2-40B4-BE49-F238E27FC236}">
-                <a16:creationId xmlns:a16="http://schemas.microsoft.com/office/drawing/2014/main" id="{09B5D634-E4FB-4856-A2ED-DDBCEB911E91}"/>
+                <a16:creationId xmlns:a16="http://schemas.microsoft.com/office/drawing/2014/main" id="{C8415E3B-DD8F-4EAE-90CB-46B00CD92FBE}"/>
               </a:ext>
             </a:extLst>
           </p:cNvPr>
@@ -24280,7 +24280,7 @@
           <p:cNvPr id="6" name="">
             <a:extLst xmlns:a="http://schemas.openxmlformats.org/drawingml/2006/main">
               <a:ext uri="{FF2B5EF4-FFF2-40B4-BE49-F238E27FC236}">
-                <a16:creationId xmlns:a16="http://schemas.microsoft.com/office/drawing/2014/main" id="{8438DBB0-6AB4-47E4-8475-8C0EB004C39C}"/>
+                <a16:creationId xmlns:a16="http://schemas.microsoft.com/office/drawing/2014/main" id="{CD9F08F9-414F-40E2-91D1-801BF9F9B1B4}"/>
               </a:ext>
             </a:extLst>
           </p:cNvPr>
@@ -24437,7 +24437,7 @@
           <p:cNvPr id="7" name="">
             <a:extLst xmlns:a="http://schemas.openxmlformats.org/drawingml/2006/main">
               <a:ext uri="{FF2B5EF4-FFF2-40B4-BE49-F238E27FC236}">
-                <a16:creationId xmlns:a16="http://schemas.microsoft.com/office/drawing/2014/main" id="{6F274C51-AD2B-4707-8452-BB6EEF803DC6}"/>
+                <a16:creationId xmlns:a16="http://schemas.microsoft.com/office/drawing/2014/main" id="{2764EE41-38BA-423E-B806-213A00EBC575}"/>
               </a:ext>
             </a:extLst>
           </p:cNvPr>
@@ -24468,7 +24468,7 @@
           <p:cNvPr id="8" name="">
             <a:extLst xmlns:a="http://schemas.openxmlformats.org/drawingml/2006/main">
               <a:ext uri="{FF2B5EF4-FFF2-40B4-BE49-F238E27FC236}">
-                <a16:creationId xmlns:a16="http://schemas.microsoft.com/office/drawing/2014/main" id="{65439DAF-E269-4176-BFD0-8AD4948129B0}"/>
+                <a16:creationId xmlns:a16="http://schemas.microsoft.com/office/drawing/2014/main" id="{905A7643-1823-4DD1-B37E-9C7AD578D644}"/>
               </a:ext>
             </a:extLst>
           </p:cNvPr>
@@ -24625,7 +24625,7 @@
           <p:cNvPr id="9" name="">
             <a:extLst xmlns:a="http://schemas.openxmlformats.org/drawingml/2006/main">
               <a:ext uri="{FF2B5EF4-FFF2-40B4-BE49-F238E27FC236}">
-                <a16:creationId xmlns:a16="http://schemas.microsoft.com/office/drawing/2014/main" id="{B250B03E-8F67-488E-B240-182647BC20AC}"/>
+                <a16:creationId xmlns:a16="http://schemas.microsoft.com/office/drawing/2014/main" id="{0A8C3408-322A-4FDD-BF4E-53E88B67B25D}"/>
               </a:ext>
             </a:extLst>
           </p:cNvPr>
@@ -24782,7 +24782,7 @@
           <p:cNvPr id="10" name="">
             <a:extLst xmlns:a="http://schemas.openxmlformats.org/drawingml/2006/main">
               <a:ext uri="{FF2B5EF4-FFF2-40B4-BE49-F238E27FC236}">
-                <a16:creationId xmlns:a16="http://schemas.microsoft.com/office/drawing/2014/main" id="{3FA95402-2087-4581-8CBA-B43E85672738}"/>
+                <a16:creationId xmlns:a16="http://schemas.microsoft.com/office/drawing/2014/main" id="{0556BD41-5951-4A5A-87E4-4957B3A6396F}"/>
               </a:ext>
             </a:extLst>
           </p:cNvPr>
@@ -24813,7 +24813,7 @@
           <p:cNvPr id="11" name="">
             <a:extLst xmlns:a="http://schemas.openxmlformats.org/drawingml/2006/main">
               <a:ext uri="{FF2B5EF4-FFF2-40B4-BE49-F238E27FC236}">
-                <a16:creationId xmlns:a16="http://schemas.microsoft.com/office/drawing/2014/main" id="{F42F1EBC-6F0D-4100-B14F-8661C2761C8D}"/>
+                <a16:creationId xmlns:a16="http://schemas.microsoft.com/office/drawing/2014/main" id="{9C42CD0F-C24E-4C21-93D2-72F68EDEED12}"/>
               </a:ext>
             </a:extLst>
           </p:cNvPr>
@@ -24970,7 +24970,7 @@
           <p:cNvPr id="12" name="">
             <a:extLst xmlns:a="http://schemas.openxmlformats.org/drawingml/2006/main">
               <a:ext uri="{FF2B5EF4-FFF2-40B4-BE49-F238E27FC236}">
-                <a16:creationId xmlns:a16="http://schemas.microsoft.com/office/drawing/2014/main" id="{58FB8208-ED8E-4AE0-AA44-1D3EA2AF7E0B}"/>
+                <a16:creationId xmlns:a16="http://schemas.microsoft.com/office/drawing/2014/main" id="{508B72C6-3CCE-420B-A9F8-2C52D64A6442}"/>
               </a:ext>
             </a:extLst>
           </p:cNvPr>
@@ -25127,7 +25127,7 @@
           <p:cNvPr id="13" name="">
             <a:extLst xmlns:a="http://schemas.openxmlformats.org/drawingml/2006/main">
               <a:ext uri="{FF2B5EF4-FFF2-40B4-BE49-F238E27FC236}">
-                <a16:creationId xmlns:a16="http://schemas.microsoft.com/office/drawing/2014/main" id="{A413EAF3-6E1C-4FC6-A7D2-F5D3C48855D0}"/>
+                <a16:creationId xmlns:a16="http://schemas.microsoft.com/office/drawing/2014/main" id="{CC80DD1A-799E-46E4-B23D-B1DB7A3A1CD3}"/>
               </a:ext>
             </a:extLst>
           </p:cNvPr>
@@ -25158,7 +25158,7 @@
           <p:cNvPr id="14" name="">
             <a:extLst xmlns:a="http://schemas.openxmlformats.org/drawingml/2006/main">
               <a:ext uri="{FF2B5EF4-FFF2-40B4-BE49-F238E27FC236}">
-                <a16:creationId xmlns:a16="http://schemas.microsoft.com/office/drawing/2014/main" id="{D8A2040C-01F2-4C45-B3B0-B61DCA429AC8}"/>
+                <a16:creationId xmlns:a16="http://schemas.microsoft.com/office/drawing/2014/main" id="{995728FD-9FFA-4CE6-B199-D5973F155653}"/>
               </a:ext>
             </a:extLst>
           </p:cNvPr>
@@ -25315,7 +25315,7 @@
           <p:cNvPr id="15" name="">
             <a:extLst xmlns:a="http://schemas.openxmlformats.org/drawingml/2006/main">
               <a:ext uri="{FF2B5EF4-FFF2-40B4-BE49-F238E27FC236}">
-                <a16:creationId xmlns:a16="http://schemas.microsoft.com/office/drawing/2014/main" id="{D0C6E401-2871-4AAE-A904-B39AA099E898}"/>
+                <a16:creationId xmlns:a16="http://schemas.microsoft.com/office/drawing/2014/main" id="{D6178011-56D2-425B-B4A4-A65D620D0C44}"/>
               </a:ext>
             </a:extLst>
           </p:cNvPr>
@@ -25472,7 +25472,7 @@
           <p:cNvPr id="16" name="">
             <a:extLst xmlns:a="http://schemas.openxmlformats.org/drawingml/2006/main">
               <a:ext uri="{FF2B5EF4-FFF2-40B4-BE49-F238E27FC236}">
-                <a16:creationId xmlns:a16="http://schemas.microsoft.com/office/drawing/2014/main" id="{64D6456F-5C62-4E34-9728-9043BC23106B}"/>
+                <a16:creationId xmlns:a16="http://schemas.microsoft.com/office/drawing/2014/main" id="{4B83E941-C4FE-4B54-8F91-AC9EB2624635}"/>
               </a:ext>
             </a:extLst>
           </p:cNvPr>
@@ -25503,7 +25503,7 @@
           <p:cNvPr id="17" name="">
             <a:extLst xmlns:a="http://schemas.openxmlformats.org/drawingml/2006/main">
               <a:ext uri="{FF2B5EF4-FFF2-40B4-BE49-F238E27FC236}">
-                <a16:creationId xmlns:a16="http://schemas.microsoft.com/office/drawing/2014/main" id="{82A263B3-CBB0-4BF3-A43C-74637CF7DF5F}"/>
+                <a16:creationId xmlns:a16="http://schemas.microsoft.com/office/drawing/2014/main" id="{314B327A-6031-4771-857C-934723A228B1}"/>
               </a:ext>
             </a:extLst>
           </p:cNvPr>
@@ -25660,7 +25660,7 @@
           <p:cNvPr id="18" name="">
             <a:extLst xmlns:a="http://schemas.openxmlformats.org/drawingml/2006/main">
               <a:ext uri="{FF2B5EF4-FFF2-40B4-BE49-F238E27FC236}">
-                <a16:creationId xmlns:a16="http://schemas.microsoft.com/office/drawing/2014/main" id="{1CB01E83-EDC6-4FD8-9C6C-C795B5489FB6}"/>
+                <a16:creationId xmlns:a16="http://schemas.microsoft.com/office/drawing/2014/main" id="{400CBE5F-8413-4A60-A309-F7FA273606CC}"/>
               </a:ext>
             </a:extLst>
           </p:cNvPr>
@@ -25817,7 +25817,7 @@
           <p:cNvPr id="19" name="">
             <a:extLst xmlns:a="http://schemas.openxmlformats.org/drawingml/2006/main">
               <a:ext uri="{FF2B5EF4-FFF2-40B4-BE49-F238E27FC236}">
-                <a16:creationId xmlns:a16="http://schemas.microsoft.com/office/drawing/2014/main" id="{65C449AA-37B3-4C1C-BF31-80E3EFB381F1}"/>
+                <a16:creationId xmlns:a16="http://schemas.microsoft.com/office/drawing/2014/main" id="{5CF2A605-2C7D-462D-9160-D4912C0FC505}"/>
               </a:ext>
             </a:extLst>
           </p:cNvPr>
@@ -25974,7 +25974,7 @@
           <p:cNvPr id="20" name="">
             <a:extLst xmlns:a="http://schemas.openxmlformats.org/drawingml/2006/main">
               <a:ext uri="{FF2B5EF4-FFF2-40B4-BE49-F238E27FC236}">
-                <a16:creationId xmlns:a16="http://schemas.microsoft.com/office/drawing/2014/main" id="{2ECEF088-0814-4829-B404-5019D5A5164D}"/>
+                <a16:creationId xmlns:a16="http://schemas.microsoft.com/office/drawing/2014/main" id="{D8798E3F-DA84-4E62-BA6D-66EA0CE40C57}"/>
               </a:ext>
             </a:extLst>
           </p:cNvPr>
@@ -26131,7 +26131,7 @@
           <p:cNvPr id="21" name="">
             <a:extLst xmlns:a="http://schemas.openxmlformats.org/drawingml/2006/main">
               <a:ext uri="{FF2B5EF4-FFF2-40B4-BE49-F238E27FC236}">
-                <a16:creationId xmlns:a16="http://schemas.microsoft.com/office/drawing/2014/main" id="{1911A451-7F3A-48DA-819E-202FA091A91E}"/>
+                <a16:creationId xmlns:a16="http://schemas.microsoft.com/office/drawing/2014/main" id="{BE408F92-3B78-4AF4-8DFB-89014A307859}"/>
               </a:ext>
             </a:extLst>
           </p:cNvPr>
@@ -26311,7 +26311,7 @@
           <p:cNvPr id="22" name="">
             <a:extLst xmlns:a="http://schemas.openxmlformats.org/drawingml/2006/main">
               <a:ext uri="{FF2B5EF4-FFF2-40B4-BE49-F238E27FC236}">
-                <a16:creationId xmlns:a16="http://schemas.microsoft.com/office/drawing/2014/main" id="{CC8500F8-E0BD-4872-AEEC-734BDAEC7763}"/>
+                <a16:creationId xmlns:a16="http://schemas.microsoft.com/office/drawing/2014/main" id="{746998A7-DA73-4600-8ED6-2047F811E896}"/>
               </a:ext>
             </a:extLst>
           </p:cNvPr>
@@ -26468,7 +26468,7 @@
           <p:cNvPr id="23" name="">
             <a:extLst xmlns:a="http://schemas.openxmlformats.org/drawingml/2006/main">
               <a:ext uri="{FF2B5EF4-FFF2-40B4-BE49-F238E27FC236}">
-                <a16:creationId xmlns:a16="http://schemas.microsoft.com/office/drawing/2014/main" id="{7692E793-32BB-4C98-A249-75B0C5BE93AD}"/>
+                <a16:creationId xmlns:a16="http://schemas.microsoft.com/office/drawing/2014/main" id="{F8D246E1-6BA8-415C-B3E1-0544F530A86B}"/>
               </a:ext>
             </a:extLst>
           </p:cNvPr>
@@ -26648,7 +26648,7 @@
           <p:cNvPr id="24" name="">
             <a:extLst xmlns:a="http://schemas.openxmlformats.org/drawingml/2006/main">
               <a:ext uri="{FF2B5EF4-FFF2-40B4-BE49-F238E27FC236}">
-                <a16:creationId xmlns:a16="http://schemas.microsoft.com/office/drawing/2014/main" id="{1A5FB980-ABEC-4EF0-A015-DA8B54DEAB66}"/>
+                <a16:creationId xmlns:a16="http://schemas.microsoft.com/office/drawing/2014/main" id="{3D668430-4572-4732-87D0-322D4C8C61EE}"/>
               </a:ext>
             </a:extLst>
           </p:cNvPr>
@@ -26805,7 +26805,7 @@
           <p:cNvPr id="25" name="">
             <a:extLst xmlns:a="http://schemas.openxmlformats.org/drawingml/2006/main">
               <a:ext uri="{FF2B5EF4-FFF2-40B4-BE49-F238E27FC236}">
-                <a16:creationId xmlns:a16="http://schemas.microsoft.com/office/drawing/2014/main" id="{B21CE6A3-74E1-4504-BB8B-1BF0E0AFFE7A}"/>
+                <a16:creationId xmlns:a16="http://schemas.microsoft.com/office/drawing/2014/main" id="{AA1E647D-2CE0-4D57-90F0-A239D48EB4AB}"/>
               </a:ext>
             </a:extLst>
           </p:cNvPr>
@@ -26952,7 +26952,7 @@
                 <a:ea typeface="Arial"/>
                 <a:cs typeface="Arial"/>
               </a:rPr>
-              <a:t>84 focused tests pass. Recovery router not live-compared; tokens / inference latency unavailable.</a:t>
+              <a:t>85 focused tests pass. Recovery router not live-compared; tokens / inference latency unavailable.</a:t>
             </a:r>
           </a:p>
         </p:txBody>
@@ -26960,7 +26960,7 @@
     </p:spTree>
     <p:extLst>
       <p:ext uri="{BB962C8B-B14F-4D97-AF65-F5344CB8AC3E}">
-        <p14:creationId xmlns:p14="http://schemas.microsoft.com/office/powerpoint/2010/main" val="835441529"/>
+        <p14:creationId xmlns:p14="http://schemas.microsoft.com/office/powerpoint/2010/main" val="1733200023"/>
       </p:ext>
     </p:extLst>
   </p:cSld>
@@ -26991,7 +26991,7 @@
           <p:cNvPr id="9" name="">
             <a:extLst xmlns:a="http://schemas.openxmlformats.org/drawingml/2006/main">
               <a:ext uri="{FF2B5EF4-FFF2-40B4-BE49-F238E27FC236}">
-                <a16:creationId xmlns:a16="http://schemas.microsoft.com/office/drawing/2014/main" id="{06C98519-B810-4060-8D6F-14787579A0CF}"/>
+                <a16:creationId xmlns:a16="http://schemas.microsoft.com/office/drawing/2014/main" id="{8004C2A7-E473-496E-A47B-4DA544E212B3}"/>
               </a:ext>
             </a:extLst>
           </p:cNvPr>
@@ -27148,7 +27148,7 @@
           <p:cNvPr id="2" name="">
             <a:extLst xmlns:a="http://schemas.openxmlformats.org/drawingml/2006/main">
               <a:ext uri="{FF2B5EF4-FFF2-40B4-BE49-F238E27FC236}">
-                <a16:creationId xmlns:a16="http://schemas.microsoft.com/office/drawing/2014/main" id="{33A1ED0C-B095-4C3C-8485-B7C82E9FF190}"/>
+                <a16:creationId xmlns:a16="http://schemas.microsoft.com/office/drawing/2014/main" id="{D8E5D30F-1FB6-40DD-A161-5F901B9C652C}"/>
               </a:ext>
             </a:extLst>
           </p:cNvPr>
@@ -27179,7 +27179,7 @@
           <p:cNvPr id="3" name="">
             <a:extLst xmlns:a="http://schemas.openxmlformats.org/drawingml/2006/main">
               <a:ext uri="{FF2B5EF4-FFF2-40B4-BE49-F238E27FC236}">
-                <a16:creationId xmlns:a16="http://schemas.microsoft.com/office/drawing/2014/main" id="{9F6491AD-7EAA-455C-8C38-BEF7A7C2826C}"/>
+                <a16:creationId xmlns:a16="http://schemas.microsoft.com/office/drawing/2014/main" id="{28476BD1-FE69-4787-8F81-FA8A32773B09}"/>
               </a:ext>
             </a:extLst>
           </p:cNvPr>
@@ -27336,7 +27336,7 @@
           <p:cNvPr id="4" name="">
             <a:extLst xmlns:a="http://schemas.openxmlformats.org/drawingml/2006/main">
               <a:ext uri="{FF2B5EF4-FFF2-40B4-BE49-F238E27FC236}">
-                <a16:creationId xmlns:a16="http://schemas.microsoft.com/office/drawing/2014/main" id="{8A3BA4E8-B547-4314-A70C-48703529579D}"/>
+                <a16:creationId xmlns:a16="http://schemas.microsoft.com/office/drawing/2014/main" id="{DD6BC649-A1E4-440C-A4B9-912EB5C7C245}"/>
               </a:ext>
             </a:extLst>
           </p:cNvPr>
@@ -27493,7 +27493,7 @@
           <p:cNvPr id="5" name="">
             <a:extLst xmlns:a="http://schemas.openxmlformats.org/drawingml/2006/main">
               <a:ext uri="{FF2B5EF4-FFF2-40B4-BE49-F238E27FC236}">
-                <a16:creationId xmlns:a16="http://schemas.microsoft.com/office/drawing/2014/main" id="{072A4484-A04E-48D9-889D-E2CFAA6403CE}"/>
+                <a16:creationId xmlns:a16="http://schemas.microsoft.com/office/drawing/2014/main" id="{AFAFF495-EFF9-49B5-810B-6706B59197AC}"/>
               </a:ext>
             </a:extLst>
           </p:cNvPr>
@@ -27742,7 +27742,7 @@
           <p:cNvPr id="6" name="">
             <a:extLst xmlns:a="http://schemas.openxmlformats.org/drawingml/2006/main">
               <a:ext uri="{FF2B5EF4-FFF2-40B4-BE49-F238E27FC236}">
-                <a16:creationId xmlns:a16="http://schemas.microsoft.com/office/drawing/2014/main" id="{5AE53EE8-E6D5-4142-B185-D2A1E4AFA31A}"/>
+                <a16:creationId xmlns:a16="http://schemas.microsoft.com/office/drawing/2014/main" id="{6EAFC725-5046-4502-BF48-452E02975388}"/>
               </a:ext>
             </a:extLst>
           </p:cNvPr>
@@ -27899,7 +27899,7 @@
           <p:cNvPr id="7" name="">
             <a:extLst xmlns:a="http://schemas.openxmlformats.org/drawingml/2006/main">
               <a:ext uri="{FF2B5EF4-FFF2-40B4-BE49-F238E27FC236}">
-                <a16:creationId xmlns:a16="http://schemas.microsoft.com/office/drawing/2014/main" id="{38F2BEF9-0A12-43E5-8B61-1D67432A3B9D}"/>
+                <a16:creationId xmlns:a16="http://schemas.microsoft.com/office/drawing/2014/main" id="{E9FB3D70-C81F-42E4-BD49-A06B6BF29FD3}"/>
               </a:ext>
             </a:extLst>
           </p:cNvPr>
@@ -28148,7 +28148,7 @@
           <p:cNvPr id="8" name="">
             <a:extLst xmlns:a="http://schemas.openxmlformats.org/drawingml/2006/main">
               <a:ext uri="{FF2B5EF4-FFF2-40B4-BE49-F238E27FC236}">
-                <a16:creationId xmlns:a16="http://schemas.microsoft.com/office/drawing/2014/main" id="{47DB7026-E3CF-4EAD-A7BF-AEA50967D45F}"/>
+                <a16:creationId xmlns:a16="http://schemas.microsoft.com/office/drawing/2014/main" id="{8FAF2455-74E3-4260-B33A-2D688A072EF1}"/>
               </a:ext>
             </a:extLst>
           </p:cNvPr>
@@ -28303,7 +28303,7 @@
     </p:spTree>
     <p:extLst>
       <p:ext uri="{BB962C8B-B14F-4D97-AF65-F5344CB8AC3E}">
-        <p14:creationId xmlns:p14="http://schemas.microsoft.com/office/powerpoint/2010/main" val="518459209"/>
+        <p14:creationId xmlns:p14="http://schemas.microsoft.com/office/powerpoint/2010/main" val="2118897810"/>
       </p:ext>
     </p:extLst>
   </p:cSld>

</xml_diff>